<commit_message>
docs(decks): CTO architecture slide — readable module names from whiteboard
</commit_message>
<xml_diff>
--- a/docs/decks/LedgeRX-System-Architecture-CTO.pptx
+++ b/docs/decks/LedgeRX-System-Architecture-CTO.pptx
@@ -3139,7 +3139,7 @@
         </p:nvSpPr>
         <p:spPr>
           <a:xfrm>
-            <a:off x="365760" y="182880"/>
+            <a:off x="365760" y="164592"/>
             <a:ext cx="8229600" cy="320040"/>
           </a:xfrm>
           <a:prstGeom prst="rect">
@@ -3174,8 +3174,8 @@
         </p:nvSpPr>
         <p:spPr>
           <a:xfrm>
-            <a:off x="365760" y="475488"/>
-            <a:ext cx="9144000" cy="256032"/>
+            <a:off x="365760" y="457200"/>
+            <a:ext cx="9601200" cy="256032"/>
           </a:xfrm>
           <a:prstGeom prst="rect">
             <a:avLst/>
@@ -3196,7 +3196,7 @@
                 </a:solidFill>
                 <a:latin typeface="Calibri"/>
               </a:rPr>
-              <a:t>High-level component edges  ·  Upstream systems → SDK → Product engine → Landing systems  ·  Add-ons extend the core</a:t>
+              <a:t>One product engine  ·  Upstream systems plug in via SDK  ·  Clear modules  ·  Results land back to client systems</a:t>
             </a:r>
           </a:p>
         </p:txBody>
@@ -3209,8 +3209,8 @@
         </p:nvSpPr>
         <p:spPr>
           <a:xfrm>
-            <a:off x="9601200" y="228600"/>
-            <a:ext cx="2286000" cy="274320"/>
+            <a:off x="9692640" y="201168"/>
+            <a:ext cx="2194560" cy="274320"/>
           </a:xfrm>
           <a:prstGeom prst="rect">
             <a:avLst/>
@@ -3231,31 +3231,66 @@
                 </a:solidFill>
                 <a:latin typeface="Calibri"/>
               </a:rPr>
-              <a:t>CTO briefing  ·  1 slide</a:t>
-            </a:r>
-          </a:p>
-        </p:txBody>
-      </p:sp>
-      <p:sp>
-        <p:nvSpPr>
-          <p:cNvPr id="6" name="Rounded Rectangle 5"/>
+              <a:t>CTO  ·  1 slide</a:t>
+            </a:r>
+          </a:p>
+        </p:txBody>
+      </p:sp>
+      <p:sp>
+        <p:nvSpPr>
+          <p:cNvPr id="6" name="TextBox 5"/>
+          <p:cNvSpPr txBox="1"/>
+          <p:nvPr/>
+        </p:nvSpPr>
+        <p:spPr>
+          <a:xfrm>
+            <a:off x="320040" y="822960"/>
+            <a:ext cx="2194560" cy="256032"/>
+          </a:xfrm>
+          <a:prstGeom prst="rect">
+            <a:avLst/>
+          </a:prstGeom>
+          <a:noFill/>
+        </p:spPr>
+        <p:txBody>
+          <a:bodyPr wrap="square">
+            <a:spAutoFit/>
+          </a:bodyPr>
+          <a:lstStyle/>
+          <a:p>
+            <a:pPr algn="l"/>
+            <a:r>
+              <a:rPr sz="1200" b="1">
+                <a:solidFill>
+                  <a:srgbClr val="22D3EE"/>
+                </a:solidFill>
+                <a:latin typeface="Calibri"/>
+              </a:rPr>
+              <a:t>1  Upstream systems</a:t>
+            </a:r>
+          </a:p>
+        </p:txBody>
+      </p:sp>
+      <p:sp>
+        <p:nvSpPr>
+          <p:cNvPr id="7" name="Rounded Rectangle 6"/>
           <p:cNvSpPr/>
           <p:nvPr/>
         </p:nvSpPr>
         <p:spPr>
           <a:xfrm>
-            <a:off x="274320" y="868680"/>
-            <a:ext cx="1920240" cy="5257800"/>
+            <a:off x="274320" y="1097280"/>
+            <a:ext cx="2240280" cy="1417320"/>
           </a:xfrm>
           <a:prstGeom prst="roundRect">
             <a:avLst>
-              <a:gd name="adj" fmla="val 10000"/>
+              <a:gd name="adj" fmla="val 12000"/>
             </a:avLst>
           </a:prstGeom>
           <a:solidFill>
             <a:srgbClr val="0C2340"/>
           </a:solidFill>
-          <a:ln w="22225">
+          <a:ln w="19050">
             <a:solidFill>
               <a:srgbClr val="22D3EE"/>
             </a:solidFill>
@@ -3285,25 +3320,62 @@
       </p:sp>
       <p:sp>
         <p:nvSpPr>
-          <p:cNvPr id="7" name="Rounded Rectangle 6"/>
+          <p:cNvPr id="8" name="TextBox 7"/>
+          <p:cNvSpPr txBox="1"/>
+          <p:nvPr/>
+        </p:nvSpPr>
+        <p:spPr>
+          <a:xfrm>
+            <a:off x="411480" y="1207008"/>
+            <a:ext cx="1965960" cy="274320"/>
+          </a:xfrm>
+          <a:prstGeom prst="rect">
+            <a:avLst/>
+          </a:prstGeom>
+          <a:noFill/>
+        </p:spPr>
+        <p:txBody>
+          <a:bodyPr wrap="square">
+            <a:spAutoFit/>
+          </a:bodyPr>
+          <a:lstStyle/>
+          <a:p>
+            <a:pPr algn="l"/>
+            <a:r>
+              <a:rPr sz="1100" b="1">
+                <a:solidFill>
+                  <a:srgbClr val="94A3B8"/>
+                </a:solidFill>
+                <a:latin typeface="Calibri"/>
+              </a:rPr>
+              <a:t>Client systems</a:t>
+            </a:r>
+          </a:p>
+        </p:txBody>
+      </p:sp>
+      <p:sp>
+        <p:nvSpPr>
+          <p:cNvPr id="9" name="Rounded Rectangle 8"/>
           <p:cNvSpPr/>
           <p:nvPr/>
         </p:nvSpPr>
         <p:spPr>
           <a:xfrm>
-            <a:off x="384048" y="978408"/>
-            <a:ext cx="274320" cy="274320"/>
+            <a:off x="411480" y="1508760"/>
+            <a:ext cx="1965960" cy="411480"/>
           </a:xfrm>
           <a:prstGeom prst="roundRect">
             <a:avLst>
-              <a:gd name="adj" fmla="val 10000"/>
+              <a:gd name="adj" fmla="val 12000"/>
             </a:avLst>
           </a:prstGeom>
           <a:solidFill>
-            <a:srgbClr val="22D3EE"/>
+            <a:srgbClr val="0E2A4A"/>
           </a:solidFill>
-          <a:ln>
-            <a:noFill/>
+          <a:ln w="17145">
+            <a:solidFill>
+              <a:srgbClr val="22D3EE"/>
+            </a:solidFill>
           </a:ln>
         </p:spPr>
         <p:style>
@@ -3330,14 +3402,14 @@
       </p:sp>
       <p:sp>
         <p:nvSpPr>
-          <p:cNvPr id="8" name="TextBox 7"/>
+          <p:cNvPr id="10" name="TextBox 9"/>
           <p:cNvSpPr txBox="1"/>
           <p:nvPr/>
         </p:nvSpPr>
         <p:spPr>
           <a:xfrm>
-            <a:off x="384048" y="996696"/>
-            <a:ext cx="274320" cy="256032"/>
+            <a:off x="521208" y="1600200"/>
+            <a:ext cx="1783080" cy="292608"/>
           </a:xfrm>
           <a:prstGeom prst="rect">
             <a:avLst/>
@@ -3350,29 +3422,29 @@
           </a:bodyPr>
           <a:lstStyle/>
           <a:p>
-            <a:pPr algn="ctr"/>
+            <a:pPr algn="l"/>
             <a:r>
               <a:rPr sz="1200" b="1">
                 <a:solidFill>
-                  <a:srgbClr val="0B1220"/>
+                  <a:srgbClr val="F1F5F9"/>
                 </a:solidFill>
                 <a:latin typeface="Calibri"/>
               </a:rPr>
-              <a:t>1</a:t>
-            </a:r>
-          </a:p>
-        </p:txBody>
-      </p:sp>
-      <p:sp>
-        <p:nvSpPr>
-          <p:cNvPr id="9" name="TextBox 8"/>
+              <a:t>Credit Card  +  Loan</a:t>
+            </a:r>
+          </a:p>
+        </p:txBody>
+      </p:sp>
+      <p:sp>
+        <p:nvSpPr>
+          <p:cNvPr id="11" name="TextBox 10"/>
           <p:cNvSpPr txBox="1"/>
           <p:nvPr/>
         </p:nvSpPr>
         <p:spPr>
           <a:xfrm>
-            <a:off x="713232" y="996696"/>
-            <a:ext cx="1371600" cy="274320"/>
+            <a:off x="521208" y="1892808"/>
+            <a:ext cx="1783080" cy="-41806368000"/>
           </a:xfrm>
           <a:prstGeom prst="rect">
             <a:avLst/>
@@ -3387,37 +3459,37 @@
           <a:p>
             <a:pPr algn="l"/>
             <a:r>
-              <a:rPr sz="1300" b="1">
-                <a:solidFill>
-                  <a:srgbClr val="22D3EE"/>
+              <a:rPr sz="1000" b="0">
+                <a:solidFill>
+                  <a:srgbClr val="94A3B8"/>
                 </a:solidFill>
                 <a:latin typeface="Calibri"/>
               </a:rPr>
-              <a:t>Upstream Edge</a:t>
-            </a:r>
-          </a:p>
-        </p:txBody>
-      </p:sp>
-      <p:sp>
-        <p:nvSpPr>
-          <p:cNvPr id="10" name="Rounded Rectangle 9"/>
+              <a:t>Core business channels</a:t>
+            </a:r>
+          </a:p>
+        </p:txBody>
+      </p:sp>
+      <p:sp>
+        <p:nvSpPr>
+          <p:cNvPr id="12" name="Rounded Rectangle 11"/>
           <p:cNvSpPr/>
           <p:nvPr/>
         </p:nvSpPr>
         <p:spPr>
           <a:xfrm>
-            <a:off x="411480" y="1371600"/>
-            <a:ext cx="1645920" cy="1051560"/>
+            <a:off x="411480" y="2011680"/>
+            <a:ext cx="1965960" cy="365760"/>
           </a:xfrm>
           <a:prstGeom prst="roundRect">
             <a:avLst>
-              <a:gd name="adj" fmla="val 10000"/>
+              <a:gd name="adj" fmla="val 12000"/>
             </a:avLst>
           </a:prstGeom>
           <a:solidFill>
             <a:srgbClr val="0E2A4A"/>
           </a:solidFill>
-          <a:ln w="15875">
+          <a:ln w="17145">
             <a:solidFill>
               <a:srgbClr val="22D3EE"/>
             </a:solidFill>
@@ -3447,14 +3519,14 @@
       </p:sp>
       <p:sp>
         <p:nvSpPr>
-          <p:cNvPr id="11" name="TextBox 10"/>
+          <p:cNvPr id="13" name="TextBox 12"/>
           <p:cNvSpPr txBox="1"/>
           <p:nvPr/>
         </p:nvSpPr>
         <p:spPr>
           <a:xfrm>
-            <a:off x="521208" y="1481328"/>
-            <a:ext cx="1463040" cy="292608"/>
+            <a:off x="521208" y="2103120"/>
+            <a:ext cx="1783080" cy="292608"/>
           </a:xfrm>
           <a:prstGeom prst="rect">
             <a:avLst/>
@@ -3469,27 +3541,27 @@
           <a:p>
             <a:pPr algn="l"/>
             <a:r>
-              <a:rPr sz="1300" b="1">
+              <a:rPr sz="1100" b="1">
                 <a:solidFill>
                   <a:srgbClr val="F1F5F9"/>
                 </a:solidFill>
                 <a:latin typeface="Calibri"/>
               </a:rPr>
-              <a:t>Credit Card System</a:t>
-            </a:r>
-          </a:p>
-        </p:txBody>
-      </p:sp>
-      <p:sp>
-        <p:nvSpPr>
-          <p:cNvPr id="12" name="TextBox 11"/>
+              <a:t>App / CRM / Campaign</a:t>
+            </a:r>
+          </a:p>
+        </p:txBody>
+      </p:sp>
+      <p:sp>
+        <p:nvSpPr>
+          <p:cNvPr id="14" name="TextBox 13"/>
           <p:cNvSpPr txBox="1"/>
           <p:nvPr/>
         </p:nvSpPr>
         <p:spPr>
           <a:xfrm>
-            <a:off x="521208" y="1755648"/>
-            <a:ext cx="1463040" cy="365760"/>
+            <a:off x="320040" y="2697480"/>
+            <a:ext cx="2194560" cy="256032"/>
           </a:xfrm>
           <a:prstGeom prst="rect">
             <a:avLst/>
@@ -3504,39 +3576,39 @@
           <a:p>
             <a:pPr algn="l"/>
             <a:r>
-              <a:rPr sz="1000" b="0">
-                <a:solidFill>
-                  <a:srgbClr val="94A3B8"/>
+              <a:rPr sz="1200" b="1">
+                <a:solidFill>
+                  <a:srgbClr val="FB923C"/>
                 </a:solidFill>
                 <a:latin typeface="Calibri"/>
               </a:rPr>
-              <a:t>Spend · auth · MCC</a:t>
-            </a:r>
-          </a:p>
-        </p:txBody>
-      </p:sp>
-      <p:sp>
-        <p:nvSpPr>
-          <p:cNvPr id="13" name="Rounded Rectangle 12"/>
+              <a:t>2  Integration</a:t>
+            </a:r>
+          </a:p>
+        </p:txBody>
+      </p:sp>
+      <p:sp>
+        <p:nvSpPr>
+          <p:cNvPr id="15" name="Rounded Rectangle 14"/>
           <p:cNvSpPr/>
           <p:nvPr/>
         </p:nvSpPr>
         <p:spPr>
           <a:xfrm>
-            <a:off x="411480" y="2606040"/>
-            <a:ext cx="1645920" cy="1051560"/>
+            <a:off x="274320" y="2971800"/>
+            <a:ext cx="2240280" cy="2148840"/>
           </a:xfrm>
           <a:prstGeom prst="roundRect">
             <a:avLst>
-              <a:gd name="adj" fmla="val 10000"/>
+              <a:gd name="adj" fmla="val 12000"/>
             </a:avLst>
           </a:prstGeom>
           <a:solidFill>
-            <a:srgbClr val="0E2A4A"/>
+            <a:srgbClr val="0C2340"/>
           </a:solidFill>
-          <a:ln w="15875">
+          <a:ln w="19050">
             <a:solidFill>
-              <a:srgbClr val="22D3EE"/>
+              <a:srgbClr val="FB923C"/>
             </a:solidFill>
           </a:ln>
         </p:spPr>
@@ -3564,14 +3636,14 @@
       </p:sp>
       <p:sp>
         <p:nvSpPr>
-          <p:cNvPr id="14" name="TextBox 13"/>
+          <p:cNvPr id="16" name="TextBox 15"/>
           <p:cNvSpPr txBox="1"/>
           <p:nvPr/>
         </p:nvSpPr>
         <p:spPr>
           <a:xfrm>
-            <a:off x="521208" y="2715768"/>
-            <a:ext cx="1463040" cy="292608"/>
+            <a:off x="411480" y="3108960"/>
+            <a:ext cx="1965960" cy="320040"/>
           </a:xfrm>
           <a:prstGeom prst="rect">
             <a:avLst/>
@@ -3586,27 +3658,27 @@
           <a:p>
             <a:pPr algn="l"/>
             <a:r>
-              <a:rPr sz="1300" b="1">
+              <a:rPr sz="1600" b="1">
                 <a:solidFill>
                   <a:srgbClr val="F1F5F9"/>
                 </a:solidFill>
                 <a:latin typeface="Calibri"/>
               </a:rPr>
-              <a:t>Loan System</a:t>
-            </a:r>
-          </a:p>
-        </p:txBody>
-      </p:sp>
-      <p:sp>
-        <p:nvSpPr>
-          <p:cNvPr id="15" name="TextBox 14"/>
+              <a:t>LedgeRX SDK</a:t>
+            </a:r>
+          </a:p>
+        </p:txBody>
+      </p:sp>
+      <p:sp>
+        <p:nvSpPr>
+          <p:cNvPr id="17" name="TextBox 16"/>
           <p:cNvSpPr txBox="1"/>
           <p:nvPr/>
         </p:nvSpPr>
         <p:spPr>
           <a:xfrm>
-            <a:off x="521208" y="2990088"/>
-            <a:ext cx="1463040" cy="365760"/>
+            <a:off x="411480" y="3429000"/>
+            <a:ext cx="1965960" cy="320040"/>
           </a:xfrm>
           <a:prstGeom prst="rect">
             <a:avLst/>
@@ -3621,39 +3693,39 @@
           <a:p>
             <a:pPr algn="l"/>
             <a:r>
-              <a:rPr sz="1000" b="0">
+              <a:rPr sz="1100" b="0">
                 <a:solidFill>
                   <a:srgbClr val="94A3B8"/>
                 </a:solidFill>
                 <a:latin typeface="Calibri"/>
               </a:rPr>
-              <a:t>DD · drawdown · load</a:t>
-            </a:r>
-          </a:p>
-        </p:txBody>
-      </p:sp>
-      <p:sp>
-        <p:nvSpPr>
-          <p:cNvPr id="16" name="Rounded Rectangle 15"/>
+              <a:t>How upstreams connect</a:t>
+            </a:r>
+          </a:p>
+        </p:txBody>
+      </p:sp>
+      <p:sp>
+        <p:nvSpPr>
+          <p:cNvPr id="18" name="Rounded Rectangle 17"/>
           <p:cNvSpPr/>
           <p:nvPr/>
         </p:nvSpPr>
         <p:spPr>
           <a:xfrm>
             <a:off x="411480" y="3840480"/>
-            <a:ext cx="1645920" cy="1051560"/>
+            <a:ext cx="1965960" cy="347472"/>
           </a:xfrm>
           <a:prstGeom prst="roundRect">
             <a:avLst>
-              <a:gd name="adj" fmla="val 10000"/>
+              <a:gd name="adj" fmla="val 12000"/>
             </a:avLst>
           </a:prstGeom>
           <a:solidFill>
             <a:srgbClr val="0E2A4A"/>
           </a:solidFill>
-          <a:ln w="15875">
+          <a:ln w="17145">
             <a:solidFill>
-              <a:srgbClr val="22D3EE"/>
+              <a:srgbClr val="FB923C"/>
             </a:solidFill>
           </a:ln>
         </p:spPr>
@@ -3681,14 +3753,14 @@
       </p:sp>
       <p:sp>
         <p:nvSpPr>
-          <p:cNvPr id="17" name="TextBox 16"/>
+          <p:cNvPr id="19" name="TextBox 18"/>
           <p:cNvSpPr txBox="1"/>
           <p:nvPr/>
         </p:nvSpPr>
         <p:spPr>
           <a:xfrm>
-            <a:off x="521208" y="3950208"/>
-            <a:ext cx="1463040" cy="292608"/>
+            <a:off x="521208" y="3931920"/>
+            <a:ext cx="1783080" cy="292608"/>
           </a:xfrm>
           <a:prstGeom prst="rect">
             <a:avLst/>
@@ -3703,84 +3775,13 @@
           <a:p>
             <a:pPr algn="l"/>
             <a:r>
-              <a:rPr sz="1300" b="1">
+              <a:rPr sz="1200" b="1">
                 <a:solidFill>
                   <a:srgbClr val="F1F5F9"/>
                 </a:solidFill>
                 <a:latin typeface="Calibri"/>
               </a:rPr>
-              <a:t>App / CRM / Campaign</a:t>
-            </a:r>
-          </a:p>
-        </p:txBody>
-      </p:sp>
-      <p:sp>
-        <p:nvSpPr>
-          <p:cNvPr id="18" name="TextBox 17"/>
-          <p:cNvSpPr txBox="1"/>
-          <p:nvPr/>
-        </p:nvSpPr>
-        <p:spPr>
-          <a:xfrm>
-            <a:off x="521208" y="4224528"/>
-            <a:ext cx="1463040" cy="365760"/>
-          </a:xfrm>
-          <a:prstGeom prst="rect">
-            <a:avLst/>
-          </a:prstGeom>
-          <a:noFill/>
-        </p:spPr>
-        <p:txBody>
-          <a:bodyPr wrap="square">
-            <a:spAutoFit/>
-          </a:bodyPr>
-          <a:lstStyle/>
-          <a:p>
-            <a:pPr algn="l"/>
-            <a:r>
-              <a:rPr sz="1000" b="0">
-                <a:solidFill>
-                  <a:srgbClr val="94A3B8"/>
-                </a:solidFill>
-                <a:latin typeface="Calibri"/>
-              </a:rPr>
-              <a:t>Engage · like · events</a:t>
-            </a:r>
-          </a:p>
-        </p:txBody>
-      </p:sp>
-      <p:sp>
-        <p:nvSpPr>
-          <p:cNvPr id="19" name="TextBox 18"/>
-          <p:cNvSpPr txBox="1"/>
-          <p:nvPr/>
-        </p:nvSpPr>
-        <p:spPr>
-          <a:xfrm>
-            <a:off x="411480" y="5212080"/>
-            <a:ext cx="1645920" cy="640080"/>
-          </a:xfrm>
-          <a:prstGeom prst="rect">
-            <a:avLst/>
-          </a:prstGeom>
-          <a:noFill/>
-        </p:spPr>
-        <p:txBody>
-          <a:bodyPr wrap="square">
-            <a:spAutoFit/>
-          </a:bodyPr>
-          <a:lstStyle/>
-          <a:p>
-            <a:pPr algn="l"/>
-            <a:r>
-              <a:rPr sz="1000" b="0">
-                <a:solidFill>
-                  <a:srgbClr val="94A3B8"/>
-                </a:solidFill>
-                <a:latin typeface="Calibri"/>
-              </a:rPr>
-              <a:t>Systems of record
-No ledger logic</a:t>
+              <a:t>REST API</a:t>
             </a:r>
           </a:p>
         </p:txBody>
@@ -3793,18 +3794,18 @@
         </p:nvSpPr>
         <p:spPr>
           <a:xfrm>
-            <a:off x="2377440" y="868680"/>
-            <a:ext cx="1965960" cy="5257800"/>
+            <a:off x="411480" y="4251960"/>
+            <a:ext cx="1965960" cy="347472"/>
           </a:xfrm>
           <a:prstGeom prst="roundRect">
             <a:avLst>
-              <a:gd name="adj" fmla="val 10000"/>
+              <a:gd name="adj" fmla="val 12000"/>
             </a:avLst>
           </a:prstGeom>
           <a:solidFill>
-            <a:srgbClr val="0C2340"/>
+            <a:srgbClr val="0E2A4A"/>
           </a:solidFill>
-          <a:ln w="22225">
+          <a:ln w="17145">
             <a:solidFill>
               <a:srgbClr val="FB923C"/>
             </a:solidFill>
@@ -3834,19 +3835,134 @@
       </p:sp>
       <p:sp>
         <p:nvSpPr>
-          <p:cNvPr id="21" name="Rounded Rectangle 20"/>
+          <p:cNvPr id="21" name="TextBox 20"/>
+          <p:cNvSpPr txBox="1"/>
+          <p:nvPr/>
+        </p:nvSpPr>
+        <p:spPr>
+          <a:xfrm>
+            <a:off x="521208" y="4343400"/>
+            <a:ext cx="1783080" cy="292608"/>
+          </a:xfrm>
+          <a:prstGeom prst="rect">
+            <a:avLst/>
+          </a:prstGeom>
+          <a:noFill/>
+        </p:spPr>
+        <p:txBody>
+          <a:bodyPr wrap="square">
+            <a:spAutoFit/>
+          </a:bodyPr>
+          <a:lstStyle/>
+          <a:p>
+            <a:pPr algn="l"/>
+            <a:r>
+              <a:rPr sz="1200" b="1">
+                <a:solidFill>
+                  <a:srgbClr val="F1F5F9"/>
+                </a:solidFill>
+                <a:latin typeface="Calibri"/>
+              </a:rPr>
+              <a:t>Message queue (Kafka)</a:t>
+            </a:r>
+          </a:p>
+        </p:txBody>
+      </p:sp>
+      <p:sp>
+        <p:nvSpPr>
+          <p:cNvPr id="22" name="Rounded Rectangle 21"/>
           <p:cNvSpPr/>
           <p:nvPr/>
         </p:nvSpPr>
         <p:spPr>
           <a:xfrm>
-            <a:off x="2487168" y="978408"/>
-            <a:ext cx="274320" cy="274320"/>
+            <a:off x="411480" y="4663440"/>
+            <a:ext cx="1965960" cy="347472"/>
           </a:xfrm>
           <a:prstGeom prst="roundRect">
             <a:avLst>
-              <a:gd name="adj" fmla="val 10000"/>
+              <a:gd name="adj" fmla="val 12000"/>
             </a:avLst>
+          </a:prstGeom>
+          <a:solidFill>
+            <a:srgbClr val="0E2A4A"/>
+          </a:solidFill>
+          <a:ln w="17145">
+            <a:solidFill>
+              <a:srgbClr val="FB923C"/>
+            </a:solidFill>
+          </a:ln>
+        </p:spPr>
+        <p:style>
+          <a:lnRef idx="1">
+            <a:schemeClr val="accent1"/>
+          </a:lnRef>
+          <a:fillRef idx="3">
+            <a:schemeClr val="accent1"/>
+          </a:fillRef>
+          <a:effectRef idx="2">
+            <a:schemeClr val="accent1"/>
+          </a:effectRef>
+          <a:fontRef idx="minor">
+            <a:schemeClr val="lt1"/>
+          </a:fontRef>
+        </p:style>
+        <p:txBody>
+          <a:bodyPr rtlCol="0" anchor="ctr"/>
+          <a:lstStyle/>
+          <a:p>
+            <a:pPr algn="ctr"/>
+          </a:p>
+        </p:txBody>
+      </p:sp>
+      <p:sp>
+        <p:nvSpPr>
+          <p:cNvPr id="23" name="TextBox 22"/>
+          <p:cNvSpPr txBox="1"/>
+          <p:nvPr/>
+        </p:nvSpPr>
+        <p:spPr>
+          <a:xfrm>
+            <a:off x="521208" y="4754880"/>
+            <a:ext cx="1783080" cy="292608"/>
+          </a:xfrm>
+          <a:prstGeom prst="rect">
+            <a:avLst/>
+          </a:prstGeom>
+          <a:noFill/>
+        </p:spPr>
+        <p:txBody>
+          <a:bodyPr wrap="square">
+            <a:spAutoFit/>
+          </a:bodyPr>
+          <a:lstStyle/>
+          <a:p>
+            <a:pPr algn="l"/>
+            <a:r>
+              <a:rPr sz="1200" b="1">
+                <a:solidFill>
+                  <a:srgbClr val="F1F5F9"/>
+                </a:solidFill>
+                <a:latin typeface="Calibri"/>
+              </a:rPr>
+              <a:t>File / batch</a:t>
+            </a:r>
+          </a:p>
+        </p:txBody>
+      </p:sp>
+      <p:sp>
+        <p:nvSpPr>
+          <p:cNvPr id="24" name="Right Arrow 23"/>
+          <p:cNvSpPr/>
+          <p:nvPr/>
+        </p:nvSpPr>
+        <p:spPr>
+          <a:xfrm>
+            <a:off x="2606040" y="3657600"/>
+            <a:ext cx="292608" cy="219456"/>
+          </a:xfrm>
+          <a:prstGeom prst="rightArrow">
+            <a:avLst/>
           </a:prstGeom>
           <a:solidFill>
             <a:srgbClr val="FB923C"/>
@@ -3879,14 +3995,14 @@
       </p:sp>
       <p:sp>
         <p:nvSpPr>
-          <p:cNvPr id="22" name="TextBox 21"/>
+          <p:cNvPr id="25" name="TextBox 24"/>
           <p:cNvSpPr txBox="1"/>
           <p:nvPr/>
         </p:nvSpPr>
         <p:spPr>
           <a:xfrm>
-            <a:off x="2487168" y="996696"/>
-            <a:ext cx="274320" cy="256032"/>
+            <a:off x="2514600" y="3913632"/>
+            <a:ext cx="502920" cy="228600"/>
           </a:xfrm>
           <a:prstGeom prst="rect">
             <a:avLst/>
@@ -3901,118 +4017,13 @@
           <a:p>
             <a:pPr algn="ctr"/>
             <a:r>
-              <a:rPr sz="1200" b="1">
-                <a:solidFill>
-                  <a:srgbClr val="0B1220"/>
+              <a:rPr sz="900" b="0">
+                <a:solidFill>
+                  <a:srgbClr val="FB923C"/>
                 </a:solidFill>
                 <a:latin typeface="Calibri"/>
               </a:rPr>
-              <a:t>2</a:t>
-            </a:r>
-          </a:p>
-        </p:txBody>
-      </p:sp>
-      <p:sp>
-        <p:nvSpPr>
-          <p:cNvPr id="23" name="TextBox 22"/>
-          <p:cNvSpPr txBox="1"/>
-          <p:nvPr/>
-        </p:nvSpPr>
-        <p:spPr>
-          <a:xfrm>
-            <a:off x="2816352" y="996696"/>
-            <a:ext cx="1417320" cy="274320"/>
-          </a:xfrm>
-          <a:prstGeom prst="rect">
-            <a:avLst/>
-          </a:prstGeom>
-          <a:noFill/>
-        </p:spPr>
-        <p:txBody>
-          <a:bodyPr wrap="square">
-            <a:spAutoFit/>
-          </a:bodyPr>
-          <a:lstStyle/>
-          <a:p>
-            <a:pPr algn="l"/>
-            <a:r>
-              <a:rPr sz="1300" b="1">
-                <a:solidFill>
-                  <a:srgbClr val="FB923C"/>
-                </a:solidFill>
-                <a:latin typeface="Calibri"/>
-              </a:rPr>
-              <a:t>Integration Edge</a:t>
-            </a:r>
-          </a:p>
-        </p:txBody>
-      </p:sp>
-      <p:sp>
-        <p:nvSpPr>
-          <p:cNvPr id="24" name="TextBox 23"/>
-          <p:cNvSpPr txBox="1"/>
-          <p:nvPr/>
-        </p:nvSpPr>
-        <p:spPr>
-          <a:xfrm>
-            <a:off x="2514600" y="1325880"/>
-            <a:ext cx="1691640" cy="274320"/>
-          </a:xfrm>
-          <a:prstGeom prst="rect">
-            <a:avLst/>
-          </a:prstGeom>
-          <a:noFill/>
-        </p:spPr>
-        <p:txBody>
-          <a:bodyPr wrap="square">
-            <a:spAutoFit/>
-          </a:bodyPr>
-          <a:lstStyle/>
-          <a:p>
-            <a:pPr algn="l"/>
-            <a:r>
-              <a:rPr sz="1500" b="1">
-                <a:solidFill>
-                  <a:srgbClr val="F1F5F9"/>
-                </a:solidFill>
-                <a:latin typeface="Calibri"/>
-              </a:rPr>
-              <a:t>LedgeRX SDK</a:t>
-            </a:r>
-          </a:p>
-        </p:txBody>
-      </p:sp>
-      <p:sp>
-        <p:nvSpPr>
-          <p:cNvPr id="25" name="TextBox 24"/>
-          <p:cNvSpPr txBox="1"/>
-          <p:nvPr/>
-        </p:nvSpPr>
-        <p:spPr>
-          <a:xfrm>
-            <a:off x="2514600" y="1600200"/>
-            <a:ext cx="1691640" cy="365760"/>
-          </a:xfrm>
-          <a:prstGeom prst="rect">
-            <a:avLst/>
-          </a:prstGeom>
-          <a:noFill/>
-        </p:spPr>
-        <p:txBody>
-          <a:bodyPr wrap="square">
-            <a:spAutoFit/>
-          </a:bodyPr>
-          <a:lstStyle/>
-          <a:p>
-            <a:pPr algn="l"/>
-            <a:r>
-              <a:rPr sz="1100" b="0">
-                <a:solidFill>
-                  <a:srgbClr val="94A3B8"/>
-                </a:solidFill>
-                <a:latin typeface="Calibri"/>
-              </a:rPr>
-              <a:t>One library · any upstream</a:t>
+              <a:t>in</a:t>
             </a:r>
           </a:p>
         </p:txBody>
@@ -4025,20 +4036,20 @@
         </p:nvSpPr>
         <p:spPr>
           <a:xfrm>
-            <a:off x="2514600" y="2103120"/>
-            <a:ext cx="1691640" cy="822960"/>
+            <a:off x="2971800" y="868680"/>
+            <a:ext cx="5806440" cy="4572000"/>
           </a:xfrm>
           <a:prstGeom prst="roundRect">
             <a:avLst>
-              <a:gd name="adj" fmla="val 10000"/>
+              <a:gd name="adj" fmla="val 12000"/>
             </a:avLst>
           </a:prstGeom>
           <a:solidFill>
-            <a:srgbClr val="0E2A4A"/>
+            <a:srgbClr val="0A2E28"/>
           </a:solidFill>
-          <a:ln w="15875">
+          <a:ln w="28575">
             <a:solidFill>
-              <a:srgbClr val="FB923C"/>
+              <a:srgbClr val="2DD4BF"/>
             </a:solidFill>
           </a:ln>
         </p:spPr>
@@ -4066,406 +4077,18 @@
       </p:sp>
       <p:sp>
         <p:nvSpPr>
-          <p:cNvPr id="27" name="TextBox 26"/>
-          <p:cNvSpPr txBox="1"/>
-          <p:nvPr/>
-        </p:nvSpPr>
-        <p:spPr>
-          <a:xfrm>
-            <a:off x="2624328" y="2212848"/>
-            <a:ext cx="1508760" cy="292608"/>
-          </a:xfrm>
-          <a:prstGeom prst="rect">
-            <a:avLst/>
-          </a:prstGeom>
-          <a:noFill/>
-        </p:spPr>
-        <p:txBody>
-          <a:bodyPr wrap="square">
-            <a:spAutoFit/>
-          </a:bodyPr>
-          <a:lstStyle/>
-          <a:p>
-            <a:pPr algn="l"/>
-            <a:r>
-              <a:rPr sz="1300" b="1">
-                <a:solidFill>
-                  <a:srgbClr val="F1F5F9"/>
-                </a:solidFill>
-                <a:latin typeface="Calibri"/>
-              </a:rPr>
-              <a:t>REST</a:t>
-            </a:r>
-          </a:p>
-        </p:txBody>
-      </p:sp>
-      <p:sp>
-        <p:nvSpPr>
-          <p:cNvPr id="28" name="TextBox 27"/>
-          <p:cNvSpPr txBox="1"/>
-          <p:nvPr/>
-        </p:nvSpPr>
-        <p:spPr>
-          <a:xfrm>
-            <a:off x="2624328" y="2487168"/>
-            <a:ext cx="1508760" cy="365760"/>
-          </a:xfrm>
-          <a:prstGeom prst="rect">
-            <a:avLst/>
-          </a:prstGeom>
-          <a:noFill/>
-        </p:spPr>
-        <p:txBody>
-          <a:bodyPr wrap="square">
-            <a:spAutoFit/>
-          </a:bodyPr>
-          <a:lstStyle/>
-          <a:p>
-            <a:pPr algn="l"/>
-            <a:r>
-              <a:rPr sz="1000" b="0">
-                <a:solidFill>
-                  <a:srgbClr val="94A3B8"/>
-                </a:solidFill>
-                <a:latin typeface="Calibri"/>
-              </a:rPr>
-              <a:t>useCases · catalog · dry-run</a:t>
-            </a:r>
-          </a:p>
-        </p:txBody>
-      </p:sp>
-      <p:sp>
-        <p:nvSpPr>
-          <p:cNvPr id="29" name="Rounded Rectangle 28"/>
+          <p:cNvPr id="27" name="Rounded Rectangle 26"/>
           <p:cNvSpPr/>
           <p:nvPr/>
         </p:nvSpPr>
         <p:spPr>
           <a:xfrm>
-            <a:off x="2514600" y="3063240"/>
-            <a:ext cx="1691640" cy="822960"/>
+            <a:off x="4617720" y="978408"/>
+            <a:ext cx="2468880" cy="347472"/>
           </a:xfrm>
           <a:prstGeom prst="roundRect">
             <a:avLst>
-              <a:gd name="adj" fmla="val 10000"/>
-            </a:avLst>
-          </a:prstGeom>
-          <a:solidFill>
-            <a:srgbClr val="0E2A4A"/>
-          </a:solidFill>
-          <a:ln w="15875">
-            <a:solidFill>
-              <a:srgbClr val="FB923C"/>
-            </a:solidFill>
-          </a:ln>
-        </p:spPr>
-        <p:style>
-          <a:lnRef idx="1">
-            <a:schemeClr val="accent1"/>
-          </a:lnRef>
-          <a:fillRef idx="3">
-            <a:schemeClr val="accent1"/>
-          </a:fillRef>
-          <a:effectRef idx="2">
-            <a:schemeClr val="accent1"/>
-          </a:effectRef>
-          <a:fontRef idx="minor">
-            <a:schemeClr val="lt1"/>
-          </a:fontRef>
-        </p:style>
-        <p:txBody>
-          <a:bodyPr rtlCol="0" anchor="ctr"/>
-          <a:lstStyle/>
-          <a:p>
-            <a:pPr algn="ctr"/>
-          </a:p>
-        </p:txBody>
-      </p:sp>
-      <p:sp>
-        <p:nvSpPr>
-          <p:cNvPr id="30" name="TextBox 29"/>
-          <p:cNvSpPr txBox="1"/>
-          <p:nvPr/>
-        </p:nvSpPr>
-        <p:spPr>
-          <a:xfrm>
-            <a:off x="2624328" y="3172968"/>
-            <a:ext cx="1508760" cy="292608"/>
-          </a:xfrm>
-          <a:prstGeom prst="rect">
-            <a:avLst/>
-          </a:prstGeom>
-          <a:noFill/>
-        </p:spPr>
-        <p:txBody>
-          <a:bodyPr wrap="square">
-            <a:spAutoFit/>
-          </a:bodyPr>
-          <a:lstStyle/>
-          <a:p>
-            <a:pPr algn="l"/>
-            <a:r>
-              <a:rPr sz="1300" b="1">
-                <a:solidFill>
-                  <a:srgbClr val="F1F5F9"/>
-                </a:solidFill>
-                <a:latin typeface="Calibri"/>
-              </a:rPr>
-              <a:t>MQ / Kafka</a:t>
-            </a:r>
-          </a:p>
-        </p:txBody>
-      </p:sp>
-      <p:sp>
-        <p:nvSpPr>
-          <p:cNvPr id="31" name="TextBox 30"/>
-          <p:cNvSpPr txBox="1"/>
-          <p:nvPr/>
-        </p:nvSpPr>
-        <p:spPr>
-          <a:xfrm>
-            <a:off x="2624328" y="3447288"/>
-            <a:ext cx="1508760" cy="365760"/>
-          </a:xfrm>
-          <a:prstGeom prst="rect">
-            <a:avLst/>
-          </a:prstGeom>
-          <a:noFill/>
-        </p:spPr>
-        <p:txBody>
-          <a:bodyPr wrap="square">
-            <a:spAutoFit/>
-          </a:bodyPr>
-          <a:lstStyle/>
-          <a:p>
-            <a:pPr algn="l"/>
-            <a:r>
-              <a:rPr sz="1000" b="0">
-                <a:solidFill>
-                  <a:srgbClr val="94A3B8"/>
-                </a:solidFill>
-                <a:latin typeface="Calibri"/>
-              </a:rPr>
-              <a:t>Async event stream</a:t>
-            </a:r>
-          </a:p>
-        </p:txBody>
-      </p:sp>
-      <p:sp>
-        <p:nvSpPr>
-          <p:cNvPr id="32" name="Rounded Rectangle 31"/>
-          <p:cNvSpPr/>
-          <p:nvPr/>
-        </p:nvSpPr>
-        <p:spPr>
-          <a:xfrm>
-            <a:off x="2514600" y="4023360"/>
-            <a:ext cx="1691640" cy="822960"/>
-          </a:xfrm>
-          <a:prstGeom prst="roundRect">
-            <a:avLst>
-              <a:gd name="adj" fmla="val 10000"/>
-            </a:avLst>
-          </a:prstGeom>
-          <a:solidFill>
-            <a:srgbClr val="0E2A4A"/>
-          </a:solidFill>
-          <a:ln w="15875">
-            <a:solidFill>
-              <a:srgbClr val="FB923C"/>
-            </a:solidFill>
-          </a:ln>
-        </p:spPr>
-        <p:style>
-          <a:lnRef idx="1">
-            <a:schemeClr val="accent1"/>
-          </a:lnRef>
-          <a:fillRef idx="3">
-            <a:schemeClr val="accent1"/>
-          </a:fillRef>
-          <a:effectRef idx="2">
-            <a:schemeClr val="accent1"/>
-          </a:effectRef>
-          <a:fontRef idx="minor">
-            <a:schemeClr val="lt1"/>
-          </a:fontRef>
-        </p:style>
-        <p:txBody>
-          <a:bodyPr rtlCol="0" anchor="ctr"/>
-          <a:lstStyle/>
-          <a:p>
-            <a:pPr algn="ctr"/>
-          </a:p>
-        </p:txBody>
-      </p:sp>
-      <p:sp>
-        <p:nvSpPr>
-          <p:cNvPr id="33" name="TextBox 32"/>
-          <p:cNvSpPr txBox="1"/>
-          <p:nvPr/>
-        </p:nvSpPr>
-        <p:spPr>
-          <a:xfrm>
-            <a:off x="2624328" y="4133088"/>
-            <a:ext cx="1508760" cy="292608"/>
-          </a:xfrm>
-          <a:prstGeom prst="rect">
-            <a:avLst/>
-          </a:prstGeom>
-          <a:noFill/>
-        </p:spPr>
-        <p:txBody>
-          <a:bodyPr wrap="square">
-            <a:spAutoFit/>
-          </a:bodyPr>
-          <a:lstStyle/>
-          <a:p>
-            <a:pPr algn="l"/>
-            <a:r>
-              <a:rPr sz="1300" b="1">
-                <a:solidFill>
-                  <a:srgbClr val="F1F5F9"/>
-                </a:solidFill>
-                <a:latin typeface="Calibri"/>
-              </a:rPr>
-              <a:t>File</a:t>
-            </a:r>
-          </a:p>
-        </p:txBody>
-      </p:sp>
-      <p:sp>
-        <p:nvSpPr>
-          <p:cNvPr id="34" name="TextBox 33"/>
-          <p:cNvSpPr txBox="1"/>
-          <p:nvPr/>
-        </p:nvSpPr>
-        <p:spPr>
-          <a:xfrm>
-            <a:off x="2624328" y="4407408"/>
-            <a:ext cx="1508760" cy="365760"/>
-          </a:xfrm>
-          <a:prstGeom prst="rect">
-            <a:avLst/>
-          </a:prstGeom>
-          <a:noFill/>
-        </p:spPr>
-        <p:txBody>
-          <a:bodyPr wrap="square">
-            <a:spAutoFit/>
-          </a:bodyPr>
-          <a:lstStyle/>
-          <a:p>
-            <a:pPr algn="l"/>
-            <a:r>
-              <a:rPr sz="1000" b="0">
-                <a:solidFill>
-                  <a:srgbClr val="94A3B8"/>
-                </a:solidFill>
-                <a:latin typeface="Calibri"/>
-              </a:rPr>
-              <a:t>Batch / bulk ingest</a:t>
-            </a:r>
-          </a:p>
-        </p:txBody>
-      </p:sp>
-      <p:sp>
-        <p:nvSpPr>
-          <p:cNvPr id="35" name="TextBox 34"/>
-          <p:cNvSpPr txBox="1"/>
-          <p:nvPr/>
-        </p:nvSpPr>
-        <p:spPr>
-          <a:xfrm>
-            <a:off x="2514600" y="5074920"/>
-            <a:ext cx="1691640" cy="822960"/>
-          </a:xfrm>
-          <a:prstGeom prst="rect">
-            <a:avLst/>
-          </a:prstGeom>
-          <a:noFill/>
-        </p:spPr>
-        <p:txBody>
-          <a:bodyPr wrap="square">
-            <a:spAutoFit/>
-          </a:bodyPr>
-          <a:lstStyle/>
-          <a:p>
-            <a:pPr algn="l"/>
-            <a:r>
-              <a:rPr sz="1000" b="0">
-                <a:solidFill>
-                  <a:srgbClr val="94A3B8"/>
-                </a:solidFill>
-                <a:latin typeface="Calibri"/>
-              </a:rPr>
-              <a:t>Idempotency · retries
-Contract: ownerId + code
-No hand-built JSON</a:t>
-            </a:r>
-          </a:p>
-        </p:txBody>
-      </p:sp>
-      <p:sp>
-        <p:nvSpPr>
-          <p:cNvPr id="36" name="Rounded Rectangle 35"/>
-          <p:cNvSpPr/>
-          <p:nvPr/>
-        </p:nvSpPr>
-        <p:spPr>
-          <a:xfrm>
-            <a:off x="4526280" y="868680"/>
-            <a:ext cx="3246120" cy="5257800"/>
-          </a:xfrm>
-          <a:prstGeom prst="roundRect">
-            <a:avLst>
-              <a:gd name="adj" fmla="val 10000"/>
-            </a:avLst>
-          </a:prstGeom>
-          <a:solidFill>
-            <a:srgbClr val="0C2340"/>
-          </a:solidFill>
-          <a:ln w="22225">
-            <a:solidFill>
-              <a:srgbClr val="2DD4BF"/>
-            </a:solidFill>
-          </a:ln>
-        </p:spPr>
-        <p:style>
-          <a:lnRef idx="1">
-            <a:schemeClr val="accent1"/>
-          </a:lnRef>
-          <a:fillRef idx="3">
-            <a:schemeClr val="accent1"/>
-          </a:fillRef>
-          <a:effectRef idx="2">
-            <a:schemeClr val="accent1"/>
-          </a:effectRef>
-          <a:fontRef idx="minor">
-            <a:schemeClr val="lt1"/>
-          </a:fontRef>
-        </p:style>
-        <p:txBody>
-          <a:bodyPr rtlCol="0" anchor="ctr"/>
-          <a:lstStyle/>
-          <a:p>
-            <a:pPr algn="ctr"/>
-          </a:p>
-        </p:txBody>
-      </p:sp>
-      <p:sp>
-        <p:nvSpPr>
-          <p:cNvPr id="37" name="Rounded Rectangle 36"/>
-          <p:cNvSpPr/>
-          <p:nvPr/>
-        </p:nvSpPr>
-        <p:spPr>
-          <a:xfrm>
-            <a:off x="4636008" y="978408"/>
-            <a:ext cx="274320" cy="274320"/>
-          </a:xfrm>
-          <a:prstGeom prst="roundRect">
-            <a:avLst>
-              <a:gd name="adj" fmla="val 10000"/>
+              <a:gd name="adj" fmla="val 12000"/>
             </a:avLst>
           </a:prstGeom>
           <a:solidFill>
@@ -4499,14 +4122,14 @@
       </p:sp>
       <p:sp>
         <p:nvSpPr>
-          <p:cNvPr id="38" name="TextBox 37"/>
+          <p:cNvPr id="28" name="TextBox 27"/>
           <p:cNvSpPr txBox="1"/>
           <p:nvPr/>
         </p:nvSpPr>
         <p:spPr>
           <a:xfrm>
-            <a:off x="4636008" y="996696"/>
-            <a:ext cx="274320" cy="256032"/>
+            <a:off x="4617720" y="1014984"/>
+            <a:ext cx="2468880" cy="292608"/>
           </a:xfrm>
           <a:prstGeom prst="rect">
             <a:avLst/>
@@ -4521,27 +4144,27 @@
           <a:p>
             <a:pPr algn="ctr"/>
             <a:r>
-              <a:rPr sz="1200" b="1">
+              <a:rPr sz="1400" b="1">
                 <a:solidFill>
                   <a:srgbClr val="0B1220"/>
                 </a:solidFill>
                 <a:latin typeface="Calibri"/>
               </a:rPr>
-              <a:t>3</a:t>
-            </a:r>
-          </a:p>
-        </p:txBody>
-      </p:sp>
-      <p:sp>
-        <p:nvSpPr>
-          <p:cNvPr id="39" name="TextBox 38"/>
+              <a:t>3  LedgeRX Product</a:t>
+            </a:r>
+          </a:p>
+        </p:txBody>
+      </p:sp>
+      <p:sp>
+        <p:nvSpPr>
+          <p:cNvPr id="29" name="TextBox 28"/>
           <p:cNvSpPr txBox="1"/>
           <p:nvPr/>
         </p:nvSpPr>
         <p:spPr>
           <a:xfrm>
-            <a:off x="4965192" y="996696"/>
-            <a:ext cx="2697480" cy="274320"/>
+            <a:off x="3200400" y="1371600"/>
+            <a:ext cx="5349240" cy="274320"/>
           </a:xfrm>
           <a:prstGeom prst="rect">
             <a:avLst/>
@@ -4556,72 +4179,37 @@
           <a:p>
             <a:pPr algn="l"/>
             <a:r>
-              <a:rPr sz="1300" b="1">
+              <a:rPr sz="1100" b="0">
                 <a:solidFill>
                   <a:srgbClr val="2DD4BF"/>
                 </a:solidFill>
                 <a:latin typeface="Calibri"/>
               </a:rPr>
-              <a:t>Product Edge · LedgeRX</a:t>
-            </a:r>
-          </a:p>
-        </p:txBody>
-      </p:sp>
-      <p:sp>
-        <p:nvSpPr>
-          <p:cNvPr id="40" name="TextBox 39"/>
-          <p:cNvSpPr txBox="1"/>
-          <p:nvPr/>
-        </p:nvSpPr>
-        <p:spPr>
-          <a:xfrm>
-            <a:off x="4663440" y="1280160"/>
-            <a:ext cx="2971800" cy="320040"/>
-          </a:xfrm>
-          <a:prstGeom prst="rect">
-            <a:avLst/>
-          </a:prstGeom>
-          <a:noFill/>
-        </p:spPr>
-        <p:txBody>
-          <a:bodyPr wrap="square">
-            <a:spAutoFit/>
-          </a:bodyPr>
-          <a:lstStyle/>
-          <a:p>
-            <a:pPr algn="l"/>
-            <a:r>
-              <a:rPr sz="1100" b="0">
-                <a:solidFill>
-                  <a:srgbClr val="2DD4BF"/>
-                </a:solidFill>
-                <a:latin typeface="Calibri"/>
-              </a:rPr>
-              <a:t>Purchasable engine product  ·  microservice modules  ·  in-cluster</a:t>
-            </a:r>
-          </a:p>
-        </p:txBody>
-      </p:sp>
-      <p:sp>
-        <p:nvSpPr>
-          <p:cNvPr id="41" name="Rounded Rectangle 40"/>
+              <a:t>Powerful loyalty + ledger engine  ·  modular services  ·  one product to purchase</a:t>
+            </a:r>
+          </a:p>
+        </p:txBody>
+      </p:sp>
+      <p:sp>
+        <p:nvSpPr>
+          <p:cNvPr id="30" name="Rounded Rectangle 29"/>
           <p:cNvSpPr/>
           <p:nvPr/>
         </p:nvSpPr>
         <p:spPr>
           <a:xfrm>
-            <a:off x="4690872" y="1691640"/>
-            <a:ext cx="1417320" cy="914400"/>
+            <a:off x="3246120" y="1783080"/>
+            <a:ext cx="2606040" cy="777240"/>
           </a:xfrm>
           <a:prstGeom prst="roundRect">
             <a:avLst>
-              <a:gd name="adj" fmla="val 10000"/>
+              <a:gd name="adj" fmla="val 12000"/>
             </a:avLst>
           </a:prstGeom>
           <a:solidFill>
             <a:srgbClr val="0E2A4A"/>
           </a:solidFill>
-          <a:ln w="15875">
+          <a:ln w="17145">
             <a:solidFill>
               <a:srgbClr val="2DD4BF"/>
             </a:solidFill>
@@ -4651,14 +4239,14 @@
       </p:sp>
       <p:sp>
         <p:nvSpPr>
-          <p:cNvPr id="42" name="TextBox 41"/>
+          <p:cNvPr id="31" name="TextBox 30"/>
           <p:cNvSpPr txBox="1"/>
           <p:nvPr/>
         </p:nvSpPr>
         <p:spPr>
           <a:xfrm>
-            <a:off x="4800600" y="1801368"/>
-            <a:ext cx="1234440" cy="292608"/>
+            <a:off x="3355848" y="1874520"/>
+            <a:ext cx="2423160" cy="292608"/>
           </a:xfrm>
           <a:prstGeom prst="rect">
             <a:avLst/>
@@ -4679,21 +4267,21 @@
                 </a:solidFill>
                 <a:latin typeface="Calibri"/>
               </a:rPr>
-              <a:t>Door</a:t>
-            </a:r>
-          </a:p>
-        </p:txBody>
-      </p:sp>
-      <p:sp>
-        <p:nvSpPr>
-          <p:cNvPr id="43" name="TextBox 42"/>
+              <a:t>Customer Onboarding</a:t>
+            </a:r>
+          </a:p>
+        </p:txBody>
+      </p:sp>
+      <p:sp>
+        <p:nvSpPr>
+          <p:cNvPr id="32" name="TextBox 31"/>
           <p:cNvSpPr txBox="1"/>
           <p:nvPr/>
         </p:nvSpPr>
         <p:spPr>
           <a:xfrm>
-            <a:off x="4800600" y="2075688"/>
-            <a:ext cx="1234440" cy="365760"/>
+            <a:off x="3355848" y="2167128"/>
+            <a:ext cx="2423160" cy="292644576000"/>
           </a:xfrm>
           <a:prstGeom prst="rect">
             <a:avLst/>
@@ -4714,31 +4302,31 @@
                 </a:solidFill>
                 <a:latin typeface="Calibri"/>
               </a:rPr>
-              <a:t>Admit · policy · auto-wallet</a:t>
-            </a:r>
-          </a:p>
-        </p:txBody>
-      </p:sp>
-      <p:sp>
-        <p:nvSpPr>
-          <p:cNvPr id="44" name="Rounded Rectangle 43"/>
+              <a:t>Open wallet · owner · currencies</a:t>
+            </a:r>
+          </a:p>
+        </p:txBody>
+      </p:sp>
+      <p:sp>
+        <p:nvSpPr>
+          <p:cNvPr id="33" name="Rounded Rectangle 32"/>
           <p:cNvSpPr/>
           <p:nvPr/>
         </p:nvSpPr>
         <p:spPr>
           <a:xfrm>
-            <a:off x="6217920" y="1691640"/>
-            <a:ext cx="1417320" cy="914400"/>
+            <a:off x="6035040" y="1783080"/>
+            <a:ext cx="2606040" cy="777240"/>
           </a:xfrm>
           <a:prstGeom prst="roundRect">
             <a:avLst>
-              <a:gd name="adj" fmla="val 10000"/>
+              <a:gd name="adj" fmla="val 12000"/>
             </a:avLst>
           </a:prstGeom>
           <a:solidFill>
             <a:srgbClr val="0E2A4A"/>
           </a:solidFill>
-          <a:ln w="15875">
+          <a:ln w="17145">
             <a:solidFill>
               <a:srgbClr val="2DD4BF"/>
             </a:solidFill>
@@ -4768,14 +4356,14 @@
       </p:sp>
       <p:sp>
         <p:nvSpPr>
-          <p:cNvPr id="45" name="TextBox 44"/>
+          <p:cNvPr id="34" name="TextBox 33"/>
           <p:cNvSpPr txBox="1"/>
           <p:nvPr/>
         </p:nvSpPr>
         <p:spPr>
           <a:xfrm>
-            <a:off x="6327648" y="1801368"/>
-            <a:ext cx="1234440" cy="292608"/>
+            <a:off x="6144768" y="1874520"/>
+            <a:ext cx="2423160" cy="292608"/>
           </a:xfrm>
           <a:prstGeom prst="rect">
             <a:avLst/>
@@ -4796,21 +4384,21 @@
                 </a:solidFill>
                 <a:latin typeface="Calibri"/>
               </a:rPr>
-              <a:t>Brain</a:t>
-            </a:r>
-          </a:p>
-        </p:txBody>
-      </p:sp>
-      <p:sp>
-        <p:nvSpPr>
-          <p:cNvPr id="46" name="TextBox 45"/>
+              <a:t>Referrer Management</a:t>
+            </a:r>
+          </a:p>
+        </p:txBody>
+      </p:sp>
+      <p:sp>
+        <p:nvSpPr>
+          <p:cNvPr id="35" name="TextBox 34"/>
           <p:cNvSpPr txBox="1"/>
           <p:nvPr/>
         </p:nvSpPr>
         <p:spPr>
           <a:xfrm>
-            <a:off x="6327648" y="2075688"/>
-            <a:ext cx="1234440" cy="365760"/>
+            <a:off x="6144768" y="2167128"/>
+            <a:ext cx="2423160" cy="292644576000"/>
           </a:xfrm>
           <a:prstGeom prst="rect">
             <a:avLst/>
@@ -4831,31 +4419,31 @@
                 </a:solidFill>
                 <a:latin typeface="Calibri"/>
               </a:rPr>
-              <a:t>Rules · factors · formula</a:t>
-            </a:r>
-          </a:p>
-        </p:txBody>
-      </p:sp>
-      <p:sp>
-        <p:nvSpPr>
-          <p:cNvPr id="47" name="Rounded Rectangle 46"/>
+              <a:t>Referral / affiliate rules</a:t>
+            </a:r>
+          </a:p>
+        </p:txBody>
+      </p:sp>
+      <p:sp>
+        <p:nvSpPr>
+          <p:cNvPr id="36" name="Rounded Rectangle 35"/>
           <p:cNvSpPr/>
           <p:nvPr/>
         </p:nvSpPr>
         <p:spPr>
           <a:xfrm>
-            <a:off x="4690872" y="2715768"/>
-            <a:ext cx="1417320" cy="914400"/>
+            <a:off x="3246120" y="2697480"/>
+            <a:ext cx="2606040" cy="777240"/>
           </a:xfrm>
           <a:prstGeom prst="roundRect">
             <a:avLst>
-              <a:gd name="adj" fmla="val 10000"/>
+              <a:gd name="adj" fmla="val 12000"/>
             </a:avLst>
           </a:prstGeom>
           <a:solidFill>
             <a:srgbClr val="0E2A4A"/>
           </a:solidFill>
-          <a:ln w="15875">
+          <a:ln w="17145">
             <a:solidFill>
               <a:srgbClr val="2DD4BF"/>
             </a:solidFill>
@@ -4885,14 +4473,14 @@
       </p:sp>
       <p:sp>
         <p:nvSpPr>
-          <p:cNvPr id="48" name="TextBox 47"/>
+          <p:cNvPr id="37" name="TextBox 36"/>
           <p:cNvSpPr txBox="1"/>
           <p:nvPr/>
         </p:nvSpPr>
         <p:spPr>
           <a:xfrm>
-            <a:off x="4800600" y="2825496"/>
-            <a:ext cx="1234440" cy="292608"/>
+            <a:off x="3355848" y="2788920"/>
+            <a:ext cx="2423160" cy="292608"/>
           </a:xfrm>
           <a:prstGeom prst="rect">
             <a:avLst/>
@@ -4913,21 +4501,21 @@
                 </a:solidFill>
                 <a:latin typeface="Calibri"/>
               </a:rPr>
-              <a:t>Books</a:t>
-            </a:r>
-          </a:p>
-        </p:txBody>
-      </p:sp>
-      <p:sp>
-        <p:nvSpPr>
-          <p:cNvPr id="49" name="TextBox 48"/>
+              <a:t>Posting Engine</a:t>
+            </a:r>
+          </a:p>
+        </p:txBody>
+      </p:sp>
+      <p:sp>
+        <p:nvSpPr>
+          <p:cNvPr id="38" name="TextBox 37"/>
           <p:cNvSpPr txBox="1"/>
           <p:nvPr/>
         </p:nvSpPr>
         <p:spPr>
           <a:xfrm>
-            <a:off x="4800600" y="3099816"/>
-            <a:ext cx="1234440" cy="365760"/>
+            <a:off x="3355848" y="3081528"/>
+            <a:ext cx="2423160" cy="292644576000"/>
           </a:xfrm>
           <a:prstGeom prst="rect">
             <a:avLst/>
@@ -4948,31 +4536,31 @@
                 </a:solidFill>
                 <a:latin typeface="Calibri"/>
               </a:rPr>
-              <a:t>ApplyPosting · DE settle</a:t>
-            </a:r>
-          </a:p>
-        </p:txBody>
-      </p:sp>
-      <p:sp>
-        <p:nvSpPr>
-          <p:cNvPr id="50" name="Rounded Rectangle 49"/>
+              <a:t>Double-entry · settle movements</a:t>
+            </a:r>
+          </a:p>
+        </p:txBody>
+      </p:sp>
+      <p:sp>
+        <p:nvSpPr>
+          <p:cNvPr id="39" name="Rounded Rectangle 38"/>
           <p:cNvSpPr/>
           <p:nvPr/>
         </p:nvSpPr>
         <p:spPr>
           <a:xfrm>
-            <a:off x="6217920" y="2715768"/>
-            <a:ext cx="1417320" cy="914400"/>
+            <a:off x="6035040" y="2697480"/>
+            <a:ext cx="2606040" cy="777240"/>
           </a:xfrm>
           <a:prstGeom prst="roundRect">
             <a:avLst>
-              <a:gd name="adj" fmla="val 10000"/>
+              <a:gd name="adj" fmla="val 12000"/>
             </a:avLst>
           </a:prstGeom>
           <a:solidFill>
             <a:srgbClr val="0E2A4A"/>
           </a:solidFill>
-          <a:ln w="15875">
+          <a:ln w="17145">
             <a:solidFill>
               <a:srgbClr val="2DD4BF"/>
             </a:solidFill>
@@ -5002,14 +4590,14 @@
       </p:sp>
       <p:sp>
         <p:nvSpPr>
-          <p:cNvPr id="51" name="TextBox 50"/>
+          <p:cNvPr id="40" name="TextBox 39"/>
           <p:cNvSpPr txBox="1"/>
           <p:nvPr/>
         </p:nvSpPr>
         <p:spPr>
           <a:xfrm>
-            <a:off x="6327648" y="2825496"/>
-            <a:ext cx="1234440" cy="292608"/>
+            <a:off x="6144768" y="2788920"/>
+            <a:ext cx="2423160" cy="292608"/>
           </a:xfrm>
           <a:prstGeom prst="rect">
             <a:avLst/>
@@ -5030,21 +4618,21 @@
                 </a:solidFill>
                 <a:latin typeface="Calibri"/>
               </a:rPr>
-              <a:t>Wallet</a:t>
-            </a:r>
-          </a:p>
-        </p:txBody>
-      </p:sp>
-      <p:sp>
-        <p:nvSpPr>
-          <p:cNvPr id="52" name="TextBox 51"/>
+              <a:t>Ledger Books</a:t>
+            </a:r>
+          </a:p>
+        </p:txBody>
+      </p:sp>
+      <p:sp>
+        <p:nvSpPr>
+          <p:cNvPr id="41" name="TextBox 40"/>
           <p:cNvSpPr txBox="1"/>
           <p:nvPr/>
         </p:nvSpPr>
         <p:spPr>
           <a:xfrm>
-            <a:off x="6327648" y="3099816"/>
-            <a:ext cx="1234440" cy="365760"/>
+            <a:off x="6144768" y="3081528"/>
+            <a:ext cx="2423160" cy="292644576000"/>
           </a:xfrm>
           <a:prstGeom prst="rect">
             <a:avLst/>
@@ -5065,31 +4653,31 @@
                 </a:solidFill>
                 <a:latin typeface="Calibri"/>
               </a:rPr>
-              <a:t>1 owner · multi-ccy books</a:t>
-            </a:r>
-          </a:p>
-        </p:txBody>
-      </p:sp>
-      <p:sp>
-        <p:nvSpPr>
-          <p:cNvPr id="53" name="Rounded Rectangle 52"/>
+              <a:t>Balances · multi-currency accounts</a:t>
+            </a:r>
+          </a:p>
+        </p:txBody>
+      </p:sp>
+      <p:sp>
+        <p:nvSpPr>
+          <p:cNvPr id="42" name="Rounded Rectangle 41"/>
           <p:cNvSpPr/>
           <p:nvPr/>
         </p:nvSpPr>
         <p:spPr>
           <a:xfrm>
-            <a:off x="4690872" y="3739896"/>
-            <a:ext cx="1417320" cy="914400"/>
+            <a:off x="3246120" y="3611880"/>
+            <a:ext cx="2606040" cy="777240"/>
           </a:xfrm>
           <a:prstGeom prst="roundRect">
             <a:avLst>
-              <a:gd name="adj" fmla="val 10000"/>
+              <a:gd name="adj" fmla="val 12000"/>
             </a:avLst>
           </a:prstGeom>
           <a:solidFill>
             <a:srgbClr val="0E2A4A"/>
           </a:solidFill>
-          <a:ln w="15875">
+          <a:ln w="17145">
             <a:solidFill>
               <a:srgbClr val="2DD4BF"/>
             </a:solidFill>
@@ -5119,14 +4707,14 @@
       </p:sp>
       <p:sp>
         <p:nvSpPr>
-          <p:cNvPr id="54" name="TextBox 53"/>
+          <p:cNvPr id="43" name="TextBox 42"/>
           <p:cNvSpPr txBox="1"/>
           <p:nvPr/>
         </p:nvSpPr>
         <p:spPr>
           <a:xfrm>
-            <a:off x="4800600" y="3849624"/>
-            <a:ext cx="1234440" cy="292608"/>
+            <a:off x="3355848" y="3703320"/>
+            <a:ext cx="2423160" cy="292608"/>
           </a:xfrm>
           <a:prstGeom prst="rect">
             <a:avLst/>
@@ -5147,21 +4735,21 @@
                 </a:solidFill>
                 <a:latin typeface="Calibri"/>
               </a:rPr>
-              <a:t>COA &amp; Catalog</a:t>
-            </a:r>
-          </a:p>
-        </p:txBody>
-      </p:sp>
-      <p:sp>
-        <p:nvSpPr>
-          <p:cNvPr id="55" name="TextBox 54"/>
+              <a:t>Account Rules (COA)</a:t>
+            </a:r>
+          </a:p>
+        </p:txBody>
+      </p:sp>
+      <p:sp>
+        <p:nvSpPr>
+          <p:cNvPr id="44" name="TextBox 43"/>
           <p:cNvSpPr txBox="1"/>
           <p:nvPr/>
         </p:nvSpPr>
         <p:spPr>
           <a:xfrm>
-            <a:off x="4800600" y="4123944"/>
-            <a:ext cx="1234440" cy="365760"/>
+            <a:off x="3355848" y="3995928"/>
+            <a:ext cx="2423160" cy="292644576000"/>
           </a:xfrm>
           <a:prstGeom prst="rect">
             <a:avLst/>
@@ -5182,31 +4770,31 @@
                 </a:solidFill>
                 <a:latin typeface="Calibri"/>
               </a:rPr>
-              <a:t>Profiles · recipes · codes</a:t>
-            </a:r>
-          </a:p>
-        </p:txBody>
-      </p:sp>
-      <p:sp>
-        <p:nvSpPr>
-          <p:cNvPr id="56" name="Rounded Rectangle 55"/>
+              <a:t>Chart of accounts · profiles</a:t>
+            </a:r>
+          </a:p>
+        </p:txBody>
+      </p:sp>
+      <p:sp>
+        <p:nvSpPr>
+          <p:cNvPr id="45" name="Rounded Rectangle 44"/>
           <p:cNvSpPr/>
           <p:nvPr/>
         </p:nvSpPr>
         <p:spPr>
           <a:xfrm>
-            <a:off x="6217920" y="3739896"/>
-            <a:ext cx="1417320" cy="914400"/>
+            <a:off x="6035040" y="3611880"/>
+            <a:ext cx="2606040" cy="777240"/>
           </a:xfrm>
           <a:prstGeom prst="roundRect">
             <a:avLst>
-              <a:gd name="adj" fmla="val 10000"/>
+              <a:gd name="adj" fmla="val 12000"/>
             </a:avLst>
           </a:prstGeom>
           <a:solidFill>
             <a:srgbClr val="0E2A4A"/>
           </a:solidFill>
-          <a:ln w="15875">
+          <a:ln w="17145">
             <a:solidFill>
               <a:srgbClr val="2DD4BF"/>
             </a:solidFill>
@@ -5236,14 +4824,14 @@
       </p:sp>
       <p:sp>
         <p:nvSpPr>
-          <p:cNvPr id="57" name="TextBox 56"/>
+          <p:cNvPr id="46" name="TextBox 45"/>
           <p:cNvSpPr txBox="1"/>
           <p:nvPr/>
         </p:nvSpPr>
         <p:spPr>
           <a:xfrm>
-            <a:off x="6327648" y="3849624"/>
-            <a:ext cx="1234440" cy="292608"/>
+            <a:off x="6144768" y="3703320"/>
+            <a:ext cx="2423160" cy="292608"/>
           </a:xfrm>
           <a:prstGeom prst="rect">
             <a:avLst/>
@@ -5264,21 +4852,21 @@
                 </a:solidFill>
                 <a:latin typeface="Calibri"/>
               </a:rPr>
-              <a:t>Event Bus</a:t>
-            </a:r>
-          </a:p>
-        </p:txBody>
-      </p:sp>
-      <p:sp>
-        <p:nvSpPr>
-          <p:cNvPr id="58" name="TextBox 57"/>
+              <a:t>Points Calculation</a:t>
+            </a:r>
+          </a:p>
+        </p:txBody>
+      </p:sp>
+      <p:sp>
+        <p:nvSpPr>
+          <p:cNvPr id="47" name="TextBox 46"/>
           <p:cNvSpPr txBox="1"/>
           <p:nvPr/>
         </p:nvSpPr>
         <p:spPr>
           <a:xfrm>
-            <a:off x="6327648" y="4123944"/>
-            <a:ext cx="1234440" cy="365760"/>
+            <a:off x="6144768" y="3995928"/>
+            <a:ext cx="2423160" cy="292644576000"/>
           </a:xfrm>
           <a:prstGeom prst="rect">
             <a:avLst/>
@@ -5299,25 +4887,25 @@
                 </a:solidFill>
                 <a:latin typeface="Calibri"/>
               </a:rPr>
-              <a:t>balance.updated · audit</a:t>
-            </a:r>
-          </a:p>
-        </p:txBody>
-      </p:sp>
-      <p:sp>
-        <p:nvSpPr>
-          <p:cNvPr id="59" name="Rounded Rectangle 58"/>
+              <a:t>Formulas · rates · fixed rewards</a:t>
+            </a:r>
+          </a:p>
+        </p:txBody>
+      </p:sp>
+      <p:sp>
+        <p:nvSpPr>
+          <p:cNvPr id="48" name="Rounded Rectangle 47"/>
           <p:cNvSpPr/>
           <p:nvPr/>
         </p:nvSpPr>
         <p:spPr>
           <a:xfrm>
-            <a:off x="4690872" y="4709160"/>
-            <a:ext cx="2916936" cy="502920"/>
+            <a:off x="3246120" y="4663440"/>
+            <a:ext cx="5257800" cy="502920"/>
           </a:xfrm>
           <a:prstGeom prst="roundRect">
             <a:avLst>
-              <a:gd name="adj" fmla="val 10000"/>
+              <a:gd name="adj" fmla="val 12000"/>
             </a:avLst>
           </a:prstGeom>
           <a:solidFill>
@@ -5353,14 +4941,14 @@
       </p:sp>
       <p:sp>
         <p:nvSpPr>
-          <p:cNvPr id="60" name="TextBox 59"/>
+          <p:cNvPr id="49" name="TextBox 48"/>
           <p:cNvSpPr txBox="1"/>
           <p:nvPr/>
         </p:nvSpPr>
         <p:spPr>
           <a:xfrm>
-            <a:off x="4754880" y="4773168"/>
-            <a:ext cx="2788920" cy="384048"/>
+            <a:off x="3337560" y="4754880"/>
+            <a:ext cx="5074920" cy="365760"/>
           </a:xfrm>
           <a:prstGeom prst="rect">
             <a:avLst/>
@@ -5375,27 +4963,27 @@
           <a:p>
             <a:pPr algn="l"/>
             <a:r>
-              <a:rPr sz="1100" b="1">
+              <a:rPr sz="1200" b="1">
                 <a:solidFill>
                   <a:srgbClr val="F1F5F9"/>
                 </a:solidFill>
                 <a:latin typeface="Calibri"/>
               </a:rPr>
-              <a:t>Event → Door → Brain → COA/Recipe → Posting → Balances → Out</a:t>
-            </a:r>
-          </a:p>
-        </p:txBody>
-      </p:sp>
-      <p:sp>
-        <p:nvSpPr>
-          <p:cNvPr id="61" name="TextBox 60"/>
+              <a:t>Flow:  Event in  →  Rules &amp; calculation  →  Posting  →  Ledger books  →  Event out</a:t>
+            </a:r>
+          </a:p>
+        </p:txBody>
+      </p:sp>
+      <p:sp>
+        <p:nvSpPr>
+          <p:cNvPr id="50" name="TextBox 49"/>
           <p:cNvSpPr txBox="1"/>
           <p:nvPr/>
         </p:nvSpPr>
         <p:spPr>
           <a:xfrm>
-            <a:off x="4690872" y="5349240"/>
-            <a:ext cx="2916936" cy="594360"/>
+            <a:off x="8961120" y="822960"/>
+            <a:ext cx="2926080" cy="256032"/>
           </a:xfrm>
           <a:prstGeom prst="rect">
             <a:avLst/>
@@ -5410,38 +4998,37 @@
           <a:p>
             <a:pPr algn="l"/>
             <a:r>
-              <a:rPr sz="1000" b="0">
-                <a:solidFill>
-                  <a:srgbClr val="94A3B8"/>
+              <a:rPr sz="1200" b="1">
+                <a:solidFill>
+                  <a:srgbClr val="FBBF24"/>
                 </a:solidFill>
                 <a:latin typeface="Calibri"/>
               </a:rPr>
-              <a:t>Ops configures once (Admin)  ·  Upstream invokes use-case codes only
-One engine — not N custom ledgers per channel</a:t>
-            </a:r>
-          </a:p>
-        </p:txBody>
-      </p:sp>
-      <p:sp>
-        <p:nvSpPr>
-          <p:cNvPr id="62" name="Rounded Rectangle 61"/>
+              <a:t>5  Add-on modules</a:t>
+            </a:r>
+          </a:p>
+        </p:txBody>
+      </p:sp>
+      <p:sp>
+        <p:nvSpPr>
+          <p:cNvPr id="51" name="Rounded Rectangle 50"/>
           <p:cNvSpPr/>
           <p:nvPr/>
         </p:nvSpPr>
         <p:spPr>
           <a:xfrm>
-            <a:off x="7909560" y="868680"/>
-            <a:ext cx="1417320" cy="5257800"/>
+            <a:off x="8915400" y="1097280"/>
+            <a:ext cx="2971800" cy="1691640"/>
           </a:xfrm>
           <a:prstGeom prst="roundRect">
             <a:avLst>
-              <a:gd name="adj" fmla="val 10000"/>
+              <a:gd name="adj" fmla="val 12000"/>
             </a:avLst>
           </a:prstGeom>
           <a:solidFill>
             <a:srgbClr val="0C2340"/>
           </a:solidFill>
-          <a:ln w="22225">
+          <a:ln w="19050">
             <a:solidFill>
               <a:srgbClr val="FBBF24"/>
             </a:solidFill>
@@ -5471,25 +5058,62 @@
       </p:sp>
       <p:sp>
         <p:nvSpPr>
-          <p:cNvPr id="63" name="Rounded Rectangle 62"/>
+          <p:cNvPr id="52" name="TextBox 51"/>
+          <p:cNvSpPr txBox="1"/>
+          <p:nvPr/>
+        </p:nvSpPr>
+        <p:spPr>
+          <a:xfrm>
+            <a:off x="9052560" y="1207008"/>
+            <a:ext cx="2743200" cy="320040"/>
+          </a:xfrm>
+          <a:prstGeom prst="rect">
+            <a:avLst/>
+          </a:prstGeom>
+          <a:noFill/>
+        </p:spPr>
+        <p:txBody>
+          <a:bodyPr wrap="square">
+            <a:spAutoFit/>
+          </a:bodyPr>
+          <a:lstStyle/>
+          <a:p>
+            <a:pPr algn="l"/>
+            <a:r>
+              <a:rPr sz="1100" b="0">
+                <a:solidFill>
+                  <a:srgbClr val="94A3B8"/>
+                </a:solidFill>
+                <a:latin typeface="Calibri"/>
+              </a:rPr>
+              <a:t>Extends LedgeRX core</a:t>
+            </a:r>
+          </a:p>
+        </p:txBody>
+      </p:sp>
+      <p:sp>
+        <p:nvSpPr>
+          <p:cNvPr id="53" name="Rounded Rectangle 52"/>
           <p:cNvSpPr/>
           <p:nvPr/>
         </p:nvSpPr>
         <p:spPr>
           <a:xfrm>
-            <a:off x="8019288" y="978408"/>
-            <a:ext cx="274320" cy="274320"/>
+            <a:off x="9098280" y="1600200"/>
+            <a:ext cx="2651760" cy="457200"/>
           </a:xfrm>
           <a:prstGeom prst="roundRect">
             <a:avLst>
-              <a:gd name="adj" fmla="val 10000"/>
+              <a:gd name="adj" fmla="val 12000"/>
             </a:avLst>
           </a:prstGeom>
           <a:solidFill>
-            <a:srgbClr val="FBBF24"/>
+            <a:srgbClr val="0E2A4A"/>
           </a:solidFill>
-          <a:ln>
-            <a:noFill/>
+          <a:ln w="17145">
+            <a:solidFill>
+              <a:srgbClr val="FBBF24"/>
+            </a:solidFill>
           </a:ln>
         </p:spPr>
         <p:style>
@@ -5516,14 +5140,14 @@
       </p:sp>
       <p:sp>
         <p:nvSpPr>
-          <p:cNvPr id="64" name="TextBox 63"/>
+          <p:cNvPr id="54" name="TextBox 53"/>
           <p:cNvSpPr txBox="1"/>
           <p:nvPr/>
         </p:nvSpPr>
         <p:spPr>
           <a:xfrm>
-            <a:off x="8019288" y="996696"/>
-            <a:ext cx="274320" cy="256032"/>
+            <a:off x="9208008" y="1691640"/>
+            <a:ext cx="2468880" cy="292608"/>
           </a:xfrm>
           <a:prstGeom prst="rect">
             <a:avLst/>
@@ -5536,29 +5160,29 @@
           </a:bodyPr>
           <a:lstStyle/>
           <a:p>
-            <a:pPr algn="ctr"/>
+            <a:pPr algn="l"/>
             <a:r>
               <a:rPr sz="1200" b="1">
                 <a:solidFill>
-                  <a:srgbClr val="0B1220"/>
+                  <a:srgbClr val="F1F5F9"/>
                 </a:solidFill>
                 <a:latin typeface="Calibri"/>
               </a:rPr>
-              <a:t>5</a:t>
-            </a:r>
-          </a:p>
-        </p:txBody>
-      </p:sp>
-      <p:sp>
-        <p:nvSpPr>
-          <p:cNvPr id="65" name="TextBox 64"/>
+              <a:t>Wallet Tiering</a:t>
+            </a:r>
+          </a:p>
+        </p:txBody>
+      </p:sp>
+      <p:sp>
+        <p:nvSpPr>
+          <p:cNvPr id="55" name="TextBox 54"/>
           <p:cNvSpPr txBox="1"/>
           <p:nvPr/>
         </p:nvSpPr>
         <p:spPr>
           <a:xfrm>
-            <a:off x="8348472" y="996696"/>
-            <a:ext cx="868680" cy="274320"/>
+            <a:off x="9208008" y="1984248"/>
+            <a:ext cx="2468880" cy="0"/>
           </a:xfrm>
           <a:prstGeom prst="rect">
             <a:avLst/>
@@ -5573,73 +5197,37 @@
           <a:p>
             <a:pPr algn="l"/>
             <a:r>
-              <a:rPr sz="1300" b="1">
-                <a:solidFill>
-                  <a:srgbClr val="FBBF24"/>
+              <a:rPr sz="1000" b="0">
+                <a:solidFill>
+                  <a:srgbClr val="94A3B8"/>
                 </a:solidFill>
                 <a:latin typeface="Calibri"/>
               </a:rPr>
-              <a:t>Add-ons</a:t>
-            </a:r>
-          </a:p>
-        </p:txBody>
-      </p:sp>
-      <p:sp>
-        <p:nvSpPr>
-          <p:cNvPr id="66" name="TextBox 65"/>
-          <p:cNvSpPr txBox="1"/>
-          <p:nvPr/>
-        </p:nvSpPr>
-        <p:spPr>
-          <a:xfrm>
-            <a:off x="8001000" y="1325880"/>
-            <a:ext cx="1234440" cy="502920"/>
-          </a:xfrm>
-          <a:prstGeom prst="rect">
-            <a:avLst/>
-          </a:prstGeom>
-          <a:noFill/>
-        </p:spPr>
-        <p:txBody>
-          <a:bodyPr wrap="square">
-            <a:spAutoFit/>
-          </a:bodyPr>
-          <a:lstStyle/>
-          <a:p>
-            <a:pPr algn="l"/>
-            <a:r>
-              <a:rPr sz="1100" b="0">
-                <a:solidFill>
-                  <a:srgbClr val="94A3B8"/>
-                </a:solidFill>
-                <a:latin typeface="Calibri"/>
-              </a:rPr>
-              <a:t>Beside core
-Extend without fork</a:t>
-            </a:r>
-          </a:p>
-        </p:txBody>
-      </p:sp>
-      <p:sp>
-        <p:nvSpPr>
-          <p:cNvPr id="67" name="Rounded Rectangle 66"/>
+              <a:t>Segments · benefits · TBC</a:t>
+            </a:r>
+          </a:p>
+        </p:txBody>
+      </p:sp>
+      <p:sp>
+        <p:nvSpPr>
+          <p:cNvPr id="56" name="Rounded Rectangle 55"/>
           <p:cNvSpPr/>
           <p:nvPr/>
         </p:nvSpPr>
         <p:spPr>
           <a:xfrm>
-            <a:off x="8019288" y="2011680"/>
-            <a:ext cx="1197864" cy="914400"/>
+            <a:off x="9098280" y="2148840"/>
+            <a:ext cx="2651760" cy="457200"/>
           </a:xfrm>
           <a:prstGeom prst="roundRect">
             <a:avLst>
-              <a:gd name="adj" fmla="val 10000"/>
+              <a:gd name="adj" fmla="val 12000"/>
             </a:avLst>
           </a:prstGeom>
           <a:solidFill>
             <a:srgbClr val="0E2A4A"/>
           </a:solidFill>
-          <a:ln w="15875">
+          <a:ln w="17145">
             <a:solidFill>
               <a:srgbClr val="FBBF24"/>
             </a:solidFill>
@@ -5669,14 +5257,14 @@
       </p:sp>
       <p:sp>
         <p:nvSpPr>
-          <p:cNvPr id="68" name="TextBox 67"/>
+          <p:cNvPr id="57" name="TextBox 56"/>
           <p:cNvSpPr txBox="1"/>
           <p:nvPr/>
         </p:nvSpPr>
         <p:spPr>
           <a:xfrm>
-            <a:off x="8129016" y="2121408"/>
-            <a:ext cx="1014984" cy="292608"/>
+            <a:off x="9208008" y="2240280"/>
+            <a:ext cx="2468880" cy="292608"/>
           </a:xfrm>
           <a:prstGeom prst="rect">
             <a:avLst/>
@@ -5691,27 +5279,27 @@
           <a:p>
             <a:pPr algn="l"/>
             <a:r>
-              <a:rPr sz="1300" b="1">
+              <a:rPr sz="1200" b="1">
                 <a:solidFill>
                   <a:srgbClr val="F1F5F9"/>
                 </a:solidFill>
                 <a:latin typeface="Calibri"/>
               </a:rPr>
-              <a:t>Wallet Tiering</a:t>
-            </a:r>
-          </a:p>
-        </p:txBody>
-      </p:sp>
-      <p:sp>
-        <p:nvSpPr>
-          <p:cNvPr id="69" name="TextBox 68"/>
+              <a:t>More add-ons…</a:t>
+            </a:r>
+          </a:p>
+        </p:txBody>
+      </p:sp>
+      <p:sp>
+        <p:nvSpPr>
+          <p:cNvPr id="58" name="TextBox 57"/>
           <p:cNvSpPr txBox="1"/>
           <p:nvPr/>
         </p:nvSpPr>
         <p:spPr>
           <a:xfrm>
-            <a:off x="8129016" y="2395728"/>
-            <a:ext cx="1014984" cy="365760"/>
+            <a:off x="9208008" y="2532888"/>
+            <a:ext cx="2468880" cy="0"/>
           </a:xfrm>
           <a:prstGeom prst="rect">
             <a:avLst/>
@@ -5732,33 +5320,68 @@
                 </a:solidFill>
                 <a:latin typeface="Calibri"/>
               </a:rPr>
-              <a:t>Segments · benefits</a:t>
-            </a:r>
-          </a:p>
-        </p:txBody>
-      </p:sp>
-      <p:sp>
-        <p:nvSpPr>
-          <p:cNvPr id="70" name="Rounded Rectangle 69"/>
+              <a:t>TBC</a:t>
+            </a:r>
+          </a:p>
+        </p:txBody>
+      </p:sp>
+      <p:sp>
+        <p:nvSpPr>
+          <p:cNvPr id="59" name="TextBox 58"/>
+          <p:cNvSpPr txBox="1"/>
+          <p:nvPr/>
+        </p:nvSpPr>
+        <p:spPr>
+          <a:xfrm>
+            <a:off x="8961120" y="2971800"/>
+            <a:ext cx="2926080" cy="256032"/>
+          </a:xfrm>
+          <a:prstGeom prst="rect">
+            <a:avLst/>
+          </a:prstGeom>
+          <a:noFill/>
+        </p:spPr>
+        <p:txBody>
+          <a:bodyPr wrap="square">
+            <a:spAutoFit/>
+          </a:bodyPr>
+          <a:lstStyle/>
+          <a:p>
+            <a:pPr algn="l"/>
+            <a:r>
+              <a:rPr sz="1200" b="1">
+                <a:solidFill>
+                  <a:srgbClr val="A78BFA"/>
+                </a:solidFill>
+                <a:latin typeface="Calibri"/>
+              </a:rPr>
+              <a:t>4  Landing / Downstream</a:t>
+            </a:r>
+          </a:p>
+        </p:txBody>
+      </p:sp>
+      <p:sp>
+        <p:nvSpPr>
+          <p:cNvPr id="60" name="Rounded Rectangle 59"/>
           <p:cNvSpPr/>
           <p:nvPr/>
         </p:nvSpPr>
         <p:spPr>
           <a:xfrm>
-            <a:off x="8019288" y="3063240"/>
-            <a:ext cx="1197864" cy="914400"/>
+            <a:off x="8915400" y="3246120"/>
+            <a:ext cx="2971800" cy="2194560"/>
           </a:xfrm>
           <a:prstGeom prst="roundRect">
             <a:avLst>
-              <a:gd name="adj" fmla="val 10000"/>
+              <a:gd name="adj" fmla="val 12000"/>
             </a:avLst>
           </a:prstGeom>
           <a:solidFill>
-            <a:srgbClr val="0E2A4A"/>
+            <a:srgbClr val="0C2340"/>
           </a:solidFill>
-          <a:ln w="15875">
+          <a:ln w="19050">
             <a:solidFill>
-              <a:srgbClr val="FBBF24"/>
+              <a:srgbClr val="A78BFA"/>
             </a:solidFill>
           </a:ln>
         </p:spPr>
@@ -5786,14 +5409,14 @@
       </p:sp>
       <p:sp>
         <p:nvSpPr>
-          <p:cNvPr id="71" name="TextBox 70"/>
+          <p:cNvPr id="61" name="TextBox 60"/>
           <p:cNvSpPr txBox="1"/>
           <p:nvPr/>
         </p:nvSpPr>
         <p:spPr>
           <a:xfrm>
-            <a:off x="8129016" y="3172968"/>
-            <a:ext cx="1014984" cy="292608"/>
+            <a:off x="9052560" y="3337560"/>
+            <a:ext cx="2743200" cy="274320"/>
           </a:xfrm>
           <a:prstGeom prst="rect">
             <a:avLst/>
@@ -5808,74 +5431,39 @@
           <a:p>
             <a:pPr algn="l"/>
             <a:r>
-              <a:rPr sz="1300" b="1">
-                <a:solidFill>
-                  <a:srgbClr val="F1F5F9"/>
+              <a:rPr sz="1100" b="0">
+                <a:solidFill>
+                  <a:srgbClr val="94A3B8"/>
                 </a:solidFill>
                 <a:latin typeface="Calibri"/>
               </a:rPr>
-              <a:t>Campaign packs</a:t>
-            </a:r>
-          </a:p>
-        </p:txBody>
-      </p:sp>
-      <p:sp>
-        <p:nvSpPr>
-          <p:cNvPr id="72" name="TextBox 71"/>
-          <p:cNvSpPr txBox="1"/>
-          <p:nvPr/>
-        </p:nvSpPr>
-        <p:spPr>
-          <a:xfrm>
-            <a:off x="8129016" y="3447288"/>
-            <a:ext cx="1014984" cy="365760"/>
-          </a:xfrm>
-          <a:prstGeom prst="rect">
-            <a:avLst/>
-          </a:prstGeom>
-          <a:noFill/>
-        </p:spPr>
-        <p:txBody>
-          <a:bodyPr wrap="square">
-            <a:spAutoFit/>
-          </a:bodyPr>
-          <a:lstStyle/>
-          <a:p>
-            <a:pPr algn="l"/>
-            <a:r>
-              <a:rPr sz="1000" b="0">
-                <a:solidFill>
-                  <a:srgbClr val="94A3B8"/>
-                </a:solidFill>
-                <a:latin typeface="Calibri"/>
-              </a:rPr>
-              <a:t>TBC</a:t>
-            </a:r>
-          </a:p>
-        </p:txBody>
-      </p:sp>
-      <p:sp>
-        <p:nvSpPr>
-          <p:cNvPr id="73" name="Rounded Rectangle 72"/>
+              <a:t>Results back to client</a:t>
+            </a:r>
+          </a:p>
+        </p:txBody>
+      </p:sp>
+      <p:sp>
+        <p:nvSpPr>
+          <p:cNvPr id="62" name="Rounded Rectangle 61"/>
           <p:cNvSpPr/>
           <p:nvPr/>
         </p:nvSpPr>
         <p:spPr>
           <a:xfrm>
-            <a:off x="8019288" y="4114800"/>
-            <a:ext cx="1197864" cy="914400"/>
+            <a:off x="9098280" y="3703320"/>
+            <a:ext cx="2651760" cy="438912"/>
           </a:xfrm>
           <a:prstGeom prst="roundRect">
             <a:avLst>
-              <a:gd name="adj" fmla="val 10000"/>
+              <a:gd name="adj" fmla="val 12000"/>
             </a:avLst>
           </a:prstGeom>
           <a:solidFill>
             <a:srgbClr val="0E2A4A"/>
           </a:solidFill>
-          <a:ln w="15875">
+          <a:ln w="17145">
             <a:solidFill>
-              <a:srgbClr val="FBBF24"/>
+              <a:srgbClr val="A78BFA"/>
             </a:solidFill>
           </a:ln>
         </p:spPr>
@@ -5903,14 +5491,14 @@
       </p:sp>
       <p:sp>
         <p:nvSpPr>
-          <p:cNvPr id="74" name="TextBox 73"/>
+          <p:cNvPr id="63" name="TextBox 62"/>
           <p:cNvSpPr txBox="1"/>
           <p:nvPr/>
         </p:nvSpPr>
         <p:spPr>
           <a:xfrm>
-            <a:off x="8129016" y="4224528"/>
-            <a:ext cx="1014984" cy="292608"/>
+            <a:off x="9208008" y="3794760"/>
+            <a:ext cx="2468880" cy="292608"/>
           </a:xfrm>
           <a:prstGeom prst="rect">
             <a:avLst/>
@@ -5925,27 +5513,27 @@
           <a:p>
             <a:pPr algn="l"/>
             <a:r>
-              <a:rPr sz="1300" b="1">
+              <a:rPr sz="1200" b="1">
                 <a:solidFill>
                   <a:srgbClr val="F1F5F9"/>
                 </a:solidFill>
                 <a:latin typeface="Calibri"/>
               </a:rPr>
-              <a:t>More modules</a:t>
-            </a:r>
-          </a:p>
-        </p:txBody>
-      </p:sp>
-      <p:sp>
-        <p:nvSpPr>
-          <p:cNvPr id="75" name="TextBox 74"/>
+              <a:t>E-coupon system</a:t>
+            </a:r>
+          </a:p>
+        </p:txBody>
+      </p:sp>
+      <p:sp>
+        <p:nvSpPr>
+          <p:cNvPr id="64" name="TextBox 63"/>
           <p:cNvSpPr txBox="1"/>
           <p:nvPr/>
         </p:nvSpPr>
         <p:spPr>
           <a:xfrm>
-            <a:off x="8129016" y="4498848"/>
-            <a:ext cx="1014984" cy="365760"/>
+            <a:off x="9208008" y="4087368"/>
+            <a:ext cx="2468880" cy="-16722547200"/>
           </a:xfrm>
           <a:prstGeom prst="rect">
             <a:avLst/>
@@ -5966,67 +5554,31 @@
                 </a:solidFill>
                 <a:latin typeface="Calibri"/>
               </a:rPr>
-              <a:t>TBC …</a:t>
-            </a:r>
-          </a:p>
-        </p:txBody>
-      </p:sp>
-      <p:sp>
-        <p:nvSpPr>
-          <p:cNvPr id="76" name="TextBox 75"/>
-          <p:cNvSpPr txBox="1"/>
-          <p:nvPr/>
-        </p:nvSpPr>
-        <p:spPr>
-          <a:xfrm>
-            <a:off x="8001000" y="5303520"/>
-            <a:ext cx="1234440" cy="640080"/>
-          </a:xfrm>
-          <a:prstGeom prst="rect">
-            <a:avLst/>
-          </a:prstGeom>
-          <a:noFill/>
-        </p:spPr>
-        <p:txBody>
-          <a:bodyPr wrap="square">
-            <a:spAutoFit/>
-          </a:bodyPr>
-          <a:lstStyle/>
-          <a:p>
-            <a:pPr algn="l"/>
-            <a:r>
-              <a:rPr sz="1000" b="0">
-                <a:solidFill>
-                  <a:srgbClr val="94A3B8"/>
-                </a:solidFill>
-                <a:latin typeface="Calibri"/>
-              </a:rPr>
-              <a:t>Plugs into
-Product Edge</a:t>
-            </a:r>
-          </a:p>
-        </p:txBody>
-      </p:sp>
-      <p:sp>
-        <p:nvSpPr>
-          <p:cNvPr id="77" name="Rounded Rectangle 76"/>
+              <a:t>Issue · redeem</a:t>
+            </a:r>
+          </a:p>
+        </p:txBody>
+      </p:sp>
+      <p:sp>
+        <p:nvSpPr>
+          <p:cNvPr id="65" name="Rounded Rectangle 64"/>
           <p:cNvSpPr/>
           <p:nvPr/>
         </p:nvSpPr>
         <p:spPr>
           <a:xfrm>
-            <a:off x="9509760" y="868680"/>
-            <a:ext cx="2377440" cy="5257800"/>
+            <a:off x="9098280" y="4206240"/>
+            <a:ext cx="2651760" cy="438912"/>
           </a:xfrm>
           <a:prstGeom prst="roundRect">
             <a:avLst>
-              <a:gd name="adj" fmla="val 10000"/>
+              <a:gd name="adj" fmla="val 12000"/>
             </a:avLst>
           </a:prstGeom>
           <a:solidFill>
-            <a:srgbClr val="0C2340"/>
+            <a:srgbClr val="0E2A4A"/>
           </a:solidFill>
-          <a:ln w="22225">
+          <a:ln w="17145">
             <a:solidFill>
               <a:srgbClr val="A78BFA"/>
             </a:solidFill>
@@ -6056,25 +5608,97 @@
       </p:sp>
       <p:sp>
         <p:nvSpPr>
-          <p:cNvPr id="78" name="Rounded Rectangle 77"/>
+          <p:cNvPr id="66" name="TextBox 65"/>
+          <p:cNvSpPr txBox="1"/>
+          <p:nvPr/>
+        </p:nvSpPr>
+        <p:spPr>
+          <a:xfrm>
+            <a:off x="9208008" y="4297680"/>
+            <a:ext cx="2468880" cy="292608"/>
+          </a:xfrm>
+          <a:prstGeom prst="rect">
+            <a:avLst/>
+          </a:prstGeom>
+          <a:noFill/>
+        </p:spPr>
+        <p:txBody>
+          <a:bodyPr wrap="square">
+            <a:spAutoFit/>
+          </a:bodyPr>
+          <a:lstStyle/>
+          <a:p>
+            <a:pPr algn="l"/>
+            <a:r>
+              <a:rPr sz="1200" b="1">
+                <a:solidFill>
+                  <a:srgbClr val="F1F5F9"/>
+                </a:solidFill>
+                <a:latin typeface="Calibri"/>
+              </a:rPr>
+              <a:t>Gift system</a:t>
+            </a:r>
+          </a:p>
+        </p:txBody>
+      </p:sp>
+      <p:sp>
+        <p:nvSpPr>
+          <p:cNvPr id="67" name="TextBox 66"/>
+          <p:cNvSpPr txBox="1"/>
+          <p:nvPr/>
+        </p:nvSpPr>
+        <p:spPr>
+          <a:xfrm>
+            <a:off x="9208008" y="4590288"/>
+            <a:ext cx="2468880" cy="-16722547200"/>
+          </a:xfrm>
+          <a:prstGeom prst="rect">
+            <a:avLst/>
+          </a:prstGeom>
+          <a:noFill/>
+        </p:spPr>
+        <p:txBody>
+          <a:bodyPr wrap="square">
+            <a:spAutoFit/>
+          </a:bodyPr>
+          <a:lstStyle/>
+          <a:p>
+            <a:pPr algn="l"/>
+            <a:r>
+              <a:rPr sz="1000" b="0">
+                <a:solidFill>
+                  <a:srgbClr val="94A3B8"/>
+                </a:solidFill>
+                <a:latin typeface="Calibri"/>
+              </a:rPr>
+              <a:t>Fulfillment</a:t>
+            </a:r>
+          </a:p>
+        </p:txBody>
+      </p:sp>
+      <p:sp>
+        <p:nvSpPr>
+          <p:cNvPr id="68" name="Rounded Rectangle 67"/>
           <p:cNvSpPr/>
           <p:nvPr/>
         </p:nvSpPr>
         <p:spPr>
           <a:xfrm>
-            <a:off x="9619488" y="978408"/>
-            <a:ext cx="274320" cy="274320"/>
+            <a:off x="9098280" y="4709160"/>
+            <a:ext cx="2651760" cy="438912"/>
           </a:xfrm>
           <a:prstGeom prst="roundRect">
             <a:avLst>
-              <a:gd name="adj" fmla="val 10000"/>
+              <a:gd name="adj" fmla="val 12000"/>
             </a:avLst>
           </a:prstGeom>
           <a:solidFill>
-            <a:srgbClr val="A78BFA"/>
+            <a:srgbClr val="0E2A4A"/>
           </a:solidFill>
-          <a:ln>
-            <a:noFill/>
+          <a:ln w="17145">
+            <a:solidFill>
+              <a:srgbClr val="A78BFA"/>
+            </a:solidFill>
           </a:ln>
         </p:spPr>
         <p:style>
@@ -6101,14 +5725,14 @@
       </p:sp>
       <p:sp>
         <p:nvSpPr>
-          <p:cNvPr id="79" name="TextBox 78"/>
+          <p:cNvPr id="69" name="TextBox 68"/>
           <p:cNvSpPr txBox="1"/>
           <p:nvPr/>
         </p:nvSpPr>
         <p:spPr>
           <a:xfrm>
-            <a:off x="9619488" y="996696"/>
-            <a:ext cx="274320" cy="256032"/>
+            <a:off x="9208008" y="4800600"/>
+            <a:ext cx="2468880" cy="292608"/>
           </a:xfrm>
           <a:prstGeom prst="rect">
             <a:avLst/>
@@ -6121,29 +5745,29 @@
           </a:bodyPr>
           <a:lstStyle/>
           <a:p>
-            <a:pPr algn="ctr"/>
+            <a:pPr algn="l"/>
             <a:r>
               <a:rPr sz="1200" b="1">
                 <a:solidFill>
-                  <a:srgbClr val="0B1220"/>
+                  <a:srgbClr val="F1F5F9"/>
                 </a:solidFill>
                 <a:latin typeface="Calibri"/>
               </a:rPr>
-              <a:t>4</a:t>
-            </a:r>
-          </a:p>
-        </p:txBody>
-      </p:sp>
-      <p:sp>
-        <p:nvSpPr>
-          <p:cNvPr id="80" name="TextBox 79"/>
+              <a:t>Notifications</a:t>
+            </a:r>
+          </a:p>
+        </p:txBody>
+      </p:sp>
+      <p:sp>
+        <p:nvSpPr>
+          <p:cNvPr id="70" name="TextBox 69"/>
           <p:cNvSpPr txBox="1"/>
           <p:nvPr/>
         </p:nvSpPr>
         <p:spPr>
           <a:xfrm>
-            <a:off x="9948672" y="996696"/>
-            <a:ext cx="1828800" cy="274320"/>
+            <a:off x="9208008" y="5093208"/>
+            <a:ext cx="2468880" cy="-16722547200"/>
           </a:xfrm>
           <a:prstGeom prst="rect">
             <a:avLst/>
@@ -6158,653 +5782,27 @@
           <a:p>
             <a:pPr algn="l"/>
             <a:r>
-              <a:rPr sz="1300" b="1">
-                <a:solidFill>
-                  <a:srgbClr val="A78BFA"/>
+              <a:rPr sz="1000" b="0">
+                <a:solidFill>
+                  <a:srgbClr val="94A3B8"/>
                 </a:solidFill>
                 <a:latin typeface="Calibri"/>
               </a:rPr>
-              <a:t>Landing Edge</a:t>
-            </a:r>
-          </a:p>
-        </p:txBody>
-      </p:sp>
-      <p:sp>
-        <p:nvSpPr>
-          <p:cNvPr id="81" name="TextBox 80"/>
-          <p:cNvSpPr txBox="1"/>
-          <p:nvPr/>
-        </p:nvSpPr>
-        <p:spPr>
-          <a:xfrm>
-            <a:off x="9619488" y="1325880"/>
-            <a:ext cx="2157984" cy="411480"/>
-          </a:xfrm>
-          <a:prstGeom prst="rect">
-            <a:avLst/>
-          </a:prstGeom>
-          <a:noFill/>
-        </p:spPr>
-        <p:txBody>
-          <a:bodyPr wrap="square">
-            <a:spAutoFit/>
-          </a:bodyPr>
-          <a:lstStyle/>
-          <a:p>
-            <a:pPr algn="l"/>
-            <a:r>
-              <a:rPr sz="1100" b="0">
-                <a:solidFill>
-                  <a:srgbClr val="94A3B8"/>
-                </a:solidFill>
-                <a:latin typeface="Calibri"/>
-              </a:rPr>
-              <a:t>Downstream results
-&amp; client callbacks</a:t>
-            </a:r>
-          </a:p>
-        </p:txBody>
-      </p:sp>
-      <p:sp>
-        <p:nvSpPr>
-          <p:cNvPr id="82" name="Rounded Rectangle 81"/>
+              <a:t>Push · SMS</a:t>
+            </a:r>
+          </a:p>
+        </p:txBody>
+      </p:sp>
+      <p:sp>
+        <p:nvSpPr>
+          <p:cNvPr id="71" name="Right Arrow 70"/>
           <p:cNvSpPr/>
           <p:nvPr/>
         </p:nvSpPr>
         <p:spPr>
           <a:xfrm>
-            <a:off x="9619488" y="1874519"/>
-            <a:ext cx="2157984" cy="777240"/>
-          </a:xfrm>
-          <a:prstGeom prst="roundRect">
-            <a:avLst>
-              <a:gd name="adj" fmla="val 10000"/>
-            </a:avLst>
-          </a:prstGeom>
-          <a:solidFill>
-            <a:srgbClr val="0E2A4A"/>
-          </a:solidFill>
-          <a:ln w="15875">
-            <a:solidFill>
-              <a:srgbClr val="A78BFA"/>
-            </a:solidFill>
-          </a:ln>
-        </p:spPr>
-        <p:style>
-          <a:lnRef idx="1">
-            <a:schemeClr val="accent1"/>
-          </a:lnRef>
-          <a:fillRef idx="3">
-            <a:schemeClr val="accent1"/>
-          </a:fillRef>
-          <a:effectRef idx="2">
-            <a:schemeClr val="accent1"/>
-          </a:effectRef>
-          <a:fontRef idx="minor">
-            <a:schemeClr val="lt1"/>
-          </a:fontRef>
-        </p:style>
-        <p:txBody>
-          <a:bodyPr rtlCol="0" anchor="ctr"/>
-          <a:lstStyle/>
-          <a:p>
-            <a:pPr algn="ctr"/>
-          </a:p>
-        </p:txBody>
-      </p:sp>
-      <p:sp>
-        <p:nvSpPr>
-          <p:cNvPr id="83" name="TextBox 82"/>
-          <p:cNvSpPr txBox="1"/>
-          <p:nvPr/>
-        </p:nvSpPr>
-        <p:spPr>
-          <a:xfrm>
-            <a:off x="9729216" y="1984247"/>
-            <a:ext cx="1975104" cy="292608"/>
-          </a:xfrm>
-          <a:prstGeom prst="rect">
-            <a:avLst/>
-          </a:prstGeom>
-          <a:noFill/>
-        </p:spPr>
-        <p:txBody>
-          <a:bodyPr wrap="square">
-            <a:spAutoFit/>
-          </a:bodyPr>
-          <a:lstStyle/>
-          <a:p>
-            <a:pPr algn="l"/>
-            <a:r>
-              <a:rPr sz="1300" b="1">
-                <a:solidFill>
-                  <a:srgbClr val="F1F5F9"/>
-                </a:solidFill>
-                <a:latin typeface="Calibri"/>
-              </a:rPr>
-              <a:t>E-coupon System</a:t>
-            </a:r>
-          </a:p>
-        </p:txBody>
-      </p:sp>
-      <p:sp>
-        <p:nvSpPr>
-          <p:cNvPr id="84" name="TextBox 83"/>
-          <p:cNvSpPr txBox="1"/>
-          <p:nvPr/>
-        </p:nvSpPr>
-        <p:spPr>
-          <a:xfrm>
-            <a:off x="9729216" y="2258567"/>
-            <a:ext cx="1975104" cy="365760"/>
-          </a:xfrm>
-          <a:prstGeom prst="rect">
-            <a:avLst/>
-          </a:prstGeom>
-          <a:noFill/>
-        </p:spPr>
-        <p:txBody>
-          <a:bodyPr wrap="square">
-            <a:spAutoFit/>
-          </a:bodyPr>
-          <a:lstStyle/>
-          <a:p>
-            <a:pPr algn="l"/>
-            <a:r>
-              <a:rPr sz="1000" b="0">
-                <a:solidFill>
-                  <a:srgbClr val="94A3B8"/>
-                </a:solidFill>
-                <a:latin typeface="Calibri"/>
-              </a:rPr>
-              <a:t>Issue / redeem hooks</a:t>
-            </a:r>
-          </a:p>
-        </p:txBody>
-      </p:sp>
-      <p:sp>
-        <p:nvSpPr>
-          <p:cNvPr id="85" name="Rounded Rectangle 84"/>
-          <p:cNvSpPr/>
-          <p:nvPr/>
-        </p:nvSpPr>
-        <p:spPr>
-          <a:xfrm>
-            <a:off x="9619488" y="2743199"/>
-            <a:ext cx="2157984" cy="777240"/>
-          </a:xfrm>
-          <a:prstGeom prst="roundRect">
-            <a:avLst>
-              <a:gd name="adj" fmla="val 10000"/>
-            </a:avLst>
-          </a:prstGeom>
-          <a:solidFill>
-            <a:srgbClr val="0E2A4A"/>
-          </a:solidFill>
-          <a:ln w="15875">
-            <a:solidFill>
-              <a:srgbClr val="A78BFA"/>
-            </a:solidFill>
-          </a:ln>
-        </p:spPr>
-        <p:style>
-          <a:lnRef idx="1">
-            <a:schemeClr val="accent1"/>
-          </a:lnRef>
-          <a:fillRef idx="3">
-            <a:schemeClr val="accent1"/>
-          </a:fillRef>
-          <a:effectRef idx="2">
-            <a:schemeClr val="accent1"/>
-          </a:effectRef>
-          <a:fontRef idx="minor">
-            <a:schemeClr val="lt1"/>
-          </a:fontRef>
-        </p:style>
-        <p:txBody>
-          <a:bodyPr rtlCol="0" anchor="ctr"/>
-          <a:lstStyle/>
-          <a:p>
-            <a:pPr algn="ctr"/>
-          </a:p>
-        </p:txBody>
-      </p:sp>
-      <p:sp>
-        <p:nvSpPr>
-          <p:cNvPr id="86" name="TextBox 85"/>
-          <p:cNvSpPr txBox="1"/>
-          <p:nvPr/>
-        </p:nvSpPr>
-        <p:spPr>
-          <a:xfrm>
-            <a:off x="9729216" y="2852927"/>
-            <a:ext cx="1975104" cy="292608"/>
-          </a:xfrm>
-          <a:prstGeom prst="rect">
-            <a:avLst/>
-          </a:prstGeom>
-          <a:noFill/>
-        </p:spPr>
-        <p:txBody>
-          <a:bodyPr wrap="square">
-            <a:spAutoFit/>
-          </a:bodyPr>
-          <a:lstStyle/>
-          <a:p>
-            <a:pPr algn="l"/>
-            <a:r>
-              <a:rPr sz="1300" b="1">
-                <a:solidFill>
-                  <a:srgbClr val="F1F5F9"/>
-                </a:solidFill>
-                <a:latin typeface="Calibri"/>
-              </a:rPr>
-              <a:t>Gift System</a:t>
-            </a:r>
-          </a:p>
-        </p:txBody>
-      </p:sp>
-      <p:sp>
-        <p:nvSpPr>
-          <p:cNvPr id="87" name="TextBox 86"/>
-          <p:cNvSpPr txBox="1"/>
-          <p:nvPr/>
-        </p:nvSpPr>
-        <p:spPr>
-          <a:xfrm>
-            <a:off x="9729216" y="3127247"/>
-            <a:ext cx="1975104" cy="365760"/>
-          </a:xfrm>
-          <a:prstGeom prst="rect">
-            <a:avLst/>
-          </a:prstGeom>
-          <a:noFill/>
-        </p:spPr>
-        <p:txBody>
-          <a:bodyPr wrap="square">
-            <a:spAutoFit/>
-          </a:bodyPr>
-          <a:lstStyle/>
-          <a:p>
-            <a:pPr algn="l"/>
-            <a:r>
-              <a:rPr sz="1000" b="0">
-                <a:solidFill>
-                  <a:srgbClr val="94A3B8"/>
-                </a:solidFill>
-                <a:latin typeface="Calibri"/>
-              </a:rPr>
-              <a:t>Fulfillment triggers</a:t>
-            </a:r>
-          </a:p>
-        </p:txBody>
-      </p:sp>
-      <p:sp>
-        <p:nvSpPr>
-          <p:cNvPr id="88" name="Rounded Rectangle 87"/>
-          <p:cNvSpPr/>
-          <p:nvPr/>
-        </p:nvSpPr>
-        <p:spPr>
-          <a:xfrm>
-            <a:off x="9619488" y="3611879"/>
-            <a:ext cx="2157984" cy="777240"/>
-          </a:xfrm>
-          <a:prstGeom prst="roundRect">
-            <a:avLst>
-              <a:gd name="adj" fmla="val 10000"/>
-            </a:avLst>
-          </a:prstGeom>
-          <a:solidFill>
-            <a:srgbClr val="0E2A4A"/>
-          </a:solidFill>
-          <a:ln w="15875">
-            <a:solidFill>
-              <a:srgbClr val="A78BFA"/>
-            </a:solidFill>
-          </a:ln>
-        </p:spPr>
-        <p:style>
-          <a:lnRef idx="1">
-            <a:schemeClr val="accent1"/>
-          </a:lnRef>
-          <a:fillRef idx="3">
-            <a:schemeClr val="accent1"/>
-          </a:fillRef>
-          <a:effectRef idx="2">
-            <a:schemeClr val="accent1"/>
-          </a:effectRef>
-          <a:fontRef idx="minor">
-            <a:schemeClr val="lt1"/>
-          </a:fontRef>
-        </p:style>
-        <p:txBody>
-          <a:bodyPr rtlCol="0" anchor="ctr"/>
-          <a:lstStyle/>
-          <a:p>
-            <a:pPr algn="ctr"/>
-          </a:p>
-        </p:txBody>
-      </p:sp>
-      <p:sp>
-        <p:nvSpPr>
-          <p:cNvPr id="89" name="TextBox 88"/>
-          <p:cNvSpPr txBox="1"/>
-          <p:nvPr/>
-        </p:nvSpPr>
-        <p:spPr>
-          <a:xfrm>
-            <a:off x="9729216" y="3721607"/>
-            <a:ext cx="1975104" cy="292608"/>
-          </a:xfrm>
-          <a:prstGeom prst="rect">
-            <a:avLst/>
-          </a:prstGeom>
-          <a:noFill/>
-        </p:spPr>
-        <p:txBody>
-          <a:bodyPr wrap="square">
-            <a:spAutoFit/>
-          </a:bodyPr>
-          <a:lstStyle/>
-          <a:p>
-            <a:pPr algn="l"/>
-            <a:r>
-              <a:rPr sz="1300" b="1">
-                <a:solidFill>
-                  <a:srgbClr val="F1F5F9"/>
-                </a:solidFill>
-                <a:latin typeface="Calibri"/>
-              </a:rPr>
-              <a:t>Notification</a:t>
-            </a:r>
-          </a:p>
-        </p:txBody>
-      </p:sp>
-      <p:sp>
-        <p:nvSpPr>
-          <p:cNvPr id="90" name="TextBox 89"/>
-          <p:cNvSpPr txBox="1"/>
-          <p:nvPr/>
-        </p:nvSpPr>
-        <p:spPr>
-          <a:xfrm>
-            <a:off x="9729216" y="3995927"/>
-            <a:ext cx="1975104" cy="365760"/>
-          </a:xfrm>
-          <a:prstGeom prst="rect">
-            <a:avLst/>
-          </a:prstGeom>
-          <a:noFill/>
-        </p:spPr>
-        <p:txBody>
-          <a:bodyPr wrap="square">
-            <a:spAutoFit/>
-          </a:bodyPr>
-          <a:lstStyle/>
-          <a:p>
-            <a:pPr algn="l"/>
-            <a:r>
-              <a:rPr sz="1000" b="0">
-                <a:solidFill>
-                  <a:srgbClr val="94A3B8"/>
-                </a:solidFill>
-                <a:latin typeface="Calibri"/>
-              </a:rPr>
-              <a:t>Push · SMS · inbox</a:t>
-            </a:r>
-          </a:p>
-        </p:txBody>
-      </p:sp>
-      <p:sp>
-        <p:nvSpPr>
-          <p:cNvPr id="91" name="Rounded Rectangle 90"/>
-          <p:cNvSpPr/>
-          <p:nvPr/>
-        </p:nvSpPr>
-        <p:spPr>
-          <a:xfrm>
-            <a:off x="9619488" y="4480558"/>
-            <a:ext cx="2157984" cy="777240"/>
-          </a:xfrm>
-          <a:prstGeom prst="roundRect">
-            <a:avLst>
-              <a:gd name="adj" fmla="val 10000"/>
-            </a:avLst>
-          </a:prstGeom>
-          <a:solidFill>
-            <a:srgbClr val="0E2A4A"/>
-          </a:solidFill>
-          <a:ln w="15875">
-            <a:solidFill>
-              <a:srgbClr val="A78BFA"/>
-            </a:solidFill>
-          </a:ln>
-        </p:spPr>
-        <p:style>
-          <a:lnRef idx="1">
-            <a:schemeClr val="accent1"/>
-          </a:lnRef>
-          <a:fillRef idx="3">
-            <a:schemeClr val="accent1"/>
-          </a:fillRef>
-          <a:effectRef idx="2">
-            <a:schemeClr val="accent1"/>
-          </a:effectRef>
-          <a:fontRef idx="minor">
-            <a:schemeClr val="lt1"/>
-          </a:fontRef>
-        </p:style>
-        <p:txBody>
-          <a:bodyPr rtlCol="0" anchor="ctr"/>
-          <a:lstStyle/>
-          <a:p>
-            <a:pPr algn="ctr"/>
-          </a:p>
-        </p:txBody>
-      </p:sp>
-      <p:sp>
-        <p:nvSpPr>
-          <p:cNvPr id="92" name="TextBox 91"/>
-          <p:cNvSpPr txBox="1"/>
-          <p:nvPr/>
-        </p:nvSpPr>
-        <p:spPr>
-          <a:xfrm>
-            <a:off x="9729216" y="4590286"/>
-            <a:ext cx="1975104" cy="292608"/>
-          </a:xfrm>
-          <a:prstGeom prst="rect">
-            <a:avLst/>
-          </a:prstGeom>
-          <a:noFill/>
-        </p:spPr>
-        <p:txBody>
-          <a:bodyPr wrap="square">
-            <a:spAutoFit/>
-          </a:bodyPr>
-          <a:lstStyle/>
-          <a:p>
-            <a:pPr algn="l"/>
-            <a:r>
-              <a:rPr sz="1300" b="1">
-                <a:solidFill>
-                  <a:srgbClr val="F1F5F9"/>
-                </a:solidFill>
-                <a:latin typeface="Calibri"/>
-              </a:rPr>
-              <a:t>Client core / xapi</a:t>
-            </a:r>
-          </a:p>
-        </p:txBody>
-      </p:sp>
-      <p:sp>
-        <p:nvSpPr>
-          <p:cNvPr id="93" name="TextBox 92"/>
-          <p:cNvSpPr txBox="1"/>
-          <p:nvPr/>
-        </p:nvSpPr>
-        <p:spPr>
-          <a:xfrm>
-            <a:off x="9729216" y="4864606"/>
-            <a:ext cx="1975104" cy="365760"/>
-          </a:xfrm>
-          <a:prstGeom prst="rect">
-            <a:avLst/>
-          </a:prstGeom>
-          <a:noFill/>
-        </p:spPr>
-        <p:txBody>
-          <a:bodyPr wrap="square">
-            <a:spAutoFit/>
-          </a:bodyPr>
-          <a:lstStyle/>
-          <a:p>
-            <a:pPr algn="l"/>
-            <a:r>
-              <a:rPr sz="1000" b="0">
-                <a:solidFill>
-                  <a:srgbClr val="94A3B8"/>
-                </a:solidFill>
-                <a:latin typeface="Calibri"/>
-              </a:rPr>
-              <a:t>Balances · CRM sync</a:t>
-            </a:r>
-          </a:p>
-        </p:txBody>
-      </p:sp>
-      <p:sp>
-        <p:nvSpPr>
-          <p:cNvPr id="94" name="TextBox 93"/>
-          <p:cNvSpPr txBox="1"/>
-          <p:nvPr/>
-        </p:nvSpPr>
-        <p:spPr>
-          <a:xfrm>
-            <a:off x="9619488" y="5486400"/>
-            <a:ext cx="2157984" cy="411480"/>
-          </a:xfrm>
-          <a:prstGeom prst="rect">
-            <a:avLst/>
-          </a:prstGeom>
-          <a:noFill/>
-        </p:spPr>
-        <p:txBody>
-          <a:bodyPr wrap="square">
-            <a:spAutoFit/>
-          </a:bodyPr>
-          <a:lstStyle/>
-          <a:p>
-            <a:pPr algn="l"/>
-            <a:r>
-              <a:rPr sz="1000" b="0">
-                <a:solidFill>
-                  <a:srgbClr val="94A3B8"/>
-                </a:solidFill>
-                <a:latin typeface="Calibri"/>
-              </a:rPr>
-              <a:t>Kafka / webhooks out
-ledger.balance.updated</a:t>
-            </a:r>
-          </a:p>
-        </p:txBody>
-      </p:sp>
-      <p:sp>
-        <p:nvSpPr>
-          <p:cNvPr id="95" name="Right Arrow 94"/>
-          <p:cNvSpPr/>
-          <p:nvPr/>
-        </p:nvSpPr>
-        <p:spPr>
-          <a:xfrm>
-            <a:off x="2194560" y="2286000"/>
-            <a:ext cx="237744" cy="182880"/>
-          </a:xfrm>
-          <a:prstGeom prst="rightArrow">
-            <a:avLst/>
-          </a:prstGeom>
-          <a:solidFill>
-            <a:srgbClr val="22D3EE"/>
-          </a:solidFill>
-          <a:ln>
-            <a:noFill/>
-          </a:ln>
-        </p:spPr>
-        <p:style>
-          <a:lnRef idx="1">
-            <a:schemeClr val="accent1"/>
-          </a:lnRef>
-          <a:fillRef idx="3">
-            <a:schemeClr val="accent1"/>
-          </a:fillRef>
-          <a:effectRef idx="2">
-            <a:schemeClr val="accent1"/>
-          </a:effectRef>
-          <a:fontRef idx="minor">
-            <a:schemeClr val="lt1"/>
-          </a:fontRef>
-        </p:style>
-        <p:txBody>
-          <a:bodyPr rtlCol="0" anchor="ctr"/>
-          <a:lstStyle/>
-          <a:p>
-            <a:pPr algn="ctr"/>
-          </a:p>
-        </p:txBody>
-      </p:sp>
-      <p:sp>
-        <p:nvSpPr>
-          <p:cNvPr id="96" name="Right Arrow 95"/>
-          <p:cNvSpPr/>
-          <p:nvPr/>
-        </p:nvSpPr>
-        <p:spPr>
-          <a:xfrm>
-            <a:off x="4343400" y="2286000"/>
-            <a:ext cx="237744" cy="182880"/>
-          </a:xfrm>
-          <a:prstGeom prst="rightArrow">
-            <a:avLst/>
-          </a:prstGeom>
-          <a:solidFill>
-            <a:srgbClr val="FB923C"/>
-          </a:solidFill>
-          <a:ln>
-            <a:noFill/>
-          </a:ln>
-        </p:spPr>
-        <p:style>
-          <a:lnRef idx="1">
-            <a:schemeClr val="accent1"/>
-          </a:lnRef>
-          <a:fillRef idx="3">
-            <a:schemeClr val="accent1"/>
-          </a:fillRef>
-          <a:effectRef idx="2">
-            <a:schemeClr val="accent1"/>
-          </a:effectRef>
-          <a:fontRef idx="minor">
-            <a:schemeClr val="lt1"/>
-          </a:fontRef>
-        </p:style>
-        <p:txBody>
-          <a:bodyPr rtlCol="0" anchor="ctr"/>
-          <a:lstStyle/>
-          <a:p>
-            <a:pPr algn="ctr"/>
-          </a:p>
-        </p:txBody>
-      </p:sp>
-      <p:sp>
-        <p:nvSpPr>
-          <p:cNvPr id="97" name="Right Arrow 96"/>
-          <p:cNvSpPr/>
-          <p:nvPr/>
-        </p:nvSpPr>
-        <p:spPr>
-          <a:xfrm>
-            <a:off x="7772400" y="2286000"/>
-            <a:ext cx="237744" cy="182880"/>
+            <a:off x="8732520" y="4114800"/>
+            <a:ext cx="256032" cy="201168"/>
           </a:xfrm>
           <a:prstGeom prst="rightArrow">
             <a:avLst/>
@@ -6840,23 +5838,62 @@
       </p:sp>
       <p:sp>
         <p:nvSpPr>
-          <p:cNvPr id="98" name="Right Arrow 97"/>
+          <p:cNvPr id="72" name="TextBox 71"/>
+          <p:cNvSpPr txBox="1"/>
+          <p:nvPr/>
+        </p:nvSpPr>
+        <p:spPr>
+          <a:xfrm>
+            <a:off x="320040" y="5349240"/>
+            <a:ext cx="2743200" cy="228600"/>
+          </a:xfrm>
+          <a:prstGeom prst="rect">
+            <a:avLst/>
+          </a:prstGeom>
+          <a:noFill/>
+        </p:spPr>
+        <p:txBody>
+          <a:bodyPr wrap="square">
+            <a:spAutoFit/>
+          </a:bodyPr>
+          <a:lstStyle/>
+          <a:p>
+            <a:pPr algn="l"/>
+            <a:r>
+              <a:rPr sz="1100" b="1">
+                <a:solidFill>
+                  <a:srgbClr val="94A3B8"/>
+                </a:solidFill>
+                <a:latin typeface="Calibri"/>
+              </a:rPr>
+              <a:t>Configuration (ops)</a:t>
+            </a:r>
+          </a:p>
+        </p:txBody>
+      </p:sp>
+      <p:sp>
+        <p:nvSpPr>
+          <p:cNvPr id="73" name="Rounded Rectangle 72"/>
           <p:cNvSpPr/>
           <p:nvPr/>
         </p:nvSpPr>
         <p:spPr>
           <a:xfrm>
-            <a:off x="9326880" y="2286000"/>
-            <a:ext cx="237744" cy="182880"/>
-          </a:xfrm>
-          <a:prstGeom prst="rightArrow">
-            <a:avLst/>
+            <a:off x="274320" y="5577840"/>
+            <a:ext cx="8412480" cy="502920"/>
+          </a:xfrm>
+          <a:prstGeom prst="roundRect">
+            <a:avLst>
+              <a:gd name="adj" fmla="val 12000"/>
+            </a:avLst>
           </a:prstGeom>
           <a:solidFill>
-            <a:srgbClr val="2DD4BF"/>
+            <a:srgbClr val="0C2340"/>
           </a:solidFill>
-          <a:ln>
-            <a:noFill/>
+          <a:ln w="15875">
+            <a:solidFill>
+              <a:srgbClr val="14B8A6"/>
+            </a:solidFill>
           </a:ln>
         </p:spPr>
         <p:style>
@@ -6883,23 +5920,62 @@
       </p:sp>
       <p:sp>
         <p:nvSpPr>
-          <p:cNvPr id="99" name="Right Arrow 98"/>
+          <p:cNvPr id="74" name="TextBox 73"/>
+          <p:cNvSpPr txBox="1"/>
+          <p:nvPr/>
+        </p:nvSpPr>
+        <p:spPr>
+          <a:xfrm>
+            <a:off x="411480" y="5669280"/>
+            <a:ext cx="8138160" cy="365760"/>
+          </a:xfrm>
+          <a:prstGeom prst="rect">
+            <a:avLst/>
+          </a:prstGeom>
+          <a:noFill/>
+        </p:spPr>
+        <p:txBody>
+          <a:bodyPr wrap="square">
+            <a:spAutoFit/>
+          </a:bodyPr>
+          <a:lstStyle/>
+          <a:p>
+            <a:pPr algn="l"/>
+            <a:r>
+              <a:rPr sz="1200" b="0">
+                <a:solidFill>
+                  <a:srgbClr val="F1F5F9"/>
+                </a:solidFill>
+                <a:latin typeface="Calibri"/>
+              </a:rPr>
+              <a:t>Configuration rules  ·  Use-case catalog  ·  Account (COA) profiles  ·  Calculation formulas  ·  Door / Brain policies  —  Admin, not upstream code</a:t>
+            </a:r>
+          </a:p>
+        </p:txBody>
+      </p:sp>
+      <p:sp>
+        <p:nvSpPr>
+          <p:cNvPr id="75" name="Rounded Rectangle 74"/>
           <p:cNvSpPr/>
           <p:nvPr/>
         </p:nvSpPr>
         <p:spPr>
           <a:xfrm>
-            <a:off x="2194560" y="3383280"/>
-            <a:ext cx="237744" cy="182880"/>
-          </a:xfrm>
-          <a:prstGeom prst="rightArrow">
-            <a:avLst/>
+            <a:off x="8823960" y="5577840"/>
+            <a:ext cx="3063240" cy="502920"/>
+          </a:xfrm>
+          <a:prstGeom prst="roundRect">
+            <a:avLst>
+              <a:gd name="adj" fmla="val 12000"/>
+            </a:avLst>
           </a:prstGeom>
           <a:solidFill>
-            <a:srgbClr val="22D3EE"/>
+            <a:srgbClr val="0C2340"/>
           </a:solidFill>
-          <a:ln>
-            <a:noFill/>
+          <a:ln w="12700">
+            <a:solidFill>
+              <a:srgbClr val="2DD4BF"/>
+            </a:solidFill>
           </a:ln>
         </p:spPr>
         <p:style>
@@ -6926,362 +6002,14 @@
       </p:sp>
       <p:sp>
         <p:nvSpPr>
-          <p:cNvPr id="100" name="Right Arrow 99"/>
-          <p:cNvSpPr/>
-          <p:nvPr/>
-        </p:nvSpPr>
-        <p:spPr>
-          <a:xfrm>
-            <a:off x="4343400" y="3383280"/>
-            <a:ext cx="237744" cy="182880"/>
-          </a:xfrm>
-          <a:prstGeom prst="rightArrow">
-            <a:avLst/>
-          </a:prstGeom>
-          <a:solidFill>
-            <a:srgbClr val="FB923C"/>
-          </a:solidFill>
-          <a:ln>
-            <a:noFill/>
-          </a:ln>
-        </p:spPr>
-        <p:style>
-          <a:lnRef idx="1">
-            <a:schemeClr val="accent1"/>
-          </a:lnRef>
-          <a:fillRef idx="3">
-            <a:schemeClr val="accent1"/>
-          </a:fillRef>
-          <a:effectRef idx="2">
-            <a:schemeClr val="accent1"/>
-          </a:effectRef>
-          <a:fontRef idx="minor">
-            <a:schemeClr val="lt1"/>
-          </a:fontRef>
-        </p:style>
-        <p:txBody>
-          <a:bodyPr rtlCol="0" anchor="ctr"/>
-          <a:lstStyle/>
-          <a:p>
-            <a:pPr algn="ctr"/>
-          </a:p>
-        </p:txBody>
-      </p:sp>
-      <p:sp>
-        <p:nvSpPr>
-          <p:cNvPr id="101" name="Right Arrow 100"/>
-          <p:cNvSpPr/>
-          <p:nvPr/>
-        </p:nvSpPr>
-        <p:spPr>
-          <a:xfrm>
-            <a:off x="7772400" y="3383280"/>
-            <a:ext cx="237744" cy="182880"/>
-          </a:xfrm>
-          <a:prstGeom prst="rightArrow">
-            <a:avLst/>
-          </a:prstGeom>
-          <a:solidFill>
-            <a:srgbClr val="2DD4BF"/>
-          </a:solidFill>
-          <a:ln>
-            <a:noFill/>
-          </a:ln>
-        </p:spPr>
-        <p:style>
-          <a:lnRef idx="1">
-            <a:schemeClr val="accent1"/>
-          </a:lnRef>
-          <a:fillRef idx="3">
-            <a:schemeClr val="accent1"/>
-          </a:fillRef>
-          <a:effectRef idx="2">
-            <a:schemeClr val="accent1"/>
-          </a:effectRef>
-          <a:fontRef idx="minor">
-            <a:schemeClr val="lt1"/>
-          </a:fontRef>
-        </p:style>
-        <p:txBody>
-          <a:bodyPr rtlCol="0" anchor="ctr"/>
-          <a:lstStyle/>
-          <a:p>
-            <a:pPr algn="ctr"/>
-          </a:p>
-        </p:txBody>
-      </p:sp>
-      <p:sp>
-        <p:nvSpPr>
-          <p:cNvPr id="102" name="Right Arrow 101"/>
-          <p:cNvSpPr/>
-          <p:nvPr/>
-        </p:nvSpPr>
-        <p:spPr>
-          <a:xfrm>
-            <a:off x="9326880" y="3383280"/>
-            <a:ext cx="237744" cy="182880"/>
-          </a:xfrm>
-          <a:prstGeom prst="rightArrow">
-            <a:avLst/>
-          </a:prstGeom>
-          <a:solidFill>
-            <a:srgbClr val="2DD4BF"/>
-          </a:solidFill>
-          <a:ln>
-            <a:noFill/>
-          </a:ln>
-        </p:spPr>
-        <p:style>
-          <a:lnRef idx="1">
-            <a:schemeClr val="accent1"/>
-          </a:lnRef>
-          <a:fillRef idx="3">
-            <a:schemeClr val="accent1"/>
-          </a:fillRef>
-          <a:effectRef idx="2">
-            <a:schemeClr val="accent1"/>
-          </a:effectRef>
-          <a:fontRef idx="minor">
-            <a:schemeClr val="lt1"/>
-          </a:fontRef>
-        </p:style>
-        <p:txBody>
-          <a:bodyPr rtlCol="0" anchor="ctr"/>
-          <a:lstStyle/>
-          <a:p>
-            <a:pPr algn="ctr"/>
-          </a:p>
-        </p:txBody>
-      </p:sp>
-      <p:sp>
-        <p:nvSpPr>
-          <p:cNvPr id="103" name="Right Arrow 102"/>
-          <p:cNvSpPr/>
-          <p:nvPr/>
-        </p:nvSpPr>
-        <p:spPr>
-          <a:xfrm>
-            <a:off x="2194560" y="4480560"/>
-            <a:ext cx="237744" cy="182880"/>
-          </a:xfrm>
-          <a:prstGeom prst="rightArrow">
-            <a:avLst/>
-          </a:prstGeom>
-          <a:solidFill>
-            <a:srgbClr val="22D3EE"/>
-          </a:solidFill>
-          <a:ln>
-            <a:noFill/>
-          </a:ln>
-        </p:spPr>
-        <p:style>
-          <a:lnRef idx="1">
-            <a:schemeClr val="accent1"/>
-          </a:lnRef>
-          <a:fillRef idx="3">
-            <a:schemeClr val="accent1"/>
-          </a:fillRef>
-          <a:effectRef idx="2">
-            <a:schemeClr val="accent1"/>
-          </a:effectRef>
-          <a:fontRef idx="minor">
-            <a:schemeClr val="lt1"/>
-          </a:fontRef>
-        </p:style>
-        <p:txBody>
-          <a:bodyPr rtlCol="0" anchor="ctr"/>
-          <a:lstStyle/>
-          <a:p>
-            <a:pPr algn="ctr"/>
-          </a:p>
-        </p:txBody>
-      </p:sp>
-      <p:sp>
-        <p:nvSpPr>
-          <p:cNvPr id="104" name="Right Arrow 103"/>
-          <p:cNvSpPr/>
-          <p:nvPr/>
-        </p:nvSpPr>
-        <p:spPr>
-          <a:xfrm>
-            <a:off x="4343400" y="4480560"/>
-            <a:ext cx="237744" cy="182880"/>
-          </a:xfrm>
-          <a:prstGeom prst="rightArrow">
-            <a:avLst/>
-          </a:prstGeom>
-          <a:solidFill>
-            <a:srgbClr val="FB923C"/>
-          </a:solidFill>
-          <a:ln>
-            <a:noFill/>
-          </a:ln>
-        </p:spPr>
-        <p:style>
-          <a:lnRef idx="1">
-            <a:schemeClr val="accent1"/>
-          </a:lnRef>
-          <a:fillRef idx="3">
-            <a:schemeClr val="accent1"/>
-          </a:fillRef>
-          <a:effectRef idx="2">
-            <a:schemeClr val="accent1"/>
-          </a:effectRef>
-          <a:fontRef idx="minor">
-            <a:schemeClr val="lt1"/>
-          </a:fontRef>
-        </p:style>
-        <p:txBody>
-          <a:bodyPr rtlCol="0" anchor="ctr"/>
-          <a:lstStyle/>
-          <a:p>
-            <a:pPr algn="ctr"/>
-          </a:p>
-        </p:txBody>
-      </p:sp>
-      <p:sp>
-        <p:nvSpPr>
-          <p:cNvPr id="105" name="Right Arrow 104"/>
-          <p:cNvSpPr/>
-          <p:nvPr/>
-        </p:nvSpPr>
-        <p:spPr>
-          <a:xfrm>
-            <a:off x="7772400" y="4480560"/>
-            <a:ext cx="237744" cy="182880"/>
-          </a:xfrm>
-          <a:prstGeom prst="rightArrow">
-            <a:avLst/>
-          </a:prstGeom>
-          <a:solidFill>
-            <a:srgbClr val="2DD4BF"/>
-          </a:solidFill>
-          <a:ln>
-            <a:noFill/>
-          </a:ln>
-        </p:spPr>
-        <p:style>
-          <a:lnRef idx="1">
-            <a:schemeClr val="accent1"/>
-          </a:lnRef>
-          <a:fillRef idx="3">
-            <a:schemeClr val="accent1"/>
-          </a:fillRef>
-          <a:effectRef idx="2">
-            <a:schemeClr val="accent1"/>
-          </a:effectRef>
-          <a:fontRef idx="minor">
-            <a:schemeClr val="lt1"/>
-          </a:fontRef>
-        </p:style>
-        <p:txBody>
-          <a:bodyPr rtlCol="0" anchor="ctr"/>
-          <a:lstStyle/>
-          <a:p>
-            <a:pPr algn="ctr"/>
-          </a:p>
-        </p:txBody>
-      </p:sp>
-      <p:sp>
-        <p:nvSpPr>
-          <p:cNvPr id="106" name="Right Arrow 105"/>
-          <p:cNvSpPr/>
-          <p:nvPr/>
-        </p:nvSpPr>
-        <p:spPr>
-          <a:xfrm>
-            <a:off x="9326880" y="4480560"/>
-            <a:ext cx="237744" cy="182880"/>
-          </a:xfrm>
-          <a:prstGeom prst="rightArrow">
-            <a:avLst/>
-          </a:prstGeom>
-          <a:solidFill>
-            <a:srgbClr val="2DD4BF"/>
-          </a:solidFill>
-          <a:ln>
-            <a:noFill/>
-          </a:ln>
-        </p:spPr>
-        <p:style>
-          <a:lnRef idx="1">
-            <a:schemeClr val="accent1"/>
-          </a:lnRef>
-          <a:fillRef idx="3">
-            <a:schemeClr val="accent1"/>
-          </a:fillRef>
-          <a:effectRef idx="2">
-            <a:schemeClr val="accent1"/>
-          </a:effectRef>
-          <a:fontRef idx="minor">
-            <a:schemeClr val="lt1"/>
-          </a:fontRef>
-        </p:style>
-        <p:txBody>
-          <a:bodyPr rtlCol="0" anchor="ctr"/>
-          <a:lstStyle/>
-          <a:p>
-            <a:pPr algn="ctr"/>
-          </a:p>
-        </p:txBody>
-      </p:sp>
-      <p:sp>
-        <p:nvSpPr>
-          <p:cNvPr id="107" name="Rounded Rectangle 106"/>
-          <p:cNvSpPr/>
-          <p:nvPr/>
-        </p:nvSpPr>
-        <p:spPr>
-          <a:xfrm>
-            <a:off x="274320" y="6263640"/>
-            <a:ext cx="11612880" cy="411480"/>
-          </a:xfrm>
-          <a:prstGeom prst="roundRect">
-            <a:avLst>
-              <a:gd name="adj" fmla="val 10000"/>
-            </a:avLst>
-          </a:prstGeom>
-          <a:solidFill>
-            <a:srgbClr val="0C2340"/>
-          </a:solidFill>
-          <a:ln w="12700">
-            <a:solidFill>
-              <a:srgbClr val="14B8A6"/>
-            </a:solidFill>
-          </a:ln>
-        </p:spPr>
-        <p:style>
-          <a:lnRef idx="1">
-            <a:schemeClr val="accent1"/>
-          </a:lnRef>
-          <a:fillRef idx="3">
-            <a:schemeClr val="accent1"/>
-          </a:fillRef>
-          <a:effectRef idx="2">
-            <a:schemeClr val="accent1"/>
-          </a:effectRef>
-          <a:fontRef idx="minor">
-            <a:schemeClr val="lt1"/>
-          </a:fontRef>
-        </p:style>
-        <p:txBody>
-          <a:bodyPr rtlCol="0" anchor="ctr"/>
-          <a:lstStyle/>
-          <a:p>
-            <a:pPr algn="ctr"/>
-          </a:p>
-        </p:txBody>
-      </p:sp>
-      <p:sp>
-        <p:nvSpPr>
-          <p:cNvPr id="108" name="TextBox 107"/>
+          <p:cNvPr id="76" name="TextBox 75"/>
           <p:cNvSpPr txBox="1"/>
           <p:nvPr/>
         </p:nvSpPr>
         <p:spPr>
           <a:xfrm>
-            <a:off x="411480" y="6327648"/>
-            <a:ext cx="8229600" cy="292608"/>
+            <a:off x="8915400" y="5669280"/>
+            <a:ext cx="2880360" cy="365760"/>
           </a:xfrm>
           <a:prstGeom prst="rect">
             <a:avLst/>
@@ -7294,50 +6022,15 @@
           </a:bodyPr>
           <a:lstStyle/>
           <a:p>
-            <a:pPr algn="l"/>
-            <a:r>
-              <a:rPr sz="1200" b="0">
-                <a:solidFill>
-                  <a:srgbClr val="F1F5F9"/>
+            <a:pPr algn="ctr"/>
+            <a:r>
+              <a:rPr sz="1200" b="1">
+                <a:solidFill>
+                  <a:srgbClr val="2DD4BF"/>
                 </a:solidFill>
                 <a:latin typeface="Calibri"/>
               </a:rPr>
-              <a:t>LedgeRX  =  powerful single product engine   ·   multi-channel via SDK   ·   ops-configured catalog   ·   outbound landing</a:t>
-            </a:r>
-          </a:p>
-        </p:txBody>
-      </p:sp>
-      <p:sp>
-        <p:nvSpPr>
-          <p:cNvPr id="109" name="TextBox 108"/>
-          <p:cNvSpPr txBox="1"/>
-          <p:nvPr/>
-        </p:nvSpPr>
-        <p:spPr>
-          <a:xfrm>
-            <a:off x="9326880" y="6327648"/>
-            <a:ext cx="2377440" cy="292608"/>
-          </a:xfrm>
-          <a:prstGeom prst="rect">
-            <a:avLst/>
-          </a:prstGeom>
-          <a:noFill/>
-        </p:spPr>
-        <p:txBody>
-          <a:bodyPr wrap="square">
-            <a:spAutoFit/>
-          </a:bodyPr>
-          <a:lstStyle/>
-          <a:p>
-            <a:pPr algn="r"/>
-            <a:r>
-              <a:rPr sz="1200" b="1">
-                <a:solidFill>
-                  <a:srgbClr val="2DD4BF"/>
-                </a:solidFill>
-                <a:latin typeface="Calibri"/>
-              </a:rPr>
-              <a:t>1 / 1</a:t>
+              <a:t>1 product  ·  multi-channel  ·  1 / 1</a:t>
             </a:r>
           </a:p>
         </p:txBody>

</xml_diff>

<commit_message>
docs(decks): fix architecture slide column balance (走位)
</commit_message>
<xml_diff>
--- a/docs/decks/LedgeRX-System-Architecture-CTO.pptx
+++ b/docs/decks/LedgeRX-System-Architecture-CTO.pptx
@@ -3140,7 +3140,7 @@
         <p:spPr>
           <a:xfrm>
             <a:off x="0" y="0"/>
-            <a:ext cx="12191695" cy="54864"/>
+            <a:ext cx="12191695" cy="45720"/>
           </a:xfrm>
           <a:prstGeom prst="rect">
             <a:avLst/>
@@ -3182,8 +3182,8 @@
         </p:nvSpPr>
         <p:spPr>
           <a:xfrm>
-            <a:off x="411480" y="182880"/>
-            <a:ext cx="7772400" cy="329184"/>
+            <a:off x="365760" y="164592"/>
+            <a:ext cx="8229600" cy="310896"/>
           </a:xfrm>
           <a:prstGeom prst="rect">
             <a:avLst/>
@@ -3191,12 +3191,14 @@
           <a:noFill/>
         </p:spPr>
         <p:txBody>
-          <a:bodyPr wrap="square"/>
+          <a:bodyPr wrap="square">
+            <a:spAutoFit/>
+          </a:bodyPr>
           <a:lstStyle/>
           <a:p>
             <a:pPr algn="l"/>
             <a:r>
-              <a:rPr sz="2600" b="1">
+              <a:rPr sz="2400" b="1">
                 <a:solidFill>
                   <a:srgbClr val="F8FAFC"/>
                 </a:solidFill>
@@ -3215,8 +3217,8 @@
         </p:nvSpPr>
         <p:spPr>
           <a:xfrm>
-            <a:off x="411480" y="502920"/>
-            <a:ext cx="8686800" cy="256032"/>
+            <a:off x="365760" y="457200"/>
+            <a:ext cx="8412480" cy="237744"/>
           </a:xfrm>
           <a:prstGeom prst="rect">
             <a:avLst/>
@@ -3224,7 +3226,9 @@
           <a:noFill/>
         </p:spPr>
         <p:txBody>
-          <a:bodyPr wrap="square"/>
+          <a:bodyPr wrap="square">
+            <a:spAutoFit/>
+          </a:bodyPr>
           <a:lstStyle/>
           <a:p>
             <a:pPr algn="l"/>
@@ -3235,7 +3239,7 @@
                 </a:solidFill>
                 <a:latin typeface="Calibri"/>
               </a:rPr>
-              <a:t>Upstream systems  →  SDK  →  Product engine  →  Landing systems   ·   Add-ons extend the core</a:t>
+              <a:t>Upstream  →  SDK  →  Product engine  →  Landing    ·    Add-ons extend the core</a:t>
             </a:r>
           </a:p>
         </p:txBody>
@@ -3248,12 +3252,12 @@
         </p:nvSpPr>
         <p:spPr>
           <a:xfrm>
-            <a:off x="10195560" y="201168"/>
-            <a:ext cx="1645920" cy="384048"/>
+            <a:off x="10241280" y="182880"/>
+            <a:ext cx="1554480" cy="365760"/>
           </a:xfrm>
           <a:prstGeom prst="roundRect">
             <a:avLst>
-              <a:gd name="adj" fmla="val 8000"/>
+              <a:gd name="adj" fmla="val 15000"/>
             </a:avLst>
           </a:prstGeom>
           <a:solidFill>
@@ -3295,8 +3299,8 @@
         </p:nvSpPr>
         <p:spPr>
           <a:xfrm>
-            <a:off x="10195560" y="256032"/>
-            <a:ext cx="1645920" cy="292608"/>
+            <a:off x="10241280" y="237744"/>
+            <a:ext cx="1554480" cy="274320"/>
           </a:xfrm>
           <a:prstGeom prst="rect">
             <a:avLst/>
@@ -3304,7 +3308,9 @@
           <a:noFill/>
         </p:spPr>
         <p:txBody>
-          <a:bodyPr wrap="square"/>
+          <a:bodyPr wrap="square">
+            <a:spAutoFit/>
+          </a:bodyPr>
           <a:lstStyle/>
           <a:p>
             <a:pPr algn="ctr"/>
@@ -3328,18 +3334,18 @@
         </p:nvSpPr>
         <p:spPr>
           <a:xfrm>
-            <a:off x="320040" y="868680"/>
-            <a:ext cx="1874519" cy="5074920"/>
+            <a:off x="365760" y="822960"/>
+            <a:ext cx="1761082" cy="5120640"/>
           </a:xfrm>
           <a:prstGeom prst="roundRect">
             <a:avLst>
-              <a:gd name="adj" fmla="val 6000"/>
+              <a:gd name="adj" fmla="val 5500"/>
             </a:avLst>
           </a:prstGeom>
           <a:solidFill>
             <a:srgbClr val="0C2340"/>
           </a:solidFill>
-          <a:ln w="17145">
+          <a:ln w="17780">
             <a:solidFill>
               <a:srgbClr val="38BDF8"/>
             </a:solidFill>
@@ -3375,8 +3381,8 @@
         </p:nvSpPr>
         <p:spPr>
           <a:xfrm>
-            <a:off x="429768" y="996696"/>
-            <a:ext cx="256032" cy="256032"/>
+            <a:off x="475488" y="950976"/>
+            <a:ext cx="237744" cy="237744"/>
           </a:xfrm>
           <a:prstGeom prst="ellipse">
             <a:avLst/>
@@ -3418,8 +3424,8 @@
         </p:nvSpPr>
         <p:spPr>
           <a:xfrm>
-            <a:off x="429768" y="1014984"/>
-            <a:ext cx="256032" cy="237744"/>
+            <a:off x="475488" y="960120"/>
+            <a:ext cx="237744" cy="219456"/>
           </a:xfrm>
           <a:prstGeom prst="rect">
             <a:avLst/>
@@ -3427,7 +3433,9 @@
           <a:noFill/>
         </p:spPr>
         <p:txBody>
-          <a:bodyPr wrap="square"/>
+          <a:bodyPr wrap="square">
+            <a:spAutoFit/>
+          </a:bodyPr>
           <a:lstStyle/>
           <a:p>
             <a:pPr algn="ctr"/>
@@ -3451,8 +3459,8 @@
         </p:nvSpPr>
         <p:spPr>
           <a:xfrm>
-            <a:off x="740664" y="1014984"/>
-            <a:ext cx="1325879" cy="237744"/>
+            <a:off x="768096" y="960120"/>
+            <a:ext cx="1249018" cy="219456"/>
           </a:xfrm>
           <a:prstGeom prst="rect">
             <a:avLst/>
@@ -3460,7 +3468,9 @@
           <a:noFill/>
         </p:spPr>
         <p:txBody>
-          <a:bodyPr wrap="square"/>
+          <a:bodyPr wrap="square">
+            <a:spAutoFit/>
+          </a:bodyPr>
           <a:lstStyle/>
           <a:p>
             <a:pPr algn="l"/>
@@ -3484,8 +3494,8 @@
         </p:nvSpPr>
         <p:spPr>
           <a:xfrm>
-            <a:off x="429768" y="1307592"/>
-            <a:ext cx="1655063" cy="320040"/>
+            <a:off x="475488" y="1261872"/>
+            <a:ext cx="1541626" cy="274320"/>
           </a:xfrm>
           <a:prstGeom prst="rect">
             <a:avLst/>
@@ -3493,7 +3503,9 @@
           <a:noFill/>
         </p:spPr>
         <p:txBody>
-          <a:bodyPr wrap="square"/>
+          <a:bodyPr wrap="square">
+            <a:spAutoFit/>
+          </a:bodyPr>
           <a:lstStyle/>
           <a:p>
             <a:pPr algn="l"/>
@@ -3517,8 +3529,8 @@
         </p:nvSpPr>
         <p:spPr>
           <a:xfrm>
-            <a:off x="429768" y="1783080"/>
-            <a:ext cx="1655063" cy="914400"/>
+            <a:off x="475488" y="1691640"/>
+            <a:ext cx="1541626" cy="932688"/>
           </a:xfrm>
           <a:prstGeom prst="roundRect">
             <a:avLst>
@@ -3564,8 +3576,8 @@
         </p:nvSpPr>
         <p:spPr>
           <a:xfrm>
-            <a:off x="429768" y="1856232"/>
-            <a:ext cx="54864" cy="768096"/>
+            <a:off x="475488" y="1783080"/>
+            <a:ext cx="50292" cy="749808"/>
           </a:xfrm>
           <a:prstGeom prst="rect">
             <a:avLst/>
@@ -3607,8 +3619,8 @@
         </p:nvSpPr>
         <p:spPr>
           <a:xfrm>
-            <a:off x="594360" y="1874520"/>
-            <a:ext cx="1399031" cy="786384"/>
+            <a:off x="621792" y="1801368"/>
+            <a:ext cx="1303882" cy="768096"/>
           </a:xfrm>
           <a:prstGeom prst="rect">
             <a:avLst/>
@@ -3623,10 +3635,10 @@
           <a:p>
             <a:pPr algn="l">
               <a:spcBef>
-                <a:spcPts val="100"/>
+                <a:spcPts val="0"/>
               </a:spcBef>
               <a:spcAft>
-                <a:spcPts val="0"/>
+                <a:spcPts val="100"/>
               </a:spcAft>
             </a:pPr>
             <a:r>
@@ -3642,10 +3654,10 @@
           <a:p>
             <a:pPr algn="l">
               <a:spcBef>
-                <a:spcPts val="100"/>
+                <a:spcPts val="0"/>
               </a:spcBef>
               <a:spcAft>
-                <a:spcPts val="0"/>
+                <a:spcPts val="100"/>
               </a:spcAft>
             </a:pPr>
             <a:r>
@@ -3668,8 +3680,8 @@
         </p:nvSpPr>
         <p:spPr>
           <a:xfrm>
-            <a:off x="429768" y="2834640"/>
-            <a:ext cx="1655063" cy="914400"/>
+            <a:off x="475488" y="2743200"/>
+            <a:ext cx="1541626" cy="932688"/>
           </a:xfrm>
           <a:prstGeom prst="roundRect">
             <a:avLst>
@@ -3715,8 +3727,8 @@
         </p:nvSpPr>
         <p:spPr>
           <a:xfrm>
-            <a:off x="429768" y="2907792"/>
-            <a:ext cx="54864" cy="768096"/>
+            <a:off x="475488" y="2834640"/>
+            <a:ext cx="50292" cy="749808"/>
           </a:xfrm>
           <a:prstGeom prst="rect">
             <a:avLst/>
@@ -3758,8 +3770,8 @@
         </p:nvSpPr>
         <p:spPr>
           <a:xfrm>
-            <a:off x="594360" y="2926080"/>
-            <a:ext cx="1399031" cy="786384"/>
+            <a:off x="621792" y="2852928"/>
+            <a:ext cx="1303882" cy="768096"/>
           </a:xfrm>
           <a:prstGeom prst="rect">
             <a:avLst/>
@@ -3774,10 +3786,10 @@
           <a:p>
             <a:pPr algn="l">
               <a:spcBef>
-                <a:spcPts val="100"/>
+                <a:spcPts val="0"/>
               </a:spcBef>
               <a:spcAft>
-                <a:spcPts val="0"/>
+                <a:spcPts val="100"/>
               </a:spcAft>
             </a:pPr>
             <a:r>
@@ -3793,10 +3805,10 @@
           <a:p>
             <a:pPr algn="l">
               <a:spcBef>
-                <a:spcPts val="100"/>
+                <a:spcPts val="0"/>
               </a:spcBef>
               <a:spcAft>
-                <a:spcPts val="0"/>
+                <a:spcPts val="100"/>
               </a:spcAft>
             </a:pPr>
             <a:r>
@@ -3819,8 +3831,8 @@
         </p:nvSpPr>
         <p:spPr>
           <a:xfrm>
-            <a:off x="429768" y="3886200"/>
-            <a:ext cx="1655063" cy="914400"/>
+            <a:off x="475488" y="3794760"/>
+            <a:ext cx="1541626" cy="932688"/>
           </a:xfrm>
           <a:prstGeom prst="roundRect">
             <a:avLst>
@@ -3866,8 +3878,8 @@
         </p:nvSpPr>
         <p:spPr>
           <a:xfrm>
-            <a:off x="429768" y="3959352"/>
-            <a:ext cx="54864" cy="768096"/>
+            <a:off x="475488" y="3886200"/>
+            <a:ext cx="50292" cy="749808"/>
           </a:xfrm>
           <a:prstGeom prst="rect">
             <a:avLst/>
@@ -3909,8 +3921,8 @@
         </p:nvSpPr>
         <p:spPr>
           <a:xfrm>
-            <a:off x="594360" y="3977640"/>
-            <a:ext cx="1399031" cy="786384"/>
+            <a:off x="621792" y="3904488"/>
+            <a:ext cx="1303882" cy="768096"/>
           </a:xfrm>
           <a:prstGeom prst="rect">
             <a:avLst/>
@@ -3925,10 +3937,10 @@
           <a:p>
             <a:pPr algn="l">
               <a:spcBef>
-                <a:spcPts val="100"/>
+                <a:spcPts val="0"/>
               </a:spcBef>
               <a:spcAft>
-                <a:spcPts val="0"/>
+                <a:spcPts val="100"/>
               </a:spcAft>
             </a:pPr>
             <a:r>
@@ -3944,10 +3956,10 @@
           <a:p>
             <a:pPr algn="l">
               <a:spcBef>
-                <a:spcPts val="100"/>
+                <a:spcPts val="0"/>
               </a:spcBef>
               <a:spcAft>
-                <a:spcPts val="0"/>
+                <a:spcPts val="100"/>
               </a:spcAft>
             </a:pPr>
             <a:r>
@@ -3970,8 +3982,8 @@
         </p:nvSpPr>
         <p:spPr>
           <a:xfrm>
-            <a:off x="429768" y="5120640"/>
-            <a:ext cx="1655063" cy="640080"/>
+            <a:off x="475488" y="5029200"/>
+            <a:ext cx="1541626" cy="640080"/>
           </a:xfrm>
           <a:prstGeom prst="rect">
             <a:avLst/>
@@ -3979,7 +3991,9 @@
           <a:noFill/>
         </p:spPr>
         <p:txBody>
-          <a:bodyPr wrap="square"/>
+          <a:bodyPr wrap="square">
+            <a:spAutoFit/>
+          </a:bodyPr>
           <a:lstStyle/>
           <a:p>
             <a:pPr algn="l"/>
@@ -4004,18 +4018,18 @@
         </p:nvSpPr>
         <p:spPr>
           <a:xfrm>
-            <a:off x="2331720" y="868680"/>
-            <a:ext cx="1874519" cy="5074920"/>
+            <a:off x="2382874" y="822960"/>
+            <a:ext cx="1761082" cy="5120640"/>
           </a:xfrm>
           <a:prstGeom prst="roundRect">
             <a:avLst>
-              <a:gd name="adj" fmla="val 6000"/>
+              <a:gd name="adj" fmla="val 5500"/>
             </a:avLst>
           </a:prstGeom>
           <a:solidFill>
             <a:srgbClr val="0C2340"/>
           </a:solidFill>
-          <a:ln w="17145">
+          <a:ln w="17780">
             <a:solidFill>
               <a:srgbClr val="FB923C"/>
             </a:solidFill>
@@ -4051,8 +4065,8 @@
         </p:nvSpPr>
         <p:spPr>
           <a:xfrm>
-            <a:off x="2441448" y="996696"/>
-            <a:ext cx="256032" cy="256032"/>
+            <a:off x="2492602" y="950976"/>
+            <a:ext cx="237744" cy="237744"/>
           </a:xfrm>
           <a:prstGeom prst="ellipse">
             <a:avLst/>
@@ -4094,8 +4108,8 @@
         </p:nvSpPr>
         <p:spPr>
           <a:xfrm>
-            <a:off x="2441448" y="1014984"/>
-            <a:ext cx="256032" cy="237744"/>
+            <a:off x="2492602" y="960120"/>
+            <a:ext cx="237744" cy="219456"/>
           </a:xfrm>
           <a:prstGeom prst="rect">
             <a:avLst/>
@@ -4103,7 +4117,9 @@
           <a:noFill/>
         </p:spPr>
         <p:txBody>
-          <a:bodyPr wrap="square"/>
+          <a:bodyPr wrap="square">
+            <a:spAutoFit/>
+          </a:bodyPr>
           <a:lstStyle/>
           <a:p>
             <a:pPr algn="ctr"/>
@@ -4127,8 +4143,8 @@
         </p:nvSpPr>
         <p:spPr>
           <a:xfrm>
-            <a:off x="2752344" y="1014984"/>
-            <a:ext cx="1325879" cy="237744"/>
+            <a:off x="2785210" y="960120"/>
+            <a:ext cx="1249018" cy="219456"/>
           </a:xfrm>
           <a:prstGeom prst="rect">
             <a:avLst/>
@@ -4136,7 +4152,9 @@
           <a:noFill/>
         </p:spPr>
         <p:txBody>
-          <a:bodyPr wrap="square"/>
+          <a:bodyPr wrap="square">
+            <a:spAutoFit/>
+          </a:bodyPr>
           <a:lstStyle/>
           <a:p>
             <a:pPr algn="l"/>
@@ -4160,8 +4178,8 @@
         </p:nvSpPr>
         <p:spPr>
           <a:xfrm>
-            <a:off x="2441448" y="1325880"/>
-            <a:ext cx="1655063" cy="256032"/>
+            <a:off x="2492602" y="1261872"/>
+            <a:ext cx="1541626" cy="256032"/>
           </a:xfrm>
           <a:prstGeom prst="rect">
             <a:avLst/>
@@ -4169,12 +4187,14 @@
           <a:noFill/>
         </p:spPr>
         <p:txBody>
-          <a:bodyPr wrap="square"/>
+          <a:bodyPr wrap="square">
+            <a:spAutoFit/>
+          </a:bodyPr>
           <a:lstStyle/>
           <a:p>
             <a:pPr algn="l"/>
             <a:r>
-              <a:rPr sz="1500" b="1">
+              <a:rPr sz="1400" b="1">
                 <a:solidFill>
                   <a:srgbClr val="F8FAFC"/>
                 </a:solidFill>
@@ -4193,8 +4213,8 @@
         </p:nvSpPr>
         <p:spPr>
           <a:xfrm>
-            <a:off x="2441448" y="1600200"/>
-            <a:ext cx="1655063" cy="320040"/>
+            <a:off x="2492602" y="1536192"/>
+            <a:ext cx="1541626" cy="320040"/>
           </a:xfrm>
           <a:prstGeom prst="rect">
             <a:avLst/>
@@ -4202,7 +4222,9 @@
           <a:noFill/>
         </p:spPr>
         <p:txBody>
-          <a:bodyPr wrap="square"/>
+          <a:bodyPr wrap="square">
+            <a:spAutoFit/>
+          </a:bodyPr>
           <a:lstStyle/>
           <a:p>
             <a:pPr algn="l"/>
@@ -4226,8 +4248,8 @@
         </p:nvSpPr>
         <p:spPr>
           <a:xfrm>
-            <a:off x="2441448" y="2103120"/>
-            <a:ext cx="1655063" cy="777240"/>
+            <a:off x="2492602" y="1965960"/>
+            <a:ext cx="1541626" cy="804672"/>
           </a:xfrm>
           <a:prstGeom prst="roundRect">
             <a:avLst>
@@ -4273,8 +4295,8 @@
         </p:nvSpPr>
         <p:spPr>
           <a:xfrm>
-            <a:off x="2441448" y="2176272"/>
-            <a:ext cx="54864" cy="630936"/>
+            <a:off x="2492602" y="2057400"/>
+            <a:ext cx="50292" cy="621792"/>
           </a:xfrm>
           <a:prstGeom prst="rect">
             <a:avLst/>
@@ -4316,8 +4338,8 @@
         </p:nvSpPr>
         <p:spPr>
           <a:xfrm>
-            <a:off x="2606040" y="2194560"/>
-            <a:ext cx="1399031" cy="649224"/>
+            <a:off x="2638906" y="2075688"/>
+            <a:ext cx="1303882" cy="640080"/>
           </a:xfrm>
           <a:prstGeom prst="rect">
             <a:avLst/>
@@ -4332,10 +4354,10 @@
           <a:p>
             <a:pPr algn="l">
               <a:spcBef>
-                <a:spcPts val="100"/>
+                <a:spcPts val="0"/>
               </a:spcBef>
               <a:spcAft>
-                <a:spcPts val="0"/>
+                <a:spcPts val="100"/>
               </a:spcAft>
             </a:pPr>
             <a:r>
@@ -4351,10 +4373,10 @@
           <a:p>
             <a:pPr algn="l">
               <a:spcBef>
-                <a:spcPts val="100"/>
+                <a:spcPts val="0"/>
               </a:spcBef>
               <a:spcAft>
-                <a:spcPts val="0"/>
+                <a:spcPts val="100"/>
               </a:spcAft>
             </a:pPr>
             <a:r>
@@ -4377,8 +4399,8 @@
         </p:nvSpPr>
         <p:spPr>
           <a:xfrm>
-            <a:off x="2441448" y="2971800"/>
-            <a:ext cx="1655063" cy="777240"/>
+            <a:off x="2492602" y="2880360"/>
+            <a:ext cx="1541626" cy="804672"/>
           </a:xfrm>
           <a:prstGeom prst="roundRect">
             <a:avLst>
@@ -4424,8 +4446,8 @@
         </p:nvSpPr>
         <p:spPr>
           <a:xfrm>
-            <a:off x="2441448" y="3044952"/>
-            <a:ext cx="54864" cy="630936"/>
+            <a:off x="2492602" y="2971800"/>
+            <a:ext cx="50292" cy="621792"/>
           </a:xfrm>
           <a:prstGeom prst="rect">
             <a:avLst/>
@@ -4467,8 +4489,8 @@
         </p:nvSpPr>
         <p:spPr>
           <a:xfrm>
-            <a:off x="2606040" y="3063240"/>
-            <a:ext cx="1399031" cy="649224"/>
+            <a:off x="2638906" y="2990088"/>
+            <a:ext cx="1303882" cy="640080"/>
           </a:xfrm>
           <a:prstGeom prst="rect">
             <a:avLst/>
@@ -4483,10 +4505,10 @@
           <a:p>
             <a:pPr algn="l">
               <a:spcBef>
-                <a:spcPts val="100"/>
+                <a:spcPts val="0"/>
               </a:spcBef>
               <a:spcAft>
-                <a:spcPts val="0"/>
+                <a:spcPts val="100"/>
               </a:spcAft>
             </a:pPr>
             <a:r>
@@ -4502,10 +4524,10 @@
           <a:p>
             <a:pPr algn="l">
               <a:spcBef>
-                <a:spcPts val="100"/>
+                <a:spcPts val="0"/>
               </a:spcBef>
               <a:spcAft>
-                <a:spcPts val="0"/>
+                <a:spcPts val="100"/>
               </a:spcAft>
             </a:pPr>
             <a:r>
@@ -4528,8 +4550,8 @@
         </p:nvSpPr>
         <p:spPr>
           <a:xfrm>
-            <a:off x="2441448" y="3840480"/>
-            <a:ext cx="1655063" cy="777240"/>
+            <a:off x="2492602" y="3794760"/>
+            <a:ext cx="1541626" cy="804672"/>
           </a:xfrm>
           <a:prstGeom prst="roundRect">
             <a:avLst>
@@ -4575,8 +4597,8 @@
         </p:nvSpPr>
         <p:spPr>
           <a:xfrm>
-            <a:off x="2441448" y="3913632"/>
-            <a:ext cx="54864" cy="630936"/>
+            <a:off x="2492602" y="3886200"/>
+            <a:ext cx="50292" cy="621792"/>
           </a:xfrm>
           <a:prstGeom prst="rect">
             <a:avLst/>
@@ -4618,8 +4640,8 @@
         </p:nvSpPr>
         <p:spPr>
           <a:xfrm>
-            <a:off x="2606040" y="3931920"/>
-            <a:ext cx="1399031" cy="649224"/>
+            <a:off x="2638906" y="3904488"/>
+            <a:ext cx="1303882" cy="640080"/>
           </a:xfrm>
           <a:prstGeom prst="rect">
             <a:avLst/>
@@ -4634,10 +4656,10 @@
           <a:p>
             <a:pPr algn="l">
               <a:spcBef>
-                <a:spcPts val="100"/>
+                <a:spcPts val="0"/>
               </a:spcBef>
               <a:spcAft>
-                <a:spcPts val="0"/>
+                <a:spcPts val="100"/>
               </a:spcAft>
             </a:pPr>
             <a:r>
@@ -4653,10 +4675,10 @@
           <a:p>
             <a:pPr algn="l">
               <a:spcBef>
-                <a:spcPts val="100"/>
+                <a:spcPts val="0"/>
               </a:spcBef>
               <a:spcAft>
-                <a:spcPts val="0"/>
+                <a:spcPts val="100"/>
               </a:spcAft>
             </a:pPr>
             <a:r>
@@ -4679,8 +4701,8 @@
         </p:nvSpPr>
         <p:spPr>
           <a:xfrm>
-            <a:off x="2441448" y="4892040"/>
-            <a:ext cx="1655063" cy="868680"/>
+            <a:off x="2492602" y="4892040"/>
+            <a:ext cx="1541626" cy="822960"/>
           </a:xfrm>
           <a:prstGeom prst="rect">
             <a:avLst/>
@@ -4688,7 +4710,9 @@
           <a:noFill/>
         </p:spPr>
         <p:txBody>
-          <a:bodyPr wrap="square"/>
+          <a:bodyPr wrap="square">
+            <a:spAutoFit/>
+          </a:bodyPr>
           <a:lstStyle/>
           <a:p>
             <a:pPr algn="l"/>
@@ -4714,8 +4738,8 @@
         </p:nvSpPr>
         <p:spPr>
           <a:xfrm>
-            <a:off x="2231135" y="2697480"/>
-            <a:ext cx="201168" cy="146304"/>
+            <a:off x="2163418" y="2743200"/>
+            <a:ext cx="182880" cy="137160"/>
           </a:xfrm>
           <a:prstGeom prst="rightArrow">
             <a:avLst/>
@@ -4757,8 +4781,8 @@
         </p:nvSpPr>
         <p:spPr>
           <a:xfrm>
-            <a:off x="4242815" y="2697480"/>
-            <a:ext cx="201168" cy="146304"/>
+            <a:off x="4180532" y="2743200"/>
+            <a:ext cx="182880" cy="137160"/>
           </a:xfrm>
           <a:prstGeom prst="rightArrow">
             <a:avLst/>
@@ -4800,8 +4824,8 @@
         </p:nvSpPr>
         <p:spPr>
           <a:xfrm>
-            <a:off x="2231135" y="3977640"/>
-            <a:ext cx="201168" cy="146304"/>
+            <a:off x="2163418" y="4023360"/>
+            <a:ext cx="182880" cy="137160"/>
           </a:xfrm>
           <a:prstGeom prst="rightArrow">
             <a:avLst/>
@@ -4843,8 +4867,8 @@
         </p:nvSpPr>
         <p:spPr>
           <a:xfrm>
-            <a:off x="4242815" y="3977640"/>
-            <a:ext cx="201168" cy="146304"/>
+            <a:off x="4180532" y="4023360"/>
+            <a:ext cx="182880" cy="137160"/>
           </a:xfrm>
           <a:prstGeom prst="rightArrow">
             <a:avLst/>
@@ -4886,8 +4910,8 @@
         </p:nvSpPr>
         <p:spPr>
           <a:xfrm>
-            <a:off x="4434840" y="868680"/>
-            <a:ext cx="4160520" cy="5074920"/>
+            <a:off x="4399988" y="822960"/>
+            <a:ext cx="3913517" cy="5120640"/>
           </a:xfrm>
           <a:prstGeom prst="roundRect">
             <a:avLst>
@@ -4933,16 +4957,16 @@
         </p:nvSpPr>
         <p:spPr>
           <a:xfrm>
-            <a:off x="4572000" y="978408"/>
-            <a:ext cx="3886200" cy="502920"/>
+            <a:off x="4528004" y="932688"/>
+            <a:ext cx="3657485" cy="384048"/>
           </a:xfrm>
           <a:prstGeom prst="roundRect">
             <a:avLst>
-              <a:gd name="adj" fmla="val 12000"/>
+              <a:gd name="adj" fmla="val 14000"/>
             </a:avLst>
           </a:prstGeom>
           <a:solidFill>
-            <a:srgbClr val="0D3D38"/>
+            <a:srgbClr val="0C3532"/>
           </a:solidFill>
           <a:ln w="12700">
             <a:solidFill>
@@ -4980,8 +5004,8 @@
         </p:nvSpPr>
         <p:spPr>
           <a:xfrm>
-            <a:off x="4663440" y="1014984"/>
-            <a:ext cx="3703320" cy="256032"/>
+            <a:off x="4601156" y="987552"/>
+            <a:ext cx="3511181" cy="292608"/>
           </a:xfrm>
           <a:prstGeom prst="rect">
             <a:avLst/>
@@ -4989,12 +5013,14 @@
           <a:noFill/>
         </p:spPr>
         <p:txBody>
-          <a:bodyPr wrap="square"/>
+          <a:bodyPr wrap="square">
+            <a:spAutoFit/>
+          </a:bodyPr>
           <a:lstStyle/>
           <a:p>
             <a:pPr algn="l"/>
             <a:r>
-              <a:rPr sz="1500" b="1">
+              <a:rPr sz="1400" b="1">
                 <a:solidFill>
                   <a:srgbClr val="2DD4BF"/>
                 </a:solidFill>
@@ -5013,8 +5039,8 @@
         </p:nvSpPr>
         <p:spPr>
           <a:xfrm>
-            <a:off x="4663440" y="1234440"/>
-            <a:ext cx="3703320" cy="201168"/>
+            <a:off x="4564580" y="1371600"/>
+            <a:ext cx="3584333" cy="256032"/>
           </a:xfrm>
           <a:prstGeom prst="rect">
             <a:avLst/>
@@ -5022,7 +5048,9 @@
           <a:noFill/>
         </p:spPr>
         <p:txBody>
-          <a:bodyPr wrap="square"/>
+          <a:bodyPr wrap="square">
+            <a:spAutoFit/>
+          </a:bodyPr>
           <a:lstStyle/>
           <a:p>
             <a:pPr algn="l"/>
@@ -5046,8 +5074,8 @@
         </p:nvSpPr>
         <p:spPr>
           <a:xfrm>
-            <a:off x="4617720" y="1691640"/>
-            <a:ext cx="1874519" cy="868680"/>
+            <a:off x="4546292" y="1719072"/>
+            <a:ext cx="1755590" cy="841248"/>
           </a:xfrm>
           <a:prstGeom prst="roundRect">
             <a:avLst>
@@ -5093,8 +5121,8 @@
         </p:nvSpPr>
         <p:spPr>
           <a:xfrm>
-            <a:off x="4617720" y="1764792"/>
-            <a:ext cx="54864" cy="722376"/>
+            <a:off x="4546292" y="1810512"/>
+            <a:ext cx="50292" cy="658368"/>
           </a:xfrm>
           <a:prstGeom prst="rect">
             <a:avLst/>
@@ -5136,8 +5164,8 @@
         </p:nvSpPr>
         <p:spPr>
           <a:xfrm>
-            <a:off x="4782312" y="1783080"/>
-            <a:ext cx="1618487" cy="740664"/>
+            <a:off x="4692596" y="1828800"/>
+            <a:ext cx="1517846" cy="676656"/>
           </a:xfrm>
           <a:prstGeom prst="rect">
             <a:avLst/>
@@ -5152,10 +5180,10 @@
           <a:p>
             <a:pPr algn="l">
               <a:spcBef>
-                <a:spcPts val="100"/>
+                <a:spcPts val="0"/>
               </a:spcBef>
               <a:spcAft>
-                <a:spcPts val="0"/>
+                <a:spcPts val="100"/>
               </a:spcAft>
             </a:pPr>
             <a:r>
@@ -5171,10 +5199,10 @@
           <a:p>
             <a:pPr algn="l">
               <a:spcBef>
-                <a:spcPts val="100"/>
+                <a:spcPts val="0"/>
               </a:spcBef>
               <a:spcAft>
-                <a:spcPts val="0"/>
+                <a:spcPts val="100"/>
               </a:spcAft>
             </a:pPr>
             <a:r>
@@ -5197,8 +5225,8 @@
         </p:nvSpPr>
         <p:spPr>
           <a:xfrm>
-            <a:off x="6601967" y="1691640"/>
-            <a:ext cx="1874519" cy="868680"/>
+            <a:off x="6411610" y="1719072"/>
+            <a:ext cx="1755590" cy="841248"/>
           </a:xfrm>
           <a:prstGeom prst="roundRect">
             <a:avLst>
@@ -5244,8 +5272,8 @@
         </p:nvSpPr>
         <p:spPr>
           <a:xfrm>
-            <a:off x="6601967" y="1764792"/>
-            <a:ext cx="54864" cy="722376"/>
+            <a:off x="6411610" y="1810512"/>
+            <a:ext cx="50292" cy="658368"/>
           </a:xfrm>
           <a:prstGeom prst="rect">
             <a:avLst/>
@@ -5287,8 +5315,8 @@
         </p:nvSpPr>
         <p:spPr>
           <a:xfrm>
-            <a:off x="6766559" y="1783080"/>
-            <a:ext cx="1618487" cy="740664"/>
+            <a:off x="6557914" y="1828800"/>
+            <a:ext cx="1517846" cy="676656"/>
           </a:xfrm>
           <a:prstGeom prst="rect">
             <a:avLst/>
@@ -5303,10 +5331,10 @@
           <a:p>
             <a:pPr algn="l">
               <a:spcBef>
-                <a:spcPts val="100"/>
+                <a:spcPts val="0"/>
               </a:spcBef>
               <a:spcAft>
-                <a:spcPts val="0"/>
+                <a:spcPts val="100"/>
               </a:spcAft>
             </a:pPr>
             <a:r>
@@ -5322,10 +5350,10 @@
           <a:p>
             <a:pPr algn="l">
               <a:spcBef>
-                <a:spcPts val="100"/>
+                <a:spcPts val="0"/>
               </a:spcBef>
               <a:spcAft>
-                <a:spcPts val="0"/>
+                <a:spcPts val="100"/>
               </a:spcAft>
             </a:pPr>
             <a:r>
@@ -5348,8 +5376,8 @@
         </p:nvSpPr>
         <p:spPr>
           <a:xfrm>
-            <a:off x="4617720" y="2670048"/>
-            <a:ext cx="1874519" cy="868680"/>
+            <a:off x="4546292" y="2651760"/>
+            <a:ext cx="1755590" cy="841248"/>
           </a:xfrm>
           <a:prstGeom prst="roundRect">
             <a:avLst>
@@ -5395,8 +5423,8 @@
         </p:nvSpPr>
         <p:spPr>
           <a:xfrm>
-            <a:off x="4617720" y="2743200"/>
-            <a:ext cx="54864" cy="722376"/>
+            <a:off x="4546292" y="2743200"/>
+            <a:ext cx="50292" cy="658368"/>
           </a:xfrm>
           <a:prstGeom prst="rect">
             <a:avLst/>
@@ -5438,8 +5466,8 @@
         </p:nvSpPr>
         <p:spPr>
           <a:xfrm>
-            <a:off x="4782312" y="2761488"/>
-            <a:ext cx="1618487" cy="740664"/>
+            <a:off x="4692596" y="2761488"/>
+            <a:ext cx="1517846" cy="676656"/>
           </a:xfrm>
           <a:prstGeom prst="rect">
             <a:avLst/>
@@ -5454,10 +5482,10 @@
           <a:p>
             <a:pPr algn="l">
               <a:spcBef>
-                <a:spcPts val="100"/>
+                <a:spcPts val="0"/>
               </a:spcBef>
               <a:spcAft>
-                <a:spcPts val="0"/>
+                <a:spcPts val="100"/>
               </a:spcAft>
             </a:pPr>
             <a:r>
@@ -5473,10 +5501,10 @@
           <a:p>
             <a:pPr algn="l">
               <a:spcBef>
-                <a:spcPts val="100"/>
+                <a:spcPts val="0"/>
               </a:spcBef>
               <a:spcAft>
-                <a:spcPts val="0"/>
+                <a:spcPts val="100"/>
               </a:spcAft>
             </a:pPr>
             <a:r>
@@ -5499,8 +5527,8 @@
         </p:nvSpPr>
         <p:spPr>
           <a:xfrm>
-            <a:off x="6601967" y="2670048"/>
-            <a:ext cx="1874519" cy="868680"/>
+            <a:off x="6411610" y="2651760"/>
+            <a:ext cx="1755590" cy="841248"/>
           </a:xfrm>
           <a:prstGeom prst="roundRect">
             <a:avLst>
@@ -5546,8 +5574,8 @@
         </p:nvSpPr>
         <p:spPr>
           <a:xfrm>
-            <a:off x="6601967" y="2743200"/>
-            <a:ext cx="54864" cy="722376"/>
+            <a:off x="6411610" y="2743200"/>
+            <a:ext cx="50292" cy="658368"/>
           </a:xfrm>
           <a:prstGeom prst="rect">
             <a:avLst/>
@@ -5589,8 +5617,8 @@
         </p:nvSpPr>
         <p:spPr>
           <a:xfrm>
-            <a:off x="6766559" y="2761488"/>
-            <a:ext cx="1618487" cy="740664"/>
+            <a:off x="6557914" y="2761488"/>
+            <a:ext cx="1517846" cy="676656"/>
           </a:xfrm>
           <a:prstGeom prst="rect">
             <a:avLst/>
@@ -5605,10 +5633,10 @@
           <a:p>
             <a:pPr algn="l">
               <a:spcBef>
-                <a:spcPts val="100"/>
+                <a:spcPts val="0"/>
               </a:spcBef>
               <a:spcAft>
-                <a:spcPts val="0"/>
+                <a:spcPts val="100"/>
               </a:spcAft>
             </a:pPr>
             <a:r>
@@ -5624,10 +5652,10 @@
           <a:p>
             <a:pPr algn="l">
               <a:spcBef>
-                <a:spcPts val="100"/>
+                <a:spcPts val="0"/>
               </a:spcBef>
               <a:spcAft>
-                <a:spcPts val="0"/>
+                <a:spcPts val="100"/>
               </a:spcAft>
             </a:pPr>
             <a:r>
@@ -5637,7 +5665,7 @@
                 </a:solidFill>
                 <a:latin typeface="Calibri"/>
               </a:rPr>
-              <a:t>Balances · multi-ccy accounts</a:t>
+              <a:t>Balances · multi-currency</a:t>
             </a:r>
           </a:p>
         </p:txBody>
@@ -5650,8 +5678,8 @@
         </p:nvSpPr>
         <p:spPr>
           <a:xfrm>
-            <a:off x="4617720" y="3648456"/>
-            <a:ext cx="1874519" cy="868680"/>
+            <a:off x="4546292" y="3584448"/>
+            <a:ext cx="1755590" cy="841248"/>
           </a:xfrm>
           <a:prstGeom prst="roundRect">
             <a:avLst>
@@ -5697,8 +5725,8 @@
         </p:nvSpPr>
         <p:spPr>
           <a:xfrm>
-            <a:off x="4617720" y="3721608"/>
-            <a:ext cx="54864" cy="722376"/>
+            <a:off x="4546292" y="3675888"/>
+            <a:ext cx="50292" cy="658368"/>
           </a:xfrm>
           <a:prstGeom prst="rect">
             <a:avLst/>
@@ -5740,8 +5768,8 @@
         </p:nvSpPr>
         <p:spPr>
           <a:xfrm>
-            <a:off x="4782312" y="3739896"/>
-            <a:ext cx="1618487" cy="740664"/>
+            <a:off x="4692596" y="3694176"/>
+            <a:ext cx="1517846" cy="676656"/>
           </a:xfrm>
           <a:prstGeom prst="rect">
             <a:avLst/>
@@ -5756,10 +5784,10 @@
           <a:p>
             <a:pPr algn="l">
               <a:spcBef>
-                <a:spcPts val="100"/>
+                <a:spcPts val="0"/>
               </a:spcBef>
               <a:spcAft>
-                <a:spcPts val="0"/>
+                <a:spcPts val="100"/>
               </a:spcAft>
             </a:pPr>
             <a:r>
@@ -5775,10 +5803,10 @@
           <a:p>
             <a:pPr algn="l">
               <a:spcBef>
-                <a:spcPts val="100"/>
+                <a:spcPts val="0"/>
               </a:spcBef>
               <a:spcAft>
-                <a:spcPts val="0"/>
+                <a:spcPts val="100"/>
               </a:spcAft>
             </a:pPr>
             <a:r>
@@ -5801,8 +5829,8 @@
         </p:nvSpPr>
         <p:spPr>
           <a:xfrm>
-            <a:off x="6601967" y="3648456"/>
-            <a:ext cx="1874519" cy="868680"/>
+            <a:off x="6411610" y="3584448"/>
+            <a:ext cx="1755590" cy="841248"/>
           </a:xfrm>
           <a:prstGeom prst="roundRect">
             <a:avLst>
@@ -5848,8 +5876,8 @@
         </p:nvSpPr>
         <p:spPr>
           <a:xfrm>
-            <a:off x="6601967" y="3721608"/>
-            <a:ext cx="54864" cy="722376"/>
+            <a:off x="6411610" y="3675888"/>
+            <a:ext cx="50292" cy="658368"/>
           </a:xfrm>
           <a:prstGeom prst="rect">
             <a:avLst/>
@@ -5891,8 +5919,8 @@
         </p:nvSpPr>
         <p:spPr>
           <a:xfrm>
-            <a:off x="6766559" y="3739896"/>
-            <a:ext cx="1618487" cy="740664"/>
+            <a:off x="6557914" y="3694176"/>
+            <a:ext cx="1517846" cy="676656"/>
           </a:xfrm>
           <a:prstGeom prst="rect">
             <a:avLst/>
@@ -5907,10 +5935,10 @@
           <a:p>
             <a:pPr algn="l">
               <a:spcBef>
-                <a:spcPts val="100"/>
+                <a:spcPts val="0"/>
               </a:spcBef>
               <a:spcAft>
-                <a:spcPts val="0"/>
+                <a:spcPts val="100"/>
               </a:spcAft>
             </a:pPr>
             <a:r>
@@ -5926,10 +5954,10 @@
           <a:p>
             <a:pPr algn="l">
               <a:spcBef>
-                <a:spcPts val="100"/>
+                <a:spcPts val="0"/>
               </a:spcBef>
               <a:spcAft>
-                <a:spcPts val="0"/>
+                <a:spcPts val="100"/>
               </a:spcAft>
             </a:pPr>
             <a:r>
@@ -5952,12 +5980,12 @@
         </p:nvSpPr>
         <p:spPr>
           <a:xfrm>
-            <a:off x="4617720" y="4663440"/>
-            <a:ext cx="3794760" cy="502920"/>
+            <a:off x="4546292" y="4571999"/>
+            <a:ext cx="3620909" cy="457200"/>
           </a:xfrm>
           <a:prstGeom prst="roundRect">
             <a:avLst>
-              <a:gd name="adj" fmla="val 10000"/>
+              <a:gd name="adj" fmla="val 12000"/>
             </a:avLst>
           </a:prstGeom>
           <a:solidFill>
@@ -5999,8 +6027,8 @@
         </p:nvSpPr>
         <p:spPr>
           <a:xfrm>
-            <a:off x="4709160" y="4754880"/>
-            <a:ext cx="3657600" cy="365760"/>
+            <a:off x="4619444" y="4663440"/>
+            <a:ext cx="3511181" cy="320040"/>
           </a:xfrm>
           <a:prstGeom prst="rect">
             <a:avLst/>
@@ -6008,7 +6036,9 @@
           <a:noFill/>
         </p:spPr>
         <p:txBody>
-          <a:bodyPr wrap="square"/>
+          <a:bodyPr wrap="square">
+            <a:spAutoFit/>
+          </a:bodyPr>
           <a:lstStyle/>
           <a:p>
             <a:pPr algn="l"/>
@@ -6019,7 +6049,7 @@
                 </a:solidFill>
                 <a:latin typeface="Calibri"/>
               </a:rPr>
-              <a:t>Runtime   Event → Rules &amp; calculation → Posting → Ledger books → Outbound event</a:t>
+              <a:t>Runtime:  Event → Rules &amp; calculation → Posting → Ledger books → Outbound</a:t>
             </a:r>
           </a:p>
         </p:txBody>
@@ -6032,8 +6062,8 @@
         </p:nvSpPr>
         <p:spPr>
           <a:xfrm>
-            <a:off x="4617720" y="5303520"/>
-            <a:ext cx="3794760" cy="502920"/>
+            <a:off x="4546292" y="5166360"/>
+            <a:ext cx="3620909" cy="594360"/>
           </a:xfrm>
           <a:prstGeom prst="rect">
             <a:avLst/>
@@ -6041,7 +6071,9 @@
           <a:noFill/>
         </p:spPr>
         <p:txBody>
-          <a:bodyPr wrap="square"/>
+          <a:bodyPr wrap="square">
+            <a:spAutoFit/>
+          </a:bodyPr>
           <a:lstStyle/>
           <a:p>
             <a:pPr algn="l"/>
@@ -6066,8 +6098,8 @@
         </p:nvSpPr>
         <p:spPr>
           <a:xfrm>
-            <a:off x="8613648" y="2697480"/>
-            <a:ext cx="201168" cy="146304"/>
+            <a:off x="8350081" y="2743200"/>
+            <a:ext cx="182880" cy="137160"/>
           </a:xfrm>
           <a:prstGeom prst="rightArrow">
             <a:avLst/>
@@ -6109,8 +6141,8 @@
         </p:nvSpPr>
         <p:spPr>
           <a:xfrm>
-            <a:off x="8613648" y="3977640"/>
-            <a:ext cx="201168" cy="146304"/>
+            <a:off x="8350081" y="4023360"/>
+            <a:ext cx="182880" cy="137160"/>
           </a:xfrm>
           <a:prstGeom prst="rightArrow">
             <a:avLst/>
@@ -6152,18 +6184,18 @@
         </p:nvSpPr>
         <p:spPr>
           <a:xfrm>
-            <a:off x="8732520" y="868680"/>
-            <a:ext cx="1417320" cy="5074920"/>
+            <a:off x="8569537" y="822960"/>
+            <a:ext cx="1434956" cy="5120640"/>
           </a:xfrm>
           <a:prstGeom prst="roundRect">
             <a:avLst>
-              <a:gd name="adj" fmla="val 6000"/>
+              <a:gd name="adj" fmla="val 5500"/>
             </a:avLst>
           </a:prstGeom>
           <a:solidFill>
             <a:srgbClr val="0C2340"/>
           </a:solidFill>
-          <a:ln w="17145">
+          <a:ln w="17780">
             <a:solidFill>
               <a:srgbClr val="FCD34D"/>
             </a:solidFill>
@@ -6199,8 +6231,8 @@
         </p:nvSpPr>
         <p:spPr>
           <a:xfrm>
-            <a:off x="8805672" y="996696"/>
-            <a:ext cx="256032" cy="256032"/>
+            <a:off x="8642689" y="950976"/>
+            <a:ext cx="237744" cy="237744"/>
           </a:xfrm>
           <a:prstGeom prst="ellipse">
             <a:avLst/>
@@ -6242,8 +6274,8 @@
         </p:nvSpPr>
         <p:spPr>
           <a:xfrm>
-            <a:off x="8805672" y="1014984"/>
-            <a:ext cx="256032" cy="237744"/>
+            <a:off x="8642689" y="960120"/>
+            <a:ext cx="237744" cy="219456"/>
           </a:xfrm>
           <a:prstGeom prst="rect">
             <a:avLst/>
@@ -6251,7 +6283,9 @@
           <a:noFill/>
         </p:spPr>
         <p:txBody>
-          <a:bodyPr wrap="square"/>
+          <a:bodyPr wrap="square">
+            <a:spAutoFit/>
+          </a:bodyPr>
           <a:lstStyle/>
           <a:p>
             <a:pPr algn="ctr"/>
@@ -6275,8 +6309,8 @@
         </p:nvSpPr>
         <p:spPr>
           <a:xfrm>
-            <a:off x="9116568" y="1014984"/>
-            <a:ext cx="960120" cy="237744"/>
+            <a:off x="8935297" y="960120"/>
+            <a:ext cx="1014332" cy="219456"/>
           </a:xfrm>
           <a:prstGeom prst="rect">
             <a:avLst/>
@@ -6284,7 +6318,9 @@
           <a:noFill/>
         </p:spPr>
         <p:txBody>
-          <a:bodyPr wrap="square"/>
+          <a:bodyPr wrap="square">
+            <a:spAutoFit/>
+          </a:bodyPr>
           <a:lstStyle/>
           <a:p>
             <a:pPr algn="l"/>
@@ -6308,8 +6344,8 @@
         </p:nvSpPr>
         <p:spPr>
           <a:xfrm>
-            <a:off x="8823960" y="1325880"/>
-            <a:ext cx="1252728" cy="502920"/>
+            <a:off x="8660977" y="1280160"/>
+            <a:ext cx="1270364" cy="457200"/>
           </a:xfrm>
           <a:prstGeom prst="rect">
             <a:avLst/>
@@ -6317,7 +6353,9 @@
           <a:noFill/>
         </p:spPr>
         <p:txBody>
-          <a:bodyPr wrap="square"/>
+          <a:bodyPr wrap="square">
+            <a:spAutoFit/>
+          </a:bodyPr>
           <a:lstStyle/>
           <a:p>
             <a:pPr algn="l"/>
@@ -6342,8 +6380,8 @@
         </p:nvSpPr>
         <p:spPr>
           <a:xfrm>
-            <a:off x="8823960" y="2011680"/>
-            <a:ext cx="1234440" cy="914400"/>
+            <a:off x="8660977" y="1920240"/>
+            <a:ext cx="1252076" cy="914400"/>
           </a:xfrm>
           <a:prstGeom prst="roundRect">
             <a:avLst>
@@ -6389,8 +6427,8 @@
         </p:nvSpPr>
         <p:spPr>
           <a:xfrm>
-            <a:off x="8823960" y="2084832"/>
-            <a:ext cx="54864" cy="768096"/>
+            <a:off x="8660977" y="2011680"/>
+            <a:ext cx="50292" cy="731520"/>
           </a:xfrm>
           <a:prstGeom prst="rect">
             <a:avLst/>
@@ -6432,8 +6470,8 @@
         </p:nvSpPr>
         <p:spPr>
           <a:xfrm>
-            <a:off x="8988552" y="2103120"/>
-            <a:ext cx="978408" cy="786384"/>
+            <a:off x="8807281" y="2029968"/>
+            <a:ext cx="1014332" cy="749808"/>
           </a:xfrm>
           <a:prstGeom prst="rect">
             <a:avLst/>
@@ -6448,10 +6486,10 @@
           <a:p>
             <a:pPr algn="l">
               <a:spcBef>
-                <a:spcPts val="100"/>
+                <a:spcPts val="0"/>
               </a:spcBef>
               <a:spcAft>
-                <a:spcPts val="0"/>
+                <a:spcPts val="100"/>
               </a:spcAft>
             </a:pPr>
             <a:r>
@@ -6467,10 +6505,10 @@
           <a:p>
             <a:pPr algn="l">
               <a:spcBef>
-                <a:spcPts val="100"/>
+                <a:spcPts val="0"/>
               </a:spcBef>
               <a:spcAft>
-                <a:spcPts val="0"/>
+                <a:spcPts val="100"/>
               </a:spcAft>
             </a:pPr>
             <a:r>
@@ -6493,8 +6531,8 @@
         </p:nvSpPr>
         <p:spPr>
           <a:xfrm>
-            <a:off x="8823960" y="3063240"/>
-            <a:ext cx="1234440" cy="914400"/>
+            <a:off x="8660977" y="2971800"/>
+            <a:ext cx="1252076" cy="914400"/>
           </a:xfrm>
           <a:prstGeom prst="roundRect">
             <a:avLst>
@@ -6540,8 +6578,8 @@
         </p:nvSpPr>
         <p:spPr>
           <a:xfrm>
-            <a:off x="8823960" y="3136392"/>
-            <a:ext cx="54864" cy="768096"/>
+            <a:off x="8660977" y="3063240"/>
+            <a:ext cx="50292" cy="731520"/>
           </a:xfrm>
           <a:prstGeom prst="rect">
             <a:avLst/>
@@ -6583,8 +6621,8 @@
         </p:nvSpPr>
         <p:spPr>
           <a:xfrm>
-            <a:off x="8988552" y="3154680"/>
-            <a:ext cx="978408" cy="786384"/>
+            <a:off x="8807281" y="3081528"/>
+            <a:ext cx="1014332" cy="749808"/>
           </a:xfrm>
           <a:prstGeom prst="rect">
             <a:avLst/>
@@ -6599,10 +6637,10 @@
           <a:p>
             <a:pPr algn="l">
               <a:spcBef>
-                <a:spcPts val="100"/>
+                <a:spcPts val="0"/>
               </a:spcBef>
               <a:spcAft>
-                <a:spcPts val="0"/>
+                <a:spcPts val="100"/>
               </a:spcAft>
             </a:pPr>
             <a:r>
@@ -6618,10 +6656,10 @@
           <a:p>
             <a:pPr algn="l">
               <a:spcBef>
-                <a:spcPts val="100"/>
+                <a:spcPts val="0"/>
               </a:spcBef>
               <a:spcAft>
-                <a:spcPts val="0"/>
+                <a:spcPts val="100"/>
               </a:spcAft>
             </a:pPr>
             <a:r>
@@ -6644,8 +6682,8 @@
         </p:nvSpPr>
         <p:spPr>
           <a:xfrm>
-            <a:off x="8823960" y="4114800"/>
-            <a:ext cx="1234440" cy="914400"/>
+            <a:off x="8660977" y="4023360"/>
+            <a:ext cx="1252076" cy="914400"/>
           </a:xfrm>
           <a:prstGeom prst="roundRect">
             <a:avLst>
@@ -6691,8 +6729,8 @@
         </p:nvSpPr>
         <p:spPr>
           <a:xfrm>
-            <a:off x="8823960" y="4187952"/>
-            <a:ext cx="54864" cy="768096"/>
+            <a:off x="8660977" y="4114800"/>
+            <a:ext cx="50292" cy="731520"/>
           </a:xfrm>
           <a:prstGeom prst="rect">
             <a:avLst/>
@@ -6734,8 +6772,8 @@
         </p:nvSpPr>
         <p:spPr>
           <a:xfrm>
-            <a:off x="8988552" y="4206240"/>
-            <a:ext cx="978408" cy="786384"/>
+            <a:off x="8807281" y="4133088"/>
+            <a:ext cx="1014332" cy="749808"/>
           </a:xfrm>
           <a:prstGeom prst="rect">
             <a:avLst/>
@@ -6750,10 +6788,10 @@
           <a:p>
             <a:pPr algn="l">
               <a:spcBef>
-                <a:spcPts val="100"/>
+                <a:spcPts val="0"/>
               </a:spcBef>
               <a:spcAft>
-                <a:spcPts val="0"/>
+                <a:spcPts val="100"/>
               </a:spcAft>
             </a:pPr>
             <a:r>
@@ -6769,10 +6807,10 @@
           <a:p>
             <a:pPr algn="l">
               <a:spcBef>
-                <a:spcPts val="100"/>
+                <a:spcPts val="0"/>
               </a:spcBef>
               <a:spcAft>
-                <a:spcPts val="0"/>
+                <a:spcPts val="100"/>
               </a:spcAft>
             </a:pPr>
             <a:r>
@@ -6795,8 +6833,8 @@
         </p:nvSpPr>
         <p:spPr>
           <a:xfrm>
-            <a:off x="8823960" y="5303520"/>
-            <a:ext cx="1252728" cy="502920"/>
+            <a:off x="8660977" y="5257800"/>
+            <a:ext cx="1270364" cy="457200"/>
           </a:xfrm>
           <a:prstGeom prst="rect">
             <a:avLst/>
@@ -6804,7 +6842,9 @@
           <a:noFill/>
         </p:spPr>
         <p:txBody>
-          <a:bodyPr wrap="square"/>
+          <a:bodyPr wrap="square">
+            <a:spAutoFit/>
+          </a:bodyPr>
           <a:lstStyle/>
           <a:p>
             <a:pPr algn="l"/>
@@ -6829,8 +6869,8 @@
         </p:nvSpPr>
         <p:spPr>
           <a:xfrm>
-            <a:off x="10168128" y="2697480"/>
-            <a:ext cx="201168" cy="146304"/>
+            <a:off x="10041069" y="2743200"/>
+            <a:ext cx="182880" cy="137160"/>
           </a:xfrm>
           <a:prstGeom prst="rightArrow">
             <a:avLst/>
@@ -6872,8 +6912,8 @@
         </p:nvSpPr>
         <p:spPr>
           <a:xfrm>
-            <a:off x="10168128" y="3977640"/>
-            <a:ext cx="201168" cy="146304"/>
+            <a:off x="10041069" y="4023360"/>
+            <a:ext cx="182880" cy="137160"/>
           </a:xfrm>
           <a:prstGeom prst="rightArrow">
             <a:avLst/>
@@ -6915,18 +6955,18 @@
         </p:nvSpPr>
         <p:spPr>
           <a:xfrm>
-            <a:off x="10287000" y="868680"/>
-            <a:ext cx="1600200" cy="5074920"/>
+            <a:off x="10260525" y="822960"/>
+            <a:ext cx="1565407" cy="5120640"/>
           </a:xfrm>
           <a:prstGeom prst="roundRect">
             <a:avLst>
-              <a:gd name="adj" fmla="val 6000"/>
+              <a:gd name="adj" fmla="val 5500"/>
             </a:avLst>
           </a:prstGeom>
           <a:solidFill>
             <a:srgbClr val="0C2340"/>
           </a:solidFill>
-          <a:ln w="17145">
+          <a:ln w="17780">
             <a:solidFill>
               <a:srgbClr val="C4B5FD"/>
             </a:solidFill>
@@ -6962,8 +7002,8 @@
         </p:nvSpPr>
         <p:spPr>
           <a:xfrm>
-            <a:off x="10360152" y="996696"/>
-            <a:ext cx="256032" cy="256032"/>
+            <a:off x="10333677" y="950976"/>
+            <a:ext cx="237744" cy="237744"/>
           </a:xfrm>
           <a:prstGeom prst="ellipse">
             <a:avLst/>
@@ -7005,8 +7045,8 @@
         </p:nvSpPr>
         <p:spPr>
           <a:xfrm>
-            <a:off x="10360152" y="1014984"/>
-            <a:ext cx="256032" cy="237744"/>
+            <a:off x="10333677" y="960120"/>
+            <a:ext cx="237744" cy="219456"/>
           </a:xfrm>
           <a:prstGeom prst="rect">
             <a:avLst/>
@@ -7014,7 +7054,9 @@
           <a:noFill/>
         </p:spPr>
         <p:txBody>
-          <a:bodyPr wrap="square"/>
+          <a:bodyPr wrap="square">
+            <a:spAutoFit/>
+          </a:bodyPr>
           <a:lstStyle/>
           <a:p>
             <a:pPr algn="ctr"/>
@@ -7038,8 +7080,8 @@
         </p:nvSpPr>
         <p:spPr>
           <a:xfrm>
-            <a:off x="10671048" y="1014984"/>
-            <a:ext cx="1143000" cy="237744"/>
+            <a:off x="10626285" y="960120"/>
+            <a:ext cx="1144783" cy="219456"/>
           </a:xfrm>
           <a:prstGeom prst="rect">
             <a:avLst/>
@@ -7047,7 +7089,9 @@
           <a:noFill/>
         </p:spPr>
         <p:txBody>
-          <a:bodyPr wrap="square"/>
+          <a:bodyPr wrap="square">
+            <a:spAutoFit/>
+          </a:bodyPr>
           <a:lstStyle/>
           <a:p>
             <a:pPr algn="l"/>
@@ -7071,8 +7115,8 @@
         </p:nvSpPr>
         <p:spPr>
           <a:xfrm>
-            <a:off x="10378440" y="1325880"/>
-            <a:ext cx="1435608" cy="411480"/>
+            <a:off x="10351965" y="1261872"/>
+            <a:ext cx="1400815" cy="365760"/>
           </a:xfrm>
           <a:prstGeom prst="rect">
             <a:avLst/>
@@ -7080,7 +7124,9 @@
           <a:noFill/>
         </p:spPr>
         <p:txBody>
-          <a:bodyPr wrap="square"/>
+          <a:bodyPr wrap="square">
+            <a:spAutoFit/>
+          </a:bodyPr>
           <a:lstStyle/>
           <a:p>
             <a:pPr algn="l"/>
@@ -7091,8 +7137,7 @@
                 </a:solidFill>
                 <a:latin typeface="Calibri"/>
               </a:rPr>
-              <a:t>Downstream
-results</a:t>
+              <a:t>Downstream results</a:t>
             </a:r>
           </a:p>
         </p:txBody>
@@ -7105,8 +7150,8 @@
         </p:nvSpPr>
         <p:spPr>
           <a:xfrm>
-            <a:off x="10378440" y="1920240"/>
-            <a:ext cx="1417320" cy="777240"/>
+            <a:off x="10351965" y="1783080"/>
+            <a:ext cx="1382527" cy="777240"/>
           </a:xfrm>
           <a:prstGeom prst="roundRect">
             <a:avLst>
@@ -7152,8 +7197,8 @@
         </p:nvSpPr>
         <p:spPr>
           <a:xfrm>
-            <a:off x="10378440" y="1993392"/>
-            <a:ext cx="54864" cy="630936"/>
+            <a:off x="10351965" y="1874520"/>
+            <a:ext cx="50292" cy="594360"/>
           </a:xfrm>
           <a:prstGeom prst="rect">
             <a:avLst/>
@@ -7195,8 +7240,8 @@
         </p:nvSpPr>
         <p:spPr>
           <a:xfrm>
-            <a:off x="10543032" y="2011680"/>
-            <a:ext cx="1161288" cy="649224"/>
+            <a:off x="10498269" y="1892808"/>
+            <a:ext cx="1144783" cy="612648"/>
           </a:xfrm>
           <a:prstGeom prst="rect">
             <a:avLst/>
@@ -7211,14 +7256,14 @@
           <a:p>
             <a:pPr algn="l">
               <a:spcBef>
-                <a:spcPts val="100"/>
+                <a:spcPts val="0"/>
               </a:spcBef>
               <a:spcAft>
-                <a:spcPts val="0"/>
+                <a:spcPts val="100"/>
               </a:spcAft>
             </a:pPr>
             <a:r>
-              <a:rPr sz="1200" b="1">
+              <a:rPr sz="1100" b="1">
                 <a:solidFill>
                   <a:srgbClr val="F8FAFC"/>
                 </a:solidFill>
@@ -7230,10 +7275,10 @@
           <a:p>
             <a:pPr algn="l">
               <a:spcBef>
-                <a:spcPts val="100"/>
+                <a:spcPts val="0"/>
               </a:spcBef>
               <a:spcAft>
-                <a:spcPts val="0"/>
+                <a:spcPts val="100"/>
               </a:spcAft>
             </a:pPr>
             <a:r>
@@ -7256,8 +7301,8 @@
         </p:nvSpPr>
         <p:spPr>
           <a:xfrm>
-            <a:off x="10378440" y="2788920"/>
-            <a:ext cx="1417320" cy="777240"/>
+            <a:off x="10351965" y="2651760"/>
+            <a:ext cx="1382527" cy="777240"/>
           </a:xfrm>
           <a:prstGeom prst="roundRect">
             <a:avLst>
@@ -7303,8 +7348,8 @@
         </p:nvSpPr>
         <p:spPr>
           <a:xfrm>
-            <a:off x="10378440" y="2862072"/>
-            <a:ext cx="54864" cy="630936"/>
+            <a:off x="10351965" y="2743200"/>
+            <a:ext cx="50292" cy="594360"/>
           </a:xfrm>
           <a:prstGeom prst="rect">
             <a:avLst/>
@@ -7346,8 +7391,8 @@
         </p:nvSpPr>
         <p:spPr>
           <a:xfrm>
-            <a:off x="10543032" y="2880360"/>
-            <a:ext cx="1161288" cy="649224"/>
+            <a:off x="10498269" y="2761488"/>
+            <a:ext cx="1144783" cy="612648"/>
           </a:xfrm>
           <a:prstGeom prst="rect">
             <a:avLst/>
@@ -7362,14 +7407,14 @@
           <a:p>
             <a:pPr algn="l">
               <a:spcBef>
-                <a:spcPts val="100"/>
+                <a:spcPts val="0"/>
               </a:spcBef>
               <a:spcAft>
-                <a:spcPts val="0"/>
+                <a:spcPts val="100"/>
               </a:spcAft>
             </a:pPr>
             <a:r>
-              <a:rPr sz="1200" b="1">
+              <a:rPr sz="1100" b="1">
                 <a:solidFill>
                   <a:srgbClr val="F8FAFC"/>
                 </a:solidFill>
@@ -7381,10 +7426,10 @@
           <a:p>
             <a:pPr algn="l">
               <a:spcBef>
-                <a:spcPts val="100"/>
+                <a:spcPts val="0"/>
               </a:spcBef>
               <a:spcAft>
-                <a:spcPts val="0"/>
+                <a:spcPts val="100"/>
               </a:spcAft>
             </a:pPr>
             <a:r>
@@ -7407,8 +7452,8 @@
         </p:nvSpPr>
         <p:spPr>
           <a:xfrm>
-            <a:off x="10378440" y="3657600"/>
-            <a:ext cx="1417320" cy="777240"/>
+            <a:off x="10351965" y="3520440"/>
+            <a:ext cx="1382527" cy="777240"/>
           </a:xfrm>
           <a:prstGeom prst="roundRect">
             <a:avLst>
@@ -7454,8 +7499,8 @@
         </p:nvSpPr>
         <p:spPr>
           <a:xfrm>
-            <a:off x="10378440" y="3730752"/>
-            <a:ext cx="54864" cy="630936"/>
+            <a:off x="10351965" y="3611880"/>
+            <a:ext cx="50292" cy="594360"/>
           </a:xfrm>
           <a:prstGeom prst="rect">
             <a:avLst/>
@@ -7497,8 +7542,8 @@
         </p:nvSpPr>
         <p:spPr>
           <a:xfrm>
-            <a:off x="10543032" y="3749040"/>
-            <a:ext cx="1161288" cy="649224"/>
+            <a:off x="10498269" y="3630168"/>
+            <a:ext cx="1144783" cy="612648"/>
           </a:xfrm>
           <a:prstGeom prst="rect">
             <a:avLst/>
@@ -7513,14 +7558,14 @@
           <a:p>
             <a:pPr algn="l">
               <a:spcBef>
-                <a:spcPts val="100"/>
+                <a:spcPts val="0"/>
               </a:spcBef>
               <a:spcAft>
-                <a:spcPts val="0"/>
+                <a:spcPts val="100"/>
               </a:spcAft>
             </a:pPr>
             <a:r>
-              <a:rPr sz="1200" b="1">
+              <a:rPr sz="1100" b="1">
                 <a:solidFill>
                   <a:srgbClr val="F8FAFC"/>
                 </a:solidFill>
@@ -7532,10 +7577,10 @@
           <a:p>
             <a:pPr algn="l">
               <a:spcBef>
-                <a:spcPts val="100"/>
+                <a:spcPts val="0"/>
               </a:spcBef>
               <a:spcAft>
-                <a:spcPts val="0"/>
+                <a:spcPts val="100"/>
               </a:spcAft>
             </a:pPr>
             <a:r>
@@ -7558,8 +7603,8 @@
         </p:nvSpPr>
         <p:spPr>
           <a:xfrm>
-            <a:off x="10378440" y="4526279"/>
-            <a:ext cx="1417320" cy="777240"/>
+            <a:off x="10351965" y="4389119"/>
+            <a:ext cx="1382527" cy="777240"/>
           </a:xfrm>
           <a:prstGeom prst="roundRect">
             <a:avLst>
@@ -7605,8 +7650,8 @@
         </p:nvSpPr>
         <p:spPr>
           <a:xfrm>
-            <a:off x="10378440" y="4599431"/>
-            <a:ext cx="54864" cy="630936"/>
+            <a:off x="10351965" y="4480559"/>
+            <a:ext cx="50292" cy="594360"/>
           </a:xfrm>
           <a:prstGeom prst="rect">
             <a:avLst/>
@@ -7648,8 +7693,8 @@
         </p:nvSpPr>
         <p:spPr>
           <a:xfrm>
-            <a:off x="10543032" y="4617719"/>
-            <a:ext cx="1161288" cy="649224"/>
+            <a:off x="10498269" y="4498847"/>
+            <a:ext cx="1144783" cy="612648"/>
           </a:xfrm>
           <a:prstGeom prst="rect">
             <a:avLst/>
@@ -7664,14 +7709,14 @@
           <a:p>
             <a:pPr algn="l">
               <a:spcBef>
-                <a:spcPts val="100"/>
+                <a:spcPts val="0"/>
               </a:spcBef>
               <a:spcAft>
-                <a:spcPts val="0"/>
+                <a:spcPts val="100"/>
               </a:spcAft>
             </a:pPr>
             <a:r>
-              <a:rPr sz="1200" b="1">
+              <a:rPr sz="1100" b="1">
                 <a:solidFill>
                   <a:srgbClr val="F8FAFC"/>
                 </a:solidFill>
@@ -7683,10 +7728,10 @@
           <a:p>
             <a:pPr algn="l">
               <a:spcBef>
-                <a:spcPts val="100"/>
+                <a:spcPts val="0"/>
               </a:spcBef>
               <a:spcAft>
-                <a:spcPts val="0"/>
+                <a:spcPts val="100"/>
               </a:spcAft>
             </a:pPr>
             <a:r>
@@ -7709,8 +7754,8 @@
         </p:nvSpPr>
         <p:spPr>
           <a:xfrm>
-            <a:off x="10378440" y="5486400"/>
-            <a:ext cx="1435608" cy="365760"/>
+            <a:off x="10351965" y="5440680"/>
+            <a:ext cx="1400815" cy="320040"/>
           </a:xfrm>
           <a:prstGeom prst="rect">
             <a:avLst/>
@@ -7718,7 +7763,9 @@
           <a:noFill/>
         </p:spPr>
         <p:txBody>
-          <a:bodyPr wrap="square"/>
+          <a:bodyPr wrap="square">
+            <a:spAutoFit/>
+          </a:bodyPr>
           <a:lstStyle/>
           <a:p>
             <a:pPr algn="l"/>
@@ -7742,12 +7789,12 @@
         </p:nvSpPr>
         <p:spPr>
           <a:xfrm>
-            <a:off x="320040" y="6126480"/>
-            <a:ext cx="11567160" cy="502920"/>
+            <a:off x="365760" y="6126480"/>
+            <a:ext cx="11460175" cy="502920"/>
           </a:xfrm>
           <a:prstGeom prst="roundRect">
             <a:avLst>
-              <a:gd name="adj" fmla="val 8000"/>
+              <a:gd name="adj" fmla="val 10000"/>
             </a:avLst>
           </a:prstGeom>
           <a:solidFill>
@@ -7832,7 +7879,7 @@
         </p:nvSpPr>
         <p:spPr>
           <a:xfrm>
-            <a:off x="758952" y="6291072"/>
+            <a:off x="740664" y="6291072"/>
             <a:ext cx="128016" cy="128016"/>
           </a:xfrm>
           <a:prstGeom prst="ellipse">
@@ -7875,7 +7922,7 @@
         </p:nvSpPr>
         <p:spPr>
           <a:xfrm>
-            <a:off x="1014984" y="6291072"/>
+            <a:off x="978408" y="6291072"/>
             <a:ext cx="128016" cy="128016"/>
           </a:xfrm>
           <a:prstGeom prst="ellipse">
@@ -7918,7 +7965,7 @@
         </p:nvSpPr>
         <p:spPr>
           <a:xfrm>
-            <a:off x="1271016" y="6291072"/>
+            <a:off x="1216152" y="6291072"/>
             <a:ext cx="128016" cy="128016"/>
           </a:xfrm>
           <a:prstGeom prst="ellipse">
@@ -7961,7 +8008,7 @@
         </p:nvSpPr>
         <p:spPr>
           <a:xfrm>
-            <a:off x="1527048" y="6291072"/>
+            <a:off x="1453896" y="6291072"/>
             <a:ext cx="128016" cy="128016"/>
           </a:xfrm>
           <a:prstGeom prst="ellipse">
@@ -8004,8 +8051,8 @@
         </p:nvSpPr>
         <p:spPr>
           <a:xfrm>
-            <a:off x="1920240" y="6236208"/>
-            <a:ext cx="7772400" cy="320040"/>
+            <a:off x="1783080" y="6236208"/>
+            <a:ext cx="8412480" cy="320040"/>
           </a:xfrm>
           <a:prstGeom prst="rect">
             <a:avLst/>
@@ -8013,7 +8060,9 @@
           <a:noFill/>
         </p:spPr>
         <p:txBody>
-          <a:bodyPr wrap="square"/>
+          <a:bodyPr wrap="square">
+            <a:spAutoFit/>
+          </a:bodyPr>
           <a:lstStyle/>
           <a:p>
             <a:pPr algn="l"/>
@@ -8024,7 +8073,7 @@
                 </a:solidFill>
                 <a:latin typeface="Calibri"/>
               </a:rPr>
-              <a:t>LedgeRX  =  one powerful product engine     ·     multi-channel via SDK     ·     ops-configured catalog     ·     outbound landing</a:t>
+              <a:t>LedgeRX = one powerful product engine   ·   multi-channel via SDK   ·   ops-configured catalog   ·   outbound landing</a:t>
             </a:r>
           </a:p>
         </p:txBody>
@@ -8037,8 +8086,8 @@
         </p:nvSpPr>
         <p:spPr>
           <a:xfrm>
-            <a:off x="10058400" y="6236208"/>
-            <a:ext cx="1645920" cy="320040"/>
+            <a:off x="10332720" y="6236208"/>
+            <a:ext cx="1371600" cy="320040"/>
           </a:xfrm>
           <a:prstGeom prst="rect">
             <a:avLst/>
@@ -8046,7 +8095,9 @@
           <a:noFill/>
         </p:spPr>
         <p:txBody>
-          <a:bodyPr wrap="square"/>
+          <a:bodyPr wrap="square">
+            <a:spAutoFit/>
+          </a:bodyPr>
           <a:lstStyle/>
           <a:p>
             <a:pPr algn="r"/>

</xml_diff>

<commit_message>
docs(decks): slide 2 — after Landing, UAF CBP maps to Kenny Reward/CBP diagram
</commit_message>
<xml_diff>
--- a/docs/decks/LedgeRX-System-Architecture-CTO.pptx
+++ b/docs/decks/LedgeRX-System-Architecture-CTO.pptx
@@ -6,6 +6,7 @@
   </p:sldMasterIdLst>
   <p:sldIdLst>
     <p:sldId id="256" r:id="rId7"/>
+    <p:sldId id="257" r:id="rId8"/>
   </p:sldIdLst>
   <p:sldSz cx="12191695" cy="6858000" type="screen4x3"/>
   <p:notesSz cx="6858000" cy="9144000"/>
@@ -3321,7 +3322,7 @@
                 </a:solidFill>
                 <a:latin typeface="Calibri"/>
               </a:rPr>
-              <a:t>CTO  ·  1 / 1</a:t>
+              <a:t>CTO  ·  1 / 2</a:t>
             </a:r>
           </a:p>
         </p:txBody>
@@ -3638,7 +3639,7 @@
                 <a:spcPts val="0"/>
               </a:spcBef>
               <a:spcAft>
-                <a:spcPts val="100"/>
+                <a:spcPts val="200"/>
               </a:spcAft>
             </a:pPr>
             <a:r>
@@ -3657,7 +3658,7 @@
                 <a:spcPts val="0"/>
               </a:spcBef>
               <a:spcAft>
-                <a:spcPts val="100"/>
+                <a:spcPts val="200"/>
               </a:spcAft>
             </a:pPr>
             <a:r>
@@ -3789,7 +3790,7 @@
                 <a:spcPts val="0"/>
               </a:spcBef>
               <a:spcAft>
-                <a:spcPts val="100"/>
+                <a:spcPts val="200"/>
               </a:spcAft>
             </a:pPr>
             <a:r>
@@ -3808,7 +3809,7 @@
                 <a:spcPts val="0"/>
               </a:spcBef>
               <a:spcAft>
-                <a:spcPts val="100"/>
+                <a:spcPts val="200"/>
               </a:spcAft>
             </a:pPr>
             <a:r>
@@ -3940,7 +3941,7 @@
                 <a:spcPts val="0"/>
               </a:spcBef>
               <a:spcAft>
-                <a:spcPts val="100"/>
+                <a:spcPts val="200"/>
               </a:spcAft>
             </a:pPr>
             <a:r>
@@ -3959,7 +3960,7 @@
                 <a:spcPts val="0"/>
               </a:spcBef>
               <a:spcAft>
-                <a:spcPts val="100"/>
+                <a:spcPts val="200"/>
               </a:spcAft>
             </a:pPr>
             <a:r>
@@ -4357,7 +4358,7 @@
                 <a:spcPts val="0"/>
               </a:spcBef>
               <a:spcAft>
-                <a:spcPts val="100"/>
+                <a:spcPts val="200"/>
               </a:spcAft>
             </a:pPr>
             <a:r>
@@ -4376,7 +4377,7 @@
                 <a:spcPts val="0"/>
               </a:spcBef>
               <a:spcAft>
-                <a:spcPts val="100"/>
+                <a:spcPts val="200"/>
               </a:spcAft>
             </a:pPr>
             <a:r>
@@ -4508,7 +4509,7 @@
                 <a:spcPts val="0"/>
               </a:spcBef>
               <a:spcAft>
-                <a:spcPts val="100"/>
+                <a:spcPts val="200"/>
               </a:spcAft>
             </a:pPr>
             <a:r>
@@ -4527,7 +4528,7 @@
                 <a:spcPts val="0"/>
               </a:spcBef>
               <a:spcAft>
-                <a:spcPts val="100"/>
+                <a:spcPts val="200"/>
               </a:spcAft>
             </a:pPr>
             <a:r>
@@ -4659,7 +4660,7 @@
                 <a:spcPts val="0"/>
               </a:spcBef>
               <a:spcAft>
-                <a:spcPts val="100"/>
+                <a:spcPts val="200"/>
               </a:spcAft>
             </a:pPr>
             <a:r>
@@ -4678,7 +4679,7 @@
                 <a:spcPts val="0"/>
               </a:spcBef>
               <a:spcAft>
-                <a:spcPts val="100"/>
+                <a:spcPts val="200"/>
               </a:spcAft>
             </a:pPr>
             <a:r>
@@ -5020,13 +5021,13 @@
           <a:p>
             <a:pPr algn="l"/>
             <a:r>
-              <a:rPr sz="1400" b="1">
+              <a:rPr sz="1300" b="1">
                 <a:solidFill>
                   <a:srgbClr val="2DD4BF"/>
                 </a:solidFill>
                 <a:latin typeface="Calibri"/>
               </a:rPr>
-              <a:t>3   LedgeRX Product Engine</a:t>
+              <a:t>3   LedgeRX Product Engine   =   Reward System</a:t>
             </a:r>
           </a:p>
         </p:txBody>
@@ -5183,7 +5184,7 @@
                 <a:spcPts val="0"/>
               </a:spcBef>
               <a:spcAft>
-                <a:spcPts val="100"/>
+                <a:spcPts val="200"/>
               </a:spcAft>
             </a:pPr>
             <a:r>
@@ -5202,7 +5203,7 @@
                 <a:spcPts val="0"/>
               </a:spcBef>
               <a:spcAft>
-                <a:spcPts val="100"/>
+                <a:spcPts val="200"/>
               </a:spcAft>
             </a:pPr>
             <a:r>
@@ -5334,7 +5335,7 @@
                 <a:spcPts val="0"/>
               </a:spcBef>
               <a:spcAft>
-                <a:spcPts val="100"/>
+                <a:spcPts val="200"/>
               </a:spcAft>
             </a:pPr>
             <a:r>
@@ -5353,7 +5354,7 @@
                 <a:spcPts val="0"/>
               </a:spcBef>
               <a:spcAft>
-                <a:spcPts val="100"/>
+                <a:spcPts val="200"/>
               </a:spcAft>
             </a:pPr>
             <a:r>
@@ -5485,7 +5486,7 @@
                 <a:spcPts val="0"/>
               </a:spcBef>
               <a:spcAft>
-                <a:spcPts val="100"/>
+                <a:spcPts val="200"/>
               </a:spcAft>
             </a:pPr>
             <a:r>
@@ -5504,7 +5505,7 @@
                 <a:spcPts val="0"/>
               </a:spcBef>
               <a:spcAft>
-                <a:spcPts val="100"/>
+                <a:spcPts val="200"/>
               </a:spcAft>
             </a:pPr>
             <a:r>
@@ -5636,7 +5637,7 @@
                 <a:spcPts val="0"/>
               </a:spcBef>
               <a:spcAft>
-                <a:spcPts val="100"/>
+                <a:spcPts val="200"/>
               </a:spcAft>
             </a:pPr>
             <a:r>
@@ -5655,7 +5656,7 @@
                 <a:spcPts val="0"/>
               </a:spcBef>
               <a:spcAft>
-                <a:spcPts val="100"/>
+                <a:spcPts val="200"/>
               </a:spcAft>
             </a:pPr>
             <a:r>
@@ -5787,7 +5788,7 @@
                 <a:spcPts val="0"/>
               </a:spcBef>
               <a:spcAft>
-                <a:spcPts val="100"/>
+                <a:spcPts val="200"/>
               </a:spcAft>
             </a:pPr>
             <a:r>
@@ -5806,7 +5807,7 @@
                 <a:spcPts val="0"/>
               </a:spcBef>
               <a:spcAft>
-                <a:spcPts val="100"/>
+                <a:spcPts val="200"/>
               </a:spcAft>
             </a:pPr>
             <a:r>
@@ -5938,7 +5939,7 @@
                 <a:spcPts val="0"/>
               </a:spcBef>
               <a:spcAft>
-                <a:spcPts val="100"/>
+                <a:spcPts val="200"/>
               </a:spcAft>
             </a:pPr>
             <a:r>
@@ -5957,7 +5958,7 @@
                 <a:spcPts val="0"/>
               </a:spcBef>
               <a:spcAft>
-                <a:spcPts val="100"/>
+                <a:spcPts val="200"/>
               </a:spcAft>
             </a:pPr>
             <a:r>
@@ -6084,8 +6085,8 @@
                 </a:solidFill>
                 <a:latin typeface="Calibri"/>
               </a:rPr>
-              <a:t>Ops configures once in Admin  ·  Upstream only calls use-case codes via SDK
-One engine to buy — not N custom ledgers per channel</a:t>
+              <a:t>UA “Reward System”: points ledger · redemption rules · reward redemption
+Ops configures once  ·  Upstream calls use-case codes via SDK only</a:t>
             </a:r>
           </a:p>
         </p:txBody>
@@ -6489,7 +6490,7 @@
                 <a:spcPts val="0"/>
               </a:spcBef>
               <a:spcAft>
-                <a:spcPts val="100"/>
+                <a:spcPts val="200"/>
               </a:spcAft>
             </a:pPr>
             <a:r>
@@ -6508,7 +6509,7 @@
                 <a:spcPts val="0"/>
               </a:spcBef>
               <a:spcAft>
-                <a:spcPts val="100"/>
+                <a:spcPts val="200"/>
               </a:spcAft>
             </a:pPr>
             <a:r>
@@ -6640,7 +6641,7 @@
                 <a:spcPts val="0"/>
               </a:spcBef>
               <a:spcAft>
-                <a:spcPts val="100"/>
+                <a:spcPts val="200"/>
               </a:spcAft>
             </a:pPr>
             <a:r>
@@ -6659,7 +6660,7 @@
                 <a:spcPts val="0"/>
               </a:spcBef>
               <a:spcAft>
-                <a:spcPts val="100"/>
+                <a:spcPts val="200"/>
               </a:spcAft>
             </a:pPr>
             <a:r>
@@ -6791,7 +6792,7 @@
                 <a:spcPts val="0"/>
               </a:spcBef>
               <a:spcAft>
-                <a:spcPts val="100"/>
+                <a:spcPts val="200"/>
               </a:spcAft>
             </a:pPr>
             <a:r>
@@ -6810,7 +6811,7 @@
                 <a:spcPts val="0"/>
               </a:spcBef>
               <a:spcAft>
-                <a:spcPts val="100"/>
+                <a:spcPts val="200"/>
               </a:spcAft>
             </a:pPr>
             <a:r>
@@ -6827,43 +6828,7 @@
       </p:sp>
       <p:sp>
         <p:nvSpPr>
-          <p:cNvPr id="84" name="TextBox 83"/>
-          <p:cNvSpPr txBox="1"/>
-          <p:nvPr/>
-        </p:nvSpPr>
-        <p:spPr>
-          <a:xfrm>
-            <a:off x="8660977" y="5257800"/>
-            <a:ext cx="1270364" cy="457200"/>
-          </a:xfrm>
-          <a:prstGeom prst="rect">
-            <a:avLst/>
-          </a:prstGeom>
-          <a:noFill/>
-        </p:spPr>
-        <p:txBody>
-          <a:bodyPr wrap="square">
-            <a:spAutoFit/>
-          </a:bodyPr>
-          <a:lstStyle/>
-          <a:p>
-            <a:pPr algn="l"/>
-            <a:r>
-              <a:rPr sz="1000" b="0">
-                <a:solidFill>
-                  <a:srgbClr val="64748B"/>
-                </a:solidFill>
-                <a:latin typeface="Calibri"/>
-              </a:rPr>
-              <a:t>Plugs into
-Product Edge</a:t>
-            </a:r>
-          </a:p>
-        </p:txBody>
-      </p:sp>
-      <p:sp>
-        <p:nvSpPr>
-          <p:cNvPr id="85" name="Right Arrow 84"/>
+          <p:cNvPr id="84" name="Right Arrow 83"/>
           <p:cNvSpPr/>
           <p:nvPr/>
         </p:nvSpPr>
@@ -6906,7 +6871,7 @@
       </p:sp>
       <p:sp>
         <p:nvSpPr>
-          <p:cNvPr id="86" name="Right Arrow 85"/>
+          <p:cNvPr id="85" name="Right Arrow 84"/>
           <p:cNvSpPr/>
           <p:nvPr/>
         </p:nvSpPr>
@@ -6949,7 +6914,7 @@
       </p:sp>
       <p:sp>
         <p:nvSpPr>
-          <p:cNvPr id="87" name="Rounded Rectangle 86"/>
+          <p:cNvPr id="86" name="Rounded Rectangle 85"/>
           <p:cNvSpPr/>
           <p:nvPr/>
         </p:nvSpPr>
@@ -6996,7 +6961,7 @@
       </p:sp>
       <p:sp>
         <p:nvSpPr>
-          <p:cNvPr id="88" name="Oval 87"/>
+          <p:cNvPr id="87" name="Oval 86"/>
           <p:cNvSpPr/>
           <p:nvPr/>
         </p:nvSpPr>
@@ -7039,7 +7004,7 @@
       </p:sp>
       <p:sp>
         <p:nvSpPr>
-          <p:cNvPr id="89" name="TextBox 88"/>
+          <p:cNvPr id="88" name="TextBox 87"/>
           <p:cNvSpPr txBox="1"/>
           <p:nvPr/>
         </p:nvSpPr>
@@ -7074,7 +7039,7 @@
       </p:sp>
       <p:sp>
         <p:nvSpPr>
-          <p:cNvPr id="90" name="TextBox 89"/>
+          <p:cNvPr id="89" name="TextBox 88"/>
           <p:cNvSpPr txBox="1"/>
           <p:nvPr/>
         </p:nvSpPr>
@@ -7109,7 +7074,7 @@
       </p:sp>
       <p:sp>
         <p:nvSpPr>
-          <p:cNvPr id="91" name="TextBox 90"/>
+          <p:cNvPr id="90" name="TextBox 89"/>
           <p:cNvSpPr txBox="1"/>
           <p:nvPr/>
         </p:nvSpPr>
@@ -7131,26 +7096,26 @@
           <a:p>
             <a:pPr algn="l"/>
             <a:r>
-              <a:rPr sz="1000" b="0">
-                <a:solidFill>
-                  <a:srgbClr val="64748B"/>
+              <a:rPr sz="1100" b="1">
+                <a:solidFill>
+                  <a:srgbClr val="C4B5FD"/>
                 </a:solidFill>
                 <a:latin typeface="Calibri"/>
               </a:rPr>
-              <a:t>Downstream results</a:t>
-            </a:r>
-          </a:p>
-        </p:txBody>
-      </p:sp>
-      <p:sp>
-        <p:nvSpPr>
-          <p:cNvPr id="92" name="Rounded Rectangle 91"/>
+              <a:t>→ UAF CBP</a:t>
+            </a:r>
+          </a:p>
+        </p:txBody>
+      </p:sp>
+      <p:sp>
+        <p:nvSpPr>
+          <p:cNvPr id="91" name="Rounded Rectangle 90"/>
           <p:cNvSpPr/>
           <p:nvPr/>
         </p:nvSpPr>
         <p:spPr>
           <a:xfrm>
-            <a:off x="10351965" y="1783080"/>
+            <a:off x="10351965" y="1828800"/>
             <a:ext cx="1382527" cy="777240"/>
           </a:xfrm>
           <a:prstGeom prst="roundRect">
@@ -7191,13 +7156,13 @@
       </p:sp>
       <p:sp>
         <p:nvSpPr>
-          <p:cNvPr id="93" name="Rectangle 92"/>
+          <p:cNvPr id="92" name="Rectangle 91"/>
           <p:cNvSpPr/>
           <p:nvPr/>
         </p:nvSpPr>
         <p:spPr>
           <a:xfrm>
-            <a:off x="10351965" y="1874520"/>
+            <a:off x="10351965" y="1920240"/>
             <a:ext cx="50292" cy="594360"/>
           </a:xfrm>
           <a:prstGeom prst="rect">
@@ -7234,13 +7199,13 @@
       </p:sp>
       <p:sp>
         <p:nvSpPr>
-          <p:cNvPr id="94" name="TextBox 93"/>
+          <p:cNvPr id="93" name="TextBox 92"/>
           <p:cNvSpPr txBox="1"/>
           <p:nvPr/>
         </p:nvSpPr>
         <p:spPr>
           <a:xfrm>
-            <a:off x="10498269" y="1892808"/>
+            <a:off x="10498269" y="1938528"/>
             <a:ext cx="1144783" cy="612648"/>
           </a:xfrm>
           <a:prstGeom prst="rect">
@@ -7259,7 +7224,7 @@
                 <a:spcPts val="0"/>
               </a:spcBef>
               <a:spcAft>
-                <a:spcPts val="100"/>
+                <a:spcPts val="200"/>
               </a:spcAft>
             </a:pPr>
             <a:r>
@@ -7278,7 +7243,7 @@
                 <a:spcPts val="0"/>
               </a:spcBef>
               <a:spcAft>
-                <a:spcPts val="100"/>
+                <a:spcPts val="200"/>
               </a:spcAft>
             </a:pPr>
             <a:r>
@@ -7295,13 +7260,13 @@
       </p:sp>
       <p:sp>
         <p:nvSpPr>
-          <p:cNvPr id="95" name="Rounded Rectangle 94"/>
+          <p:cNvPr id="94" name="Rounded Rectangle 93"/>
           <p:cNvSpPr/>
           <p:nvPr/>
         </p:nvSpPr>
         <p:spPr>
           <a:xfrm>
-            <a:off x="10351965" y="2651760"/>
+            <a:off x="10351965" y="2697480"/>
             <a:ext cx="1382527" cy="777240"/>
           </a:xfrm>
           <a:prstGeom prst="roundRect">
@@ -7342,13 +7307,13 @@
       </p:sp>
       <p:sp>
         <p:nvSpPr>
-          <p:cNvPr id="96" name="Rectangle 95"/>
+          <p:cNvPr id="95" name="Rectangle 94"/>
           <p:cNvSpPr/>
           <p:nvPr/>
         </p:nvSpPr>
         <p:spPr>
           <a:xfrm>
-            <a:off x="10351965" y="2743200"/>
+            <a:off x="10351965" y="2788920"/>
             <a:ext cx="50292" cy="594360"/>
           </a:xfrm>
           <a:prstGeom prst="rect">
@@ -7385,13 +7350,13 @@
       </p:sp>
       <p:sp>
         <p:nvSpPr>
-          <p:cNvPr id="97" name="TextBox 96"/>
+          <p:cNvPr id="96" name="TextBox 95"/>
           <p:cNvSpPr txBox="1"/>
           <p:nvPr/>
         </p:nvSpPr>
         <p:spPr>
           <a:xfrm>
-            <a:off x="10498269" y="2761488"/>
+            <a:off x="10498269" y="2807208"/>
             <a:ext cx="1144783" cy="612648"/>
           </a:xfrm>
           <a:prstGeom prst="rect">
@@ -7410,7 +7375,7 @@
                 <a:spcPts val="0"/>
               </a:spcBef>
               <a:spcAft>
-                <a:spcPts val="100"/>
+                <a:spcPts val="200"/>
               </a:spcAft>
             </a:pPr>
             <a:r>
@@ -7429,7 +7394,7 @@
                 <a:spcPts val="0"/>
               </a:spcBef>
               <a:spcAft>
-                <a:spcPts val="100"/>
+                <a:spcPts val="200"/>
               </a:spcAft>
             </a:pPr>
             <a:r>
@@ -7446,13 +7411,13 @@
       </p:sp>
       <p:sp>
         <p:nvSpPr>
-          <p:cNvPr id="98" name="Rounded Rectangle 97"/>
+          <p:cNvPr id="97" name="Rounded Rectangle 96"/>
           <p:cNvSpPr/>
           <p:nvPr/>
         </p:nvSpPr>
         <p:spPr>
           <a:xfrm>
-            <a:off x="10351965" y="3520440"/>
+            <a:off x="10351965" y="3566160"/>
             <a:ext cx="1382527" cy="777240"/>
           </a:xfrm>
           <a:prstGeom prst="roundRect">
@@ -7493,13 +7458,13 @@
       </p:sp>
       <p:sp>
         <p:nvSpPr>
-          <p:cNvPr id="99" name="Rectangle 98"/>
+          <p:cNvPr id="98" name="Rectangle 97"/>
           <p:cNvSpPr/>
           <p:nvPr/>
         </p:nvSpPr>
         <p:spPr>
           <a:xfrm>
-            <a:off x="10351965" y="3611880"/>
+            <a:off x="10351965" y="3657600"/>
             <a:ext cx="50292" cy="594360"/>
           </a:xfrm>
           <a:prstGeom prst="rect">
@@ -7536,13 +7501,13 @@
       </p:sp>
       <p:sp>
         <p:nvSpPr>
-          <p:cNvPr id="100" name="TextBox 99"/>
+          <p:cNvPr id="99" name="TextBox 98"/>
           <p:cNvSpPr txBox="1"/>
           <p:nvPr/>
         </p:nvSpPr>
         <p:spPr>
           <a:xfrm>
-            <a:off x="10498269" y="3630168"/>
+            <a:off x="10498269" y="3675888"/>
             <a:ext cx="1144783" cy="612648"/>
           </a:xfrm>
           <a:prstGeom prst="rect">
@@ -7561,7 +7526,7 @@
                 <a:spcPts val="0"/>
               </a:spcBef>
               <a:spcAft>
-                <a:spcPts val="100"/>
+                <a:spcPts val="200"/>
               </a:spcAft>
             </a:pPr>
             <a:r>
@@ -7580,7 +7545,7 @@
                 <a:spcPts val="0"/>
               </a:spcBef>
               <a:spcAft>
-                <a:spcPts val="100"/>
+                <a:spcPts val="200"/>
               </a:spcAft>
             </a:pPr>
             <a:r>
@@ -7597,13 +7562,13 @@
       </p:sp>
       <p:sp>
         <p:nvSpPr>
-          <p:cNvPr id="101" name="Rounded Rectangle 100"/>
+          <p:cNvPr id="100" name="Rounded Rectangle 99"/>
           <p:cNvSpPr/>
           <p:nvPr/>
         </p:nvSpPr>
         <p:spPr>
           <a:xfrm>
-            <a:off x="10351965" y="4389119"/>
+            <a:off x="10351965" y="4434839"/>
             <a:ext cx="1382527" cy="777240"/>
           </a:xfrm>
           <a:prstGeom prst="roundRect">
@@ -7644,13 +7609,13 @@
       </p:sp>
       <p:sp>
         <p:nvSpPr>
-          <p:cNvPr id="102" name="Rectangle 101"/>
+          <p:cNvPr id="101" name="Rectangle 100"/>
           <p:cNvSpPr/>
           <p:nvPr/>
         </p:nvSpPr>
         <p:spPr>
           <a:xfrm>
-            <a:off x="10351965" y="4480559"/>
+            <a:off x="10351965" y="4526279"/>
             <a:ext cx="50292" cy="594360"/>
           </a:xfrm>
           <a:prstGeom prst="rect">
@@ -7687,13 +7652,13 @@
       </p:sp>
       <p:sp>
         <p:nvSpPr>
-          <p:cNvPr id="103" name="TextBox 102"/>
+          <p:cNvPr id="102" name="TextBox 101"/>
           <p:cNvSpPr txBox="1"/>
           <p:nvPr/>
         </p:nvSpPr>
         <p:spPr>
           <a:xfrm>
-            <a:off x="10498269" y="4498847"/>
+            <a:off x="10498269" y="4544567"/>
             <a:ext cx="1144783" cy="612648"/>
           </a:xfrm>
           <a:prstGeom prst="rect">
@@ -7712,7 +7677,7 @@
                 <a:spcPts val="0"/>
               </a:spcBef>
               <a:spcAft>
-                <a:spcPts val="100"/>
+                <a:spcPts val="200"/>
               </a:spcAft>
             </a:pPr>
             <a:r>
@@ -7731,7 +7696,7 @@
                 <a:spcPts val="0"/>
               </a:spcBef>
               <a:spcAft>
-                <a:spcPts val="100"/>
+                <a:spcPts val="200"/>
               </a:spcAft>
             </a:pPr>
             <a:r>
@@ -7748,42 +7713,7 @@
       </p:sp>
       <p:sp>
         <p:nvSpPr>
-          <p:cNvPr id="104" name="TextBox 103"/>
-          <p:cNvSpPr txBox="1"/>
-          <p:nvPr/>
-        </p:nvSpPr>
-        <p:spPr>
-          <a:xfrm>
-            <a:off x="10351965" y="5440680"/>
-            <a:ext cx="1400815" cy="320040"/>
-          </a:xfrm>
-          <a:prstGeom prst="rect">
-            <a:avLst/>
-          </a:prstGeom>
-          <a:noFill/>
-        </p:spPr>
-        <p:txBody>
-          <a:bodyPr wrap="square">
-            <a:spAutoFit/>
-          </a:bodyPr>
-          <a:lstStyle/>
-          <a:p>
-            <a:pPr algn="l"/>
-            <a:r>
-              <a:rPr sz="900" b="0">
-                <a:solidFill>
-                  <a:srgbClr val="64748B"/>
-                </a:solidFill>
-                <a:latin typeface="Calibri"/>
-              </a:rPr>
-              <a:t>Kafka / webhooks</a:t>
-            </a:r>
-          </a:p>
-        </p:txBody>
-      </p:sp>
-      <p:sp>
-        <p:nvSpPr>
-          <p:cNvPr id="105" name="Rounded Rectangle 104"/>
+          <p:cNvPr id="103" name="Rounded Rectangle 102"/>
           <p:cNvSpPr/>
           <p:nvPr/>
         </p:nvSpPr>
@@ -7830,7 +7760,7 @@
       </p:sp>
       <p:sp>
         <p:nvSpPr>
-          <p:cNvPr id="106" name="Oval 105"/>
+          <p:cNvPr id="104" name="Oval 103"/>
           <p:cNvSpPr/>
           <p:nvPr/>
         </p:nvSpPr>
@@ -7873,7 +7803,7 @@
       </p:sp>
       <p:sp>
         <p:nvSpPr>
-          <p:cNvPr id="107" name="Oval 106"/>
+          <p:cNvPr id="105" name="Oval 104"/>
           <p:cNvSpPr/>
           <p:nvPr/>
         </p:nvSpPr>
@@ -7916,7 +7846,7 @@
       </p:sp>
       <p:sp>
         <p:nvSpPr>
-          <p:cNvPr id="108" name="Oval 107"/>
+          <p:cNvPr id="106" name="Oval 105"/>
           <p:cNvSpPr/>
           <p:nvPr/>
         </p:nvSpPr>
@@ -7959,7 +7889,7 @@
       </p:sp>
       <p:sp>
         <p:nvSpPr>
-          <p:cNvPr id="109" name="Oval 108"/>
+          <p:cNvPr id="107" name="Oval 106"/>
           <p:cNvSpPr/>
           <p:nvPr/>
         </p:nvSpPr>
@@ -8002,7 +7932,7 @@
       </p:sp>
       <p:sp>
         <p:nvSpPr>
-          <p:cNvPr id="110" name="Oval 109"/>
+          <p:cNvPr id="108" name="Oval 107"/>
           <p:cNvSpPr/>
           <p:nvPr/>
         </p:nvSpPr>
@@ -8045,14 +7975,14 @@
       </p:sp>
       <p:sp>
         <p:nvSpPr>
-          <p:cNvPr id="111" name="TextBox 110"/>
+          <p:cNvPr id="109" name="TextBox 108"/>
           <p:cNvSpPr txBox="1"/>
           <p:nvPr/>
         </p:nvSpPr>
         <p:spPr>
           <a:xfrm>
             <a:off x="1783080" y="6236208"/>
-            <a:ext cx="8412480" cy="320040"/>
+            <a:ext cx="8229600" cy="320040"/>
           </a:xfrm>
           <a:prstGeom prst="rect">
             <a:avLst/>
@@ -8073,14 +8003,14 @@
                 </a:solidFill>
                 <a:latin typeface="Calibri"/>
               </a:rPr>
-              <a:t>LedgeRX = one powerful product engine   ·   multi-channel via SDK   ·   ops-configured catalog   ·   outbound landing</a:t>
-            </a:r>
-          </a:p>
-        </p:txBody>
-      </p:sp>
-      <p:sp>
-        <p:nvSpPr>
-          <p:cNvPr id="112" name="TextBox 111"/>
+              <a:t>LedgeRX = Reward System     ·     Landing = UAF CBP (slide 2)     ·     multi-channel via SDK</a:t>
+            </a:r>
+          </a:p>
+        </p:txBody>
+      </p:sp>
+      <p:sp>
+        <p:nvSpPr>
+          <p:cNvPr id="110" name="TextBox 109"/>
           <p:cNvSpPr txBox="1"/>
           <p:nvPr/>
         </p:nvSpPr>
@@ -8109,6 +8039,1613 @@
                 <a:latin typeface="Calibri"/>
               </a:rPr>
               <a:t>Confidential</a:t>
+            </a:r>
+          </a:p>
+        </p:txBody>
+      </p:sp>
+    </p:spTree>
+  </p:cSld>
+  <p:clrMapOvr>
+    <a:masterClrMapping/>
+  </p:clrMapOvr>
+</p:sld>
+</file>
+
+<file path=ppt/slides/slide2.xml><?xml version="1.0" encoding="utf-8"?>
+<p:sld xmlns:a="http://schemas.openxmlformats.org/drawingml/2006/main" xmlns:p="http://schemas.openxmlformats.org/presentationml/2006/main" xmlns:r="http://schemas.openxmlformats.org/officeDocument/2006/relationships">
+  <p:cSld>
+    <p:spTree>
+      <p:nvGrpSpPr>
+        <p:cNvPr id="1" name=""/>
+        <p:cNvGrpSpPr/>
+        <p:nvPr/>
+      </p:nvGrpSpPr>
+      <p:grpSpPr/>
+      <p:sp>
+        <p:nvSpPr>
+          <p:cNvPr id="2" name="Rectangle 1"/>
+          <p:cNvSpPr/>
+          <p:nvPr/>
+        </p:nvSpPr>
+        <p:spPr>
+          <a:xfrm>
+            <a:off x="0" y="0"/>
+            <a:ext cx="12191695" cy="6858000"/>
+          </a:xfrm>
+          <a:prstGeom prst="rect">
+            <a:avLst/>
+          </a:prstGeom>
+          <a:solidFill>
+            <a:srgbClr val="0B1220"/>
+          </a:solidFill>
+          <a:ln>
+            <a:noFill/>
+          </a:ln>
+        </p:spPr>
+        <p:style>
+          <a:lnRef idx="1">
+            <a:schemeClr val="accent1"/>
+          </a:lnRef>
+          <a:fillRef idx="3">
+            <a:schemeClr val="accent1"/>
+          </a:fillRef>
+          <a:effectRef idx="2">
+            <a:schemeClr val="accent1"/>
+          </a:effectRef>
+          <a:fontRef idx="minor">
+            <a:schemeClr val="lt1"/>
+          </a:fontRef>
+        </p:style>
+        <p:txBody>
+          <a:bodyPr rtlCol="0" anchor="ctr"/>
+          <a:lstStyle/>
+          <a:p>
+            <a:pPr algn="ctr"/>
+          </a:p>
+        </p:txBody>
+      </p:sp>
+      <p:sp>
+        <p:nvSpPr>
+          <p:cNvPr id="3" name="Rectangle 2"/>
+          <p:cNvSpPr/>
+          <p:nvPr/>
+        </p:nvSpPr>
+        <p:spPr>
+          <a:xfrm>
+            <a:off x="0" y="0"/>
+            <a:ext cx="12191695" cy="45720"/>
+          </a:xfrm>
+          <a:prstGeom prst="rect">
+            <a:avLst/>
+          </a:prstGeom>
+          <a:solidFill>
+            <a:srgbClr val="14B8A6"/>
+          </a:solidFill>
+          <a:ln>
+            <a:noFill/>
+          </a:ln>
+        </p:spPr>
+        <p:style>
+          <a:lnRef idx="1">
+            <a:schemeClr val="accent1"/>
+          </a:lnRef>
+          <a:fillRef idx="3">
+            <a:schemeClr val="accent1"/>
+          </a:fillRef>
+          <a:effectRef idx="2">
+            <a:schemeClr val="accent1"/>
+          </a:effectRef>
+          <a:fontRef idx="minor">
+            <a:schemeClr val="lt1"/>
+          </a:fontRef>
+        </p:style>
+        <p:txBody>
+          <a:bodyPr rtlCol="0" anchor="ctr"/>
+          <a:lstStyle/>
+          <a:p>
+            <a:pPr algn="ctr"/>
+          </a:p>
+        </p:txBody>
+      </p:sp>
+      <p:sp>
+        <p:nvSpPr>
+          <p:cNvPr id="4" name="TextBox 3"/>
+          <p:cNvSpPr txBox="1"/>
+          <p:nvPr/>
+        </p:nvSpPr>
+        <p:spPr>
+          <a:xfrm>
+            <a:off x="365760" y="146304"/>
+            <a:ext cx="9144000" cy="310896"/>
+          </a:xfrm>
+          <a:prstGeom prst="rect">
+            <a:avLst/>
+          </a:prstGeom>
+          <a:noFill/>
+        </p:spPr>
+        <p:txBody>
+          <a:bodyPr wrap="square">
+            <a:spAutoFit/>
+          </a:bodyPr>
+          <a:lstStyle/>
+          <a:p>
+            <a:pPr algn="l"/>
+            <a:r>
+              <a:rPr sz="2400" b="1">
+                <a:solidFill>
+                  <a:srgbClr val="F8FAFC"/>
+                </a:solidFill>
+                <a:latin typeface="Calibri"/>
+              </a:rPr>
+              <a:t>After Landing  ·  What UAF handles</a:t>
+            </a:r>
+          </a:p>
+        </p:txBody>
+      </p:sp>
+      <p:sp>
+        <p:nvSpPr>
+          <p:cNvPr id="5" name="TextBox 4"/>
+          <p:cNvSpPr txBox="1"/>
+          <p:nvPr/>
+        </p:nvSpPr>
+        <p:spPr>
+          <a:xfrm>
+            <a:off x="365760" y="438912"/>
+            <a:ext cx="9144000" cy="256032"/>
+          </a:xfrm>
+          <a:prstGeom prst="rect">
+            <a:avLst/>
+          </a:prstGeom>
+          <a:noFill/>
+        </p:spPr>
+        <p:txBody>
+          <a:bodyPr wrap="square">
+            <a:spAutoFit/>
+          </a:bodyPr>
+          <a:lstStyle/>
+          <a:p>
+            <a:pPr algn="l"/>
+            <a:r>
+              <a:rPr sz="1200" b="0">
+                <a:solidFill>
+                  <a:srgbClr val="94A3B8"/>
+                </a:solidFill>
+                <a:latin typeface="Calibri"/>
+              </a:rPr>
+              <a:t>Boundary of responsibility  ·  LedgeRX stops at reward outcomes  ·  UAF owns coupon platform &amp; partners</a:t>
+            </a:r>
+          </a:p>
+        </p:txBody>
+      </p:sp>
+      <p:sp>
+        <p:nvSpPr>
+          <p:cNvPr id="6" name="Rounded Rectangle 5"/>
+          <p:cNvSpPr/>
+          <p:nvPr/>
+        </p:nvSpPr>
+        <p:spPr>
+          <a:xfrm>
+            <a:off x="10241280" y="164592"/>
+            <a:ext cx="1554480" cy="365760"/>
+          </a:xfrm>
+          <a:prstGeom prst="roundRect">
+            <a:avLst>
+              <a:gd name="adj" fmla="val 15000"/>
+            </a:avLst>
+          </a:prstGeom>
+          <a:solidFill>
+            <a:srgbClr val="102A48"/>
+          </a:solidFill>
+          <a:ln w="12700">
+            <a:solidFill>
+              <a:srgbClr val="14B8A6"/>
+            </a:solidFill>
+          </a:ln>
+        </p:spPr>
+        <p:style>
+          <a:lnRef idx="1">
+            <a:schemeClr val="accent1"/>
+          </a:lnRef>
+          <a:fillRef idx="3">
+            <a:schemeClr val="accent1"/>
+          </a:fillRef>
+          <a:effectRef idx="2">
+            <a:schemeClr val="accent1"/>
+          </a:effectRef>
+          <a:fontRef idx="minor">
+            <a:schemeClr val="lt1"/>
+          </a:fontRef>
+        </p:style>
+        <p:txBody>
+          <a:bodyPr rtlCol="0" anchor="ctr"/>
+          <a:lstStyle/>
+          <a:p>
+            <a:pPr algn="ctr"/>
+          </a:p>
+        </p:txBody>
+      </p:sp>
+      <p:sp>
+        <p:nvSpPr>
+          <p:cNvPr id="7" name="TextBox 6"/>
+          <p:cNvSpPr txBox="1"/>
+          <p:nvPr/>
+        </p:nvSpPr>
+        <p:spPr>
+          <a:xfrm>
+            <a:off x="10241280" y="219456"/>
+            <a:ext cx="1554480" cy="274320"/>
+          </a:xfrm>
+          <a:prstGeom prst="rect">
+            <a:avLst/>
+          </a:prstGeom>
+          <a:noFill/>
+        </p:spPr>
+        <p:txBody>
+          <a:bodyPr wrap="square">
+            <a:spAutoFit/>
+          </a:bodyPr>
+          <a:lstStyle/>
+          <a:p>
+            <a:pPr algn="ctr"/>
+            <a:r>
+              <a:rPr sz="1100" b="1">
+                <a:solidFill>
+                  <a:srgbClr val="2DD4BF"/>
+                </a:solidFill>
+                <a:latin typeface="Calibri"/>
+              </a:rPr>
+              <a:t>CTO  ·  2 / 2</a:t>
+            </a:r>
+          </a:p>
+        </p:txBody>
+      </p:sp>
+      <p:sp>
+        <p:nvSpPr>
+          <p:cNvPr id="8" name="Rounded Rectangle 7"/>
+          <p:cNvSpPr/>
+          <p:nvPr/>
+        </p:nvSpPr>
+        <p:spPr>
+          <a:xfrm>
+            <a:off x="365760" y="822960"/>
+            <a:ext cx="5577840" cy="777240"/>
+          </a:xfrm>
+          <a:prstGeom prst="roundRect">
+            <a:avLst>
+              <a:gd name="adj" fmla="val 10000"/>
+            </a:avLst>
+          </a:prstGeom>
+          <a:solidFill>
+            <a:srgbClr val="0A282A"/>
+          </a:solidFill>
+          <a:ln w="17145">
+            <a:solidFill>
+              <a:srgbClr val="2DD4BF"/>
+            </a:solidFill>
+          </a:ln>
+        </p:spPr>
+        <p:style>
+          <a:lnRef idx="1">
+            <a:schemeClr val="accent1"/>
+          </a:lnRef>
+          <a:fillRef idx="3">
+            <a:schemeClr val="accent1"/>
+          </a:fillRef>
+          <a:effectRef idx="2">
+            <a:schemeClr val="accent1"/>
+          </a:effectRef>
+          <a:fontRef idx="minor">
+            <a:schemeClr val="lt1"/>
+          </a:fontRef>
+        </p:style>
+        <p:txBody>
+          <a:bodyPr rtlCol="0" anchor="ctr"/>
+          <a:lstStyle/>
+          <a:p>
+            <a:pPr algn="ctr"/>
+          </a:p>
+        </p:txBody>
+      </p:sp>
+      <p:sp>
+        <p:nvSpPr>
+          <p:cNvPr id="9" name="TextBox 8"/>
+          <p:cNvSpPr txBox="1"/>
+          <p:nvPr/>
+        </p:nvSpPr>
+        <p:spPr>
+          <a:xfrm>
+            <a:off x="502920" y="896112"/>
+            <a:ext cx="5303520" cy="256032"/>
+          </a:xfrm>
+          <a:prstGeom prst="rect">
+            <a:avLst/>
+          </a:prstGeom>
+          <a:noFill/>
+        </p:spPr>
+        <p:txBody>
+          <a:bodyPr wrap="square">
+            <a:spAutoFit/>
+          </a:bodyPr>
+          <a:lstStyle/>
+          <a:p>
+            <a:pPr algn="l"/>
+            <a:r>
+              <a:rPr sz="1500" b="1">
+                <a:solidFill>
+                  <a:srgbClr val="2DD4BF"/>
+                </a:solidFill>
+                <a:latin typeface="Calibri"/>
+              </a:rPr>
+              <a:t>LedgeRX  =  Reward System</a:t>
+            </a:r>
+          </a:p>
+        </p:txBody>
+      </p:sp>
+      <p:sp>
+        <p:nvSpPr>
+          <p:cNvPr id="10" name="TextBox 9"/>
+          <p:cNvSpPr txBox="1"/>
+          <p:nvPr/>
+        </p:nvSpPr>
+        <p:spPr>
+          <a:xfrm>
+            <a:off x="502920" y="1207008"/>
+            <a:ext cx="5303520" cy="274320"/>
+          </a:xfrm>
+          <a:prstGeom prst="rect">
+            <a:avLst/>
+          </a:prstGeom>
+          <a:noFill/>
+        </p:spPr>
+        <p:txBody>
+          <a:bodyPr wrap="square">
+            <a:spAutoFit/>
+          </a:bodyPr>
+          <a:lstStyle/>
+          <a:p>
+            <a:pPr algn="l"/>
+            <a:r>
+              <a:rPr sz="1200" b="0">
+                <a:solidFill>
+                  <a:srgbClr val="CBD5E1"/>
+                </a:solidFill>
+                <a:latin typeface="Calibri"/>
+              </a:rPr>
+              <a:t>Points ledger · redemption rules · reward redemption</a:t>
+            </a:r>
+          </a:p>
+        </p:txBody>
+      </p:sp>
+      <p:sp>
+        <p:nvSpPr>
+          <p:cNvPr id="11" name="Rounded Rectangle 10"/>
+          <p:cNvSpPr/>
+          <p:nvPr/>
+        </p:nvSpPr>
+        <p:spPr>
+          <a:xfrm>
+            <a:off x="6126480" y="822960"/>
+            <a:ext cx="5669280" cy="777240"/>
+          </a:xfrm>
+          <a:prstGeom prst="roundRect">
+            <a:avLst>
+              <a:gd name="adj" fmla="val 10000"/>
+            </a:avLst>
+          </a:prstGeom>
+          <a:solidFill>
+            <a:srgbClr val="0A2F24"/>
+          </a:solidFill>
+          <a:ln w="17145">
+            <a:solidFill>
+              <a:srgbClr val="6EE7B7"/>
+            </a:solidFill>
+          </a:ln>
+        </p:spPr>
+        <p:style>
+          <a:lnRef idx="1">
+            <a:schemeClr val="accent1"/>
+          </a:lnRef>
+          <a:fillRef idx="3">
+            <a:schemeClr val="accent1"/>
+          </a:fillRef>
+          <a:effectRef idx="2">
+            <a:schemeClr val="accent1"/>
+          </a:effectRef>
+          <a:fontRef idx="minor">
+            <a:schemeClr val="lt1"/>
+          </a:fontRef>
+        </p:style>
+        <p:txBody>
+          <a:bodyPr rtlCol="0" anchor="ctr"/>
+          <a:lstStyle/>
+          <a:p>
+            <a:pPr algn="ctr"/>
+          </a:p>
+        </p:txBody>
+      </p:sp>
+      <p:sp>
+        <p:nvSpPr>
+          <p:cNvPr id="12" name="TextBox 11"/>
+          <p:cNvSpPr txBox="1"/>
+          <p:nvPr/>
+        </p:nvSpPr>
+        <p:spPr>
+          <a:xfrm>
+            <a:off x="6309360" y="896112"/>
+            <a:ext cx="5303520" cy="256032"/>
+          </a:xfrm>
+          <a:prstGeom prst="rect">
+            <a:avLst/>
+          </a:prstGeom>
+          <a:noFill/>
+        </p:spPr>
+        <p:txBody>
+          <a:bodyPr wrap="square">
+            <a:spAutoFit/>
+          </a:bodyPr>
+          <a:lstStyle/>
+          <a:p>
+            <a:pPr algn="l"/>
+            <a:r>
+              <a:rPr sz="1500" b="1">
+                <a:solidFill>
+                  <a:srgbClr val="6EE7B7"/>
+                </a:solidFill>
+                <a:latin typeface="Calibri"/>
+              </a:rPr>
+              <a:t>Landing Edge  =  CBP (green box)</a:t>
+            </a:r>
+          </a:p>
+        </p:txBody>
+      </p:sp>
+      <p:sp>
+        <p:nvSpPr>
+          <p:cNvPr id="13" name="TextBox 12"/>
+          <p:cNvSpPr txBox="1"/>
+          <p:nvPr/>
+        </p:nvSpPr>
+        <p:spPr>
+          <a:xfrm>
+            <a:off x="6309360" y="1207008"/>
+            <a:ext cx="5303520" cy="274320"/>
+          </a:xfrm>
+          <a:prstGeom prst="rect">
+            <a:avLst/>
+          </a:prstGeom>
+          <a:noFill/>
+        </p:spPr>
+        <p:txBody>
+          <a:bodyPr wrap="square">
+            <a:spAutoFit/>
+          </a:bodyPr>
+          <a:lstStyle/>
+          <a:p>
+            <a:pPr algn="l"/>
+            <a:r>
+              <a:rPr sz="1200" b="0">
+                <a:solidFill>
+                  <a:srgbClr val="CBD5E1"/>
+                </a:solidFill>
+                <a:latin typeface="Calibri"/>
+              </a:rPr>
+              <a:t>E-coupon inventory · issue / redeem · track usage</a:t>
+            </a:r>
+          </a:p>
+        </p:txBody>
+      </p:sp>
+      <p:sp>
+        <p:nvSpPr>
+          <p:cNvPr id="14" name="Rounded Rectangle 13"/>
+          <p:cNvSpPr/>
+          <p:nvPr/>
+        </p:nvSpPr>
+        <p:spPr>
+          <a:xfrm>
+            <a:off x="365760" y="1828800"/>
+            <a:ext cx="3657600" cy="3977639"/>
+          </a:xfrm>
+          <a:prstGeom prst="roundRect">
+            <a:avLst>
+              <a:gd name="adj" fmla="val 7000"/>
+            </a:avLst>
+          </a:prstGeom>
+          <a:solidFill>
+            <a:srgbClr val="0A282A"/>
+          </a:solidFill>
+          <a:ln w="22225">
+            <a:solidFill>
+              <a:srgbClr val="2DD4BF"/>
+            </a:solidFill>
+          </a:ln>
+        </p:spPr>
+        <p:style>
+          <a:lnRef idx="1">
+            <a:schemeClr val="accent1"/>
+          </a:lnRef>
+          <a:fillRef idx="3">
+            <a:schemeClr val="accent1"/>
+          </a:fillRef>
+          <a:effectRef idx="2">
+            <a:schemeClr val="accent1"/>
+          </a:effectRef>
+          <a:fontRef idx="minor">
+            <a:schemeClr val="lt1"/>
+          </a:fontRef>
+        </p:style>
+        <p:txBody>
+          <a:bodyPr rtlCol="0" anchor="ctr"/>
+          <a:lstStyle/>
+          <a:p>
+            <a:pPr algn="ctr"/>
+          </a:p>
+        </p:txBody>
+      </p:sp>
+      <p:sp>
+        <p:nvSpPr>
+          <p:cNvPr id="15" name="TextBox 14"/>
+          <p:cNvSpPr txBox="1"/>
+          <p:nvPr/>
+        </p:nvSpPr>
+        <p:spPr>
+          <a:xfrm>
+            <a:off x="502920" y="1965960"/>
+            <a:ext cx="3383280" cy="274320"/>
+          </a:xfrm>
+          <a:prstGeom prst="rect">
+            <a:avLst/>
+          </a:prstGeom>
+          <a:noFill/>
+        </p:spPr>
+        <p:txBody>
+          <a:bodyPr wrap="square">
+            <a:spAutoFit/>
+          </a:bodyPr>
+          <a:lstStyle/>
+          <a:p>
+            <a:pPr algn="l"/>
+            <a:r>
+              <a:rPr sz="1300" b="1">
+                <a:solidFill>
+                  <a:srgbClr val="2DD4BF"/>
+                </a:solidFill>
+                <a:latin typeface="Calibri"/>
+              </a:rPr>
+              <a:t>Owned by LedgeRX</a:t>
+            </a:r>
+          </a:p>
+        </p:txBody>
+      </p:sp>
+      <p:sp>
+        <p:nvSpPr>
+          <p:cNvPr id="16" name="TextBox 15"/>
+          <p:cNvSpPr txBox="1"/>
+          <p:nvPr/>
+        </p:nvSpPr>
+        <p:spPr>
+          <a:xfrm>
+            <a:off x="502920" y="2331720"/>
+            <a:ext cx="3383280" cy="3200400"/>
+          </a:xfrm>
+          <a:prstGeom prst="rect">
+            <a:avLst/>
+          </a:prstGeom>
+          <a:noFill/>
+        </p:spPr>
+        <p:txBody>
+          <a:bodyPr wrap="square">
+            <a:spAutoFit/>
+          </a:bodyPr>
+          <a:lstStyle/>
+          <a:p>
+            <a:pPr algn="l">
+              <a:spcBef>
+                <a:spcPts val="0"/>
+              </a:spcBef>
+              <a:spcAft>
+                <a:spcPts val="200"/>
+              </a:spcAft>
+            </a:pPr>
+            <a:r>
+              <a:rPr sz="1300" b="1">
+                <a:solidFill>
+                  <a:srgbClr val="F8FAFC"/>
+                </a:solidFill>
+                <a:latin typeface="Calibri"/>
+              </a:rPr>
+              <a:t>Customer wallet &amp; balances</a:t>
+            </a:r>
+          </a:p>
+          <a:p>
+            <a:pPr algn="l">
+              <a:spcBef>
+                <a:spcPts val="0"/>
+              </a:spcBef>
+              <a:spcAft>
+                <a:spcPts val="200"/>
+              </a:spcAft>
+            </a:pPr>
+            <a:r>
+              <a:rPr sz="1200" b="0">
+                <a:solidFill>
+                  <a:srgbClr val="CBD5E1"/>
+                </a:solidFill>
+                <a:latin typeface="Calibri"/>
+              </a:rPr>
+              <a:t>Earn / burn / hold points</a:t>
+            </a:r>
+          </a:p>
+          <a:p>
+            <a:pPr algn="l">
+              <a:spcBef>
+                <a:spcPts val="0"/>
+              </a:spcBef>
+              <a:spcAft>
+                <a:spcPts val="200"/>
+              </a:spcAft>
+            </a:pPr>
+            <a:r>
+              <a:rPr sz="1200" b="0">
+                <a:solidFill>
+                  <a:srgbClr val="CBD5E1"/>
+                </a:solidFill>
+                <a:latin typeface="Calibri"/>
+              </a:rPr>
+              <a:t>Use-case catalog &amp; COA</a:t>
+            </a:r>
+          </a:p>
+          <a:p>
+            <a:pPr algn="l">
+              <a:spcBef>
+                <a:spcPts val="0"/>
+              </a:spcBef>
+              <a:spcAft>
+                <a:spcPts val="200"/>
+              </a:spcAft>
+            </a:pPr>
+            <a:r>
+              <a:rPr sz="1200" b="0">
+                <a:solidFill>
+                  <a:srgbClr val="CBD5E1"/>
+                </a:solidFill>
+                <a:latin typeface="Calibri"/>
+              </a:rPr>
+              <a:t>Calculation formulas (Brain)</a:t>
+            </a:r>
+          </a:p>
+          <a:p>
+            <a:pPr algn="l">
+              <a:spcBef>
+                <a:spcPts val="0"/>
+              </a:spcBef>
+              <a:spcAft>
+                <a:spcPts val="200"/>
+              </a:spcAft>
+            </a:pPr>
+            <a:r>
+              <a:rPr sz="1200" b="0">
+                <a:solidFill>
+                  <a:srgbClr val="CBD5E1"/>
+                </a:solidFill>
+                <a:latin typeface="Calibri"/>
+              </a:rPr>
+              <a:t>Posting &amp; double-entry books</a:t>
+            </a:r>
+          </a:p>
+          <a:p>
+            <a:pPr algn="l">
+              <a:spcBef>
+                <a:spcPts val="0"/>
+              </a:spcBef>
+              <a:spcAft>
+                <a:spcPts val="200"/>
+              </a:spcAft>
+            </a:pPr>
+            <a:r>
+              <a:rPr sz="1200" b="1">
+                <a:solidFill>
+                  <a:srgbClr val="F8FAFC"/>
+                </a:solidFill>
+                <a:latin typeface="Calibri"/>
+              </a:rPr>
+              <a:t>Outbound event:</a:t>
+            </a:r>
+          </a:p>
+          <a:p>
+            <a:pPr algn="l">
+              <a:spcBef>
+                <a:spcPts val="0"/>
+              </a:spcBef>
+              <a:spcAft>
+                <a:spcPts val="200"/>
+              </a:spcAft>
+            </a:pPr>
+            <a:r>
+              <a:rPr sz="1200" b="0">
+                <a:solidFill>
+                  <a:srgbClr val="2DD4BF"/>
+                </a:solidFill>
+                <a:latin typeface="Calibri"/>
+              </a:rPr>
+              <a:t>  ledger.balance.updated</a:t>
+            </a:r>
+          </a:p>
+          <a:p>
+            <a:pPr algn="l">
+              <a:spcBef>
+                <a:spcPts val="0"/>
+              </a:spcBef>
+              <a:spcAft>
+                <a:spcPts val="200"/>
+              </a:spcAft>
+            </a:pPr>
+            <a:r>
+              <a:rPr sz="1200" b="0">
+                <a:solidFill>
+                  <a:srgbClr val="2DD4BF"/>
+                </a:solidFill>
+                <a:latin typeface="Calibri"/>
+              </a:rPr>
+              <a:t>  reward redemption request</a:t>
+            </a:r>
+          </a:p>
+          <a:p>
+            <a:pPr algn="l">
+              <a:spcBef>
+                <a:spcPts val="0"/>
+              </a:spcBef>
+              <a:spcAft>
+                <a:spcPts val="200"/>
+              </a:spcAft>
+            </a:pPr>
+            <a:r>
+              <a:rPr sz="800" b="0">
+                <a:solidFill>
+                  <a:srgbClr val="64748B"/>
+                </a:solidFill>
+                <a:latin typeface="Calibri"/>
+              </a:rPr>
+              <a:t/>
+            </a:r>
+          </a:p>
+          <a:p>
+            <a:pPr algn="l">
+              <a:spcBef>
+                <a:spcPts val="0"/>
+              </a:spcBef>
+              <a:spcAft>
+                <a:spcPts val="200"/>
+              </a:spcAft>
+            </a:pPr>
+            <a:r>
+              <a:rPr sz="1100" b="0">
+                <a:solidFill>
+                  <a:srgbClr val="64748B"/>
+                </a:solidFill>
+                <a:latin typeface="Calibri"/>
+              </a:rPr>
+              <a:t>Does NOT own e-coupon stock,</a:t>
+            </a:r>
+          </a:p>
+          <a:p>
+            <a:pPr algn="l">
+              <a:spcBef>
+                <a:spcPts val="0"/>
+              </a:spcBef>
+              <a:spcAft>
+                <a:spcPts val="200"/>
+              </a:spcAft>
+            </a:pPr>
+            <a:r>
+              <a:rPr sz="1100" b="0">
+                <a:solidFill>
+                  <a:srgbClr val="64748B"/>
+                </a:solidFill>
+                <a:latin typeface="Calibri"/>
+              </a:rPr>
+              <a:t>partner settlement, or COD rails</a:t>
+            </a:r>
+          </a:p>
+        </p:txBody>
+      </p:sp>
+      <p:sp>
+        <p:nvSpPr>
+          <p:cNvPr id="17" name="Right Arrow 16"/>
+          <p:cNvSpPr/>
+          <p:nvPr/>
+        </p:nvSpPr>
+        <p:spPr>
+          <a:xfrm>
+            <a:off x="4160520" y="3566160"/>
+            <a:ext cx="320040" cy="201168"/>
+          </a:xfrm>
+          <a:prstGeom prst="rightArrow">
+            <a:avLst/>
+          </a:prstGeom>
+          <a:solidFill>
+            <a:srgbClr val="2DD4BF"/>
+          </a:solidFill>
+          <a:ln>
+            <a:noFill/>
+          </a:ln>
+        </p:spPr>
+        <p:style>
+          <a:lnRef idx="1">
+            <a:schemeClr val="accent1"/>
+          </a:lnRef>
+          <a:fillRef idx="3">
+            <a:schemeClr val="accent1"/>
+          </a:fillRef>
+          <a:effectRef idx="2">
+            <a:schemeClr val="accent1"/>
+          </a:effectRef>
+          <a:fontRef idx="minor">
+            <a:schemeClr val="lt1"/>
+          </a:fontRef>
+        </p:style>
+        <p:txBody>
+          <a:bodyPr rtlCol="0" anchor="ctr"/>
+          <a:lstStyle/>
+          <a:p>
+            <a:pPr algn="ctr"/>
+          </a:p>
+        </p:txBody>
+      </p:sp>
+      <p:sp>
+        <p:nvSpPr>
+          <p:cNvPr id="18" name="TextBox 17"/>
+          <p:cNvSpPr txBox="1"/>
+          <p:nvPr/>
+        </p:nvSpPr>
+        <p:spPr>
+          <a:xfrm>
+            <a:off x="4023360" y="3840480"/>
+            <a:ext cx="640080" cy="457200"/>
+          </a:xfrm>
+          <a:prstGeom prst="rect">
+            <a:avLst/>
+          </a:prstGeom>
+          <a:noFill/>
+        </p:spPr>
+        <p:txBody>
+          <a:bodyPr wrap="square">
+            <a:spAutoFit/>
+          </a:bodyPr>
+          <a:lstStyle/>
+          <a:p>
+            <a:pPr algn="ctr"/>
+            <a:r>
+              <a:rPr sz="1000" b="0">
+                <a:solidFill>
+                  <a:srgbClr val="2DD4BF"/>
+                </a:solidFill>
+                <a:latin typeface="Calibri"/>
+              </a:rPr>
+              <a:t>event /
+API</a:t>
+            </a:r>
+          </a:p>
+        </p:txBody>
+      </p:sp>
+      <p:sp>
+        <p:nvSpPr>
+          <p:cNvPr id="19" name="Rounded Rectangle 18"/>
+          <p:cNvSpPr/>
+          <p:nvPr/>
+        </p:nvSpPr>
+        <p:spPr>
+          <a:xfrm>
+            <a:off x="4709160" y="1828800"/>
+            <a:ext cx="7086600" cy="777240"/>
+          </a:xfrm>
+          <a:prstGeom prst="roundRect">
+            <a:avLst>
+              <a:gd name="adj" fmla="val 10000"/>
+            </a:avLst>
+          </a:prstGeom>
+          <a:solidFill>
+            <a:srgbClr val="0C2340"/>
+          </a:solidFill>
+          <a:ln w="15240">
+            <a:solidFill>
+              <a:srgbClr val="38BDF8"/>
+            </a:solidFill>
+          </a:ln>
+        </p:spPr>
+        <p:style>
+          <a:lnRef idx="1">
+            <a:schemeClr val="accent1"/>
+          </a:lnRef>
+          <a:fillRef idx="3">
+            <a:schemeClr val="accent1"/>
+          </a:fillRef>
+          <a:effectRef idx="2">
+            <a:schemeClr val="accent1"/>
+          </a:effectRef>
+          <a:fontRef idx="minor">
+            <a:schemeClr val="lt1"/>
+          </a:fontRef>
+        </p:style>
+        <p:txBody>
+          <a:bodyPr rtlCol="0" anchor="ctr"/>
+          <a:lstStyle/>
+          <a:p>
+            <a:pPr algn="ctr"/>
+          </a:p>
+        </p:txBody>
+      </p:sp>
+      <p:sp>
+        <p:nvSpPr>
+          <p:cNvPr id="20" name="TextBox 19"/>
+          <p:cNvSpPr txBox="1"/>
+          <p:nvPr/>
+        </p:nvSpPr>
+        <p:spPr>
+          <a:xfrm>
+            <a:off x="4846320" y="1901952"/>
+            <a:ext cx="6766560" cy="228600"/>
+          </a:xfrm>
+          <a:prstGeom prst="rect">
+            <a:avLst/>
+          </a:prstGeom>
+          <a:noFill/>
+        </p:spPr>
+        <p:txBody>
+          <a:bodyPr wrap="square">
+            <a:spAutoFit/>
+          </a:bodyPr>
+          <a:lstStyle/>
+          <a:p>
+            <a:pPr algn="l"/>
+            <a:r>
+              <a:rPr sz="1100" b="1">
+                <a:solidFill>
+                  <a:srgbClr val="38BDF8"/>
+                </a:solidFill>
+                <a:latin typeface="Calibri"/>
+              </a:rPr>
+              <a:t>UAF channels (unchanged)</a:t>
+            </a:r>
+          </a:p>
+        </p:txBody>
+      </p:sp>
+      <p:sp>
+        <p:nvSpPr>
+          <p:cNvPr id="21" name="TextBox 20"/>
+          <p:cNvSpPr txBox="1"/>
+          <p:nvPr/>
+        </p:nvSpPr>
+        <p:spPr>
+          <a:xfrm>
+            <a:off x="4846320" y="2194560"/>
+            <a:ext cx="6766560" cy="274320"/>
+          </a:xfrm>
+          <a:prstGeom prst="rect">
+            <a:avLst/>
+          </a:prstGeom>
+          <a:noFill/>
+        </p:spPr>
+        <p:txBody>
+          <a:bodyPr wrap="square">
+            <a:spAutoFit/>
+          </a:bodyPr>
+          <a:lstStyle/>
+          <a:p>
+            <a:pPr algn="l"/>
+            <a:r>
+              <a:rPr sz="1300" b="0">
+                <a:solidFill>
+                  <a:srgbClr val="F8FAFC"/>
+                </a:solidFill>
+                <a:latin typeface="Calibri"/>
+              </a:rPr>
+              <a:t>Yes UA (Mobile App)    ·    aim (Mobile App)    ·    Branch Loan System</a:t>
+            </a:r>
+          </a:p>
+        </p:txBody>
+      </p:sp>
+      <p:sp>
+        <p:nvSpPr>
+          <p:cNvPr id="22" name="Down Arrow 21"/>
+          <p:cNvSpPr/>
+          <p:nvPr/>
+        </p:nvSpPr>
+        <p:spPr>
+          <a:xfrm>
+            <a:off x="8092440" y="2651760"/>
+            <a:ext cx="146304" cy="182880"/>
+          </a:xfrm>
+          <a:prstGeom prst="downArrow">
+            <a:avLst/>
+          </a:prstGeom>
+          <a:solidFill>
+            <a:srgbClr val="2DD4BF"/>
+          </a:solidFill>
+          <a:ln>
+            <a:noFill/>
+          </a:ln>
+        </p:spPr>
+        <p:style>
+          <a:lnRef idx="1">
+            <a:schemeClr val="accent1"/>
+          </a:lnRef>
+          <a:fillRef idx="3">
+            <a:schemeClr val="accent1"/>
+          </a:fillRef>
+          <a:effectRef idx="2">
+            <a:schemeClr val="accent1"/>
+          </a:effectRef>
+          <a:fontRef idx="minor">
+            <a:schemeClr val="lt1"/>
+          </a:fontRef>
+        </p:style>
+        <p:txBody>
+          <a:bodyPr rtlCol="0" anchor="ctr"/>
+          <a:lstStyle/>
+          <a:p>
+            <a:pPr algn="ctr"/>
+          </a:p>
+        </p:txBody>
+      </p:sp>
+      <p:sp>
+        <p:nvSpPr>
+          <p:cNvPr id="23" name="Rounded Rectangle 22"/>
+          <p:cNvSpPr/>
+          <p:nvPr/>
+        </p:nvSpPr>
+        <p:spPr>
+          <a:xfrm>
+            <a:off x="4709160" y="2880360"/>
+            <a:ext cx="7086600" cy="640080"/>
+          </a:xfrm>
+          <a:prstGeom prst="roundRect">
+            <a:avLst>
+              <a:gd name="adj" fmla="val 10000"/>
+            </a:avLst>
+          </a:prstGeom>
+          <a:solidFill>
+            <a:srgbClr val="0A282A"/>
+          </a:solidFill>
+          <a:ln w="15240">
+            <a:solidFill>
+              <a:srgbClr val="2DD4BF"/>
+            </a:solidFill>
+          </a:ln>
+        </p:spPr>
+        <p:style>
+          <a:lnRef idx="1">
+            <a:schemeClr val="accent1"/>
+          </a:lnRef>
+          <a:fillRef idx="3">
+            <a:schemeClr val="accent1"/>
+          </a:fillRef>
+          <a:effectRef idx="2">
+            <a:schemeClr val="accent1"/>
+          </a:effectRef>
+          <a:fontRef idx="minor">
+            <a:schemeClr val="lt1"/>
+          </a:fontRef>
+        </p:style>
+        <p:txBody>
+          <a:bodyPr rtlCol="0" anchor="ctr"/>
+          <a:lstStyle/>
+          <a:p>
+            <a:pPr algn="ctr"/>
+          </a:p>
+        </p:txBody>
+      </p:sp>
+      <p:sp>
+        <p:nvSpPr>
+          <p:cNvPr id="24" name="TextBox 23"/>
+          <p:cNvSpPr txBox="1"/>
+          <p:nvPr/>
+        </p:nvSpPr>
+        <p:spPr>
+          <a:xfrm>
+            <a:off x="4846320" y="2971800"/>
+            <a:ext cx="6766560" cy="228600"/>
+          </a:xfrm>
+          <a:prstGeom prst="rect">
+            <a:avLst/>
+          </a:prstGeom>
+          <a:noFill/>
+        </p:spPr>
+        <p:txBody>
+          <a:bodyPr wrap="square">
+            <a:spAutoFit/>
+          </a:bodyPr>
+          <a:lstStyle/>
+          <a:p>
+            <a:pPr algn="l"/>
+            <a:r>
+              <a:rPr sz="1300" b="1">
+                <a:solidFill>
+                  <a:srgbClr val="2DD4BF"/>
+                </a:solidFill>
+                <a:latin typeface="Calibri"/>
+              </a:rPr>
+              <a:t>LedgeRX  (= Reward System)  —  you buy this</a:t>
+            </a:r>
+          </a:p>
+        </p:txBody>
+      </p:sp>
+      <p:sp>
+        <p:nvSpPr>
+          <p:cNvPr id="25" name="TextBox 24"/>
+          <p:cNvSpPr txBox="1"/>
+          <p:nvPr/>
+        </p:nvSpPr>
+        <p:spPr>
+          <a:xfrm>
+            <a:off x="4846320" y="3218688"/>
+            <a:ext cx="6766560" cy="228600"/>
+          </a:xfrm>
+          <a:prstGeom prst="rect">
+            <a:avLst/>
+          </a:prstGeom>
+          <a:noFill/>
+        </p:spPr>
+        <p:txBody>
+          <a:bodyPr wrap="square">
+            <a:spAutoFit/>
+          </a:bodyPr>
+          <a:lstStyle/>
+          <a:p>
+            <a:pPr algn="l"/>
+            <a:r>
+              <a:rPr sz="1100" b="0">
+                <a:solidFill>
+                  <a:srgbClr val="CBD5E1"/>
+                </a:solidFill>
+                <a:latin typeface="Calibri"/>
+              </a:rPr>
+              <a:t>request e-coupon / redemption outcome  →  Landing</a:t>
+            </a:r>
+          </a:p>
+        </p:txBody>
+      </p:sp>
+      <p:sp>
+        <p:nvSpPr>
+          <p:cNvPr id="26" name="Down Arrow 25"/>
+          <p:cNvSpPr/>
+          <p:nvPr/>
+        </p:nvSpPr>
+        <p:spPr>
+          <a:xfrm>
+            <a:off x="8092440" y="3566160"/>
+            <a:ext cx="146304" cy="182880"/>
+          </a:xfrm>
+          <a:prstGeom prst="downArrow">
+            <a:avLst/>
+          </a:prstGeom>
+          <a:solidFill>
+            <a:srgbClr val="6EE7B7"/>
+          </a:solidFill>
+          <a:ln>
+            <a:noFill/>
+          </a:ln>
+        </p:spPr>
+        <p:style>
+          <a:lnRef idx="1">
+            <a:schemeClr val="accent1"/>
+          </a:lnRef>
+          <a:fillRef idx="3">
+            <a:schemeClr val="accent1"/>
+          </a:fillRef>
+          <a:effectRef idx="2">
+            <a:schemeClr val="accent1"/>
+          </a:effectRef>
+          <a:fontRef idx="minor">
+            <a:schemeClr val="lt1"/>
+          </a:fontRef>
+        </p:style>
+        <p:txBody>
+          <a:bodyPr rtlCol="0" anchor="ctr"/>
+          <a:lstStyle/>
+          <a:p>
+            <a:pPr algn="ctr"/>
+          </a:p>
+        </p:txBody>
+      </p:sp>
+      <p:sp>
+        <p:nvSpPr>
+          <p:cNvPr id="27" name="Rounded Rectangle 26"/>
+          <p:cNvSpPr/>
+          <p:nvPr/>
+        </p:nvSpPr>
+        <p:spPr>
+          <a:xfrm>
+            <a:off x="4709160" y="3794760"/>
+            <a:ext cx="7086600" cy="1234440"/>
+          </a:xfrm>
+          <a:prstGeom prst="roundRect">
+            <a:avLst>
+              <a:gd name="adj" fmla="val 8000"/>
+            </a:avLst>
+          </a:prstGeom>
+          <a:solidFill>
+            <a:srgbClr val="0A2F24"/>
+          </a:solidFill>
+          <a:ln w="25400">
+            <a:solidFill>
+              <a:srgbClr val="6EE7B7"/>
+            </a:solidFill>
+          </a:ln>
+        </p:spPr>
+        <p:style>
+          <a:lnRef idx="1">
+            <a:schemeClr val="accent1"/>
+          </a:lnRef>
+          <a:fillRef idx="3">
+            <a:schemeClr val="accent1"/>
+          </a:fillRef>
+          <a:effectRef idx="2">
+            <a:schemeClr val="accent1"/>
+          </a:effectRef>
+          <a:fontRef idx="minor">
+            <a:schemeClr val="lt1"/>
+          </a:fontRef>
+        </p:style>
+        <p:txBody>
+          <a:bodyPr rtlCol="0" anchor="ctr"/>
+          <a:lstStyle/>
+          <a:p>
+            <a:pPr algn="ctr"/>
+          </a:p>
+        </p:txBody>
+      </p:sp>
+      <p:sp>
+        <p:nvSpPr>
+          <p:cNvPr id="28" name="TextBox 27"/>
+          <p:cNvSpPr txBox="1"/>
+          <p:nvPr/>
+        </p:nvSpPr>
+        <p:spPr>
+          <a:xfrm>
+            <a:off x="4892040" y="3886200"/>
+            <a:ext cx="6766560" cy="256032"/>
+          </a:xfrm>
+          <a:prstGeom prst="rect">
+            <a:avLst/>
+          </a:prstGeom>
+          <a:noFill/>
+        </p:spPr>
+        <p:txBody>
+          <a:bodyPr wrap="square">
+            <a:spAutoFit/>
+          </a:bodyPr>
+          <a:lstStyle/>
+          <a:p>
+            <a:pPr algn="l"/>
+            <a:r>
+              <a:rPr sz="1400" b="1">
+                <a:solidFill>
+                  <a:srgbClr val="6EE7B7"/>
+                </a:solidFill>
+                <a:latin typeface="Calibri"/>
+              </a:rPr>
+              <a:t>UAF owns  ·  Centralized Backend Platform (CBP)  =  Landing Edge</a:t>
+            </a:r>
+          </a:p>
+        </p:txBody>
+      </p:sp>
+      <p:sp>
+        <p:nvSpPr>
+          <p:cNvPr id="29" name="TextBox 28"/>
+          <p:cNvSpPr txBox="1"/>
+          <p:nvPr/>
+        </p:nvSpPr>
+        <p:spPr>
+          <a:xfrm>
+            <a:off x="4892040" y="4206240"/>
+            <a:ext cx="6766560" cy="731520"/>
+          </a:xfrm>
+          <a:prstGeom prst="rect">
+            <a:avLst/>
+          </a:prstGeom>
+          <a:noFill/>
+        </p:spPr>
+        <p:txBody>
+          <a:bodyPr wrap="square">
+            <a:spAutoFit/>
+          </a:bodyPr>
+          <a:lstStyle/>
+          <a:p>
+            <a:pPr algn="l">
+              <a:spcBef>
+                <a:spcPts val="0"/>
+              </a:spcBef>
+              <a:spcAft>
+                <a:spcPts val="200"/>
+              </a:spcAft>
+            </a:pPr>
+            <a:r>
+              <a:rPr sz="1200" b="0">
+                <a:solidFill>
+                  <a:srgbClr val="F8FAFC"/>
+                </a:solidFill>
+                <a:latin typeface="Calibri"/>
+              </a:rPr>
+              <a:t>• E-coupon inventory management</a:t>
+            </a:r>
+          </a:p>
+          <a:p>
+            <a:pPr algn="l">
+              <a:spcBef>
+                <a:spcPts val="0"/>
+              </a:spcBef>
+              <a:spcAft>
+                <a:spcPts val="200"/>
+              </a:spcAft>
+            </a:pPr>
+            <a:r>
+              <a:rPr sz="1200" b="0">
+                <a:solidFill>
+                  <a:srgbClr val="F8FAFC"/>
+                </a:solidFill>
+                <a:latin typeface="Calibri"/>
+              </a:rPr>
+              <a:t>• Coupon redemption &amp; issue e-coupons</a:t>
+            </a:r>
+          </a:p>
+          <a:p>
+            <a:pPr algn="l">
+              <a:spcBef>
+                <a:spcPts val="0"/>
+              </a:spcBef>
+              <a:spcAft>
+                <a:spcPts val="200"/>
+              </a:spcAft>
+            </a:pPr>
+            <a:r>
+              <a:rPr sz="1200" b="0">
+                <a:solidFill>
+                  <a:srgbClr val="F8FAFC"/>
+                </a:solidFill>
+                <a:latin typeface="Calibri"/>
+              </a:rPr>
+              <a:t>• Track coupon usage  ·  orchestration after reward outcome</a:t>
+            </a:r>
+          </a:p>
+        </p:txBody>
+      </p:sp>
+      <p:sp>
+        <p:nvSpPr>
+          <p:cNvPr id="30" name="Down Arrow 29"/>
+          <p:cNvSpPr/>
+          <p:nvPr/>
+        </p:nvSpPr>
+        <p:spPr>
+          <a:xfrm>
+            <a:off x="8092440" y="5074920"/>
+            <a:ext cx="146304" cy="182880"/>
+          </a:xfrm>
+          <a:prstGeom prst="downArrow">
+            <a:avLst/>
+          </a:prstGeom>
+          <a:solidFill>
+            <a:srgbClr val="F9A8D4"/>
+          </a:solidFill>
+          <a:ln>
+            <a:noFill/>
+          </a:ln>
+        </p:spPr>
+        <p:style>
+          <a:lnRef idx="1">
+            <a:schemeClr val="accent1"/>
+          </a:lnRef>
+          <a:fillRef idx="3">
+            <a:schemeClr val="accent1"/>
+          </a:fillRef>
+          <a:effectRef idx="2">
+            <a:schemeClr val="accent1"/>
+          </a:effectRef>
+          <a:fontRef idx="minor">
+            <a:schemeClr val="lt1"/>
+          </a:fontRef>
+        </p:style>
+        <p:txBody>
+          <a:bodyPr rtlCol="0" anchor="ctr"/>
+          <a:lstStyle/>
+          <a:p>
+            <a:pPr algn="ctr"/>
+          </a:p>
+        </p:txBody>
+      </p:sp>
+      <p:sp>
+        <p:nvSpPr>
+          <p:cNvPr id="31" name="Rounded Rectangle 30"/>
+          <p:cNvSpPr/>
+          <p:nvPr/>
+        </p:nvSpPr>
+        <p:spPr>
+          <a:xfrm>
+            <a:off x="4709160" y="5303520"/>
+            <a:ext cx="7086600" cy="685800"/>
+          </a:xfrm>
+          <a:prstGeom prst="roundRect">
+            <a:avLst>
+              <a:gd name="adj" fmla="val 10000"/>
+            </a:avLst>
+          </a:prstGeom>
+          <a:solidFill>
+            <a:srgbClr val="2A1424"/>
+          </a:solidFill>
+          <a:ln w="17145">
+            <a:solidFill>
+              <a:srgbClr val="F9A8D4"/>
+            </a:solidFill>
+          </a:ln>
+        </p:spPr>
+        <p:style>
+          <a:lnRef idx="1">
+            <a:schemeClr val="accent1"/>
+          </a:lnRef>
+          <a:fillRef idx="3">
+            <a:schemeClr val="accent1"/>
+          </a:fillRef>
+          <a:effectRef idx="2">
+            <a:schemeClr val="accent1"/>
+          </a:effectRef>
+          <a:fontRef idx="minor">
+            <a:schemeClr val="lt1"/>
+          </a:fontRef>
+        </p:style>
+        <p:txBody>
+          <a:bodyPr rtlCol="0" anchor="ctr"/>
+          <a:lstStyle/>
+          <a:p>
+            <a:pPr algn="ctr"/>
+          </a:p>
+        </p:txBody>
+      </p:sp>
+      <p:sp>
+        <p:nvSpPr>
+          <p:cNvPr id="32" name="TextBox 31"/>
+          <p:cNvSpPr txBox="1"/>
+          <p:nvPr/>
+        </p:nvSpPr>
+        <p:spPr>
+          <a:xfrm>
+            <a:off x="4892040" y="5376672"/>
+            <a:ext cx="6766560" cy="228600"/>
+          </a:xfrm>
+          <a:prstGeom prst="rect">
+            <a:avLst/>
+          </a:prstGeom>
+          <a:noFill/>
+        </p:spPr>
+        <p:txBody>
+          <a:bodyPr wrap="square">
+            <a:spAutoFit/>
+          </a:bodyPr>
+          <a:lstStyle/>
+          <a:p>
+            <a:pPr algn="l"/>
+            <a:r>
+              <a:rPr sz="1300" b="1">
+                <a:solidFill>
+                  <a:srgbClr val="F9A8D4"/>
+                </a:solidFill>
+                <a:latin typeface="Calibri"/>
+              </a:rPr>
+              <a:t>UAF owns  ·  Coupon Partners</a:t>
+            </a:r>
+          </a:p>
+        </p:txBody>
+      </p:sp>
+      <p:sp>
+        <p:nvSpPr>
+          <p:cNvPr id="33" name="TextBox 32"/>
+          <p:cNvSpPr txBox="1"/>
+          <p:nvPr/>
+        </p:nvSpPr>
+        <p:spPr>
+          <a:xfrm>
+            <a:off x="4892040" y="5650992"/>
+            <a:ext cx="6766560" cy="256032"/>
+          </a:xfrm>
+          <a:prstGeom prst="rect">
+            <a:avLst/>
+          </a:prstGeom>
+          <a:noFill/>
+        </p:spPr>
+        <p:txBody>
+          <a:bodyPr wrap="square">
+            <a:spAutoFit/>
+          </a:bodyPr>
+          <a:lstStyle/>
+          <a:p>
+            <a:pPr algn="l"/>
+            <a:r>
+              <a:rPr sz="1200" b="0">
+                <a:solidFill>
+                  <a:srgbClr val="CBD5E1"/>
+                </a:solidFill>
+                <a:latin typeface="Calibri"/>
+              </a:rPr>
+              <a:t>COD    ·    Other partners (future)</a:t>
+            </a:r>
+          </a:p>
+        </p:txBody>
+      </p:sp>
+      <p:sp>
+        <p:nvSpPr>
+          <p:cNvPr id="34" name="Rounded Rectangle 33"/>
+          <p:cNvSpPr/>
+          <p:nvPr/>
+        </p:nvSpPr>
+        <p:spPr>
+          <a:xfrm>
+            <a:off x="365760" y="6172200"/>
+            <a:ext cx="11460175" cy="457200"/>
+          </a:xfrm>
+          <a:prstGeom prst="roundRect">
+            <a:avLst>
+              <a:gd name="adj" fmla="val 10000"/>
+            </a:avLst>
+          </a:prstGeom>
+          <a:solidFill>
+            <a:srgbClr val="102A48"/>
+          </a:solidFill>
+          <a:ln w="12700">
+            <a:solidFill>
+              <a:srgbClr val="14B8A6"/>
+            </a:solidFill>
+          </a:ln>
+        </p:spPr>
+        <p:style>
+          <a:lnRef idx="1">
+            <a:schemeClr val="accent1"/>
+          </a:lnRef>
+          <a:fillRef idx="3">
+            <a:schemeClr val="accent1"/>
+          </a:fillRef>
+          <a:effectRef idx="2">
+            <a:schemeClr val="accent1"/>
+          </a:effectRef>
+          <a:fontRef idx="minor">
+            <a:schemeClr val="lt1"/>
+          </a:fontRef>
+        </p:style>
+        <p:txBody>
+          <a:bodyPr rtlCol="0" anchor="ctr"/>
+          <a:lstStyle/>
+          <a:p>
+            <a:pPr algn="ctr"/>
+          </a:p>
+        </p:txBody>
+      </p:sp>
+      <p:sp>
+        <p:nvSpPr>
+          <p:cNvPr id="35" name="TextBox 34"/>
+          <p:cNvSpPr txBox="1"/>
+          <p:nvPr/>
+        </p:nvSpPr>
+        <p:spPr>
+          <a:xfrm>
+            <a:off x="502920" y="6263640"/>
+            <a:ext cx="11155680" cy="320040"/>
+          </a:xfrm>
+          <a:prstGeom prst="rect">
+            <a:avLst/>
+          </a:prstGeom>
+          <a:noFill/>
+        </p:spPr>
+        <p:txBody>
+          <a:bodyPr wrap="square">
+            <a:spAutoFit/>
+          </a:bodyPr>
+          <a:lstStyle/>
+          <a:p>
+            <a:pPr algn="l"/>
+            <a:r>
+              <a:rPr sz="1200" b="0">
+                <a:solidFill>
+                  <a:srgbClr val="CBD5E1"/>
+                </a:solidFill>
+                <a:latin typeface="Calibri"/>
+              </a:rPr>
+              <a:t>Clear split:   LedgeRX earns &amp; decides rewards   ·   UAF CBP turns outcomes into coupons / gifts / partner fulfill   ·   Apps stay the same</a:t>
             </a:r>
           </a:p>
         </p:txBody>

</xml_diff>

<commit_message>
docs(decks): slide2 — CBP is one LedgeRX downstream, not a peer system
</commit_message>
<xml_diff>
--- a/docs/decks/LedgeRX-System-Architecture-CTO.pptx
+++ b/docs/decks/LedgeRX-System-Architecture-CTO.pptx
@@ -6085,7 +6085,7 @@
                 </a:solidFill>
                 <a:latin typeface="Calibri"/>
               </a:rPr>
-              <a:t>UA “Reward System”: points ledger · redemption rules · reward redemption
+              <a:t>UA “Reward System”: points ledger · redemption rules · reward outcomes
 Ops configures once  ·  Upstream calls use-case codes via SDK only</a:t>
             </a:r>
           </a:p>
@@ -7096,13 +7096,13 @@
           <a:p>
             <a:pPr algn="l"/>
             <a:r>
-              <a:rPr sz="1100" b="1">
+              <a:rPr sz="1000" b="1">
                 <a:solidFill>
                   <a:srgbClr val="C4B5FD"/>
                 </a:solidFill>
                 <a:latin typeface="Calibri"/>
               </a:rPr>
-              <a:t>→ UAF CBP</a:t>
+              <a:t>Product outlets</a:t>
             </a:r>
           </a:p>
         </p:txBody>
@@ -7234,7 +7234,7 @@
                 </a:solidFill>
                 <a:latin typeface="Calibri"/>
               </a:rPr>
-              <a:t>E-coupon</a:t>
+              <a:t>E-coupon / CBP</a:t>
             </a:r>
           </a:p>
           <a:p>
@@ -7253,7 +7253,7 @@
                 </a:solidFill>
                 <a:latin typeface="Calibri"/>
               </a:rPr>
-              <a:t>Issue · redeem</a:t>
+              <a:t>One downstream</a:t>
             </a:r>
           </a:p>
         </p:txBody>
@@ -8003,7 +8003,7 @@
                 </a:solidFill>
                 <a:latin typeface="Calibri"/>
               </a:rPr>
-              <a:t>LedgeRX = Reward System     ·     Landing = UAF CBP (slide 2)     ·     multi-channel via SDK</a:t>
+              <a:t>LedgeRX = product     ·     Landing = many downstream outlets (CBP is one)     ·     see slide 2</a:t>
             </a:r>
           </a:p>
         </p:txBody>
@@ -8155,8 +8155,8 @@
         </p:nvSpPr>
         <p:spPr>
           <a:xfrm>
-            <a:off x="365760" y="146304"/>
-            <a:ext cx="9144000" cy="310896"/>
+            <a:off x="365760" y="128016"/>
+            <a:ext cx="9601200" cy="292608"/>
           </a:xfrm>
           <a:prstGeom prst="rect">
             <a:avLst/>
@@ -8171,13 +8171,13 @@
           <a:p>
             <a:pPr algn="l"/>
             <a:r>
-              <a:rPr sz="2400" b="1">
+              <a:rPr sz="2200" b="1">
                 <a:solidFill>
                   <a:srgbClr val="F8FAFC"/>
                 </a:solidFill>
                 <a:latin typeface="Calibri"/>
               </a:rPr>
-              <a:t>After Landing  ·  What UAF handles</a:t>
+              <a:t>Landing Edge  ·  Downstream of LedgeRX (our product)</a:t>
             </a:r>
           </a:p>
         </p:txBody>
@@ -8190,8 +8190,8 @@
         </p:nvSpPr>
         <p:spPr>
           <a:xfrm>
-            <a:off x="365760" y="438912"/>
-            <a:ext cx="9144000" cy="256032"/>
+            <a:off x="365760" y="420624"/>
+            <a:ext cx="9601200" cy="256032"/>
           </a:xfrm>
           <a:prstGeom prst="rect">
             <a:avLst/>
@@ -8206,13 +8206,13 @@
           <a:p>
             <a:pPr algn="l"/>
             <a:r>
-              <a:rPr sz="1200" b="0">
+              <a:rPr sz="1300" b="0">
                 <a:solidFill>
                   <a:srgbClr val="94A3B8"/>
                 </a:solidFill>
                 <a:latin typeface="Calibri"/>
               </a:rPr>
-              <a:t>Boundary of responsibility  ·  LedgeRX stops at reward outcomes  ·  UAF owns coupon platform &amp; partners</a:t>
+              <a:t>CBP is not a peer system — it is one consumer of LedgeRX outcomes</a:t>
             </a:r>
           </a:p>
         </p:txBody>
@@ -8225,7 +8225,7 @@
         </p:nvSpPr>
         <p:spPr>
           <a:xfrm>
-            <a:off x="10241280" y="164592"/>
+            <a:off x="10241280" y="146304"/>
             <a:ext cx="1554480" cy="365760"/>
           </a:xfrm>
           <a:prstGeom prst="roundRect">
@@ -8272,7 +8272,7 @@
         </p:nvSpPr>
         <p:spPr>
           <a:xfrm>
-            <a:off x="10241280" y="219456"/>
+            <a:off x="10241280" y="201168"/>
             <a:ext cx="1554480" cy="274320"/>
           </a:xfrm>
           <a:prstGeom prst="rect">
@@ -8307,18 +8307,18 @@
         </p:nvSpPr>
         <p:spPr>
           <a:xfrm>
-            <a:off x="365760" y="822960"/>
-            <a:ext cx="5577840" cy="777240"/>
+            <a:off x="365760" y="804672"/>
+            <a:ext cx="11457432" cy="1234440"/>
           </a:xfrm>
           <a:prstGeom prst="roundRect">
             <a:avLst>
-              <a:gd name="adj" fmla="val 10000"/>
+              <a:gd name="adj" fmla="val 6000"/>
             </a:avLst>
           </a:prstGeom>
           <a:solidFill>
             <a:srgbClr val="0A282A"/>
           </a:solidFill>
-          <a:ln w="17145">
+          <a:ln w="28575">
             <a:solidFill>
               <a:srgbClr val="2DD4BF"/>
             </a:solidFill>
@@ -8348,518 +8348,19 @@
       </p:sp>
       <p:sp>
         <p:nvSpPr>
-          <p:cNvPr id="9" name="TextBox 8"/>
-          <p:cNvSpPr txBox="1"/>
-          <p:nvPr/>
-        </p:nvSpPr>
-        <p:spPr>
-          <a:xfrm>
-            <a:off x="502920" y="896112"/>
-            <a:ext cx="5303520" cy="256032"/>
-          </a:xfrm>
-          <a:prstGeom prst="rect">
-            <a:avLst/>
-          </a:prstGeom>
-          <a:noFill/>
-        </p:spPr>
-        <p:txBody>
-          <a:bodyPr wrap="square">
-            <a:spAutoFit/>
-          </a:bodyPr>
-          <a:lstStyle/>
-          <a:p>
-            <a:pPr algn="l"/>
-            <a:r>
-              <a:rPr sz="1500" b="1">
-                <a:solidFill>
-                  <a:srgbClr val="2DD4BF"/>
-                </a:solidFill>
-                <a:latin typeface="Calibri"/>
-              </a:rPr>
-              <a:t>LedgeRX  =  Reward System</a:t>
-            </a:r>
-          </a:p>
-        </p:txBody>
-      </p:sp>
-      <p:sp>
-        <p:nvSpPr>
-          <p:cNvPr id="10" name="TextBox 9"/>
-          <p:cNvSpPr txBox="1"/>
-          <p:nvPr/>
-        </p:nvSpPr>
-        <p:spPr>
-          <a:xfrm>
-            <a:off x="502920" y="1207008"/>
-            <a:ext cx="5303520" cy="274320"/>
-          </a:xfrm>
-          <a:prstGeom prst="rect">
-            <a:avLst/>
-          </a:prstGeom>
-          <a:noFill/>
-        </p:spPr>
-        <p:txBody>
-          <a:bodyPr wrap="square">
-            <a:spAutoFit/>
-          </a:bodyPr>
-          <a:lstStyle/>
-          <a:p>
-            <a:pPr algn="l"/>
-            <a:r>
-              <a:rPr sz="1200" b="0">
-                <a:solidFill>
-                  <a:srgbClr val="CBD5E1"/>
-                </a:solidFill>
-                <a:latin typeface="Calibri"/>
-              </a:rPr>
-              <a:t>Points ledger · redemption rules · reward redemption</a:t>
-            </a:r>
-          </a:p>
-        </p:txBody>
-      </p:sp>
-      <p:sp>
-        <p:nvSpPr>
-          <p:cNvPr id="11" name="Rounded Rectangle 10"/>
+          <p:cNvPr id="9" name="Rounded Rectangle 8"/>
           <p:cNvSpPr/>
           <p:nvPr/>
         </p:nvSpPr>
         <p:spPr>
           <a:xfrm>
-            <a:off x="6126480" y="822960"/>
-            <a:ext cx="5669280" cy="777240"/>
+            <a:off x="502920" y="914400"/>
+            <a:ext cx="2194560" cy="347472"/>
           </a:xfrm>
           <a:prstGeom prst="roundRect">
             <a:avLst>
-              <a:gd name="adj" fmla="val 10000"/>
+              <a:gd name="adj" fmla="val 8000"/>
             </a:avLst>
-          </a:prstGeom>
-          <a:solidFill>
-            <a:srgbClr val="0A2F24"/>
-          </a:solidFill>
-          <a:ln w="17145">
-            <a:solidFill>
-              <a:srgbClr val="6EE7B7"/>
-            </a:solidFill>
-          </a:ln>
-        </p:spPr>
-        <p:style>
-          <a:lnRef idx="1">
-            <a:schemeClr val="accent1"/>
-          </a:lnRef>
-          <a:fillRef idx="3">
-            <a:schemeClr val="accent1"/>
-          </a:fillRef>
-          <a:effectRef idx="2">
-            <a:schemeClr val="accent1"/>
-          </a:effectRef>
-          <a:fontRef idx="minor">
-            <a:schemeClr val="lt1"/>
-          </a:fontRef>
-        </p:style>
-        <p:txBody>
-          <a:bodyPr rtlCol="0" anchor="ctr"/>
-          <a:lstStyle/>
-          <a:p>
-            <a:pPr algn="ctr"/>
-          </a:p>
-        </p:txBody>
-      </p:sp>
-      <p:sp>
-        <p:nvSpPr>
-          <p:cNvPr id="12" name="TextBox 11"/>
-          <p:cNvSpPr txBox="1"/>
-          <p:nvPr/>
-        </p:nvSpPr>
-        <p:spPr>
-          <a:xfrm>
-            <a:off x="6309360" y="896112"/>
-            <a:ext cx="5303520" cy="256032"/>
-          </a:xfrm>
-          <a:prstGeom prst="rect">
-            <a:avLst/>
-          </a:prstGeom>
-          <a:noFill/>
-        </p:spPr>
-        <p:txBody>
-          <a:bodyPr wrap="square">
-            <a:spAutoFit/>
-          </a:bodyPr>
-          <a:lstStyle/>
-          <a:p>
-            <a:pPr algn="l"/>
-            <a:r>
-              <a:rPr sz="1500" b="1">
-                <a:solidFill>
-                  <a:srgbClr val="6EE7B7"/>
-                </a:solidFill>
-                <a:latin typeface="Calibri"/>
-              </a:rPr>
-              <a:t>Landing Edge  =  CBP (green box)</a:t>
-            </a:r>
-          </a:p>
-        </p:txBody>
-      </p:sp>
-      <p:sp>
-        <p:nvSpPr>
-          <p:cNvPr id="13" name="TextBox 12"/>
-          <p:cNvSpPr txBox="1"/>
-          <p:nvPr/>
-        </p:nvSpPr>
-        <p:spPr>
-          <a:xfrm>
-            <a:off x="6309360" y="1207008"/>
-            <a:ext cx="5303520" cy="274320"/>
-          </a:xfrm>
-          <a:prstGeom prst="rect">
-            <a:avLst/>
-          </a:prstGeom>
-          <a:noFill/>
-        </p:spPr>
-        <p:txBody>
-          <a:bodyPr wrap="square">
-            <a:spAutoFit/>
-          </a:bodyPr>
-          <a:lstStyle/>
-          <a:p>
-            <a:pPr algn="l"/>
-            <a:r>
-              <a:rPr sz="1200" b="0">
-                <a:solidFill>
-                  <a:srgbClr val="CBD5E1"/>
-                </a:solidFill>
-                <a:latin typeface="Calibri"/>
-              </a:rPr>
-              <a:t>E-coupon inventory · issue / redeem · track usage</a:t>
-            </a:r>
-          </a:p>
-        </p:txBody>
-      </p:sp>
-      <p:sp>
-        <p:nvSpPr>
-          <p:cNvPr id="14" name="Rounded Rectangle 13"/>
-          <p:cNvSpPr/>
-          <p:nvPr/>
-        </p:nvSpPr>
-        <p:spPr>
-          <a:xfrm>
-            <a:off x="365760" y="1828800"/>
-            <a:ext cx="3657600" cy="3977639"/>
-          </a:xfrm>
-          <a:prstGeom prst="roundRect">
-            <a:avLst>
-              <a:gd name="adj" fmla="val 7000"/>
-            </a:avLst>
-          </a:prstGeom>
-          <a:solidFill>
-            <a:srgbClr val="0A282A"/>
-          </a:solidFill>
-          <a:ln w="22225">
-            <a:solidFill>
-              <a:srgbClr val="2DD4BF"/>
-            </a:solidFill>
-          </a:ln>
-        </p:spPr>
-        <p:style>
-          <a:lnRef idx="1">
-            <a:schemeClr val="accent1"/>
-          </a:lnRef>
-          <a:fillRef idx="3">
-            <a:schemeClr val="accent1"/>
-          </a:fillRef>
-          <a:effectRef idx="2">
-            <a:schemeClr val="accent1"/>
-          </a:effectRef>
-          <a:fontRef idx="minor">
-            <a:schemeClr val="lt1"/>
-          </a:fontRef>
-        </p:style>
-        <p:txBody>
-          <a:bodyPr rtlCol="0" anchor="ctr"/>
-          <a:lstStyle/>
-          <a:p>
-            <a:pPr algn="ctr"/>
-          </a:p>
-        </p:txBody>
-      </p:sp>
-      <p:sp>
-        <p:nvSpPr>
-          <p:cNvPr id="15" name="TextBox 14"/>
-          <p:cNvSpPr txBox="1"/>
-          <p:nvPr/>
-        </p:nvSpPr>
-        <p:spPr>
-          <a:xfrm>
-            <a:off x="502920" y="1965960"/>
-            <a:ext cx="3383280" cy="274320"/>
-          </a:xfrm>
-          <a:prstGeom prst="rect">
-            <a:avLst/>
-          </a:prstGeom>
-          <a:noFill/>
-        </p:spPr>
-        <p:txBody>
-          <a:bodyPr wrap="square">
-            <a:spAutoFit/>
-          </a:bodyPr>
-          <a:lstStyle/>
-          <a:p>
-            <a:pPr algn="l"/>
-            <a:r>
-              <a:rPr sz="1300" b="1">
-                <a:solidFill>
-                  <a:srgbClr val="2DD4BF"/>
-                </a:solidFill>
-                <a:latin typeface="Calibri"/>
-              </a:rPr>
-              <a:t>Owned by LedgeRX</a:t>
-            </a:r>
-          </a:p>
-        </p:txBody>
-      </p:sp>
-      <p:sp>
-        <p:nvSpPr>
-          <p:cNvPr id="16" name="TextBox 15"/>
-          <p:cNvSpPr txBox="1"/>
-          <p:nvPr/>
-        </p:nvSpPr>
-        <p:spPr>
-          <a:xfrm>
-            <a:off x="502920" y="2331720"/>
-            <a:ext cx="3383280" cy="3200400"/>
-          </a:xfrm>
-          <a:prstGeom prst="rect">
-            <a:avLst/>
-          </a:prstGeom>
-          <a:noFill/>
-        </p:spPr>
-        <p:txBody>
-          <a:bodyPr wrap="square">
-            <a:spAutoFit/>
-          </a:bodyPr>
-          <a:lstStyle/>
-          <a:p>
-            <a:pPr algn="l">
-              <a:spcBef>
-                <a:spcPts val="0"/>
-              </a:spcBef>
-              <a:spcAft>
-                <a:spcPts val="200"/>
-              </a:spcAft>
-            </a:pPr>
-            <a:r>
-              <a:rPr sz="1300" b="1">
-                <a:solidFill>
-                  <a:srgbClr val="F8FAFC"/>
-                </a:solidFill>
-                <a:latin typeface="Calibri"/>
-              </a:rPr>
-              <a:t>Customer wallet &amp; balances</a:t>
-            </a:r>
-          </a:p>
-          <a:p>
-            <a:pPr algn="l">
-              <a:spcBef>
-                <a:spcPts val="0"/>
-              </a:spcBef>
-              <a:spcAft>
-                <a:spcPts val="200"/>
-              </a:spcAft>
-            </a:pPr>
-            <a:r>
-              <a:rPr sz="1200" b="0">
-                <a:solidFill>
-                  <a:srgbClr val="CBD5E1"/>
-                </a:solidFill>
-                <a:latin typeface="Calibri"/>
-              </a:rPr>
-              <a:t>Earn / burn / hold points</a:t>
-            </a:r>
-          </a:p>
-          <a:p>
-            <a:pPr algn="l">
-              <a:spcBef>
-                <a:spcPts val="0"/>
-              </a:spcBef>
-              <a:spcAft>
-                <a:spcPts val="200"/>
-              </a:spcAft>
-            </a:pPr>
-            <a:r>
-              <a:rPr sz="1200" b="0">
-                <a:solidFill>
-                  <a:srgbClr val="CBD5E1"/>
-                </a:solidFill>
-                <a:latin typeface="Calibri"/>
-              </a:rPr>
-              <a:t>Use-case catalog &amp; COA</a:t>
-            </a:r>
-          </a:p>
-          <a:p>
-            <a:pPr algn="l">
-              <a:spcBef>
-                <a:spcPts val="0"/>
-              </a:spcBef>
-              <a:spcAft>
-                <a:spcPts val="200"/>
-              </a:spcAft>
-            </a:pPr>
-            <a:r>
-              <a:rPr sz="1200" b="0">
-                <a:solidFill>
-                  <a:srgbClr val="CBD5E1"/>
-                </a:solidFill>
-                <a:latin typeface="Calibri"/>
-              </a:rPr>
-              <a:t>Calculation formulas (Brain)</a:t>
-            </a:r>
-          </a:p>
-          <a:p>
-            <a:pPr algn="l">
-              <a:spcBef>
-                <a:spcPts val="0"/>
-              </a:spcBef>
-              <a:spcAft>
-                <a:spcPts val="200"/>
-              </a:spcAft>
-            </a:pPr>
-            <a:r>
-              <a:rPr sz="1200" b="0">
-                <a:solidFill>
-                  <a:srgbClr val="CBD5E1"/>
-                </a:solidFill>
-                <a:latin typeface="Calibri"/>
-              </a:rPr>
-              <a:t>Posting &amp; double-entry books</a:t>
-            </a:r>
-          </a:p>
-          <a:p>
-            <a:pPr algn="l">
-              <a:spcBef>
-                <a:spcPts val="0"/>
-              </a:spcBef>
-              <a:spcAft>
-                <a:spcPts val="200"/>
-              </a:spcAft>
-            </a:pPr>
-            <a:r>
-              <a:rPr sz="1200" b="1">
-                <a:solidFill>
-                  <a:srgbClr val="F8FAFC"/>
-                </a:solidFill>
-                <a:latin typeface="Calibri"/>
-              </a:rPr>
-              <a:t>Outbound event:</a:t>
-            </a:r>
-          </a:p>
-          <a:p>
-            <a:pPr algn="l">
-              <a:spcBef>
-                <a:spcPts val="0"/>
-              </a:spcBef>
-              <a:spcAft>
-                <a:spcPts val="200"/>
-              </a:spcAft>
-            </a:pPr>
-            <a:r>
-              <a:rPr sz="1200" b="0">
-                <a:solidFill>
-                  <a:srgbClr val="2DD4BF"/>
-                </a:solidFill>
-                <a:latin typeface="Calibri"/>
-              </a:rPr>
-              <a:t>  ledger.balance.updated</a:t>
-            </a:r>
-          </a:p>
-          <a:p>
-            <a:pPr algn="l">
-              <a:spcBef>
-                <a:spcPts val="0"/>
-              </a:spcBef>
-              <a:spcAft>
-                <a:spcPts val="200"/>
-              </a:spcAft>
-            </a:pPr>
-            <a:r>
-              <a:rPr sz="1200" b="0">
-                <a:solidFill>
-                  <a:srgbClr val="2DD4BF"/>
-                </a:solidFill>
-                <a:latin typeface="Calibri"/>
-              </a:rPr>
-              <a:t>  reward redemption request</a:t>
-            </a:r>
-          </a:p>
-          <a:p>
-            <a:pPr algn="l">
-              <a:spcBef>
-                <a:spcPts val="0"/>
-              </a:spcBef>
-              <a:spcAft>
-                <a:spcPts val="200"/>
-              </a:spcAft>
-            </a:pPr>
-            <a:r>
-              <a:rPr sz="800" b="0">
-                <a:solidFill>
-                  <a:srgbClr val="64748B"/>
-                </a:solidFill>
-                <a:latin typeface="Calibri"/>
-              </a:rPr>
-              <a:t/>
-            </a:r>
-          </a:p>
-          <a:p>
-            <a:pPr algn="l">
-              <a:spcBef>
-                <a:spcPts val="0"/>
-              </a:spcBef>
-              <a:spcAft>
-                <a:spcPts val="200"/>
-              </a:spcAft>
-            </a:pPr>
-            <a:r>
-              <a:rPr sz="1100" b="0">
-                <a:solidFill>
-                  <a:srgbClr val="64748B"/>
-                </a:solidFill>
-                <a:latin typeface="Calibri"/>
-              </a:rPr>
-              <a:t>Does NOT own e-coupon stock,</a:t>
-            </a:r>
-          </a:p>
-          <a:p>
-            <a:pPr algn="l">
-              <a:spcBef>
-                <a:spcPts val="0"/>
-              </a:spcBef>
-              <a:spcAft>
-                <a:spcPts val="200"/>
-              </a:spcAft>
-            </a:pPr>
-            <a:r>
-              <a:rPr sz="1100" b="0">
-                <a:solidFill>
-                  <a:srgbClr val="64748B"/>
-                </a:solidFill>
-                <a:latin typeface="Calibri"/>
-              </a:rPr>
-              <a:t>partner settlement, or COD rails</a:t>
-            </a:r>
-          </a:p>
-        </p:txBody>
-      </p:sp>
-      <p:sp>
-        <p:nvSpPr>
-          <p:cNvPr id="17" name="Right Arrow 16"/>
-          <p:cNvSpPr/>
-          <p:nvPr/>
-        </p:nvSpPr>
-        <p:spPr>
-          <a:xfrm>
-            <a:off x="4160520" y="3566160"/>
-            <a:ext cx="320040" cy="201168"/>
-          </a:xfrm>
-          <a:prstGeom prst="rightArrow">
-            <a:avLst/>
           </a:prstGeom>
           <a:solidFill>
             <a:srgbClr val="2DD4BF"/>
@@ -8892,14 +8393,14 @@
       </p:sp>
       <p:sp>
         <p:nvSpPr>
-          <p:cNvPr id="18" name="TextBox 17"/>
+          <p:cNvPr id="10" name="TextBox 9"/>
           <p:cNvSpPr txBox="1"/>
           <p:nvPr/>
         </p:nvSpPr>
         <p:spPr>
           <a:xfrm>
-            <a:off x="4023360" y="3840480"/>
-            <a:ext cx="640080" cy="457200"/>
+            <a:off x="502920" y="960120"/>
+            <a:ext cx="2194560" cy="274320"/>
           </a:xfrm>
           <a:prstGeom prst="rect">
             <a:avLst/>
@@ -8914,75 +8415,27 @@
           <a:p>
             <a:pPr algn="ctr"/>
             <a:r>
-              <a:rPr sz="1000" b="0">
-                <a:solidFill>
-                  <a:srgbClr val="2DD4BF"/>
+              <a:rPr sz="1200" b="1">
+                <a:solidFill>
+                  <a:srgbClr val="0B1220"/>
                 </a:solidFill>
                 <a:latin typeface="Calibri"/>
               </a:rPr>
-              <a:t>event /
-API</a:t>
-            </a:r>
-          </a:p>
-        </p:txBody>
-      </p:sp>
-      <p:sp>
-        <p:nvSpPr>
-          <p:cNvPr id="19" name="Rounded Rectangle 18"/>
-          <p:cNvSpPr/>
-          <p:nvPr/>
-        </p:nvSpPr>
-        <p:spPr>
-          <a:xfrm>
-            <a:off x="4709160" y="1828800"/>
-            <a:ext cx="7086600" cy="777240"/>
-          </a:xfrm>
-          <a:prstGeom prst="roundRect">
-            <a:avLst>
-              <a:gd name="adj" fmla="val 10000"/>
-            </a:avLst>
-          </a:prstGeom>
-          <a:solidFill>
-            <a:srgbClr val="0C2340"/>
-          </a:solidFill>
-          <a:ln w="15240">
-            <a:solidFill>
-              <a:srgbClr val="38BDF8"/>
-            </a:solidFill>
-          </a:ln>
-        </p:spPr>
-        <p:style>
-          <a:lnRef idx="1">
-            <a:schemeClr val="accent1"/>
-          </a:lnRef>
-          <a:fillRef idx="3">
-            <a:schemeClr val="accent1"/>
-          </a:fillRef>
-          <a:effectRef idx="2">
-            <a:schemeClr val="accent1"/>
-          </a:effectRef>
-          <a:fontRef idx="minor">
-            <a:schemeClr val="lt1"/>
-          </a:fontRef>
-        </p:style>
-        <p:txBody>
-          <a:bodyPr rtlCol="0" anchor="ctr"/>
-          <a:lstStyle/>
-          <a:p>
-            <a:pPr algn="ctr"/>
-          </a:p>
-        </p:txBody>
-      </p:sp>
-      <p:sp>
-        <p:nvSpPr>
-          <p:cNvPr id="20" name="TextBox 19"/>
+              <a:t>OUR PRODUCT</a:t>
+            </a:r>
+          </a:p>
+        </p:txBody>
+      </p:sp>
+      <p:sp>
+        <p:nvSpPr>
+          <p:cNvPr id="11" name="TextBox 10"/>
           <p:cNvSpPr txBox="1"/>
           <p:nvPr/>
         </p:nvSpPr>
         <p:spPr>
           <a:xfrm>
-            <a:off x="4846320" y="1901952"/>
-            <a:ext cx="6766560" cy="228600"/>
+            <a:off x="2834640" y="914400"/>
+            <a:ext cx="8686800" cy="292608"/>
           </a:xfrm>
           <a:prstGeom prst="rect">
             <a:avLst/>
@@ -8997,27 +8450,27 @@
           <a:p>
             <a:pPr algn="l"/>
             <a:r>
-              <a:rPr sz="1100" b="1">
-                <a:solidFill>
-                  <a:srgbClr val="38BDF8"/>
+              <a:rPr sz="1800" b="1">
+                <a:solidFill>
+                  <a:srgbClr val="2DD4BF"/>
                 </a:solidFill>
                 <a:latin typeface="Calibri"/>
               </a:rPr>
-              <a:t>UAF channels (unchanged)</a:t>
-            </a:r>
-          </a:p>
-        </p:txBody>
-      </p:sp>
-      <p:sp>
-        <p:nvSpPr>
-          <p:cNvPr id="21" name="TextBox 20"/>
+              <a:t>LedgeRX   =   UA “Reward System”</a:t>
+            </a:r>
+          </a:p>
+        </p:txBody>
+      </p:sp>
+      <p:sp>
+        <p:nvSpPr>
+          <p:cNvPr id="12" name="TextBox 11"/>
           <p:cNvSpPr txBox="1"/>
           <p:nvPr/>
         </p:nvSpPr>
         <p:spPr>
           <a:xfrm>
-            <a:off x="4846320" y="2194560"/>
-            <a:ext cx="6766560" cy="274320"/>
+            <a:off x="2834640" y="1261872"/>
+            <a:ext cx="8686800" cy="502920"/>
           </a:xfrm>
           <a:prstGeom prst="rect">
             <a:avLst/>
@@ -9032,27 +8485,62 @@
           <a:p>
             <a:pPr algn="l"/>
             <a:r>
-              <a:rPr sz="1300" b="0">
-                <a:solidFill>
-                  <a:srgbClr val="F8FAFC"/>
+              <a:rPr sz="1200" b="0">
+                <a:solidFill>
+                  <a:srgbClr val="CBD5E1"/>
                 </a:solidFill>
                 <a:latin typeface="Calibri"/>
               </a:rPr>
-              <a:t>Yes UA (Mobile App)    ·    aim (Mobile App)    ·    Branch Loan System</a:t>
-            </a:r>
-          </a:p>
-        </p:txBody>
-      </p:sp>
-      <p:sp>
-        <p:nvSpPr>
-          <p:cNvPr id="22" name="Down Arrow 21"/>
+              <a:t>Earn / burn points  ·  wallets &amp; ledgers  ·  rules &amp; COA  ·  emits: balance.updated  ·  reward redemption request  ·  …</a:t>
+            </a:r>
+          </a:p>
+        </p:txBody>
+      </p:sp>
+      <p:sp>
+        <p:nvSpPr>
+          <p:cNvPr id="13" name="TextBox 12"/>
+          <p:cNvSpPr txBox="1"/>
+          <p:nvPr/>
+        </p:nvSpPr>
+        <p:spPr>
+          <a:xfrm>
+            <a:off x="365760" y="2194560"/>
+            <a:ext cx="11430000" cy="274320"/>
+          </a:xfrm>
+          <a:prstGeom prst="rect">
+            <a:avLst/>
+          </a:prstGeom>
+          <a:noFill/>
+        </p:spPr>
+        <p:txBody>
+          <a:bodyPr wrap="square">
+            <a:spAutoFit/>
+          </a:bodyPr>
+          <a:lstStyle/>
+          <a:p>
+            <a:pPr algn="l"/>
+            <a:r>
+              <a:rPr sz="1300" b="1">
+                <a:solidFill>
+                  <a:srgbClr val="C4B5FD"/>
+                </a:solidFill>
+                <a:latin typeface="Calibri"/>
+              </a:rPr>
+              <a:t>LedgeRX Landing Edge  →  multiple downstream systems (UAF-operated)</a:t>
+            </a:r>
+          </a:p>
+        </p:txBody>
+      </p:sp>
+      <p:sp>
+        <p:nvSpPr>
+          <p:cNvPr id="14" name="Down Arrow 13"/>
           <p:cNvSpPr/>
           <p:nvPr/>
         </p:nvSpPr>
         <p:spPr>
           <a:xfrm>
-            <a:off x="8092440" y="2651760"/>
-            <a:ext cx="146304" cy="182880"/>
+            <a:off x="1463040" y="2514600"/>
+            <a:ext cx="164592" cy="201168"/>
           </a:xfrm>
           <a:prstGeom prst="downArrow">
             <a:avLst/>
@@ -9088,27 +8576,23 @@
       </p:sp>
       <p:sp>
         <p:nvSpPr>
-          <p:cNvPr id="23" name="Rounded Rectangle 22"/>
+          <p:cNvPr id="15" name="Down Arrow 14"/>
           <p:cNvSpPr/>
           <p:nvPr/>
         </p:nvSpPr>
         <p:spPr>
           <a:xfrm>
-            <a:off x="4709160" y="2880360"/>
-            <a:ext cx="7086600" cy="640080"/>
-          </a:xfrm>
-          <a:prstGeom prst="roundRect">
-            <a:avLst>
-              <a:gd name="adj" fmla="val 10000"/>
-            </a:avLst>
+            <a:off x="4114800" y="2514600"/>
+            <a:ext cx="164592" cy="201168"/>
+          </a:xfrm>
+          <a:prstGeom prst="downArrow">
+            <a:avLst/>
           </a:prstGeom>
           <a:solidFill>
-            <a:srgbClr val="0A282A"/>
+            <a:srgbClr val="2DD4BF"/>
           </a:solidFill>
-          <a:ln w="15240">
-            <a:solidFill>
-              <a:srgbClr val="2DD4BF"/>
-            </a:solidFill>
+          <a:ln>
+            <a:noFill/>
           </a:ln>
         </p:spPr>
         <p:style>
@@ -9135,87 +8619,152 @@
       </p:sp>
       <p:sp>
         <p:nvSpPr>
-          <p:cNvPr id="24" name="TextBox 23"/>
-          <p:cNvSpPr txBox="1"/>
-          <p:nvPr/>
-        </p:nvSpPr>
-        <p:spPr>
-          <a:xfrm>
-            <a:off x="4846320" y="2971800"/>
-            <a:ext cx="6766560" cy="228600"/>
-          </a:xfrm>
-          <a:prstGeom prst="rect">
-            <a:avLst/>
-          </a:prstGeom>
-          <a:noFill/>
-        </p:spPr>
-        <p:txBody>
-          <a:bodyPr wrap="square">
-            <a:spAutoFit/>
-          </a:bodyPr>
-          <a:lstStyle/>
-          <a:p>
-            <a:pPr algn="l"/>
-            <a:r>
-              <a:rPr sz="1300" b="1">
-                <a:solidFill>
-                  <a:srgbClr val="2DD4BF"/>
-                </a:solidFill>
-                <a:latin typeface="Calibri"/>
-              </a:rPr>
-              <a:t>LedgeRX  (= Reward System)  —  you buy this</a:t>
-            </a:r>
-          </a:p>
-        </p:txBody>
-      </p:sp>
-      <p:sp>
-        <p:nvSpPr>
-          <p:cNvPr id="25" name="TextBox 24"/>
-          <p:cNvSpPr txBox="1"/>
-          <p:nvPr/>
-        </p:nvSpPr>
-        <p:spPr>
-          <a:xfrm>
-            <a:off x="4846320" y="3218688"/>
-            <a:ext cx="6766560" cy="228600"/>
-          </a:xfrm>
-          <a:prstGeom prst="rect">
-            <a:avLst/>
-          </a:prstGeom>
-          <a:noFill/>
-        </p:spPr>
-        <p:txBody>
-          <a:bodyPr wrap="square">
-            <a:spAutoFit/>
-          </a:bodyPr>
-          <a:lstStyle/>
-          <a:p>
-            <a:pPr algn="l"/>
-            <a:r>
-              <a:rPr sz="1100" b="0">
-                <a:solidFill>
-                  <a:srgbClr val="CBD5E1"/>
-                </a:solidFill>
-                <a:latin typeface="Calibri"/>
-              </a:rPr>
-              <a:t>request e-coupon / redemption outcome  →  Landing</a:t>
-            </a:r>
-          </a:p>
-        </p:txBody>
-      </p:sp>
-      <p:sp>
-        <p:nvSpPr>
-          <p:cNvPr id="26" name="Down Arrow 25"/>
+          <p:cNvPr id="16" name="Down Arrow 15"/>
           <p:cNvSpPr/>
           <p:nvPr/>
         </p:nvSpPr>
         <p:spPr>
           <a:xfrm>
-            <a:off x="8092440" y="3566160"/>
-            <a:ext cx="146304" cy="182880"/>
+            <a:off x="6766560" y="2514600"/>
+            <a:ext cx="164592" cy="201168"/>
           </a:xfrm>
           <a:prstGeom prst="downArrow">
             <a:avLst/>
+          </a:prstGeom>
+          <a:solidFill>
+            <a:srgbClr val="2DD4BF"/>
+          </a:solidFill>
+          <a:ln>
+            <a:noFill/>
+          </a:ln>
+        </p:spPr>
+        <p:style>
+          <a:lnRef idx="1">
+            <a:schemeClr val="accent1"/>
+          </a:lnRef>
+          <a:fillRef idx="3">
+            <a:schemeClr val="accent1"/>
+          </a:fillRef>
+          <a:effectRef idx="2">
+            <a:schemeClr val="accent1"/>
+          </a:effectRef>
+          <a:fontRef idx="minor">
+            <a:schemeClr val="lt1"/>
+          </a:fontRef>
+        </p:style>
+        <p:txBody>
+          <a:bodyPr rtlCol="0" anchor="ctr"/>
+          <a:lstStyle/>
+          <a:p>
+            <a:pPr algn="ctr"/>
+          </a:p>
+        </p:txBody>
+      </p:sp>
+      <p:sp>
+        <p:nvSpPr>
+          <p:cNvPr id="17" name="Down Arrow 16"/>
+          <p:cNvSpPr/>
+          <p:nvPr/>
+        </p:nvSpPr>
+        <p:spPr>
+          <a:xfrm>
+            <a:off x="9418320" y="2514600"/>
+            <a:ext cx="164592" cy="201168"/>
+          </a:xfrm>
+          <a:prstGeom prst="downArrow">
+            <a:avLst/>
+          </a:prstGeom>
+          <a:solidFill>
+            <a:srgbClr val="2DD4BF"/>
+          </a:solidFill>
+          <a:ln>
+            <a:noFill/>
+          </a:ln>
+        </p:spPr>
+        <p:style>
+          <a:lnRef idx="1">
+            <a:schemeClr val="accent1"/>
+          </a:lnRef>
+          <a:fillRef idx="3">
+            <a:schemeClr val="accent1"/>
+          </a:fillRef>
+          <a:effectRef idx="2">
+            <a:schemeClr val="accent1"/>
+          </a:effectRef>
+          <a:fontRef idx="minor">
+            <a:schemeClr val="lt1"/>
+          </a:fontRef>
+        </p:style>
+        <p:txBody>
+          <a:bodyPr rtlCol="0" anchor="ctr"/>
+          <a:lstStyle/>
+          <a:p>
+            <a:pPr algn="ctr"/>
+          </a:p>
+        </p:txBody>
+      </p:sp>
+      <p:sp>
+        <p:nvSpPr>
+          <p:cNvPr id="18" name="Rounded Rectangle 17"/>
+          <p:cNvSpPr/>
+          <p:nvPr/>
+        </p:nvSpPr>
+        <p:spPr>
+          <a:xfrm>
+            <a:off x="457200" y="2788920"/>
+            <a:ext cx="2606040" cy="2331720"/>
+          </a:xfrm>
+          <a:prstGeom prst="roundRect">
+            <a:avLst>
+              <a:gd name="adj" fmla="val 8000"/>
+            </a:avLst>
+          </a:prstGeom>
+          <a:solidFill>
+            <a:srgbClr val="0A2F24"/>
+          </a:solidFill>
+          <a:ln w="28575">
+            <a:solidFill>
+              <a:srgbClr val="6EE7B7"/>
+            </a:solidFill>
+          </a:ln>
+        </p:spPr>
+        <p:style>
+          <a:lnRef idx="1">
+            <a:schemeClr val="accent1"/>
+          </a:lnRef>
+          <a:fillRef idx="3">
+            <a:schemeClr val="accent1"/>
+          </a:fillRef>
+          <a:effectRef idx="2">
+            <a:schemeClr val="accent1"/>
+          </a:effectRef>
+          <a:fontRef idx="minor">
+            <a:schemeClr val="lt1"/>
+          </a:fontRef>
+        </p:style>
+        <p:txBody>
+          <a:bodyPr rtlCol="0" anchor="ctr"/>
+          <a:lstStyle/>
+          <a:p>
+            <a:pPr algn="ctr"/>
+          </a:p>
+        </p:txBody>
+      </p:sp>
+      <p:sp>
+        <p:nvSpPr>
+          <p:cNvPr id="19" name="Rounded Rectangle 18"/>
+          <p:cNvSpPr/>
+          <p:nvPr/>
+        </p:nvSpPr>
+        <p:spPr>
+          <a:xfrm>
+            <a:off x="566928" y="2898648"/>
+            <a:ext cx="1417320" cy="256032"/>
+          </a:xfrm>
+          <a:prstGeom prst="roundRect">
+            <a:avLst>
+              <a:gd name="adj" fmla="val 8000"/>
+            </a:avLst>
           </a:prstGeom>
           <a:solidFill>
             <a:srgbClr val="6EE7B7"/>
@@ -9248,14 +8797,259 @@
       </p:sp>
       <p:sp>
         <p:nvSpPr>
+          <p:cNvPr id="20" name="TextBox 19"/>
+          <p:cNvSpPr txBox="1"/>
+          <p:nvPr/>
+        </p:nvSpPr>
+        <p:spPr>
+          <a:xfrm>
+            <a:off x="566928" y="2916936"/>
+            <a:ext cx="1417320" cy="228600"/>
+          </a:xfrm>
+          <a:prstGeom prst="rect">
+            <a:avLst/>
+          </a:prstGeom>
+          <a:noFill/>
+        </p:spPr>
+        <p:txBody>
+          <a:bodyPr wrap="square">
+            <a:spAutoFit/>
+          </a:bodyPr>
+          <a:lstStyle/>
+          <a:p>
+            <a:pPr algn="ctr"/>
+            <a:r>
+              <a:rPr sz="900" b="1">
+                <a:solidFill>
+                  <a:srgbClr val="0B1220"/>
+                </a:solidFill>
+                <a:latin typeface="Calibri"/>
+              </a:rPr>
+              <a:t>ONE DOWNSTREAM</a:t>
+            </a:r>
+          </a:p>
+        </p:txBody>
+      </p:sp>
+      <p:sp>
+        <p:nvSpPr>
+          <p:cNvPr id="21" name="TextBox 20"/>
+          <p:cNvSpPr txBox="1"/>
+          <p:nvPr/>
+        </p:nvSpPr>
+        <p:spPr>
+          <a:xfrm>
+            <a:off x="585216" y="3227832"/>
+            <a:ext cx="2350008" cy="292608"/>
+          </a:xfrm>
+          <a:prstGeom prst="rect">
+            <a:avLst/>
+          </a:prstGeom>
+          <a:noFill/>
+        </p:spPr>
+        <p:txBody>
+          <a:bodyPr wrap="square">
+            <a:spAutoFit/>
+          </a:bodyPr>
+          <a:lstStyle/>
+          <a:p>
+            <a:pPr algn="l"/>
+            <a:r>
+              <a:rPr sz="1400" b="1">
+                <a:solidFill>
+                  <a:srgbClr val="F8FAFC"/>
+                </a:solidFill>
+                <a:latin typeface="Calibri"/>
+              </a:rPr>
+              <a:t>E-coupon / CBP</a:t>
+            </a:r>
+          </a:p>
+        </p:txBody>
+      </p:sp>
+      <p:sp>
+        <p:nvSpPr>
+          <p:cNvPr id="22" name="TextBox 21"/>
+          <p:cNvSpPr txBox="1"/>
+          <p:nvPr/>
+        </p:nvSpPr>
+        <p:spPr>
+          <a:xfrm>
+            <a:off x="585216" y="3520440"/>
+            <a:ext cx="2350008" cy="256032"/>
+          </a:xfrm>
+          <a:prstGeom prst="rect">
+            <a:avLst/>
+          </a:prstGeom>
+          <a:noFill/>
+        </p:spPr>
+        <p:txBody>
+          <a:bodyPr wrap="square">
+            <a:spAutoFit/>
+          </a:bodyPr>
+          <a:lstStyle/>
+          <a:p>
+            <a:pPr algn="l"/>
+            <a:r>
+              <a:rPr sz="1100" b="0">
+                <a:solidFill>
+                  <a:srgbClr val="6EE7B7"/>
+                </a:solidFill>
+                <a:latin typeface="Calibri"/>
+              </a:rPr>
+              <a:t>UAF-owned platform</a:t>
+            </a:r>
+          </a:p>
+        </p:txBody>
+      </p:sp>
+      <p:sp>
+        <p:nvSpPr>
+          <p:cNvPr id="23" name="TextBox 22"/>
+          <p:cNvSpPr txBox="1"/>
+          <p:nvPr/>
+        </p:nvSpPr>
+        <p:spPr>
+          <a:xfrm>
+            <a:off x="585216" y="3867912"/>
+            <a:ext cx="2350008" cy="256032"/>
+          </a:xfrm>
+          <a:prstGeom prst="rect">
+            <a:avLst/>
+          </a:prstGeom>
+          <a:noFill/>
+        </p:spPr>
+        <p:txBody>
+          <a:bodyPr wrap="square">
+            <a:spAutoFit/>
+          </a:bodyPr>
+          <a:lstStyle/>
+          <a:p>
+            <a:pPr algn="l"/>
+            <a:r>
+              <a:rPr sz="1100" b="0">
+                <a:solidFill>
+                  <a:srgbClr val="CBD5E1"/>
+                </a:solidFill>
+                <a:latin typeface="Calibri"/>
+              </a:rPr>
+              <a:t>• Coupon inventory</a:t>
+            </a:r>
+          </a:p>
+        </p:txBody>
+      </p:sp>
+      <p:sp>
+        <p:nvSpPr>
+          <p:cNvPr id="24" name="TextBox 23"/>
+          <p:cNvSpPr txBox="1"/>
+          <p:nvPr/>
+        </p:nvSpPr>
+        <p:spPr>
+          <a:xfrm>
+            <a:off x="585216" y="4123944"/>
+            <a:ext cx="2350008" cy="256032"/>
+          </a:xfrm>
+          <a:prstGeom prst="rect">
+            <a:avLst/>
+          </a:prstGeom>
+          <a:noFill/>
+        </p:spPr>
+        <p:txBody>
+          <a:bodyPr wrap="square">
+            <a:spAutoFit/>
+          </a:bodyPr>
+          <a:lstStyle/>
+          <a:p>
+            <a:pPr algn="l"/>
+            <a:r>
+              <a:rPr sz="1100" b="0">
+                <a:solidFill>
+                  <a:srgbClr val="CBD5E1"/>
+                </a:solidFill>
+                <a:latin typeface="Calibri"/>
+              </a:rPr>
+              <a:t>• Issue &amp; redeem</a:t>
+            </a:r>
+          </a:p>
+        </p:txBody>
+      </p:sp>
+      <p:sp>
+        <p:nvSpPr>
+          <p:cNvPr id="25" name="TextBox 24"/>
+          <p:cNvSpPr txBox="1"/>
+          <p:nvPr/>
+        </p:nvSpPr>
+        <p:spPr>
+          <a:xfrm>
+            <a:off x="585216" y="4379976"/>
+            <a:ext cx="2350008" cy="256032"/>
+          </a:xfrm>
+          <a:prstGeom prst="rect">
+            <a:avLst/>
+          </a:prstGeom>
+          <a:noFill/>
+        </p:spPr>
+        <p:txBody>
+          <a:bodyPr wrap="square">
+            <a:spAutoFit/>
+          </a:bodyPr>
+          <a:lstStyle/>
+          <a:p>
+            <a:pPr algn="l"/>
+            <a:r>
+              <a:rPr sz="1100" b="0">
+                <a:solidFill>
+                  <a:srgbClr val="CBD5E1"/>
+                </a:solidFill>
+                <a:latin typeface="Calibri"/>
+              </a:rPr>
+              <a:t>• Track usage</a:t>
+            </a:r>
+          </a:p>
+        </p:txBody>
+      </p:sp>
+      <p:sp>
+        <p:nvSpPr>
+          <p:cNvPr id="26" name="TextBox 25"/>
+          <p:cNvSpPr txBox="1"/>
+          <p:nvPr/>
+        </p:nvSpPr>
+        <p:spPr>
+          <a:xfrm>
+            <a:off x="585216" y="4636008"/>
+            <a:ext cx="2350008" cy="256032"/>
+          </a:xfrm>
+          <a:prstGeom prst="rect">
+            <a:avLst/>
+          </a:prstGeom>
+          <a:noFill/>
+        </p:spPr>
+        <p:txBody>
+          <a:bodyPr wrap="square">
+            <a:spAutoFit/>
+          </a:bodyPr>
+          <a:lstStyle/>
+          <a:p>
+            <a:pPr algn="l"/>
+            <a:r>
+              <a:rPr sz="1100" b="0">
+                <a:solidFill>
+                  <a:srgbClr val="CBD5E1"/>
+                </a:solidFill>
+                <a:latin typeface="Calibri"/>
+              </a:rPr>
+              <a:t>• = Kenny green box</a:t>
+            </a:r>
+          </a:p>
+        </p:txBody>
+      </p:sp>
+      <p:sp>
+        <p:nvSpPr>
           <p:cNvPr id="27" name="Rounded Rectangle 26"/>
           <p:cNvSpPr/>
           <p:nvPr/>
         </p:nvSpPr>
         <p:spPr>
           <a:xfrm>
-            <a:off x="4709160" y="3794760"/>
-            <a:ext cx="7086600" cy="1234440"/>
+            <a:off x="3264408" y="2788920"/>
+            <a:ext cx="2606040" cy="2331720"/>
           </a:xfrm>
           <a:prstGeom prst="roundRect">
             <a:avLst>
@@ -9263,11 +9057,11 @@
             </a:avLst>
           </a:prstGeom>
           <a:solidFill>
-            <a:srgbClr val="0A2F24"/>
+            <a:srgbClr val="0C2340"/>
           </a:solidFill>
-          <a:ln w="25400">
+          <a:ln w="17145">
             <a:solidFill>
-              <a:srgbClr val="6EE7B7"/>
+              <a:srgbClr val="C4B5FD"/>
             </a:solidFill>
           </a:ln>
         </p:spPr>
@@ -9301,8 +9095,8 @@
         </p:nvSpPr>
         <p:spPr>
           <a:xfrm>
-            <a:off x="4892040" y="3886200"/>
-            <a:ext cx="6766560" cy="256032"/>
+            <a:off x="3392424" y="2953512"/>
+            <a:ext cx="2350008" cy="292608"/>
           </a:xfrm>
           <a:prstGeom prst="rect">
             <a:avLst/>
@@ -9319,11 +9113,11 @@
             <a:r>
               <a:rPr sz="1400" b="1">
                 <a:solidFill>
-                  <a:srgbClr val="6EE7B7"/>
+                  <a:srgbClr val="F8FAFC"/>
                 </a:solidFill>
                 <a:latin typeface="Calibri"/>
               </a:rPr>
-              <a:t>UAF owns  ·  Centralized Backend Platform (CBP)  =  Landing Edge</a:t>
+              <a:t>Gift system</a:t>
             </a:r>
           </a:p>
         </p:txBody>
@@ -9336,8 +9130,8 @@
         </p:nvSpPr>
         <p:spPr>
           <a:xfrm>
-            <a:off x="4892040" y="4206240"/>
-            <a:ext cx="6766560" cy="731520"/>
+            <a:off x="3392424" y="3246120"/>
+            <a:ext cx="2350008" cy="256032"/>
           </a:xfrm>
           <a:prstGeom prst="rect">
             <a:avLst/>
@@ -9350,83 +9144,182 @@
           </a:bodyPr>
           <a:lstStyle/>
           <a:p>
-            <a:pPr algn="l">
-              <a:spcBef>
-                <a:spcPts val="0"/>
-              </a:spcBef>
-              <a:spcAft>
-                <a:spcPts val="200"/>
-              </a:spcAft>
-            </a:pPr>
-            <a:r>
-              <a:rPr sz="1200" b="0">
-                <a:solidFill>
-                  <a:srgbClr val="F8FAFC"/>
+            <a:pPr algn="l"/>
+            <a:r>
+              <a:rPr sz="1100" b="0">
+                <a:solidFill>
+                  <a:srgbClr val="C4B5FD"/>
                 </a:solidFill>
                 <a:latin typeface="Calibri"/>
               </a:rPr>
-              <a:t>• E-coupon inventory management</a:t>
-            </a:r>
-          </a:p>
-          <a:p>
-            <a:pPr algn="l">
-              <a:spcBef>
-                <a:spcPts val="0"/>
-              </a:spcBef>
-              <a:spcAft>
-                <a:spcPts val="200"/>
-              </a:spcAft>
-            </a:pPr>
-            <a:r>
-              <a:rPr sz="1200" b="0">
-                <a:solidFill>
-                  <a:srgbClr val="F8FAFC"/>
+              <a:t>UAF-owned</a:t>
+            </a:r>
+          </a:p>
+        </p:txBody>
+      </p:sp>
+      <p:sp>
+        <p:nvSpPr>
+          <p:cNvPr id="30" name="TextBox 29"/>
+          <p:cNvSpPr txBox="1"/>
+          <p:nvPr/>
+        </p:nvSpPr>
+        <p:spPr>
+          <a:xfrm>
+            <a:off x="3392424" y="3593592"/>
+            <a:ext cx="2350008" cy="256032"/>
+          </a:xfrm>
+          <a:prstGeom prst="rect">
+            <a:avLst/>
+          </a:prstGeom>
+          <a:noFill/>
+        </p:spPr>
+        <p:txBody>
+          <a:bodyPr wrap="square">
+            <a:spAutoFit/>
+          </a:bodyPr>
+          <a:lstStyle/>
+          <a:p>
+            <a:pPr algn="l"/>
+            <a:r>
+              <a:rPr sz="1100" b="0">
+                <a:solidFill>
+                  <a:srgbClr val="CBD5E1"/>
                 </a:solidFill>
                 <a:latin typeface="Calibri"/>
               </a:rPr>
-              <a:t>• Coupon redemption &amp; issue e-coupons</a:t>
-            </a:r>
-          </a:p>
-          <a:p>
-            <a:pPr algn="l">
-              <a:spcBef>
-                <a:spcPts val="0"/>
-              </a:spcBef>
-              <a:spcAft>
-                <a:spcPts val="200"/>
-              </a:spcAft>
-            </a:pPr>
-            <a:r>
-              <a:rPr sz="1200" b="0">
-                <a:solidFill>
-                  <a:srgbClr val="F8FAFC"/>
+              <a:t>• Fulfillment</a:t>
+            </a:r>
+          </a:p>
+        </p:txBody>
+      </p:sp>
+      <p:sp>
+        <p:nvSpPr>
+          <p:cNvPr id="31" name="TextBox 30"/>
+          <p:cNvSpPr txBox="1"/>
+          <p:nvPr/>
+        </p:nvSpPr>
+        <p:spPr>
+          <a:xfrm>
+            <a:off x="3392424" y="3849624"/>
+            <a:ext cx="2350008" cy="256032"/>
+          </a:xfrm>
+          <a:prstGeom prst="rect">
+            <a:avLst/>
+          </a:prstGeom>
+          <a:noFill/>
+        </p:spPr>
+        <p:txBody>
+          <a:bodyPr wrap="square">
+            <a:spAutoFit/>
+          </a:bodyPr>
+          <a:lstStyle/>
+          <a:p>
+            <a:pPr algn="l"/>
+            <a:r>
+              <a:rPr sz="1100" b="0">
+                <a:solidFill>
+                  <a:srgbClr val="CBD5E1"/>
                 </a:solidFill>
                 <a:latin typeface="Calibri"/>
               </a:rPr>
-              <a:t>• Track coupon usage  ·  orchestration after reward outcome</a:t>
-            </a:r>
-          </a:p>
-        </p:txBody>
-      </p:sp>
-      <p:sp>
-        <p:nvSpPr>
-          <p:cNvPr id="30" name="Down Arrow 29"/>
+              <a:t>• Physical / digital gifts</a:t>
+            </a:r>
+          </a:p>
+        </p:txBody>
+      </p:sp>
+      <p:sp>
+        <p:nvSpPr>
+          <p:cNvPr id="32" name="TextBox 31"/>
+          <p:cNvSpPr txBox="1"/>
+          <p:nvPr/>
+        </p:nvSpPr>
+        <p:spPr>
+          <a:xfrm>
+            <a:off x="3392424" y="4105656"/>
+            <a:ext cx="2350008" cy="256032"/>
+          </a:xfrm>
+          <a:prstGeom prst="rect">
+            <a:avLst/>
+          </a:prstGeom>
+          <a:noFill/>
+        </p:spPr>
+        <p:txBody>
+          <a:bodyPr wrap="square">
+            <a:spAutoFit/>
+          </a:bodyPr>
+          <a:lstStyle/>
+          <a:p>
+            <a:pPr algn="l"/>
+            <a:r>
+              <a:rPr sz="1100" b="0">
+                <a:solidFill>
+                  <a:srgbClr val="CBD5E1"/>
+                </a:solidFill>
+                <a:latin typeface="Calibri"/>
+              </a:rPr>
+              <a:t>• Triggered by reward</a:t>
+            </a:r>
+          </a:p>
+        </p:txBody>
+      </p:sp>
+      <p:sp>
+        <p:nvSpPr>
+          <p:cNvPr id="33" name="TextBox 32"/>
+          <p:cNvSpPr txBox="1"/>
+          <p:nvPr/>
+        </p:nvSpPr>
+        <p:spPr>
+          <a:xfrm>
+            <a:off x="3392424" y="4361688"/>
+            <a:ext cx="2350008" cy="256032"/>
+          </a:xfrm>
+          <a:prstGeom prst="rect">
+            <a:avLst/>
+          </a:prstGeom>
+          <a:noFill/>
+        </p:spPr>
+        <p:txBody>
+          <a:bodyPr wrap="square">
+            <a:spAutoFit/>
+          </a:bodyPr>
+          <a:lstStyle/>
+          <a:p>
+            <a:pPr algn="l"/>
+            <a:r>
+              <a:rPr sz="1100" b="0">
+                <a:solidFill>
+                  <a:srgbClr val="CBD5E1"/>
+                </a:solidFill>
+                <a:latin typeface="Calibri"/>
+              </a:rPr>
+              <a:t>  outcome</a:t>
+            </a:r>
+          </a:p>
+        </p:txBody>
+      </p:sp>
+      <p:sp>
+        <p:nvSpPr>
+          <p:cNvPr id="34" name="Rounded Rectangle 33"/>
           <p:cNvSpPr/>
           <p:nvPr/>
         </p:nvSpPr>
         <p:spPr>
           <a:xfrm>
-            <a:off x="8092440" y="5074920"/>
-            <a:ext cx="146304" cy="182880"/>
-          </a:xfrm>
-          <a:prstGeom prst="downArrow">
-            <a:avLst/>
+            <a:off x="6071616" y="2788920"/>
+            <a:ext cx="2606040" cy="2331720"/>
+          </a:xfrm>
+          <a:prstGeom prst="roundRect">
+            <a:avLst>
+              <a:gd name="adj" fmla="val 8000"/>
+            </a:avLst>
           </a:prstGeom>
           <a:solidFill>
-            <a:srgbClr val="F9A8D4"/>
+            <a:srgbClr val="0C2340"/>
           </a:solidFill>
-          <a:ln>
-            <a:noFill/>
+          <a:ln w="17145">
+            <a:solidFill>
+              <a:srgbClr val="38BDF8"/>
+            </a:solidFill>
           </a:ln>
         </p:spPr>
         <p:style>
@@ -9453,26 +9346,236 @@
       </p:sp>
       <p:sp>
         <p:nvSpPr>
-          <p:cNvPr id="31" name="Rounded Rectangle 30"/>
+          <p:cNvPr id="35" name="TextBox 34"/>
+          <p:cNvSpPr txBox="1"/>
+          <p:nvPr/>
+        </p:nvSpPr>
+        <p:spPr>
+          <a:xfrm>
+            <a:off x="6199632" y="2953512"/>
+            <a:ext cx="2350008" cy="292608"/>
+          </a:xfrm>
+          <a:prstGeom prst="rect">
+            <a:avLst/>
+          </a:prstGeom>
+          <a:noFill/>
+        </p:spPr>
+        <p:txBody>
+          <a:bodyPr wrap="square">
+            <a:spAutoFit/>
+          </a:bodyPr>
+          <a:lstStyle/>
+          <a:p>
+            <a:pPr algn="l"/>
+            <a:r>
+              <a:rPr sz="1400" b="1">
+                <a:solidFill>
+                  <a:srgbClr val="F8FAFC"/>
+                </a:solidFill>
+                <a:latin typeface="Calibri"/>
+              </a:rPr>
+              <a:t>Notification</a:t>
+            </a:r>
+          </a:p>
+        </p:txBody>
+      </p:sp>
+      <p:sp>
+        <p:nvSpPr>
+          <p:cNvPr id="36" name="TextBox 35"/>
+          <p:cNvSpPr txBox="1"/>
+          <p:nvPr/>
+        </p:nvSpPr>
+        <p:spPr>
+          <a:xfrm>
+            <a:off x="6199632" y="3246120"/>
+            <a:ext cx="2350008" cy="256032"/>
+          </a:xfrm>
+          <a:prstGeom prst="rect">
+            <a:avLst/>
+          </a:prstGeom>
+          <a:noFill/>
+        </p:spPr>
+        <p:txBody>
+          <a:bodyPr wrap="square">
+            <a:spAutoFit/>
+          </a:bodyPr>
+          <a:lstStyle/>
+          <a:p>
+            <a:pPr algn="l"/>
+            <a:r>
+              <a:rPr sz="1100" b="0">
+                <a:solidFill>
+                  <a:srgbClr val="38BDF8"/>
+                </a:solidFill>
+                <a:latin typeface="Calibri"/>
+              </a:rPr>
+              <a:t>UAF-owned</a:t>
+            </a:r>
+          </a:p>
+        </p:txBody>
+      </p:sp>
+      <p:sp>
+        <p:nvSpPr>
+          <p:cNvPr id="37" name="TextBox 36"/>
+          <p:cNvSpPr txBox="1"/>
+          <p:nvPr/>
+        </p:nvSpPr>
+        <p:spPr>
+          <a:xfrm>
+            <a:off x="6199632" y="3593592"/>
+            <a:ext cx="2350008" cy="256032"/>
+          </a:xfrm>
+          <a:prstGeom prst="rect">
+            <a:avLst/>
+          </a:prstGeom>
+          <a:noFill/>
+        </p:spPr>
+        <p:txBody>
+          <a:bodyPr wrap="square">
+            <a:spAutoFit/>
+          </a:bodyPr>
+          <a:lstStyle/>
+          <a:p>
+            <a:pPr algn="l"/>
+            <a:r>
+              <a:rPr sz="1100" b="0">
+                <a:solidFill>
+                  <a:srgbClr val="CBD5E1"/>
+                </a:solidFill>
+                <a:latin typeface="Calibri"/>
+              </a:rPr>
+              <a:t>• Push · SMS · inbox</a:t>
+            </a:r>
+          </a:p>
+        </p:txBody>
+      </p:sp>
+      <p:sp>
+        <p:nvSpPr>
+          <p:cNvPr id="38" name="TextBox 37"/>
+          <p:cNvSpPr txBox="1"/>
+          <p:nvPr/>
+        </p:nvSpPr>
+        <p:spPr>
+          <a:xfrm>
+            <a:off x="6199632" y="3849624"/>
+            <a:ext cx="2350008" cy="256032"/>
+          </a:xfrm>
+          <a:prstGeom prst="rect">
+            <a:avLst/>
+          </a:prstGeom>
+          <a:noFill/>
+        </p:spPr>
+        <p:txBody>
+          <a:bodyPr wrap="square">
+            <a:spAutoFit/>
+          </a:bodyPr>
+          <a:lstStyle/>
+          <a:p>
+            <a:pPr algn="l"/>
+            <a:r>
+              <a:rPr sz="1100" b="0">
+                <a:solidFill>
+                  <a:srgbClr val="CBD5E1"/>
+                </a:solidFill>
+                <a:latin typeface="Calibri"/>
+              </a:rPr>
+              <a:t>• Balance alerts</a:t>
+            </a:r>
+          </a:p>
+        </p:txBody>
+      </p:sp>
+      <p:sp>
+        <p:nvSpPr>
+          <p:cNvPr id="39" name="TextBox 38"/>
+          <p:cNvSpPr txBox="1"/>
+          <p:nvPr/>
+        </p:nvSpPr>
+        <p:spPr>
+          <a:xfrm>
+            <a:off x="6199632" y="4105656"/>
+            <a:ext cx="2350008" cy="256032"/>
+          </a:xfrm>
+          <a:prstGeom prst="rect">
+            <a:avLst/>
+          </a:prstGeom>
+          <a:noFill/>
+        </p:spPr>
+        <p:txBody>
+          <a:bodyPr wrap="square">
+            <a:spAutoFit/>
+          </a:bodyPr>
+          <a:lstStyle/>
+          <a:p>
+            <a:pPr algn="l"/>
+            <a:r>
+              <a:rPr sz="1100" b="0">
+                <a:solidFill>
+                  <a:srgbClr val="CBD5E1"/>
+                </a:solidFill>
+                <a:latin typeface="Calibri"/>
+              </a:rPr>
+              <a:t>• Redemption confirm</a:t>
+            </a:r>
+          </a:p>
+        </p:txBody>
+      </p:sp>
+      <p:sp>
+        <p:nvSpPr>
+          <p:cNvPr id="40" name="TextBox 39"/>
+          <p:cNvSpPr txBox="1"/>
+          <p:nvPr/>
+        </p:nvSpPr>
+        <p:spPr>
+          <a:xfrm>
+            <a:off x="6199632" y="4361688"/>
+            <a:ext cx="2350008" cy="256032"/>
+          </a:xfrm>
+          <a:prstGeom prst="rect">
+            <a:avLst/>
+          </a:prstGeom>
+          <a:noFill/>
+        </p:spPr>
+        <p:txBody>
+          <a:bodyPr wrap="square">
+            <a:spAutoFit/>
+          </a:bodyPr>
+          <a:lstStyle/>
+          <a:p>
+            <a:pPr algn="l"/>
+            <a:r>
+              <a:rPr sz="1100" b="0">
+                <a:solidFill>
+                  <a:srgbClr val="CBD5E1"/>
+                </a:solidFill>
+                <a:latin typeface="Calibri"/>
+              </a:rPr>
+              <a:t/>
+            </a:r>
+          </a:p>
+        </p:txBody>
+      </p:sp>
+      <p:sp>
+        <p:nvSpPr>
+          <p:cNvPr id="41" name="Rounded Rectangle 40"/>
           <p:cNvSpPr/>
           <p:nvPr/>
         </p:nvSpPr>
         <p:spPr>
           <a:xfrm>
-            <a:off x="4709160" y="5303520"/>
-            <a:ext cx="7086600" cy="685800"/>
+            <a:off x="8878824" y="2788920"/>
+            <a:ext cx="2606040" cy="2331720"/>
           </a:xfrm>
           <a:prstGeom prst="roundRect">
             <a:avLst>
-              <a:gd name="adj" fmla="val 10000"/>
+              <a:gd name="adj" fmla="val 8000"/>
             </a:avLst>
           </a:prstGeom>
           <a:solidFill>
-            <a:srgbClr val="2A1424"/>
+            <a:srgbClr val="0C2340"/>
           </a:solidFill>
           <a:ln w="17145">
             <a:solidFill>
-              <a:srgbClr val="F9A8D4"/>
+              <a:srgbClr val="FB923C"/>
             </a:solidFill>
           </a:ln>
         </p:spPr>
@@ -9500,14 +9603,14 @@
       </p:sp>
       <p:sp>
         <p:nvSpPr>
-          <p:cNvPr id="32" name="TextBox 31"/>
+          <p:cNvPr id="42" name="TextBox 41"/>
           <p:cNvSpPr txBox="1"/>
           <p:nvPr/>
         </p:nvSpPr>
         <p:spPr>
           <a:xfrm>
-            <a:off x="4892040" y="5376672"/>
-            <a:ext cx="6766560" cy="228600"/>
+            <a:off x="9006840" y="2953512"/>
+            <a:ext cx="2350008" cy="292608"/>
           </a:xfrm>
           <a:prstGeom prst="rect">
             <a:avLst/>
@@ -9522,27 +9625,27 @@
           <a:p>
             <a:pPr algn="l"/>
             <a:r>
-              <a:rPr sz="1300" b="1">
-                <a:solidFill>
-                  <a:srgbClr val="F9A8D4"/>
+              <a:rPr sz="1400" b="1">
+                <a:solidFill>
+                  <a:srgbClr val="F8FAFC"/>
                 </a:solidFill>
                 <a:latin typeface="Calibri"/>
               </a:rPr>
-              <a:t>UAF owns  ·  Coupon Partners</a:t>
-            </a:r>
-          </a:p>
-        </p:txBody>
-      </p:sp>
-      <p:sp>
-        <p:nvSpPr>
-          <p:cNvPr id="33" name="TextBox 32"/>
+              <a:t>xapi / CRM</a:t>
+            </a:r>
+          </a:p>
+        </p:txBody>
+      </p:sp>
+      <p:sp>
+        <p:nvSpPr>
+          <p:cNvPr id="43" name="TextBox 42"/>
           <p:cNvSpPr txBox="1"/>
           <p:nvPr/>
         </p:nvSpPr>
         <p:spPr>
           <a:xfrm>
-            <a:off x="4892040" y="5650992"/>
-            <a:ext cx="6766560" cy="256032"/>
+            <a:off x="9006840" y="3246120"/>
+            <a:ext cx="2350008" cy="256032"/>
           </a:xfrm>
           <a:prstGeom prst="rect">
             <a:avLst/>
@@ -9557,27 +9660,366 @@
           <a:p>
             <a:pPr algn="l"/>
             <a:r>
-              <a:rPr sz="1200" b="0">
-                <a:solidFill>
-                  <a:srgbClr val="CBD5E1"/>
+              <a:rPr sz="1100" b="0">
+                <a:solidFill>
+                  <a:srgbClr val="FB923C"/>
                 </a:solidFill>
                 <a:latin typeface="Calibri"/>
               </a:rPr>
-              <a:t>COD    ·    Other partners (future)</a:t>
-            </a:r>
-          </a:p>
-        </p:txBody>
-      </p:sp>
-      <p:sp>
-        <p:nvSpPr>
-          <p:cNvPr id="34" name="Rounded Rectangle 33"/>
+              <a:t>UAF-owned</a:t>
+            </a:r>
+          </a:p>
+        </p:txBody>
+      </p:sp>
+      <p:sp>
+        <p:nvSpPr>
+          <p:cNvPr id="44" name="TextBox 43"/>
+          <p:cNvSpPr txBox="1"/>
+          <p:nvPr/>
+        </p:nvSpPr>
+        <p:spPr>
+          <a:xfrm>
+            <a:off x="9006840" y="3593592"/>
+            <a:ext cx="2350008" cy="256032"/>
+          </a:xfrm>
+          <a:prstGeom prst="rect">
+            <a:avLst/>
+          </a:prstGeom>
+          <a:noFill/>
+        </p:spPr>
+        <p:txBody>
+          <a:bodyPr wrap="square">
+            <a:spAutoFit/>
+          </a:bodyPr>
+          <a:lstStyle/>
+          <a:p>
+            <a:pPr algn="l"/>
+            <a:r>
+              <a:rPr sz="1100" b="0">
+                <a:solidFill>
+                  <a:srgbClr val="CBD5E1"/>
+                </a:solidFill>
+                <a:latin typeface="Calibri"/>
+              </a:rPr>
+              <a:t>• Balance views</a:t>
+            </a:r>
+          </a:p>
+        </p:txBody>
+      </p:sp>
+      <p:sp>
+        <p:nvSpPr>
+          <p:cNvPr id="45" name="TextBox 44"/>
+          <p:cNvSpPr txBox="1"/>
+          <p:nvPr/>
+        </p:nvSpPr>
+        <p:spPr>
+          <a:xfrm>
+            <a:off x="9006840" y="3849624"/>
+            <a:ext cx="2350008" cy="256032"/>
+          </a:xfrm>
+          <a:prstGeom prst="rect">
+            <a:avLst/>
+          </a:prstGeom>
+          <a:noFill/>
+        </p:spPr>
+        <p:txBody>
+          <a:bodyPr wrap="square">
+            <a:spAutoFit/>
+          </a:bodyPr>
+          <a:lstStyle/>
+          <a:p>
+            <a:pPr algn="l"/>
+            <a:r>
+              <a:rPr sz="1100" b="0">
+                <a:solidFill>
+                  <a:srgbClr val="CBD5E1"/>
+                </a:solidFill>
+                <a:latin typeface="Calibri"/>
+              </a:rPr>
+              <a:t>• Customer profile</a:t>
+            </a:r>
+          </a:p>
+        </p:txBody>
+      </p:sp>
+      <p:sp>
+        <p:nvSpPr>
+          <p:cNvPr id="46" name="TextBox 45"/>
+          <p:cNvSpPr txBox="1"/>
+          <p:nvPr/>
+        </p:nvSpPr>
+        <p:spPr>
+          <a:xfrm>
+            <a:off x="9006840" y="4105656"/>
+            <a:ext cx="2350008" cy="256032"/>
+          </a:xfrm>
+          <a:prstGeom prst="rect">
+            <a:avLst/>
+          </a:prstGeom>
+          <a:noFill/>
+        </p:spPr>
+        <p:txBody>
+          <a:bodyPr wrap="square">
+            <a:spAutoFit/>
+          </a:bodyPr>
+          <a:lstStyle/>
+          <a:p>
+            <a:pPr algn="l"/>
+            <a:r>
+              <a:rPr sz="1100" b="0">
+                <a:solidFill>
+                  <a:srgbClr val="CBD5E1"/>
+                </a:solidFill>
+                <a:latin typeface="Calibri"/>
+              </a:rPr>
+              <a:t>• Channel apps</a:t>
+            </a:r>
+          </a:p>
+        </p:txBody>
+      </p:sp>
+      <p:sp>
+        <p:nvSpPr>
+          <p:cNvPr id="47" name="TextBox 46"/>
+          <p:cNvSpPr txBox="1"/>
+          <p:nvPr/>
+        </p:nvSpPr>
+        <p:spPr>
+          <a:xfrm>
+            <a:off x="9006840" y="4361688"/>
+            <a:ext cx="2350008" cy="256032"/>
+          </a:xfrm>
+          <a:prstGeom prst="rect">
+            <a:avLst/>
+          </a:prstGeom>
+          <a:noFill/>
+        </p:spPr>
+        <p:txBody>
+          <a:bodyPr wrap="square">
+            <a:spAutoFit/>
+          </a:bodyPr>
+          <a:lstStyle/>
+          <a:p>
+            <a:pPr algn="l"/>
+            <a:r>
+              <a:rPr sz="1100" b="0">
+                <a:solidFill>
+                  <a:srgbClr val="CBD5E1"/>
+                </a:solidFill>
+                <a:latin typeface="Calibri"/>
+              </a:rPr>
+              <a:t>  (Yes UA · aim)</a:t>
+            </a:r>
+          </a:p>
+        </p:txBody>
+      </p:sp>
+      <p:sp>
+        <p:nvSpPr>
+          <p:cNvPr id="48" name="Rounded Rectangle 47"/>
           <p:cNvSpPr/>
           <p:nvPr/>
         </p:nvSpPr>
         <p:spPr>
           <a:xfrm>
-            <a:off x="365760" y="6172200"/>
-            <a:ext cx="11460175" cy="457200"/>
+            <a:off x="457200" y="5257800"/>
+            <a:ext cx="2606040" cy="640080"/>
+          </a:xfrm>
+          <a:prstGeom prst="roundRect">
+            <a:avLst>
+              <a:gd name="adj" fmla="val 10000"/>
+            </a:avLst>
+          </a:prstGeom>
+          <a:solidFill>
+            <a:srgbClr val="2A1424"/>
+          </a:solidFill>
+          <a:ln w="15875">
+            <a:solidFill>
+              <a:srgbClr val="F9A8D4"/>
+            </a:solidFill>
+          </a:ln>
+        </p:spPr>
+        <p:style>
+          <a:lnRef idx="1">
+            <a:schemeClr val="accent1"/>
+          </a:lnRef>
+          <a:fillRef idx="3">
+            <a:schemeClr val="accent1"/>
+          </a:fillRef>
+          <a:effectRef idx="2">
+            <a:schemeClr val="accent1"/>
+          </a:effectRef>
+          <a:fontRef idx="minor">
+            <a:schemeClr val="lt1"/>
+          </a:fontRef>
+        </p:style>
+        <p:txBody>
+          <a:bodyPr rtlCol="0" anchor="ctr"/>
+          <a:lstStyle/>
+          <a:p>
+            <a:pPr algn="ctr"/>
+          </a:p>
+        </p:txBody>
+      </p:sp>
+      <p:sp>
+        <p:nvSpPr>
+          <p:cNvPr id="49" name="TextBox 48"/>
+          <p:cNvSpPr txBox="1"/>
+          <p:nvPr/>
+        </p:nvSpPr>
+        <p:spPr>
+          <a:xfrm>
+            <a:off x="566928" y="5321808"/>
+            <a:ext cx="2386584" cy="228600"/>
+          </a:xfrm>
+          <a:prstGeom prst="rect">
+            <a:avLst/>
+          </a:prstGeom>
+          <a:noFill/>
+        </p:spPr>
+        <p:txBody>
+          <a:bodyPr wrap="square">
+            <a:spAutoFit/>
+          </a:bodyPr>
+          <a:lstStyle/>
+          <a:p>
+            <a:pPr algn="l"/>
+            <a:r>
+              <a:rPr sz="1100" b="1">
+                <a:solidFill>
+                  <a:srgbClr val="F9A8D4"/>
+                </a:solidFill>
+                <a:latin typeface="Calibri"/>
+              </a:rPr>
+              <a:t>↓ then UAF partners</a:t>
+            </a:r>
+          </a:p>
+        </p:txBody>
+      </p:sp>
+      <p:sp>
+        <p:nvSpPr>
+          <p:cNvPr id="50" name="TextBox 49"/>
+          <p:cNvSpPr txBox="1"/>
+          <p:nvPr/>
+        </p:nvSpPr>
+        <p:spPr>
+          <a:xfrm>
+            <a:off x="566928" y="5577840"/>
+            <a:ext cx="2386584" cy="228600"/>
+          </a:xfrm>
+          <a:prstGeom prst="rect">
+            <a:avLst/>
+          </a:prstGeom>
+          <a:noFill/>
+        </p:spPr>
+        <p:txBody>
+          <a:bodyPr wrap="square">
+            <a:spAutoFit/>
+          </a:bodyPr>
+          <a:lstStyle/>
+          <a:p>
+            <a:pPr algn="l"/>
+            <a:r>
+              <a:rPr sz="1100" b="0">
+                <a:solidFill>
+                  <a:srgbClr val="CBD5E1"/>
+                </a:solidFill>
+                <a:latin typeface="Calibri"/>
+              </a:rPr>
+              <a:t>COD  ·  other coupon partners</a:t>
+            </a:r>
+          </a:p>
+        </p:txBody>
+      </p:sp>
+      <p:sp>
+        <p:nvSpPr>
+          <p:cNvPr id="51" name="Rounded Rectangle 50"/>
+          <p:cNvSpPr/>
+          <p:nvPr/>
+        </p:nvSpPr>
+        <p:spPr>
+          <a:xfrm>
+            <a:off x="3264408" y="5257800"/>
+            <a:ext cx="8412480" cy="640080"/>
+          </a:xfrm>
+          <a:prstGeom prst="roundRect">
+            <a:avLst>
+              <a:gd name="adj" fmla="val 10000"/>
+            </a:avLst>
+          </a:prstGeom>
+          <a:solidFill>
+            <a:srgbClr val="102A48"/>
+          </a:solidFill>
+          <a:ln w="15875">
+            <a:solidFill>
+              <a:srgbClr val="2DD4BF"/>
+            </a:solidFill>
+          </a:ln>
+        </p:spPr>
+        <p:style>
+          <a:lnRef idx="1">
+            <a:schemeClr val="accent1"/>
+          </a:lnRef>
+          <a:fillRef idx="3">
+            <a:schemeClr val="accent1"/>
+          </a:fillRef>
+          <a:effectRef idx="2">
+            <a:schemeClr val="accent1"/>
+          </a:effectRef>
+          <a:fontRef idx="minor">
+            <a:schemeClr val="lt1"/>
+          </a:fontRef>
+        </p:style>
+        <p:txBody>
+          <a:bodyPr rtlCol="0" anchor="ctr"/>
+          <a:lstStyle/>
+          <a:p>
+            <a:pPr algn="ctr"/>
+          </a:p>
+        </p:txBody>
+      </p:sp>
+      <p:sp>
+        <p:nvSpPr>
+          <p:cNvPr id="52" name="TextBox 51"/>
+          <p:cNvSpPr txBox="1"/>
+          <p:nvPr/>
+        </p:nvSpPr>
+        <p:spPr>
+          <a:xfrm>
+            <a:off x="3447288" y="5349240"/>
+            <a:ext cx="8046720" cy="457200"/>
+          </a:xfrm>
+          <a:prstGeom prst="rect">
+            <a:avLst/>
+          </a:prstGeom>
+          <a:noFill/>
+        </p:spPr>
+        <p:txBody>
+          <a:bodyPr wrap="square">
+            <a:spAutoFit/>
+          </a:bodyPr>
+          <a:lstStyle/>
+          <a:p>
+            <a:pPr algn="l"/>
+            <a:r>
+              <a:rPr sz="1300" b="1">
+                <a:solidFill>
+                  <a:srgbClr val="F8FAFC"/>
+                </a:solidFill>
+                <a:latin typeface="Calibri"/>
+              </a:rPr>
+              <a:t>Pitch line:  You buy LedgeRX (Reward System).  CBP stays yours — it simply becomes one Landing consumer of our engine’s events.</a:t>
+            </a:r>
+          </a:p>
+        </p:txBody>
+      </p:sp>
+      <p:sp>
+        <p:nvSpPr>
+          <p:cNvPr id="53" name="Rounded Rectangle 52"/>
+          <p:cNvSpPr/>
+          <p:nvPr/>
+        </p:nvSpPr>
+        <p:spPr>
+          <a:xfrm>
+            <a:off x="365760" y="6080760"/>
+            <a:ext cx="11460175" cy="502920"/>
           </a:xfrm>
           <a:prstGeom prst="roundRect">
             <a:avLst>
@@ -9617,13 +10059,13 @@
       </p:sp>
       <p:sp>
         <p:nvSpPr>
-          <p:cNvPr id="35" name="TextBox 34"/>
+          <p:cNvPr id="54" name="TextBox 53"/>
           <p:cNvSpPr txBox="1"/>
           <p:nvPr/>
         </p:nvSpPr>
         <p:spPr>
           <a:xfrm>
-            <a:off x="502920" y="6263640"/>
+            <a:off x="502920" y="6199632"/>
             <a:ext cx="11155680" cy="320040"/>
           </a:xfrm>
           <a:prstGeom prst="rect">
@@ -9639,13 +10081,13 @@
           <a:p>
             <a:pPr algn="l"/>
             <a:r>
-              <a:rPr sz="1200" b="0">
+              <a:rPr sz="1300" b="0">
                 <a:solidFill>
                   <a:srgbClr val="CBD5E1"/>
                 </a:solidFill>
                 <a:latin typeface="Calibri"/>
               </a:rPr>
-              <a:t>Clear split:   LedgeRX earns &amp; decides rewards   ·   UAF CBP turns outcomes into coupons / gifts / partner fulfill   ·   Apps stay the same</a:t>
+              <a:t>Not peer-to-peer platforms   ·   LedgeRX is the product hub   ·   CBP / Gift / Notify / CRM are downstream spokes</a:t>
             </a:r>
           </a:p>
         </p:txBody>

</xml_diff>

<commit_message>
docs(decks): unified UAF Landing 對口 layer — sole interface to LedgeRX
</commit_message>
<xml_diff>
--- a/docs/decks/LedgeRX-System-Architecture-CTO.pptx
+++ b/docs/decks/LedgeRX-System-Architecture-CTO.pptx
@@ -3639,7 +3639,7 @@
                 <a:spcPts val="0"/>
               </a:spcBef>
               <a:spcAft>
-                <a:spcPts val="200"/>
+                <a:spcPts val="100"/>
               </a:spcAft>
             </a:pPr>
             <a:r>
@@ -3658,7 +3658,7 @@
                 <a:spcPts val="0"/>
               </a:spcBef>
               <a:spcAft>
-                <a:spcPts val="200"/>
+                <a:spcPts val="100"/>
               </a:spcAft>
             </a:pPr>
             <a:r>
@@ -3790,7 +3790,7 @@
                 <a:spcPts val="0"/>
               </a:spcBef>
               <a:spcAft>
-                <a:spcPts val="200"/>
+                <a:spcPts val="100"/>
               </a:spcAft>
             </a:pPr>
             <a:r>
@@ -3809,7 +3809,7 @@
                 <a:spcPts val="0"/>
               </a:spcBef>
               <a:spcAft>
-                <a:spcPts val="200"/>
+                <a:spcPts val="100"/>
               </a:spcAft>
             </a:pPr>
             <a:r>
@@ -3941,7 +3941,7 @@
                 <a:spcPts val="0"/>
               </a:spcBef>
               <a:spcAft>
-                <a:spcPts val="200"/>
+                <a:spcPts val="100"/>
               </a:spcAft>
             </a:pPr>
             <a:r>
@@ -3960,7 +3960,7 @@
                 <a:spcPts val="0"/>
               </a:spcBef>
               <a:spcAft>
-                <a:spcPts val="200"/>
+                <a:spcPts val="100"/>
               </a:spcAft>
             </a:pPr>
             <a:r>
@@ -4358,7 +4358,7 @@
                 <a:spcPts val="0"/>
               </a:spcBef>
               <a:spcAft>
-                <a:spcPts val="200"/>
+                <a:spcPts val="100"/>
               </a:spcAft>
             </a:pPr>
             <a:r>
@@ -4377,7 +4377,7 @@
                 <a:spcPts val="0"/>
               </a:spcBef>
               <a:spcAft>
-                <a:spcPts val="200"/>
+                <a:spcPts val="100"/>
               </a:spcAft>
             </a:pPr>
             <a:r>
@@ -4509,7 +4509,7 @@
                 <a:spcPts val="0"/>
               </a:spcBef>
               <a:spcAft>
-                <a:spcPts val="200"/>
+                <a:spcPts val="100"/>
               </a:spcAft>
             </a:pPr>
             <a:r>
@@ -4528,7 +4528,7 @@
                 <a:spcPts val="0"/>
               </a:spcBef>
               <a:spcAft>
-                <a:spcPts val="200"/>
+                <a:spcPts val="100"/>
               </a:spcAft>
             </a:pPr>
             <a:r>
@@ -4660,7 +4660,7 @@
                 <a:spcPts val="0"/>
               </a:spcBef>
               <a:spcAft>
-                <a:spcPts val="200"/>
+                <a:spcPts val="100"/>
               </a:spcAft>
             </a:pPr>
             <a:r>
@@ -4679,7 +4679,7 @@
                 <a:spcPts val="0"/>
               </a:spcBef>
               <a:spcAft>
-                <a:spcPts val="200"/>
+                <a:spcPts val="100"/>
               </a:spcAft>
             </a:pPr>
             <a:r>
@@ -5184,7 +5184,7 @@
                 <a:spcPts val="0"/>
               </a:spcBef>
               <a:spcAft>
-                <a:spcPts val="200"/>
+                <a:spcPts val="100"/>
               </a:spcAft>
             </a:pPr>
             <a:r>
@@ -5203,7 +5203,7 @@
                 <a:spcPts val="0"/>
               </a:spcBef>
               <a:spcAft>
-                <a:spcPts val="200"/>
+                <a:spcPts val="100"/>
               </a:spcAft>
             </a:pPr>
             <a:r>
@@ -5335,7 +5335,7 @@
                 <a:spcPts val="0"/>
               </a:spcBef>
               <a:spcAft>
-                <a:spcPts val="200"/>
+                <a:spcPts val="100"/>
               </a:spcAft>
             </a:pPr>
             <a:r>
@@ -5354,7 +5354,7 @@
                 <a:spcPts val="0"/>
               </a:spcBef>
               <a:spcAft>
-                <a:spcPts val="200"/>
+                <a:spcPts val="100"/>
               </a:spcAft>
             </a:pPr>
             <a:r>
@@ -5486,7 +5486,7 @@
                 <a:spcPts val="0"/>
               </a:spcBef>
               <a:spcAft>
-                <a:spcPts val="200"/>
+                <a:spcPts val="100"/>
               </a:spcAft>
             </a:pPr>
             <a:r>
@@ -5505,7 +5505,7 @@
                 <a:spcPts val="0"/>
               </a:spcBef>
               <a:spcAft>
-                <a:spcPts val="200"/>
+                <a:spcPts val="100"/>
               </a:spcAft>
             </a:pPr>
             <a:r>
@@ -5637,7 +5637,7 @@
                 <a:spcPts val="0"/>
               </a:spcBef>
               <a:spcAft>
-                <a:spcPts val="200"/>
+                <a:spcPts val="100"/>
               </a:spcAft>
             </a:pPr>
             <a:r>
@@ -5656,7 +5656,7 @@
                 <a:spcPts val="0"/>
               </a:spcBef>
               <a:spcAft>
-                <a:spcPts val="200"/>
+                <a:spcPts val="100"/>
               </a:spcAft>
             </a:pPr>
             <a:r>
@@ -5788,7 +5788,7 @@
                 <a:spcPts val="0"/>
               </a:spcBef>
               <a:spcAft>
-                <a:spcPts val="200"/>
+                <a:spcPts val="100"/>
               </a:spcAft>
             </a:pPr>
             <a:r>
@@ -5807,7 +5807,7 @@
                 <a:spcPts val="0"/>
               </a:spcBef>
               <a:spcAft>
-                <a:spcPts val="200"/>
+                <a:spcPts val="100"/>
               </a:spcAft>
             </a:pPr>
             <a:r>
@@ -5939,7 +5939,7 @@
                 <a:spcPts val="0"/>
               </a:spcBef>
               <a:spcAft>
-                <a:spcPts val="200"/>
+                <a:spcPts val="100"/>
               </a:spcAft>
             </a:pPr>
             <a:r>
@@ -5958,7 +5958,7 @@
                 <a:spcPts val="0"/>
               </a:spcBef>
               <a:spcAft>
-                <a:spcPts val="200"/>
+                <a:spcPts val="100"/>
               </a:spcAft>
             </a:pPr>
             <a:r>
@@ -6490,7 +6490,7 @@
                 <a:spcPts val="0"/>
               </a:spcBef>
               <a:spcAft>
-                <a:spcPts val="200"/>
+                <a:spcPts val="100"/>
               </a:spcAft>
             </a:pPr>
             <a:r>
@@ -6509,7 +6509,7 @@
                 <a:spcPts val="0"/>
               </a:spcBef>
               <a:spcAft>
-                <a:spcPts val="200"/>
+                <a:spcPts val="100"/>
               </a:spcAft>
             </a:pPr>
             <a:r>
@@ -6641,7 +6641,7 @@
                 <a:spcPts val="0"/>
               </a:spcBef>
               <a:spcAft>
-                <a:spcPts val="200"/>
+                <a:spcPts val="100"/>
               </a:spcAft>
             </a:pPr>
             <a:r>
@@ -6660,7 +6660,7 @@
                 <a:spcPts val="0"/>
               </a:spcBef>
               <a:spcAft>
-                <a:spcPts val="200"/>
+                <a:spcPts val="100"/>
               </a:spcAft>
             </a:pPr>
             <a:r>
@@ -6792,7 +6792,7 @@
                 <a:spcPts val="0"/>
               </a:spcBef>
               <a:spcAft>
-                <a:spcPts val="200"/>
+                <a:spcPts val="100"/>
               </a:spcAft>
             </a:pPr>
             <a:r>
@@ -6811,7 +6811,7 @@
                 <a:spcPts val="0"/>
               </a:spcBef>
               <a:spcAft>
-                <a:spcPts val="200"/>
+                <a:spcPts val="100"/>
               </a:spcAft>
             </a:pPr>
             <a:r>
@@ -7081,7 +7081,7 @@
         <p:spPr>
           <a:xfrm>
             <a:off x="10351965" y="1261872"/>
-            <a:ext cx="1400815" cy="365760"/>
+            <a:ext cx="1400815" cy="502920"/>
           </a:xfrm>
           <a:prstGeom prst="rect">
             <a:avLst/>
@@ -7102,7 +7102,8 @@
                 </a:solidFill>
                 <a:latin typeface="Calibri"/>
               </a:rPr>
-              <a:t>Product outlets</a:t>
+              <a:t>One UAF layer
+(see slide 2)</a:t>
             </a:r>
           </a:p>
         </p:txBody>
@@ -7115,7 +7116,7 @@
         </p:nvSpPr>
         <p:spPr>
           <a:xfrm>
-            <a:off x="10351965" y="1828800"/>
+            <a:off x="10351965" y="1874520"/>
             <a:ext cx="1382527" cy="777240"/>
           </a:xfrm>
           <a:prstGeom prst="roundRect">
@@ -7162,7 +7163,7 @@
         </p:nvSpPr>
         <p:spPr>
           <a:xfrm>
-            <a:off x="10351965" y="1920240"/>
+            <a:off x="10351965" y="1965960"/>
             <a:ext cx="50292" cy="594360"/>
           </a:xfrm>
           <a:prstGeom prst="rect">
@@ -7205,7 +7206,7 @@
         </p:nvSpPr>
         <p:spPr>
           <a:xfrm>
-            <a:off x="10498269" y="1938528"/>
+            <a:off x="10498269" y="1984248"/>
             <a:ext cx="1144783" cy="612648"/>
           </a:xfrm>
           <a:prstGeom prst="rect">
@@ -7224,7 +7225,7 @@
                 <a:spcPts val="0"/>
               </a:spcBef>
               <a:spcAft>
-                <a:spcPts val="200"/>
+                <a:spcPts val="100"/>
               </a:spcAft>
             </a:pPr>
             <a:r>
@@ -7234,7 +7235,7 @@
                 </a:solidFill>
                 <a:latin typeface="Calibri"/>
               </a:rPr>
-              <a:t>E-coupon / CBP</a:t>
+              <a:t>Unified hub</a:t>
             </a:r>
           </a:p>
           <a:p>
@@ -7243,7 +7244,7 @@
                 <a:spcPts val="0"/>
               </a:spcBef>
               <a:spcAft>
-                <a:spcPts val="200"/>
+                <a:spcPts val="100"/>
               </a:spcAft>
             </a:pPr>
             <a:r>
@@ -7253,7 +7254,7 @@
                 </a:solidFill>
                 <a:latin typeface="Calibri"/>
               </a:rPr>
-              <a:t>One downstream</a:t>
+              <a:t>Only 對口</a:t>
             </a:r>
           </a:p>
         </p:txBody>
@@ -7266,7 +7267,7 @@
         </p:nvSpPr>
         <p:spPr>
           <a:xfrm>
-            <a:off x="10351965" y="2697480"/>
+            <a:off x="10351965" y="2743200"/>
             <a:ext cx="1382527" cy="777240"/>
           </a:xfrm>
           <a:prstGeom prst="roundRect">
@@ -7313,7 +7314,7 @@
         </p:nvSpPr>
         <p:spPr>
           <a:xfrm>
-            <a:off x="10351965" y="2788920"/>
+            <a:off x="10351965" y="2834640"/>
             <a:ext cx="50292" cy="594360"/>
           </a:xfrm>
           <a:prstGeom prst="rect">
@@ -7356,7 +7357,7 @@
         </p:nvSpPr>
         <p:spPr>
           <a:xfrm>
-            <a:off x="10498269" y="2807208"/>
+            <a:off x="10498269" y="2852928"/>
             <a:ext cx="1144783" cy="612648"/>
           </a:xfrm>
           <a:prstGeom prst="rect">
@@ -7375,7 +7376,7 @@
                 <a:spcPts val="0"/>
               </a:spcBef>
               <a:spcAft>
-                <a:spcPts val="200"/>
+                <a:spcPts val="100"/>
               </a:spcAft>
             </a:pPr>
             <a:r>
@@ -7385,7 +7386,7 @@
                 </a:solidFill>
                 <a:latin typeface="Calibri"/>
               </a:rPr>
-              <a:t>Gift</a:t>
+              <a:t>→ CBP / Gift</a:t>
             </a:r>
           </a:p>
           <a:p>
@@ -7394,7 +7395,7 @@
                 <a:spcPts val="0"/>
               </a:spcBef>
               <a:spcAft>
-                <a:spcPts val="200"/>
+                <a:spcPts val="100"/>
               </a:spcAft>
             </a:pPr>
             <a:r>
@@ -7404,7 +7405,7 @@
                 </a:solidFill>
                 <a:latin typeface="Calibri"/>
               </a:rPr>
-              <a:t>Fulfillment</a:t>
+              <a:t>…</a:t>
             </a:r>
           </a:p>
         </p:txBody>
@@ -7417,7 +7418,7 @@
         </p:nvSpPr>
         <p:spPr>
           <a:xfrm>
-            <a:off x="10351965" y="3566160"/>
+            <a:off x="10351965" y="3611880"/>
             <a:ext cx="1382527" cy="777240"/>
           </a:xfrm>
           <a:prstGeom prst="roundRect">
@@ -7464,7 +7465,7 @@
         </p:nvSpPr>
         <p:spPr>
           <a:xfrm>
-            <a:off x="10351965" y="3657600"/>
+            <a:off x="10351965" y="3703320"/>
             <a:ext cx="50292" cy="594360"/>
           </a:xfrm>
           <a:prstGeom prst="rect">
@@ -7507,7 +7508,7 @@
         </p:nvSpPr>
         <p:spPr>
           <a:xfrm>
-            <a:off x="10498269" y="3675888"/>
+            <a:off x="10498269" y="3721608"/>
             <a:ext cx="1144783" cy="612648"/>
           </a:xfrm>
           <a:prstGeom prst="rect">
@@ -7526,7 +7527,7 @@
                 <a:spcPts val="0"/>
               </a:spcBef>
               <a:spcAft>
-                <a:spcPts val="200"/>
+                <a:spcPts val="100"/>
               </a:spcAft>
             </a:pPr>
             <a:r>
@@ -7536,7 +7537,7 @@
                 </a:solidFill>
                 <a:latin typeface="Calibri"/>
               </a:rPr>
-              <a:t>Notify</a:t>
+              <a:t>→ Notify</a:t>
             </a:r>
           </a:p>
           <a:p>
@@ -7545,7 +7546,7 @@
                 <a:spcPts val="0"/>
               </a:spcBef>
               <a:spcAft>
-                <a:spcPts val="200"/>
+                <a:spcPts val="100"/>
               </a:spcAft>
             </a:pPr>
             <a:r>
@@ -7555,7 +7556,7 @@
                 </a:solidFill>
                 <a:latin typeface="Calibri"/>
               </a:rPr>
-              <a:t>Push · SMS</a:t>
+              <a:t>…</a:t>
             </a:r>
           </a:p>
         </p:txBody>
@@ -7568,7 +7569,7 @@
         </p:nvSpPr>
         <p:spPr>
           <a:xfrm>
-            <a:off x="10351965" y="4434839"/>
+            <a:off x="10351965" y="4480559"/>
             <a:ext cx="1382527" cy="777240"/>
           </a:xfrm>
           <a:prstGeom prst="roundRect">
@@ -7615,7 +7616,7 @@
         </p:nvSpPr>
         <p:spPr>
           <a:xfrm>
-            <a:off x="10351965" y="4526279"/>
+            <a:off x="10351965" y="4571999"/>
             <a:ext cx="50292" cy="594360"/>
           </a:xfrm>
           <a:prstGeom prst="rect">
@@ -7658,7 +7659,7 @@
         </p:nvSpPr>
         <p:spPr>
           <a:xfrm>
-            <a:off x="10498269" y="4544567"/>
+            <a:off x="10498269" y="4590287"/>
             <a:ext cx="1144783" cy="612648"/>
           </a:xfrm>
           <a:prstGeom prst="rect">
@@ -7677,7 +7678,7 @@
                 <a:spcPts val="0"/>
               </a:spcBef>
               <a:spcAft>
-                <a:spcPts val="200"/>
+                <a:spcPts val="100"/>
               </a:spcAft>
             </a:pPr>
             <a:r>
@@ -7687,7 +7688,7 @@
                 </a:solidFill>
                 <a:latin typeface="Calibri"/>
               </a:rPr>
-              <a:t>xapi / CRM</a:t>
+              <a:t>→ xapi</a:t>
             </a:r>
           </a:p>
           <a:p>
@@ -7696,7 +7697,7 @@
                 <a:spcPts val="0"/>
               </a:spcBef>
               <a:spcAft>
-                <a:spcPts val="200"/>
+                <a:spcPts val="100"/>
               </a:spcAft>
             </a:pPr>
             <a:r>
@@ -7706,7 +7707,7 @@
                 </a:solidFill>
                 <a:latin typeface="Calibri"/>
               </a:rPr>
-              <a:t>Balances</a:t>
+              <a:t>…</a:t>
             </a:r>
           </a:p>
         </p:txBody>
@@ -8003,7 +8004,7 @@
                 </a:solidFill>
                 <a:latin typeface="Calibri"/>
               </a:rPr>
-              <a:t>LedgeRX = product     ·     Landing = many downstream outlets (CBP is one)     ·     see slide 2</a:t>
+              <a:t>LedgeRX = product hub     ·     one Landing 對口 layer on UAF side     ·     then UAF systems fan-out</a:t>
             </a:r>
           </a:p>
         </p:txBody>
@@ -8155,7 +8156,7 @@
         </p:nvSpPr>
         <p:spPr>
           <a:xfrm>
-            <a:off x="365760" y="128016"/>
+            <a:off x="365760" y="109728"/>
             <a:ext cx="9601200" cy="292608"/>
           </a:xfrm>
           <a:prstGeom prst="rect">
@@ -8177,7 +8178,7 @@
                 </a:solidFill>
                 <a:latin typeface="Calibri"/>
               </a:rPr>
-              <a:t>Landing Edge  ·  Downstream of LedgeRX (our product)</a:t>
+              <a:t>Landing  ·  One unified 對口 to LedgeRX</a:t>
             </a:r>
           </a:p>
         </p:txBody>
@@ -8190,8 +8191,8 @@
         </p:nvSpPr>
         <p:spPr>
           <a:xfrm>
-            <a:off x="365760" y="420624"/>
-            <a:ext cx="9601200" cy="256032"/>
+            <a:off x="365760" y="384048"/>
+            <a:ext cx="9601200" cy="237744"/>
           </a:xfrm>
           <a:prstGeom prst="rect">
             <a:avLst/>
@@ -8206,13 +8207,13 @@
           <a:p>
             <a:pPr algn="l"/>
             <a:r>
-              <a:rPr sz="1300" b="0">
+              <a:rPr sz="1200" b="0">
                 <a:solidFill>
                   <a:srgbClr val="94A3B8"/>
                 </a:solidFill>
                 <a:latin typeface="Calibri"/>
               </a:rPr>
-              <a:t>CBP is not a peer system — it is one consumer of LedgeRX outcomes</a:t>
+              <a:t>LedgeRX talks to a single UAF layer only  ·  that layer applies UAF business logic  ·  then fans out internally</a:t>
             </a:r>
           </a:p>
         </p:txBody>
@@ -8225,8 +8226,8 @@
         </p:nvSpPr>
         <p:spPr>
           <a:xfrm>
-            <a:off x="10241280" y="146304"/>
-            <a:ext cx="1554480" cy="365760"/>
+            <a:off x="10241280" y="128016"/>
+            <a:ext cx="1554480" cy="347472"/>
           </a:xfrm>
           <a:prstGeom prst="roundRect">
             <a:avLst>
@@ -8272,8 +8273,8 @@
         </p:nvSpPr>
         <p:spPr>
           <a:xfrm>
-            <a:off x="10241280" y="201168"/>
-            <a:ext cx="1554480" cy="274320"/>
+            <a:off x="10241280" y="182880"/>
+            <a:ext cx="1554480" cy="256032"/>
           </a:xfrm>
           <a:prstGeom prst="rect">
             <a:avLst/>
@@ -8307,8 +8308,8 @@
         </p:nvSpPr>
         <p:spPr>
           <a:xfrm>
-            <a:off x="365760" y="804672"/>
-            <a:ext cx="11457432" cy="1234440"/>
+            <a:off x="365760" y="731520"/>
+            <a:ext cx="11457432" cy="1051560"/>
           </a:xfrm>
           <a:prstGeom prst="roundRect">
             <a:avLst>
@@ -8354,8 +8355,8 @@
         </p:nvSpPr>
         <p:spPr>
           <a:xfrm>
-            <a:off x="502920" y="914400"/>
-            <a:ext cx="2194560" cy="347472"/>
+            <a:off x="502920" y="841248"/>
+            <a:ext cx="1965960" cy="320040"/>
           </a:xfrm>
           <a:prstGeom prst="roundRect">
             <a:avLst>
@@ -8399,8 +8400,8 @@
         </p:nvSpPr>
         <p:spPr>
           <a:xfrm>
-            <a:off x="502920" y="960120"/>
-            <a:ext cx="2194560" cy="274320"/>
+            <a:off x="502920" y="877824"/>
+            <a:ext cx="1965960" cy="256032"/>
           </a:xfrm>
           <a:prstGeom prst="rect">
             <a:avLst/>
@@ -8415,7 +8416,7 @@
           <a:p>
             <a:pPr algn="ctr"/>
             <a:r>
-              <a:rPr sz="1200" b="1">
+              <a:rPr sz="1100" b="1">
                 <a:solidFill>
                   <a:srgbClr val="0B1220"/>
                 </a:solidFill>
@@ -8434,8 +8435,8 @@
         </p:nvSpPr>
         <p:spPr>
           <a:xfrm>
-            <a:off x="2834640" y="914400"/>
-            <a:ext cx="8686800" cy="292608"/>
+            <a:off x="2651760" y="822960"/>
+            <a:ext cx="8686800" cy="274320"/>
           </a:xfrm>
           <a:prstGeom prst="rect">
             <a:avLst/>
@@ -8450,7 +8451,7 @@
           <a:p>
             <a:pPr algn="l"/>
             <a:r>
-              <a:rPr sz="1800" b="1">
+              <a:rPr sz="1700" b="1">
                 <a:solidFill>
                   <a:srgbClr val="2DD4BF"/>
                 </a:solidFill>
@@ -8469,8 +8470,8 @@
         </p:nvSpPr>
         <p:spPr>
           <a:xfrm>
-            <a:off x="2834640" y="1261872"/>
-            <a:ext cx="8686800" cy="502920"/>
+            <a:off x="2651760" y="1143000"/>
+            <a:ext cx="8686800" cy="411480"/>
           </a:xfrm>
           <a:prstGeom prst="rect">
             <a:avLst/>
@@ -8491,56 +8492,21 @@
                 </a:solidFill>
                 <a:latin typeface="Calibri"/>
               </a:rPr>
-              <a:t>Earn / burn points  ·  wallets &amp; ledgers  ·  rules &amp; COA  ·  emits: balance.updated  ·  reward redemption request  ·  …</a:t>
-            </a:r>
-          </a:p>
-        </p:txBody>
-      </p:sp>
-      <p:sp>
-        <p:nvSpPr>
-          <p:cNvPr id="13" name="TextBox 12"/>
-          <p:cNvSpPr txBox="1"/>
-          <p:nvPr/>
-        </p:nvSpPr>
-        <p:spPr>
-          <a:xfrm>
-            <a:off x="365760" y="2194560"/>
-            <a:ext cx="11430000" cy="274320"/>
-          </a:xfrm>
-          <a:prstGeom prst="rect">
-            <a:avLst/>
-          </a:prstGeom>
-          <a:noFill/>
-        </p:spPr>
-        <p:txBody>
-          <a:bodyPr wrap="square">
-            <a:spAutoFit/>
-          </a:bodyPr>
-          <a:lstStyle/>
-          <a:p>
-            <a:pPr algn="l"/>
-            <a:r>
-              <a:rPr sz="1300" b="1">
-                <a:solidFill>
-                  <a:srgbClr val="C4B5FD"/>
-                </a:solidFill>
-                <a:latin typeface="Calibri"/>
-              </a:rPr>
-              <a:t>LedgeRX Landing Edge  →  multiple downstream systems (UAF-operated)</a:t>
-            </a:r>
-          </a:p>
-        </p:txBody>
-      </p:sp>
-      <p:sp>
-        <p:nvSpPr>
-          <p:cNvPr id="14" name="Down Arrow 13"/>
+              <a:t>Emits only:   balance.updated   ·   reward redemption request   ·   other ledger outcomes   ·   (Kafka / webhook)</a:t>
+            </a:r>
+          </a:p>
+        </p:txBody>
+      </p:sp>
+      <p:sp>
+        <p:nvSpPr>
+          <p:cNvPr id="13" name="Down Arrow 12"/>
           <p:cNvSpPr/>
           <p:nvPr/>
         </p:nvSpPr>
         <p:spPr>
           <a:xfrm>
-            <a:off x="1463040" y="2514600"/>
-            <a:ext cx="164592" cy="201168"/>
+            <a:off x="5943600" y="1874519"/>
+            <a:ext cx="201168" cy="237744"/>
           </a:xfrm>
           <a:prstGeom prst="downArrow">
             <a:avLst/>
@@ -8576,23 +8542,97 @@
       </p:sp>
       <p:sp>
         <p:nvSpPr>
-          <p:cNvPr id="15" name="Down Arrow 14"/>
+          <p:cNvPr id="14" name="TextBox 13"/>
+          <p:cNvSpPr txBox="1"/>
+          <p:nvPr/>
+        </p:nvSpPr>
+        <p:spPr>
+          <a:xfrm>
+            <a:off x="5029200" y="1901952"/>
+            <a:ext cx="914400" cy="228600"/>
+          </a:xfrm>
+          <a:prstGeom prst="rect">
+            <a:avLst/>
+          </a:prstGeom>
+          <a:noFill/>
+        </p:spPr>
+        <p:txBody>
+          <a:bodyPr wrap="square">
+            <a:spAutoFit/>
+          </a:bodyPr>
+          <a:lstStyle/>
+          <a:p>
+            <a:pPr algn="l"/>
+            <a:r>
+              <a:rPr sz="800" b="0">
+                <a:solidFill>
+                  <a:srgbClr val="64748B"/>
+                </a:solidFill>
+                <a:latin typeface="Calibri"/>
+              </a:rPr>
+              <a:t/>
+            </a:r>
+          </a:p>
+        </p:txBody>
+      </p:sp>
+      <p:sp>
+        <p:nvSpPr>
+          <p:cNvPr id="15" name="TextBox 14"/>
+          <p:cNvSpPr txBox="1"/>
+          <p:nvPr/>
+        </p:nvSpPr>
+        <p:spPr>
+          <a:xfrm>
+            <a:off x="6263640" y="1920240"/>
+            <a:ext cx="2286000" cy="228600"/>
+          </a:xfrm>
+          <a:prstGeom prst="rect">
+            <a:avLst/>
+          </a:prstGeom>
+          <a:noFill/>
+        </p:spPr>
+        <p:txBody>
+          <a:bodyPr wrap="square">
+            <a:spAutoFit/>
+          </a:bodyPr>
+          <a:lstStyle/>
+          <a:p>
+            <a:pPr algn="l"/>
+            <a:r>
+              <a:rPr sz="1100" b="1">
+                <a:solidFill>
+                  <a:srgbClr val="2DD4BF"/>
+                </a:solidFill>
+                <a:latin typeface="Calibri"/>
+              </a:rPr>
+              <a:t>sole interface</a:t>
+            </a:r>
+          </a:p>
+        </p:txBody>
+      </p:sp>
+      <p:sp>
+        <p:nvSpPr>
+          <p:cNvPr id="16" name="Rounded Rectangle 15"/>
           <p:cNvSpPr/>
           <p:nvPr/>
         </p:nvSpPr>
         <p:spPr>
           <a:xfrm>
-            <a:off x="4114800" y="2514600"/>
-            <a:ext cx="164592" cy="201168"/>
-          </a:xfrm>
-          <a:prstGeom prst="downArrow">
-            <a:avLst/>
-          </a:prstGeom>
-          <a:solidFill>
-            <a:srgbClr val="2DD4BF"/>
-          </a:solidFill>
-          <a:ln>
-            <a:noFill/>
+            <a:off x="365760" y="2194560"/>
+            <a:ext cx="11457432" cy="1417320"/>
+          </a:xfrm>
+          <a:prstGeom prst="roundRect">
+            <a:avLst>
+              <a:gd name="adj" fmla="val 6000"/>
+            </a:avLst>
+          </a:prstGeom>
+          <a:solidFill>
+            <a:srgbClr val="121A3A"/>
+          </a:solidFill>
+          <a:ln w="31750">
+            <a:solidFill>
+              <a:srgbClr val="818CF8"/>
+            </a:solidFill>
           </a:ln>
         </p:spPr>
         <p:style>
@@ -8619,20 +8659,22 @@
       </p:sp>
       <p:sp>
         <p:nvSpPr>
-          <p:cNvPr id="16" name="Down Arrow 15"/>
+          <p:cNvPr id="17" name="Rounded Rectangle 16"/>
           <p:cNvSpPr/>
           <p:nvPr/>
         </p:nvSpPr>
         <p:spPr>
           <a:xfrm>
-            <a:off x="6766560" y="2514600"/>
-            <a:ext cx="164592" cy="201168"/>
-          </a:xfrm>
-          <a:prstGeom prst="downArrow">
-            <a:avLst/>
-          </a:prstGeom>
-          <a:solidFill>
-            <a:srgbClr val="2DD4BF"/>
+            <a:off x="502920" y="2304288"/>
+            <a:ext cx="3017520" cy="292608"/>
+          </a:xfrm>
+          <a:prstGeom prst="roundRect">
+            <a:avLst>
+              <a:gd name="adj" fmla="val 8000"/>
+            </a:avLst>
+          </a:prstGeom>
+          <a:solidFill>
+            <a:srgbClr val="818CF8"/>
           </a:solidFill>
           <a:ln>
             <a:noFill/>
@@ -8662,23 +8704,97 @@
       </p:sp>
       <p:sp>
         <p:nvSpPr>
-          <p:cNvPr id="17" name="Down Arrow 16"/>
+          <p:cNvPr id="18" name="TextBox 17"/>
+          <p:cNvSpPr txBox="1"/>
+          <p:nvPr/>
+        </p:nvSpPr>
+        <p:spPr>
+          <a:xfrm>
+            <a:off x="502920" y="2331720"/>
+            <a:ext cx="3017520" cy="256032"/>
+          </a:xfrm>
+          <a:prstGeom prst="rect">
+            <a:avLst/>
+          </a:prstGeom>
+          <a:noFill/>
+        </p:spPr>
+        <p:txBody>
+          <a:bodyPr wrap="square">
+            <a:spAutoFit/>
+          </a:bodyPr>
+          <a:lstStyle/>
+          <a:p>
+            <a:pPr algn="ctr"/>
+            <a:r>
+              <a:rPr sz="1100" b="1">
+                <a:solidFill>
+                  <a:srgbClr val="0B1220"/>
+                </a:solidFill>
+                <a:latin typeface="Calibri"/>
+              </a:rPr>
+              <a:t>ONLY 對口  ·  UAF-owned</a:t>
+            </a:r>
+          </a:p>
+        </p:txBody>
+      </p:sp>
+      <p:sp>
+        <p:nvSpPr>
+          <p:cNvPr id="19" name="TextBox 18"/>
+          <p:cNvSpPr txBox="1"/>
+          <p:nvPr/>
+        </p:nvSpPr>
+        <p:spPr>
+          <a:xfrm>
+            <a:off x="3657600" y="2304288"/>
+            <a:ext cx="7772400" cy="274320"/>
+          </a:xfrm>
+          <a:prstGeom prst="rect">
+            <a:avLst/>
+          </a:prstGeom>
+          <a:noFill/>
+        </p:spPr>
+        <p:txBody>
+          <a:bodyPr wrap="square">
+            <a:spAutoFit/>
+          </a:bodyPr>
+          <a:lstStyle/>
+          <a:p>
+            <a:pPr algn="l"/>
+            <a:r>
+              <a:rPr sz="1500" b="1">
+                <a:solidFill>
+                  <a:srgbClr val="F8FAFC"/>
+                </a:solidFill>
+                <a:latin typeface="Calibri"/>
+              </a:rPr>
+              <a:t>Unified Landing Layer  (collect results + UAF business logic)</a:t>
+            </a:r>
+          </a:p>
+        </p:txBody>
+      </p:sp>
+      <p:sp>
+        <p:nvSpPr>
+          <p:cNvPr id="20" name="Rounded Rectangle 19"/>
           <p:cNvSpPr/>
           <p:nvPr/>
         </p:nvSpPr>
         <p:spPr>
           <a:xfrm>
-            <a:off x="9418320" y="2514600"/>
-            <a:ext cx="164592" cy="201168"/>
-          </a:xfrm>
-          <a:prstGeom prst="downArrow">
-            <a:avLst/>
-          </a:prstGeom>
-          <a:solidFill>
-            <a:srgbClr val="2DD4BF"/>
-          </a:solidFill>
-          <a:ln>
-            <a:noFill/>
+            <a:off x="502920" y="2697480"/>
+            <a:ext cx="3566160" cy="685800"/>
+          </a:xfrm>
+          <a:prstGeom prst="roundRect">
+            <a:avLst>
+              <a:gd name="adj" fmla="val 10000"/>
+            </a:avLst>
+          </a:prstGeom>
+          <a:solidFill>
+            <a:srgbClr val="0F2D4A"/>
+          </a:solidFill>
+          <a:ln w="12700">
+            <a:solidFill>
+              <a:srgbClr val="818CF8"/>
+            </a:solidFill>
           </a:ln>
         </p:spPr>
         <p:style>
@@ -8705,26 +8821,96 @@
       </p:sp>
       <p:sp>
         <p:nvSpPr>
-          <p:cNvPr id="18" name="Rounded Rectangle 17"/>
+          <p:cNvPr id="21" name="TextBox 20"/>
+          <p:cNvSpPr txBox="1"/>
+          <p:nvPr/>
+        </p:nvSpPr>
+        <p:spPr>
+          <a:xfrm>
+            <a:off x="640080" y="2761488"/>
+            <a:ext cx="3291840" cy="256032"/>
+          </a:xfrm>
+          <a:prstGeom prst="rect">
+            <a:avLst/>
+          </a:prstGeom>
+          <a:noFill/>
+        </p:spPr>
+        <p:txBody>
+          <a:bodyPr wrap="square">
+            <a:spAutoFit/>
+          </a:bodyPr>
+          <a:lstStyle/>
+          <a:p>
+            <a:pPr algn="l"/>
+            <a:r>
+              <a:rPr sz="1300" b="1">
+                <a:solidFill>
+                  <a:srgbClr val="818CF8"/>
+                </a:solidFill>
+                <a:latin typeface="Calibri"/>
+              </a:rPr>
+              <a:t>1 · Collect</a:t>
+            </a:r>
+          </a:p>
+        </p:txBody>
+      </p:sp>
+      <p:sp>
+        <p:nvSpPr>
+          <p:cNvPr id="22" name="TextBox 21"/>
+          <p:cNvSpPr txBox="1"/>
+          <p:nvPr/>
+        </p:nvSpPr>
+        <p:spPr>
+          <a:xfrm>
+            <a:off x="640080" y="3035808"/>
+            <a:ext cx="3291840" cy="256032"/>
+          </a:xfrm>
+          <a:prstGeom prst="rect">
+            <a:avLst/>
+          </a:prstGeom>
+          <a:noFill/>
+        </p:spPr>
+        <p:txBody>
+          <a:bodyPr wrap="square">
+            <a:spAutoFit/>
+          </a:bodyPr>
+          <a:lstStyle/>
+          <a:p>
+            <a:pPr algn="l"/>
+            <a:r>
+              <a:rPr sz="1100" b="0">
+                <a:solidFill>
+                  <a:srgbClr val="CBD5E1"/>
+                </a:solidFill>
+                <a:latin typeface="Calibri"/>
+              </a:rPr>
+              <a:t>Subscribe LedgeRX events / APIs</a:t>
+            </a:r>
+          </a:p>
+        </p:txBody>
+      </p:sp>
+      <p:sp>
+        <p:nvSpPr>
+          <p:cNvPr id="23" name="Rounded Rectangle 22"/>
           <p:cNvSpPr/>
           <p:nvPr/>
         </p:nvSpPr>
         <p:spPr>
           <a:xfrm>
-            <a:off x="457200" y="2788920"/>
-            <a:ext cx="2606040" cy="2331720"/>
+            <a:off x="4251959" y="2697480"/>
+            <a:ext cx="3566160" cy="685800"/>
           </a:xfrm>
           <a:prstGeom prst="roundRect">
             <a:avLst>
-              <a:gd name="adj" fmla="val 8000"/>
+              <a:gd name="adj" fmla="val 10000"/>
             </a:avLst>
           </a:prstGeom>
           <a:solidFill>
-            <a:srgbClr val="0A2F24"/>
-          </a:solidFill>
-          <a:ln w="28575">
+            <a:srgbClr val="0F2D4A"/>
+          </a:solidFill>
+          <a:ln w="12700">
             <a:solidFill>
-              <a:srgbClr val="6EE7B7"/>
+              <a:srgbClr val="818CF8"/>
             </a:solidFill>
           </a:ln>
         </p:spPr>
@@ -8752,25 +8938,97 @@
       </p:sp>
       <p:sp>
         <p:nvSpPr>
-          <p:cNvPr id="19" name="Rounded Rectangle 18"/>
+          <p:cNvPr id="24" name="TextBox 23"/>
+          <p:cNvSpPr txBox="1"/>
+          <p:nvPr/>
+        </p:nvSpPr>
+        <p:spPr>
+          <a:xfrm>
+            <a:off x="4389119" y="2761488"/>
+            <a:ext cx="3291840" cy="256032"/>
+          </a:xfrm>
+          <a:prstGeom prst="rect">
+            <a:avLst/>
+          </a:prstGeom>
+          <a:noFill/>
+        </p:spPr>
+        <p:txBody>
+          <a:bodyPr wrap="square">
+            <a:spAutoFit/>
+          </a:bodyPr>
+          <a:lstStyle/>
+          <a:p>
+            <a:pPr algn="l"/>
+            <a:r>
+              <a:rPr sz="1300" b="1">
+                <a:solidFill>
+                  <a:srgbClr val="818CF8"/>
+                </a:solidFill>
+                <a:latin typeface="Calibri"/>
+              </a:rPr>
+              <a:t>2 · Decide</a:t>
+            </a:r>
+          </a:p>
+        </p:txBody>
+      </p:sp>
+      <p:sp>
+        <p:nvSpPr>
+          <p:cNvPr id="25" name="TextBox 24"/>
+          <p:cNvSpPr txBox="1"/>
+          <p:nvPr/>
+        </p:nvSpPr>
+        <p:spPr>
+          <a:xfrm>
+            <a:off x="4389119" y="3035808"/>
+            <a:ext cx="3291840" cy="256032"/>
+          </a:xfrm>
+          <a:prstGeom prst="rect">
+            <a:avLst/>
+          </a:prstGeom>
+          <a:noFill/>
+        </p:spPr>
+        <p:txBody>
+          <a:bodyPr wrap="square">
+            <a:spAutoFit/>
+          </a:bodyPr>
+          <a:lstStyle/>
+          <a:p>
+            <a:pPr algn="l"/>
+            <a:r>
+              <a:rPr sz="1100" b="0">
+                <a:solidFill>
+                  <a:srgbClr val="CBD5E1"/>
+                </a:solidFill>
+                <a:latin typeface="Calibri"/>
+              </a:rPr>
+              <a:t>UAF policies · eligibility · routing</a:t>
+            </a:r>
+          </a:p>
+        </p:txBody>
+      </p:sp>
+      <p:sp>
+        <p:nvSpPr>
+          <p:cNvPr id="26" name="Rounded Rectangle 25"/>
           <p:cNvSpPr/>
           <p:nvPr/>
         </p:nvSpPr>
         <p:spPr>
           <a:xfrm>
-            <a:off x="566928" y="2898648"/>
-            <a:ext cx="1417320" cy="256032"/>
+            <a:off x="8000999" y="2697480"/>
+            <a:ext cx="3566160" cy="685800"/>
           </a:xfrm>
           <a:prstGeom prst="roundRect">
             <a:avLst>
-              <a:gd name="adj" fmla="val 8000"/>
+              <a:gd name="adj" fmla="val 10000"/>
             </a:avLst>
           </a:prstGeom>
           <a:solidFill>
-            <a:srgbClr val="6EE7B7"/>
-          </a:solidFill>
-          <a:ln>
-            <a:noFill/>
+            <a:srgbClr val="0F2D4A"/>
+          </a:solidFill>
+          <a:ln w="12700">
+            <a:solidFill>
+              <a:srgbClr val="818CF8"/>
+            </a:solidFill>
           </a:ln>
         </p:spPr>
         <p:style>
@@ -8797,14 +9055,14 @@
       </p:sp>
       <p:sp>
         <p:nvSpPr>
-          <p:cNvPr id="20" name="TextBox 19"/>
+          <p:cNvPr id="27" name="TextBox 26"/>
           <p:cNvSpPr txBox="1"/>
           <p:nvPr/>
         </p:nvSpPr>
         <p:spPr>
           <a:xfrm>
-            <a:off x="566928" y="2916936"/>
-            <a:ext cx="1417320" cy="228600"/>
+            <a:off x="8138159" y="2761488"/>
+            <a:ext cx="3291840" cy="256032"/>
           </a:xfrm>
           <a:prstGeom prst="rect">
             <a:avLst/>
@@ -8817,29 +9075,29 @@
           </a:bodyPr>
           <a:lstStyle/>
           <a:p>
-            <a:pPr algn="ctr"/>
-            <a:r>
-              <a:rPr sz="900" b="1">
-                <a:solidFill>
-                  <a:srgbClr val="0B1220"/>
+            <a:pPr algn="l"/>
+            <a:r>
+              <a:rPr sz="1300" b="1">
+                <a:solidFill>
+                  <a:srgbClr val="818CF8"/>
                 </a:solidFill>
                 <a:latin typeface="Calibri"/>
               </a:rPr>
-              <a:t>ONE DOWNSTREAM</a:t>
-            </a:r>
-          </a:p>
-        </p:txBody>
-      </p:sp>
-      <p:sp>
-        <p:nvSpPr>
-          <p:cNvPr id="21" name="TextBox 20"/>
+              <a:t>3 · Dispatch</a:t>
+            </a:r>
+          </a:p>
+        </p:txBody>
+      </p:sp>
+      <p:sp>
+        <p:nvSpPr>
+          <p:cNvPr id="28" name="TextBox 27"/>
           <p:cNvSpPr txBox="1"/>
           <p:nvPr/>
         </p:nvSpPr>
         <p:spPr>
           <a:xfrm>
-            <a:off x="585216" y="3227832"/>
-            <a:ext cx="2350008" cy="292608"/>
+            <a:off x="8138159" y="3035808"/>
+            <a:ext cx="3291840" cy="256032"/>
           </a:xfrm>
           <a:prstGeom prst="rect">
             <a:avLst/>
@@ -8854,215 +9112,36 @@
           <a:p>
             <a:pPr algn="l"/>
             <a:r>
-              <a:rPr sz="1400" b="1">
-                <a:solidFill>
-                  <a:srgbClr val="F8FAFC"/>
+              <a:rPr sz="1100" b="0">
+                <a:solidFill>
+                  <a:srgbClr val="CBD5E1"/>
                 </a:solidFill>
                 <a:latin typeface="Calibri"/>
               </a:rPr>
-              <a:t>E-coupon / CBP</a:t>
-            </a:r>
-          </a:p>
-        </p:txBody>
-      </p:sp>
-      <p:sp>
-        <p:nvSpPr>
-          <p:cNvPr id="22" name="TextBox 21"/>
-          <p:cNvSpPr txBox="1"/>
-          <p:nvPr/>
-        </p:nvSpPr>
-        <p:spPr>
-          <a:xfrm>
-            <a:off x="585216" y="3520440"/>
-            <a:ext cx="2350008" cy="256032"/>
-          </a:xfrm>
-          <a:prstGeom prst="rect">
-            <a:avLst/>
-          </a:prstGeom>
-          <a:noFill/>
-        </p:spPr>
-        <p:txBody>
-          <a:bodyPr wrap="square">
-            <a:spAutoFit/>
-          </a:bodyPr>
-          <a:lstStyle/>
-          <a:p>
-            <a:pPr algn="l"/>
-            <a:r>
-              <a:rPr sz="1100" b="0">
-                <a:solidFill>
-                  <a:srgbClr val="6EE7B7"/>
-                </a:solidFill>
-                <a:latin typeface="Calibri"/>
-              </a:rPr>
-              <a:t>UAF-owned platform</a:t>
-            </a:r>
-          </a:p>
-        </p:txBody>
-      </p:sp>
-      <p:sp>
-        <p:nvSpPr>
-          <p:cNvPr id="23" name="TextBox 22"/>
-          <p:cNvSpPr txBox="1"/>
-          <p:nvPr/>
-        </p:nvSpPr>
-        <p:spPr>
-          <a:xfrm>
-            <a:off x="585216" y="3867912"/>
-            <a:ext cx="2350008" cy="256032"/>
-          </a:xfrm>
-          <a:prstGeom prst="rect">
-            <a:avLst/>
-          </a:prstGeom>
-          <a:noFill/>
-        </p:spPr>
-        <p:txBody>
-          <a:bodyPr wrap="square">
-            <a:spAutoFit/>
-          </a:bodyPr>
-          <a:lstStyle/>
-          <a:p>
-            <a:pPr algn="l"/>
-            <a:r>
-              <a:rPr sz="1100" b="0">
-                <a:solidFill>
-                  <a:srgbClr val="CBD5E1"/>
-                </a:solidFill>
-                <a:latin typeface="Calibri"/>
-              </a:rPr>
-              <a:t>• Coupon inventory</a:t>
-            </a:r>
-          </a:p>
-        </p:txBody>
-      </p:sp>
-      <p:sp>
-        <p:nvSpPr>
-          <p:cNvPr id="24" name="TextBox 23"/>
-          <p:cNvSpPr txBox="1"/>
-          <p:nvPr/>
-        </p:nvSpPr>
-        <p:spPr>
-          <a:xfrm>
-            <a:off x="585216" y="4123944"/>
-            <a:ext cx="2350008" cy="256032"/>
-          </a:xfrm>
-          <a:prstGeom prst="rect">
-            <a:avLst/>
-          </a:prstGeom>
-          <a:noFill/>
-        </p:spPr>
-        <p:txBody>
-          <a:bodyPr wrap="square">
-            <a:spAutoFit/>
-          </a:bodyPr>
-          <a:lstStyle/>
-          <a:p>
-            <a:pPr algn="l"/>
-            <a:r>
-              <a:rPr sz="1100" b="0">
-                <a:solidFill>
-                  <a:srgbClr val="CBD5E1"/>
-                </a:solidFill>
-                <a:latin typeface="Calibri"/>
-              </a:rPr>
-              <a:t>• Issue &amp; redeem</a:t>
-            </a:r>
-          </a:p>
-        </p:txBody>
-      </p:sp>
-      <p:sp>
-        <p:nvSpPr>
-          <p:cNvPr id="25" name="TextBox 24"/>
-          <p:cNvSpPr txBox="1"/>
-          <p:nvPr/>
-        </p:nvSpPr>
-        <p:spPr>
-          <a:xfrm>
-            <a:off x="585216" y="4379976"/>
-            <a:ext cx="2350008" cy="256032"/>
-          </a:xfrm>
-          <a:prstGeom prst="rect">
-            <a:avLst/>
-          </a:prstGeom>
-          <a:noFill/>
-        </p:spPr>
-        <p:txBody>
-          <a:bodyPr wrap="square">
-            <a:spAutoFit/>
-          </a:bodyPr>
-          <a:lstStyle/>
-          <a:p>
-            <a:pPr algn="l"/>
-            <a:r>
-              <a:rPr sz="1100" b="0">
-                <a:solidFill>
-                  <a:srgbClr val="CBD5E1"/>
-                </a:solidFill>
-                <a:latin typeface="Calibri"/>
-              </a:rPr>
-              <a:t>• Track usage</a:t>
-            </a:r>
-          </a:p>
-        </p:txBody>
-      </p:sp>
-      <p:sp>
-        <p:nvSpPr>
-          <p:cNvPr id="26" name="TextBox 25"/>
-          <p:cNvSpPr txBox="1"/>
-          <p:nvPr/>
-        </p:nvSpPr>
-        <p:spPr>
-          <a:xfrm>
-            <a:off x="585216" y="4636008"/>
-            <a:ext cx="2350008" cy="256032"/>
-          </a:xfrm>
-          <a:prstGeom prst="rect">
-            <a:avLst/>
-          </a:prstGeom>
-          <a:noFill/>
-        </p:spPr>
-        <p:txBody>
-          <a:bodyPr wrap="square">
-            <a:spAutoFit/>
-          </a:bodyPr>
-          <a:lstStyle/>
-          <a:p>
-            <a:pPr algn="l"/>
-            <a:r>
-              <a:rPr sz="1100" b="0">
-                <a:solidFill>
-                  <a:srgbClr val="CBD5E1"/>
-                </a:solidFill>
-                <a:latin typeface="Calibri"/>
-              </a:rPr>
-              <a:t>• = Kenny green box</a:t>
-            </a:r>
-          </a:p>
-        </p:txBody>
-      </p:sp>
-      <p:sp>
-        <p:nvSpPr>
-          <p:cNvPr id="27" name="Rounded Rectangle 26"/>
+              <a:t>Call CBP · Gift · Notify · CRM</a:t>
+            </a:r>
+          </a:p>
+        </p:txBody>
+      </p:sp>
+      <p:sp>
+        <p:nvSpPr>
+          <p:cNvPr id="29" name="Down Arrow 28"/>
           <p:cNvSpPr/>
           <p:nvPr/>
         </p:nvSpPr>
         <p:spPr>
           <a:xfrm>
-            <a:off x="3264408" y="2788920"/>
-            <a:ext cx="2606040" cy="2331720"/>
-          </a:xfrm>
-          <a:prstGeom prst="roundRect">
-            <a:avLst>
-              <a:gd name="adj" fmla="val 8000"/>
-            </a:avLst>
-          </a:prstGeom>
-          <a:solidFill>
-            <a:srgbClr val="0C2340"/>
-          </a:solidFill>
-          <a:ln w="17145">
-            <a:solidFill>
-              <a:srgbClr val="C4B5FD"/>
-            </a:solidFill>
+            <a:off x="1554480" y="3703320"/>
+            <a:ext cx="146304" cy="182880"/>
+          </a:xfrm>
+          <a:prstGeom prst="downArrow">
+            <a:avLst/>
+          </a:prstGeom>
+          <a:solidFill>
+            <a:srgbClr val="818CF8"/>
+          </a:solidFill>
+          <a:ln>
+            <a:noFill/>
           </a:ln>
         </p:spPr>
         <p:style>
@@ -9089,237 +9168,23 @@
       </p:sp>
       <p:sp>
         <p:nvSpPr>
-          <p:cNvPr id="28" name="TextBox 27"/>
-          <p:cNvSpPr txBox="1"/>
-          <p:nvPr/>
-        </p:nvSpPr>
-        <p:spPr>
-          <a:xfrm>
-            <a:off x="3392424" y="2953512"/>
-            <a:ext cx="2350008" cy="292608"/>
-          </a:xfrm>
-          <a:prstGeom prst="rect">
-            <a:avLst/>
-          </a:prstGeom>
-          <a:noFill/>
-        </p:spPr>
-        <p:txBody>
-          <a:bodyPr wrap="square">
-            <a:spAutoFit/>
-          </a:bodyPr>
-          <a:lstStyle/>
-          <a:p>
-            <a:pPr algn="l"/>
-            <a:r>
-              <a:rPr sz="1400" b="1">
-                <a:solidFill>
-                  <a:srgbClr val="F8FAFC"/>
-                </a:solidFill>
-                <a:latin typeface="Calibri"/>
-              </a:rPr>
-              <a:t>Gift system</a:t>
-            </a:r>
-          </a:p>
-        </p:txBody>
-      </p:sp>
-      <p:sp>
-        <p:nvSpPr>
-          <p:cNvPr id="29" name="TextBox 28"/>
-          <p:cNvSpPr txBox="1"/>
-          <p:nvPr/>
-        </p:nvSpPr>
-        <p:spPr>
-          <a:xfrm>
-            <a:off x="3392424" y="3246120"/>
-            <a:ext cx="2350008" cy="256032"/>
-          </a:xfrm>
-          <a:prstGeom prst="rect">
-            <a:avLst/>
-          </a:prstGeom>
-          <a:noFill/>
-        </p:spPr>
-        <p:txBody>
-          <a:bodyPr wrap="square">
-            <a:spAutoFit/>
-          </a:bodyPr>
-          <a:lstStyle/>
-          <a:p>
-            <a:pPr algn="l"/>
-            <a:r>
-              <a:rPr sz="1100" b="0">
-                <a:solidFill>
-                  <a:srgbClr val="C4B5FD"/>
-                </a:solidFill>
-                <a:latin typeface="Calibri"/>
-              </a:rPr>
-              <a:t>UAF-owned</a:t>
-            </a:r>
-          </a:p>
-        </p:txBody>
-      </p:sp>
-      <p:sp>
-        <p:nvSpPr>
-          <p:cNvPr id="30" name="TextBox 29"/>
-          <p:cNvSpPr txBox="1"/>
-          <p:nvPr/>
-        </p:nvSpPr>
-        <p:spPr>
-          <a:xfrm>
-            <a:off x="3392424" y="3593592"/>
-            <a:ext cx="2350008" cy="256032"/>
-          </a:xfrm>
-          <a:prstGeom prst="rect">
-            <a:avLst/>
-          </a:prstGeom>
-          <a:noFill/>
-        </p:spPr>
-        <p:txBody>
-          <a:bodyPr wrap="square">
-            <a:spAutoFit/>
-          </a:bodyPr>
-          <a:lstStyle/>
-          <a:p>
-            <a:pPr algn="l"/>
-            <a:r>
-              <a:rPr sz="1100" b="0">
-                <a:solidFill>
-                  <a:srgbClr val="CBD5E1"/>
-                </a:solidFill>
-                <a:latin typeface="Calibri"/>
-              </a:rPr>
-              <a:t>• Fulfillment</a:t>
-            </a:r>
-          </a:p>
-        </p:txBody>
-      </p:sp>
-      <p:sp>
-        <p:nvSpPr>
-          <p:cNvPr id="31" name="TextBox 30"/>
-          <p:cNvSpPr txBox="1"/>
-          <p:nvPr/>
-        </p:nvSpPr>
-        <p:spPr>
-          <a:xfrm>
-            <a:off x="3392424" y="3849624"/>
-            <a:ext cx="2350008" cy="256032"/>
-          </a:xfrm>
-          <a:prstGeom prst="rect">
-            <a:avLst/>
-          </a:prstGeom>
-          <a:noFill/>
-        </p:spPr>
-        <p:txBody>
-          <a:bodyPr wrap="square">
-            <a:spAutoFit/>
-          </a:bodyPr>
-          <a:lstStyle/>
-          <a:p>
-            <a:pPr algn="l"/>
-            <a:r>
-              <a:rPr sz="1100" b="0">
-                <a:solidFill>
-                  <a:srgbClr val="CBD5E1"/>
-                </a:solidFill>
-                <a:latin typeface="Calibri"/>
-              </a:rPr>
-              <a:t>• Physical / digital gifts</a:t>
-            </a:r>
-          </a:p>
-        </p:txBody>
-      </p:sp>
-      <p:sp>
-        <p:nvSpPr>
-          <p:cNvPr id="32" name="TextBox 31"/>
-          <p:cNvSpPr txBox="1"/>
-          <p:nvPr/>
-        </p:nvSpPr>
-        <p:spPr>
-          <a:xfrm>
-            <a:off x="3392424" y="4105656"/>
-            <a:ext cx="2350008" cy="256032"/>
-          </a:xfrm>
-          <a:prstGeom prst="rect">
-            <a:avLst/>
-          </a:prstGeom>
-          <a:noFill/>
-        </p:spPr>
-        <p:txBody>
-          <a:bodyPr wrap="square">
-            <a:spAutoFit/>
-          </a:bodyPr>
-          <a:lstStyle/>
-          <a:p>
-            <a:pPr algn="l"/>
-            <a:r>
-              <a:rPr sz="1100" b="0">
-                <a:solidFill>
-                  <a:srgbClr val="CBD5E1"/>
-                </a:solidFill>
-                <a:latin typeface="Calibri"/>
-              </a:rPr>
-              <a:t>• Triggered by reward</a:t>
-            </a:r>
-          </a:p>
-        </p:txBody>
-      </p:sp>
-      <p:sp>
-        <p:nvSpPr>
-          <p:cNvPr id="33" name="TextBox 32"/>
-          <p:cNvSpPr txBox="1"/>
-          <p:nvPr/>
-        </p:nvSpPr>
-        <p:spPr>
-          <a:xfrm>
-            <a:off x="3392424" y="4361688"/>
-            <a:ext cx="2350008" cy="256032"/>
-          </a:xfrm>
-          <a:prstGeom prst="rect">
-            <a:avLst/>
-          </a:prstGeom>
-          <a:noFill/>
-        </p:spPr>
-        <p:txBody>
-          <a:bodyPr wrap="square">
-            <a:spAutoFit/>
-          </a:bodyPr>
-          <a:lstStyle/>
-          <a:p>
-            <a:pPr algn="l"/>
-            <a:r>
-              <a:rPr sz="1100" b="0">
-                <a:solidFill>
-                  <a:srgbClr val="CBD5E1"/>
-                </a:solidFill>
-                <a:latin typeface="Calibri"/>
-              </a:rPr>
-              <a:t>  outcome</a:t>
-            </a:r>
-          </a:p>
-        </p:txBody>
-      </p:sp>
-      <p:sp>
-        <p:nvSpPr>
-          <p:cNvPr id="34" name="Rounded Rectangle 33"/>
+          <p:cNvPr id="30" name="Down Arrow 29"/>
           <p:cNvSpPr/>
           <p:nvPr/>
         </p:nvSpPr>
         <p:spPr>
           <a:xfrm>
-            <a:off x="6071616" y="2788920"/>
-            <a:ext cx="2606040" cy="2331720"/>
-          </a:xfrm>
-          <a:prstGeom prst="roundRect">
-            <a:avLst>
-              <a:gd name="adj" fmla="val 8000"/>
-            </a:avLst>
-          </a:prstGeom>
-          <a:solidFill>
-            <a:srgbClr val="0C2340"/>
-          </a:solidFill>
-          <a:ln w="17145">
-            <a:solidFill>
-              <a:srgbClr val="38BDF8"/>
-            </a:solidFill>
+            <a:off x="4206240" y="3703320"/>
+            <a:ext cx="146304" cy="182880"/>
+          </a:xfrm>
+          <a:prstGeom prst="downArrow">
+            <a:avLst/>
+          </a:prstGeom>
+          <a:solidFill>
+            <a:srgbClr val="818CF8"/>
+          </a:solidFill>
+          <a:ln>
+            <a:noFill/>
           </a:ln>
         </p:spPr>
         <p:style>
@@ -9346,237 +9211,23 @@
       </p:sp>
       <p:sp>
         <p:nvSpPr>
-          <p:cNvPr id="35" name="TextBox 34"/>
-          <p:cNvSpPr txBox="1"/>
-          <p:nvPr/>
-        </p:nvSpPr>
-        <p:spPr>
-          <a:xfrm>
-            <a:off x="6199632" y="2953512"/>
-            <a:ext cx="2350008" cy="292608"/>
-          </a:xfrm>
-          <a:prstGeom prst="rect">
-            <a:avLst/>
-          </a:prstGeom>
-          <a:noFill/>
-        </p:spPr>
-        <p:txBody>
-          <a:bodyPr wrap="square">
-            <a:spAutoFit/>
-          </a:bodyPr>
-          <a:lstStyle/>
-          <a:p>
-            <a:pPr algn="l"/>
-            <a:r>
-              <a:rPr sz="1400" b="1">
-                <a:solidFill>
-                  <a:srgbClr val="F8FAFC"/>
-                </a:solidFill>
-                <a:latin typeface="Calibri"/>
-              </a:rPr>
-              <a:t>Notification</a:t>
-            </a:r>
-          </a:p>
-        </p:txBody>
-      </p:sp>
-      <p:sp>
-        <p:nvSpPr>
-          <p:cNvPr id="36" name="TextBox 35"/>
-          <p:cNvSpPr txBox="1"/>
-          <p:nvPr/>
-        </p:nvSpPr>
-        <p:spPr>
-          <a:xfrm>
-            <a:off x="6199632" y="3246120"/>
-            <a:ext cx="2350008" cy="256032"/>
-          </a:xfrm>
-          <a:prstGeom prst="rect">
-            <a:avLst/>
-          </a:prstGeom>
-          <a:noFill/>
-        </p:spPr>
-        <p:txBody>
-          <a:bodyPr wrap="square">
-            <a:spAutoFit/>
-          </a:bodyPr>
-          <a:lstStyle/>
-          <a:p>
-            <a:pPr algn="l"/>
-            <a:r>
-              <a:rPr sz="1100" b="0">
-                <a:solidFill>
-                  <a:srgbClr val="38BDF8"/>
-                </a:solidFill>
-                <a:latin typeface="Calibri"/>
-              </a:rPr>
-              <a:t>UAF-owned</a:t>
-            </a:r>
-          </a:p>
-        </p:txBody>
-      </p:sp>
-      <p:sp>
-        <p:nvSpPr>
-          <p:cNvPr id="37" name="TextBox 36"/>
-          <p:cNvSpPr txBox="1"/>
-          <p:nvPr/>
-        </p:nvSpPr>
-        <p:spPr>
-          <a:xfrm>
-            <a:off x="6199632" y="3593592"/>
-            <a:ext cx="2350008" cy="256032"/>
-          </a:xfrm>
-          <a:prstGeom prst="rect">
-            <a:avLst/>
-          </a:prstGeom>
-          <a:noFill/>
-        </p:spPr>
-        <p:txBody>
-          <a:bodyPr wrap="square">
-            <a:spAutoFit/>
-          </a:bodyPr>
-          <a:lstStyle/>
-          <a:p>
-            <a:pPr algn="l"/>
-            <a:r>
-              <a:rPr sz="1100" b="0">
-                <a:solidFill>
-                  <a:srgbClr val="CBD5E1"/>
-                </a:solidFill>
-                <a:latin typeface="Calibri"/>
-              </a:rPr>
-              <a:t>• Push · SMS · inbox</a:t>
-            </a:r>
-          </a:p>
-        </p:txBody>
-      </p:sp>
-      <p:sp>
-        <p:nvSpPr>
-          <p:cNvPr id="38" name="TextBox 37"/>
-          <p:cNvSpPr txBox="1"/>
-          <p:nvPr/>
-        </p:nvSpPr>
-        <p:spPr>
-          <a:xfrm>
-            <a:off x="6199632" y="3849624"/>
-            <a:ext cx="2350008" cy="256032"/>
-          </a:xfrm>
-          <a:prstGeom prst="rect">
-            <a:avLst/>
-          </a:prstGeom>
-          <a:noFill/>
-        </p:spPr>
-        <p:txBody>
-          <a:bodyPr wrap="square">
-            <a:spAutoFit/>
-          </a:bodyPr>
-          <a:lstStyle/>
-          <a:p>
-            <a:pPr algn="l"/>
-            <a:r>
-              <a:rPr sz="1100" b="0">
-                <a:solidFill>
-                  <a:srgbClr val="CBD5E1"/>
-                </a:solidFill>
-                <a:latin typeface="Calibri"/>
-              </a:rPr>
-              <a:t>• Balance alerts</a:t>
-            </a:r>
-          </a:p>
-        </p:txBody>
-      </p:sp>
-      <p:sp>
-        <p:nvSpPr>
-          <p:cNvPr id="39" name="TextBox 38"/>
-          <p:cNvSpPr txBox="1"/>
-          <p:nvPr/>
-        </p:nvSpPr>
-        <p:spPr>
-          <a:xfrm>
-            <a:off x="6199632" y="4105656"/>
-            <a:ext cx="2350008" cy="256032"/>
-          </a:xfrm>
-          <a:prstGeom prst="rect">
-            <a:avLst/>
-          </a:prstGeom>
-          <a:noFill/>
-        </p:spPr>
-        <p:txBody>
-          <a:bodyPr wrap="square">
-            <a:spAutoFit/>
-          </a:bodyPr>
-          <a:lstStyle/>
-          <a:p>
-            <a:pPr algn="l"/>
-            <a:r>
-              <a:rPr sz="1100" b="0">
-                <a:solidFill>
-                  <a:srgbClr val="CBD5E1"/>
-                </a:solidFill>
-                <a:latin typeface="Calibri"/>
-              </a:rPr>
-              <a:t>• Redemption confirm</a:t>
-            </a:r>
-          </a:p>
-        </p:txBody>
-      </p:sp>
-      <p:sp>
-        <p:nvSpPr>
-          <p:cNvPr id="40" name="TextBox 39"/>
-          <p:cNvSpPr txBox="1"/>
-          <p:nvPr/>
-        </p:nvSpPr>
-        <p:spPr>
-          <a:xfrm>
-            <a:off x="6199632" y="4361688"/>
-            <a:ext cx="2350008" cy="256032"/>
-          </a:xfrm>
-          <a:prstGeom prst="rect">
-            <a:avLst/>
-          </a:prstGeom>
-          <a:noFill/>
-        </p:spPr>
-        <p:txBody>
-          <a:bodyPr wrap="square">
-            <a:spAutoFit/>
-          </a:bodyPr>
-          <a:lstStyle/>
-          <a:p>
-            <a:pPr algn="l"/>
-            <a:r>
-              <a:rPr sz="1100" b="0">
-                <a:solidFill>
-                  <a:srgbClr val="CBD5E1"/>
-                </a:solidFill>
-                <a:latin typeface="Calibri"/>
-              </a:rPr>
-              <a:t/>
-            </a:r>
-          </a:p>
-        </p:txBody>
-      </p:sp>
-      <p:sp>
-        <p:nvSpPr>
-          <p:cNvPr id="41" name="Rounded Rectangle 40"/>
+          <p:cNvPr id="31" name="Down Arrow 30"/>
           <p:cNvSpPr/>
           <p:nvPr/>
         </p:nvSpPr>
         <p:spPr>
           <a:xfrm>
-            <a:off x="8878824" y="2788920"/>
-            <a:ext cx="2606040" cy="2331720"/>
-          </a:xfrm>
-          <a:prstGeom prst="roundRect">
-            <a:avLst>
-              <a:gd name="adj" fmla="val 8000"/>
-            </a:avLst>
-          </a:prstGeom>
-          <a:solidFill>
-            <a:srgbClr val="0C2340"/>
-          </a:solidFill>
-          <a:ln w="17145">
-            <a:solidFill>
-              <a:srgbClr val="FB923C"/>
-            </a:solidFill>
+            <a:off x="6858000" y="3703320"/>
+            <a:ext cx="146304" cy="182880"/>
+          </a:xfrm>
+          <a:prstGeom prst="downArrow">
+            <a:avLst/>
+          </a:prstGeom>
+          <a:solidFill>
+            <a:srgbClr val="818CF8"/>
+          </a:solidFill>
+          <a:ln>
+            <a:noFill/>
           </a:ln>
         </p:spPr>
         <p:style>
@@ -9603,237 +9254,23 @@
       </p:sp>
       <p:sp>
         <p:nvSpPr>
-          <p:cNvPr id="42" name="TextBox 41"/>
-          <p:cNvSpPr txBox="1"/>
-          <p:nvPr/>
-        </p:nvSpPr>
-        <p:spPr>
-          <a:xfrm>
-            <a:off x="9006840" y="2953512"/>
-            <a:ext cx="2350008" cy="292608"/>
-          </a:xfrm>
-          <a:prstGeom prst="rect">
-            <a:avLst/>
-          </a:prstGeom>
-          <a:noFill/>
-        </p:spPr>
-        <p:txBody>
-          <a:bodyPr wrap="square">
-            <a:spAutoFit/>
-          </a:bodyPr>
-          <a:lstStyle/>
-          <a:p>
-            <a:pPr algn="l"/>
-            <a:r>
-              <a:rPr sz="1400" b="1">
-                <a:solidFill>
-                  <a:srgbClr val="F8FAFC"/>
-                </a:solidFill>
-                <a:latin typeface="Calibri"/>
-              </a:rPr>
-              <a:t>xapi / CRM</a:t>
-            </a:r>
-          </a:p>
-        </p:txBody>
-      </p:sp>
-      <p:sp>
-        <p:nvSpPr>
-          <p:cNvPr id="43" name="TextBox 42"/>
-          <p:cNvSpPr txBox="1"/>
-          <p:nvPr/>
-        </p:nvSpPr>
-        <p:spPr>
-          <a:xfrm>
-            <a:off x="9006840" y="3246120"/>
-            <a:ext cx="2350008" cy="256032"/>
-          </a:xfrm>
-          <a:prstGeom prst="rect">
-            <a:avLst/>
-          </a:prstGeom>
-          <a:noFill/>
-        </p:spPr>
-        <p:txBody>
-          <a:bodyPr wrap="square">
-            <a:spAutoFit/>
-          </a:bodyPr>
-          <a:lstStyle/>
-          <a:p>
-            <a:pPr algn="l"/>
-            <a:r>
-              <a:rPr sz="1100" b="0">
-                <a:solidFill>
-                  <a:srgbClr val="FB923C"/>
-                </a:solidFill>
-                <a:latin typeface="Calibri"/>
-              </a:rPr>
-              <a:t>UAF-owned</a:t>
-            </a:r>
-          </a:p>
-        </p:txBody>
-      </p:sp>
-      <p:sp>
-        <p:nvSpPr>
-          <p:cNvPr id="44" name="TextBox 43"/>
-          <p:cNvSpPr txBox="1"/>
-          <p:nvPr/>
-        </p:nvSpPr>
-        <p:spPr>
-          <a:xfrm>
-            <a:off x="9006840" y="3593592"/>
-            <a:ext cx="2350008" cy="256032"/>
-          </a:xfrm>
-          <a:prstGeom prst="rect">
-            <a:avLst/>
-          </a:prstGeom>
-          <a:noFill/>
-        </p:spPr>
-        <p:txBody>
-          <a:bodyPr wrap="square">
-            <a:spAutoFit/>
-          </a:bodyPr>
-          <a:lstStyle/>
-          <a:p>
-            <a:pPr algn="l"/>
-            <a:r>
-              <a:rPr sz="1100" b="0">
-                <a:solidFill>
-                  <a:srgbClr val="CBD5E1"/>
-                </a:solidFill>
-                <a:latin typeface="Calibri"/>
-              </a:rPr>
-              <a:t>• Balance views</a:t>
-            </a:r>
-          </a:p>
-        </p:txBody>
-      </p:sp>
-      <p:sp>
-        <p:nvSpPr>
-          <p:cNvPr id="45" name="TextBox 44"/>
-          <p:cNvSpPr txBox="1"/>
-          <p:nvPr/>
-        </p:nvSpPr>
-        <p:spPr>
-          <a:xfrm>
-            <a:off x="9006840" y="3849624"/>
-            <a:ext cx="2350008" cy="256032"/>
-          </a:xfrm>
-          <a:prstGeom prst="rect">
-            <a:avLst/>
-          </a:prstGeom>
-          <a:noFill/>
-        </p:spPr>
-        <p:txBody>
-          <a:bodyPr wrap="square">
-            <a:spAutoFit/>
-          </a:bodyPr>
-          <a:lstStyle/>
-          <a:p>
-            <a:pPr algn="l"/>
-            <a:r>
-              <a:rPr sz="1100" b="0">
-                <a:solidFill>
-                  <a:srgbClr val="CBD5E1"/>
-                </a:solidFill>
-                <a:latin typeface="Calibri"/>
-              </a:rPr>
-              <a:t>• Customer profile</a:t>
-            </a:r>
-          </a:p>
-        </p:txBody>
-      </p:sp>
-      <p:sp>
-        <p:nvSpPr>
-          <p:cNvPr id="46" name="TextBox 45"/>
-          <p:cNvSpPr txBox="1"/>
-          <p:nvPr/>
-        </p:nvSpPr>
-        <p:spPr>
-          <a:xfrm>
-            <a:off x="9006840" y="4105656"/>
-            <a:ext cx="2350008" cy="256032"/>
-          </a:xfrm>
-          <a:prstGeom prst="rect">
-            <a:avLst/>
-          </a:prstGeom>
-          <a:noFill/>
-        </p:spPr>
-        <p:txBody>
-          <a:bodyPr wrap="square">
-            <a:spAutoFit/>
-          </a:bodyPr>
-          <a:lstStyle/>
-          <a:p>
-            <a:pPr algn="l"/>
-            <a:r>
-              <a:rPr sz="1100" b="0">
-                <a:solidFill>
-                  <a:srgbClr val="CBD5E1"/>
-                </a:solidFill>
-                <a:latin typeface="Calibri"/>
-              </a:rPr>
-              <a:t>• Channel apps</a:t>
-            </a:r>
-          </a:p>
-        </p:txBody>
-      </p:sp>
-      <p:sp>
-        <p:nvSpPr>
-          <p:cNvPr id="47" name="TextBox 46"/>
-          <p:cNvSpPr txBox="1"/>
-          <p:nvPr/>
-        </p:nvSpPr>
-        <p:spPr>
-          <a:xfrm>
-            <a:off x="9006840" y="4361688"/>
-            <a:ext cx="2350008" cy="256032"/>
-          </a:xfrm>
-          <a:prstGeom prst="rect">
-            <a:avLst/>
-          </a:prstGeom>
-          <a:noFill/>
-        </p:spPr>
-        <p:txBody>
-          <a:bodyPr wrap="square">
-            <a:spAutoFit/>
-          </a:bodyPr>
-          <a:lstStyle/>
-          <a:p>
-            <a:pPr algn="l"/>
-            <a:r>
-              <a:rPr sz="1100" b="0">
-                <a:solidFill>
-                  <a:srgbClr val="CBD5E1"/>
-                </a:solidFill>
-                <a:latin typeface="Calibri"/>
-              </a:rPr>
-              <a:t>  (Yes UA · aim)</a:t>
-            </a:r>
-          </a:p>
-        </p:txBody>
-      </p:sp>
-      <p:sp>
-        <p:nvSpPr>
-          <p:cNvPr id="48" name="Rounded Rectangle 47"/>
+          <p:cNvPr id="32" name="Down Arrow 31"/>
           <p:cNvSpPr/>
           <p:nvPr/>
         </p:nvSpPr>
         <p:spPr>
           <a:xfrm>
-            <a:off x="457200" y="5257800"/>
-            <a:ext cx="2606040" cy="640080"/>
-          </a:xfrm>
-          <a:prstGeom prst="roundRect">
-            <a:avLst>
-              <a:gd name="adj" fmla="val 10000"/>
-            </a:avLst>
-          </a:prstGeom>
-          <a:solidFill>
-            <a:srgbClr val="2A1424"/>
-          </a:solidFill>
-          <a:ln w="15875">
-            <a:solidFill>
-              <a:srgbClr val="F9A8D4"/>
-            </a:solidFill>
+            <a:off x="9509760" y="3703320"/>
+            <a:ext cx="146304" cy="182880"/>
+          </a:xfrm>
+          <a:prstGeom prst="downArrow">
+            <a:avLst/>
+          </a:prstGeom>
+          <a:solidFill>
+            <a:srgbClr val="818CF8"/>
+          </a:solidFill>
+          <a:ln>
+            <a:noFill/>
           </a:ln>
         </p:spPr>
         <p:style>
@@ -9860,14 +9297,14 @@
       </p:sp>
       <p:sp>
         <p:nvSpPr>
-          <p:cNvPr id="49" name="TextBox 48"/>
+          <p:cNvPr id="33" name="TextBox 32"/>
           <p:cNvSpPr txBox="1"/>
           <p:nvPr/>
         </p:nvSpPr>
         <p:spPr>
           <a:xfrm>
-            <a:off x="566928" y="5321808"/>
-            <a:ext cx="2386584" cy="228600"/>
+            <a:off x="365760" y="3913632"/>
+            <a:ext cx="11430000" cy="228600"/>
           </a:xfrm>
           <a:prstGeom prst="rect">
             <a:avLst/>
@@ -9882,62 +9319,27 @@
           <a:p>
             <a:pPr algn="l"/>
             <a:r>
-              <a:rPr sz="1100" b="1">
-                <a:solidFill>
-                  <a:srgbClr val="F9A8D4"/>
+              <a:rPr sz="1100" b="0">
+                <a:solidFill>
+                  <a:srgbClr val="64748B"/>
                 </a:solidFill>
                 <a:latin typeface="Calibri"/>
               </a:rPr>
-              <a:t>↓ then UAF partners</a:t>
-            </a:r>
-          </a:p>
-        </p:txBody>
-      </p:sp>
-      <p:sp>
-        <p:nvSpPr>
-          <p:cNvPr id="50" name="TextBox 49"/>
-          <p:cNvSpPr txBox="1"/>
-          <p:nvPr/>
-        </p:nvSpPr>
-        <p:spPr>
-          <a:xfrm>
-            <a:off x="566928" y="5577840"/>
-            <a:ext cx="2386584" cy="228600"/>
-          </a:xfrm>
-          <a:prstGeom prst="rect">
-            <a:avLst/>
-          </a:prstGeom>
-          <a:noFill/>
-        </p:spPr>
-        <p:txBody>
-          <a:bodyPr wrap="square">
-            <a:spAutoFit/>
-          </a:bodyPr>
-          <a:lstStyle/>
-          <a:p>
-            <a:pPr algn="l"/>
-            <a:r>
-              <a:rPr sz="1100" b="0">
-                <a:solidFill>
-                  <a:srgbClr val="CBD5E1"/>
-                </a:solidFill>
-                <a:latin typeface="Calibri"/>
-              </a:rPr>
-              <a:t>COD  ·  other coupon partners</a:t>
-            </a:r>
-          </a:p>
-        </p:txBody>
-      </p:sp>
-      <p:sp>
-        <p:nvSpPr>
-          <p:cNvPr id="51" name="Rounded Rectangle 50"/>
+              <a:t>Internal UAF systems  —  LedgeRX never integrates to these directly</a:t>
+            </a:r>
+          </a:p>
+        </p:txBody>
+      </p:sp>
+      <p:sp>
+        <p:nvSpPr>
+          <p:cNvPr id="34" name="Rounded Rectangle 33"/>
           <p:cNvSpPr/>
           <p:nvPr/>
         </p:nvSpPr>
         <p:spPr>
           <a:xfrm>
-            <a:off x="3264408" y="5257800"/>
-            <a:ext cx="8412480" cy="640080"/>
+            <a:off x="411480" y="4160520"/>
+            <a:ext cx="2651760" cy="1417320"/>
           </a:xfrm>
           <a:prstGeom prst="roundRect">
             <a:avLst>
@@ -9945,11 +9347,11 @@
             </a:avLst>
           </a:prstGeom>
           <a:solidFill>
-            <a:srgbClr val="102A48"/>
-          </a:solidFill>
-          <a:ln w="15875">
+            <a:srgbClr val="0A2F24"/>
+          </a:solidFill>
+          <a:ln w="22225">
             <a:solidFill>
-              <a:srgbClr val="2DD4BF"/>
+              <a:srgbClr val="6EE7B7"/>
             </a:solidFill>
           </a:ln>
         </p:spPr>
@@ -9977,14 +9379,59 @@
       </p:sp>
       <p:sp>
         <p:nvSpPr>
-          <p:cNvPr id="52" name="TextBox 51"/>
+          <p:cNvPr id="35" name="Rounded Rectangle 34"/>
+          <p:cNvSpPr/>
+          <p:nvPr/>
+        </p:nvSpPr>
+        <p:spPr>
+          <a:xfrm>
+            <a:off x="502920" y="4251960"/>
+            <a:ext cx="1234440" cy="219456"/>
+          </a:xfrm>
+          <a:prstGeom prst="roundRect">
+            <a:avLst>
+              <a:gd name="adj" fmla="val 8000"/>
+            </a:avLst>
+          </a:prstGeom>
+          <a:solidFill>
+            <a:srgbClr val="6EE7B7"/>
+          </a:solidFill>
+          <a:ln>
+            <a:noFill/>
+          </a:ln>
+        </p:spPr>
+        <p:style>
+          <a:lnRef idx="1">
+            <a:schemeClr val="accent1"/>
+          </a:lnRef>
+          <a:fillRef idx="3">
+            <a:schemeClr val="accent1"/>
+          </a:fillRef>
+          <a:effectRef idx="2">
+            <a:schemeClr val="accent1"/>
+          </a:effectRef>
+          <a:fontRef idx="minor">
+            <a:schemeClr val="lt1"/>
+          </a:fontRef>
+        </p:style>
+        <p:txBody>
+          <a:bodyPr rtlCol="0" anchor="ctr"/>
+          <a:lstStyle/>
+          <a:p>
+            <a:pPr algn="ctr"/>
+          </a:p>
+        </p:txBody>
+      </p:sp>
+      <p:sp>
+        <p:nvSpPr>
+          <p:cNvPr id="36" name="TextBox 35"/>
           <p:cNvSpPr txBox="1"/>
           <p:nvPr/>
         </p:nvSpPr>
         <p:spPr>
           <a:xfrm>
-            <a:off x="3447288" y="5349240"/>
-            <a:ext cx="8046720" cy="457200"/>
+            <a:off x="502920" y="4270248"/>
+            <a:ext cx="1234440" cy="201168"/>
           </a:xfrm>
           <a:prstGeom prst="rect">
             <a:avLst/>
@@ -9997,29 +9444,754 @@
           </a:bodyPr>
           <a:lstStyle/>
           <a:p>
-            <a:pPr algn="l"/>
-            <a:r>
-              <a:rPr sz="1300" b="1">
-                <a:solidFill>
-                  <a:srgbClr val="F8FAFC"/>
+            <a:pPr algn="ctr"/>
+            <a:r>
+              <a:rPr sz="900" b="1">
+                <a:solidFill>
+                  <a:srgbClr val="0B1220"/>
                 </a:solidFill>
                 <a:latin typeface="Calibri"/>
               </a:rPr>
-              <a:t>Pitch line:  You buy LedgeRX (Reward System).  CBP stays yours — it simply becomes one Landing consumer of our engine’s events.</a:t>
-            </a:r>
-          </a:p>
-        </p:txBody>
-      </p:sp>
-      <p:sp>
-        <p:nvSpPr>
-          <p:cNvPr id="53" name="Rounded Rectangle 52"/>
+              <a:t>Kenny green box</a:t>
+            </a:r>
+          </a:p>
+        </p:txBody>
+      </p:sp>
+      <p:sp>
+        <p:nvSpPr>
+          <p:cNvPr id="37" name="TextBox 36"/>
+          <p:cNvSpPr txBox="1"/>
+          <p:nvPr/>
+        </p:nvSpPr>
+        <p:spPr>
+          <a:xfrm>
+            <a:off x="539496" y="4544568"/>
+            <a:ext cx="2395728" cy="274320"/>
+          </a:xfrm>
+          <a:prstGeom prst="rect">
+            <a:avLst/>
+          </a:prstGeom>
+          <a:noFill/>
+        </p:spPr>
+        <p:txBody>
+          <a:bodyPr wrap="square">
+            <a:spAutoFit/>
+          </a:bodyPr>
+          <a:lstStyle/>
+          <a:p>
+            <a:pPr algn="l"/>
+            <a:r>
+              <a:rPr sz="1400" b="1">
+                <a:solidFill>
+                  <a:srgbClr val="F8FAFC"/>
+                </a:solidFill>
+                <a:latin typeface="Calibri"/>
+              </a:rPr>
+              <a:t>E-coupon / CBP</a:t>
+            </a:r>
+          </a:p>
+        </p:txBody>
+      </p:sp>
+      <p:sp>
+        <p:nvSpPr>
+          <p:cNvPr id="38" name="TextBox 37"/>
+          <p:cNvSpPr txBox="1"/>
+          <p:nvPr/>
+        </p:nvSpPr>
+        <p:spPr>
+          <a:xfrm>
+            <a:off x="539496" y="4864608"/>
+            <a:ext cx="2395728" cy="502920"/>
+          </a:xfrm>
+          <a:prstGeom prst="rect">
+            <a:avLst/>
+          </a:prstGeom>
+          <a:noFill/>
+        </p:spPr>
+        <p:txBody>
+          <a:bodyPr wrap="square">
+            <a:spAutoFit/>
+          </a:bodyPr>
+          <a:lstStyle/>
+          <a:p>
+            <a:pPr algn="l"/>
+            <a:r>
+              <a:rPr sz="1100" b="0">
+                <a:solidFill>
+                  <a:srgbClr val="94A3B8"/>
+                </a:solidFill>
+                <a:latin typeface="Calibri"/>
+              </a:rPr>
+              <a:t>Green box · inventory · issue/redeem · track</a:t>
+            </a:r>
+          </a:p>
+        </p:txBody>
+      </p:sp>
+      <p:sp>
+        <p:nvSpPr>
+          <p:cNvPr id="39" name="TextBox 38"/>
+          <p:cNvSpPr txBox="1"/>
+          <p:nvPr/>
+        </p:nvSpPr>
+        <p:spPr>
+          <a:xfrm>
+            <a:off x="539496" y="5321808"/>
+            <a:ext cx="2395728" cy="228600"/>
+          </a:xfrm>
+          <a:prstGeom prst="rect">
+            <a:avLst/>
+          </a:prstGeom>
+          <a:noFill/>
+        </p:spPr>
+        <p:txBody>
+          <a:bodyPr wrap="square">
+            <a:spAutoFit/>
+          </a:bodyPr>
+          <a:lstStyle/>
+          <a:p>
+            <a:pPr algn="l"/>
+            <a:r>
+              <a:rPr sz="1000" b="0">
+                <a:solidFill>
+                  <a:srgbClr val="6EE7B7"/>
+                </a:solidFill>
+                <a:latin typeface="Calibri"/>
+              </a:rPr>
+              <a:t>UAF-owned</a:t>
+            </a:r>
+          </a:p>
+        </p:txBody>
+      </p:sp>
+      <p:sp>
+        <p:nvSpPr>
+          <p:cNvPr id="40" name="Rounded Rectangle 39"/>
           <p:cNvSpPr/>
           <p:nvPr/>
         </p:nvSpPr>
         <p:spPr>
           <a:xfrm>
-            <a:off x="365760" y="6080760"/>
-            <a:ext cx="11460175" cy="502920"/>
+            <a:off x="3246120" y="4160520"/>
+            <a:ext cx="2651760" cy="1417320"/>
+          </a:xfrm>
+          <a:prstGeom prst="roundRect">
+            <a:avLst>
+              <a:gd name="adj" fmla="val 10000"/>
+            </a:avLst>
+          </a:prstGeom>
+          <a:solidFill>
+            <a:srgbClr val="0C2340"/>
+          </a:solidFill>
+          <a:ln w="15240">
+            <a:solidFill>
+              <a:srgbClr val="C4B5FD"/>
+            </a:solidFill>
+          </a:ln>
+        </p:spPr>
+        <p:style>
+          <a:lnRef idx="1">
+            <a:schemeClr val="accent1"/>
+          </a:lnRef>
+          <a:fillRef idx="3">
+            <a:schemeClr val="accent1"/>
+          </a:fillRef>
+          <a:effectRef idx="2">
+            <a:schemeClr val="accent1"/>
+          </a:effectRef>
+          <a:fontRef idx="minor">
+            <a:schemeClr val="lt1"/>
+          </a:fontRef>
+        </p:style>
+        <p:txBody>
+          <a:bodyPr rtlCol="0" anchor="ctr"/>
+          <a:lstStyle/>
+          <a:p>
+            <a:pPr algn="ctr"/>
+          </a:p>
+        </p:txBody>
+      </p:sp>
+      <p:sp>
+        <p:nvSpPr>
+          <p:cNvPr id="41" name="TextBox 40"/>
+          <p:cNvSpPr txBox="1"/>
+          <p:nvPr/>
+        </p:nvSpPr>
+        <p:spPr>
+          <a:xfrm>
+            <a:off x="3374136" y="4325112"/>
+            <a:ext cx="2395728" cy="274320"/>
+          </a:xfrm>
+          <a:prstGeom prst="rect">
+            <a:avLst/>
+          </a:prstGeom>
+          <a:noFill/>
+        </p:spPr>
+        <p:txBody>
+          <a:bodyPr wrap="square">
+            <a:spAutoFit/>
+          </a:bodyPr>
+          <a:lstStyle/>
+          <a:p>
+            <a:pPr algn="l"/>
+            <a:r>
+              <a:rPr sz="1400" b="1">
+                <a:solidFill>
+                  <a:srgbClr val="F8FAFC"/>
+                </a:solidFill>
+                <a:latin typeface="Calibri"/>
+              </a:rPr>
+              <a:t>Gift system</a:t>
+            </a:r>
+          </a:p>
+        </p:txBody>
+      </p:sp>
+      <p:sp>
+        <p:nvSpPr>
+          <p:cNvPr id="42" name="TextBox 41"/>
+          <p:cNvSpPr txBox="1"/>
+          <p:nvPr/>
+        </p:nvSpPr>
+        <p:spPr>
+          <a:xfrm>
+            <a:off x="3374136" y="4645152"/>
+            <a:ext cx="2395728" cy="502920"/>
+          </a:xfrm>
+          <a:prstGeom prst="rect">
+            <a:avLst/>
+          </a:prstGeom>
+          <a:noFill/>
+        </p:spPr>
+        <p:txBody>
+          <a:bodyPr wrap="square">
+            <a:spAutoFit/>
+          </a:bodyPr>
+          <a:lstStyle/>
+          <a:p>
+            <a:pPr algn="l"/>
+            <a:r>
+              <a:rPr sz="1100" b="0">
+                <a:solidFill>
+                  <a:srgbClr val="94A3B8"/>
+                </a:solidFill>
+                <a:latin typeface="Calibri"/>
+              </a:rPr>
+              <a:t>Fulfillment · triggered after routing</a:t>
+            </a:r>
+          </a:p>
+        </p:txBody>
+      </p:sp>
+      <p:sp>
+        <p:nvSpPr>
+          <p:cNvPr id="43" name="TextBox 42"/>
+          <p:cNvSpPr txBox="1"/>
+          <p:nvPr/>
+        </p:nvSpPr>
+        <p:spPr>
+          <a:xfrm>
+            <a:off x="3374136" y="5102352"/>
+            <a:ext cx="2395728" cy="228600"/>
+          </a:xfrm>
+          <a:prstGeom prst="rect">
+            <a:avLst/>
+          </a:prstGeom>
+          <a:noFill/>
+        </p:spPr>
+        <p:txBody>
+          <a:bodyPr wrap="square">
+            <a:spAutoFit/>
+          </a:bodyPr>
+          <a:lstStyle/>
+          <a:p>
+            <a:pPr algn="l"/>
+            <a:r>
+              <a:rPr sz="1000" b="0">
+                <a:solidFill>
+                  <a:srgbClr val="C4B5FD"/>
+                </a:solidFill>
+                <a:latin typeface="Calibri"/>
+              </a:rPr>
+              <a:t>UAF-owned</a:t>
+            </a:r>
+          </a:p>
+        </p:txBody>
+      </p:sp>
+      <p:sp>
+        <p:nvSpPr>
+          <p:cNvPr id="44" name="Rounded Rectangle 43"/>
+          <p:cNvSpPr/>
+          <p:nvPr/>
+        </p:nvSpPr>
+        <p:spPr>
+          <a:xfrm>
+            <a:off x="6080760" y="4160520"/>
+            <a:ext cx="2651760" cy="1417320"/>
+          </a:xfrm>
+          <a:prstGeom prst="roundRect">
+            <a:avLst>
+              <a:gd name="adj" fmla="val 10000"/>
+            </a:avLst>
+          </a:prstGeom>
+          <a:solidFill>
+            <a:srgbClr val="0C2340"/>
+          </a:solidFill>
+          <a:ln w="15240">
+            <a:solidFill>
+              <a:srgbClr val="38BDF8"/>
+            </a:solidFill>
+          </a:ln>
+        </p:spPr>
+        <p:style>
+          <a:lnRef idx="1">
+            <a:schemeClr val="accent1"/>
+          </a:lnRef>
+          <a:fillRef idx="3">
+            <a:schemeClr val="accent1"/>
+          </a:fillRef>
+          <a:effectRef idx="2">
+            <a:schemeClr val="accent1"/>
+          </a:effectRef>
+          <a:fontRef idx="minor">
+            <a:schemeClr val="lt1"/>
+          </a:fontRef>
+        </p:style>
+        <p:txBody>
+          <a:bodyPr rtlCol="0" anchor="ctr"/>
+          <a:lstStyle/>
+          <a:p>
+            <a:pPr algn="ctr"/>
+          </a:p>
+        </p:txBody>
+      </p:sp>
+      <p:sp>
+        <p:nvSpPr>
+          <p:cNvPr id="45" name="TextBox 44"/>
+          <p:cNvSpPr txBox="1"/>
+          <p:nvPr/>
+        </p:nvSpPr>
+        <p:spPr>
+          <a:xfrm>
+            <a:off x="6208776" y="4325112"/>
+            <a:ext cx="2395728" cy="274320"/>
+          </a:xfrm>
+          <a:prstGeom prst="rect">
+            <a:avLst/>
+          </a:prstGeom>
+          <a:noFill/>
+        </p:spPr>
+        <p:txBody>
+          <a:bodyPr wrap="square">
+            <a:spAutoFit/>
+          </a:bodyPr>
+          <a:lstStyle/>
+          <a:p>
+            <a:pPr algn="l"/>
+            <a:r>
+              <a:rPr sz="1400" b="1">
+                <a:solidFill>
+                  <a:srgbClr val="F8FAFC"/>
+                </a:solidFill>
+                <a:latin typeface="Calibri"/>
+              </a:rPr>
+              <a:t>Notification</a:t>
+            </a:r>
+          </a:p>
+        </p:txBody>
+      </p:sp>
+      <p:sp>
+        <p:nvSpPr>
+          <p:cNvPr id="46" name="TextBox 45"/>
+          <p:cNvSpPr txBox="1"/>
+          <p:nvPr/>
+        </p:nvSpPr>
+        <p:spPr>
+          <a:xfrm>
+            <a:off x="6208776" y="4645152"/>
+            <a:ext cx="2395728" cy="502920"/>
+          </a:xfrm>
+          <a:prstGeom prst="rect">
+            <a:avLst/>
+          </a:prstGeom>
+          <a:noFill/>
+        </p:spPr>
+        <p:txBody>
+          <a:bodyPr wrap="square">
+            <a:spAutoFit/>
+          </a:bodyPr>
+          <a:lstStyle/>
+          <a:p>
+            <a:pPr algn="l"/>
+            <a:r>
+              <a:rPr sz="1100" b="0">
+                <a:solidFill>
+                  <a:srgbClr val="94A3B8"/>
+                </a:solidFill>
+                <a:latin typeface="Calibri"/>
+              </a:rPr>
+              <a:t>Push · SMS · inbox</a:t>
+            </a:r>
+          </a:p>
+        </p:txBody>
+      </p:sp>
+      <p:sp>
+        <p:nvSpPr>
+          <p:cNvPr id="47" name="TextBox 46"/>
+          <p:cNvSpPr txBox="1"/>
+          <p:nvPr/>
+        </p:nvSpPr>
+        <p:spPr>
+          <a:xfrm>
+            <a:off x="6208776" y="5102352"/>
+            <a:ext cx="2395728" cy="228600"/>
+          </a:xfrm>
+          <a:prstGeom prst="rect">
+            <a:avLst/>
+          </a:prstGeom>
+          <a:noFill/>
+        </p:spPr>
+        <p:txBody>
+          <a:bodyPr wrap="square">
+            <a:spAutoFit/>
+          </a:bodyPr>
+          <a:lstStyle/>
+          <a:p>
+            <a:pPr algn="l"/>
+            <a:r>
+              <a:rPr sz="1000" b="0">
+                <a:solidFill>
+                  <a:srgbClr val="38BDF8"/>
+                </a:solidFill>
+                <a:latin typeface="Calibri"/>
+              </a:rPr>
+              <a:t>UAF-owned</a:t>
+            </a:r>
+          </a:p>
+        </p:txBody>
+      </p:sp>
+      <p:sp>
+        <p:nvSpPr>
+          <p:cNvPr id="48" name="Rounded Rectangle 47"/>
+          <p:cNvSpPr/>
+          <p:nvPr/>
+        </p:nvSpPr>
+        <p:spPr>
+          <a:xfrm>
+            <a:off x="8915400" y="4160520"/>
+            <a:ext cx="2651760" cy="1417320"/>
+          </a:xfrm>
+          <a:prstGeom prst="roundRect">
+            <a:avLst>
+              <a:gd name="adj" fmla="val 10000"/>
+            </a:avLst>
+          </a:prstGeom>
+          <a:solidFill>
+            <a:srgbClr val="0C2340"/>
+          </a:solidFill>
+          <a:ln w="15240">
+            <a:solidFill>
+              <a:srgbClr val="FB923C"/>
+            </a:solidFill>
+          </a:ln>
+        </p:spPr>
+        <p:style>
+          <a:lnRef idx="1">
+            <a:schemeClr val="accent1"/>
+          </a:lnRef>
+          <a:fillRef idx="3">
+            <a:schemeClr val="accent1"/>
+          </a:fillRef>
+          <a:effectRef idx="2">
+            <a:schemeClr val="accent1"/>
+          </a:effectRef>
+          <a:fontRef idx="minor">
+            <a:schemeClr val="lt1"/>
+          </a:fontRef>
+        </p:style>
+        <p:txBody>
+          <a:bodyPr rtlCol="0" anchor="ctr"/>
+          <a:lstStyle/>
+          <a:p>
+            <a:pPr algn="ctr"/>
+          </a:p>
+        </p:txBody>
+      </p:sp>
+      <p:sp>
+        <p:nvSpPr>
+          <p:cNvPr id="49" name="TextBox 48"/>
+          <p:cNvSpPr txBox="1"/>
+          <p:nvPr/>
+        </p:nvSpPr>
+        <p:spPr>
+          <a:xfrm>
+            <a:off x="9043416" y="4325112"/>
+            <a:ext cx="2395728" cy="274320"/>
+          </a:xfrm>
+          <a:prstGeom prst="rect">
+            <a:avLst/>
+          </a:prstGeom>
+          <a:noFill/>
+        </p:spPr>
+        <p:txBody>
+          <a:bodyPr wrap="square">
+            <a:spAutoFit/>
+          </a:bodyPr>
+          <a:lstStyle/>
+          <a:p>
+            <a:pPr algn="l"/>
+            <a:r>
+              <a:rPr sz="1400" b="1">
+                <a:solidFill>
+                  <a:srgbClr val="F8FAFC"/>
+                </a:solidFill>
+                <a:latin typeface="Calibri"/>
+              </a:rPr>
+              <a:t>xapi / CRM</a:t>
+            </a:r>
+          </a:p>
+        </p:txBody>
+      </p:sp>
+      <p:sp>
+        <p:nvSpPr>
+          <p:cNvPr id="50" name="TextBox 49"/>
+          <p:cNvSpPr txBox="1"/>
+          <p:nvPr/>
+        </p:nvSpPr>
+        <p:spPr>
+          <a:xfrm>
+            <a:off x="9043416" y="4645152"/>
+            <a:ext cx="2395728" cy="502920"/>
+          </a:xfrm>
+          <a:prstGeom prst="rect">
+            <a:avLst/>
+          </a:prstGeom>
+          <a:noFill/>
+        </p:spPr>
+        <p:txBody>
+          <a:bodyPr wrap="square">
+            <a:spAutoFit/>
+          </a:bodyPr>
+          <a:lstStyle/>
+          <a:p>
+            <a:pPr algn="l"/>
+            <a:r>
+              <a:rPr sz="1100" b="0">
+                <a:solidFill>
+                  <a:srgbClr val="94A3B8"/>
+                </a:solidFill>
+                <a:latin typeface="Calibri"/>
+              </a:rPr>
+              <a:t>Balances · apps (Yes UA · aim)</a:t>
+            </a:r>
+          </a:p>
+        </p:txBody>
+      </p:sp>
+      <p:sp>
+        <p:nvSpPr>
+          <p:cNvPr id="51" name="TextBox 50"/>
+          <p:cNvSpPr txBox="1"/>
+          <p:nvPr/>
+        </p:nvSpPr>
+        <p:spPr>
+          <a:xfrm>
+            <a:off x="9043416" y="5102352"/>
+            <a:ext cx="2395728" cy="228600"/>
+          </a:xfrm>
+          <a:prstGeom prst="rect">
+            <a:avLst/>
+          </a:prstGeom>
+          <a:noFill/>
+        </p:spPr>
+        <p:txBody>
+          <a:bodyPr wrap="square">
+            <a:spAutoFit/>
+          </a:bodyPr>
+          <a:lstStyle/>
+          <a:p>
+            <a:pPr algn="l"/>
+            <a:r>
+              <a:rPr sz="1000" b="0">
+                <a:solidFill>
+                  <a:srgbClr val="FB923C"/>
+                </a:solidFill>
+                <a:latin typeface="Calibri"/>
+              </a:rPr>
+              <a:t>UAF-owned</a:t>
+            </a:r>
+          </a:p>
+        </p:txBody>
+      </p:sp>
+      <p:sp>
+        <p:nvSpPr>
+          <p:cNvPr id="52" name="Rounded Rectangle 51"/>
+          <p:cNvSpPr/>
+          <p:nvPr/>
+        </p:nvSpPr>
+        <p:spPr>
+          <a:xfrm>
+            <a:off x="411480" y="5669280"/>
+            <a:ext cx="2651760" cy="365760"/>
+          </a:xfrm>
+          <a:prstGeom prst="roundRect">
+            <a:avLst>
+              <a:gd name="adj" fmla="val 12000"/>
+            </a:avLst>
+          </a:prstGeom>
+          <a:solidFill>
+            <a:srgbClr val="2A1424"/>
+          </a:solidFill>
+          <a:ln w="12700">
+            <a:solidFill>
+              <a:srgbClr val="F9A8D4"/>
+            </a:solidFill>
+          </a:ln>
+        </p:spPr>
+        <p:style>
+          <a:lnRef idx="1">
+            <a:schemeClr val="accent1"/>
+          </a:lnRef>
+          <a:fillRef idx="3">
+            <a:schemeClr val="accent1"/>
+          </a:fillRef>
+          <a:effectRef idx="2">
+            <a:schemeClr val="accent1"/>
+          </a:effectRef>
+          <a:fontRef idx="minor">
+            <a:schemeClr val="lt1"/>
+          </a:fontRef>
+        </p:style>
+        <p:txBody>
+          <a:bodyPr rtlCol="0" anchor="ctr"/>
+          <a:lstStyle/>
+          <a:p>
+            <a:pPr algn="ctr"/>
+          </a:p>
+        </p:txBody>
+      </p:sp>
+      <p:sp>
+        <p:nvSpPr>
+          <p:cNvPr id="53" name="TextBox 52"/>
+          <p:cNvSpPr txBox="1"/>
+          <p:nvPr/>
+        </p:nvSpPr>
+        <p:spPr>
+          <a:xfrm>
+            <a:off x="502920" y="5742432"/>
+            <a:ext cx="2468880" cy="256032"/>
+          </a:xfrm>
+          <a:prstGeom prst="rect">
+            <a:avLst/>
+          </a:prstGeom>
+          <a:noFill/>
+        </p:spPr>
+        <p:txBody>
+          <a:bodyPr wrap="square">
+            <a:spAutoFit/>
+          </a:bodyPr>
+          <a:lstStyle/>
+          <a:p>
+            <a:pPr algn="l"/>
+            <a:r>
+              <a:rPr sz="1100" b="0">
+                <a:solidFill>
+                  <a:srgbClr val="F9A8D4"/>
+                </a:solidFill>
+                <a:latin typeface="Calibri"/>
+              </a:rPr>
+              <a:t>↓ COD · other partners</a:t>
+            </a:r>
+          </a:p>
+        </p:txBody>
+      </p:sp>
+      <p:sp>
+        <p:nvSpPr>
+          <p:cNvPr id="54" name="Rounded Rectangle 53"/>
+          <p:cNvSpPr/>
+          <p:nvPr/>
+        </p:nvSpPr>
+        <p:spPr>
+          <a:xfrm>
+            <a:off x="3246120" y="5669280"/>
+            <a:ext cx="8458200" cy="365760"/>
+          </a:xfrm>
+          <a:prstGeom prst="roundRect">
+            <a:avLst>
+              <a:gd name="adj" fmla="val 12000"/>
+            </a:avLst>
+          </a:prstGeom>
+          <a:solidFill>
+            <a:srgbClr val="102A48"/>
+          </a:solidFill>
+          <a:ln w="12700">
+            <a:solidFill>
+              <a:srgbClr val="2DD4BF"/>
+            </a:solidFill>
+          </a:ln>
+        </p:spPr>
+        <p:style>
+          <a:lnRef idx="1">
+            <a:schemeClr val="accent1"/>
+          </a:lnRef>
+          <a:fillRef idx="3">
+            <a:schemeClr val="accent1"/>
+          </a:fillRef>
+          <a:effectRef idx="2">
+            <a:schemeClr val="accent1"/>
+          </a:effectRef>
+          <a:fontRef idx="minor">
+            <a:schemeClr val="lt1"/>
+          </a:fontRef>
+        </p:style>
+        <p:txBody>
+          <a:bodyPr rtlCol="0" anchor="ctr"/>
+          <a:lstStyle/>
+          <a:p>
+            <a:pPr algn="ctr"/>
+          </a:p>
+        </p:txBody>
+      </p:sp>
+      <p:sp>
+        <p:nvSpPr>
+          <p:cNvPr id="55" name="TextBox 54"/>
+          <p:cNvSpPr txBox="1"/>
+          <p:nvPr/>
+        </p:nvSpPr>
+        <p:spPr>
+          <a:xfrm>
+            <a:off x="3383280" y="5742432"/>
+            <a:ext cx="8229600" cy="256032"/>
+          </a:xfrm>
+          <a:prstGeom prst="rect">
+            <a:avLst/>
+          </a:prstGeom>
+          <a:noFill/>
+        </p:spPr>
+        <p:txBody>
+          <a:bodyPr wrap="square">
+            <a:spAutoFit/>
+          </a:bodyPr>
+          <a:lstStyle/>
+          <a:p>
+            <a:pPr algn="l"/>
+            <a:r>
+              <a:rPr sz="1200" b="1">
+                <a:solidFill>
+                  <a:srgbClr val="F8FAFC"/>
+                </a:solidFill>
+                <a:latin typeface="Calibri"/>
+              </a:rPr>
+              <a:t>Pitch: Buy LedgeRX. Integrate once to the Landing hub. CBP/Gift/Notify stay behind your layer.</a:t>
+            </a:r>
+          </a:p>
+        </p:txBody>
+      </p:sp>
+      <p:sp>
+        <p:nvSpPr>
+          <p:cNvPr id="56" name="Rounded Rectangle 55"/>
+          <p:cNvSpPr/>
+          <p:nvPr/>
+        </p:nvSpPr>
+        <p:spPr>
+          <a:xfrm>
+            <a:off x="365760" y="6172200"/>
+            <a:ext cx="11460175" cy="457200"/>
           </a:xfrm>
           <a:prstGeom prst="roundRect">
             <a:avLst>
@@ -10059,13 +10231,13 @@
       </p:sp>
       <p:sp>
         <p:nvSpPr>
-          <p:cNvPr id="54" name="TextBox 53"/>
+          <p:cNvPr id="57" name="TextBox 56"/>
           <p:cNvSpPr txBox="1"/>
           <p:nvPr/>
         </p:nvSpPr>
         <p:spPr>
           <a:xfrm>
-            <a:off x="502920" y="6199632"/>
+            <a:off x="502920" y="6263640"/>
             <a:ext cx="11155680" cy="320040"/>
           </a:xfrm>
           <a:prstGeom prst="rect">
@@ -10081,13 +10253,13 @@
           <a:p>
             <a:pPr algn="l"/>
             <a:r>
-              <a:rPr sz="1300" b="0">
+              <a:rPr sz="1200" b="0">
                 <a:solidFill>
                   <a:srgbClr val="CBD5E1"/>
                 </a:solidFill>
                 <a:latin typeface="Calibri"/>
               </a:rPr>
-              <a:t>Not peer-to-peer platforms   ·   LedgeRX is the product hub   ·   CBP / Gift / Notify / CRM are downstream spokes</a:t>
+              <a:t>LedgeRX ↔ one UAF 對口 only     ·     hub collects outcomes + runs UAF logic     ·     internal fan-out is UAF’s business</a:t>
             </a:r>
           </a:p>
         </p:txBody>

</xml_diff>

<commit_message>
docs(decks): fix slide2 format — clean title stack, no overlap
</commit_message>
<xml_diff>
--- a/docs/decks/LedgeRX-System-Architecture-CTO.pptx
+++ b/docs/decks/LedgeRX-System-Architecture-CTO.pptx
@@ -3184,7 +3184,7 @@
         <p:spPr>
           <a:xfrm>
             <a:off x="365760" y="164592"/>
-            <a:ext cx="8229600" cy="310896"/>
+            <a:ext cx="8229600" cy="292608"/>
           </a:xfrm>
           <a:prstGeom prst="rect">
             <a:avLst/>
@@ -3192,7 +3192,7 @@
           <a:noFill/>
         </p:spPr>
         <p:txBody>
-          <a:bodyPr wrap="square">
+          <a:bodyPr wrap="square" lIns="0" rIns="0" tIns="0" bIns="0">
             <a:spAutoFit/>
           </a:bodyPr>
           <a:lstStyle/>
@@ -3219,7 +3219,7 @@
         <p:spPr>
           <a:xfrm>
             <a:off x="365760" y="457200"/>
-            <a:ext cx="8412480" cy="237744"/>
+            <a:ext cx="8412480" cy="219456"/>
           </a:xfrm>
           <a:prstGeom prst="rect">
             <a:avLst/>
@@ -3227,7 +3227,7 @@
           <a:noFill/>
         </p:spPr>
         <p:txBody>
-          <a:bodyPr wrap="square">
+          <a:bodyPr wrap="square" lIns="0" rIns="0" tIns="0" bIns="0">
             <a:spAutoFit/>
           </a:bodyPr>
           <a:lstStyle/>
@@ -3253,8 +3253,8 @@
         </p:nvSpPr>
         <p:spPr>
           <a:xfrm>
-            <a:off x="10241280" y="182880"/>
-            <a:ext cx="1554480" cy="365760"/>
+            <a:off x="10241280" y="164592"/>
+            <a:ext cx="1554480" cy="347472"/>
           </a:xfrm>
           <a:prstGeom prst="roundRect">
             <a:avLst>
@@ -3300,8 +3300,8 @@
         </p:nvSpPr>
         <p:spPr>
           <a:xfrm>
-            <a:off x="10241280" y="237744"/>
-            <a:ext cx="1554480" cy="274320"/>
+            <a:off x="10241280" y="219456"/>
+            <a:ext cx="1554480" cy="256032"/>
           </a:xfrm>
           <a:prstGeom prst="rect">
             <a:avLst/>
@@ -3309,7 +3309,7 @@
           <a:noFill/>
         </p:spPr>
         <p:txBody>
-          <a:bodyPr wrap="square">
+          <a:bodyPr wrap="square" lIns="0" rIns="0" tIns="0" bIns="0">
             <a:spAutoFit/>
           </a:bodyPr>
           <a:lstStyle/>
@@ -3335,8 +3335,8 @@
         </p:nvSpPr>
         <p:spPr>
           <a:xfrm>
-            <a:off x="365760" y="822960"/>
-            <a:ext cx="1761082" cy="5120640"/>
+            <a:off x="365760" y="804672"/>
+            <a:ext cx="1761082" cy="5074920"/>
           </a:xfrm>
           <a:prstGeom prst="roundRect">
             <a:avLst>
@@ -3382,7 +3382,7 @@
         </p:nvSpPr>
         <p:spPr>
           <a:xfrm>
-            <a:off x="475488" y="950976"/>
+            <a:off x="475488" y="914400"/>
             <a:ext cx="237744" cy="237744"/>
           </a:xfrm>
           <a:prstGeom prst="ellipse">
@@ -3425,8 +3425,8 @@
         </p:nvSpPr>
         <p:spPr>
           <a:xfrm>
-            <a:off x="475488" y="960120"/>
-            <a:ext cx="237744" cy="219456"/>
+            <a:off x="475488" y="932688"/>
+            <a:ext cx="237744" cy="201168"/>
           </a:xfrm>
           <a:prstGeom prst="rect">
             <a:avLst/>
@@ -3434,7 +3434,7 @@
           <a:noFill/>
         </p:spPr>
         <p:txBody>
-          <a:bodyPr wrap="square">
+          <a:bodyPr wrap="square" lIns="0" rIns="0" tIns="0" bIns="0">
             <a:spAutoFit/>
           </a:bodyPr>
           <a:lstStyle/>
@@ -3460,8 +3460,8 @@
         </p:nvSpPr>
         <p:spPr>
           <a:xfrm>
-            <a:off x="768096" y="960120"/>
-            <a:ext cx="1249018" cy="219456"/>
+            <a:off x="768096" y="932688"/>
+            <a:ext cx="1249018" cy="201168"/>
           </a:xfrm>
           <a:prstGeom prst="rect">
             <a:avLst/>
@@ -3469,7 +3469,7 @@
           <a:noFill/>
         </p:spPr>
         <p:txBody>
-          <a:bodyPr wrap="square">
+          <a:bodyPr wrap="square" lIns="0" rIns="0" tIns="0" bIns="0">
             <a:spAutoFit/>
           </a:bodyPr>
           <a:lstStyle/>
@@ -3495,8 +3495,8 @@
         </p:nvSpPr>
         <p:spPr>
           <a:xfrm>
-            <a:off x="475488" y="1261872"/>
-            <a:ext cx="1541626" cy="274320"/>
+            <a:off x="475488" y="1225296"/>
+            <a:ext cx="1541626" cy="256032"/>
           </a:xfrm>
           <a:prstGeom prst="rect">
             <a:avLst/>
@@ -3504,7 +3504,7 @@
           <a:noFill/>
         </p:spPr>
         <p:txBody>
-          <a:bodyPr wrap="square">
+          <a:bodyPr wrap="square" lIns="0" rIns="0" tIns="0" bIns="0">
             <a:spAutoFit/>
           </a:bodyPr>
           <a:lstStyle/>
@@ -3530,7 +3530,7 @@
         </p:nvSpPr>
         <p:spPr>
           <a:xfrm>
-            <a:off x="475488" y="1691640"/>
+            <a:off x="475488" y="1627632"/>
             <a:ext cx="1541626" cy="932688"/>
           </a:xfrm>
           <a:prstGeom prst="roundRect">
@@ -3577,7 +3577,7 @@
         </p:nvSpPr>
         <p:spPr>
           <a:xfrm>
-            <a:off x="475488" y="1783080"/>
+            <a:off x="475488" y="1719072"/>
             <a:ext cx="50292" cy="749808"/>
           </a:xfrm>
           <a:prstGeom prst="rect">
@@ -3620,7 +3620,7 @@
         </p:nvSpPr>
         <p:spPr>
           <a:xfrm>
-            <a:off x="621792" y="1801368"/>
+            <a:off x="621792" y="1737360"/>
             <a:ext cx="1303882" cy="768096"/>
           </a:xfrm>
           <a:prstGeom prst="rect">
@@ -3629,7 +3629,7 @@
           <a:noFill/>
         </p:spPr>
         <p:txBody>
-          <a:bodyPr wrap="square">
+          <a:bodyPr wrap="square" lIns="0" rIns="0" tIns="0" bIns="0">
             <a:spAutoFit/>
           </a:bodyPr>
           <a:lstStyle/>
@@ -3639,7 +3639,7 @@
                 <a:spcPts val="0"/>
               </a:spcBef>
               <a:spcAft>
-                <a:spcPts val="100"/>
+                <a:spcPts val="200"/>
               </a:spcAft>
             </a:pPr>
             <a:r>
@@ -3658,7 +3658,7 @@
                 <a:spcPts val="0"/>
               </a:spcBef>
               <a:spcAft>
-                <a:spcPts val="100"/>
+                <a:spcPts val="200"/>
               </a:spcAft>
             </a:pPr>
             <a:r>
@@ -3681,7 +3681,7 @@
         </p:nvSpPr>
         <p:spPr>
           <a:xfrm>
-            <a:off x="475488" y="2743200"/>
+            <a:off x="475488" y="2679192"/>
             <a:ext cx="1541626" cy="932688"/>
           </a:xfrm>
           <a:prstGeom prst="roundRect">
@@ -3728,7 +3728,7 @@
         </p:nvSpPr>
         <p:spPr>
           <a:xfrm>
-            <a:off x="475488" y="2834640"/>
+            <a:off x="475488" y="2770632"/>
             <a:ext cx="50292" cy="749808"/>
           </a:xfrm>
           <a:prstGeom prst="rect">
@@ -3771,7 +3771,7 @@
         </p:nvSpPr>
         <p:spPr>
           <a:xfrm>
-            <a:off x="621792" y="2852928"/>
+            <a:off x="621792" y="2788920"/>
             <a:ext cx="1303882" cy="768096"/>
           </a:xfrm>
           <a:prstGeom prst="rect">
@@ -3780,7 +3780,7 @@
           <a:noFill/>
         </p:spPr>
         <p:txBody>
-          <a:bodyPr wrap="square">
+          <a:bodyPr wrap="square" lIns="0" rIns="0" tIns="0" bIns="0">
             <a:spAutoFit/>
           </a:bodyPr>
           <a:lstStyle/>
@@ -3790,7 +3790,7 @@
                 <a:spcPts val="0"/>
               </a:spcBef>
               <a:spcAft>
-                <a:spcPts val="100"/>
+                <a:spcPts val="200"/>
               </a:spcAft>
             </a:pPr>
             <a:r>
@@ -3809,7 +3809,7 @@
                 <a:spcPts val="0"/>
               </a:spcBef>
               <a:spcAft>
-                <a:spcPts val="100"/>
+                <a:spcPts val="200"/>
               </a:spcAft>
             </a:pPr>
             <a:r>
@@ -3832,7 +3832,7 @@
         </p:nvSpPr>
         <p:spPr>
           <a:xfrm>
-            <a:off x="475488" y="3794760"/>
+            <a:off x="475488" y="3730752"/>
             <a:ext cx="1541626" cy="932688"/>
           </a:xfrm>
           <a:prstGeom prst="roundRect">
@@ -3879,7 +3879,7 @@
         </p:nvSpPr>
         <p:spPr>
           <a:xfrm>
-            <a:off x="475488" y="3886200"/>
+            <a:off x="475488" y="3822192"/>
             <a:ext cx="50292" cy="749808"/>
           </a:xfrm>
           <a:prstGeom prst="rect">
@@ -3922,7 +3922,7 @@
         </p:nvSpPr>
         <p:spPr>
           <a:xfrm>
-            <a:off x="621792" y="3904488"/>
+            <a:off x="621792" y="3840480"/>
             <a:ext cx="1303882" cy="768096"/>
           </a:xfrm>
           <a:prstGeom prst="rect">
@@ -3931,7 +3931,7 @@
           <a:noFill/>
         </p:spPr>
         <p:txBody>
-          <a:bodyPr wrap="square">
+          <a:bodyPr wrap="square" lIns="0" rIns="0" tIns="0" bIns="0">
             <a:spAutoFit/>
           </a:bodyPr>
           <a:lstStyle/>
@@ -3941,7 +3941,7 @@
                 <a:spcPts val="0"/>
               </a:spcBef>
               <a:spcAft>
-                <a:spcPts val="100"/>
+                <a:spcPts val="200"/>
               </a:spcAft>
             </a:pPr>
             <a:r>
@@ -3960,7 +3960,7 @@
                 <a:spcPts val="0"/>
               </a:spcBef>
               <a:spcAft>
-                <a:spcPts val="100"/>
+                <a:spcPts val="200"/>
               </a:spcAft>
             </a:pPr>
             <a:r>
@@ -3983,8 +3983,8 @@
         </p:nvSpPr>
         <p:spPr>
           <a:xfrm>
-            <a:off x="475488" y="5029200"/>
-            <a:ext cx="1541626" cy="640080"/>
+            <a:off x="475488" y="4965192"/>
+            <a:ext cx="1541626" cy="594360"/>
           </a:xfrm>
           <a:prstGeom prst="rect">
             <a:avLst/>
@@ -3992,7 +3992,7 @@
           <a:noFill/>
         </p:spPr>
         <p:txBody>
-          <a:bodyPr wrap="square">
+          <a:bodyPr wrap="square" lIns="0" rIns="0" tIns="0" bIns="0">
             <a:spAutoFit/>
           </a:bodyPr>
           <a:lstStyle/>
@@ -4019,8 +4019,8 @@
         </p:nvSpPr>
         <p:spPr>
           <a:xfrm>
-            <a:off x="2382874" y="822960"/>
-            <a:ext cx="1761082" cy="5120640"/>
+            <a:off x="2382874" y="804672"/>
+            <a:ext cx="1761082" cy="5074920"/>
           </a:xfrm>
           <a:prstGeom prst="roundRect">
             <a:avLst>
@@ -4066,7 +4066,7 @@
         </p:nvSpPr>
         <p:spPr>
           <a:xfrm>
-            <a:off x="2492602" y="950976"/>
+            <a:off x="2492602" y="914400"/>
             <a:ext cx="237744" cy="237744"/>
           </a:xfrm>
           <a:prstGeom prst="ellipse">
@@ -4109,8 +4109,8 @@
         </p:nvSpPr>
         <p:spPr>
           <a:xfrm>
-            <a:off x="2492602" y="960120"/>
-            <a:ext cx="237744" cy="219456"/>
+            <a:off x="2492602" y="932688"/>
+            <a:ext cx="237744" cy="201168"/>
           </a:xfrm>
           <a:prstGeom prst="rect">
             <a:avLst/>
@@ -4118,7 +4118,7 @@
           <a:noFill/>
         </p:spPr>
         <p:txBody>
-          <a:bodyPr wrap="square">
+          <a:bodyPr wrap="square" lIns="0" rIns="0" tIns="0" bIns="0">
             <a:spAutoFit/>
           </a:bodyPr>
           <a:lstStyle/>
@@ -4144,8 +4144,8 @@
         </p:nvSpPr>
         <p:spPr>
           <a:xfrm>
-            <a:off x="2785210" y="960120"/>
-            <a:ext cx="1249018" cy="219456"/>
+            <a:off x="2785210" y="932688"/>
+            <a:ext cx="1249018" cy="201168"/>
           </a:xfrm>
           <a:prstGeom prst="rect">
             <a:avLst/>
@@ -4153,7 +4153,7 @@
           <a:noFill/>
         </p:spPr>
         <p:txBody>
-          <a:bodyPr wrap="square">
+          <a:bodyPr wrap="square" lIns="0" rIns="0" tIns="0" bIns="0">
             <a:spAutoFit/>
           </a:bodyPr>
           <a:lstStyle/>
@@ -4179,8 +4179,8 @@
         </p:nvSpPr>
         <p:spPr>
           <a:xfrm>
-            <a:off x="2492602" y="1261872"/>
-            <a:ext cx="1541626" cy="256032"/>
+            <a:off x="2492602" y="1225296"/>
+            <a:ext cx="1541626" cy="237744"/>
           </a:xfrm>
           <a:prstGeom prst="rect">
             <a:avLst/>
@@ -4188,7 +4188,7 @@
           <a:noFill/>
         </p:spPr>
         <p:txBody>
-          <a:bodyPr wrap="square">
+          <a:bodyPr wrap="square" lIns="0" rIns="0" tIns="0" bIns="0">
             <a:spAutoFit/>
           </a:bodyPr>
           <a:lstStyle/>
@@ -4214,8 +4214,8 @@
         </p:nvSpPr>
         <p:spPr>
           <a:xfrm>
-            <a:off x="2492602" y="1536192"/>
-            <a:ext cx="1541626" cy="320040"/>
+            <a:off x="2492602" y="1481328"/>
+            <a:ext cx="1541626" cy="292608"/>
           </a:xfrm>
           <a:prstGeom prst="rect">
             <a:avLst/>
@@ -4223,7 +4223,7 @@
           <a:noFill/>
         </p:spPr>
         <p:txBody>
-          <a:bodyPr wrap="square">
+          <a:bodyPr wrap="square" lIns="0" rIns="0" tIns="0" bIns="0">
             <a:spAutoFit/>
           </a:bodyPr>
           <a:lstStyle/>
@@ -4249,7 +4249,7 @@
         </p:nvSpPr>
         <p:spPr>
           <a:xfrm>
-            <a:off x="2492602" y="1965960"/>
+            <a:off x="2492602" y="1901952"/>
             <a:ext cx="1541626" cy="804672"/>
           </a:xfrm>
           <a:prstGeom prst="roundRect">
@@ -4296,7 +4296,7 @@
         </p:nvSpPr>
         <p:spPr>
           <a:xfrm>
-            <a:off x="2492602" y="2057400"/>
+            <a:off x="2492602" y="1993392"/>
             <a:ext cx="50292" cy="621792"/>
           </a:xfrm>
           <a:prstGeom prst="rect">
@@ -4339,7 +4339,7 @@
         </p:nvSpPr>
         <p:spPr>
           <a:xfrm>
-            <a:off x="2638906" y="2075688"/>
+            <a:off x="2638906" y="2011680"/>
             <a:ext cx="1303882" cy="640080"/>
           </a:xfrm>
           <a:prstGeom prst="rect">
@@ -4348,7 +4348,7 @@
           <a:noFill/>
         </p:spPr>
         <p:txBody>
-          <a:bodyPr wrap="square">
+          <a:bodyPr wrap="square" lIns="0" rIns="0" tIns="0" bIns="0">
             <a:spAutoFit/>
           </a:bodyPr>
           <a:lstStyle/>
@@ -4358,7 +4358,7 @@
                 <a:spcPts val="0"/>
               </a:spcBef>
               <a:spcAft>
-                <a:spcPts val="100"/>
+                <a:spcPts val="200"/>
               </a:spcAft>
             </a:pPr>
             <a:r>
@@ -4377,7 +4377,7 @@
                 <a:spcPts val="0"/>
               </a:spcBef>
               <a:spcAft>
-                <a:spcPts val="100"/>
+                <a:spcPts val="200"/>
               </a:spcAft>
             </a:pPr>
             <a:r>
@@ -4400,7 +4400,7 @@
         </p:nvSpPr>
         <p:spPr>
           <a:xfrm>
-            <a:off x="2492602" y="2880360"/>
+            <a:off x="2492602" y="2816352"/>
             <a:ext cx="1541626" cy="804672"/>
           </a:xfrm>
           <a:prstGeom prst="roundRect">
@@ -4447,7 +4447,7 @@
         </p:nvSpPr>
         <p:spPr>
           <a:xfrm>
-            <a:off x="2492602" y="2971800"/>
+            <a:off x="2492602" y="2907792"/>
             <a:ext cx="50292" cy="621792"/>
           </a:xfrm>
           <a:prstGeom prst="rect">
@@ -4490,7 +4490,7 @@
         </p:nvSpPr>
         <p:spPr>
           <a:xfrm>
-            <a:off x="2638906" y="2990088"/>
+            <a:off x="2638906" y="2926080"/>
             <a:ext cx="1303882" cy="640080"/>
           </a:xfrm>
           <a:prstGeom prst="rect">
@@ -4499,7 +4499,7 @@
           <a:noFill/>
         </p:spPr>
         <p:txBody>
-          <a:bodyPr wrap="square">
+          <a:bodyPr wrap="square" lIns="0" rIns="0" tIns="0" bIns="0">
             <a:spAutoFit/>
           </a:bodyPr>
           <a:lstStyle/>
@@ -4509,7 +4509,7 @@
                 <a:spcPts val="0"/>
               </a:spcBef>
               <a:spcAft>
-                <a:spcPts val="100"/>
+                <a:spcPts val="200"/>
               </a:spcAft>
             </a:pPr>
             <a:r>
@@ -4528,7 +4528,7 @@
                 <a:spcPts val="0"/>
               </a:spcBef>
               <a:spcAft>
-                <a:spcPts val="100"/>
+                <a:spcPts val="200"/>
               </a:spcAft>
             </a:pPr>
             <a:r>
@@ -4551,7 +4551,7 @@
         </p:nvSpPr>
         <p:spPr>
           <a:xfrm>
-            <a:off x="2492602" y="3794760"/>
+            <a:off x="2492602" y="3730752"/>
             <a:ext cx="1541626" cy="804672"/>
           </a:xfrm>
           <a:prstGeom prst="roundRect">
@@ -4598,7 +4598,7 @@
         </p:nvSpPr>
         <p:spPr>
           <a:xfrm>
-            <a:off x="2492602" y="3886200"/>
+            <a:off x="2492602" y="3822192"/>
             <a:ext cx="50292" cy="621792"/>
           </a:xfrm>
           <a:prstGeom prst="rect">
@@ -4641,7 +4641,7 @@
         </p:nvSpPr>
         <p:spPr>
           <a:xfrm>
-            <a:off x="2638906" y="3904488"/>
+            <a:off x="2638906" y="3840480"/>
             <a:ext cx="1303882" cy="640080"/>
           </a:xfrm>
           <a:prstGeom prst="rect">
@@ -4650,7 +4650,7 @@
           <a:noFill/>
         </p:spPr>
         <p:txBody>
-          <a:bodyPr wrap="square">
+          <a:bodyPr wrap="square" lIns="0" rIns="0" tIns="0" bIns="0">
             <a:spAutoFit/>
           </a:bodyPr>
           <a:lstStyle/>
@@ -4660,7 +4660,7 @@
                 <a:spcPts val="0"/>
               </a:spcBef>
               <a:spcAft>
-                <a:spcPts val="100"/>
+                <a:spcPts val="200"/>
               </a:spcAft>
             </a:pPr>
             <a:r>
@@ -4679,7 +4679,7 @@
                 <a:spcPts val="0"/>
               </a:spcBef>
               <a:spcAft>
-                <a:spcPts val="100"/>
+                <a:spcPts val="200"/>
               </a:spcAft>
             </a:pPr>
             <a:r>
@@ -4702,8 +4702,8 @@
         </p:nvSpPr>
         <p:spPr>
           <a:xfrm>
-            <a:off x="2492602" y="4892040"/>
-            <a:ext cx="1541626" cy="822960"/>
+            <a:off x="2492602" y="4828032"/>
+            <a:ext cx="1541626" cy="777240"/>
           </a:xfrm>
           <a:prstGeom prst="rect">
             <a:avLst/>
@@ -4711,7 +4711,7 @@
           <a:noFill/>
         </p:spPr>
         <p:txBody>
-          <a:bodyPr wrap="square">
+          <a:bodyPr wrap="square" lIns="0" rIns="0" tIns="0" bIns="0">
             <a:spAutoFit/>
           </a:bodyPr>
           <a:lstStyle/>
@@ -4739,7 +4739,7 @@
         </p:nvSpPr>
         <p:spPr>
           <a:xfrm>
-            <a:off x="2163418" y="2743200"/>
+            <a:off x="2163418" y="2679191"/>
             <a:ext cx="182880" cy="137160"/>
           </a:xfrm>
           <a:prstGeom prst="rightArrow">
@@ -4782,7 +4782,7 @@
         </p:nvSpPr>
         <p:spPr>
           <a:xfrm>
-            <a:off x="4180532" y="2743200"/>
+            <a:off x="4180532" y="2679191"/>
             <a:ext cx="182880" cy="137160"/>
           </a:xfrm>
           <a:prstGeom prst="rightArrow">
@@ -4825,7 +4825,7 @@
         </p:nvSpPr>
         <p:spPr>
           <a:xfrm>
-            <a:off x="2163418" y="4023360"/>
+            <a:off x="2163418" y="3959352"/>
             <a:ext cx="182880" cy="137160"/>
           </a:xfrm>
           <a:prstGeom prst="rightArrow">
@@ -4868,7 +4868,7 @@
         </p:nvSpPr>
         <p:spPr>
           <a:xfrm>
-            <a:off x="4180532" y="4023360"/>
+            <a:off x="4180532" y="3959352"/>
             <a:ext cx="182880" cy="137160"/>
           </a:xfrm>
           <a:prstGeom prst="rightArrow">
@@ -4911,8 +4911,8 @@
         </p:nvSpPr>
         <p:spPr>
           <a:xfrm>
-            <a:off x="4399988" y="822960"/>
-            <a:ext cx="3913517" cy="5120640"/>
+            <a:off x="4399988" y="804672"/>
+            <a:ext cx="3913517" cy="5074920"/>
           </a:xfrm>
           <a:prstGeom prst="roundRect">
             <a:avLst>
@@ -4958,8 +4958,8 @@
         </p:nvSpPr>
         <p:spPr>
           <a:xfrm>
-            <a:off x="4528004" y="932688"/>
-            <a:ext cx="3657485" cy="384048"/>
+            <a:off x="4528004" y="896112"/>
+            <a:ext cx="3657485" cy="365760"/>
           </a:xfrm>
           <a:prstGeom prst="roundRect">
             <a:avLst>
@@ -5005,8 +5005,8 @@
         </p:nvSpPr>
         <p:spPr>
           <a:xfrm>
-            <a:off x="4601156" y="987552"/>
-            <a:ext cx="3511181" cy="292608"/>
+            <a:off x="4601156" y="950976"/>
+            <a:ext cx="3511181" cy="274320"/>
           </a:xfrm>
           <a:prstGeom prst="rect">
             <a:avLst/>
@@ -5014,7 +5014,7 @@
           <a:noFill/>
         </p:spPr>
         <p:txBody>
-          <a:bodyPr wrap="square">
+          <a:bodyPr wrap="square" lIns="0" rIns="0" tIns="0" bIns="0">
             <a:spAutoFit/>
           </a:bodyPr>
           <a:lstStyle/>
@@ -5040,8 +5040,8 @@
         </p:nvSpPr>
         <p:spPr>
           <a:xfrm>
-            <a:off x="4564580" y="1371600"/>
-            <a:ext cx="3584333" cy="256032"/>
+            <a:off x="4564580" y="1316736"/>
+            <a:ext cx="3584333" cy="237744"/>
           </a:xfrm>
           <a:prstGeom prst="rect">
             <a:avLst/>
@@ -5049,7 +5049,7 @@
           <a:noFill/>
         </p:spPr>
         <p:txBody>
-          <a:bodyPr wrap="square">
+          <a:bodyPr wrap="square" lIns="0" rIns="0" tIns="0" bIns="0">
             <a:spAutoFit/>
           </a:bodyPr>
           <a:lstStyle/>
@@ -5075,8 +5075,8 @@
         </p:nvSpPr>
         <p:spPr>
           <a:xfrm>
-            <a:off x="4546292" y="1719072"/>
-            <a:ext cx="1755590" cy="841248"/>
+            <a:off x="4546292" y="1673352"/>
+            <a:ext cx="1755590" cy="822960"/>
           </a:xfrm>
           <a:prstGeom prst="roundRect">
             <a:avLst>
@@ -5122,8 +5122,8 @@
         </p:nvSpPr>
         <p:spPr>
           <a:xfrm>
-            <a:off x="4546292" y="1810512"/>
-            <a:ext cx="50292" cy="658368"/>
+            <a:off x="4546292" y="1764792"/>
+            <a:ext cx="50292" cy="640080"/>
           </a:xfrm>
           <a:prstGeom prst="rect">
             <a:avLst/>
@@ -5165,8 +5165,8 @@
         </p:nvSpPr>
         <p:spPr>
           <a:xfrm>
-            <a:off x="4692596" y="1828800"/>
-            <a:ext cx="1517846" cy="676656"/>
+            <a:off x="4692596" y="1783080"/>
+            <a:ext cx="1517846" cy="658368"/>
           </a:xfrm>
           <a:prstGeom prst="rect">
             <a:avLst/>
@@ -5174,7 +5174,7 @@
           <a:noFill/>
         </p:spPr>
         <p:txBody>
-          <a:bodyPr wrap="square">
+          <a:bodyPr wrap="square" lIns="0" rIns="0" tIns="0" bIns="0">
             <a:spAutoFit/>
           </a:bodyPr>
           <a:lstStyle/>
@@ -5184,7 +5184,7 @@
                 <a:spcPts val="0"/>
               </a:spcBef>
               <a:spcAft>
-                <a:spcPts val="100"/>
+                <a:spcPts val="200"/>
               </a:spcAft>
             </a:pPr>
             <a:r>
@@ -5203,7 +5203,7 @@
                 <a:spcPts val="0"/>
               </a:spcBef>
               <a:spcAft>
-                <a:spcPts val="100"/>
+                <a:spcPts val="200"/>
               </a:spcAft>
             </a:pPr>
             <a:r>
@@ -5226,8 +5226,8 @@
         </p:nvSpPr>
         <p:spPr>
           <a:xfrm>
-            <a:off x="6411610" y="1719072"/>
-            <a:ext cx="1755590" cy="841248"/>
+            <a:off x="6411610" y="1673352"/>
+            <a:ext cx="1755590" cy="822960"/>
           </a:xfrm>
           <a:prstGeom prst="roundRect">
             <a:avLst>
@@ -5273,8 +5273,8 @@
         </p:nvSpPr>
         <p:spPr>
           <a:xfrm>
-            <a:off x="6411610" y="1810512"/>
-            <a:ext cx="50292" cy="658368"/>
+            <a:off x="6411610" y="1764792"/>
+            <a:ext cx="50292" cy="640080"/>
           </a:xfrm>
           <a:prstGeom prst="rect">
             <a:avLst/>
@@ -5316,8 +5316,8 @@
         </p:nvSpPr>
         <p:spPr>
           <a:xfrm>
-            <a:off x="6557914" y="1828800"/>
-            <a:ext cx="1517846" cy="676656"/>
+            <a:off x="6557914" y="1783080"/>
+            <a:ext cx="1517846" cy="658368"/>
           </a:xfrm>
           <a:prstGeom prst="rect">
             <a:avLst/>
@@ -5325,7 +5325,7 @@
           <a:noFill/>
         </p:spPr>
         <p:txBody>
-          <a:bodyPr wrap="square">
+          <a:bodyPr wrap="square" lIns="0" rIns="0" tIns="0" bIns="0">
             <a:spAutoFit/>
           </a:bodyPr>
           <a:lstStyle/>
@@ -5335,7 +5335,7 @@
                 <a:spcPts val="0"/>
               </a:spcBef>
               <a:spcAft>
-                <a:spcPts val="100"/>
+                <a:spcPts val="200"/>
               </a:spcAft>
             </a:pPr>
             <a:r>
@@ -5354,7 +5354,7 @@
                 <a:spcPts val="0"/>
               </a:spcBef>
               <a:spcAft>
-                <a:spcPts val="100"/>
+                <a:spcPts val="200"/>
               </a:spcAft>
             </a:pPr>
             <a:r>
@@ -5377,8 +5377,8 @@
         </p:nvSpPr>
         <p:spPr>
           <a:xfrm>
-            <a:off x="4546292" y="2651760"/>
-            <a:ext cx="1755590" cy="841248"/>
+            <a:off x="4546292" y="2587752"/>
+            <a:ext cx="1755590" cy="822960"/>
           </a:xfrm>
           <a:prstGeom prst="roundRect">
             <a:avLst>
@@ -5424,8 +5424,8 @@
         </p:nvSpPr>
         <p:spPr>
           <a:xfrm>
-            <a:off x="4546292" y="2743200"/>
-            <a:ext cx="50292" cy="658368"/>
+            <a:off x="4546292" y="2679192"/>
+            <a:ext cx="50292" cy="640080"/>
           </a:xfrm>
           <a:prstGeom prst="rect">
             <a:avLst/>
@@ -5467,8 +5467,8 @@
         </p:nvSpPr>
         <p:spPr>
           <a:xfrm>
-            <a:off x="4692596" y="2761488"/>
-            <a:ext cx="1517846" cy="676656"/>
+            <a:off x="4692596" y="2697480"/>
+            <a:ext cx="1517846" cy="658368"/>
           </a:xfrm>
           <a:prstGeom prst="rect">
             <a:avLst/>
@@ -5476,7 +5476,7 @@
           <a:noFill/>
         </p:spPr>
         <p:txBody>
-          <a:bodyPr wrap="square">
+          <a:bodyPr wrap="square" lIns="0" rIns="0" tIns="0" bIns="0">
             <a:spAutoFit/>
           </a:bodyPr>
           <a:lstStyle/>
@@ -5486,7 +5486,7 @@
                 <a:spcPts val="0"/>
               </a:spcBef>
               <a:spcAft>
-                <a:spcPts val="100"/>
+                <a:spcPts val="200"/>
               </a:spcAft>
             </a:pPr>
             <a:r>
@@ -5505,7 +5505,7 @@
                 <a:spcPts val="0"/>
               </a:spcBef>
               <a:spcAft>
-                <a:spcPts val="100"/>
+                <a:spcPts val="200"/>
               </a:spcAft>
             </a:pPr>
             <a:r>
@@ -5528,8 +5528,8 @@
         </p:nvSpPr>
         <p:spPr>
           <a:xfrm>
-            <a:off x="6411610" y="2651760"/>
-            <a:ext cx="1755590" cy="841248"/>
+            <a:off x="6411610" y="2587752"/>
+            <a:ext cx="1755590" cy="822960"/>
           </a:xfrm>
           <a:prstGeom prst="roundRect">
             <a:avLst>
@@ -5575,8 +5575,8 @@
         </p:nvSpPr>
         <p:spPr>
           <a:xfrm>
-            <a:off x="6411610" y="2743200"/>
-            <a:ext cx="50292" cy="658368"/>
+            <a:off x="6411610" y="2679192"/>
+            <a:ext cx="50292" cy="640080"/>
           </a:xfrm>
           <a:prstGeom prst="rect">
             <a:avLst/>
@@ -5618,8 +5618,8 @@
         </p:nvSpPr>
         <p:spPr>
           <a:xfrm>
-            <a:off x="6557914" y="2761488"/>
-            <a:ext cx="1517846" cy="676656"/>
+            <a:off x="6557914" y="2697480"/>
+            <a:ext cx="1517846" cy="658368"/>
           </a:xfrm>
           <a:prstGeom prst="rect">
             <a:avLst/>
@@ -5627,7 +5627,7 @@
           <a:noFill/>
         </p:spPr>
         <p:txBody>
-          <a:bodyPr wrap="square">
+          <a:bodyPr wrap="square" lIns="0" rIns="0" tIns="0" bIns="0">
             <a:spAutoFit/>
           </a:bodyPr>
           <a:lstStyle/>
@@ -5637,7 +5637,7 @@
                 <a:spcPts val="0"/>
               </a:spcBef>
               <a:spcAft>
-                <a:spcPts val="100"/>
+                <a:spcPts val="200"/>
               </a:spcAft>
             </a:pPr>
             <a:r>
@@ -5656,7 +5656,7 @@
                 <a:spcPts val="0"/>
               </a:spcBef>
               <a:spcAft>
-                <a:spcPts val="100"/>
+                <a:spcPts val="200"/>
               </a:spcAft>
             </a:pPr>
             <a:r>
@@ -5679,8 +5679,8 @@
         </p:nvSpPr>
         <p:spPr>
           <a:xfrm>
-            <a:off x="4546292" y="3584448"/>
-            <a:ext cx="1755590" cy="841248"/>
+            <a:off x="4546292" y="3502152"/>
+            <a:ext cx="1755590" cy="822960"/>
           </a:xfrm>
           <a:prstGeom prst="roundRect">
             <a:avLst>
@@ -5726,8 +5726,8 @@
         </p:nvSpPr>
         <p:spPr>
           <a:xfrm>
-            <a:off x="4546292" y="3675888"/>
-            <a:ext cx="50292" cy="658368"/>
+            <a:off x="4546292" y="3593592"/>
+            <a:ext cx="50292" cy="640080"/>
           </a:xfrm>
           <a:prstGeom prst="rect">
             <a:avLst/>
@@ -5769,8 +5769,8 @@
         </p:nvSpPr>
         <p:spPr>
           <a:xfrm>
-            <a:off x="4692596" y="3694176"/>
-            <a:ext cx="1517846" cy="676656"/>
+            <a:off x="4692596" y="3611880"/>
+            <a:ext cx="1517846" cy="658368"/>
           </a:xfrm>
           <a:prstGeom prst="rect">
             <a:avLst/>
@@ -5778,7 +5778,7 @@
           <a:noFill/>
         </p:spPr>
         <p:txBody>
-          <a:bodyPr wrap="square">
+          <a:bodyPr wrap="square" lIns="0" rIns="0" tIns="0" bIns="0">
             <a:spAutoFit/>
           </a:bodyPr>
           <a:lstStyle/>
@@ -5788,7 +5788,7 @@
                 <a:spcPts val="0"/>
               </a:spcBef>
               <a:spcAft>
-                <a:spcPts val="100"/>
+                <a:spcPts val="200"/>
               </a:spcAft>
             </a:pPr>
             <a:r>
@@ -5807,7 +5807,7 @@
                 <a:spcPts val="0"/>
               </a:spcBef>
               <a:spcAft>
-                <a:spcPts val="100"/>
+                <a:spcPts val="200"/>
               </a:spcAft>
             </a:pPr>
             <a:r>
@@ -5830,8 +5830,8 @@
         </p:nvSpPr>
         <p:spPr>
           <a:xfrm>
-            <a:off x="6411610" y="3584448"/>
-            <a:ext cx="1755590" cy="841248"/>
+            <a:off x="6411610" y="3502152"/>
+            <a:ext cx="1755590" cy="822960"/>
           </a:xfrm>
           <a:prstGeom prst="roundRect">
             <a:avLst>
@@ -5877,8 +5877,8 @@
         </p:nvSpPr>
         <p:spPr>
           <a:xfrm>
-            <a:off x="6411610" y="3675888"/>
-            <a:ext cx="50292" cy="658368"/>
+            <a:off x="6411610" y="3593592"/>
+            <a:ext cx="50292" cy="640080"/>
           </a:xfrm>
           <a:prstGeom prst="rect">
             <a:avLst/>
@@ -5920,8 +5920,8 @@
         </p:nvSpPr>
         <p:spPr>
           <a:xfrm>
-            <a:off x="6557914" y="3694176"/>
-            <a:ext cx="1517846" cy="676656"/>
+            <a:off x="6557914" y="3611880"/>
+            <a:ext cx="1517846" cy="658368"/>
           </a:xfrm>
           <a:prstGeom prst="rect">
             <a:avLst/>
@@ -5929,7 +5929,7 @@
           <a:noFill/>
         </p:spPr>
         <p:txBody>
-          <a:bodyPr wrap="square">
+          <a:bodyPr wrap="square" lIns="0" rIns="0" tIns="0" bIns="0">
             <a:spAutoFit/>
           </a:bodyPr>
           <a:lstStyle/>
@@ -5939,7 +5939,7 @@
                 <a:spcPts val="0"/>
               </a:spcBef>
               <a:spcAft>
-                <a:spcPts val="100"/>
+                <a:spcPts val="200"/>
               </a:spcAft>
             </a:pPr>
             <a:r>
@@ -5958,7 +5958,7 @@
                 <a:spcPts val="0"/>
               </a:spcBef>
               <a:spcAft>
-                <a:spcPts val="100"/>
+                <a:spcPts val="200"/>
               </a:spcAft>
             </a:pPr>
             <a:r>
@@ -5981,8 +5981,8 @@
         </p:nvSpPr>
         <p:spPr>
           <a:xfrm>
-            <a:off x="4546292" y="4571999"/>
-            <a:ext cx="3620909" cy="457200"/>
+            <a:off x="4546292" y="4507992"/>
+            <a:ext cx="3620909" cy="438912"/>
           </a:xfrm>
           <a:prstGeom prst="roundRect">
             <a:avLst>
@@ -6028,8 +6028,8 @@
         </p:nvSpPr>
         <p:spPr>
           <a:xfrm>
-            <a:off x="4619444" y="4663440"/>
-            <a:ext cx="3511181" cy="320040"/>
+            <a:off x="4619444" y="4590287"/>
+            <a:ext cx="3511181" cy="292608"/>
           </a:xfrm>
           <a:prstGeom prst="rect">
             <a:avLst/>
@@ -6037,7 +6037,7 @@
           <a:noFill/>
         </p:spPr>
         <p:txBody>
-          <a:bodyPr wrap="square">
+          <a:bodyPr wrap="square" lIns="0" rIns="0" tIns="0" bIns="0">
             <a:spAutoFit/>
           </a:bodyPr>
           <a:lstStyle/>
@@ -6063,8 +6063,8 @@
         </p:nvSpPr>
         <p:spPr>
           <a:xfrm>
-            <a:off x="4546292" y="5166360"/>
-            <a:ext cx="3620909" cy="594360"/>
+            <a:off x="4546292" y="5056632"/>
+            <a:ext cx="3620909" cy="548640"/>
           </a:xfrm>
           <a:prstGeom prst="rect">
             <a:avLst/>
@@ -6072,7 +6072,7 @@
           <a:noFill/>
         </p:spPr>
         <p:txBody>
-          <a:bodyPr wrap="square">
+          <a:bodyPr wrap="square" lIns="0" rIns="0" tIns="0" bIns="0">
             <a:spAutoFit/>
           </a:bodyPr>
           <a:lstStyle/>
@@ -6099,7 +6099,7 @@
         </p:nvSpPr>
         <p:spPr>
           <a:xfrm>
-            <a:off x="8350081" y="2743200"/>
+            <a:off x="8350081" y="2679191"/>
             <a:ext cx="182880" cy="137160"/>
           </a:xfrm>
           <a:prstGeom prst="rightArrow">
@@ -6142,7 +6142,7 @@
         </p:nvSpPr>
         <p:spPr>
           <a:xfrm>
-            <a:off x="8350081" y="4023360"/>
+            <a:off x="8350081" y="3959352"/>
             <a:ext cx="182880" cy="137160"/>
           </a:xfrm>
           <a:prstGeom prst="rightArrow">
@@ -6185,8 +6185,8 @@
         </p:nvSpPr>
         <p:spPr>
           <a:xfrm>
-            <a:off x="8569537" y="822960"/>
-            <a:ext cx="1434956" cy="5120640"/>
+            <a:off x="8569537" y="804672"/>
+            <a:ext cx="1434956" cy="5074920"/>
           </a:xfrm>
           <a:prstGeom prst="roundRect">
             <a:avLst>
@@ -6232,7 +6232,7 @@
         </p:nvSpPr>
         <p:spPr>
           <a:xfrm>
-            <a:off x="8642689" y="950976"/>
+            <a:off x="8642689" y="914400"/>
             <a:ext cx="237744" cy="237744"/>
           </a:xfrm>
           <a:prstGeom prst="ellipse">
@@ -6275,8 +6275,8 @@
         </p:nvSpPr>
         <p:spPr>
           <a:xfrm>
-            <a:off x="8642689" y="960120"/>
-            <a:ext cx="237744" cy="219456"/>
+            <a:off x="8642689" y="932688"/>
+            <a:ext cx="237744" cy="201168"/>
           </a:xfrm>
           <a:prstGeom prst="rect">
             <a:avLst/>
@@ -6284,7 +6284,7 @@
           <a:noFill/>
         </p:spPr>
         <p:txBody>
-          <a:bodyPr wrap="square">
+          <a:bodyPr wrap="square" lIns="0" rIns="0" tIns="0" bIns="0">
             <a:spAutoFit/>
           </a:bodyPr>
           <a:lstStyle/>
@@ -6310,8 +6310,8 @@
         </p:nvSpPr>
         <p:spPr>
           <a:xfrm>
-            <a:off x="8935297" y="960120"/>
-            <a:ext cx="1014332" cy="219456"/>
+            <a:off x="8935297" y="932688"/>
+            <a:ext cx="1014332" cy="201168"/>
           </a:xfrm>
           <a:prstGeom prst="rect">
             <a:avLst/>
@@ -6319,7 +6319,7 @@
           <a:noFill/>
         </p:spPr>
         <p:txBody>
-          <a:bodyPr wrap="square">
+          <a:bodyPr wrap="square" lIns="0" rIns="0" tIns="0" bIns="0">
             <a:spAutoFit/>
           </a:bodyPr>
           <a:lstStyle/>
@@ -6345,8 +6345,8 @@
         </p:nvSpPr>
         <p:spPr>
           <a:xfrm>
-            <a:off x="8660977" y="1280160"/>
-            <a:ext cx="1270364" cy="457200"/>
+            <a:off x="8660977" y="1243584"/>
+            <a:ext cx="1270364" cy="438912"/>
           </a:xfrm>
           <a:prstGeom prst="rect">
             <a:avLst/>
@@ -6354,7 +6354,7 @@
           <a:noFill/>
         </p:spPr>
         <p:txBody>
-          <a:bodyPr wrap="square">
+          <a:bodyPr wrap="square" lIns="0" rIns="0" tIns="0" bIns="0">
             <a:spAutoFit/>
           </a:bodyPr>
           <a:lstStyle/>
@@ -6381,7 +6381,7 @@
         </p:nvSpPr>
         <p:spPr>
           <a:xfrm>
-            <a:off x="8660977" y="1920240"/>
+            <a:off x="8660977" y="1856232"/>
             <a:ext cx="1252076" cy="914400"/>
           </a:xfrm>
           <a:prstGeom prst="roundRect">
@@ -6428,7 +6428,7 @@
         </p:nvSpPr>
         <p:spPr>
           <a:xfrm>
-            <a:off x="8660977" y="2011680"/>
+            <a:off x="8660977" y="1947672"/>
             <a:ext cx="50292" cy="731520"/>
           </a:xfrm>
           <a:prstGeom prst="rect">
@@ -6471,7 +6471,7 @@
         </p:nvSpPr>
         <p:spPr>
           <a:xfrm>
-            <a:off x="8807281" y="2029968"/>
+            <a:off x="8807281" y="1965960"/>
             <a:ext cx="1014332" cy="749808"/>
           </a:xfrm>
           <a:prstGeom prst="rect">
@@ -6480,7 +6480,7 @@
           <a:noFill/>
         </p:spPr>
         <p:txBody>
-          <a:bodyPr wrap="square">
+          <a:bodyPr wrap="square" lIns="0" rIns="0" tIns="0" bIns="0">
             <a:spAutoFit/>
           </a:bodyPr>
           <a:lstStyle/>
@@ -6490,7 +6490,7 @@
                 <a:spcPts val="0"/>
               </a:spcBef>
               <a:spcAft>
-                <a:spcPts val="100"/>
+                <a:spcPts val="200"/>
               </a:spcAft>
             </a:pPr>
             <a:r>
@@ -6509,7 +6509,7 @@
                 <a:spcPts val="0"/>
               </a:spcBef>
               <a:spcAft>
-                <a:spcPts val="100"/>
+                <a:spcPts val="200"/>
               </a:spcAft>
             </a:pPr>
             <a:r>
@@ -6532,7 +6532,7 @@
         </p:nvSpPr>
         <p:spPr>
           <a:xfrm>
-            <a:off x="8660977" y="2971800"/>
+            <a:off x="8660977" y="2907792"/>
             <a:ext cx="1252076" cy="914400"/>
           </a:xfrm>
           <a:prstGeom prst="roundRect">
@@ -6579,7 +6579,7 @@
         </p:nvSpPr>
         <p:spPr>
           <a:xfrm>
-            <a:off x="8660977" y="3063240"/>
+            <a:off x="8660977" y="2999232"/>
             <a:ext cx="50292" cy="731520"/>
           </a:xfrm>
           <a:prstGeom prst="rect">
@@ -6622,7 +6622,7 @@
         </p:nvSpPr>
         <p:spPr>
           <a:xfrm>
-            <a:off x="8807281" y="3081528"/>
+            <a:off x="8807281" y="3017520"/>
             <a:ext cx="1014332" cy="749808"/>
           </a:xfrm>
           <a:prstGeom prst="rect">
@@ -6631,7 +6631,7 @@
           <a:noFill/>
         </p:spPr>
         <p:txBody>
-          <a:bodyPr wrap="square">
+          <a:bodyPr wrap="square" lIns="0" rIns="0" tIns="0" bIns="0">
             <a:spAutoFit/>
           </a:bodyPr>
           <a:lstStyle/>
@@ -6641,7 +6641,7 @@
                 <a:spcPts val="0"/>
               </a:spcBef>
               <a:spcAft>
-                <a:spcPts val="100"/>
+                <a:spcPts val="200"/>
               </a:spcAft>
             </a:pPr>
             <a:r>
@@ -6660,7 +6660,7 @@
                 <a:spcPts val="0"/>
               </a:spcBef>
               <a:spcAft>
-                <a:spcPts val="100"/>
+                <a:spcPts val="200"/>
               </a:spcAft>
             </a:pPr>
             <a:r>
@@ -6683,7 +6683,7 @@
         </p:nvSpPr>
         <p:spPr>
           <a:xfrm>
-            <a:off x="8660977" y="4023360"/>
+            <a:off x="8660977" y="3959352"/>
             <a:ext cx="1252076" cy="914400"/>
           </a:xfrm>
           <a:prstGeom prst="roundRect">
@@ -6730,7 +6730,7 @@
         </p:nvSpPr>
         <p:spPr>
           <a:xfrm>
-            <a:off x="8660977" y="4114800"/>
+            <a:off x="8660977" y="4050792"/>
             <a:ext cx="50292" cy="731520"/>
           </a:xfrm>
           <a:prstGeom prst="rect">
@@ -6773,7 +6773,7 @@
         </p:nvSpPr>
         <p:spPr>
           <a:xfrm>
-            <a:off x="8807281" y="4133088"/>
+            <a:off x="8807281" y="4069080"/>
             <a:ext cx="1014332" cy="749808"/>
           </a:xfrm>
           <a:prstGeom prst="rect">
@@ -6782,7 +6782,7 @@
           <a:noFill/>
         </p:spPr>
         <p:txBody>
-          <a:bodyPr wrap="square">
+          <a:bodyPr wrap="square" lIns="0" rIns="0" tIns="0" bIns="0">
             <a:spAutoFit/>
           </a:bodyPr>
           <a:lstStyle/>
@@ -6792,7 +6792,7 @@
                 <a:spcPts val="0"/>
               </a:spcBef>
               <a:spcAft>
-                <a:spcPts val="100"/>
+                <a:spcPts val="200"/>
               </a:spcAft>
             </a:pPr>
             <a:r>
@@ -6811,7 +6811,7 @@
                 <a:spcPts val="0"/>
               </a:spcBef>
               <a:spcAft>
-                <a:spcPts val="100"/>
+                <a:spcPts val="200"/>
               </a:spcAft>
             </a:pPr>
             <a:r>
@@ -6834,7 +6834,7 @@
         </p:nvSpPr>
         <p:spPr>
           <a:xfrm>
-            <a:off x="10041069" y="2743200"/>
+            <a:off x="10041069" y="2679191"/>
             <a:ext cx="182880" cy="137160"/>
           </a:xfrm>
           <a:prstGeom prst="rightArrow">
@@ -6877,7 +6877,7 @@
         </p:nvSpPr>
         <p:spPr>
           <a:xfrm>
-            <a:off x="10041069" y="4023360"/>
+            <a:off x="10041069" y="3959352"/>
             <a:ext cx="182880" cy="137160"/>
           </a:xfrm>
           <a:prstGeom prst="rightArrow">
@@ -6920,8 +6920,8 @@
         </p:nvSpPr>
         <p:spPr>
           <a:xfrm>
-            <a:off x="10260525" y="822960"/>
-            <a:ext cx="1565407" cy="5120640"/>
+            <a:off x="10260525" y="804672"/>
+            <a:ext cx="1565407" cy="5074920"/>
           </a:xfrm>
           <a:prstGeom prst="roundRect">
             <a:avLst>
@@ -6967,7 +6967,7 @@
         </p:nvSpPr>
         <p:spPr>
           <a:xfrm>
-            <a:off x="10333677" y="950976"/>
+            <a:off x="10333677" y="914400"/>
             <a:ext cx="237744" cy="237744"/>
           </a:xfrm>
           <a:prstGeom prst="ellipse">
@@ -7010,8 +7010,8 @@
         </p:nvSpPr>
         <p:spPr>
           <a:xfrm>
-            <a:off x="10333677" y="960120"/>
-            <a:ext cx="237744" cy="219456"/>
+            <a:off x="10333677" y="932688"/>
+            <a:ext cx="237744" cy="201168"/>
           </a:xfrm>
           <a:prstGeom prst="rect">
             <a:avLst/>
@@ -7019,7 +7019,7 @@
           <a:noFill/>
         </p:spPr>
         <p:txBody>
-          <a:bodyPr wrap="square">
+          <a:bodyPr wrap="square" lIns="0" rIns="0" tIns="0" bIns="0">
             <a:spAutoFit/>
           </a:bodyPr>
           <a:lstStyle/>
@@ -7045,8 +7045,8 @@
         </p:nvSpPr>
         <p:spPr>
           <a:xfrm>
-            <a:off x="10626285" y="960120"/>
-            <a:ext cx="1144783" cy="219456"/>
+            <a:off x="10626285" y="932688"/>
+            <a:ext cx="1144783" cy="201168"/>
           </a:xfrm>
           <a:prstGeom prst="rect">
             <a:avLst/>
@@ -7054,7 +7054,7 @@
           <a:noFill/>
         </p:spPr>
         <p:txBody>
-          <a:bodyPr wrap="square">
+          <a:bodyPr wrap="square" lIns="0" rIns="0" tIns="0" bIns="0">
             <a:spAutoFit/>
           </a:bodyPr>
           <a:lstStyle/>
@@ -7080,8 +7080,8 @@
         </p:nvSpPr>
         <p:spPr>
           <a:xfrm>
-            <a:off x="10351965" y="1261872"/>
-            <a:ext cx="1400815" cy="502920"/>
+            <a:off x="10351965" y="1225296"/>
+            <a:ext cx="1400815" cy="457200"/>
           </a:xfrm>
           <a:prstGeom prst="rect">
             <a:avLst/>
@@ -7089,7 +7089,7 @@
           <a:noFill/>
         </p:spPr>
         <p:txBody>
-          <a:bodyPr wrap="square">
+          <a:bodyPr wrap="square" lIns="0" rIns="0" tIns="0" bIns="0">
             <a:spAutoFit/>
           </a:bodyPr>
           <a:lstStyle/>
@@ -7116,7 +7116,7 @@
         </p:nvSpPr>
         <p:spPr>
           <a:xfrm>
-            <a:off x="10351965" y="1874520"/>
+            <a:off x="10351965" y="1856232"/>
             <a:ext cx="1382527" cy="777240"/>
           </a:xfrm>
           <a:prstGeom prst="roundRect">
@@ -7163,7 +7163,7 @@
         </p:nvSpPr>
         <p:spPr>
           <a:xfrm>
-            <a:off x="10351965" y="1965960"/>
+            <a:off x="10351965" y="1947672"/>
             <a:ext cx="50292" cy="594360"/>
           </a:xfrm>
           <a:prstGeom prst="rect">
@@ -7206,7 +7206,7 @@
         </p:nvSpPr>
         <p:spPr>
           <a:xfrm>
-            <a:off x="10498269" y="1984248"/>
+            <a:off x="10498269" y="1965960"/>
             <a:ext cx="1144783" cy="612648"/>
           </a:xfrm>
           <a:prstGeom prst="rect">
@@ -7215,7 +7215,7 @@
           <a:noFill/>
         </p:spPr>
         <p:txBody>
-          <a:bodyPr wrap="square">
+          <a:bodyPr wrap="square" lIns="0" rIns="0" tIns="0" bIns="0">
             <a:spAutoFit/>
           </a:bodyPr>
           <a:lstStyle/>
@@ -7225,7 +7225,7 @@
                 <a:spcPts val="0"/>
               </a:spcBef>
               <a:spcAft>
-                <a:spcPts val="100"/>
+                <a:spcPts val="200"/>
               </a:spcAft>
             </a:pPr>
             <a:r>
@@ -7244,7 +7244,7 @@
                 <a:spcPts val="0"/>
               </a:spcBef>
               <a:spcAft>
-                <a:spcPts val="100"/>
+                <a:spcPts val="200"/>
               </a:spcAft>
             </a:pPr>
             <a:r>
@@ -7254,7 +7254,7 @@
                 </a:solidFill>
                 <a:latin typeface="Calibri"/>
               </a:rPr>
-              <a:t>Only 對口</a:t>
+              <a:t>Only interface</a:t>
             </a:r>
           </a:p>
         </p:txBody>
@@ -7267,7 +7267,7 @@
         </p:nvSpPr>
         <p:spPr>
           <a:xfrm>
-            <a:off x="10351965" y="2743200"/>
+            <a:off x="10351965" y="2724912"/>
             <a:ext cx="1382527" cy="777240"/>
           </a:xfrm>
           <a:prstGeom prst="roundRect">
@@ -7314,7 +7314,7 @@
         </p:nvSpPr>
         <p:spPr>
           <a:xfrm>
-            <a:off x="10351965" y="2834640"/>
+            <a:off x="10351965" y="2816352"/>
             <a:ext cx="50292" cy="594360"/>
           </a:xfrm>
           <a:prstGeom prst="rect">
@@ -7357,7 +7357,7 @@
         </p:nvSpPr>
         <p:spPr>
           <a:xfrm>
-            <a:off x="10498269" y="2852928"/>
+            <a:off x="10498269" y="2834640"/>
             <a:ext cx="1144783" cy="612648"/>
           </a:xfrm>
           <a:prstGeom prst="rect">
@@ -7366,7 +7366,7 @@
           <a:noFill/>
         </p:spPr>
         <p:txBody>
-          <a:bodyPr wrap="square">
+          <a:bodyPr wrap="square" lIns="0" rIns="0" tIns="0" bIns="0">
             <a:spAutoFit/>
           </a:bodyPr>
           <a:lstStyle/>
@@ -7376,7 +7376,7 @@
                 <a:spcPts val="0"/>
               </a:spcBef>
               <a:spcAft>
-                <a:spcPts val="100"/>
+                <a:spcPts val="200"/>
               </a:spcAft>
             </a:pPr>
             <a:r>
@@ -7395,7 +7395,7 @@
                 <a:spcPts val="0"/>
               </a:spcBef>
               <a:spcAft>
-                <a:spcPts val="100"/>
+                <a:spcPts val="200"/>
               </a:spcAft>
             </a:pPr>
             <a:r>
@@ -7418,7 +7418,7 @@
         </p:nvSpPr>
         <p:spPr>
           <a:xfrm>
-            <a:off x="10351965" y="3611880"/>
+            <a:off x="10351965" y="3593592"/>
             <a:ext cx="1382527" cy="777240"/>
           </a:xfrm>
           <a:prstGeom prst="roundRect">
@@ -7465,7 +7465,7 @@
         </p:nvSpPr>
         <p:spPr>
           <a:xfrm>
-            <a:off x="10351965" y="3703320"/>
+            <a:off x="10351965" y="3685032"/>
             <a:ext cx="50292" cy="594360"/>
           </a:xfrm>
           <a:prstGeom prst="rect">
@@ -7508,7 +7508,7 @@
         </p:nvSpPr>
         <p:spPr>
           <a:xfrm>
-            <a:off x="10498269" y="3721608"/>
+            <a:off x="10498269" y="3703320"/>
             <a:ext cx="1144783" cy="612648"/>
           </a:xfrm>
           <a:prstGeom prst="rect">
@@ -7517,7 +7517,7 @@
           <a:noFill/>
         </p:spPr>
         <p:txBody>
-          <a:bodyPr wrap="square">
+          <a:bodyPr wrap="square" lIns="0" rIns="0" tIns="0" bIns="0">
             <a:spAutoFit/>
           </a:bodyPr>
           <a:lstStyle/>
@@ -7527,7 +7527,7 @@
                 <a:spcPts val="0"/>
               </a:spcBef>
               <a:spcAft>
-                <a:spcPts val="100"/>
+                <a:spcPts val="200"/>
               </a:spcAft>
             </a:pPr>
             <a:r>
@@ -7546,7 +7546,7 @@
                 <a:spcPts val="0"/>
               </a:spcBef>
               <a:spcAft>
-                <a:spcPts val="100"/>
+                <a:spcPts val="200"/>
               </a:spcAft>
             </a:pPr>
             <a:r>
@@ -7569,7 +7569,7 @@
         </p:nvSpPr>
         <p:spPr>
           <a:xfrm>
-            <a:off x="10351965" y="4480559"/>
+            <a:off x="10351965" y="4462271"/>
             <a:ext cx="1382527" cy="777240"/>
           </a:xfrm>
           <a:prstGeom prst="roundRect">
@@ -7616,7 +7616,7 @@
         </p:nvSpPr>
         <p:spPr>
           <a:xfrm>
-            <a:off x="10351965" y="4571999"/>
+            <a:off x="10351965" y="4553711"/>
             <a:ext cx="50292" cy="594360"/>
           </a:xfrm>
           <a:prstGeom prst="rect">
@@ -7659,7 +7659,7 @@
         </p:nvSpPr>
         <p:spPr>
           <a:xfrm>
-            <a:off x="10498269" y="4590287"/>
+            <a:off x="10498269" y="4571999"/>
             <a:ext cx="1144783" cy="612648"/>
           </a:xfrm>
           <a:prstGeom prst="rect">
@@ -7668,7 +7668,7 @@
           <a:noFill/>
         </p:spPr>
         <p:txBody>
-          <a:bodyPr wrap="square">
+          <a:bodyPr wrap="square" lIns="0" rIns="0" tIns="0" bIns="0">
             <a:spAutoFit/>
           </a:bodyPr>
           <a:lstStyle/>
@@ -7678,7 +7678,7 @@
                 <a:spcPts val="0"/>
               </a:spcBef>
               <a:spcAft>
-                <a:spcPts val="100"/>
+                <a:spcPts val="200"/>
               </a:spcAft>
             </a:pPr>
             <a:r>
@@ -7697,7 +7697,7 @@
                 <a:spcPts val="0"/>
               </a:spcBef>
               <a:spcAft>
-                <a:spcPts val="100"/>
+                <a:spcPts val="200"/>
               </a:spcAft>
             </a:pPr>
             <a:r>
@@ -7720,7 +7720,7 @@
         </p:nvSpPr>
         <p:spPr>
           <a:xfrm>
-            <a:off x="365760" y="6126480"/>
+            <a:off x="365760" y="6080760"/>
             <a:ext cx="11460175" cy="502920"/>
           </a:xfrm>
           <a:prstGeom prst="roundRect">
@@ -7767,7 +7767,7 @@
         </p:nvSpPr>
         <p:spPr>
           <a:xfrm>
-            <a:off x="502920" y="6291072"/>
+            <a:off x="502920" y="6236208"/>
             <a:ext cx="128016" cy="128016"/>
           </a:xfrm>
           <a:prstGeom prst="ellipse">
@@ -7810,7 +7810,7 @@
         </p:nvSpPr>
         <p:spPr>
           <a:xfrm>
-            <a:off x="740664" y="6291072"/>
+            <a:off x="740664" y="6236208"/>
             <a:ext cx="128016" cy="128016"/>
           </a:xfrm>
           <a:prstGeom prst="ellipse">
@@ -7853,7 +7853,7 @@
         </p:nvSpPr>
         <p:spPr>
           <a:xfrm>
-            <a:off x="978408" y="6291072"/>
+            <a:off x="978408" y="6236208"/>
             <a:ext cx="128016" cy="128016"/>
           </a:xfrm>
           <a:prstGeom prst="ellipse">
@@ -7896,7 +7896,7 @@
         </p:nvSpPr>
         <p:spPr>
           <a:xfrm>
-            <a:off x="1216152" y="6291072"/>
+            <a:off x="1216152" y="6236208"/>
             <a:ext cx="128016" cy="128016"/>
           </a:xfrm>
           <a:prstGeom prst="ellipse">
@@ -7939,7 +7939,7 @@
         </p:nvSpPr>
         <p:spPr>
           <a:xfrm>
-            <a:off x="1453896" y="6291072"/>
+            <a:off x="1453896" y="6236208"/>
             <a:ext cx="128016" cy="128016"/>
           </a:xfrm>
           <a:prstGeom prst="ellipse">
@@ -7982,8 +7982,8 @@
         </p:nvSpPr>
         <p:spPr>
           <a:xfrm>
-            <a:off x="1783080" y="6236208"/>
-            <a:ext cx="8229600" cy="320040"/>
+            <a:off x="1783080" y="6199632"/>
+            <a:ext cx="8229600" cy="292608"/>
           </a:xfrm>
           <a:prstGeom prst="rect">
             <a:avLst/>
@@ -7991,7 +7991,7 @@
           <a:noFill/>
         </p:spPr>
         <p:txBody>
-          <a:bodyPr wrap="square">
+          <a:bodyPr wrap="square" lIns="0" rIns="0" tIns="0" bIns="0">
             <a:spAutoFit/>
           </a:bodyPr>
           <a:lstStyle/>
@@ -8004,7 +8004,7 @@
                 </a:solidFill>
                 <a:latin typeface="Calibri"/>
               </a:rPr>
-              <a:t>LedgeRX = product hub     ·     one Landing 對口 layer on UAF side     ·     then UAF systems fan-out</a:t>
+              <a:t>LedgeRX = product hub     ·     one Landing interface on UAF side     ·     then UAF systems fan-out</a:t>
             </a:r>
           </a:p>
         </p:txBody>
@@ -8017,8 +8017,8 @@
         </p:nvSpPr>
         <p:spPr>
           <a:xfrm>
-            <a:off x="10332720" y="6236208"/>
-            <a:ext cx="1371600" cy="320040"/>
+            <a:off x="10332720" y="6199632"/>
+            <a:ext cx="1371600" cy="292608"/>
           </a:xfrm>
           <a:prstGeom prst="rect">
             <a:avLst/>
@@ -8026,7 +8026,7 @@
           <a:noFill/>
         </p:spPr>
         <p:txBody>
-          <a:bodyPr wrap="square">
+          <a:bodyPr wrap="square" lIns="0" rIns="0" tIns="0" bIns="0">
             <a:spAutoFit/>
           </a:bodyPr>
           <a:lstStyle/>
@@ -8156,8 +8156,8 @@
         </p:nvSpPr>
         <p:spPr>
           <a:xfrm>
-            <a:off x="365760" y="109728"/>
-            <a:ext cx="9601200" cy="292608"/>
+            <a:off x="365760" y="128016"/>
+            <a:ext cx="9326880" cy="292608"/>
           </a:xfrm>
           <a:prstGeom prst="rect">
             <a:avLst/>
@@ -8165,7 +8165,7 @@
           <a:noFill/>
         </p:spPr>
         <p:txBody>
-          <a:bodyPr wrap="square">
+          <a:bodyPr wrap="square" lIns="0" rIns="0" tIns="0" bIns="0">
             <a:spAutoFit/>
           </a:bodyPr>
           <a:lstStyle/>
@@ -8178,7 +8178,7 @@
                 </a:solidFill>
                 <a:latin typeface="Calibri"/>
               </a:rPr>
-              <a:t>Landing  ·  One unified 對口 to LedgeRX</a:t>
+              <a:t>Landing  ·  One unified interface to LedgeRX</a:t>
             </a:r>
           </a:p>
         </p:txBody>
@@ -8191,8 +8191,8 @@
         </p:nvSpPr>
         <p:spPr>
           <a:xfrm>
-            <a:off x="365760" y="384048"/>
-            <a:ext cx="9601200" cy="237744"/>
+            <a:off x="365760" y="420624"/>
+            <a:ext cx="9326880" cy="237744"/>
           </a:xfrm>
           <a:prstGeom prst="rect">
             <a:avLst/>
@@ -8200,7 +8200,7 @@
           <a:noFill/>
         </p:spPr>
         <p:txBody>
-          <a:bodyPr wrap="square">
+          <a:bodyPr wrap="square" lIns="0" rIns="0" tIns="0" bIns="0">
             <a:spAutoFit/>
           </a:bodyPr>
           <a:lstStyle/>
@@ -8213,7 +8213,7 @@
                 </a:solidFill>
                 <a:latin typeface="Calibri"/>
               </a:rPr>
-              <a:t>LedgeRX talks to a single UAF layer only  ·  that layer applies UAF business logic  ·  then fans out internally</a:t>
+              <a:t>LedgeRX talks to a single UAF layer only  ·  that layer applies UAF logic  ·  then fans out internally</a:t>
             </a:r>
           </a:p>
         </p:txBody>
@@ -8226,8 +8226,8 @@
         </p:nvSpPr>
         <p:spPr>
           <a:xfrm>
-            <a:off x="10241280" y="128016"/>
-            <a:ext cx="1554480" cy="347472"/>
+            <a:off x="10241280" y="146304"/>
+            <a:ext cx="1554480" cy="329184"/>
           </a:xfrm>
           <a:prstGeom prst="roundRect">
             <a:avLst>
@@ -8282,7 +8282,7 @@
           <a:noFill/>
         </p:spPr>
         <p:txBody>
-          <a:bodyPr wrap="square">
+          <a:bodyPr wrap="square" lIns="0" rIns="0" tIns="0" bIns="0">
             <a:spAutoFit/>
           </a:bodyPr>
           <a:lstStyle/>
@@ -8308,8 +8308,8 @@
         </p:nvSpPr>
         <p:spPr>
           <a:xfrm>
-            <a:off x="365760" y="731520"/>
-            <a:ext cx="11457432" cy="1051560"/>
+            <a:off x="365760" y="777240"/>
+            <a:ext cx="11457432" cy="960120"/>
           </a:xfrm>
           <a:prstGeom prst="roundRect">
             <a:avLst>
@@ -8319,7 +8319,7 @@
           <a:solidFill>
             <a:srgbClr val="0A282A"/>
           </a:solidFill>
-          <a:ln w="28575">
+          <a:ln w="25400">
             <a:solidFill>
               <a:srgbClr val="2DD4BF"/>
             </a:solidFill>
@@ -8355,8 +8355,8 @@
         </p:nvSpPr>
         <p:spPr>
           <a:xfrm>
-            <a:off x="502920" y="841248"/>
-            <a:ext cx="1965960" cy="320040"/>
+            <a:off x="502920" y="905256"/>
+            <a:ext cx="1828800" cy="292608"/>
           </a:xfrm>
           <a:prstGeom prst="roundRect">
             <a:avLst>
@@ -8400,8 +8400,8 @@
         </p:nvSpPr>
         <p:spPr>
           <a:xfrm>
-            <a:off x="502920" y="877824"/>
-            <a:ext cx="1965960" cy="256032"/>
+            <a:off x="502920" y="923544"/>
+            <a:ext cx="1828800" cy="256032"/>
           </a:xfrm>
           <a:prstGeom prst="rect">
             <a:avLst/>
@@ -8409,7 +8409,7 @@
           <a:noFill/>
         </p:spPr>
         <p:txBody>
-          <a:bodyPr wrap="square">
+          <a:bodyPr wrap="square" lIns="0" rIns="0" tIns="0" bIns="0">
             <a:spAutoFit/>
           </a:bodyPr>
           <a:lstStyle/>
@@ -8435,8 +8435,8 @@
         </p:nvSpPr>
         <p:spPr>
           <a:xfrm>
-            <a:off x="2651760" y="822960"/>
-            <a:ext cx="8686800" cy="274320"/>
+            <a:off x="2514600" y="886968"/>
+            <a:ext cx="8961120" cy="274320"/>
           </a:xfrm>
           <a:prstGeom prst="rect">
             <a:avLst/>
@@ -8444,14 +8444,14 @@
           <a:noFill/>
         </p:spPr>
         <p:txBody>
-          <a:bodyPr wrap="square">
+          <a:bodyPr wrap="square" lIns="0" rIns="0" tIns="0" bIns="0">
             <a:spAutoFit/>
           </a:bodyPr>
           <a:lstStyle/>
           <a:p>
             <a:pPr algn="l"/>
             <a:r>
-              <a:rPr sz="1700" b="1">
+              <a:rPr sz="1600" b="1">
                 <a:solidFill>
                   <a:srgbClr val="2DD4BF"/>
                 </a:solidFill>
@@ -8470,8 +8470,8 @@
         </p:nvSpPr>
         <p:spPr>
           <a:xfrm>
-            <a:off x="2651760" y="1143000"/>
-            <a:ext cx="8686800" cy="411480"/>
+            <a:off x="2514600" y="1216152"/>
+            <a:ext cx="8961120" cy="365760"/>
           </a:xfrm>
           <a:prstGeom prst="rect">
             <a:avLst/>
@@ -8479,7 +8479,7 @@
           <a:noFill/>
         </p:spPr>
         <p:txBody>
-          <a:bodyPr wrap="square">
+          <a:bodyPr wrap="square" lIns="0" rIns="0" tIns="0" bIns="0">
             <a:spAutoFit/>
           </a:bodyPr>
           <a:lstStyle/>
@@ -8492,7 +8492,7 @@
                 </a:solidFill>
                 <a:latin typeface="Calibri"/>
               </a:rPr>
-              <a:t>Emits only:   balance.updated   ·   reward redemption request   ·   other ledger outcomes   ·   (Kafka / webhook)</a:t>
+              <a:t>Emits only:  balance.updated  ·  reward redemption request  ·  other ledger outcomes   (Kafka / webhook)</a:t>
             </a:r>
           </a:p>
         </p:txBody>
@@ -8505,8 +8505,8 @@
         </p:nvSpPr>
         <p:spPr>
           <a:xfrm>
-            <a:off x="5943600" y="1874519"/>
-            <a:ext cx="201168" cy="237744"/>
+            <a:off x="5943600" y="1828800"/>
+            <a:ext cx="182880" cy="201168"/>
           </a:xfrm>
           <a:prstGeom prst="downArrow">
             <a:avLst/>
@@ -8548,8 +8548,8 @@
         </p:nvSpPr>
         <p:spPr>
           <a:xfrm>
-            <a:off x="5029200" y="1901952"/>
-            <a:ext cx="914400" cy="228600"/>
+            <a:off x="6263640" y="1828800"/>
+            <a:ext cx="2011680" cy="219456"/>
           </a:xfrm>
           <a:prstGeom prst="rect">
             <a:avLst/>
@@ -8557,42 +8557,7 @@
           <a:noFill/>
         </p:spPr>
         <p:txBody>
-          <a:bodyPr wrap="square">
-            <a:spAutoFit/>
-          </a:bodyPr>
-          <a:lstStyle/>
-          <a:p>
-            <a:pPr algn="l"/>
-            <a:r>
-              <a:rPr sz="800" b="0">
-                <a:solidFill>
-                  <a:srgbClr val="64748B"/>
-                </a:solidFill>
-                <a:latin typeface="Calibri"/>
-              </a:rPr>
-              <a:t/>
-            </a:r>
-          </a:p>
-        </p:txBody>
-      </p:sp>
-      <p:sp>
-        <p:nvSpPr>
-          <p:cNvPr id="15" name="TextBox 14"/>
-          <p:cNvSpPr txBox="1"/>
-          <p:nvPr/>
-        </p:nvSpPr>
-        <p:spPr>
-          <a:xfrm>
-            <a:off x="6263640" y="1920240"/>
-            <a:ext cx="2286000" cy="228600"/>
-          </a:xfrm>
-          <a:prstGeom prst="rect">
-            <a:avLst/>
-          </a:prstGeom>
-          <a:noFill/>
-        </p:spPr>
-        <p:txBody>
-          <a:bodyPr wrap="square">
+          <a:bodyPr wrap="square" lIns="0" rIns="0" tIns="0" bIns="0">
             <a:spAutoFit/>
           </a:bodyPr>
           <a:lstStyle/>
@@ -8612,14 +8577,14 @@
       </p:sp>
       <p:sp>
         <p:nvSpPr>
-          <p:cNvPr id="16" name="Rounded Rectangle 15"/>
+          <p:cNvPr id="15" name="Rounded Rectangle 14"/>
           <p:cNvSpPr/>
           <p:nvPr/>
         </p:nvSpPr>
         <p:spPr>
           <a:xfrm>
-            <a:off x="365760" y="2194560"/>
-            <a:ext cx="11457432" cy="1417320"/>
+            <a:off x="365760" y="2103120"/>
+            <a:ext cx="11457432" cy="1325880"/>
           </a:xfrm>
           <a:prstGeom prst="roundRect">
             <a:avLst>
@@ -8629,7 +8594,7 @@
           <a:solidFill>
             <a:srgbClr val="121A3A"/>
           </a:solidFill>
-          <a:ln w="31750">
+          <a:ln w="28575">
             <a:solidFill>
               <a:srgbClr val="818CF8"/>
             </a:solidFill>
@@ -8659,14 +8624,14 @@
       </p:sp>
       <p:sp>
         <p:nvSpPr>
-          <p:cNvPr id="17" name="Rounded Rectangle 16"/>
+          <p:cNvPr id="16" name="Rounded Rectangle 15"/>
           <p:cNvSpPr/>
           <p:nvPr/>
         </p:nvSpPr>
         <p:spPr>
           <a:xfrm>
-            <a:off x="502920" y="2304288"/>
-            <a:ext cx="3017520" cy="292608"/>
+            <a:off x="502920" y="2212848"/>
+            <a:ext cx="2606040" cy="274320"/>
           </a:xfrm>
           <a:prstGeom prst="roundRect">
             <a:avLst>
@@ -8704,14 +8669,49 @@
       </p:sp>
       <p:sp>
         <p:nvSpPr>
+          <p:cNvPr id="17" name="TextBox 16"/>
+          <p:cNvSpPr txBox="1"/>
+          <p:nvPr/>
+        </p:nvSpPr>
+        <p:spPr>
+          <a:xfrm>
+            <a:off x="502920" y="2231136"/>
+            <a:ext cx="2606040" cy="237744"/>
+          </a:xfrm>
+          <a:prstGeom prst="rect">
+            <a:avLst/>
+          </a:prstGeom>
+          <a:noFill/>
+        </p:spPr>
+        <p:txBody>
+          <a:bodyPr wrap="square" lIns="0" rIns="0" tIns="0" bIns="0">
+            <a:spAutoFit/>
+          </a:bodyPr>
+          <a:lstStyle/>
+          <a:p>
+            <a:pPr algn="ctr"/>
+            <a:r>
+              <a:rPr sz="1000" b="1">
+                <a:solidFill>
+                  <a:srgbClr val="0B1220"/>
+                </a:solidFill>
+                <a:latin typeface="Calibri"/>
+              </a:rPr>
+              <a:t>ONLY INTERFACE  ·  UAF-owned</a:t>
+            </a:r>
+          </a:p>
+        </p:txBody>
+      </p:sp>
+      <p:sp>
+        <p:nvSpPr>
           <p:cNvPr id="18" name="TextBox 17"/>
           <p:cNvSpPr txBox="1"/>
           <p:nvPr/>
         </p:nvSpPr>
         <p:spPr>
           <a:xfrm>
-            <a:off x="502920" y="2331720"/>
-            <a:ext cx="3017520" cy="256032"/>
+            <a:off x="3246120" y="2212848"/>
+            <a:ext cx="8229600" cy="274320"/>
           </a:xfrm>
           <a:prstGeom prst="rect">
             <a:avLst/>
@@ -8719,69 +8719,34 @@
           <a:noFill/>
         </p:spPr>
         <p:txBody>
-          <a:bodyPr wrap="square">
+          <a:bodyPr wrap="square" lIns="0" rIns="0" tIns="0" bIns="0">
             <a:spAutoFit/>
           </a:bodyPr>
           <a:lstStyle/>
           <a:p>
-            <a:pPr algn="ctr"/>
-            <a:r>
-              <a:rPr sz="1100" b="1">
-                <a:solidFill>
-                  <a:srgbClr val="0B1220"/>
+            <a:pPr algn="l"/>
+            <a:r>
+              <a:rPr sz="1400" b="1">
+                <a:solidFill>
+                  <a:srgbClr val="F8FAFC"/>
                 </a:solidFill>
                 <a:latin typeface="Calibri"/>
               </a:rPr>
-              <a:t>ONLY 對口  ·  UAF-owned</a:t>
-            </a:r>
-          </a:p>
-        </p:txBody>
-      </p:sp>
-      <p:sp>
-        <p:nvSpPr>
-          <p:cNvPr id="19" name="TextBox 18"/>
-          <p:cNvSpPr txBox="1"/>
-          <p:nvPr/>
-        </p:nvSpPr>
-        <p:spPr>
-          <a:xfrm>
-            <a:off x="3657600" y="2304288"/>
-            <a:ext cx="7772400" cy="274320"/>
-          </a:xfrm>
-          <a:prstGeom prst="rect">
-            <a:avLst/>
-          </a:prstGeom>
-          <a:noFill/>
-        </p:spPr>
-        <p:txBody>
-          <a:bodyPr wrap="square">
-            <a:spAutoFit/>
-          </a:bodyPr>
-          <a:lstStyle/>
-          <a:p>
-            <a:pPr algn="l"/>
-            <a:r>
-              <a:rPr sz="1500" b="1">
-                <a:solidFill>
-                  <a:srgbClr val="F8FAFC"/>
-                </a:solidFill>
-                <a:latin typeface="Calibri"/>
-              </a:rPr>
-              <a:t>Unified Landing Layer  (collect results + UAF business logic)</a:t>
-            </a:r>
-          </a:p>
-        </p:txBody>
-      </p:sp>
-      <p:sp>
-        <p:nvSpPr>
-          <p:cNvPr id="20" name="Rounded Rectangle 19"/>
+              <a:t>Unified Landing Layer  ·  collect results + UAF business logic</a:t>
+            </a:r>
+          </a:p>
+        </p:txBody>
+      </p:sp>
+      <p:sp>
+        <p:nvSpPr>
+          <p:cNvPr id="19" name="Rounded Rectangle 18"/>
           <p:cNvSpPr/>
           <p:nvPr/>
         </p:nvSpPr>
         <p:spPr>
           <a:xfrm>
-            <a:off x="502920" y="2697480"/>
-            <a:ext cx="3566160" cy="685800"/>
+            <a:off x="502920" y="2606040"/>
+            <a:ext cx="3611880" cy="658368"/>
           </a:xfrm>
           <a:prstGeom prst="roundRect">
             <a:avLst>
@@ -8821,14 +8786,49 @@
       </p:sp>
       <p:sp>
         <p:nvSpPr>
+          <p:cNvPr id="20" name="TextBox 19"/>
+          <p:cNvSpPr txBox="1"/>
+          <p:nvPr/>
+        </p:nvSpPr>
+        <p:spPr>
+          <a:xfrm>
+            <a:off x="640080" y="2670048"/>
+            <a:ext cx="3337560" cy="256032"/>
+          </a:xfrm>
+          <a:prstGeom prst="rect">
+            <a:avLst/>
+          </a:prstGeom>
+          <a:noFill/>
+        </p:spPr>
+        <p:txBody>
+          <a:bodyPr wrap="square" lIns="0" rIns="0" tIns="0" bIns="0">
+            <a:spAutoFit/>
+          </a:bodyPr>
+          <a:lstStyle/>
+          <a:p>
+            <a:pPr algn="l"/>
+            <a:r>
+              <a:rPr sz="1300" b="1">
+                <a:solidFill>
+                  <a:srgbClr val="818CF8"/>
+                </a:solidFill>
+                <a:latin typeface="Calibri"/>
+              </a:rPr>
+              <a:t>1  ·  Collect</a:t>
+            </a:r>
+          </a:p>
+        </p:txBody>
+      </p:sp>
+      <p:sp>
+        <p:nvSpPr>
           <p:cNvPr id="21" name="TextBox 20"/>
           <p:cNvSpPr txBox="1"/>
           <p:nvPr/>
         </p:nvSpPr>
         <p:spPr>
           <a:xfrm>
-            <a:off x="640080" y="2761488"/>
-            <a:ext cx="3291840" cy="256032"/>
+            <a:off x="640080" y="2944368"/>
+            <a:ext cx="3337560" cy="256032"/>
           </a:xfrm>
           <a:prstGeom prst="rect">
             <a:avLst/>
@@ -8836,42 +8836,7 @@
           <a:noFill/>
         </p:spPr>
         <p:txBody>
-          <a:bodyPr wrap="square">
-            <a:spAutoFit/>
-          </a:bodyPr>
-          <a:lstStyle/>
-          <a:p>
-            <a:pPr algn="l"/>
-            <a:r>
-              <a:rPr sz="1300" b="1">
-                <a:solidFill>
-                  <a:srgbClr val="818CF8"/>
-                </a:solidFill>
-                <a:latin typeface="Calibri"/>
-              </a:rPr>
-              <a:t>1 · Collect</a:t>
-            </a:r>
-          </a:p>
-        </p:txBody>
-      </p:sp>
-      <p:sp>
-        <p:nvSpPr>
-          <p:cNvPr id="22" name="TextBox 21"/>
-          <p:cNvSpPr txBox="1"/>
-          <p:nvPr/>
-        </p:nvSpPr>
-        <p:spPr>
-          <a:xfrm>
-            <a:off x="640080" y="3035808"/>
-            <a:ext cx="3291840" cy="256032"/>
-          </a:xfrm>
-          <a:prstGeom prst="rect">
-            <a:avLst/>
-          </a:prstGeom>
-          <a:noFill/>
-        </p:spPr>
-        <p:txBody>
-          <a:bodyPr wrap="square">
+          <a:bodyPr wrap="square" lIns="0" rIns="0" tIns="0" bIns="0">
             <a:spAutoFit/>
           </a:bodyPr>
           <a:lstStyle/>
@@ -8891,14 +8856,14 @@
       </p:sp>
       <p:sp>
         <p:nvSpPr>
-          <p:cNvPr id="23" name="Rounded Rectangle 22"/>
+          <p:cNvPr id="22" name="Rounded Rectangle 21"/>
           <p:cNvSpPr/>
           <p:nvPr/>
         </p:nvSpPr>
         <p:spPr>
           <a:xfrm>
-            <a:off x="4251959" y="2697480"/>
-            <a:ext cx="3566160" cy="685800"/>
+            <a:off x="4279392" y="2606040"/>
+            <a:ext cx="3611880" cy="658368"/>
           </a:xfrm>
           <a:prstGeom prst="roundRect">
             <a:avLst>
@@ -8938,14 +8903,49 @@
       </p:sp>
       <p:sp>
         <p:nvSpPr>
+          <p:cNvPr id="23" name="TextBox 22"/>
+          <p:cNvSpPr txBox="1"/>
+          <p:nvPr/>
+        </p:nvSpPr>
+        <p:spPr>
+          <a:xfrm>
+            <a:off x="4416552" y="2670048"/>
+            <a:ext cx="3337560" cy="256032"/>
+          </a:xfrm>
+          <a:prstGeom prst="rect">
+            <a:avLst/>
+          </a:prstGeom>
+          <a:noFill/>
+        </p:spPr>
+        <p:txBody>
+          <a:bodyPr wrap="square" lIns="0" rIns="0" tIns="0" bIns="0">
+            <a:spAutoFit/>
+          </a:bodyPr>
+          <a:lstStyle/>
+          <a:p>
+            <a:pPr algn="l"/>
+            <a:r>
+              <a:rPr sz="1300" b="1">
+                <a:solidFill>
+                  <a:srgbClr val="818CF8"/>
+                </a:solidFill>
+                <a:latin typeface="Calibri"/>
+              </a:rPr>
+              <a:t>2  ·  Decide</a:t>
+            </a:r>
+          </a:p>
+        </p:txBody>
+      </p:sp>
+      <p:sp>
+        <p:nvSpPr>
           <p:cNvPr id="24" name="TextBox 23"/>
           <p:cNvSpPr txBox="1"/>
           <p:nvPr/>
         </p:nvSpPr>
         <p:spPr>
           <a:xfrm>
-            <a:off x="4389119" y="2761488"/>
-            <a:ext cx="3291840" cy="256032"/>
+            <a:off x="4416552" y="2944368"/>
+            <a:ext cx="3337560" cy="256032"/>
           </a:xfrm>
           <a:prstGeom prst="rect">
             <a:avLst/>
@@ -8953,42 +8953,7 @@
           <a:noFill/>
         </p:spPr>
         <p:txBody>
-          <a:bodyPr wrap="square">
-            <a:spAutoFit/>
-          </a:bodyPr>
-          <a:lstStyle/>
-          <a:p>
-            <a:pPr algn="l"/>
-            <a:r>
-              <a:rPr sz="1300" b="1">
-                <a:solidFill>
-                  <a:srgbClr val="818CF8"/>
-                </a:solidFill>
-                <a:latin typeface="Calibri"/>
-              </a:rPr>
-              <a:t>2 · Decide</a:t>
-            </a:r>
-          </a:p>
-        </p:txBody>
-      </p:sp>
-      <p:sp>
-        <p:nvSpPr>
-          <p:cNvPr id="25" name="TextBox 24"/>
-          <p:cNvSpPr txBox="1"/>
-          <p:nvPr/>
-        </p:nvSpPr>
-        <p:spPr>
-          <a:xfrm>
-            <a:off x="4389119" y="3035808"/>
-            <a:ext cx="3291840" cy="256032"/>
-          </a:xfrm>
-          <a:prstGeom prst="rect">
-            <a:avLst/>
-          </a:prstGeom>
-          <a:noFill/>
-        </p:spPr>
-        <p:txBody>
-          <a:bodyPr wrap="square">
+          <a:bodyPr wrap="square" lIns="0" rIns="0" tIns="0" bIns="0">
             <a:spAutoFit/>
           </a:bodyPr>
           <a:lstStyle/>
@@ -9008,14 +8973,14 @@
       </p:sp>
       <p:sp>
         <p:nvSpPr>
-          <p:cNvPr id="26" name="Rounded Rectangle 25"/>
+          <p:cNvPr id="25" name="Rounded Rectangle 24"/>
           <p:cNvSpPr/>
           <p:nvPr/>
         </p:nvSpPr>
         <p:spPr>
           <a:xfrm>
-            <a:off x="8000999" y="2697480"/>
-            <a:ext cx="3566160" cy="685800"/>
+            <a:off x="8055864" y="2606040"/>
+            <a:ext cx="3611880" cy="658368"/>
           </a:xfrm>
           <a:prstGeom prst="roundRect">
             <a:avLst>
@@ -9055,14 +9020,49 @@
       </p:sp>
       <p:sp>
         <p:nvSpPr>
+          <p:cNvPr id="26" name="TextBox 25"/>
+          <p:cNvSpPr txBox="1"/>
+          <p:nvPr/>
+        </p:nvSpPr>
+        <p:spPr>
+          <a:xfrm>
+            <a:off x="8193024" y="2670048"/>
+            <a:ext cx="3337560" cy="256032"/>
+          </a:xfrm>
+          <a:prstGeom prst="rect">
+            <a:avLst/>
+          </a:prstGeom>
+          <a:noFill/>
+        </p:spPr>
+        <p:txBody>
+          <a:bodyPr wrap="square" lIns="0" rIns="0" tIns="0" bIns="0">
+            <a:spAutoFit/>
+          </a:bodyPr>
+          <a:lstStyle/>
+          <a:p>
+            <a:pPr algn="l"/>
+            <a:r>
+              <a:rPr sz="1300" b="1">
+                <a:solidFill>
+                  <a:srgbClr val="818CF8"/>
+                </a:solidFill>
+                <a:latin typeface="Calibri"/>
+              </a:rPr>
+              <a:t>3  ·  Dispatch</a:t>
+            </a:r>
+          </a:p>
+        </p:txBody>
+      </p:sp>
+      <p:sp>
+        <p:nvSpPr>
           <p:cNvPr id="27" name="TextBox 26"/>
           <p:cNvSpPr txBox="1"/>
           <p:nvPr/>
         </p:nvSpPr>
         <p:spPr>
           <a:xfrm>
-            <a:off x="8138159" y="2761488"/>
-            <a:ext cx="3291840" cy="256032"/>
+            <a:off x="8193024" y="2944368"/>
+            <a:ext cx="3337560" cy="256032"/>
           </a:xfrm>
           <a:prstGeom prst="rect">
             <a:avLst/>
@@ -9070,42 +9070,7 @@
           <a:noFill/>
         </p:spPr>
         <p:txBody>
-          <a:bodyPr wrap="square">
-            <a:spAutoFit/>
-          </a:bodyPr>
-          <a:lstStyle/>
-          <a:p>
-            <a:pPr algn="l"/>
-            <a:r>
-              <a:rPr sz="1300" b="1">
-                <a:solidFill>
-                  <a:srgbClr val="818CF8"/>
-                </a:solidFill>
-                <a:latin typeface="Calibri"/>
-              </a:rPr>
-              <a:t>3 · Dispatch</a:t>
-            </a:r>
-          </a:p>
-        </p:txBody>
-      </p:sp>
-      <p:sp>
-        <p:nvSpPr>
-          <p:cNvPr id="28" name="TextBox 27"/>
-          <p:cNvSpPr txBox="1"/>
-          <p:nvPr/>
-        </p:nvSpPr>
-        <p:spPr>
-          <a:xfrm>
-            <a:off x="8138159" y="3035808"/>
-            <a:ext cx="3291840" cy="256032"/>
-          </a:xfrm>
-          <a:prstGeom prst="rect">
-            <a:avLst/>
-          </a:prstGeom>
-          <a:noFill/>
-        </p:spPr>
-        <p:txBody>
-          <a:bodyPr wrap="square">
+          <a:bodyPr wrap="square" lIns="0" rIns="0" tIns="0" bIns="0">
             <a:spAutoFit/>
           </a:bodyPr>
           <a:lstStyle/>
@@ -9125,14 +9090,14 @@
       </p:sp>
       <p:sp>
         <p:nvSpPr>
-          <p:cNvPr id="29" name="Down Arrow 28"/>
+          <p:cNvPr id="28" name="Down Arrow 27"/>
           <p:cNvSpPr/>
           <p:nvPr/>
         </p:nvSpPr>
         <p:spPr>
           <a:xfrm>
-            <a:off x="1554480" y="3703320"/>
-            <a:ext cx="146304" cy="182880"/>
+            <a:off x="1600200" y="3547872"/>
+            <a:ext cx="146304" cy="164592"/>
           </a:xfrm>
           <a:prstGeom prst="downArrow">
             <a:avLst/>
@@ -9168,14 +9133,14 @@
       </p:sp>
       <p:sp>
         <p:nvSpPr>
-          <p:cNvPr id="30" name="Down Arrow 29"/>
+          <p:cNvPr id="29" name="Down Arrow 28"/>
           <p:cNvSpPr/>
           <p:nvPr/>
         </p:nvSpPr>
         <p:spPr>
           <a:xfrm>
-            <a:off x="4206240" y="3703320"/>
-            <a:ext cx="146304" cy="182880"/>
+            <a:off x="4251960" y="3547872"/>
+            <a:ext cx="146304" cy="164592"/>
           </a:xfrm>
           <a:prstGeom prst="downArrow">
             <a:avLst/>
@@ -9211,14 +9176,14 @@
       </p:sp>
       <p:sp>
         <p:nvSpPr>
-          <p:cNvPr id="31" name="Down Arrow 30"/>
+          <p:cNvPr id="30" name="Down Arrow 29"/>
           <p:cNvSpPr/>
           <p:nvPr/>
         </p:nvSpPr>
         <p:spPr>
           <a:xfrm>
-            <a:off x="6858000" y="3703320"/>
-            <a:ext cx="146304" cy="182880"/>
+            <a:off x="6903720" y="3547872"/>
+            <a:ext cx="146304" cy="164592"/>
           </a:xfrm>
           <a:prstGeom prst="downArrow">
             <a:avLst/>
@@ -9254,14 +9219,14 @@
       </p:sp>
       <p:sp>
         <p:nvSpPr>
-          <p:cNvPr id="32" name="Down Arrow 31"/>
+          <p:cNvPr id="31" name="Down Arrow 30"/>
           <p:cNvSpPr/>
           <p:nvPr/>
         </p:nvSpPr>
         <p:spPr>
           <a:xfrm>
-            <a:off x="9509760" y="3703320"/>
-            <a:ext cx="146304" cy="182880"/>
+            <a:off x="9555480" y="3547872"/>
+            <a:ext cx="146304" cy="164592"/>
           </a:xfrm>
           <a:prstGeom prst="downArrow">
             <a:avLst/>
@@ -9297,14 +9262,14 @@
       </p:sp>
       <p:sp>
         <p:nvSpPr>
-          <p:cNvPr id="33" name="TextBox 32"/>
+          <p:cNvPr id="32" name="TextBox 31"/>
           <p:cNvSpPr txBox="1"/>
           <p:nvPr/>
         </p:nvSpPr>
         <p:spPr>
           <a:xfrm>
-            <a:off x="365760" y="3913632"/>
-            <a:ext cx="11430000" cy="228600"/>
+            <a:off x="365760" y="3767328"/>
+            <a:ext cx="11430000" cy="219456"/>
           </a:xfrm>
           <a:prstGeom prst="rect">
             <a:avLst/>
@@ -9312,7 +9277,7 @@
           <a:noFill/>
         </p:spPr>
         <p:txBody>
-          <a:bodyPr wrap="square">
+          <a:bodyPr wrap="square" lIns="0" rIns="0" tIns="0" bIns="0">
             <a:spAutoFit/>
           </a:bodyPr>
           <a:lstStyle/>
@@ -9332,14 +9297,14 @@
       </p:sp>
       <p:sp>
         <p:nvSpPr>
-          <p:cNvPr id="34" name="Rounded Rectangle 33"/>
+          <p:cNvPr id="33" name="Rounded Rectangle 32"/>
           <p:cNvSpPr/>
           <p:nvPr/>
         </p:nvSpPr>
         <p:spPr>
           <a:xfrm>
-            <a:off x="411480" y="4160520"/>
-            <a:ext cx="2651760" cy="1417320"/>
+            <a:off x="365760" y="4023360"/>
+            <a:ext cx="2697480" cy="1325880"/>
           </a:xfrm>
           <a:prstGeom prst="roundRect">
             <a:avLst>
@@ -9379,14 +9344,14 @@
       </p:sp>
       <p:sp>
         <p:nvSpPr>
-          <p:cNvPr id="35" name="Rounded Rectangle 34"/>
+          <p:cNvPr id="34" name="Rounded Rectangle 33"/>
           <p:cNvSpPr/>
           <p:nvPr/>
         </p:nvSpPr>
         <p:spPr>
           <a:xfrm>
-            <a:off x="502920" y="4251960"/>
-            <a:ext cx="1234440" cy="219456"/>
+            <a:off x="475488" y="4133088"/>
+            <a:ext cx="1325880" cy="237744"/>
           </a:xfrm>
           <a:prstGeom prst="roundRect">
             <a:avLst>
@@ -9424,14 +9389,14 @@
       </p:sp>
       <p:sp>
         <p:nvSpPr>
-          <p:cNvPr id="36" name="TextBox 35"/>
+          <p:cNvPr id="35" name="TextBox 34"/>
           <p:cNvSpPr txBox="1"/>
           <p:nvPr/>
         </p:nvSpPr>
         <p:spPr>
           <a:xfrm>
-            <a:off x="502920" y="4270248"/>
-            <a:ext cx="1234440" cy="201168"/>
+            <a:off x="475488" y="4151376"/>
+            <a:ext cx="1325880" cy="201168"/>
           </a:xfrm>
           <a:prstGeom prst="rect">
             <a:avLst/>
@@ -9439,7 +9404,7 @@
           <a:noFill/>
         </p:spPr>
         <p:txBody>
-          <a:bodyPr wrap="square">
+          <a:bodyPr wrap="square" lIns="0" rIns="0" tIns="0" bIns="0">
             <a:spAutoFit/>
           </a:bodyPr>
           <a:lstStyle/>
@@ -9459,14 +9424,14 @@
       </p:sp>
       <p:sp>
         <p:nvSpPr>
-          <p:cNvPr id="37" name="TextBox 36"/>
+          <p:cNvPr id="36" name="TextBox 35"/>
           <p:cNvSpPr txBox="1"/>
           <p:nvPr/>
         </p:nvSpPr>
         <p:spPr>
           <a:xfrm>
-            <a:off x="539496" y="4544568"/>
-            <a:ext cx="2395728" cy="274320"/>
+            <a:off x="493776" y="4462272"/>
+            <a:ext cx="2441448" cy="274320"/>
           </a:xfrm>
           <a:prstGeom prst="rect">
             <a:avLst/>
@@ -9474,7 +9439,7 @@
           <a:noFill/>
         </p:spPr>
         <p:txBody>
-          <a:bodyPr wrap="square">
+          <a:bodyPr wrap="square" lIns="0" rIns="0" tIns="0" bIns="0">
             <a:spAutoFit/>
           </a:bodyPr>
           <a:lstStyle/>
@@ -9494,14 +9459,49 @@
       </p:sp>
       <p:sp>
         <p:nvSpPr>
+          <p:cNvPr id="37" name="TextBox 36"/>
+          <p:cNvSpPr txBox="1"/>
+          <p:nvPr/>
+        </p:nvSpPr>
+        <p:spPr>
+          <a:xfrm>
+            <a:off x="493776" y="4782312"/>
+            <a:ext cx="2441448" cy="411480"/>
+          </a:xfrm>
+          <a:prstGeom prst="rect">
+            <a:avLst/>
+          </a:prstGeom>
+          <a:noFill/>
+        </p:spPr>
+        <p:txBody>
+          <a:bodyPr wrap="square" lIns="0" rIns="0" tIns="0" bIns="0">
+            <a:spAutoFit/>
+          </a:bodyPr>
+          <a:lstStyle/>
+          <a:p>
+            <a:pPr algn="l"/>
+            <a:r>
+              <a:rPr sz="1100" b="0">
+                <a:solidFill>
+                  <a:srgbClr val="94A3B8"/>
+                </a:solidFill>
+                <a:latin typeface="Calibri"/>
+              </a:rPr>
+              <a:t>Kenny green box  ·  inventory · issue/redeem · track</a:t>
+            </a:r>
+          </a:p>
+        </p:txBody>
+      </p:sp>
+      <p:sp>
+        <p:nvSpPr>
           <p:cNvPr id="38" name="TextBox 37"/>
           <p:cNvSpPr txBox="1"/>
           <p:nvPr/>
         </p:nvSpPr>
         <p:spPr>
           <a:xfrm>
-            <a:off x="539496" y="4864608"/>
-            <a:ext cx="2395728" cy="502920"/>
+            <a:off x="493776" y="5239512"/>
+            <a:ext cx="2441448" cy="228600"/>
           </a:xfrm>
           <a:prstGeom prst="rect">
             <a:avLst/>
@@ -9509,42 +9509,7 @@
           <a:noFill/>
         </p:spPr>
         <p:txBody>
-          <a:bodyPr wrap="square">
-            <a:spAutoFit/>
-          </a:bodyPr>
-          <a:lstStyle/>
-          <a:p>
-            <a:pPr algn="l"/>
-            <a:r>
-              <a:rPr sz="1100" b="0">
-                <a:solidFill>
-                  <a:srgbClr val="94A3B8"/>
-                </a:solidFill>
-                <a:latin typeface="Calibri"/>
-              </a:rPr>
-              <a:t>Green box · inventory · issue/redeem · track</a:t>
-            </a:r>
-          </a:p>
-        </p:txBody>
-      </p:sp>
-      <p:sp>
-        <p:nvSpPr>
-          <p:cNvPr id="39" name="TextBox 38"/>
-          <p:cNvSpPr txBox="1"/>
-          <p:nvPr/>
-        </p:nvSpPr>
-        <p:spPr>
-          <a:xfrm>
-            <a:off x="539496" y="5321808"/>
-            <a:ext cx="2395728" cy="228600"/>
-          </a:xfrm>
-          <a:prstGeom prst="rect">
-            <a:avLst/>
-          </a:prstGeom>
-          <a:noFill/>
-        </p:spPr>
-        <p:txBody>
-          <a:bodyPr wrap="square">
+          <a:bodyPr wrap="square" lIns="0" rIns="0" tIns="0" bIns="0">
             <a:spAutoFit/>
           </a:bodyPr>
           <a:lstStyle/>
@@ -9564,14 +9529,14 @@
       </p:sp>
       <p:sp>
         <p:nvSpPr>
-          <p:cNvPr id="40" name="Rounded Rectangle 39"/>
+          <p:cNvPr id="39" name="Rounded Rectangle 38"/>
           <p:cNvSpPr/>
           <p:nvPr/>
         </p:nvSpPr>
         <p:spPr>
           <a:xfrm>
-            <a:off x="3246120" y="4160520"/>
-            <a:ext cx="2651760" cy="1417320"/>
+            <a:off x="3227832" y="4023360"/>
+            <a:ext cx="2697480" cy="1325880"/>
           </a:xfrm>
           <a:prstGeom prst="roundRect">
             <a:avLst>
@@ -9611,14 +9576,14 @@
       </p:sp>
       <p:sp>
         <p:nvSpPr>
-          <p:cNvPr id="41" name="TextBox 40"/>
+          <p:cNvPr id="40" name="TextBox 39"/>
           <p:cNvSpPr txBox="1"/>
           <p:nvPr/>
         </p:nvSpPr>
         <p:spPr>
           <a:xfrm>
-            <a:off x="3374136" y="4325112"/>
-            <a:ext cx="2395728" cy="274320"/>
+            <a:off x="3355848" y="4187952"/>
+            <a:ext cx="2441448" cy="274320"/>
           </a:xfrm>
           <a:prstGeom prst="rect">
             <a:avLst/>
@@ -9626,7 +9591,7 @@
           <a:noFill/>
         </p:spPr>
         <p:txBody>
-          <a:bodyPr wrap="square">
+          <a:bodyPr wrap="square" lIns="0" rIns="0" tIns="0" bIns="0">
             <a:spAutoFit/>
           </a:bodyPr>
           <a:lstStyle/>
@@ -9646,14 +9611,49 @@
       </p:sp>
       <p:sp>
         <p:nvSpPr>
+          <p:cNvPr id="41" name="TextBox 40"/>
+          <p:cNvSpPr txBox="1"/>
+          <p:nvPr/>
+        </p:nvSpPr>
+        <p:spPr>
+          <a:xfrm>
+            <a:off x="3355848" y="4507992"/>
+            <a:ext cx="2441448" cy="411480"/>
+          </a:xfrm>
+          <a:prstGeom prst="rect">
+            <a:avLst/>
+          </a:prstGeom>
+          <a:noFill/>
+        </p:spPr>
+        <p:txBody>
+          <a:bodyPr wrap="square" lIns="0" rIns="0" tIns="0" bIns="0">
+            <a:spAutoFit/>
+          </a:bodyPr>
+          <a:lstStyle/>
+          <a:p>
+            <a:pPr algn="l"/>
+            <a:r>
+              <a:rPr sz="1100" b="0">
+                <a:solidFill>
+                  <a:srgbClr val="94A3B8"/>
+                </a:solidFill>
+                <a:latin typeface="Calibri"/>
+              </a:rPr>
+              <a:t>Fulfillment  ·  triggered after routing</a:t>
+            </a:r>
+          </a:p>
+        </p:txBody>
+      </p:sp>
+      <p:sp>
+        <p:nvSpPr>
           <p:cNvPr id="42" name="TextBox 41"/>
           <p:cNvSpPr txBox="1"/>
           <p:nvPr/>
         </p:nvSpPr>
         <p:spPr>
           <a:xfrm>
-            <a:off x="3374136" y="4645152"/>
-            <a:ext cx="2395728" cy="502920"/>
+            <a:off x="3355848" y="4965192"/>
+            <a:ext cx="2441448" cy="228600"/>
           </a:xfrm>
           <a:prstGeom prst="rect">
             <a:avLst/>
@@ -9661,42 +9661,7 @@
           <a:noFill/>
         </p:spPr>
         <p:txBody>
-          <a:bodyPr wrap="square">
-            <a:spAutoFit/>
-          </a:bodyPr>
-          <a:lstStyle/>
-          <a:p>
-            <a:pPr algn="l"/>
-            <a:r>
-              <a:rPr sz="1100" b="0">
-                <a:solidFill>
-                  <a:srgbClr val="94A3B8"/>
-                </a:solidFill>
-                <a:latin typeface="Calibri"/>
-              </a:rPr>
-              <a:t>Fulfillment · triggered after routing</a:t>
-            </a:r>
-          </a:p>
-        </p:txBody>
-      </p:sp>
-      <p:sp>
-        <p:nvSpPr>
-          <p:cNvPr id="43" name="TextBox 42"/>
-          <p:cNvSpPr txBox="1"/>
-          <p:nvPr/>
-        </p:nvSpPr>
-        <p:spPr>
-          <a:xfrm>
-            <a:off x="3374136" y="5102352"/>
-            <a:ext cx="2395728" cy="228600"/>
-          </a:xfrm>
-          <a:prstGeom prst="rect">
-            <a:avLst/>
-          </a:prstGeom>
-          <a:noFill/>
-        </p:spPr>
-        <p:txBody>
-          <a:bodyPr wrap="square">
+          <a:bodyPr wrap="square" lIns="0" rIns="0" tIns="0" bIns="0">
             <a:spAutoFit/>
           </a:bodyPr>
           <a:lstStyle/>
@@ -9716,14 +9681,14 @@
       </p:sp>
       <p:sp>
         <p:nvSpPr>
-          <p:cNvPr id="44" name="Rounded Rectangle 43"/>
+          <p:cNvPr id="43" name="Rounded Rectangle 42"/>
           <p:cNvSpPr/>
           <p:nvPr/>
         </p:nvSpPr>
         <p:spPr>
           <a:xfrm>
-            <a:off x="6080760" y="4160520"/>
-            <a:ext cx="2651760" cy="1417320"/>
+            <a:off x="6089904" y="4023360"/>
+            <a:ext cx="2697480" cy="1325880"/>
           </a:xfrm>
           <a:prstGeom prst="roundRect">
             <a:avLst>
@@ -9763,14 +9728,14 @@
       </p:sp>
       <p:sp>
         <p:nvSpPr>
-          <p:cNvPr id="45" name="TextBox 44"/>
+          <p:cNvPr id="44" name="TextBox 43"/>
           <p:cNvSpPr txBox="1"/>
           <p:nvPr/>
         </p:nvSpPr>
         <p:spPr>
           <a:xfrm>
-            <a:off x="6208776" y="4325112"/>
-            <a:ext cx="2395728" cy="274320"/>
+            <a:off x="6217920" y="4187952"/>
+            <a:ext cx="2441448" cy="274320"/>
           </a:xfrm>
           <a:prstGeom prst="rect">
             <a:avLst/>
@@ -9778,7 +9743,7 @@
           <a:noFill/>
         </p:spPr>
         <p:txBody>
-          <a:bodyPr wrap="square">
+          <a:bodyPr wrap="square" lIns="0" rIns="0" tIns="0" bIns="0">
             <a:spAutoFit/>
           </a:bodyPr>
           <a:lstStyle/>
@@ -9798,14 +9763,14 @@
       </p:sp>
       <p:sp>
         <p:nvSpPr>
-          <p:cNvPr id="46" name="TextBox 45"/>
+          <p:cNvPr id="45" name="TextBox 44"/>
           <p:cNvSpPr txBox="1"/>
           <p:nvPr/>
         </p:nvSpPr>
         <p:spPr>
           <a:xfrm>
-            <a:off x="6208776" y="4645152"/>
-            <a:ext cx="2395728" cy="502920"/>
+            <a:off x="6217920" y="4507992"/>
+            <a:ext cx="2441448" cy="411480"/>
           </a:xfrm>
           <a:prstGeom prst="rect">
             <a:avLst/>
@@ -9813,7 +9778,7 @@
           <a:noFill/>
         </p:spPr>
         <p:txBody>
-          <a:bodyPr wrap="square">
+          <a:bodyPr wrap="square" lIns="0" rIns="0" tIns="0" bIns="0">
             <a:spAutoFit/>
           </a:bodyPr>
           <a:lstStyle/>
@@ -9833,14 +9798,14 @@
       </p:sp>
       <p:sp>
         <p:nvSpPr>
-          <p:cNvPr id="47" name="TextBox 46"/>
+          <p:cNvPr id="46" name="TextBox 45"/>
           <p:cNvSpPr txBox="1"/>
           <p:nvPr/>
         </p:nvSpPr>
         <p:spPr>
           <a:xfrm>
-            <a:off x="6208776" y="5102352"/>
-            <a:ext cx="2395728" cy="228600"/>
+            <a:off x="6217920" y="4965192"/>
+            <a:ext cx="2441448" cy="228600"/>
           </a:xfrm>
           <a:prstGeom prst="rect">
             <a:avLst/>
@@ -9848,7 +9813,7 @@
           <a:noFill/>
         </p:spPr>
         <p:txBody>
-          <a:bodyPr wrap="square">
+          <a:bodyPr wrap="square" lIns="0" rIns="0" tIns="0" bIns="0">
             <a:spAutoFit/>
           </a:bodyPr>
           <a:lstStyle/>
@@ -9868,14 +9833,14 @@
       </p:sp>
       <p:sp>
         <p:nvSpPr>
-          <p:cNvPr id="48" name="Rounded Rectangle 47"/>
+          <p:cNvPr id="47" name="Rounded Rectangle 46"/>
           <p:cNvSpPr/>
           <p:nvPr/>
         </p:nvSpPr>
         <p:spPr>
           <a:xfrm>
-            <a:off x="8915400" y="4160520"/>
-            <a:ext cx="2651760" cy="1417320"/>
+            <a:off x="8951976" y="4023360"/>
+            <a:ext cx="2697480" cy="1325880"/>
           </a:xfrm>
           <a:prstGeom prst="roundRect">
             <a:avLst>
@@ -9915,14 +9880,14 @@
       </p:sp>
       <p:sp>
         <p:nvSpPr>
-          <p:cNvPr id="49" name="TextBox 48"/>
+          <p:cNvPr id="48" name="TextBox 47"/>
           <p:cNvSpPr txBox="1"/>
           <p:nvPr/>
         </p:nvSpPr>
         <p:spPr>
           <a:xfrm>
-            <a:off x="9043416" y="4325112"/>
-            <a:ext cx="2395728" cy="274320"/>
+            <a:off x="9079992" y="4187952"/>
+            <a:ext cx="2441448" cy="274320"/>
           </a:xfrm>
           <a:prstGeom prst="rect">
             <a:avLst/>
@@ -9930,7 +9895,7 @@
           <a:noFill/>
         </p:spPr>
         <p:txBody>
-          <a:bodyPr wrap="square">
+          <a:bodyPr wrap="square" lIns="0" rIns="0" tIns="0" bIns="0">
             <a:spAutoFit/>
           </a:bodyPr>
           <a:lstStyle/>
@@ -9950,14 +9915,14 @@
       </p:sp>
       <p:sp>
         <p:nvSpPr>
-          <p:cNvPr id="50" name="TextBox 49"/>
+          <p:cNvPr id="49" name="TextBox 48"/>
           <p:cNvSpPr txBox="1"/>
           <p:nvPr/>
         </p:nvSpPr>
         <p:spPr>
           <a:xfrm>
-            <a:off x="9043416" y="4645152"/>
-            <a:ext cx="2395728" cy="502920"/>
+            <a:off x="9079992" y="4507992"/>
+            <a:ext cx="2441448" cy="411480"/>
           </a:xfrm>
           <a:prstGeom prst="rect">
             <a:avLst/>
@@ -9965,7 +9930,7 @@
           <a:noFill/>
         </p:spPr>
         <p:txBody>
-          <a:bodyPr wrap="square">
+          <a:bodyPr wrap="square" lIns="0" rIns="0" tIns="0" bIns="0">
             <a:spAutoFit/>
           </a:bodyPr>
           <a:lstStyle/>
@@ -9985,14 +9950,14 @@
       </p:sp>
       <p:sp>
         <p:nvSpPr>
-          <p:cNvPr id="51" name="TextBox 50"/>
+          <p:cNvPr id="50" name="TextBox 49"/>
           <p:cNvSpPr txBox="1"/>
           <p:nvPr/>
         </p:nvSpPr>
         <p:spPr>
           <a:xfrm>
-            <a:off x="9043416" y="5102352"/>
-            <a:ext cx="2395728" cy="228600"/>
+            <a:off x="9079992" y="4965192"/>
+            <a:ext cx="2441448" cy="228600"/>
           </a:xfrm>
           <a:prstGeom prst="rect">
             <a:avLst/>
@@ -10000,7 +9965,7 @@
           <a:noFill/>
         </p:spPr>
         <p:txBody>
-          <a:bodyPr wrap="square">
+          <a:bodyPr wrap="square" lIns="0" rIns="0" tIns="0" bIns="0">
             <a:spAutoFit/>
           </a:bodyPr>
           <a:lstStyle/>
@@ -10020,14 +9985,14 @@
       </p:sp>
       <p:sp>
         <p:nvSpPr>
-          <p:cNvPr id="52" name="Rounded Rectangle 51"/>
+          <p:cNvPr id="51" name="Rounded Rectangle 50"/>
           <p:cNvSpPr/>
           <p:nvPr/>
         </p:nvSpPr>
         <p:spPr>
           <a:xfrm>
-            <a:off x="411480" y="5669280"/>
-            <a:ext cx="2651760" cy="365760"/>
+            <a:off x="365760" y="5468112"/>
+            <a:ext cx="2697480" cy="347472"/>
           </a:xfrm>
           <a:prstGeom prst="roundRect">
             <a:avLst>
@@ -10067,14 +10032,14 @@
       </p:sp>
       <p:sp>
         <p:nvSpPr>
-          <p:cNvPr id="53" name="TextBox 52"/>
+          <p:cNvPr id="52" name="TextBox 51"/>
           <p:cNvSpPr txBox="1"/>
           <p:nvPr/>
         </p:nvSpPr>
         <p:spPr>
           <a:xfrm>
-            <a:off x="502920" y="5742432"/>
-            <a:ext cx="2468880" cy="256032"/>
+            <a:off x="475488" y="5532120"/>
+            <a:ext cx="2478024" cy="237744"/>
           </a:xfrm>
           <a:prstGeom prst="rect">
             <a:avLst/>
@@ -10082,7 +10047,7 @@
           <a:noFill/>
         </p:spPr>
         <p:txBody>
-          <a:bodyPr wrap="square">
+          <a:bodyPr wrap="square" lIns="0" rIns="0" tIns="0" bIns="0">
             <a:spAutoFit/>
           </a:bodyPr>
           <a:lstStyle/>
@@ -10095,21 +10060,21 @@
                 </a:solidFill>
                 <a:latin typeface="Calibri"/>
               </a:rPr>
-              <a:t>↓ COD · other partners</a:t>
-            </a:r>
-          </a:p>
-        </p:txBody>
-      </p:sp>
-      <p:sp>
-        <p:nvSpPr>
-          <p:cNvPr id="54" name="Rounded Rectangle 53"/>
+              <a:t>↓  COD · other partners</a:t>
+            </a:r>
+          </a:p>
+        </p:txBody>
+      </p:sp>
+      <p:sp>
+        <p:nvSpPr>
+          <p:cNvPr id="53" name="Rounded Rectangle 52"/>
           <p:cNvSpPr/>
           <p:nvPr/>
         </p:nvSpPr>
         <p:spPr>
           <a:xfrm>
-            <a:off x="3246120" y="5669280"/>
-            <a:ext cx="8458200" cy="365760"/>
+            <a:off x="3227832" y="5468112"/>
+            <a:ext cx="8503920" cy="347472"/>
           </a:xfrm>
           <a:prstGeom prst="roundRect">
             <a:avLst>
@@ -10149,14 +10114,14 @@
       </p:sp>
       <p:sp>
         <p:nvSpPr>
-          <p:cNvPr id="55" name="TextBox 54"/>
+          <p:cNvPr id="54" name="TextBox 53"/>
           <p:cNvSpPr txBox="1"/>
           <p:nvPr/>
         </p:nvSpPr>
         <p:spPr>
           <a:xfrm>
-            <a:off x="3383280" y="5742432"/>
-            <a:ext cx="8229600" cy="256032"/>
+            <a:off x="3364992" y="5532120"/>
+            <a:ext cx="8229600" cy="237744"/>
           </a:xfrm>
           <a:prstGeom prst="rect">
             <a:avLst/>
@@ -10164,7 +10129,7 @@
           <a:noFill/>
         </p:spPr>
         <p:txBody>
-          <a:bodyPr wrap="square">
+          <a:bodyPr wrap="square" lIns="0" rIns="0" tIns="0" bIns="0">
             <a:spAutoFit/>
           </a:bodyPr>
           <a:lstStyle/>
@@ -10177,21 +10142,21 @@
                 </a:solidFill>
                 <a:latin typeface="Calibri"/>
               </a:rPr>
-              <a:t>Pitch: Buy LedgeRX. Integrate once to the Landing hub. CBP/Gift/Notify stay behind your layer.</a:t>
-            </a:r>
-          </a:p>
-        </p:txBody>
-      </p:sp>
-      <p:sp>
-        <p:nvSpPr>
-          <p:cNvPr id="56" name="Rounded Rectangle 55"/>
+              <a:t>Pitch: Buy LedgeRX. Integrate once to the Landing hub. CBP / Gift / Notify stay behind your layer.</a:t>
+            </a:r>
+          </a:p>
+        </p:txBody>
+      </p:sp>
+      <p:sp>
+        <p:nvSpPr>
+          <p:cNvPr id="55" name="Rounded Rectangle 54"/>
           <p:cNvSpPr/>
           <p:nvPr/>
         </p:nvSpPr>
         <p:spPr>
           <a:xfrm>
-            <a:off x="365760" y="6172200"/>
-            <a:ext cx="11460175" cy="457200"/>
+            <a:off x="365760" y="5989320"/>
+            <a:ext cx="11460175" cy="502920"/>
           </a:xfrm>
           <a:prstGeom prst="roundRect">
             <a:avLst>
@@ -10231,13 +10196,13 @@
       </p:sp>
       <p:sp>
         <p:nvSpPr>
-          <p:cNvPr id="57" name="TextBox 56"/>
+          <p:cNvPr id="56" name="TextBox 55"/>
           <p:cNvSpPr txBox="1"/>
           <p:nvPr/>
         </p:nvSpPr>
         <p:spPr>
           <a:xfrm>
-            <a:off x="502920" y="6263640"/>
+            <a:off x="502920" y="6108192"/>
             <a:ext cx="11155680" cy="320040"/>
           </a:xfrm>
           <a:prstGeom prst="rect">
@@ -10246,7 +10211,7 @@
           <a:noFill/>
         </p:spPr>
         <p:txBody>
-          <a:bodyPr wrap="square">
+          <a:bodyPr wrap="square" lIns="0" rIns="0" tIns="0" bIns="0">
             <a:spAutoFit/>
           </a:bodyPr>
           <a:lstStyle/>
@@ -10259,7 +10224,7 @@
                 </a:solidFill>
                 <a:latin typeface="Calibri"/>
               </a:rPr>
-              <a:t>LedgeRX ↔ one UAF 對口 only     ·     hub collects outcomes + runs UAF logic     ·     internal fan-out is UAF’s business</a:t>
+              <a:t>LedgeRX ↔ one UAF interface only     ·     hub collects outcomes + runs UAF logic     ·     internal fan-out is UAF’s business</a:t>
             </a:r>
           </a:p>
         </p:txBody>

</xml_diff>

<commit_message>
docs(decks): drop Kenny label; aim → sim
</commit_message>
<xml_diff>
--- a/docs/decks/LedgeRX-System-Architecture-CTO.pptx
+++ b/docs/decks/LedgeRX-System-Architecture-CTO.pptx
@@ -9351,7 +9351,7 @@
         <p:spPr>
           <a:xfrm>
             <a:off x="475488" y="4133088"/>
-            <a:ext cx="1325880" cy="237744"/>
+            <a:ext cx="1417320" cy="237744"/>
           </a:xfrm>
           <a:prstGeom prst="roundRect">
             <a:avLst>
@@ -9396,7 +9396,7 @@
         <p:spPr>
           <a:xfrm>
             <a:off x="475488" y="4151376"/>
-            <a:ext cx="1325880" cy="201168"/>
+            <a:ext cx="1417320" cy="201168"/>
           </a:xfrm>
           <a:prstGeom prst="rect">
             <a:avLst/>
@@ -9417,7 +9417,7 @@
                 </a:solidFill>
                 <a:latin typeface="Calibri"/>
               </a:rPr>
-              <a:t>Kenny green box</a:t>
+              <a:t>ONE DOWNSTREAM</a:t>
             </a:r>
           </a:p>
         </p:txBody>
@@ -9466,7 +9466,7 @@
         <p:spPr>
           <a:xfrm>
             <a:off x="493776" y="4782312"/>
-            <a:ext cx="2441448" cy="411480"/>
+            <a:ext cx="2441448" cy="457200"/>
           </a:xfrm>
           <a:prstGeom prst="rect">
             <a:avLst/>
@@ -9487,7 +9487,7 @@
                 </a:solidFill>
                 <a:latin typeface="Calibri"/>
               </a:rPr>
-              <a:t>Kenny green box  ·  inventory · issue/redeem · track</a:t>
+              <a:t>Central coupon platform  ·  inventory · issue / redeem · track</a:t>
             </a:r>
           </a:p>
         </p:txBody>
@@ -9500,7 +9500,7 @@
         </p:nvSpPr>
         <p:spPr>
           <a:xfrm>
-            <a:off x="493776" y="5239512"/>
+            <a:off x="493776" y="5285232"/>
             <a:ext cx="2441448" cy="228600"/>
           </a:xfrm>
           <a:prstGeom prst="rect">
@@ -9618,7 +9618,7 @@
         <p:spPr>
           <a:xfrm>
             <a:off x="3355848" y="4507992"/>
-            <a:ext cx="2441448" cy="411480"/>
+            <a:ext cx="2441448" cy="457200"/>
           </a:xfrm>
           <a:prstGeom prst="rect">
             <a:avLst/>
@@ -9652,7 +9652,7 @@
         </p:nvSpPr>
         <p:spPr>
           <a:xfrm>
-            <a:off x="3355848" y="4965192"/>
+            <a:off x="3355848" y="5010912"/>
             <a:ext cx="2441448" cy="228600"/>
           </a:xfrm>
           <a:prstGeom prst="rect">
@@ -9770,7 +9770,7 @@
         <p:spPr>
           <a:xfrm>
             <a:off x="6217920" y="4507992"/>
-            <a:ext cx="2441448" cy="411480"/>
+            <a:ext cx="2441448" cy="457200"/>
           </a:xfrm>
           <a:prstGeom prst="rect">
             <a:avLst/>
@@ -9804,7 +9804,7 @@
         </p:nvSpPr>
         <p:spPr>
           <a:xfrm>
-            <a:off x="6217920" y="4965192"/>
+            <a:off x="6217920" y="5010912"/>
             <a:ext cx="2441448" cy="228600"/>
           </a:xfrm>
           <a:prstGeom prst="rect">
@@ -9922,7 +9922,7 @@
         <p:spPr>
           <a:xfrm>
             <a:off x="9079992" y="4507992"/>
-            <a:ext cx="2441448" cy="411480"/>
+            <a:ext cx="2441448" cy="457200"/>
           </a:xfrm>
           <a:prstGeom prst="rect">
             <a:avLst/>
@@ -9943,7 +9943,7 @@
                 </a:solidFill>
                 <a:latin typeface="Calibri"/>
               </a:rPr>
-              <a:t>Balances · apps (Yes UA · aim)</a:t>
+              <a:t>Balances · apps (Yes UA · sim)</a:t>
             </a:r>
           </a:p>
         </p:txBody>
@@ -9956,7 +9956,7 @@
         </p:nvSpPr>
         <p:spPr>
           <a:xfrm>
-            <a:off x="9079992" y="4965192"/>
+            <a:off x="9079992" y="5010912"/>
             <a:ext cx="2441448" cy="228600"/>
           </a:xfrm>
           <a:prstGeom prst="rect">

</xml_diff>

<commit_message>
docs(decks): add UAF/sim brand badges + REST/Kafka/SDK icons
</commit_message>
<xml_diff>
--- a/docs/decks/LedgeRX-System-Architecture-CTO.pptx
+++ b/docs/decks/LedgeRX-System-Architecture-CTO.pptx
@@ -3183,8 +3183,8 @@
         </p:nvSpPr>
         <p:spPr>
           <a:xfrm>
-            <a:off x="365760" y="164592"/>
-            <a:ext cx="8229600" cy="292608"/>
+            <a:off x="365760" y="146304"/>
+            <a:ext cx="6858000" cy="274320"/>
           </a:xfrm>
           <a:prstGeom prst="rect">
             <a:avLst/>
@@ -3210,16 +3210,40 @@
           </a:p>
         </p:txBody>
       </p:sp>
-      <p:sp>
-        <p:nvSpPr>
-          <p:cNvPr id="5" name="TextBox 4"/>
+      <p:pic>
+        <p:nvPicPr>
+          <p:cNvPr id="5" name="Picture 4" descr="uaf.png"/>
+          <p:cNvPicPr>
+            <a:picLocks noChangeAspect="1"/>
+          </p:cNvPicPr>
+          <p:nvPr/>
+        </p:nvPicPr>
+        <p:blipFill>
+          <a:blip r:embed="rId2"/>
+          <a:stretch>
+            <a:fillRect/>
+          </a:stretch>
+        </p:blipFill>
+        <p:spPr>
+          <a:xfrm>
+            <a:off x="7818120" y="128016"/>
+            <a:ext cx="347472" cy="347472"/>
+          </a:xfrm>
+          <a:prstGeom prst="rect">
+            <a:avLst/>
+          </a:prstGeom>
+        </p:spPr>
+      </p:pic>
+      <p:sp>
+        <p:nvSpPr>
+          <p:cNvPr id="6" name="TextBox 5"/>
           <p:cNvSpPr txBox="1"/>
           <p:nvPr/>
         </p:nvSpPr>
         <p:spPr>
           <a:xfrm>
-            <a:off x="365760" y="457200"/>
-            <a:ext cx="8412480" cy="219456"/>
+            <a:off x="8211312" y="182880"/>
+            <a:ext cx="640080" cy="256032"/>
           </a:xfrm>
           <a:prstGeom prst="rect">
             <a:avLst/>
@@ -3234,6 +3258,100 @@
           <a:p>
             <a:pPr algn="l"/>
             <a:r>
+              <a:rPr sz="1200" b="1">
+                <a:solidFill>
+                  <a:srgbClr val="2DD4BF"/>
+                </a:solidFill>
+                <a:latin typeface="Calibri"/>
+              </a:rPr>
+              <a:t>UAF</a:t>
+            </a:r>
+          </a:p>
+        </p:txBody>
+      </p:sp>
+      <p:pic>
+        <p:nvPicPr>
+          <p:cNvPr id="7" name="Picture 6" descr="sim.png"/>
+          <p:cNvPicPr>
+            <a:picLocks noChangeAspect="1"/>
+          </p:cNvPicPr>
+          <p:nvPr/>
+        </p:nvPicPr>
+        <p:blipFill>
+          <a:blip r:embed="rId3"/>
+          <a:stretch>
+            <a:fillRect/>
+          </a:stretch>
+        </p:blipFill>
+        <p:spPr>
+          <a:xfrm>
+            <a:off x="8823960" y="128016"/>
+            <a:ext cx="347472" cy="347472"/>
+          </a:xfrm>
+          <a:prstGeom prst="rect">
+            <a:avLst/>
+          </a:prstGeom>
+        </p:spPr>
+      </p:pic>
+      <p:sp>
+        <p:nvSpPr>
+          <p:cNvPr id="8" name="TextBox 7"/>
+          <p:cNvSpPr txBox="1"/>
+          <p:nvPr/>
+        </p:nvSpPr>
+        <p:spPr>
+          <a:xfrm>
+            <a:off x="9217152" y="182880"/>
+            <a:ext cx="502920" cy="256032"/>
+          </a:xfrm>
+          <a:prstGeom prst="rect">
+            <a:avLst/>
+          </a:prstGeom>
+          <a:noFill/>
+        </p:spPr>
+        <p:txBody>
+          <a:bodyPr wrap="square" lIns="0" rIns="0" tIns="0" bIns="0">
+            <a:spAutoFit/>
+          </a:bodyPr>
+          <a:lstStyle/>
+          <a:p>
+            <a:pPr algn="l"/>
+            <a:r>
+              <a:rPr sz="1200" b="1">
+                <a:solidFill>
+                  <a:srgbClr val="38BDF8"/>
+                </a:solidFill>
+                <a:latin typeface="Calibri"/>
+              </a:rPr>
+              <a:t>sim</a:t>
+            </a:r>
+          </a:p>
+        </p:txBody>
+      </p:sp>
+      <p:sp>
+        <p:nvSpPr>
+          <p:cNvPr id="9" name="TextBox 8"/>
+          <p:cNvSpPr txBox="1"/>
+          <p:nvPr/>
+        </p:nvSpPr>
+        <p:spPr>
+          <a:xfrm>
+            <a:off x="365760" y="475488"/>
+            <a:ext cx="8412480" cy="219456"/>
+          </a:xfrm>
+          <a:prstGeom prst="rect">
+            <a:avLst/>
+          </a:prstGeom>
+          <a:noFill/>
+        </p:spPr>
+        <p:txBody>
+          <a:bodyPr wrap="square" lIns="0" rIns="0" tIns="0" bIns="0">
+            <a:spAutoFit/>
+          </a:bodyPr>
+          <a:lstStyle/>
+          <a:p>
+            <a:pPr algn="l"/>
+            <a:r>
               <a:rPr sz="1200" b="0">
                 <a:solidFill>
                   <a:srgbClr val="94A3B8"/>
@@ -3247,14 +3365,14 @@
       </p:sp>
       <p:sp>
         <p:nvSpPr>
-          <p:cNvPr id="6" name="Rounded Rectangle 5"/>
+          <p:cNvPr id="10" name="Rounded Rectangle 9"/>
           <p:cNvSpPr/>
           <p:nvPr/>
         </p:nvSpPr>
         <p:spPr>
           <a:xfrm>
-            <a:off x="10241280" y="164592"/>
-            <a:ext cx="1554480" cy="347472"/>
+            <a:off x="10241280" y="146304"/>
+            <a:ext cx="1554480" cy="329184"/>
           </a:xfrm>
           <a:prstGeom prst="roundRect">
             <a:avLst>
@@ -3294,13 +3412,13 @@
       </p:sp>
       <p:sp>
         <p:nvSpPr>
-          <p:cNvPr id="7" name="TextBox 6"/>
+          <p:cNvPr id="11" name="TextBox 10"/>
           <p:cNvSpPr txBox="1"/>
           <p:nvPr/>
         </p:nvSpPr>
         <p:spPr>
           <a:xfrm>
-            <a:off x="10241280" y="219456"/>
+            <a:off x="10241280" y="182880"/>
             <a:ext cx="1554480" cy="256032"/>
           </a:xfrm>
           <a:prstGeom prst="rect">
@@ -3329,7 +3447,7 @@
       </p:sp>
       <p:sp>
         <p:nvSpPr>
-          <p:cNvPr id="8" name="Rounded Rectangle 7"/>
+          <p:cNvPr id="12" name="Rounded Rectangle 11"/>
           <p:cNvSpPr/>
           <p:nvPr/>
         </p:nvSpPr>
@@ -3376,7 +3494,7 @@
       </p:sp>
       <p:sp>
         <p:nvSpPr>
-          <p:cNvPr id="9" name="Oval 8"/>
+          <p:cNvPr id="13" name="Oval 12"/>
           <p:cNvSpPr/>
           <p:nvPr/>
         </p:nvSpPr>
@@ -3419,7 +3537,7 @@
       </p:sp>
       <p:sp>
         <p:nvSpPr>
-          <p:cNvPr id="10" name="TextBox 9"/>
+          <p:cNvPr id="14" name="TextBox 13"/>
           <p:cNvSpPr txBox="1"/>
           <p:nvPr/>
         </p:nvSpPr>
@@ -3454,7 +3572,7 @@
       </p:sp>
       <p:sp>
         <p:nvSpPr>
-          <p:cNvPr id="11" name="TextBox 10"/>
+          <p:cNvPr id="15" name="TextBox 14"/>
           <p:cNvSpPr txBox="1"/>
           <p:nvPr/>
         </p:nvSpPr>
@@ -3489,14 +3607,14 @@
       </p:sp>
       <p:sp>
         <p:nvSpPr>
-          <p:cNvPr id="12" name="TextBox 11"/>
+          <p:cNvPr id="16" name="TextBox 15"/>
           <p:cNvSpPr txBox="1"/>
           <p:nvPr/>
         </p:nvSpPr>
         <p:spPr>
           <a:xfrm>
             <a:off x="475488" y="1225296"/>
-            <a:ext cx="1541626" cy="256032"/>
+            <a:ext cx="1541626" cy="237744"/>
           </a:xfrm>
           <a:prstGeom prst="rect">
             <a:avLst/>
@@ -3524,14 +3642,120 @@
       </p:sp>
       <p:sp>
         <p:nvSpPr>
-          <p:cNvPr id="13" name="Rounded Rectangle 12"/>
+          <p:cNvPr id="17" name="Rounded Rectangle 16"/>
           <p:cNvSpPr/>
           <p:nvPr/>
         </p:nvSpPr>
         <p:spPr>
           <a:xfrm>
-            <a:off x="475488" y="1627632"/>
-            <a:ext cx="1541626" cy="932688"/>
+            <a:off x="475488" y="1517904"/>
+            <a:ext cx="1541626" cy="384048"/>
+          </a:xfrm>
+          <a:prstGeom prst="roundRect">
+            <a:avLst>
+              <a:gd name="adj" fmla="val 12000"/>
+            </a:avLst>
+          </a:prstGeom>
+          <a:solidFill>
+            <a:srgbClr val="0F2D4A"/>
+          </a:solidFill>
+          <a:ln w="12700">
+            <a:solidFill>
+              <a:srgbClr val="38BDF8"/>
+            </a:solidFill>
+          </a:ln>
+        </p:spPr>
+        <p:style>
+          <a:lnRef idx="1">
+            <a:schemeClr val="accent1"/>
+          </a:lnRef>
+          <a:fillRef idx="3">
+            <a:schemeClr val="accent1"/>
+          </a:fillRef>
+          <a:effectRef idx="2">
+            <a:schemeClr val="accent1"/>
+          </a:effectRef>
+          <a:fontRef idx="minor">
+            <a:schemeClr val="lt1"/>
+          </a:fontRef>
+        </p:style>
+        <p:txBody>
+          <a:bodyPr rtlCol="0" anchor="ctr"/>
+          <a:lstStyle/>
+          <a:p>
+            <a:pPr algn="ctr"/>
+          </a:p>
+        </p:txBody>
+      </p:sp>
+      <p:pic>
+        <p:nvPicPr>
+          <p:cNvPr id="18" name="Picture 17" descr="uaf.png"/>
+          <p:cNvPicPr>
+            <a:picLocks noChangeAspect="1"/>
+          </p:cNvPicPr>
+          <p:nvPr/>
+        </p:nvPicPr>
+        <p:blipFill>
+          <a:blip r:embed="rId2"/>
+          <a:stretch>
+            <a:fillRect/>
+          </a:stretch>
+        </p:blipFill>
+        <p:spPr>
+          <a:xfrm>
+            <a:off x="548640" y="1572768"/>
+            <a:ext cx="274320" cy="274320"/>
+          </a:xfrm>
+          <a:prstGeom prst="rect">
+            <a:avLst/>
+          </a:prstGeom>
+        </p:spPr>
+      </p:pic>
+      <p:sp>
+        <p:nvSpPr>
+          <p:cNvPr id="19" name="TextBox 18"/>
+          <p:cNvSpPr txBox="1"/>
+          <p:nvPr/>
+        </p:nvSpPr>
+        <p:spPr>
+          <a:xfrm>
+            <a:off x="868680" y="1591056"/>
+            <a:ext cx="1097280" cy="256032"/>
+          </a:xfrm>
+          <a:prstGeom prst="rect">
+            <a:avLst/>
+          </a:prstGeom>
+          <a:noFill/>
+        </p:spPr>
+        <p:txBody>
+          <a:bodyPr wrap="square" lIns="0" rIns="0" tIns="0" bIns="0">
+            <a:spAutoFit/>
+          </a:bodyPr>
+          <a:lstStyle/>
+          <a:p>
+            <a:pPr algn="l"/>
+            <a:r>
+              <a:rPr sz="1100" b="1">
+                <a:solidFill>
+                  <a:srgbClr val="F8FAFC"/>
+                </a:solidFill>
+                <a:latin typeface="Calibri"/>
+              </a:rPr>
+              <a:t>UAF channels</a:t>
+            </a:r>
+          </a:p>
+        </p:txBody>
+      </p:sp>
+      <p:sp>
+        <p:nvSpPr>
+          <p:cNvPr id="20" name="Rounded Rectangle 19"/>
+          <p:cNvSpPr/>
+          <p:nvPr/>
+        </p:nvSpPr>
+        <p:spPr>
+          <a:xfrm>
+            <a:off x="475488" y="2039112"/>
+            <a:ext cx="1541626" cy="868680"/>
           </a:xfrm>
           <a:prstGeom prst="roundRect">
             <a:avLst>
@@ -3571,14 +3795,14 @@
       </p:sp>
       <p:sp>
         <p:nvSpPr>
-          <p:cNvPr id="14" name="Rectangle 13"/>
+          <p:cNvPr id="21" name="Rectangle 20"/>
           <p:cNvSpPr/>
           <p:nvPr/>
         </p:nvSpPr>
         <p:spPr>
           <a:xfrm>
-            <a:off x="475488" y="1719072"/>
-            <a:ext cx="50292" cy="749808"/>
+            <a:off x="475488" y="2130552"/>
+            <a:ext cx="50292" cy="685800"/>
           </a:xfrm>
           <a:prstGeom prst="rect">
             <a:avLst/>
@@ -3614,14 +3838,14 @@
       </p:sp>
       <p:sp>
         <p:nvSpPr>
-          <p:cNvPr id="15" name="TextBox 14"/>
+          <p:cNvPr id="22" name="TextBox 21"/>
           <p:cNvSpPr txBox="1"/>
           <p:nvPr/>
         </p:nvSpPr>
         <p:spPr>
           <a:xfrm>
-            <a:off x="621792" y="1737360"/>
-            <a:ext cx="1303882" cy="768096"/>
+            <a:off x="621792" y="2148840"/>
+            <a:ext cx="1303882" cy="704088"/>
           </a:xfrm>
           <a:prstGeom prst="rect">
             <a:avLst/>
@@ -3643,7 +3867,7 @@
               </a:spcAft>
             </a:pPr>
             <a:r>
-              <a:rPr sz="1300" b="1">
+              <a:rPr sz="1200" b="1">
                 <a:solidFill>
                   <a:srgbClr val="F8FAFC"/>
                 </a:solidFill>
@@ -3675,14 +3899,14 @@
       </p:sp>
       <p:sp>
         <p:nvSpPr>
-          <p:cNvPr id="16" name="Rounded Rectangle 15"/>
+          <p:cNvPr id="23" name="Rounded Rectangle 22"/>
           <p:cNvSpPr/>
           <p:nvPr/>
         </p:nvSpPr>
         <p:spPr>
           <a:xfrm>
-            <a:off x="475488" y="2679192"/>
-            <a:ext cx="1541626" cy="932688"/>
+            <a:off x="475488" y="2999232"/>
+            <a:ext cx="1541626" cy="868680"/>
           </a:xfrm>
           <a:prstGeom prst="roundRect">
             <a:avLst>
@@ -3722,14 +3946,14 @@
       </p:sp>
       <p:sp>
         <p:nvSpPr>
-          <p:cNvPr id="17" name="Rectangle 16"/>
+          <p:cNvPr id="24" name="Rectangle 23"/>
           <p:cNvSpPr/>
           <p:nvPr/>
         </p:nvSpPr>
         <p:spPr>
           <a:xfrm>
-            <a:off x="475488" y="2770632"/>
-            <a:ext cx="50292" cy="749808"/>
+            <a:off x="475488" y="3090672"/>
+            <a:ext cx="50292" cy="685800"/>
           </a:xfrm>
           <a:prstGeom prst="rect">
             <a:avLst/>
@@ -3765,14 +3989,14 @@
       </p:sp>
       <p:sp>
         <p:nvSpPr>
-          <p:cNvPr id="18" name="TextBox 17"/>
+          <p:cNvPr id="25" name="TextBox 24"/>
           <p:cNvSpPr txBox="1"/>
           <p:nvPr/>
         </p:nvSpPr>
         <p:spPr>
           <a:xfrm>
-            <a:off x="621792" y="2788920"/>
-            <a:ext cx="1303882" cy="768096"/>
+            <a:off x="621792" y="3108960"/>
+            <a:ext cx="1303882" cy="704088"/>
           </a:xfrm>
           <a:prstGeom prst="rect">
             <a:avLst/>
@@ -3794,7 +4018,7 @@
               </a:spcAft>
             </a:pPr>
             <a:r>
-              <a:rPr sz="1300" b="1">
+              <a:rPr sz="1200" b="1">
                 <a:solidFill>
                   <a:srgbClr val="F8FAFC"/>
                 </a:solidFill>
@@ -3826,14 +4050,14 @@
       </p:sp>
       <p:sp>
         <p:nvSpPr>
-          <p:cNvPr id="19" name="Rounded Rectangle 18"/>
+          <p:cNvPr id="26" name="Rounded Rectangle 25"/>
           <p:cNvSpPr/>
           <p:nvPr/>
         </p:nvSpPr>
         <p:spPr>
           <a:xfrm>
-            <a:off x="475488" y="3730752"/>
-            <a:ext cx="1541626" cy="932688"/>
+            <a:off x="475488" y="3959352"/>
+            <a:ext cx="1541626" cy="868680"/>
           </a:xfrm>
           <a:prstGeom prst="roundRect">
             <a:avLst>
@@ -3873,14 +4097,14 @@
       </p:sp>
       <p:sp>
         <p:nvSpPr>
-          <p:cNvPr id="20" name="Rectangle 19"/>
+          <p:cNvPr id="27" name="Rectangle 26"/>
           <p:cNvSpPr/>
           <p:nvPr/>
         </p:nvSpPr>
         <p:spPr>
           <a:xfrm>
-            <a:off x="475488" y="3822192"/>
-            <a:ext cx="50292" cy="749808"/>
+            <a:off x="475488" y="4050792"/>
+            <a:ext cx="50292" cy="685800"/>
           </a:xfrm>
           <a:prstGeom prst="rect">
             <a:avLst/>
@@ -3916,14 +4140,14 @@
       </p:sp>
       <p:sp>
         <p:nvSpPr>
-          <p:cNvPr id="21" name="TextBox 20"/>
+          <p:cNvPr id="28" name="TextBox 27"/>
           <p:cNvSpPr txBox="1"/>
           <p:nvPr/>
         </p:nvSpPr>
         <p:spPr>
           <a:xfrm>
-            <a:off x="621792" y="3840480"/>
-            <a:ext cx="1303882" cy="768096"/>
+            <a:off x="621792" y="4069080"/>
+            <a:ext cx="1303882" cy="704088"/>
           </a:xfrm>
           <a:prstGeom prst="rect">
             <a:avLst/>
@@ -3945,7 +4169,7 @@
               </a:spcAft>
             </a:pPr>
             <a:r>
-              <a:rPr sz="1300" b="1">
+              <a:rPr sz="1200" b="1">
                 <a:solidFill>
                   <a:srgbClr val="F8FAFC"/>
                 </a:solidFill>
@@ -3970,21 +4194,21 @@
                 </a:solidFill>
                 <a:latin typeface="Calibri"/>
               </a:rPr>
-              <a:t>Engage · campaigns</a:t>
-            </a:r>
-          </a:p>
-        </p:txBody>
-      </p:sp>
-      <p:sp>
-        <p:nvSpPr>
-          <p:cNvPr id="22" name="TextBox 21"/>
+              <a:t>Yes UA · sim apps</a:t>
+            </a:r>
+          </a:p>
+        </p:txBody>
+      </p:sp>
+      <p:sp>
+        <p:nvSpPr>
+          <p:cNvPr id="29" name="TextBox 28"/>
           <p:cNvSpPr txBox="1"/>
           <p:nvPr/>
         </p:nvSpPr>
         <p:spPr>
           <a:xfrm>
-            <a:off x="475488" y="4965192"/>
-            <a:ext cx="1541626" cy="594360"/>
+            <a:off x="475488" y="5102352"/>
+            <a:ext cx="1541626" cy="502920"/>
           </a:xfrm>
           <a:prstGeom prst="rect">
             <a:avLst/>
@@ -4013,7 +4237,7 @@
       </p:sp>
       <p:sp>
         <p:nvSpPr>
-          <p:cNvPr id="23" name="Rounded Rectangle 22"/>
+          <p:cNvPr id="30" name="Rounded Rectangle 29"/>
           <p:cNvSpPr/>
           <p:nvPr/>
         </p:nvSpPr>
@@ -4060,7 +4284,7 @@
       </p:sp>
       <p:sp>
         <p:nvSpPr>
-          <p:cNvPr id="24" name="Oval 23"/>
+          <p:cNvPr id="31" name="Oval 30"/>
           <p:cNvSpPr/>
           <p:nvPr/>
         </p:nvSpPr>
@@ -4103,7 +4327,7 @@
       </p:sp>
       <p:sp>
         <p:nvSpPr>
-          <p:cNvPr id="25" name="TextBox 24"/>
+          <p:cNvPr id="32" name="TextBox 31"/>
           <p:cNvSpPr txBox="1"/>
           <p:nvPr/>
         </p:nvSpPr>
@@ -4138,7 +4362,7 @@
       </p:sp>
       <p:sp>
         <p:nvSpPr>
-          <p:cNvPr id="26" name="TextBox 25"/>
+          <p:cNvPr id="33" name="TextBox 32"/>
           <p:cNvSpPr txBox="1"/>
           <p:nvPr/>
         </p:nvSpPr>
@@ -4171,16 +4395,40 @@
           </a:p>
         </p:txBody>
       </p:sp>
-      <p:sp>
-        <p:nvSpPr>
-          <p:cNvPr id="27" name="TextBox 26"/>
+      <p:pic>
+        <p:nvPicPr>
+          <p:cNvPr id="34" name="Picture 33" descr="sdk.png"/>
+          <p:cNvPicPr>
+            <a:picLocks noChangeAspect="1"/>
+          </p:cNvPicPr>
+          <p:nvPr/>
+        </p:nvPicPr>
+        <p:blipFill>
+          <a:blip r:embed="rId4"/>
+          <a:stretch>
+            <a:fillRect/>
+          </a:stretch>
+        </p:blipFill>
+        <p:spPr>
+          <a:xfrm>
+            <a:off x="2510890" y="1243584"/>
+            <a:ext cx="310896" cy="310896"/>
+          </a:xfrm>
+          <a:prstGeom prst="rect">
+            <a:avLst/>
+          </a:prstGeom>
+        </p:spPr>
+      </p:pic>
+      <p:sp>
+        <p:nvSpPr>
+          <p:cNvPr id="35" name="TextBox 34"/>
           <p:cNvSpPr txBox="1"/>
           <p:nvPr/>
         </p:nvSpPr>
         <p:spPr>
           <a:xfrm>
-            <a:off x="2492602" y="1225296"/>
-            <a:ext cx="1541626" cy="237744"/>
+            <a:off x="2876650" y="1261872"/>
+            <a:ext cx="1121002" cy="274320"/>
           </a:xfrm>
           <a:prstGeom prst="rect">
             <a:avLst/>
@@ -4208,14 +4456,14 @@
       </p:sp>
       <p:sp>
         <p:nvSpPr>
-          <p:cNvPr id="28" name="TextBox 27"/>
+          <p:cNvPr id="36" name="TextBox 35"/>
           <p:cNvSpPr txBox="1"/>
           <p:nvPr/>
         </p:nvSpPr>
         <p:spPr>
           <a:xfrm>
-            <a:off x="2492602" y="1481328"/>
-            <a:ext cx="1541626" cy="292608"/>
+            <a:off x="2510890" y="1609344"/>
+            <a:ext cx="1505050" cy="256032"/>
           </a:xfrm>
           <a:prstGeom prst="rect">
             <a:avLst/>
@@ -4243,14 +4491,14 @@
       </p:sp>
       <p:sp>
         <p:nvSpPr>
-          <p:cNvPr id="29" name="Rounded Rectangle 28"/>
+          <p:cNvPr id="37" name="Rounded Rectangle 36"/>
           <p:cNvSpPr/>
           <p:nvPr/>
         </p:nvSpPr>
         <p:spPr>
           <a:xfrm>
-            <a:off x="2492602" y="1901952"/>
-            <a:ext cx="1541626" cy="804672"/>
+            <a:off x="2492602" y="1993392"/>
+            <a:ext cx="1541626" cy="868680"/>
           </a:xfrm>
           <a:prstGeom prst="roundRect">
             <a:avLst>
@@ -4290,14 +4538,14 @@
       </p:sp>
       <p:sp>
         <p:nvSpPr>
-          <p:cNvPr id="30" name="Rectangle 29"/>
+          <p:cNvPr id="38" name="Rectangle 37"/>
           <p:cNvSpPr/>
           <p:nvPr/>
         </p:nvSpPr>
         <p:spPr>
           <a:xfrm>
-            <a:off x="2492602" y="1993392"/>
-            <a:ext cx="50292" cy="621792"/>
+            <a:off x="2492602" y="2084832"/>
+            <a:ext cx="50292" cy="685800"/>
           </a:xfrm>
           <a:prstGeom prst="rect">
             <a:avLst/>
@@ -4331,16 +4579,40 @@
           </a:p>
         </p:txBody>
       </p:sp>
-      <p:sp>
-        <p:nvSpPr>
-          <p:cNvPr id="31" name="TextBox 30"/>
+      <p:pic>
+        <p:nvPicPr>
+          <p:cNvPr id="39" name="Picture 38" descr="rest.png"/>
+          <p:cNvPicPr>
+            <a:picLocks noChangeAspect="1"/>
+          </p:cNvPicPr>
+          <p:nvPr/>
+        </p:nvPicPr>
+        <p:blipFill>
+          <a:blip r:embed="rId5"/>
+          <a:stretch>
+            <a:fillRect/>
+          </a:stretch>
+        </p:blipFill>
+        <p:spPr>
+          <a:xfrm>
+            <a:off x="2620618" y="2263140"/>
+            <a:ext cx="329184" cy="329184"/>
+          </a:xfrm>
+          <a:prstGeom prst="rect">
+            <a:avLst/>
+          </a:prstGeom>
+        </p:spPr>
+      </p:pic>
+      <p:sp>
+        <p:nvSpPr>
+          <p:cNvPr id="40" name="TextBox 39"/>
           <p:cNvSpPr txBox="1"/>
           <p:nvPr/>
         </p:nvSpPr>
         <p:spPr>
           <a:xfrm>
-            <a:off x="2638906" y="2011680"/>
-            <a:ext cx="1303882" cy="640080"/>
+            <a:off x="3022954" y="2103120"/>
+            <a:ext cx="919834" cy="704088"/>
           </a:xfrm>
           <a:prstGeom prst="rect">
             <a:avLst/>
@@ -4394,14 +4666,14 @@
       </p:sp>
       <p:sp>
         <p:nvSpPr>
-          <p:cNvPr id="32" name="Rounded Rectangle 31"/>
+          <p:cNvPr id="41" name="Rounded Rectangle 40"/>
           <p:cNvSpPr/>
           <p:nvPr/>
         </p:nvSpPr>
         <p:spPr>
           <a:xfrm>
-            <a:off x="2492602" y="2816352"/>
-            <a:ext cx="1541626" cy="804672"/>
+            <a:off x="2492602" y="2953512"/>
+            <a:ext cx="1541626" cy="868680"/>
           </a:xfrm>
           <a:prstGeom prst="roundRect">
             <a:avLst>
@@ -4441,14 +4713,14 @@
       </p:sp>
       <p:sp>
         <p:nvSpPr>
-          <p:cNvPr id="33" name="Rectangle 32"/>
+          <p:cNvPr id="42" name="Rectangle 41"/>
           <p:cNvSpPr/>
           <p:nvPr/>
         </p:nvSpPr>
         <p:spPr>
           <a:xfrm>
-            <a:off x="2492602" y="2907792"/>
-            <a:ext cx="50292" cy="621792"/>
+            <a:off x="2492602" y="3044952"/>
+            <a:ext cx="50292" cy="685800"/>
           </a:xfrm>
           <a:prstGeom prst="rect">
             <a:avLst/>
@@ -4482,16 +4754,40 @@
           </a:p>
         </p:txBody>
       </p:sp>
-      <p:sp>
-        <p:nvSpPr>
-          <p:cNvPr id="34" name="TextBox 33"/>
+      <p:pic>
+        <p:nvPicPr>
+          <p:cNvPr id="43" name="Picture 42" descr="kafka.png"/>
+          <p:cNvPicPr>
+            <a:picLocks noChangeAspect="1"/>
+          </p:cNvPicPr>
+          <p:nvPr/>
+        </p:nvPicPr>
+        <p:blipFill>
+          <a:blip r:embed="rId6"/>
+          <a:stretch>
+            <a:fillRect/>
+          </a:stretch>
+        </p:blipFill>
+        <p:spPr>
+          <a:xfrm>
+            <a:off x="2620618" y="3223260"/>
+            <a:ext cx="329184" cy="329184"/>
+          </a:xfrm>
+          <a:prstGeom prst="rect">
+            <a:avLst/>
+          </a:prstGeom>
+        </p:spPr>
+      </p:pic>
+      <p:sp>
+        <p:nvSpPr>
+          <p:cNvPr id="44" name="TextBox 43"/>
           <p:cNvSpPr txBox="1"/>
           <p:nvPr/>
         </p:nvSpPr>
         <p:spPr>
           <a:xfrm>
-            <a:off x="2638906" y="2926080"/>
-            <a:ext cx="1303882" cy="640080"/>
+            <a:off x="3022954" y="3063240"/>
+            <a:ext cx="919834" cy="704088"/>
           </a:xfrm>
           <a:prstGeom prst="rect">
             <a:avLst/>
@@ -4519,7 +4815,7 @@
                 </a:solidFill>
                 <a:latin typeface="Calibri"/>
               </a:rPr>
-              <a:t>Message queue</a:t>
+              <a:t>Kafka / MQ</a:t>
             </a:r>
           </a:p>
           <a:p>
@@ -4538,21 +4834,21 @@
                 </a:solidFill>
                 <a:latin typeface="Calibri"/>
               </a:rPr>
-              <a:t>Kafka async stream</a:t>
-            </a:r>
-          </a:p>
-        </p:txBody>
-      </p:sp>
-      <p:sp>
-        <p:nvSpPr>
-          <p:cNvPr id="35" name="Rounded Rectangle 34"/>
+              <a:t>Async event stream</a:t>
+            </a:r>
+          </a:p>
+        </p:txBody>
+      </p:sp>
+      <p:sp>
+        <p:nvSpPr>
+          <p:cNvPr id="45" name="Rounded Rectangle 44"/>
           <p:cNvSpPr/>
           <p:nvPr/>
         </p:nvSpPr>
         <p:spPr>
           <a:xfrm>
-            <a:off x="2492602" y="3730752"/>
-            <a:ext cx="1541626" cy="804672"/>
+            <a:off x="2492602" y="3913632"/>
+            <a:ext cx="1541626" cy="868680"/>
           </a:xfrm>
           <a:prstGeom prst="roundRect">
             <a:avLst>
@@ -4592,14 +4888,14 @@
       </p:sp>
       <p:sp>
         <p:nvSpPr>
-          <p:cNvPr id="36" name="Rectangle 35"/>
+          <p:cNvPr id="46" name="Rectangle 45"/>
           <p:cNvSpPr/>
           <p:nvPr/>
         </p:nvSpPr>
         <p:spPr>
           <a:xfrm>
-            <a:off x="2492602" y="3822192"/>
-            <a:ext cx="50292" cy="621792"/>
+            <a:off x="2492602" y="4005072"/>
+            <a:ext cx="50292" cy="685800"/>
           </a:xfrm>
           <a:prstGeom prst="rect">
             <a:avLst/>
@@ -4633,16 +4929,40 @@
           </a:p>
         </p:txBody>
       </p:sp>
-      <p:sp>
-        <p:nvSpPr>
-          <p:cNvPr id="37" name="TextBox 36"/>
+      <p:pic>
+        <p:nvPicPr>
+          <p:cNvPr id="47" name="Picture 46" descr="file.png"/>
+          <p:cNvPicPr>
+            <a:picLocks noChangeAspect="1"/>
+          </p:cNvPicPr>
+          <p:nvPr/>
+        </p:nvPicPr>
+        <p:blipFill>
+          <a:blip r:embed="rId7"/>
+          <a:stretch>
+            <a:fillRect/>
+          </a:stretch>
+        </p:blipFill>
+        <p:spPr>
+          <a:xfrm>
+            <a:off x="2620618" y="4183380"/>
+            <a:ext cx="329184" cy="329184"/>
+          </a:xfrm>
+          <a:prstGeom prst="rect">
+            <a:avLst/>
+          </a:prstGeom>
+        </p:spPr>
+      </p:pic>
+      <p:sp>
+        <p:nvSpPr>
+          <p:cNvPr id="48" name="TextBox 47"/>
           <p:cNvSpPr txBox="1"/>
           <p:nvPr/>
         </p:nvSpPr>
         <p:spPr>
           <a:xfrm>
-            <a:off x="2638906" y="3840480"/>
-            <a:ext cx="1303882" cy="640080"/>
+            <a:off x="3022954" y="4023360"/>
+            <a:ext cx="919834" cy="704088"/>
           </a:xfrm>
           <a:prstGeom prst="rect">
             <a:avLst/>
@@ -4696,14 +5016,14 @@
       </p:sp>
       <p:sp>
         <p:nvSpPr>
-          <p:cNvPr id="38" name="TextBox 37"/>
+          <p:cNvPr id="49" name="TextBox 48"/>
           <p:cNvSpPr txBox="1"/>
           <p:nvPr/>
         </p:nvSpPr>
         <p:spPr>
           <a:xfrm>
-            <a:off x="2492602" y="4828032"/>
-            <a:ext cx="1541626" cy="777240"/>
+            <a:off x="2492602" y="5056632"/>
+            <a:ext cx="1541626" cy="640080"/>
           </a:xfrm>
           <a:prstGeom prst="rect">
             <a:avLst/>
@@ -4724,8 +5044,7 @@
                 </a:solidFill>
                 <a:latin typeface="Calibri"/>
               </a:rPr>
-              <a:t>Idempotent calls
-ownerId + use-case code
+              <a:t>Idempotent · ownerId + code
 No hand-built JSON</a:t>
             </a:r>
           </a:p>
@@ -4733,7 +5052,7 @@
       </p:sp>
       <p:sp>
         <p:nvSpPr>
-          <p:cNvPr id="39" name="Right Arrow 38"/>
+          <p:cNvPr id="50" name="Right Arrow 49"/>
           <p:cNvSpPr/>
           <p:nvPr/>
         </p:nvSpPr>
@@ -4776,7 +5095,7 @@
       </p:sp>
       <p:sp>
         <p:nvSpPr>
-          <p:cNvPr id="40" name="Right Arrow 39"/>
+          <p:cNvPr id="51" name="Right Arrow 50"/>
           <p:cNvSpPr/>
           <p:nvPr/>
         </p:nvSpPr>
@@ -4819,7 +5138,7 @@
       </p:sp>
       <p:sp>
         <p:nvSpPr>
-          <p:cNvPr id="41" name="Right Arrow 40"/>
+          <p:cNvPr id="52" name="Right Arrow 51"/>
           <p:cNvSpPr/>
           <p:nvPr/>
         </p:nvSpPr>
@@ -4862,7 +5181,7 @@
       </p:sp>
       <p:sp>
         <p:nvSpPr>
-          <p:cNvPr id="42" name="Right Arrow 41"/>
+          <p:cNvPr id="53" name="Right Arrow 52"/>
           <p:cNvSpPr/>
           <p:nvPr/>
         </p:nvSpPr>
@@ -4905,7 +5224,7 @@
       </p:sp>
       <p:sp>
         <p:nvSpPr>
-          <p:cNvPr id="43" name="Rounded Rectangle 42"/>
+          <p:cNvPr id="54" name="Rounded Rectangle 53"/>
           <p:cNvSpPr/>
           <p:nvPr/>
         </p:nvSpPr>
@@ -4952,7 +5271,7 @@
       </p:sp>
       <p:sp>
         <p:nvSpPr>
-          <p:cNvPr id="44" name="Rounded Rectangle 43"/>
+          <p:cNvPr id="55" name="Rounded Rectangle 54"/>
           <p:cNvSpPr/>
           <p:nvPr/>
         </p:nvSpPr>
@@ -4999,7 +5318,7 @@
       </p:sp>
       <p:sp>
         <p:nvSpPr>
-          <p:cNvPr id="45" name="TextBox 44"/>
+          <p:cNvPr id="56" name="TextBox 55"/>
           <p:cNvSpPr txBox="1"/>
           <p:nvPr/>
         </p:nvSpPr>
@@ -5034,7 +5353,7 @@
       </p:sp>
       <p:sp>
         <p:nvSpPr>
-          <p:cNvPr id="46" name="TextBox 45"/>
+          <p:cNvPr id="57" name="TextBox 56"/>
           <p:cNvSpPr txBox="1"/>
           <p:nvPr/>
         </p:nvSpPr>
@@ -5069,7 +5388,7 @@
       </p:sp>
       <p:sp>
         <p:nvSpPr>
-          <p:cNvPr id="47" name="Rounded Rectangle 46"/>
+          <p:cNvPr id="58" name="Rounded Rectangle 57"/>
           <p:cNvSpPr/>
           <p:nvPr/>
         </p:nvSpPr>
@@ -5116,7 +5435,7 @@
       </p:sp>
       <p:sp>
         <p:nvSpPr>
-          <p:cNvPr id="48" name="Rectangle 47"/>
+          <p:cNvPr id="59" name="Rectangle 58"/>
           <p:cNvSpPr/>
           <p:nvPr/>
         </p:nvSpPr>
@@ -5159,7 +5478,7 @@
       </p:sp>
       <p:sp>
         <p:nvSpPr>
-          <p:cNvPr id="49" name="TextBox 48"/>
+          <p:cNvPr id="60" name="TextBox 59"/>
           <p:cNvSpPr txBox="1"/>
           <p:nvPr/>
         </p:nvSpPr>
@@ -5220,7 +5539,7 @@
       </p:sp>
       <p:sp>
         <p:nvSpPr>
-          <p:cNvPr id="50" name="Rounded Rectangle 49"/>
+          <p:cNvPr id="61" name="Rounded Rectangle 60"/>
           <p:cNvSpPr/>
           <p:nvPr/>
         </p:nvSpPr>
@@ -5267,7 +5586,7 @@
       </p:sp>
       <p:sp>
         <p:nvSpPr>
-          <p:cNvPr id="51" name="Rectangle 50"/>
+          <p:cNvPr id="62" name="Rectangle 61"/>
           <p:cNvSpPr/>
           <p:nvPr/>
         </p:nvSpPr>
@@ -5310,7 +5629,7 @@
       </p:sp>
       <p:sp>
         <p:nvSpPr>
-          <p:cNvPr id="52" name="TextBox 51"/>
+          <p:cNvPr id="63" name="TextBox 62"/>
           <p:cNvSpPr txBox="1"/>
           <p:nvPr/>
         </p:nvSpPr>
@@ -5371,7 +5690,7 @@
       </p:sp>
       <p:sp>
         <p:nvSpPr>
-          <p:cNvPr id="53" name="Rounded Rectangle 52"/>
+          <p:cNvPr id="64" name="Rounded Rectangle 63"/>
           <p:cNvSpPr/>
           <p:nvPr/>
         </p:nvSpPr>
@@ -5418,7 +5737,7 @@
       </p:sp>
       <p:sp>
         <p:nvSpPr>
-          <p:cNvPr id="54" name="Rectangle 53"/>
+          <p:cNvPr id="65" name="Rectangle 64"/>
           <p:cNvSpPr/>
           <p:nvPr/>
         </p:nvSpPr>
@@ -5461,7 +5780,7 @@
       </p:sp>
       <p:sp>
         <p:nvSpPr>
-          <p:cNvPr id="55" name="TextBox 54"/>
+          <p:cNvPr id="66" name="TextBox 65"/>
           <p:cNvSpPr txBox="1"/>
           <p:nvPr/>
         </p:nvSpPr>
@@ -5522,7 +5841,7 @@
       </p:sp>
       <p:sp>
         <p:nvSpPr>
-          <p:cNvPr id="56" name="Rounded Rectangle 55"/>
+          <p:cNvPr id="67" name="Rounded Rectangle 66"/>
           <p:cNvSpPr/>
           <p:nvPr/>
         </p:nvSpPr>
@@ -5569,7 +5888,7 @@
       </p:sp>
       <p:sp>
         <p:nvSpPr>
-          <p:cNvPr id="57" name="Rectangle 56"/>
+          <p:cNvPr id="68" name="Rectangle 67"/>
           <p:cNvSpPr/>
           <p:nvPr/>
         </p:nvSpPr>
@@ -5612,7 +5931,7 @@
       </p:sp>
       <p:sp>
         <p:nvSpPr>
-          <p:cNvPr id="58" name="TextBox 57"/>
+          <p:cNvPr id="69" name="TextBox 68"/>
           <p:cNvSpPr txBox="1"/>
           <p:nvPr/>
         </p:nvSpPr>
@@ -5673,7 +5992,7 @@
       </p:sp>
       <p:sp>
         <p:nvSpPr>
-          <p:cNvPr id="59" name="Rounded Rectangle 58"/>
+          <p:cNvPr id="70" name="Rounded Rectangle 69"/>
           <p:cNvSpPr/>
           <p:nvPr/>
         </p:nvSpPr>
@@ -5720,7 +6039,7 @@
       </p:sp>
       <p:sp>
         <p:nvSpPr>
-          <p:cNvPr id="60" name="Rectangle 59"/>
+          <p:cNvPr id="71" name="Rectangle 70"/>
           <p:cNvSpPr/>
           <p:nvPr/>
         </p:nvSpPr>
@@ -5763,7 +6082,7 @@
       </p:sp>
       <p:sp>
         <p:nvSpPr>
-          <p:cNvPr id="61" name="TextBox 60"/>
+          <p:cNvPr id="72" name="TextBox 71"/>
           <p:cNvSpPr txBox="1"/>
           <p:nvPr/>
         </p:nvSpPr>
@@ -5824,7 +6143,7 @@
       </p:sp>
       <p:sp>
         <p:nvSpPr>
-          <p:cNvPr id="62" name="Rounded Rectangle 61"/>
+          <p:cNvPr id="73" name="Rounded Rectangle 72"/>
           <p:cNvSpPr/>
           <p:nvPr/>
         </p:nvSpPr>
@@ -5871,7 +6190,7 @@
       </p:sp>
       <p:sp>
         <p:nvSpPr>
-          <p:cNvPr id="63" name="Rectangle 62"/>
+          <p:cNvPr id="74" name="Rectangle 73"/>
           <p:cNvSpPr/>
           <p:nvPr/>
         </p:nvSpPr>
@@ -5914,7 +6233,7 @@
       </p:sp>
       <p:sp>
         <p:nvSpPr>
-          <p:cNvPr id="64" name="TextBox 63"/>
+          <p:cNvPr id="75" name="TextBox 74"/>
           <p:cNvSpPr txBox="1"/>
           <p:nvPr/>
         </p:nvSpPr>
@@ -5975,7 +6294,7 @@
       </p:sp>
       <p:sp>
         <p:nvSpPr>
-          <p:cNvPr id="65" name="Rounded Rectangle 64"/>
+          <p:cNvPr id="76" name="Rounded Rectangle 75"/>
           <p:cNvSpPr/>
           <p:nvPr/>
         </p:nvSpPr>
@@ -6022,7 +6341,7 @@
       </p:sp>
       <p:sp>
         <p:nvSpPr>
-          <p:cNvPr id="66" name="TextBox 65"/>
+          <p:cNvPr id="77" name="TextBox 76"/>
           <p:cNvSpPr txBox="1"/>
           <p:nvPr/>
         </p:nvSpPr>
@@ -6057,7 +6376,7 @@
       </p:sp>
       <p:sp>
         <p:nvSpPr>
-          <p:cNvPr id="67" name="TextBox 66"/>
+          <p:cNvPr id="78" name="TextBox 77"/>
           <p:cNvSpPr txBox="1"/>
           <p:nvPr/>
         </p:nvSpPr>
@@ -6093,7 +6412,7 @@
       </p:sp>
       <p:sp>
         <p:nvSpPr>
-          <p:cNvPr id="68" name="Right Arrow 67"/>
+          <p:cNvPr id="79" name="Right Arrow 78"/>
           <p:cNvSpPr/>
           <p:nvPr/>
         </p:nvSpPr>
@@ -6136,7 +6455,7 @@
       </p:sp>
       <p:sp>
         <p:nvSpPr>
-          <p:cNvPr id="69" name="Right Arrow 68"/>
+          <p:cNvPr id="80" name="Right Arrow 79"/>
           <p:cNvSpPr/>
           <p:nvPr/>
         </p:nvSpPr>
@@ -6179,7 +6498,7 @@
       </p:sp>
       <p:sp>
         <p:nvSpPr>
-          <p:cNvPr id="70" name="Rounded Rectangle 69"/>
+          <p:cNvPr id="81" name="Rounded Rectangle 80"/>
           <p:cNvSpPr/>
           <p:nvPr/>
         </p:nvSpPr>
@@ -6226,7 +6545,7 @@
       </p:sp>
       <p:sp>
         <p:nvSpPr>
-          <p:cNvPr id="71" name="Oval 70"/>
+          <p:cNvPr id="82" name="Oval 81"/>
           <p:cNvSpPr/>
           <p:nvPr/>
         </p:nvSpPr>
@@ -6269,7 +6588,7 @@
       </p:sp>
       <p:sp>
         <p:nvSpPr>
-          <p:cNvPr id="72" name="TextBox 71"/>
+          <p:cNvPr id="83" name="TextBox 82"/>
           <p:cNvSpPr txBox="1"/>
           <p:nvPr/>
         </p:nvSpPr>
@@ -6304,7 +6623,7 @@
       </p:sp>
       <p:sp>
         <p:nvSpPr>
-          <p:cNvPr id="73" name="TextBox 72"/>
+          <p:cNvPr id="84" name="TextBox 83"/>
           <p:cNvSpPr txBox="1"/>
           <p:nvPr/>
         </p:nvSpPr>
@@ -6339,7 +6658,7 @@
       </p:sp>
       <p:sp>
         <p:nvSpPr>
-          <p:cNvPr id="74" name="TextBox 73"/>
+          <p:cNvPr id="85" name="TextBox 84"/>
           <p:cNvSpPr txBox="1"/>
           <p:nvPr/>
         </p:nvSpPr>
@@ -6375,7 +6694,7 @@
       </p:sp>
       <p:sp>
         <p:nvSpPr>
-          <p:cNvPr id="75" name="Rounded Rectangle 74"/>
+          <p:cNvPr id="86" name="Rounded Rectangle 85"/>
           <p:cNvSpPr/>
           <p:nvPr/>
         </p:nvSpPr>
@@ -6422,7 +6741,7 @@
       </p:sp>
       <p:sp>
         <p:nvSpPr>
-          <p:cNvPr id="76" name="Rectangle 75"/>
+          <p:cNvPr id="87" name="Rectangle 86"/>
           <p:cNvSpPr/>
           <p:nvPr/>
         </p:nvSpPr>
@@ -6465,7 +6784,7 @@
       </p:sp>
       <p:sp>
         <p:nvSpPr>
-          <p:cNvPr id="77" name="TextBox 76"/>
+          <p:cNvPr id="88" name="TextBox 87"/>
           <p:cNvSpPr txBox="1"/>
           <p:nvPr/>
         </p:nvSpPr>
@@ -6526,7 +6845,7 @@
       </p:sp>
       <p:sp>
         <p:nvSpPr>
-          <p:cNvPr id="78" name="Rounded Rectangle 77"/>
+          <p:cNvPr id="89" name="Rounded Rectangle 88"/>
           <p:cNvSpPr/>
           <p:nvPr/>
         </p:nvSpPr>
@@ -6573,7 +6892,7 @@
       </p:sp>
       <p:sp>
         <p:nvSpPr>
-          <p:cNvPr id="79" name="Rectangle 78"/>
+          <p:cNvPr id="90" name="Rectangle 89"/>
           <p:cNvSpPr/>
           <p:nvPr/>
         </p:nvSpPr>
@@ -6616,7 +6935,7 @@
       </p:sp>
       <p:sp>
         <p:nvSpPr>
-          <p:cNvPr id="80" name="TextBox 79"/>
+          <p:cNvPr id="91" name="TextBox 90"/>
           <p:cNvSpPr txBox="1"/>
           <p:nvPr/>
         </p:nvSpPr>
@@ -6677,7 +6996,7 @@
       </p:sp>
       <p:sp>
         <p:nvSpPr>
-          <p:cNvPr id="81" name="Rounded Rectangle 80"/>
+          <p:cNvPr id="92" name="Rounded Rectangle 91"/>
           <p:cNvSpPr/>
           <p:nvPr/>
         </p:nvSpPr>
@@ -6724,7 +7043,7 @@
       </p:sp>
       <p:sp>
         <p:nvSpPr>
-          <p:cNvPr id="82" name="Rectangle 81"/>
+          <p:cNvPr id="93" name="Rectangle 92"/>
           <p:cNvSpPr/>
           <p:nvPr/>
         </p:nvSpPr>
@@ -6767,7 +7086,7 @@
       </p:sp>
       <p:sp>
         <p:nvSpPr>
-          <p:cNvPr id="83" name="TextBox 82"/>
+          <p:cNvPr id="94" name="TextBox 93"/>
           <p:cNvSpPr txBox="1"/>
           <p:nvPr/>
         </p:nvSpPr>
@@ -6828,7 +7147,7 @@
       </p:sp>
       <p:sp>
         <p:nvSpPr>
-          <p:cNvPr id="84" name="Right Arrow 83"/>
+          <p:cNvPr id="95" name="Right Arrow 94"/>
           <p:cNvSpPr/>
           <p:nvPr/>
         </p:nvSpPr>
@@ -6871,7 +7190,7 @@
       </p:sp>
       <p:sp>
         <p:nvSpPr>
-          <p:cNvPr id="85" name="Right Arrow 84"/>
+          <p:cNvPr id="96" name="Right Arrow 95"/>
           <p:cNvSpPr/>
           <p:nvPr/>
         </p:nvSpPr>
@@ -6914,7 +7233,7 @@
       </p:sp>
       <p:sp>
         <p:nvSpPr>
-          <p:cNvPr id="86" name="Rounded Rectangle 85"/>
+          <p:cNvPr id="97" name="Rounded Rectangle 96"/>
           <p:cNvSpPr/>
           <p:nvPr/>
         </p:nvSpPr>
@@ -6961,7 +7280,7 @@
       </p:sp>
       <p:sp>
         <p:nvSpPr>
-          <p:cNvPr id="87" name="Oval 86"/>
+          <p:cNvPr id="98" name="Oval 97"/>
           <p:cNvSpPr/>
           <p:nvPr/>
         </p:nvSpPr>
@@ -7004,7 +7323,7 @@
       </p:sp>
       <p:sp>
         <p:nvSpPr>
-          <p:cNvPr id="88" name="TextBox 87"/>
+          <p:cNvPr id="99" name="TextBox 98"/>
           <p:cNvSpPr txBox="1"/>
           <p:nvPr/>
         </p:nvSpPr>
@@ -7039,7 +7358,7 @@
       </p:sp>
       <p:sp>
         <p:nvSpPr>
-          <p:cNvPr id="89" name="TextBox 88"/>
+          <p:cNvPr id="100" name="TextBox 99"/>
           <p:cNvSpPr txBox="1"/>
           <p:nvPr/>
         </p:nvSpPr>
@@ -7074,7 +7393,7 @@
       </p:sp>
       <p:sp>
         <p:nvSpPr>
-          <p:cNvPr id="90" name="TextBox 89"/>
+          <p:cNvPr id="101" name="TextBox 100"/>
           <p:cNvSpPr txBox="1"/>
           <p:nvPr/>
         </p:nvSpPr>
@@ -7110,7 +7429,7 @@
       </p:sp>
       <p:sp>
         <p:nvSpPr>
-          <p:cNvPr id="91" name="Rounded Rectangle 90"/>
+          <p:cNvPr id="102" name="Rounded Rectangle 101"/>
           <p:cNvSpPr/>
           <p:nvPr/>
         </p:nvSpPr>
@@ -7157,7 +7476,7 @@
       </p:sp>
       <p:sp>
         <p:nvSpPr>
-          <p:cNvPr id="92" name="Rectangle 91"/>
+          <p:cNvPr id="103" name="Rectangle 102"/>
           <p:cNvSpPr/>
           <p:nvPr/>
         </p:nvSpPr>
@@ -7200,7 +7519,7 @@
       </p:sp>
       <p:sp>
         <p:nvSpPr>
-          <p:cNvPr id="93" name="TextBox 92"/>
+          <p:cNvPr id="104" name="TextBox 103"/>
           <p:cNvSpPr txBox="1"/>
           <p:nvPr/>
         </p:nvSpPr>
@@ -7261,7 +7580,7 @@
       </p:sp>
       <p:sp>
         <p:nvSpPr>
-          <p:cNvPr id="94" name="Rounded Rectangle 93"/>
+          <p:cNvPr id="105" name="Rounded Rectangle 104"/>
           <p:cNvSpPr/>
           <p:nvPr/>
         </p:nvSpPr>
@@ -7308,7 +7627,7 @@
       </p:sp>
       <p:sp>
         <p:nvSpPr>
-          <p:cNvPr id="95" name="Rectangle 94"/>
+          <p:cNvPr id="106" name="Rectangle 105"/>
           <p:cNvSpPr/>
           <p:nvPr/>
         </p:nvSpPr>
@@ -7351,7 +7670,7 @@
       </p:sp>
       <p:sp>
         <p:nvSpPr>
-          <p:cNvPr id="96" name="TextBox 95"/>
+          <p:cNvPr id="107" name="TextBox 106"/>
           <p:cNvSpPr txBox="1"/>
           <p:nvPr/>
         </p:nvSpPr>
@@ -7412,7 +7731,7 @@
       </p:sp>
       <p:sp>
         <p:nvSpPr>
-          <p:cNvPr id="97" name="Rounded Rectangle 96"/>
+          <p:cNvPr id="108" name="Rounded Rectangle 107"/>
           <p:cNvSpPr/>
           <p:nvPr/>
         </p:nvSpPr>
@@ -7459,7 +7778,7 @@
       </p:sp>
       <p:sp>
         <p:nvSpPr>
-          <p:cNvPr id="98" name="Rectangle 97"/>
+          <p:cNvPr id="109" name="Rectangle 108"/>
           <p:cNvSpPr/>
           <p:nvPr/>
         </p:nvSpPr>
@@ -7502,7 +7821,7 @@
       </p:sp>
       <p:sp>
         <p:nvSpPr>
-          <p:cNvPr id="99" name="TextBox 98"/>
+          <p:cNvPr id="110" name="TextBox 109"/>
           <p:cNvSpPr txBox="1"/>
           <p:nvPr/>
         </p:nvSpPr>
@@ -7563,7 +7882,7 @@
       </p:sp>
       <p:sp>
         <p:nvSpPr>
-          <p:cNvPr id="100" name="Rounded Rectangle 99"/>
+          <p:cNvPr id="111" name="Rounded Rectangle 110"/>
           <p:cNvSpPr/>
           <p:nvPr/>
         </p:nvSpPr>
@@ -7610,7 +7929,7 @@
       </p:sp>
       <p:sp>
         <p:nvSpPr>
-          <p:cNvPr id="101" name="Rectangle 100"/>
+          <p:cNvPr id="112" name="Rectangle 111"/>
           <p:cNvSpPr/>
           <p:nvPr/>
         </p:nvSpPr>
@@ -7653,7 +7972,7 @@
       </p:sp>
       <p:sp>
         <p:nvSpPr>
-          <p:cNvPr id="102" name="TextBox 101"/>
+          <p:cNvPr id="113" name="TextBox 112"/>
           <p:cNvSpPr txBox="1"/>
           <p:nvPr/>
         </p:nvSpPr>
@@ -7714,7 +8033,7 @@
       </p:sp>
       <p:sp>
         <p:nvSpPr>
-          <p:cNvPr id="103" name="Rounded Rectangle 102"/>
+          <p:cNvPr id="114" name="Rounded Rectangle 113"/>
           <p:cNvSpPr/>
           <p:nvPr/>
         </p:nvSpPr>
@@ -7761,7 +8080,7 @@
       </p:sp>
       <p:sp>
         <p:nvSpPr>
-          <p:cNvPr id="104" name="Oval 103"/>
+          <p:cNvPr id="115" name="Oval 114"/>
           <p:cNvSpPr/>
           <p:nvPr/>
         </p:nvSpPr>
@@ -7804,7 +8123,7 @@
       </p:sp>
       <p:sp>
         <p:nvSpPr>
-          <p:cNvPr id="105" name="Oval 104"/>
+          <p:cNvPr id="116" name="Oval 115"/>
           <p:cNvSpPr/>
           <p:nvPr/>
         </p:nvSpPr>
@@ -7847,7 +8166,7 @@
       </p:sp>
       <p:sp>
         <p:nvSpPr>
-          <p:cNvPr id="106" name="Oval 105"/>
+          <p:cNvPr id="117" name="Oval 116"/>
           <p:cNvSpPr/>
           <p:nvPr/>
         </p:nvSpPr>
@@ -7890,7 +8209,7 @@
       </p:sp>
       <p:sp>
         <p:nvSpPr>
-          <p:cNvPr id="107" name="Oval 106"/>
+          <p:cNvPr id="118" name="Oval 117"/>
           <p:cNvSpPr/>
           <p:nvPr/>
         </p:nvSpPr>
@@ -7933,7 +8252,7 @@
       </p:sp>
       <p:sp>
         <p:nvSpPr>
-          <p:cNvPr id="108" name="Oval 107"/>
+          <p:cNvPr id="119" name="Oval 118"/>
           <p:cNvSpPr/>
           <p:nvPr/>
         </p:nvSpPr>
@@ -7974,16 +8293,88 @@
           </a:p>
         </p:txBody>
       </p:sp>
-      <p:sp>
-        <p:nvSpPr>
-          <p:cNvPr id="109" name="TextBox 108"/>
+      <p:pic>
+        <p:nvPicPr>
+          <p:cNvPr id="120" name="Picture 119" descr="sdk.png"/>
+          <p:cNvPicPr>
+            <a:picLocks noChangeAspect="1"/>
+          </p:cNvPicPr>
+          <p:nvPr/>
+        </p:nvPicPr>
+        <p:blipFill>
+          <a:blip r:embed="rId4"/>
+          <a:stretch>
+            <a:fillRect/>
+          </a:stretch>
+        </p:blipFill>
+        <p:spPr>
+          <a:xfrm>
+            <a:off x="1828800" y="6181344"/>
+            <a:ext cx="256032" cy="256032"/>
+          </a:xfrm>
+          <a:prstGeom prst="rect">
+            <a:avLst/>
+          </a:prstGeom>
+        </p:spPr>
+      </p:pic>
+      <p:pic>
+        <p:nvPicPr>
+          <p:cNvPr id="121" name="Picture 120" descr="rest.png"/>
+          <p:cNvPicPr>
+            <a:picLocks noChangeAspect="1"/>
+          </p:cNvPicPr>
+          <p:nvPr/>
+        </p:nvPicPr>
+        <p:blipFill>
+          <a:blip r:embed="rId5"/>
+          <a:stretch>
+            <a:fillRect/>
+          </a:stretch>
+        </p:blipFill>
+        <p:spPr>
+          <a:xfrm>
+            <a:off x="2148840" y="6181344"/>
+            <a:ext cx="256032" cy="256032"/>
+          </a:xfrm>
+          <a:prstGeom prst="rect">
+            <a:avLst/>
+          </a:prstGeom>
+        </p:spPr>
+      </p:pic>
+      <p:pic>
+        <p:nvPicPr>
+          <p:cNvPr id="122" name="Picture 121" descr="kafka.png"/>
+          <p:cNvPicPr>
+            <a:picLocks noChangeAspect="1"/>
+          </p:cNvPicPr>
+          <p:nvPr/>
+        </p:nvPicPr>
+        <p:blipFill>
+          <a:blip r:embed="rId6"/>
+          <a:stretch>
+            <a:fillRect/>
+          </a:stretch>
+        </p:blipFill>
+        <p:spPr>
+          <a:xfrm>
+            <a:off x="2468880" y="6181344"/>
+            <a:ext cx="256032" cy="256032"/>
+          </a:xfrm>
+          <a:prstGeom prst="rect">
+            <a:avLst/>
+          </a:prstGeom>
+        </p:spPr>
+      </p:pic>
+      <p:sp>
+        <p:nvSpPr>
+          <p:cNvPr id="123" name="TextBox 122"/>
           <p:cNvSpPr txBox="1"/>
           <p:nvPr/>
         </p:nvSpPr>
         <p:spPr>
           <a:xfrm>
-            <a:off x="1783080" y="6199632"/>
-            <a:ext cx="8229600" cy="292608"/>
+            <a:off x="2834640" y="6199632"/>
+            <a:ext cx="7315200" cy="292608"/>
           </a:xfrm>
           <a:prstGeom prst="rect">
             <a:avLst/>
@@ -8004,14 +8395,14 @@
                 </a:solidFill>
                 <a:latin typeface="Calibri"/>
               </a:rPr>
-              <a:t>LedgeRX = product hub     ·     one Landing interface on UAF side     ·     then UAF systems fan-out</a:t>
-            </a:r>
-          </a:p>
-        </p:txBody>
-      </p:sp>
-      <p:sp>
-        <p:nvSpPr>
-          <p:cNvPr id="110" name="TextBox 109"/>
+              <a:t>SDK · REST · Kafka     ·     one Landing interface     ·     UAF fan-out behind the hub</a:t>
+            </a:r>
+          </a:p>
+        </p:txBody>
+      </p:sp>
+      <p:sp>
+        <p:nvSpPr>
+          <p:cNvPr id="124" name="TextBox 123"/>
           <p:cNvSpPr txBox="1"/>
           <p:nvPr/>
         </p:nvSpPr>
@@ -8157,7 +8548,7 @@
         <p:spPr>
           <a:xfrm>
             <a:off x="365760" y="128016"/>
-            <a:ext cx="9326880" cy="292608"/>
+            <a:ext cx="8686800" cy="274320"/>
           </a:xfrm>
           <a:prstGeom prst="rect">
             <a:avLst/>
@@ -8183,16 +8574,40 @@
           </a:p>
         </p:txBody>
       </p:sp>
-      <p:sp>
-        <p:nvSpPr>
-          <p:cNvPr id="5" name="TextBox 4"/>
+      <p:pic>
+        <p:nvPicPr>
+          <p:cNvPr id="5" name="Picture 4" descr="uaf.png"/>
+          <p:cNvPicPr>
+            <a:picLocks noChangeAspect="1"/>
+          </p:cNvPicPr>
+          <p:nvPr/>
+        </p:nvPicPr>
+        <p:blipFill>
+          <a:blip r:embed="rId2"/>
+          <a:stretch>
+            <a:fillRect/>
+          </a:stretch>
+        </p:blipFill>
+        <p:spPr>
+          <a:xfrm>
+            <a:off x="8732520" y="128016"/>
+            <a:ext cx="310896" cy="310896"/>
+          </a:xfrm>
+          <a:prstGeom prst="rect">
+            <a:avLst/>
+          </a:prstGeom>
+        </p:spPr>
+      </p:pic>
+      <p:sp>
+        <p:nvSpPr>
+          <p:cNvPr id="6" name="TextBox 5"/>
           <p:cNvSpPr txBox="1"/>
           <p:nvPr/>
         </p:nvSpPr>
         <p:spPr>
           <a:xfrm>
-            <a:off x="365760" y="420624"/>
-            <a:ext cx="9326880" cy="237744"/>
+            <a:off x="9098280" y="164592"/>
+            <a:ext cx="502920" cy="237744"/>
           </a:xfrm>
           <a:prstGeom prst="rect">
             <a:avLst/>
@@ -8207,6 +8622,100 @@
           <a:p>
             <a:pPr algn="l"/>
             <a:r>
+              <a:rPr sz="1100" b="1">
+                <a:solidFill>
+                  <a:srgbClr val="2DD4BF"/>
+                </a:solidFill>
+                <a:latin typeface="Calibri"/>
+              </a:rPr>
+              <a:t>UAF</a:t>
+            </a:r>
+          </a:p>
+        </p:txBody>
+      </p:sp>
+      <p:pic>
+        <p:nvPicPr>
+          <p:cNvPr id="7" name="Picture 6" descr="sim.png"/>
+          <p:cNvPicPr>
+            <a:picLocks noChangeAspect="1"/>
+          </p:cNvPicPr>
+          <p:nvPr/>
+        </p:nvPicPr>
+        <p:blipFill>
+          <a:blip r:embed="rId3"/>
+          <a:stretch>
+            <a:fillRect/>
+          </a:stretch>
+        </p:blipFill>
+        <p:spPr>
+          <a:xfrm>
+            <a:off x="9601200" y="128016"/>
+            <a:ext cx="310896" cy="310896"/>
+          </a:xfrm>
+          <a:prstGeom prst="rect">
+            <a:avLst/>
+          </a:prstGeom>
+        </p:spPr>
+      </p:pic>
+      <p:sp>
+        <p:nvSpPr>
+          <p:cNvPr id="8" name="TextBox 7"/>
+          <p:cNvSpPr txBox="1"/>
+          <p:nvPr/>
+        </p:nvSpPr>
+        <p:spPr>
+          <a:xfrm>
+            <a:off x="9966960" y="164592"/>
+            <a:ext cx="411480" cy="237744"/>
+          </a:xfrm>
+          <a:prstGeom prst="rect">
+            <a:avLst/>
+          </a:prstGeom>
+          <a:noFill/>
+        </p:spPr>
+        <p:txBody>
+          <a:bodyPr wrap="square" lIns="0" rIns="0" tIns="0" bIns="0">
+            <a:spAutoFit/>
+          </a:bodyPr>
+          <a:lstStyle/>
+          <a:p>
+            <a:pPr algn="l"/>
+            <a:r>
+              <a:rPr sz="1100" b="1">
+                <a:solidFill>
+                  <a:srgbClr val="38BDF8"/>
+                </a:solidFill>
+                <a:latin typeface="Calibri"/>
+              </a:rPr>
+              <a:t>sim</a:t>
+            </a:r>
+          </a:p>
+        </p:txBody>
+      </p:sp>
+      <p:sp>
+        <p:nvSpPr>
+          <p:cNvPr id="9" name="TextBox 8"/>
+          <p:cNvSpPr txBox="1"/>
+          <p:nvPr/>
+        </p:nvSpPr>
+        <p:spPr>
+          <a:xfrm>
+            <a:off x="365760" y="438912"/>
+            <a:ext cx="9144000" cy="219456"/>
+          </a:xfrm>
+          <a:prstGeom prst="rect">
+            <a:avLst/>
+          </a:prstGeom>
+          <a:noFill/>
+        </p:spPr>
+        <p:txBody>
+          <a:bodyPr wrap="square" lIns="0" rIns="0" tIns="0" bIns="0">
+            <a:spAutoFit/>
+          </a:bodyPr>
+          <a:lstStyle/>
+          <a:p>
+            <a:pPr algn="l"/>
+            <a:r>
               <a:rPr sz="1200" b="0">
                 <a:solidFill>
                   <a:srgbClr val="94A3B8"/>
@@ -8220,14 +8729,14 @@
       </p:sp>
       <p:sp>
         <p:nvSpPr>
-          <p:cNvPr id="6" name="Rounded Rectangle 5"/>
+          <p:cNvPr id="10" name="Rounded Rectangle 9"/>
           <p:cNvSpPr/>
           <p:nvPr/>
         </p:nvSpPr>
         <p:spPr>
           <a:xfrm>
-            <a:off x="10241280" y="146304"/>
-            <a:ext cx="1554480" cy="329184"/>
+            <a:off x="10241280" y="475488"/>
+            <a:ext cx="1554480" cy="292608"/>
           </a:xfrm>
           <a:prstGeom prst="roundRect">
             <a:avLst>
@@ -8267,13 +8776,13 @@
       </p:sp>
       <p:sp>
         <p:nvSpPr>
-          <p:cNvPr id="7" name="TextBox 6"/>
+          <p:cNvPr id="11" name="TextBox 10"/>
           <p:cNvSpPr txBox="1"/>
           <p:nvPr/>
         </p:nvSpPr>
         <p:spPr>
           <a:xfrm>
-            <a:off x="10241280" y="182880"/>
+            <a:off x="10241280" y="493776"/>
             <a:ext cx="1554480" cy="256032"/>
           </a:xfrm>
           <a:prstGeom prst="rect">
@@ -8302,14 +8811,14 @@
       </p:sp>
       <p:sp>
         <p:nvSpPr>
-          <p:cNvPr id="8" name="Rounded Rectangle 7"/>
+          <p:cNvPr id="12" name="Rounded Rectangle 11"/>
           <p:cNvSpPr/>
           <p:nvPr/>
         </p:nvSpPr>
         <p:spPr>
           <a:xfrm>
-            <a:off x="365760" y="777240"/>
-            <a:ext cx="11457432" cy="960120"/>
+            <a:off x="365760" y="804672"/>
+            <a:ext cx="11457432" cy="914400"/>
           </a:xfrm>
           <a:prstGeom prst="roundRect">
             <a:avLst>
@@ -8349,14 +8858,14 @@
       </p:sp>
       <p:sp>
         <p:nvSpPr>
-          <p:cNvPr id="9" name="Rounded Rectangle 8"/>
+          <p:cNvPr id="13" name="Rounded Rectangle 12"/>
           <p:cNvSpPr/>
           <p:nvPr/>
         </p:nvSpPr>
         <p:spPr>
           <a:xfrm>
-            <a:off x="502920" y="905256"/>
-            <a:ext cx="1828800" cy="292608"/>
+            <a:off x="502920" y="914400"/>
+            <a:ext cx="1828800" cy="274320"/>
           </a:xfrm>
           <a:prstGeom prst="roundRect">
             <a:avLst>
@@ -8394,14 +8903,14 @@
       </p:sp>
       <p:sp>
         <p:nvSpPr>
-          <p:cNvPr id="10" name="TextBox 9"/>
+          <p:cNvPr id="14" name="TextBox 13"/>
           <p:cNvSpPr txBox="1"/>
           <p:nvPr/>
         </p:nvSpPr>
         <p:spPr>
           <a:xfrm>
-            <a:off x="502920" y="923544"/>
-            <a:ext cx="1828800" cy="256032"/>
+            <a:off x="502920" y="932688"/>
+            <a:ext cx="1828800" cy="237744"/>
           </a:xfrm>
           <a:prstGeom prst="rect">
             <a:avLst/>
@@ -8429,14 +8938,14 @@
       </p:sp>
       <p:sp>
         <p:nvSpPr>
-          <p:cNvPr id="11" name="TextBox 10"/>
+          <p:cNvPr id="15" name="TextBox 14"/>
           <p:cNvSpPr txBox="1"/>
           <p:nvPr/>
         </p:nvSpPr>
         <p:spPr>
           <a:xfrm>
-            <a:off x="2514600" y="886968"/>
-            <a:ext cx="8961120" cy="274320"/>
+            <a:off x="2514600" y="896112"/>
+            <a:ext cx="8686800" cy="256032"/>
           </a:xfrm>
           <a:prstGeom prst="rect">
             <a:avLst/>
@@ -8462,16 +8971,40 @@
           </a:p>
         </p:txBody>
       </p:sp>
-      <p:sp>
-        <p:nvSpPr>
-          <p:cNvPr id="12" name="TextBox 11"/>
+      <p:pic>
+        <p:nvPicPr>
+          <p:cNvPr id="16" name="Picture 15" descr="kafka.png"/>
+          <p:cNvPicPr>
+            <a:picLocks noChangeAspect="1"/>
+          </p:cNvPicPr>
+          <p:nvPr/>
+        </p:nvPicPr>
+        <p:blipFill>
+          <a:blip r:embed="rId4"/>
+          <a:stretch>
+            <a:fillRect/>
+          </a:stretch>
+        </p:blipFill>
+        <p:spPr>
+          <a:xfrm>
+            <a:off x="2514600" y="1243584"/>
+            <a:ext cx="256032" cy="256032"/>
+          </a:xfrm>
+          <a:prstGeom prst="rect">
+            <a:avLst/>
+          </a:prstGeom>
+        </p:spPr>
+      </p:pic>
+      <p:sp>
+        <p:nvSpPr>
+          <p:cNvPr id="17" name="TextBox 16"/>
           <p:cNvSpPr txBox="1"/>
           <p:nvPr/>
         </p:nvSpPr>
         <p:spPr>
           <a:xfrm>
-            <a:off x="2514600" y="1216152"/>
-            <a:ext cx="8961120" cy="365760"/>
+            <a:off x="2834640" y="1261872"/>
+            <a:ext cx="8503920" cy="256032"/>
           </a:xfrm>
           <a:prstGeom prst="rect">
             <a:avLst/>
@@ -8492,21 +9025,21 @@
                 </a:solidFill>
                 <a:latin typeface="Calibri"/>
               </a:rPr>
-              <a:t>Emits only:  balance.updated  ·  reward redemption request  ·  other ledger outcomes   (Kafka / webhook)</a:t>
-            </a:r>
-          </a:p>
-        </p:txBody>
-      </p:sp>
-      <p:sp>
-        <p:nvSpPr>
-          <p:cNvPr id="13" name="Down Arrow 12"/>
+              <a:t>Emits:  balance.updated  ·  reward redemption request  ·  ledger outcomes   (Kafka / webhook)</a:t>
+            </a:r>
+          </a:p>
+        </p:txBody>
+      </p:sp>
+      <p:sp>
+        <p:nvSpPr>
+          <p:cNvPr id="18" name="Down Arrow 17"/>
           <p:cNvSpPr/>
           <p:nvPr/>
         </p:nvSpPr>
         <p:spPr>
           <a:xfrm>
-            <a:off x="5943600" y="1828800"/>
-            <a:ext cx="182880" cy="201168"/>
+            <a:off x="5943600" y="1810512"/>
+            <a:ext cx="182880" cy="182880"/>
           </a:xfrm>
           <a:prstGeom prst="downArrow">
             <a:avLst/>
@@ -8542,14 +9075,14 @@
       </p:sp>
       <p:sp>
         <p:nvSpPr>
-          <p:cNvPr id="14" name="TextBox 13"/>
+          <p:cNvPr id="19" name="TextBox 18"/>
           <p:cNvSpPr txBox="1"/>
           <p:nvPr/>
         </p:nvSpPr>
         <p:spPr>
           <a:xfrm>
-            <a:off x="6263640" y="1828800"/>
-            <a:ext cx="2011680" cy="219456"/>
+            <a:off x="6263640" y="1810512"/>
+            <a:ext cx="2011680" cy="201168"/>
           </a:xfrm>
           <a:prstGeom prst="rect">
             <a:avLst/>
@@ -8577,14 +9110,14 @@
       </p:sp>
       <p:sp>
         <p:nvSpPr>
-          <p:cNvPr id="15" name="Rounded Rectangle 14"/>
+          <p:cNvPr id="20" name="Rounded Rectangle 19"/>
           <p:cNvSpPr/>
           <p:nvPr/>
         </p:nvSpPr>
         <p:spPr>
           <a:xfrm>
-            <a:off x="365760" y="2103120"/>
-            <a:ext cx="11457432" cy="1325880"/>
+            <a:off x="365760" y="2057400"/>
+            <a:ext cx="11457432" cy="1298448"/>
           </a:xfrm>
           <a:prstGeom prst="roundRect">
             <a:avLst>
@@ -8624,14 +9157,14 @@
       </p:sp>
       <p:sp>
         <p:nvSpPr>
-          <p:cNvPr id="16" name="Rounded Rectangle 15"/>
+          <p:cNvPr id="21" name="Rounded Rectangle 20"/>
           <p:cNvSpPr/>
           <p:nvPr/>
         </p:nvSpPr>
         <p:spPr>
           <a:xfrm>
-            <a:off x="502920" y="2212848"/>
-            <a:ext cx="2606040" cy="274320"/>
+            <a:off x="502920" y="2148840"/>
+            <a:ext cx="2606040" cy="256032"/>
           </a:xfrm>
           <a:prstGeom prst="roundRect">
             <a:avLst>
@@ -8669,14 +9202,14 @@
       </p:sp>
       <p:sp>
         <p:nvSpPr>
-          <p:cNvPr id="17" name="TextBox 16"/>
+          <p:cNvPr id="22" name="TextBox 21"/>
           <p:cNvSpPr txBox="1"/>
           <p:nvPr/>
         </p:nvSpPr>
         <p:spPr>
           <a:xfrm>
-            <a:off x="502920" y="2231136"/>
-            <a:ext cx="2606040" cy="237744"/>
+            <a:off x="502920" y="2167128"/>
+            <a:ext cx="2606040" cy="219456"/>
           </a:xfrm>
           <a:prstGeom prst="rect">
             <a:avLst/>
@@ -8702,16 +9235,40 @@
           </a:p>
         </p:txBody>
       </p:sp>
-      <p:sp>
-        <p:nvSpPr>
-          <p:cNvPr id="18" name="TextBox 17"/>
+      <p:pic>
+        <p:nvPicPr>
+          <p:cNvPr id="23" name="Picture 22" descr="uaf.png"/>
+          <p:cNvPicPr>
+            <a:picLocks noChangeAspect="1"/>
+          </p:cNvPicPr>
+          <p:nvPr/>
+        </p:nvPicPr>
+        <p:blipFill>
+          <a:blip r:embed="rId2"/>
+          <a:stretch>
+            <a:fillRect/>
+          </a:stretch>
+        </p:blipFill>
+        <p:spPr>
+          <a:xfrm>
+            <a:off x="3200400" y="2148840"/>
+            <a:ext cx="256032" cy="256032"/>
+          </a:xfrm>
+          <a:prstGeom prst="rect">
+            <a:avLst/>
+          </a:prstGeom>
+        </p:spPr>
+      </p:pic>
+      <p:sp>
+        <p:nvSpPr>
+          <p:cNvPr id="24" name="TextBox 23"/>
           <p:cNvSpPr txBox="1"/>
           <p:nvPr/>
         </p:nvSpPr>
         <p:spPr>
           <a:xfrm>
-            <a:off x="3246120" y="2212848"/>
-            <a:ext cx="8229600" cy="274320"/>
+            <a:off x="3520440" y="2148840"/>
+            <a:ext cx="7772400" cy="256032"/>
           </a:xfrm>
           <a:prstGeom prst="rect">
             <a:avLst/>
@@ -8739,13 +9296,13 @@
       </p:sp>
       <p:sp>
         <p:nvSpPr>
-          <p:cNvPr id="19" name="Rounded Rectangle 18"/>
+          <p:cNvPr id="25" name="Rounded Rectangle 24"/>
           <p:cNvSpPr/>
           <p:nvPr/>
         </p:nvSpPr>
         <p:spPr>
           <a:xfrm>
-            <a:off x="502920" y="2606040"/>
+            <a:off x="502920" y="2532888"/>
             <a:ext cx="3611880" cy="658368"/>
           </a:xfrm>
           <a:prstGeom prst="roundRect">
@@ -8784,16 +9341,40 @@
           </a:p>
         </p:txBody>
       </p:sp>
-      <p:sp>
-        <p:nvSpPr>
-          <p:cNvPr id="20" name="TextBox 19"/>
+      <p:pic>
+        <p:nvPicPr>
+          <p:cNvPr id="26" name="Picture 25" descr="kafka.png"/>
+          <p:cNvPicPr>
+            <a:picLocks noChangeAspect="1"/>
+          </p:cNvPicPr>
+          <p:nvPr/>
+        </p:nvPicPr>
+        <p:blipFill>
+          <a:blip r:embed="rId4"/>
+          <a:stretch>
+            <a:fillRect/>
+          </a:stretch>
+        </p:blipFill>
+        <p:spPr>
+          <a:xfrm>
+            <a:off x="612648" y="2624328"/>
+            <a:ext cx="329184" cy="329184"/>
+          </a:xfrm>
+          <a:prstGeom prst="rect">
+            <a:avLst/>
+          </a:prstGeom>
+        </p:spPr>
+      </p:pic>
+      <p:sp>
+        <p:nvSpPr>
+          <p:cNvPr id="27" name="TextBox 26"/>
           <p:cNvSpPr txBox="1"/>
           <p:nvPr/>
         </p:nvSpPr>
         <p:spPr>
           <a:xfrm>
-            <a:off x="640080" y="2670048"/>
-            <a:ext cx="3337560" cy="256032"/>
+            <a:off x="1005840" y="2587752"/>
+            <a:ext cx="2971800" cy="256032"/>
           </a:xfrm>
           <a:prstGeom prst="rect">
             <a:avLst/>
@@ -8821,14 +9402,14 @@
       </p:sp>
       <p:sp>
         <p:nvSpPr>
-          <p:cNvPr id="21" name="TextBox 20"/>
+          <p:cNvPr id="28" name="TextBox 27"/>
           <p:cNvSpPr txBox="1"/>
           <p:nvPr/>
         </p:nvSpPr>
         <p:spPr>
           <a:xfrm>
-            <a:off x="640080" y="2944368"/>
-            <a:ext cx="3337560" cy="256032"/>
+            <a:off x="1005840" y="2862072"/>
+            <a:ext cx="2971800" cy="256032"/>
           </a:xfrm>
           <a:prstGeom prst="rect">
             <a:avLst/>
@@ -8856,13 +9437,13 @@
       </p:sp>
       <p:sp>
         <p:nvSpPr>
-          <p:cNvPr id="22" name="Rounded Rectangle 21"/>
+          <p:cNvPr id="29" name="Rounded Rectangle 28"/>
           <p:cNvSpPr/>
           <p:nvPr/>
         </p:nvSpPr>
         <p:spPr>
           <a:xfrm>
-            <a:off x="4279392" y="2606040"/>
+            <a:off x="4279392" y="2532888"/>
             <a:ext cx="3611880" cy="658368"/>
           </a:xfrm>
           <a:prstGeom prst="roundRect">
@@ -8901,16 +9482,40 @@
           </a:p>
         </p:txBody>
       </p:sp>
-      <p:sp>
-        <p:nvSpPr>
-          <p:cNvPr id="23" name="TextBox 22"/>
+      <p:pic>
+        <p:nvPicPr>
+          <p:cNvPr id="30" name="Picture 29" descr="sdk.png"/>
+          <p:cNvPicPr>
+            <a:picLocks noChangeAspect="1"/>
+          </p:cNvPicPr>
+          <p:nvPr/>
+        </p:nvPicPr>
+        <p:blipFill>
+          <a:blip r:embed="rId5"/>
+          <a:stretch>
+            <a:fillRect/>
+          </a:stretch>
+        </p:blipFill>
+        <p:spPr>
+          <a:xfrm>
+            <a:off x="4389120" y="2624328"/>
+            <a:ext cx="329184" cy="329184"/>
+          </a:xfrm>
+          <a:prstGeom prst="rect">
+            <a:avLst/>
+          </a:prstGeom>
+        </p:spPr>
+      </p:pic>
+      <p:sp>
+        <p:nvSpPr>
+          <p:cNvPr id="31" name="TextBox 30"/>
           <p:cNvSpPr txBox="1"/>
           <p:nvPr/>
         </p:nvSpPr>
         <p:spPr>
           <a:xfrm>
-            <a:off x="4416552" y="2670048"/>
-            <a:ext cx="3337560" cy="256032"/>
+            <a:off x="4782312" y="2587752"/>
+            <a:ext cx="2971800" cy="256032"/>
           </a:xfrm>
           <a:prstGeom prst="rect">
             <a:avLst/>
@@ -8938,14 +9543,14 @@
       </p:sp>
       <p:sp>
         <p:nvSpPr>
-          <p:cNvPr id="24" name="TextBox 23"/>
+          <p:cNvPr id="32" name="TextBox 31"/>
           <p:cNvSpPr txBox="1"/>
           <p:nvPr/>
         </p:nvSpPr>
         <p:spPr>
           <a:xfrm>
-            <a:off x="4416552" y="2944368"/>
-            <a:ext cx="3337560" cy="256032"/>
+            <a:off x="4782312" y="2862072"/>
+            <a:ext cx="2971800" cy="256032"/>
           </a:xfrm>
           <a:prstGeom prst="rect">
             <a:avLst/>
@@ -8973,13 +9578,13 @@
       </p:sp>
       <p:sp>
         <p:nvSpPr>
-          <p:cNvPr id="25" name="Rounded Rectangle 24"/>
+          <p:cNvPr id="33" name="Rounded Rectangle 32"/>
           <p:cNvSpPr/>
           <p:nvPr/>
         </p:nvSpPr>
         <p:spPr>
           <a:xfrm>
-            <a:off x="8055864" y="2606040"/>
+            <a:off x="8055864" y="2532888"/>
             <a:ext cx="3611880" cy="658368"/>
           </a:xfrm>
           <a:prstGeom prst="roundRect">
@@ -9018,16 +9623,40 @@
           </a:p>
         </p:txBody>
       </p:sp>
-      <p:sp>
-        <p:nvSpPr>
-          <p:cNvPr id="26" name="TextBox 25"/>
+      <p:pic>
+        <p:nvPicPr>
+          <p:cNvPr id="34" name="Picture 33" descr="rest.png"/>
+          <p:cNvPicPr>
+            <a:picLocks noChangeAspect="1"/>
+          </p:cNvPicPr>
+          <p:nvPr/>
+        </p:nvPicPr>
+        <p:blipFill>
+          <a:blip r:embed="rId6"/>
+          <a:stretch>
+            <a:fillRect/>
+          </a:stretch>
+        </p:blipFill>
+        <p:spPr>
+          <a:xfrm>
+            <a:off x="8165592" y="2624328"/>
+            <a:ext cx="329184" cy="329184"/>
+          </a:xfrm>
+          <a:prstGeom prst="rect">
+            <a:avLst/>
+          </a:prstGeom>
+        </p:spPr>
+      </p:pic>
+      <p:sp>
+        <p:nvSpPr>
+          <p:cNvPr id="35" name="TextBox 34"/>
           <p:cNvSpPr txBox="1"/>
           <p:nvPr/>
         </p:nvSpPr>
         <p:spPr>
           <a:xfrm>
-            <a:off x="8193024" y="2670048"/>
-            <a:ext cx="3337560" cy="256032"/>
+            <a:off x="8558784" y="2587752"/>
+            <a:ext cx="2971800" cy="256032"/>
           </a:xfrm>
           <a:prstGeom prst="rect">
             <a:avLst/>
@@ -9055,14 +9684,14 @@
       </p:sp>
       <p:sp>
         <p:nvSpPr>
-          <p:cNvPr id="27" name="TextBox 26"/>
+          <p:cNvPr id="36" name="TextBox 35"/>
           <p:cNvSpPr txBox="1"/>
           <p:nvPr/>
         </p:nvSpPr>
         <p:spPr>
           <a:xfrm>
-            <a:off x="8193024" y="2944368"/>
-            <a:ext cx="3337560" cy="256032"/>
+            <a:off x="8558784" y="2862072"/>
+            <a:ext cx="2971800" cy="256032"/>
           </a:xfrm>
           <a:prstGeom prst="rect">
             <a:avLst/>
@@ -9090,14 +9719,14 @@
       </p:sp>
       <p:sp>
         <p:nvSpPr>
-          <p:cNvPr id="28" name="Down Arrow 27"/>
+          <p:cNvPr id="37" name="Down Arrow 36"/>
           <p:cNvSpPr/>
           <p:nvPr/>
         </p:nvSpPr>
         <p:spPr>
           <a:xfrm>
-            <a:off x="1600200" y="3547872"/>
-            <a:ext cx="146304" cy="164592"/>
+            <a:off x="1600200" y="3474720"/>
+            <a:ext cx="146304" cy="146304"/>
           </a:xfrm>
           <a:prstGeom prst="downArrow">
             <a:avLst/>
@@ -9133,14 +9762,14 @@
       </p:sp>
       <p:sp>
         <p:nvSpPr>
-          <p:cNvPr id="29" name="Down Arrow 28"/>
+          <p:cNvPr id="38" name="Down Arrow 37"/>
           <p:cNvSpPr/>
           <p:nvPr/>
         </p:nvSpPr>
         <p:spPr>
           <a:xfrm>
-            <a:off x="4251960" y="3547872"/>
-            <a:ext cx="146304" cy="164592"/>
+            <a:off x="4251960" y="3474720"/>
+            <a:ext cx="146304" cy="146304"/>
           </a:xfrm>
           <a:prstGeom prst="downArrow">
             <a:avLst/>
@@ -9176,14 +9805,14 @@
       </p:sp>
       <p:sp>
         <p:nvSpPr>
-          <p:cNvPr id="30" name="Down Arrow 29"/>
+          <p:cNvPr id="39" name="Down Arrow 38"/>
           <p:cNvSpPr/>
           <p:nvPr/>
         </p:nvSpPr>
         <p:spPr>
           <a:xfrm>
-            <a:off x="6903720" y="3547872"/>
-            <a:ext cx="146304" cy="164592"/>
+            <a:off x="6903720" y="3474720"/>
+            <a:ext cx="146304" cy="146304"/>
           </a:xfrm>
           <a:prstGeom prst="downArrow">
             <a:avLst/>
@@ -9219,14 +9848,14 @@
       </p:sp>
       <p:sp>
         <p:nvSpPr>
-          <p:cNvPr id="31" name="Down Arrow 30"/>
+          <p:cNvPr id="40" name="Down Arrow 39"/>
           <p:cNvSpPr/>
           <p:nvPr/>
         </p:nvSpPr>
         <p:spPr>
           <a:xfrm>
-            <a:off x="9555480" y="3547872"/>
-            <a:ext cx="146304" cy="164592"/>
+            <a:off x="9555480" y="3474720"/>
+            <a:ext cx="146304" cy="146304"/>
           </a:xfrm>
           <a:prstGeom prst="downArrow">
             <a:avLst/>
@@ -9262,14 +9891,14 @@
       </p:sp>
       <p:sp>
         <p:nvSpPr>
-          <p:cNvPr id="32" name="TextBox 31"/>
+          <p:cNvPr id="41" name="TextBox 40"/>
           <p:cNvSpPr txBox="1"/>
           <p:nvPr/>
         </p:nvSpPr>
         <p:spPr>
           <a:xfrm>
-            <a:off x="365760" y="3767328"/>
-            <a:ext cx="11430000" cy="219456"/>
+            <a:off x="365760" y="3675887"/>
+            <a:ext cx="11430000" cy="201168"/>
           </a:xfrm>
           <a:prstGeom prst="rect">
             <a:avLst/>
@@ -9297,14 +9926,14 @@
       </p:sp>
       <p:sp>
         <p:nvSpPr>
-          <p:cNvPr id="33" name="Rounded Rectangle 32"/>
+          <p:cNvPr id="42" name="Rounded Rectangle 41"/>
           <p:cNvSpPr/>
           <p:nvPr/>
         </p:nvSpPr>
         <p:spPr>
           <a:xfrm>
-            <a:off x="365760" y="4023360"/>
-            <a:ext cx="2697480" cy="1325880"/>
+            <a:off x="365760" y="3931920"/>
+            <a:ext cx="2697480" cy="1280160"/>
           </a:xfrm>
           <a:prstGeom prst="roundRect">
             <a:avLst>
@@ -9344,14 +9973,14 @@
       </p:sp>
       <p:sp>
         <p:nvSpPr>
-          <p:cNvPr id="34" name="Rounded Rectangle 33"/>
+          <p:cNvPr id="43" name="Rounded Rectangle 42"/>
           <p:cNvSpPr/>
           <p:nvPr/>
         </p:nvSpPr>
         <p:spPr>
           <a:xfrm>
-            <a:off x="475488" y="4133088"/>
-            <a:ext cx="1417320" cy="237744"/>
+            <a:off x="475488" y="4023360"/>
+            <a:ext cx="1371600" cy="219456"/>
           </a:xfrm>
           <a:prstGeom prst="roundRect">
             <a:avLst>
@@ -9389,14 +10018,14 @@
       </p:sp>
       <p:sp>
         <p:nvSpPr>
-          <p:cNvPr id="35" name="TextBox 34"/>
+          <p:cNvPr id="44" name="TextBox 43"/>
           <p:cNvSpPr txBox="1"/>
           <p:nvPr/>
         </p:nvSpPr>
         <p:spPr>
           <a:xfrm>
-            <a:off x="475488" y="4151376"/>
-            <a:ext cx="1417320" cy="201168"/>
+            <a:off x="475488" y="4041648"/>
+            <a:ext cx="1371600" cy="182880"/>
           </a:xfrm>
           <a:prstGeom prst="rect">
             <a:avLst/>
@@ -9424,14 +10053,14 @@
       </p:sp>
       <p:sp>
         <p:nvSpPr>
-          <p:cNvPr id="36" name="TextBox 35"/>
+          <p:cNvPr id="45" name="TextBox 44"/>
           <p:cNvSpPr txBox="1"/>
           <p:nvPr/>
         </p:nvSpPr>
         <p:spPr>
           <a:xfrm>
-            <a:off x="493776" y="4462272"/>
-            <a:ext cx="2441448" cy="274320"/>
+            <a:off x="493776" y="4315968"/>
+            <a:ext cx="2441448" cy="256032"/>
           </a:xfrm>
           <a:prstGeom prst="rect">
             <a:avLst/>
@@ -9459,14 +10088,14 @@
       </p:sp>
       <p:sp>
         <p:nvSpPr>
-          <p:cNvPr id="37" name="TextBox 36"/>
+          <p:cNvPr id="46" name="TextBox 45"/>
           <p:cNvSpPr txBox="1"/>
           <p:nvPr/>
         </p:nvSpPr>
         <p:spPr>
           <a:xfrm>
-            <a:off x="493776" y="4782312"/>
-            <a:ext cx="2441448" cy="457200"/>
+            <a:off x="493776" y="4636008"/>
+            <a:ext cx="2441448" cy="411480"/>
           </a:xfrm>
           <a:prstGeom prst="rect">
             <a:avLst/>
@@ -9494,14 +10123,14 @@
       </p:sp>
       <p:sp>
         <p:nvSpPr>
-          <p:cNvPr id="38" name="TextBox 37"/>
+          <p:cNvPr id="47" name="TextBox 46"/>
           <p:cNvSpPr txBox="1"/>
           <p:nvPr/>
         </p:nvSpPr>
         <p:spPr>
           <a:xfrm>
-            <a:off x="493776" y="5285232"/>
-            <a:ext cx="2441448" cy="228600"/>
+            <a:off x="493776" y="5093208"/>
+            <a:ext cx="2441448" cy="201168"/>
           </a:xfrm>
           <a:prstGeom prst="rect">
             <a:avLst/>
@@ -9529,14 +10158,14 @@
       </p:sp>
       <p:sp>
         <p:nvSpPr>
-          <p:cNvPr id="39" name="Rounded Rectangle 38"/>
+          <p:cNvPr id="48" name="Rounded Rectangle 47"/>
           <p:cNvSpPr/>
           <p:nvPr/>
         </p:nvSpPr>
         <p:spPr>
           <a:xfrm>
-            <a:off x="3227832" y="4023360"/>
-            <a:ext cx="2697480" cy="1325880"/>
+            <a:off x="3227832" y="3931920"/>
+            <a:ext cx="2697480" cy="1280160"/>
           </a:xfrm>
           <a:prstGeom prst="roundRect">
             <a:avLst>
@@ -9576,14 +10205,14 @@
       </p:sp>
       <p:sp>
         <p:nvSpPr>
-          <p:cNvPr id="40" name="TextBox 39"/>
+          <p:cNvPr id="49" name="TextBox 48"/>
           <p:cNvSpPr txBox="1"/>
           <p:nvPr/>
         </p:nvSpPr>
         <p:spPr>
           <a:xfrm>
-            <a:off x="3355848" y="4187952"/>
-            <a:ext cx="2441448" cy="274320"/>
+            <a:off x="3355848" y="4078224"/>
+            <a:ext cx="2441448" cy="256032"/>
           </a:xfrm>
           <a:prstGeom prst="rect">
             <a:avLst/>
@@ -9611,14 +10240,14 @@
       </p:sp>
       <p:sp>
         <p:nvSpPr>
-          <p:cNvPr id="41" name="TextBox 40"/>
+          <p:cNvPr id="50" name="TextBox 49"/>
           <p:cNvSpPr txBox="1"/>
           <p:nvPr/>
         </p:nvSpPr>
         <p:spPr>
           <a:xfrm>
-            <a:off x="3355848" y="4507992"/>
-            <a:ext cx="2441448" cy="457200"/>
+            <a:off x="3355848" y="4398264"/>
+            <a:ext cx="2441448" cy="411480"/>
           </a:xfrm>
           <a:prstGeom prst="rect">
             <a:avLst/>
@@ -9646,14 +10275,14 @@
       </p:sp>
       <p:sp>
         <p:nvSpPr>
-          <p:cNvPr id="42" name="TextBox 41"/>
+          <p:cNvPr id="51" name="TextBox 50"/>
           <p:cNvSpPr txBox="1"/>
           <p:nvPr/>
         </p:nvSpPr>
         <p:spPr>
           <a:xfrm>
-            <a:off x="3355848" y="5010912"/>
-            <a:ext cx="2441448" cy="228600"/>
+            <a:off x="3355848" y="4855464"/>
+            <a:ext cx="2441448" cy="201168"/>
           </a:xfrm>
           <a:prstGeom prst="rect">
             <a:avLst/>
@@ -9681,14 +10310,14 @@
       </p:sp>
       <p:sp>
         <p:nvSpPr>
-          <p:cNvPr id="43" name="Rounded Rectangle 42"/>
+          <p:cNvPr id="52" name="Rounded Rectangle 51"/>
           <p:cNvSpPr/>
           <p:nvPr/>
         </p:nvSpPr>
         <p:spPr>
           <a:xfrm>
-            <a:off x="6089904" y="4023360"/>
-            <a:ext cx="2697480" cy="1325880"/>
+            <a:off x="6089904" y="3931920"/>
+            <a:ext cx="2697480" cy="1280160"/>
           </a:xfrm>
           <a:prstGeom prst="roundRect">
             <a:avLst>
@@ -9728,14 +10357,14 @@
       </p:sp>
       <p:sp>
         <p:nvSpPr>
-          <p:cNvPr id="44" name="TextBox 43"/>
+          <p:cNvPr id="53" name="TextBox 52"/>
           <p:cNvSpPr txBox="1"/>
           <p:nvPr/>
         </p:nvSpPr>
         <p:spPr>
           <a:xfrm>
-            <a:off x="6217920" y="4187952"/>
-            <a:ext cx="2441448" cy="274320"/>
+            <a:off x="6217920" y="4078224"/>
+            <a:ext cx="2441448" cy="256032"/>
           </a:xfrm>
           <a:prstGeom prst="rect">
             <a:avLst/>
@@ -9763,14 +10392,14 @@
       </p:sp>
       <p:sp>
         <p:nvSpPr>
-          <p:cNvPr id="45" name="TextBox 44"/>
+          <p:cNvPr id="54" name="TextBox 53"/>
           <p:cNvSpPr txBox="1"/>
           <p:nvPr/>
         </p:nvSpPr>
         <p:spPr>
           <a:xfrm>
-            <a:off x="6217920" y="4507992"/>
-            <a:ext cx="2441448" cy="457200"/>
+            <a:off x="6217920" y="4398264"/>
+            <a:ext cx="2441448" cy="411480"/>
           </a:xfrm>
           <a:prstGeom prst="rect">
             <a:avLst/>
@@ -9798,14 +10427,14 @@
       </p:sp>
       <p:sp>
         <p:nvSpPr>
-          <p:cNvPr id="46" name="TextBox 45"/>
+          <p:cNvPr id="55" name="TextBox 54"/>
           <p:cNvSpPr txBox="1"/>
           <p:nvPr/>
         </p:nvSpPr>
         <p:spPr>
           <a:xfrm>
-            <a:off x="6217920" y="5010912"/>
-            <a:ext cx="2441448" cy="228600"/>
+            <a:off x="6217920" y="4855464"/>
+            <a:ext cx="2441448" cy="201168"/>
           </a:xfrm>
           <a:prstGeom prst="rect">
             <a:avLst/>
@@ -9833,14 +10462,14 @@
       </p:sp>
       <p:sp>
         <p:nvSpPr>
-          <p:cNvPr id="47" name="Rounded Rectangle 46"/>
+          <p:cNvPr id="56" name="Rounded Rectangle 55"/>
           <p:cNvSpPr/>
           <p:nvPr/>
         </p:nvSpPr>
         <p:spPr>
           <a:xfrm>
-            <a:off x="8951976" y="4023360"/>
-            <a:ext cx="2697480" cy="1325880"/>
+            <a:off x="8951976" y="3931920"/>
+            <a:ext cx="2697480" cy="1280160"/>
           </a:xfrm>
           <a:prstGeom prst="roundRect">
             <a:avLst>
@@ -9878,16 +10507,64 @@
           </a:p>
         </p:txBody>
       </p:sp>
-      <p:sp>
-        <p:nvSpPr>
-          <p:cNvPr id="48" name="TextBox 47"/>
+      <p:pic>
+        <p:nvPicPr>
+          <p:cNvPr id="57" name="Picture 56" descr="uaf.png"/>
+          <p:cNvPicPr>
+            <a:picLocks noChangeAspect="1"/>
+          </p:cNvPicPr>
+          <p:nvPr/>
+        </p:nvPicPr>
+        <p:blipFill>
+          <a:blip r:embed="rId2"/>
+          <a:stretch>
+            <a:fillRect/>
+          </a:stretch>
+        </p:blipFill>
+        <p:spPr>
+          <a:xfrm>
+            <a:off x="9079992" y="4078224"/>
+            <a:ext cx="237744" cy="237744"/>
+          </a:xfrm>
+          <a:prstGeom prst="rect">
+            <a:avLst/>
+          </a:prstGeom>
+        </p:spPr>
+      </p:pic>
+      <p:pic>
+        <p:nvPicPr>
+          <p:cNvPr id="58" name="Picture 57" descr="sim.png"/>
+          <p:cNvPicPr>
+            <a:picLocks noChangeAspect="1"/>
+          </p:cNvPicPr>
+          <p:nvPr/>
+        </p:nvPicPr>
+        <p:blipFill>
+          <a:blip r:embed="rId3"/>
+          <a:stretch>
+            <a:fillRect/>
+          </a:stretch>
+        </p:blipFill>
+        <p:spPr>
+          <a:xfrm>
+            <a:off x="9354312" y="4078224"/>
+            <a:ext cx="237744" cy="237744"/>
+          </a:xfrm>
+          <a:prstGeom prst="rect">
+            <a:avLst/>
+          </a:prstGeom>
+        </p:spPr>
+      </p:pic>
+      <p:sp>
+        <p:nvSpPr>
+          <p:cNvPr id="59" name="TextBox 58"/>
           <p:cNvSpPr txBox="1"/>
           <p:nvPr/>
         </p:nvSpPr>
         <p:spPr>
           <a:xfrm>
-            <a:off x="9079992" y="4187952"/>
-            <a:ext cx="2441448" cy="274320"/>
+            <a:off x="9665208" y="4078224"/>
+            <a:ext cx="1828800" cy="256032"/>
           </a:xfrm>
           <a:prstGeom prst="rect">
             <a:avLst/>
@@ -9902,7 +10579,7 @@
           <a:p>
             <a:pPr algn="l"/>
             <a:r>
-              <a:rPr sz="1400" b="1">
+              <a:rPr sz="1300" b="1">
                 <a:solidFill>
                   <a:srgbClr val="F8FAFC"/>
                 </a:solidFill>
@@ -9915,14 +10592,14 @@
       </p:sp>
       <p:sp>
         <p:nvSpPr>
-          <p:cNvPr id="49" name="TextBox 48"/>
+          <p:cNvPr id="60" name="TextBox 59"/>
           <p:cNvSpPr txBox="1"/>
           <p:nvPr/>
         </p:nvSpPr>
         <p:spPr>
           <a:xfrm>
-            <a:off x="9079992" y="4507992"/>
-            <a:ext cx="2441448" cy="457200"/>
+            <a:off x="9079992" y="4425696"/>
+            <a:ext cx="2441448" cy="411480"/>
           </a:xfrm>
           <a:prstGeom prst="rect">
             <a:avLst/>
@@ -9950,14 +10627,14 @@
       </p:sp>
       <p:sp>
         <p:nvSpPr>
-          <p:cNvPr id="50" name="TextBox 49"/>
+          <p:cNvPr id="61" name="TextBox 60"/>
           <p:cNvSpPr txBox="1"/>
           <p:nvPr/>
         </p:nvSpPr>
         <p:spPr>
           <a:xfrm>
-            <a:off x="9079992" y="5010912"/>
-            <a:ext cx="2441448" cy="228600"/>
+            <a:off x="9079992" y="4855464"/>
+            <a:ext cx="2441448" cy="201168"/>
           </a:xfrm>
           <a:prstGeom prst="rect">
             <a:avLst/>
@@ -9985,14 +10662,14 @@
       </p:sp>
       <p:sp>
         <p:nvSpPr>
-          <p:cNvPr id="51" name="Rounded Rectangle 50"/>
+          <p:cNvPr id="62" name="Rounded Rectangle 61"/>
           <p:cNvSpPr/>
           <p:nvPr/>
         </p:nvSpPr>
         <p:spPr>
           <a:xfrm>
-            <a:off x="365760" y="5468112"/>
-            <a:ext cx="2697480" cy="347472"/>
+            <a:off x="365760" y="5349240"/>
+            <a:ext cx="2697480" cy="329184"/>
           </a:xfrm>
           <a:prstGeom prst="roundRect">
             <a:avLst>
@@ -10032,14 +10709,14 @@
       </p:sp>
       <p:sp>
         <p:nvSpPr>
-          <p:cNvPr id="52" name="TextBox 51"/>
+          <p:cNvPr id="63" name="TextBox 62"/>
           <p:cNvSpPr txBox="1"/>
           <p:nvPr/>
         </p:nvSpPr>
         <p:spPr>
           <a:xfrm>
-            <a:off x="475488" y="5532120"/>
-            <a:ext cx="2478024" cy="237744"/>
+            <a:off x="475488" y="5413248"/>
+            <a:ext cx="2478024" cy="219456"/>
           </a:xfrm>
           <a:prstGeom prst="rect">
             <a:avLst/>
@@ -10067,14 +10744,14 @@
       </p:sp>
       <p:sp>
         <p:nvSpPr>
-          <p:cNvPr id="53" name="Rounded Rectangle 52"/>
+          <p:cNvPr id="64" name="Rounded Rectangle 63"/>
           <p:cNvSpPr/>
           <p:nvPr/>
         </p:nvSpPr>
         <p:spPr>
           <a:xfrm>
-            <a:off x="3227832" y="5468112"/>
-            <a:ext cx="8503920" cy="347472"/>
+            <a:off x="3227832" y="5349240"/>
+            <a:ext cx="8503920" cy="329184"/>
           </a:xfrm>
           <a:prstGeom prst="roundRect">
             <a:avLst>
@@ -10114,14 +10791,14 @@
       </p:sp>
       <p:sp>
         <p:nvSpPr>
-          <p:cNvPr id="54" name="TextBox 53"/>
+          <p:cNvPr id="65" name="TextBox 64"/>
           <p:cNvSpPr txBox="1"/>
           <p:nvPr/>
         </p:nvSpPr>
         <p:spPr>
           <a:xfrm>
-            <a:off x="3364992" y="5532120"/>
-            <a:ext cx="8229600" cy="237744"/>
+            <a:off x="3364992" y="5413248"/>
+            <a:ext cx="8229600" cy="219456"/>
           </a:xfrm>
           <a:prstGeom prst="rect">
             <a:avLst/>
@@ -10149,14 +10826,14 @@
       </p:sp>
       <p:sp>
         <p:nvSpPr>
-          <p:cNvPr id="55" name="Rounded Rectangle 54"/>
+          <p:cNvPr id="66" name="Rounded Rectangle 65"/>
           <p:cNvSpPr/>
           <p:nvPr/>
         </p:nvSpPr>
         <p:spPr>
           <a:xfrm>
-            <a:off x="365760" y="5989320"/>
-            <a:ext cx="11460175" cy="502920"/>
+            <a:off x="365760" y="5852160"/>
+            <a:ext cx="11460175" cy="640080"/>
           </a:xfrm>
           <a:prstGeom prst="roundRect">
             <a:avLst>
@@ -10194,16 +10871,136 @@
           </a:p>
         </p:txBody>
       </p:sp>
-      <p:sp>
-        <p:nvSpPr>
-          <p:cNvPr id="56" name="TextBox 55"/>
+      <p:pic>
+        <p:nvPicPr>
+          <p:cNvPr id="67" name="Picture 66" descr="sdk.png"/>
+          <p:cNvPicPr>
+            <a:picLocks noChangeAspect="1"/>
+          </p:cNvPicPr>
+          <p:nvPr/>
+        </p:nvPicPr>
+        <p:blipFill>
+          <a:blip r:embed="rId5"/>
+          <a:stretch>
+            <a:fillRect/>
+          </a:stretch>
+        </p:blipFill>
+        <p:spPr>
+          <a:xfrm>
+            <a:off x="502920" y="5961888"/>
+            <a:ext cx="292608" cy="292608"/>
+          </a:xfrm>
+          <a:prstGeom prst="rect">
+            <a:avLst/>
+          </a:prstGeom>
+        </p:spPr>
+      </p:pic>
+      <p:pic>
+        <p:nvPicPr>
+          <p:cNvPr id="68" name="Picture 67" descr="rest.png"/>
+          <p:cNvPicPr>
+            <a:picLocks noChangeAspect="1"/>
+          </p:cNvPicPr>
+          <p:nvPr/>
+        </p:nvPicPr>
+        <p:blipFill>
+          <a:blip r:embed="rId6"/>
+          <a:stretch>
+            <a:fillRect/>
+          </a:stretch>
+        </p:blipFill>
+        <p:spPr>
+          <a:xfrm>
+            <a:off x="868680" y="5961888"/>
+            <a:ext cx="292608" cy="292608"/>
+          </a:xfrm>
+          <a:prstGeom prst="rect">
+            <a:avLst/>
+          </a:prstGeom>
+        </p:spPr>
+      </p:pic>
+      <p:pic>
+        <p:nvPicPr>
+          <p:cNvPr id="69" name="Picture 68" descr="kafka.png"/>
+          <p:cNvPicPr>
+            <a:picLocks noChangeAspect="1"/>
+          </p:cNvPicPr>
+          <p:nvPr/>
+        </p:nvPicPr>
+        <p:blipFill>
+          <a:blip r:embed="rId4"/>
+          <a:stretch>
+            <a:fillRect/>
+          </a:stretch>
+        </p:blipFill>
+        <p:spPr>
+          <a:xfrm>
+            <a:off x="1234440" y="5961888"/>
+            <a:ext cx="292608" cy="292608"/>
+          </a:xfrm>
+          <a:prstGeom prst="rect">
+            <a:avLst/>
+          </a:prstGeom>
+        </p:spPr>
+      </p:pic>
+      <p:pic>
+        <p:nvPicPr>
+          <p:cNvPr id="70" name="Picture 69" descr="uaf.png"/>
+          <p:cNvPicPr>
+            <a:picLocks noChangeAspect="1"/>
+          </p:cNvPicPr>
+          <p:nvPr/>
+        </p:nvPicPr>
+        <p:blipFill>
+          <a:blip r:embed="rId2"/>
+          <a:stretch>
+            <a:fillRect/>
+          </a:stretch>
+        </p:blipFill>
+        <p:spPr>
+          <a:xfrm>
+            <a:off x="1691640" y="5961888"/>
+            <a:ext cx="292608" cy="292608"/>
+          </a:xfrm>
+          <a:prstGeom prst="rect">
+            <a:avLst/>
+          </a:prstGeom>
+        </p:spPr>
+      </p:pic>
+      <p:pic>
+        <p:nvPicPr>
+          <p:cNvPr id="71" name="Picture 70" descr="sim.png"/>
+          <p:cNvPicPr>
+            <a:picLocks noChangeAspect="1"/>
+          </p:cNvPicPr>
+          <p:nvPr/>
+        </p:nvPicPr>
+        <p:blipFill>
+          <a:blip r:embed="rId3"/>
+          <a:stretch>
+            <a:fillRect/>
+          </a:stretch>
+        </p:blipFill>
+        <p:spPr>
+          <a:xfrm>
+            <a:off x="2057400" y="5961888"/>
+            <a:ext cx="292608" cy="292608"/>
+          </a:xfrm>
+          <a:prstGeom prst="rect">
+            <a:avLst/>
+          </a:prstGeom>
+        </p:spPr>
+      </p:pic>
+      <p:sp>
+        <p:nvSpPr>
+          <p:cNvPr id="72" name="TextBox 71"/>
           <p:cNvSpPr txBox="1"/>
           <p:nvPr/>
         </p:nvSpPr>
         <p:spPr>
           <a:xfrm>
-            <a:off x="502920" y="6108192"/>
-            <a:ext cx="11155680" cy="320040"/>
+            <a:off x="2514600" y="5989320"/>
+            <a:ext cx="9144000" cy="320040"/>
           </a:xfrm>
           <a:prstGeom prst="rect">
             <a:avLst/>
@@ -10224,7 +11021,7 @@
                 </a:solidFill>
                 <a:latin typeface="Calibri"/>
               </a:rPr>
-              <a:t>LedgeRX ↔ one UAF interface only     ·     hub collects outcomes + runs UAF logic     ·     internal fan-out is UAF’s business</a:t>
+              <a:t>SDK · REST · Kafka     ·     LedgeRX ↔ one UAF interface     ·     hub logic then fan-out     ·     Yes UA · sim behind xapi</a:t>
             </a:r>
           </a:p>
         </p:txBody>

</xml_diff>

<commit_message>
docs(decks): clean slide2 layout — header align, equal cards, footer
</commit_message>
<xml_diff>
--- a/docs/decks/LedgeRX-System-Architecture-CTO.pptx
+++ b/docs/decks/LedgeRX-System-Architecture-CTO.pptx
@@ -3184,7 +3184,7 @@
         <p:spPr>
           <a:xfrm>
             <a:off x="365760" y="146304"/>
-            <a:ext cx="6858000" cy="274320"/>
+            <a:ext cx="6583680" cy="274320"/>
           </a:xfrm>
           <a:prstGeom prst="rect">
             <a:avLst/>
@@ -3192,7 +3192,7 @@
           <a:noFill/>
         </p:spPr>
         <p:txBody>
-          <a:bodyPr wrap="square" lIns="0" rIns="0" tIns="0" bIns="0">
+          <a:bodyPr wrap="square" lIns="25400" rIns="25400" tIns="12700" bIns="12700">
             <a:spAutoFit/>
           </a:bodyPr>
           <a:lstStyle/>
@@ -3226,8 +3226,8 @@
         </p:blipFill>
         <p:spPr>
           <a:xfrm>
-            <a:off x="7818120" y="128016"/>
-            <a:ext cx="347472" cy="347472"/>
+            <a:off x="7772400" y="128016"/>
+            <a:ext cx="329184" cy="329184"/>
           </a:xfrm>
           <a:prstGeom prst="rect">
             <a:avLst/>
@@ -3242,8 +3242,8 @@
         </p:nvSpPr>
         <p:spPr>
           <a:xfrm>
-            <a:off x="8211312" y="182880"/>
-            <a:ext cx="640080" cy="256032"/>
+            <a:off x="8156448" y="164592"/>
+            <a:ext cx="502920" cy="256032"/>
           </a:xfrm>
           <a:prstGeom prst="rect">
             <a:avLst/>
@@ -3251,14 +3251,14 @@
           <a:noFill/>
         </p:spPr>
         <p:txBody>
-          <a:bodyPr wrap="square" lIns="0" rIns="0" tIns="0" bIns="0">
+          <a:bodyPr wrap="square" lIns="25400" rIns="25400" tIns="12700" bIns="12700">
             <a:spAutoFit/>
           </a:bodyPr>
           <a:lstStyle/>
           <a:p>
             <a:pPr algn="l"/>
             <a:r>
-              <a:rPr sz="1200" b="1">
+              <a:rPr sz="1100" b="1">
                 <a:solidFill>
                   <a:srgbClr val="2DD4BF"/>
                 </a:solidFill>
@@ -3285,8 +3285,8 @@
         </p:blipFill>
         <p:spPr>
           <a:xfrm>
-            <a:off x="8823960" y="128016"/>
-            <a:ext cx="347472" cy="347472"/>
+            <a:off x="8732520" y="128016"/>
+            <a:ext cx="329184" cy="329184"/>
           </a:xfrm>
           <a:prstGeom prst="rect">
             <a:avLst/>
@@ -3301,8 +3301,8 @@
         </p:nvSpPr>
         <p:spPr>
           <a:xfrm>
-            <a:off x="9217152" y="182880"/>
-            <a:ext cx="502920" cy="256032"/>
+            <a:off x="9116568" y="164592"/>
+            <a:ext cx="457200" cy="256032"/>
           </a:xfrm>
           <a:prstGeom prst="rect">
             <a:avLst/>
@@ -3310,14 +3310,14 @@
           <a:noFill/>
         </p:spPr>
         <p:txBody>
-          <a:bodyPr wrap="square" lIns="0" rIns="0" tIns="0" bIns="0">
+          <a:bodyPr wrap="square" lIns="25400" rIns="25400" tIns="12700" bIns="12700">
             <a:spAutoFit/>
           </a:bodyPr>
           <a:lstStyle/>
           <a:p>
             <a:pPr algn="l"/>
             <a:r>
-              <a:rPr sz="1200" b="1">
+              <a:rPr sz="1100" b="1">
                 <a:solidFill>
                   <a:srgbClr val="38BDF8"/>
                 </a:solidFill>
@@ -3330,49 +3330,14 @@
       </p:sp>
       <p:sp>
         <p:nvSpPr>
-          <p:cNvPr id="9" name="TextBox 8"/>
-          <p:cNvSpPr txBox="1"/>
-          <p:nvPr/>
-        </p:nvSpPr>
-        <p:spPr>
-          <a:xfrm>
-            <a:off x="365760" y="475488"/>
-            <a:ext cx="8412480" cy="219456"/>
-          </a:xfrm>
-          <a:prstGeom prst="rect">
-            <a:avLst/>
-          </a:prstGeom>
-          <a:noFill/>
-        </p:spPr>
-        <p:txBody>
-          <a:bodyPr wrap="square" lIns="0" rIns="0" tIns="0" bIns="0">
-            <a:spAutoFit/>
-          </a:bodyPr>
-          <a:lstStyle/>
-          <a:p>
-            <a:pPr algn="l"/>
-            <a:r>
-              <a:rPr sz="1200" b="0">
-                <a:solidFill>
-                  <a:srgbClr val="94A3B8"/>
-                </a:solidFill>
-                <a:latin typeface="Calibri"/>
-              </a:rPr>
-              <a:t>Upstream  →  SDK  →  Product engine  →  Landing    ·    Add-ons extend the core</a:t>
-            </a:r>
-          </a:p>
-        </p:txBody>
-      </p:sp>
-      <p:sp>
-        <p:nvSpPr>
-          <p:cNvPr id="10" name="Rounded Rectangle 9"/>
+          <p:cNvPr id="9" name="Rounded Rectangle 8"/>
           <p:cNvSpPr/>
           <p:nvPr/>
         </p:nvSpPr>
         <p:spPr>
           <a:xfrm>
-            <a:off x="10241280" y="146304"/>
-            <a:ext cx="1554480" cy="329184"/>
+            <a:off x="10195560" y="128016"/>
+            <a:ext cx="1600200" cy="329184"/>
           </a:xfrm>
           <a:prstGeom prst="roundRect">
             <a:avLst>
@@ -3412,14 +3377,14 @@
       </p:sp>
       <p:sp>
         <p:nvSpPr>
-          <p:cNvPr id="11" name="TextBox 10"/>
+          <p:cNvPr id="10" name="TextBox 9"/>
           <p:cNvSpPr txBox="1"/>
           <p:nvPr/>
         </p:nvSpPr>
         <p:spPr>
           <a:xfrm>
-            <a:off x="10241280" y="182880"/>
-            <a:ext cx="1554480" cy="256032"/>
+            <a:off x="10195560" y="164592"/>
+            <a:ext cx="1600200" cy="256032"/>
           </a:xfrm>
           <a:prstGeom prst="rect">
             <a:avLst/>
@@ -3427,7 +3392,7 @@
           <a:noFill/>
         </p:spPr>
         <p:txBody>
-          <a:bodyPr wrap="square" lIns="0" rIns="0" tIns="0" bIns="0">
+          <a:bodyPr wrap="square" lIns="25400" rIns="25400" tIns="12700" bIns="12700">
             <a:spAutoFit/>
           </a:bodyPr>
           <a:lstStyle/>
@@ -3441,6 +3406,41 @@
                 <a:latin typeface="Calibri"/>
               </a:rPr>
               <a:t>CTO  ·  1 / 2</a:t>
+            </a:r>
+          </a:p>
+        </p:txBody>
+      </p:sp>
+      <p:sp>
+        <p:nvSpPr>
+          <p:cNvPr id="11" name="TextBox 10"/>
+          <p:cNvSpPr txBox="1"/>
+          <p:nvPr/>
+        </p:nvSpPr>
+        <p:spPr>
+          <a:xfrm>
+            <a:off x="365760" y="475488"/>
+            <a:ext cx="9144000" cy="219456"/>
+          </a:xfrm>
+          <a:prstGeom prst="rect">
+            <a:avLst/>
+          </a:prstGeom>
+          <a:noFill/>
+        </p:spPr>
+        <p:txBody>
+          <a:bodyPr wrap="square" lIns="25400" rIns="25400" tIns="12700" bIns="12700">
+            <a:spAutoFit/>
+          </a:bodyPr>
+          <a:lstStyle/>
+          <a:p>
+            <a:pPr algn="l"/>
+            <a:r>
+              <a:rPr sz="1200" b="0">
+                <a:solidFill>
+                  <a:srgbClr val="94A3B8"/>
+                </a:solidFill>
+                <a:latin typeface="Calibri"/>
+              </a:rPr>
+              <a:t>Upstream  →  SDK  →  Product engine  →  Landing    ·    Add-ons extend the core</a:t>
             </a:r>
           </a:p>
         </p:txBody>
@@ -3552,7 +3552,7 @@
           <a:noFill/>
         </p:spPr>
         <p:txBody>
-          <a:bodyPr wrap="square" lIns="0" rIns="0" tIns="0" bIns="0">
+          <a:bodyPr wrap="square" lIns="25400" rIns="25400" tIns="12700" bIns="12700">
             <a:spAutoFit/>
           </a:bodyPr>
           <a:lstStyle/>
@@ -3587,7 +3587,7 @@
           <a:noFill/>
         </p:spPr>
         <p:txBody>
-          <a:bodyPr wrap="square" lIns="0" rIns="0" tIns="0" bIns="0">
+          <a:bodyPr wrap="square" lIns="25400" rIns="25400" tIns="12700" bIns="12700">
             <a:spAutoFit/>
           </a:bodyPr>
           <a:lstStyle/>
@@ -3622,7 +3622,7 @@
           <a:noFill/>
         </p:spPr>
         <p:txBody>
-          <a:bodyPr wrap="square" lIns="0" rIns="0" tIns="0" bIns="0">
+          <a:bodyPr wrap="square" lIns="25400" rIns="25400" tIns="12700" bIns="12700">
             <a:spAutoFit/>
           </a:bodyPr>
           <a:lstStyle/>
@@ -3649,7 +3649,7 @@
         <p:spPr>
           <a:xfrm>
             <a:off x="475488" y="1517904"/>
-            <a:ext cx="1541626" cy="384048"/>
+            <a:ext cx="1541626" cy="365760"/>
           </a:xfrm>
           <a:prstGeom prst="roundRect">
             <a:avLst>
@@ -3703,8 +3703,8 @@
         </p:blipFill>
         <p:spPr>
           <a:xfrm>
-            <a:off x="548640" y="1572768"/>
-            <a:ext cx="274320" cy="274320"/>
+            <a:off x="548640" y="1563624"/>
+            <a:ext cx="256032" cy="256032"/>
           </a:xfrm>
           <a:prstGeom prst="rect">
             <a:avLst/>
@@ -3719,8 +3719,8 @@
         </p:nvSpPr>
         <p:spPr>
           <a:xfrm>
-            <a:off x="868680" y="1591056"/>
-            <a:ext cx="1097280" cy="256032"/>
+            <a:off x="859536" y="1581912"/>
+            <a:ext cx="1188720" cy="237744"/>
           </a:xfrm>
           <a:prstGeom prst="rect">
             <a:avLst/>
@@ -3728,7 +3728,7 @@
           <a:noFill/>
         </p:spPr>
         <p:txBody>
-          <a:bodyPr wrap="square" lIns="0" rIns="0" tIns="0" bIns="0">
+          <a:bodyPr wrap="square" lIns="25400" rIns="25400" tIns="12700" bIns="12700">
             <a:spAutoFit/>
           </a:bodyPr>
           <a:lstStyle/>
@@ -3802,7 +3802,7 @@
         <p:spPr>
           <a:xfrm>
             <a:off x="475488" y="2130552"/>
-            <a:ext cx="50292" cy="685800"/>
+            <a:ext cx="45720" cy="685800"/>
           </a:xfrm>
           <a:prstGeom prst="rect">
             <a:avLst/>
@@ -3844,8 +3844,8 @@
         </p:nvSpPr>
         <p:spPr>
           <a:xfrm>
-            <a:off x="621792" y="2148840"/>
-            <a:ext cx="1303882" cy="704088"/>
+            <a:off x="603504" y="2130552"/>
+            <a:ext cx="1340458" cy="722376"/>
           </a:xfrm>
           <a:prstGeom prst="rect">
             <a:avLst/>
@@ -3853,7 +3853,7 @@
           <a:noFill/>
         </p:spPr>
         <p:txBody>
-          <a:bodyPr wrap="square" lIns="0" rIns="0" tIns="0" bIns="0">
+          <a:bodyPr wrap="square" lIns="25400" rIns="25400" tIns="12700" bIns="12700">
             <a:spAutoFit/>
           </a:bodyPr>
           <a:lstStyle/>
@@ -3863,7 +3863,7 @@
                 <a:spcPts val="0"/>
               </a:spcBef>
               <a:spcAft>
-                <a:spcPts val="200"/>
+                <a:spcPts val="100"/>
               </a:spcAft>
             </a:pPr>
             <a:r>
@@ -3882,7 +3882,7 @@
                 <a:spcPts val="0"/>
               </a:spcBef>
               <a:spcAft>
-                <a:spcPts val="200"/>
+                <a:spcPts val="100"/>
               </a:spcAft>
             </a:pPr>
             <a:r>
@@ -3953,7 +3953,7 @@
         <p:spPr>
           <a:xfrm>
             <a:off x="475488" y="3090672"/>
-            <a:ext cx="50292" cy="685800"/>
+            <a:ext cx="45720" cy="685800"/>
           </a:xfrm>
           <a:prstGeom prst="rect">
             <a:avLst/>
@@ -3995,8 +3995,8 @@
         </p:nvSpPr>
         <p:spPr>
           <a:xfrm>
-            <a:off x="621792" y="3108960"/>
-            <a:ext cx="1303882" cy="704088"/>
+            <a:off x="603504" y="3090672"/>
+            <a:ext cx="1340458" cy="722376"/>
           </a:xfrm>
           <a:prstGeom prst="rect">
             <a:avLst/>
@@ -4004,7 +4004,7 @@
           <a:noFill/>
         </p:spPr>
         <p:txBody>
-          <a:bodyPr wrap="square" lIns="0" rIns="0" tIns="0" bIns="0">
+          <a:bodyPr wrap="square" lIns="25400" rIns="25400" tIns="12700" bIns="12700">
             <a:spAutoFit/>
           </a:bodyPr>
           <a:lstStyle/>
@@ -4014,7 +4014,7 @@
                 <a:spcPts val="0"/>
               </a:spcBef>
               <a:spcAft>
-                <a:spcPts val="200"/>
+                <a:spcPts val="100"/>
               </a:spcAft>
             </a:pPr>
             <a:r>
@@ -4033,7 +4033,7 @@
                 <a:spcPts val="0"/>
               </a:spcBef>
               <a:spcAft>
-                <a:spcPts val="200"/>
+                <a:spcPts val="100"/>
               </a:spcAft>
             </a:pPr>
             <a:r>
@@ -4104,7 +4104,7 @@
         <p:spPr>
           <a:xfrm>
             <a:off x="475488" y="4050792"/>
-            <a:ext cx="50292" cy="685800"/>
+            <a:ext cx="45720" cy="685800"/>
           </a:xfrm>
           <a:prstGeom prst="rect">
             <a:avLst/>
@@ -4146,8 +4146,8 @@
         </p:nvSpPr>
         <p:spPr>
           <a:xfrm>
-            <a:off x="621792" y="4069080"/>
-            <a:ext cx="1303882" cy="704088"/>
+            <a:off x="603504" y="4050792"/>
+            <a:ext cx="1340458" cy="722376"/>
           </a:xfrm>
           <a:prstGeom prst="rect">
             <a:avLst/>
@@ -4155,7 +4155,7 @@
           <a:noFill/>
         </p:spPr>
         <p:txBody>
-          <a:bodyPr wrap="square" lIns="0" rIns="0" tIns="0" bIns="0">
+          <a:bodyPr wrap="square" lIns="25400" rIns="25400" tIns="12700" bIns="12700">
             <a:spAutoFit/>
           </a:bodyPr>
           <a:lstStyle/>
@@ -4165,7 +4165,7 @@
                 <a:spcPts val="0"/>
               </a:spcBef>
               <a:spcAft>
-                <a:spcPts val="200"/>
+                <a:spcPts val="100"/>
               </a:spcAft>
             </a:pPr>
             <a:r>
@@ -4184,7 +4184,7 @@
                 <a:spcPts val="0"/>
               </a:spcBef>
               <a:spcAft>
-                <a:spcPts val="200"/>
+                <a:spcPts val="100"/>
               </a:spcAft>
             </a:pPr>
             <a:r>
@@ -4216,7 +4216,7 @@
           <a:noFill/>
         </p:spPr>
         <p:txBody>
-          <a:bodyPr wrap="square" lIns="0" rIns="0" tIns="0" bIns="0">
+          <a:bodyPr wrap="square" lIns="25400" rIns="25400" tIns="12700" bIns="12700">
             <a:spAutoFit/>
           </a:bodyPr>
           <a:lstStyle/>
@@ -4342,7 +4342,7 @@
           <a:noFill/>
         </p:spPr>
         <p:txBody>
-          <a:bodyPr wrap="square" lIns="0" rIns="0" tIns="0" bIns="0">
+          <a:bodyPr wrap="square" lIns="25400" rIns="25400" tIns="12700" bIns="12700">
             <a:spAutoFit/>
           </a:bodyPr>
           <a:lstStyle/>
@@ -4377,7 +4377,7 @@
           <a:noFill/>
         </p:spPr>
         <p:txBody>
-          <a:bodyPr wrap="square" lIns="0" rIns="0" tIns="0" bIns="0">
+          <a:bodyPr wrap="square" lIns="25400" rIns="25400" tIns="12700" bIns="12700">
             <a:spAutoFit/>
           </a:bodyPr>
           <a:lstStyle/>
@@ -4412,7 +4412,7 @@
         <p:spPr>
           <a:xfrm>
             <a:off x="2510890" y="1243584"/>
-            <a:ext cx="310896" cy="310896"/>
+            <a:ext cx="292608" cy="292608"/>
           </a:xfrm>
           <a:prstGeom prst="rect">
             <a:avLst/>
@@ -4427,8 +4427,8 @@
         </p:nvSpPr>
         <p:spPr>
           <a:xfrm>
-            <a:off x="2876650" y="1261872"/>
-            <a:ext cx="1121002" cy="274320"/>
+            <a:off x="2858362" y="1261872"/>
+            <a:ext cx="1121002" cy="256032"/>
           </a:xfrm>
           <a:prstGeom prst="rect">
             <a:avLst/>
@@ -4436,7 +4436,7 @@
           <a:noFill/>
         </p:spPr>
         <p:txBody>
-          <a:bodyPr wrap="square" lIns="0" rIns="0" tIns="0" bIns="0">
+          <a:bodyPr wrap="square" lIns="25400" rIns="25400" tIns="12700" bIns="12700">
             <a:spAutoFit/>
           </a:bodyPr>
           <a:lstStyle/>
@@ -4463,7 +4463,7 @@
         <p:spPr>
           <a:xfrm>
             <a:off x="2510890" y="1609344"/>
-            <a:ext cx="1505050" cy="256032"/>
+            <a:ext cx="1505050" cy="237744"/>
           </a:xfrm>
           <a:prstGeom prst="rect">
             <a:avLst/>
@@ -4471,7 +4471,7 @@
           <a:noFill/>
         </p:spPr>
         <p:txBody>
-          <a:bodyPr wrap="square" lIns="0" rIns="0" tIns="0" bIns="0">
+          <a:bodyPr wrap="square" lIns="25400" rIns="25400" tIns="12700" bIns="12700">
             <a:spAutoFit/>
           </a:bodyPr>
           <a:lstStyle/>
@@ -4545,7 +4545,7 @@
         <p:spPr>
           <a:xfrm>
             <a:off x="2492602" y="2084832"/>
-            <a:ext cx="50292" cy="685800"/>
+            <a:ext cx="45720" cy="685800"/>
           </a:xfrm>
           <a:prstGeom prst="rect">
             <a:avLst/>
@@ -4595,8 +4595,8 @@
         </p:blipFill>
         <p:spPr>
           <a:xfrm>
-            <a:off x="2620618" y="2263140"/>
-            <a:ext cx="329184" cy="329184"/>
+            <a:off x="2602330" y="2281428"/>
+            <a:ext cx="292608" cy="292608"/>
           </a:xfrm>
           <a:prstGeom prst="rect">
             <a:avLst/>
@@ -4611,8 +4611,8 @@
         </p:nvSpPr>
         <p:spPr>
           <a:xfrm>
-            <a:off x="3022954" y="2103120"/>
-            <a:ext cx="919834" cy="704088"/>
+            <a:off x="2968090" y="2084832"/>
+            <a:ext cx="992986" cy="722376"/>
           </a:xfrm>
           <a:prstGeom prst="rect">
             <a:avLst/>
@@ -4620,7 +4620,7 @@
           <a:noFill/>
         </p:spPr>
         <p:txBody>
-          <a:bodyPr wrap="square" lIns="0" rIns="0" tIns="0" bIns="0">
+          <a:bodyPr wrap="square" lIns="25400" rIns="25400" tIns="12700" bIns="12700">
             <a:spAutoFit/>
           </a:bodyPr>
           <a:lstStyle/>
@@ -4630,7 +4630,7 @@
                 <a:spcPts val="0"/>
               </a:spcBef>
               <a:spcAft>
-                <a:spcPts val="200"/>
+                <a:spcPts val="100"/>
               </a:spcAft>
             </a:pPr>
             <a:r>
@@ -4649,7 +4649,7 @@
                 <a:spcPts val="0"/>
               </a:spcBef>
               <a:spcAft>
-                <a:spcPts val="200"/>
+                <a:spcPts val="100"/>
               </a:spcAft>
             </a:pPr>
             <a:r>
@@ -4720,7 +4720,7 @@
         <p:spPr>
           <a:xfrm>
             <a:off x="2492602" y="3044952"/>
-            <a:ext cx="50292" cy="685800"/>
+            <a:ext cx="45720" cy="685800"/>
           </a:xfrm>
           <a:prstGeom prst="rect">
             <a:avLst/>
@@ -4770,8 +4770,8 @@
         </p:blipFill>
         <p:spPr>
           <a:xfrm>
-            <a:off x="2620618" y="3223260"/>
-            <a:ext cx="329184" cy="329184"/>
+            <a:off x="2602330" y="3241548"/>
+            <a:ext cx="292608" cy="292608"/>
           </a:xfrm>
           <a:prstGeom prst="rect">
             <a:avLst/>
@@ -4786,8 +4786,8 @@
         </p:nvSpPr>
         <p:spPr>
           <a:xfrm>
-            <a:off x="3022954" y="3063240"/>
-            <a:ext cx="919834" cy="704088"/>
+            <a:off x="2968090" y="3044952"/>
+            <a:ext cx="992986" cy="722376"/>
           </a:xfrm>
           <a:prstGeom prst="rect">
             <a:avLst/>
@@ -4795,7 +4795,7 @@
           <a:noFill/>
         </p:spPr>
         <p:txBody>
-          <a:bodyPr wrap="square" lIns="0" rIns="0" tIns="0" bIns="0">
+          <a:bodyPr wrap="square" lIns="25400" rIns="25400" tIns="12700" bIns="12700">
             <a:spAutoFit/>
           </a:bodyPr>
           <a:lstStyle/>
@@ -4805,7 +4805,7 @@
                 <a:spcPts val="0"/>
               </a:spcBef>
               <a:spcAft>
-                <a:spcPts val="200"/>
+                <a:spcPts val="100"/>
               </a:spcAft>
             </a:pPr>
             <a:r>
@@ -4824,7 +4824,7 @@
                 <a:spcPts val="0"/>
               </a:spcBef>
               <a:spcAft>
-                <a:spcPts val="200"/>
+                <a:spcPts val="100"/>
               </a:spcAft>
             </a:pPr>
             <a:r>
@@ -4895,7 +4895,7 @@
         <p:spPr>
           <a:xfrm>
             <a:off x="2492602" y="4005072"/>
-            <a:ext cx="50292" cy="685800"/>
+            <a:ext cx="45720" cy="685800"/>
           </a:xfrm>
           <a:prstGeom prst="rect">
             <a:avLst/>
@@ -4945,8 +4945,8 @@
         </p:blipFill>
         <p:spPr>
           <a:xfrm>
-            <a:off x="2620618" y="4183380"/>
-            <a:ext cx="329184" cy="329184"/>
+            <a:off x="2602330" y="4201668"/>
+            <a:ext cx="292608" cy="292608"/>
           </a:xfrm>
           <a:prstGeom prst="rect">
             <a:avLst/>
@@ -4961,8 +4961,8 @@
         </p:nvSpPr>
         <p:spPr>
           <a:xfrm>
-            <a:off x="3022954" y="4023360"/>
-            <a:ext cx="919834" cy="704088"/>
+            <a:off x="2968090" y="4005072"/>
+            <a:ext cx="992986" cy="722376"/>
           </a:xfrm>
           <a:prstGeom prst="rect">
             <a:avLst/>
@@ -4970,7 +4970,7 @@
           <a:noFill/>
         </p:spPr>
         <p:txBody>
-          <a:bodyPr wrap="square" lIns="0" rIns="0" tIns="0" bIns="0">
+          <a:bodyPr wrap="square" lIns="25400" rIns="25400" tIns="12700" bIns="12700">
             <a:spAutoFit/>
           </a:bodyPr>
           <a:lstStyle/>
@@ -4980,7 +4980,7 @@
                 <a:spcPts val="0"/>
               </a:spcBef>
               <a:spcAft>
-                <a:spcPts val="200"/>
+                <a:spcPts val="100"/>
               </a:spcAft>
             </a:pPr>
             <a:r>
@@ -4999,7 +4999,7 @@
                 <a:spcPts val="0"/>
               </a:spcBef>
               <a:spcAft>
-                <a:spcPts val="200"/>
+                <a:spcPts val="100"/>
               </a:spcAft>
             </a:pPr>
             <a:r>
@@ -5031,7 +5031,7 @@
           <a:noFill/>
         </p:spPr>
         <p:txBody>
-          <a:bodyPr wrap="square" lIns="0" rIns="0" tIns="0" bIns="0">
+          <a:bodyPr wrap="square" lIns="25400" rIns="25400" tIns="12700" bIns="12700">
             <a:spAutoFit/>
           </a:bodyPr>
           <a:lstStyle/>
@@ -5333,7 +5333,7 @@
           <a:noFill/>
         </p:spPr>
         <p:txBody>
-          <a:bodyPr wrap="square" lIns="0" rIns="0" tIns="0" bIns="0">
+          <a:bodyPr wrap="square" lIns="25400" rIns="25400" tIns="12700" bIns="12700">
             <a:spAutoFit/>
           </a:bodyPr>
           <a:lstStyle/>
@@ -5368,7 +5368,7 @@
           <a:noFill/>
         </p:spPr>
         <p:txBody>
-          <a:bodyPr wrap="square" lIns="0" rIns="0" tIns="0" bIns="0">
+          <a:bodyPr wrap="square" lIns="25400" rIns="25400" tIns="12700" bIns="12700">
             <a:spAutoFit/>
           </a:bodyPr>
           <a:lstStyle/>
@@ -5442,7 +5442,7 @@
         <p:spPr>
           <a:xfrm>
             <a:off x="4546292" y="1764792"/>
-            <a:ext cx="50292" cy="640080"/>
+            <a:ext cx="45720" cy="640080"/>
           </a:xfrm>
           <a:prstGeom prst="rect">
             <a:avLst/>
@@ -5484,8 +5484,8 @@
         </p:nvSpPr>
         <p:spPr>
           <a:xfrm>
-            <a:off x="4692596" y="1783080"/>
-            <a:ext cx="1517846" cy="658368"/>
+            <a:off x="4674308" y="1764792"/>
+            <a:ext cx="1554422" cy="676656"/>
           </a:xfrm>
           <a:prstGeom prst="rect">
             <a:avLst/>
@@ -5493,7 +5493,7 @@
           <a:noFill/>
         </p:spPr>
         <p:txBody>
-          <a:bodyPr wrap="square" lIns="0" rIns="0" tIns="0" bIns="0">
+          <a:bodyPr wrap="square" lIns="25400" rIns="25400" tIns="12700" bIns="12700">
             <a:spAutoFit/>
           </a:bodyPr>
           <a:lstStyle/>
@@ -5503,7 +5503,7 @@
                 <a:spcPts val="0"/>
               </a:spcBef>
               <a:spcAft>
-                <a:spcPts val="200"/>
+                <a:spcPts val="100"/>
               </a:spcAft>
             </a:pPr>
             <a:r>
@@ -5522,7 +5522,7 @@
                 <a:spcPts val="0"/>
               </a:spcBef>
               <a:spcAft>
-                <a:spcPts val="200"/>
+                <a:spcPts val="100"/>
               </a:spcAft>
             </a:pPr>
             <a:r>
@@ -5593,7 +5593,7 @@
         <p:spPr>
           <a:xfrm>
             <a:off x="6411610" y="1764792"/>
-            <a:ext cx="50292" cy="640080"/>
+            <a:ext cx="45720" cy="640080"/>
           </a:xfrm>
           <a:prstGeom prst="rect">
             <a:avLst/>
@@ -5635,8 +5635,8 @@
         </p:nvSpPr>
         <p:spPr>
           <a:xfrm>
-            <a:off x="6557914" y="1783080"/>
-            <a:ext cx="1517846" cy="658368"/>
+            <a:off x="6539626" y="1764792"/>
+            <a:ext cx="1554422" cy="676656"/>
           </a:xfrm>
           <a:prstGeom prst="rect">
             <a:avLst/>
@@ -5644,7 +5644,7 @@
           <a:noFill/>
         </p:spPr>
         <p:txBody>
-          <a:bodyPr wrap="square" lIns="0" rIns="0" tIns="0" bIns="0">
+          <a:bodyPr wrap="square" lIns="25400" rIns="25400" tIns="12700" bIns="12700">
             <a:spAutoFit/>
           </a:bodyPr>
           <a:lstStyle/>
@@ -5654,7 +5654,7 @@
                 <a:spcPts val="0"/>
               </a:spcBef>
               <a:spcAft>
-                <a:spcPts val="200"/>
+                <a:spcPts val="100"/>
               </a:spcAft>
             </a:pPr>
             <a:r>
@@ -5673,7 +5673,7 @@
                 <a:spcPts val="0"/>
               </a:spcBef>
               <a:spcAft>
-                <a:spcPts val="200"/>
+                <a:spcPts val="100"/>
               </a:spcAft>
             </a:pPr>
             <a:r>
@@ -5744,7 +5744,7 @@
         <p:spPr>
           <a:xfrm>
             <a:off x="4546292" y="2679192"/>
-            <a:ext cx="50292" cy="640080"/>
+            <a:ext cx="45720" cy="640080"/>
           </a:xfrm>
           <a:prstGeom prst="rect">
             <a:avLst/>
@@ -5786,8 +5786,8 @@
         </p:nvSpPr>
         <p:spPr>
           <a:xfrm>
-            <a:off x="4692596" y="2697480"/>
-            <a:ext cx="1517846" cy="658368"/>
+            <a:off x="4674308" y="2679192"/>
+            <a:ext cx="1554422" cy="676656"/>
           </a:xfrm>
           <a:prstGeom prst="rect">
             <a:avLst/>
@@ -5795,7 +5795,7 @@
           <a:noFill/>
         </p:spPr>
         <p:txBody>
-          <a:bodyPr wrap="square" lIns="0" rIns="0" tIns="0" bIns="0">
+          <a:bodyPr wrap="square" lIns="25400" rIns="25400" tIns="12700" bIns="12700">
             <a:spAutoFit/>
           </a:bodyPr>
           <a:lstStyle/>
@@ -5805,7 +5805,7 @@
                 <a:spcPts val="0"/>
               </a:spcBef>
               <a:spcAft>
-                <a:spcPts val="200"/>
+                <a:spcPts val="100"/>
               </a:spcAft>
             </a:pPr>
             <a:r>
@@ -5824,7 +5824,7 @@
                 <a:spcPts val="0"/>
               </a:spcBef>
               <a:spcAft>
-                <a:spcPts val="200"/>
+                <a:spcPts val="100"/>
               </a:spcAft>
             </a:pPr>
             <a:r>
@@ -5895,7 +5895,7 @@
         <p:spPr>
           <a:xfrm>
             <a:off x="6411610" y="2679192"/>
-            <a:ext cx="50292" cy="640080"/>
+            <a:ext cx="45720" cy="640080"/>
           </a:xfrm>
           <a:prstGeom prst="rect">
             <a:avLst/>
@@ -5937,8 +5937,8 @@
         </p:nvSpPr>
         <p:spPr>
           <a:xfrm>
-            <a:off x="6557914" y="2697480"/>
-            <a:ext cx="1517846" cy="658368"/>
+            <a:off x="6539626" y="2679192"/>
+            <a:ext cx="1554422" cy="676656"/>
           </a:xfrm>
           <a:prstGeom prst="rect">
             <a:avLst/>
@@ -5946,7 +5946,7 @@
           <a:noFill/>
         </p:spPr>
         <p:txBody>
-          <a:bodyPr wrap="square" lIns="0" rIns="0" tIns="0" bIns="0">
+          <a:bodyPr wrap="square" lIns="25400" rIns="25400" tIns="12700" bIns="12700">
             <a:spAutoFit/>
           </a:bodyPr>
           <a:lstStyle/>
@@ -5956,7 +5956,7 @@
                 <a:spcPts val="0"/>
               </a:spcBef>
               <a:spcAft>
-                <a:spcPts val="200"/>
+                <a:spcPts val="100"/>
               </a:spcAft>
             </a:pPr>
             <a:r>
@@ -5975,7 +5975,7 @@
                 <a:spcPts val="0"/>
               </a:spcBef>
               <a:spcAft>
-                <a:spcPts val="200"/>
+                <a:spcPts val="100"/>
               </a:spcAft>
             </a:pPr>
             <a:r>
@@ -6046,7 +6046,7 @@
         <p:spPr>
           <a:xfrm>
             <a:off x="4546292" y="3593592"/>
-            <a:ext cx="50292" cy="640080"/>
+            <a:ext cx="45720" cy="640080"/>
           </a:xfrm>
           <a:prstGeom prst="rect">
             <a:avLst/>
@@ -6088,8 +6088,8 @@
         </p:nvSpPr>
         <p:spPr>
           <a:xfrm>
-            <a:off x="4692596" y="3611880"/>
-            <a:ext cx="1517846" cy="658368"/>
+            <a:off x="4674308" y="3593592"/>
+            <a:ext cx="1554422" cy="676656"/>
           </a:xfrm>
           <a:prstGeom prst="rect">
             <a:avLst/>
@@ -6097,7 +6097,7 @@
           <a:noFill/>
         </p:spPr>
         <p:txBody>
-          <a:bodyPr wrap="square" lIns="0" rIns="0" tIns="0" bIns="0">
+          <a:bodyPr wrap="square" lIns="25400" rIns="25400" tIns="12700" bIns="12700">
             <a:spAutoFit/>
           </a:bodyPr>
           <a:lstStyle/>
@@ -6107,7 +6107,7 @@
                 <a:spcPts val="0"/>
               </a:spcBef>
               <a:spcAft>
-                <a:spcPts val="200"/>
+                <a:spcPts val="100"/>
               </a:spcAft>
             </a:pPr>
             <a:r>
@@ -6126,7 +6126,7 @@
                 <a:spcPts val="0"/>
               </a:spcBef>
               <a:spcAft>
-                <a:spcPts val="200"/>
+                <a:spcPts val="100"/>
               </a:spcAft>
             </a:pPr>
             <a:r>
@@ -6197,7 +6197,7 @@
         <p:spPr>
           <a:xfrm>
             <a:off x="6411610" y="3593592"/>
-            <a:ext cx="50292" cy="640080"/>
+            <a:ext cx="45720" cy="640080"/>
           </a:xfrm>
           <a:prstGeom prst="rect">
             <a:avLst/>
@@ -6239,8 +6239,8 @@
         </p:nvSpPr>
         <p:spPr>
           <a:xfrm>
-            <a:off x="6557914" y="3611880"/>
-            <a:ext cx="1517846" cy="658368"/>
+            <a:off x="6539626" y="3593592"/>
+            <a:ext cx="1554422" cy="676656"/>
           </a:xfrm>
           <a:prstGeom prst="rect">
             <a:avLst/>
@@ -6248,7 +6248,7 @@
           <a:noFill/>
         </p:spPr>
         <p:txBody>
-          <a:bodyPr wrap="square" lIns="0" rIns="0" tIns="0" bIns="0">
+          <a:bodyPr wrap="square" lIns="25400" rIns="25400" tIns="12700" bIns="12700">
             <a:spAutoFit/>
           </a:bodyPr>
           <a:lstStyle/>
@@ -6258,7 +6258,7 @@
                 <a:spcPts val="0"/>
               </a:spcBef>
               <a:spcAft>
-                <a:spcPts val="200"/>
+                <a:spcPts val="100"/>
               </a:spcAft>
             </a:pPr>
             <a:r>
@@ -6277,7 +6277,7 @@
                 <a:spcPts val="0"/>
               </a:spcBef>
               <a:spcAft>
-                <a:spcPts val="200"/>
+                <a:spcPts val="100"/>
               </a:spcAft>
             </a:pPr>
             <a:r>
@@ -6356,7 +6356,7 @@
           <a:noFill/>
         </p:spPr>
         <p:txBody>
-          <a:bodyPr wrap="square" lIns="0" rIns="0" tIns="0" bIns="0">
+          <a:bodyPr wrap="square" lIns="25400" rIns="25400" tIns="12700" bIns="12700">
             <a:spAutoFit/>
           </a:bodyPr>
           <a:lstStyle/>
@@ -6391,7 +6391,7 @@
           <a:noFill/>
         </p:spPr>
         <p:txBody>
-          <a:bodyPr wrap="square" lIns="0" rIns="0" tIns="0" bIns="0">
+          <a:bodyPr wrap="square" lIns="25400" rIns="25400" tIns="12700" bIns="12700">
             <a:spAutoFit/>
           </a:bodyPr>
           <a:lstStyle/>
@@ -6603,7 +6603,7 @@
           <a:noFill/>
         </p:spPr>
         <p:txBody>
-          <a:bodyPr wrap="square" lIns="0" rIns="0" tIns="0" bIns="0">
+          <a:bodyPr wrap="square" lIns="25400" rIns="25400" tIns="12700" bIns="12700">
             <a:spAutoFit/>
           </a:bodyPr>
           <a:lstStyle/>
@@ -6638,7 +6638,7 @@
           <a:noFill/>
         </p:spPr>
         <p:txBody>
-          <a:bodyPr wrap="square" lIns="0" rIns="0" tIns="0" bIns="0">
+          <a:bodyPr wrap="square" lIns="25400" rIns="25400" tIns="12700" bIns="12700">
             <a:spAutoFit/>
           </a:bodyPr>
           <a:lstStyle/>
@@ -6673,7 +6673,7 @@
           <a:noFill/>
         </p:spPr>
         <p:txBody>
-          <a:bodyPr wrap="square" lIns="0" rIns="0" tIns="0" bIns="0">
+          <a:bodyPr wrap="square" lIns="25400" rIns="25400" tIns="12700" bIns="12700">
             <a:spAutoFit/>
           </a:bodyPr>
           <a:lstStyle/>
@@ -6748,7 +6748,7 @@
         <p:spPr>
           <a:xfrm>
             <a:off x="8660977" y="1947672"/>
-            <a:ext cx="50292" cy="731520"/>
+            <a:ext cx="45720" cy="731520"/>
           </a:xfrm>
           <a:prstGeom prst="rect">
             <a:avLst/>
@@ -6790,8 +6790,8 @@
         </p:nvSpPr>
         <p:spPr>
           <a:xfrm>
-            <a:off x="8807281" y="1965960"/>
-            <a:ext cx="1014332" cy="749808"/>
+            <a:off x="8788993" y="1947672"/>
+            <a:ext cx="1050908" cy="768096"/>
           </a:xfrm>
           <a:prstGeom prst="rect">
             <a:avLst/>
@@ -6799,7 +6799,7 @@
           <a:noFill/>
         </p:spPr>
         <p:txBody>
-          <a:bodyPr wrap="square" lIns="0" rIns="0" tIns="0" bIns="0">
+          <a:bodyPr wrap="square" lIns="25400" rIns="25400" tIns="12700" bIns="12700">
             <a:spAutoFit/>
           </a:bodyPr>
           <a:lstStyle/>
@@ -6809,7 +6809,7 @@
                 <a:spcPts val="0"/>
               </a:spcBef>
               <a:spcAft>
-                <a:spcPts val="200"/>
+                <a:spcPts val="100"/>
               </a:spcAft>
             </a:pPr>
             <a:r>
@@ -6828,7 +6828,7 @@
                 <a:spcPts val="0"/>
               </a:spcBef>
               <a:spcAft>
-                <a:spcPts val="200"/>
+                <a:spcPts val="100"/>
               </a:spcAft>
             </a:pPr>
             <a:r>
@@ -6899,7 +6899,7 @@
         <p:spPr>
           <a:xfrm>
             <a:off x="8660977" y="2999232"/>
-            <a:ext cx="50292" cy="731520"/>
+            <a:ext cx="45720" cy="731520"/>
           </a:xfrm>
           <a:prstGeom prst="rect">
             <a:avLst/>
@@ -6941,8 +6941,8 @@
         </p:nvSpPr>
         <p:spPr>
           <a:xfrm>
-            <a:off x="8807281" y="3017520"/>
-            <a:ext cx="1014332" cy="749808"/>
+            <a:off x="8788993" y="2999232"/>
+            <a:ext cx="1050908" cy="768096"/>
           </a:xfrm>
           <a:prstGeom prst="rect">
             <a:avLst/>
@@ -6950,7 +6950,7 @@
           <a:noFill/>
         </p:spPr>
         <p:txBody>
-          <a:bodyPr wrap="square" lIns="0" rIns="0" tIns="0" bIns="0">
+          <a:bodyPr wrap="square" lIns="25400" rIns="25400" tIns="12700" bIns="12700">
             <a:spAutoFit/>
           </a:bodyPr>
           <a:lstStyle/>
@@ -6960,7 +6960,7 @@
                 <a:spcPts val="0"/>
               </a:spcBef>
               <a:spcAft>
-                <a:spcPts val="200"/>
+                <a:spcPts val="100"/>
               </a:spcAft>
             </a:pPr>
             <a:r>
@@ -6979,7 +6979,7 @@
                 <a:spcPts val="0"/>
               </a:spcBef>
               <a:spcAft>
-                <a:spcPts val="200"/>
+                <a:spcPts val="100"/>
               </a:spcAft>
             </a:pPr>
             <a:r>
@@ -7050,7 +7050,7 @@
         <p:spPr>
           <a:xfrm>
             <a:off x="8660977" y="4050792"/>
-            <a:ext cx="50292" cy="731520"/>
+            <a:ext cx="45720" cy="731520"/>
           </a:xfrm>
           <a:prstGeom prst="rect">
             <a:avLst/>
@@ -7092,8 +7092,8 @@
         </p:nvSpPr>
         <p:spPr>
           <a:xfrm>
-            <a:off x="8807281" y="4069080"/>
-            <a:ext cx="1014332" cy="749808"/>
+            <a:off x="8788993" y="4050792"/>
+            <a:ext cx="1050908" cy="768096"/>
           </a:xfrm>
           <a:prstGeom prst="rect">
             <a:avLst/>
@@ -7101,7 +7101,7 @@
           <a:noFill/>
         </p:spPr>
         <p:txBody>
-          <a:bodyPr wrap="square" lIns="0" rIns="0" tIns="0" bIns="0">
+          <a:bodyPr wrap="square" lIns="25400" rIns="25400" tIns="12700" bIns="12700">
             <a:spAutoFit/>
           </a:bodyPr>
           <a:lstStyle/>
@@ -7111,7 +7111,7 @@
                 <a:spcPts val="0"/>
               </a:spcBef>
               <a:spcAft>
-                <a:spcPts val="200"/>
+                <a:spcPts val="100"/>
               </a:spcAft>
             </a:pPr>
             <a:r>
@@ -7130,7 +7130,7 @@
                 <a:spcPts val="0"/>
               </a:spcBef>
               <a:spcAft>
-                <a:spcPts val="200"/>
+                <a:spcPts val="100"/>
               </a:spcAft>
             </a:pPr>
             <a:r>
@@ -7338,7 +7338,7 @@
           <a:noFill/>
         </p:spPr>
         <p:txBody>
-          <a:bodyPr wrap="square" lIns="0" rIns="0" tIns="0" bIns="0">
+          <a:bodyPr wrap="square" lIns="25400" rIns="25400" tIns="12700" bIns="12700">
             <a:spAutoFit/>
           </a:bodyPr>
           <a:lstStyle/>
@@ -7373,7 +7373,7 @@
           <a:noFill/>
         </p:spPr>
         <p:txBody>
-          <a:bodyPr wrap="square" lIns="0" rIns="0" tIns="0" bIns="0">
+          <a:bodyPr wrap="square" lIns="25400" rIns="25400" tIns="12700" bIns="12700">
             <a:spAutoFit/>
           </a:bodyPr>
           <a:lstStyle/>
@@ -7408,7 +7408,7 @@
           <a:noFill/>
         </p:spPr>
         <p:txBody>
-          <a:bodyPr wrap="square" lIns="0" rIns="0" tIns="0" bIns="0">
+          <a:bodyPr wrap="square" lIns="25400" rIns="25400" tIns="12700" bIns="12700">
             <a:spAutoFit/>
           </a:bodyPr>
           <a:lstStyle/>
@@ -7483,7 +7483,7 @@
         <p:spPr>
           <a:xfrm>
             <a:off x="10351965" y="1947672"/>
-            <a:ext cx="50292" cy="594360"/>
+            <a:ext cx="45720" cy="594360"/>
           </a:xfrm>
           <a:prstGeom prst="rect">
             <a:avLst/>
@@ -7525,8 +7525,8 @@
         </p:nvSpPr>
         <p:spPr>
           <a:xfrm>
-            <a:off x="10498269" y="1965960"/>
-            <a:ext cx="1144783" cy="612648"/>
+            <a:off x="10479981" y="1947672"/>
+            <a:ext cx="1181359" cy="630936"/>
           </a:xfrm>
           <a:prstGeom prst="rect">
             <a:avLst/>
@@ -7534,7 +7534,7 @@
           <a:noFill/>
         </p:spPr>
         <p:txBody>
-          <a:bodyPr wrap="square" lIns="0" rIns="0" tIns="0" bIns="0">
+          <a:bodyPr wrap="square" lIns="25400" rIns="25400" tIns="12700" bIns="12700">
             <a:spAutoFit/>
           </a:bodyPr>
           <a:lstStyle/>
@@ -7544,7 +7544,7 @@
                 <a:spcPts val="0"/>
               </a:spcBef>
               <a:spcAft>
-                <a:spcPts val="200"/>
+                <a:spcPts val="100"/>
               </a:spcAft>
             </a:pPr>
             <a:r>
@@ -7563,7 +7563,7 @@
                 <a:spcPts val="0"/>
               </a:spcBef>
               <a:spcAft>
-                <a:spcPts val="200"/>
+                <a:spcPts val="100"/>
               </a:spcAft>
             </a:pPr>
             <a:r>
@@ -7634,7 +7634,7 @@
         <p:spPr>
           <a:xfrm>
             <a:off x="10351965" y="2816352"/>
-            <a:ext cx="50292" cy="594360"/>
+            <a:ext cx="45720" cy="594360"/>
           </a:xfrm>
           <a:prstGeom prst="rect">
             <a:avLst/>
@@ -7676,8 +7676,8 @@
         </p:nvSpPr>
         <p:spPr>
           <a:xfrm>
-            <a:off x="10498269" y="2834640"/>
-            <a:ext cx="1144783" cy="612648"/>
+            <a:off x="10479981" y="2816352"/>
+            <a:ext cx="1181359" cy="630936"/>
           </a:xfrm>
           <a:prstGeom prst="rect">
             <a:avLst/>
@@ -7685,7 +7685,7 @@
           <a:noFill/>
         </p:spPr>
         <p:txBody>
-          <a:bodyPr wrap="square" lIns="0" rIns="0" tIns="0" bIns="0">
+          <a:bodyPr wrap="square" lIns="25400" rIns="25400" tIns="12700" bIns="12700">
             <a:spAutoFit/>
           </a:bodyPr>
           <a:lstStyle/>
@@ -7695,7 +7695,7 @@
                 <a:spcPts val="0"/>
               </a:spcBef>
               <a:spcAft>
-                <a:spcPts val="200"/>
+                <a:spcPts val="100"/>
               </a:spcAft>
             </a:pPr>
             <a:r>
@@ -7714,7 +7714,7 @@
                 <a:spcPts val="0"/>
               </a:spcBef>
               <a:spcAft>
-                <a:spcPts val="200"/>
+                <a:spcPts val="100"/>
               </a:spcAft>
             </a:pPr>
             <a:r>
@@ -7785,7 +7785,7 @@
         <p:spPr>
           <a:xfrm>
             <a:off x="10351965" y="3685032"/>
-            <a:ext cx="50292" cy="594360"/>
+            <a:ext cx="45720" cy="594360"/>
           </a:xfrm>
           <a:prstGeom prst="rect">
             <a:avLst/>
@@ -7827,8 +7827,8 @@
         </p:nvSpPr>
         <p:spPr>
           <a:xfrm>
-            <a:off x="10498269" y="3703320"/>
-            <a:ext cx="1144783" cy="612648"/>
+            <a:off x="10479981" y="3685032"/>
+            <a:ext cx="1181359" cy="630936"/>
           </a:xfrm>
           <a:prstGeom prst="rect">
             <a:avLst/>
@@ -7836,7 +7836,7 @@
           <a:noFill/>
         </p:spPr>
         <p:txBody>
-          <a:bodyPr wrap="square" lIns="0" rIns="0" tIns="0" bIns="0">
+          <a:bodyPr wrap="square" lIns="25400" rIns="25400" tIns="12700" bIns="12700">
             <a:spAutoFit/>
           </a:bodyPr>
           <a:lstStyle/>
@@ -7846,7 +7846,7 @@
                 <a:spcPts val="0"/>
               </a:spcBef>
               <a:spcAft>
-                <a:spcPts val="200"/>
+                <a:spcPts val="100"/>
               </a:spcAft>
             </a:pPr>
             <a:r>
@@ -7865,7 +7865,7 @@
                 <a:spcPts val="0"/>
               </a:spcBef>
               <a:spcAft>
-                <a:spcPts val="200"/>
+                <a:spcPts val="100"/>
               </a:spcAft>
             </a:pPr>
             <a:r>
@@ -7936,7 +7936,7 @@
         <p:spPr>
           <a:xfrm>
             <a:off x="10351965" y="4553711"/>
-            <a:ext cx="50292" cy="594360"/>
+            <a:ext cx="45720" cy="594360"/>
           </a:xfrm>
           <a:prstGeom prst="rect">
             <a:avLst/>
@@ -7978,8 +7978,8 @@
         </p:nvSpPr>
         <p:spPr>
           <a:xfrm>
-            <a:off x="10498269" y="4571999"/>
-            <a:ext cx="1144783" cy="612648"/>
+            <a:off x="10479981" y="4553711"/>
+            <a:ext cx="1181359" cy="630936"/>
           </a:xfrm>
           <a:prstGeom prst="rect">
             <a:avLst/>
@@ -7987,7 +7987,7 @@
           <a:noFill/>
         </p:spPr>
         <p:txBody>
-          <a:bodyPr wrap="square" lIns="0" rIns="0" tIns="0" bIns="0">
+          <a:bodyPr wrap="square" lIns="25400" rIns="25400" tIns="12700" bIns="12700">
             <a:spAutoFit/>
           </a:bodyPr>
           <a:lstStyle/>
@@ -7997,7 +7997,7 @@
                 <a:spcPts val="0"/>
               </a:spcBef>
               <a:spcAft>
-                <a:spcPts val="200"/>
+                <a:spcPts val="100"/>
               </a:spcAft>
             </a:pPr>
             <a:r>
@@ -8007,7 +8007,7 @@
                 </a:solidFill>
                 <a:latin typeface="Calibri"/>
               </a:rPr>
-              <a:t>→ xapi</a:t>
+              <a:t>→ XAPI</a:t>
             </a:r>
           </a:p>
           <a:p>
@@ -8016,7 +8016,7 @@
                 <a:spcPts val="0"/>
               </a:spcBef>
               <a:spcAft>
-                <a:spcPts val="200"/>
+                <a:spcPts val="100"/>
               </a:spcAft>
             </a:pPr>
             <a:r>
@@ -8310,7 +8310,7 @@
         <p:spPr>
           <a:xfrm>
             <a:off x="1828800" y="6181344"/>
-            <a:ext cx="256032" cy="256032"/>
+            <a:ext cx="237744" cy="237744"/>
           </a:xfrm>
           <a:prstGeom prst="rect">
             <a:avLst/>
@@ -8333,8 +8333,8 @@
         </p:blipFill>
         <p:spPr>
           <a:xfrm>
-            <a:off x="2148840" y="6181344"/>
-            <a:ext cx="256032" cy="256032"/>
+            <a:off x="2121408" y="6181344"/>
+            <a:ext cx="237744" cy="237744"/>
           </a:xfrm>
           <a:prstGeom prst="rect">
             <a:avLst/>
@@ -8357,8 +8357,8 @@
         </p:blipFill>
         <p:spPr>
           <a:xfrm>
-            <a:off x="2468880" y="6181344"/>
-            <a:ext cx="256032" cy="256032"/>
+            <a:off x="2414016" y="6181344"/>
+            <a:ext cx="237744" cy="237744"/>
           </a:xfrm>
           <a:prstGeom prst="rect">
             <a:avLst/>
@@ -8373,7 +8373,7 @@
         </p:nvSpPr>
         <p:spPr>
           <a:xfrm>
-            <a:off x="2834640" y="6199632"/>
+            <a:off x="2788920" y="6199632"/>
             <a:ext cx="7315200" cy="292608"/>
           </a:xfrm>
           <a:prstGeom prst="rect">
@@ -8382,7 +8382,7 @@
           <a:noFill/>
         </p:spPr>
         <p:txBody>
-          <a:bodyPr wrap="square" lIns="0" rIns="0" tIns="0" bIns="0">
+          <a:bodyPr wrap="square" lIns="25400" rIns="25400" tIns="12700" bIns="12700">
             <a:spAutoFit/>
           </a:bodyPr>
           <a:lstStyle/>
@@ -8417,7 +8417,7 @@
           <a:noFill/>
         </p:spPr>
         <p:txBody>
-          <a:bodyPr wrap="square" lIns="0" rIns="0" tIns="0" bIns="0">
+          <a:bodyPr wrap="square" lIns="25400" rIns="25400" tIns="12700" bIns="12700">
             <a:spAutoFit/>
           </a:bodyPr>
           <a:lstStyle/>
@@ -8547,8 +8547,8 @@
         </p:nvSpPr>
         <p:spPr>
           <a:xfrm>
-            <a:off x="365760" y="128016"/>
-            <a:ext cx="8686800" cy="274320"/>
+            <a:off x="365760" y="146304"/>
+            <a:ext cx="7315200" cy="292608"/>
           </a:xfrm>
           <a:prstGeom prst="rect">
             <a:avLst/>
@@ -8556,14 +8556,14 @@
           <a:noFill/>
         </p:spPr>
         <p:txBody>
-          <a:bodyPr wrap="square" lIns="0" rIns="0" tIns="0" bIns="0">
+          <a:bodyPr wrap="square" lIns="25400" rIns="25400" tIns="12700" bIns="12700">
             <a:spAutoFit/>
           </a:bodyPr>
           <a:lstStyle/>
           <a:p>
             <a:pPr algn="l"/>
             <a:r>
-              <a:rPr sz="2200" b="1">
+              <a:rPr sz="2000" b="1">
                 <a:solidFill>
                   <a:srgbClr val="F8FAFC"/>
                 </a:solidFill>
@@ -8590,8 +8590,8 @@
         </p:blipFill>
         <p:spPr>
           <a:xfrm>
-            <a:off x="8732520" y="128016"/>
-            <a:ext cx="310896" cy="310896"/>
+            <a:off x="8229600" y="146304"/>
+            <a:ext cx="292608" cy="292608"/>
           </a:xfrm>
           <a:prstGeom prst="rect">
             <a:avLst/>
@@ -8606,8 +8606,8 @@
         </p:nvSpPr>
         <p:spPr>
           <a:xfrm>
-            <a:off x="9098280" y="164592"/>
-            <a:ext cx="502920" cy="237744"/>
+            <a:off x="8558784" y="164592"/>
+            <a:ext cx="457200" cy="256032"/>
           </a:xfrm>
           <a:prstGeom prst="rect">
             <a:avLst/>
@@ -8615,7 +8615,7 @@
           <a:noFill/>
         </p:spPr>
         <p:txBody>
-          <a:bodyPr wrap="square" lIns="0" rIns="0" tIns="0" bIns="0">
+          <a:bodyPr wrap="square" lIns="25400" rIns="25400" tIns="12700" bIns="12700">
             <a:spAutoFit/>
           </a:bodyPr>
           <a:lstStyle/>
@@ -8649,8 +8649,8 @@
         </p:blipFill>
         <p:spPr>
           <a:xfrm>
-            <a:off x="9601200" y="128016"/>
-            <a:ext cx="310896" cy="310896"/>
+            <a:off x="9098280" y="146304"/>
+            <a:ext cx="292608" cy="292608"/>
           </a:xfrm>
           <a:prstGeom prst="rect">
             <a:avLst/>
@@ -8665,8 +8665,8 @@
         </p:nvSpPr>
         <p:spPr>
           <a:xfrm>
-            <a:off x="9966960" y="164592"/>
-            <a:ext cx="411480" cy="237744"/>
+            <a:off x="9436608" y="164592"/>
+            <a:ext cx="411480" cy="256032"/>
           </a:xfrm>
           <a:prstGeom prst="rect">
             <a:avLst/>
@@ -8674,7 +8674,7 @@
           <a:noFill/>
         </p:spPr>
         <p:txBody>
-          <a:bodyPr wrap="square" lIns="0" rIns="0" tIns="0" bIns="0">
+          <a:bodyPr wrap="square" lIns="25400" rIns="25400" tIns="12700" bIns="12700">
             <a:spAutoFit/>
           </a:bodyPr>
           <a:lstStyle/>
@@ -8694,49 +8694,14 @@
       </p:sp>
       <p:sp>
         <p:nvSpPr>
-          <p:cNvPr id="9" name="TextBox 8"/>
-          <p:cNvSpPr txBox="1"/>
-          <p:nvPr/>
-        </p:nvSpPr>
-        <p:spPr>
-          <a:xfrm>
-            <a:off x="365760" y="438912"/>
-            <a:ext cx="9144000" cy="219456"/>
-          </a:xfrm>
-          <a:prstGeom prst="rect">
-            <a:avLst/>
-          </a:prstGeom>
-          <a:noFill/>
-        </p:spPr>
-        <p:txBody>
-          <a:bodyPr wrap="square" lIns="0" rIns="0" tIns="0" bIns="0">
-            <a:spAutoFit/>
-          </a:bodyPr>
-          <a:lstStyle/>
-          <a:p>
-            <a:pPr algn="l"/>
-            <a:r>
-              <a:rPr sz="1200" b="0">
-                <a:solidFill>
-                  <a:srgbClr val="94A3B8"/>
-                </a:solidFill>
-                <a:latin typeface="Calibri"/>
-              </a:rPr>
-              <a:t>LedgeRX talks to a single UAF layer only  ·  that layer applies UAF logic  ·  then fans out internally</a:t>
-            </a:r>
-          </a:p>
-        </p:txBody>
-      </p:sp>
-      <p:sp>
-        <p:nvSpPr>
-          <p:cNvPr id="10" name="Rounded Rectangle 9"/>
+          <p:cNvPr id="9" name="Rounded Rectangle 8"/>
           <p:cNvSpPr/>
           <p:nvPr/>
         </p:nvSpPr>
         <p:spPr>
           <a:xfrm>
-            <a:off x="10241280" y="475488"/>
-            <a:ext cx="1554480" cy="292608"/>
+            <a:off x="10058400" y="128016"/>
+            <a:ext cx="1737360" cy="329184"/>
           </a:xfrm>
           <a:prstGeom prst="roundRect">
             <a:avLst>
@@ -8776,14 +8741,14 @@
       </p:sp>
       <p:sp>
         <p:nvSpPr>
-          <p:cNvPr id="11" name="TextBox 10"/>
+          <p:cNvPr id="10" name="TextBox 9"/>
           <p:cNvSpPr txBox="1"/>
           <p:nvPr/>
         </p:nvSpPr>
         <p:spPr>
           <a:xfrm>
-            <a:off x="10241280" y="493776"/>
-            <a:ext cx="1554480" cy="256032"/>
+            <a:off x="10058400" y="164592"/>
+            <a:ext cx="1737360" cy="256032"/>
           </a:xfrm>
           <a:prstGeom prst="rect">
             <a:avLst/>
@@ -8791,7 +8756,7 @@
           <a:noFill/>
         </p:spPr>
         <p:txBody>
-          <a:bodyPr wrap="square" lIns="0" rIns="0" tIns="0" bIns="0">
+          <a:bodyPr wrap="square" lIns="25400" rIns="25400" tIns="12700" bIns="12700">
             <a:spAutoFit/>
           </a:bodyPr>
           <a:lstStyle/>
@@ -8811,6 +8776,41 @@
       </p:sp>
       <p:sp>
         <p:nvSpPr>
+          <p:cNvPr id="11" name="TextBox 10"/>
+          <p:cNvSpPr txBox="1"/>
+          <p:nvPr/>
+        </p:nvSpPr>
+        <p:spPr>
+          <a:xfrm>
+            <a:off x="365760" y="475488"/>
+            <a:ext cx="11430000" cy="219456"/>
+          </a:xfrm>
+          <a:prstGeom prst="rect">
+            <a:avLst/>
+          </a:prstGeom>
+          <a:noFill/>
+        </p:spPr>
+        <p:txBody>
+          <a:bodyPr wrap="square" lIns="25400" rIns="25400" tIns="12700" bIns="12700">
+            <a:spAutoFit/>
+          </a:bodyPr>
+          <a:lstStyle/>
+          <a:p>
+            <a:pPr algn="l"/>
+            <a:r>
+              <a:rPr sz="1200" b="0">
+                <a:solidFill>
+                  <a:srgbClr val="94A3B8"/>
+                </a:solidFill>
+                <a:latin typeface="Calibri"/>
+              </a:rPr>
+              <a:t>LedgeRX talks to a single UAF layer only  ·  that layer applies UAF logic  ·  then fans out internally</a:t>
+            </a:r>
+          </a:p>
+        </p:txBody>
+      </p:sp>
+      <p:sp>
+        <p:nvSpPr>
           <p:cNvPr id="12" name="Rounded Rectangle 11"/>
           <p:cNvSpPr/>
           <p:nvPr/>
@@ -8818,7 +8818,7 @@
         <p:spPr>
           <a:xfrm>
             <a:off x="365760" y="804672"/>
-            <a:ext cx="11457432" cy="914400"/>
+            <a:ext cx="11457432" cy="868680"/>
           </a:xfrm>
           <a:prstGeom prst="roundRect">
             <a:avLst>
@@ -8864,8 +8864,8 @@
         </p:nvSpPr>
         <p:spPr>
           <a:xfrm>
-            <a:off x="502920" y="914400"/>
-            <a:ext cx="1828800" cy="274320"/>
+            <a:off x="502920" y="932688"/>
+            <a:ext cx="1691640" cy="256032"/>
           </a:xfrm>
           <a:prstGeom prst="roundRect">
             <a:avLst>
@@ -8909,8 +8909,8 @@
         </p:nvSpPr>
         <p:spPr>
           <a:xfrm>
-            <a:off x="502920" y="932688"/>
-            <a:ext cx="1828800" cy="237744"/>
+            <a:off x="502920" y="941832"/>
+            <a:ext cx="1691640" cy="237744"/>
           </a:xfrm>
           <a:prstGeom prst="rect">
             <a:avLst/>
@@ -8918,7 +8918,7 @@
           <a:noFill/>
         </p:spPr>
         <p:txBody>
-          <a:bodyPr wrap="square" lIns="0" rIns="0" tIns="0" bIns="0">
+          <a:bodyPr wrap="square" lIns="25400" rIns="25400" tIns="12700" bIns="12700">
             <a:spAutoFit/>
           </a:bodyPr>
           <a:lstStyle/>
@@ -8944,8 +8944,8 @@
         </p:nvSpPr>
         <p:spPr>
           <a:xfrm>
-            <a:off x="2514600" y="896112"/>
-            <a:ext cx="8686800" cy="256032"/>
+            <a:off x="2377440" y="914400"/>
+            <a:ext cx="8961120" cy="256032"/>
           </a:xfrm>
           <a:prstGeom prst="rect">
             <a:avLst/>
@@ -8953,7 +8953,7 @@
           <a:noFill/>
         </p:spPr>
         <p:txBody>
-          <a:bodyPr wrap="square" lIns="0" rIns="0" tIns="0" bIns="0">
+          <a:bodyPr wrap="square" lIns="25400" rIns="25400" tIns="12700" bIns="12700">
             <a:spAutoFit/>
           </a:bodyPr>
           <a:lstStyle/>
@@ -8987,8 +8987,8 @@
         </p:blipFill>
         <p:spPr>
           <a:xfrm>
-            <a:off x="2514600" y="1243584"/>
-            <a:ext cx="256032" cy="256032"/>
+            <a:off x="2377440" y="1261872"/>
+            <a:ext cx="237744" cy="237744"/>
           </a:xfrm>
           <a:prstGeom prst="rect">
             <a:avLst/>
@@ -9003,8 +9003,8 @@
         </p:nvSpPr>
         <p:spPr>
           <a:xfrm>
-            <a:off x="2834640" y="1261872"/>
-            <a:ext cx="8503920" cy="256032"/>
+            <a:off x="2697480" y="1261872"/>
+            <a:ext cx="8686800" cy="256032"/>
           </a:xfrm>
           <a:prstGeom prst="rect">
             <a:avLst/>
@@ -9012,7 +9012,7 @@
           <a:noFill/>
         </p:spPr>
         <p:txBody>
-          <a:bodyPr wrap="square" lIns="0" rIns="0" tIns="0" bIns="0">
+          <a:bodyPr wrap="square" lIns="25400" rIns="25400" tIns="12700" bIns="12700">
             <a:spAutoFit/>
           </a:bodyPr>
           <a:lstStyle/>
@@ -9025,7 +9025,7 @@
                 </a:solidFill>
                 <a:latin typeface="Calibri"/>
               </a:rPr>
-              <a:t>Emits:  balance.updated  ·  reward redemption request  ·  ledger outcomes   (Kafka / webhook)</a:t>
+              <a:t>Emits:  balance.updated  ·  reward redemption request  ·  ledger outcomes   (Kafka / HTTP callbacks)</a:t>
             </a:r>
           </a:p>
         </p:txBody>
@@ -9038,8 +9038,8 @@
         </p:nvSpPr>
         <p:spPr>
           <a:xfrm>
-            <a:off x="5943600" y="1810512"/>
-            <a:ext cx="182880" cy="182880"/>
+            <a:off x="5897880" y="1783080"/>
+            <a:ext cx="164592" cy="164592"/>
           </a:xfrm>
           <a:prstGeom prst="downArrow">
             <a:avLst/>
@@ -9081,8 +9081,8 @@
         </p:nvSpPr>
         <p:spPr>
           <a:xfrm>
-            <a:off x="6263640" y="1810512"/>
-            <a:ext cx="2011680" cy="201168"/>
+            <a:off x="6172200" y="1783080"/>
+            <a:ext cx="1645920" cy="182880"/>
           </a:xfrm>
           <a:prstGeom prst="rect">
             <a:avLst/>
@@ -9090,7 +9090,7 @@
           <a:noFill/>
         </p:spPr>
         <p:txBody>
-          <a:bodyPr wrap="square" lIns="0" rIns="0" tIns="0" bIns="0">
+          <a:bodyPr wrap="square" lIns="25400" rIns="25400" tIns="12700" bIns="12700">
             <a:spAutoFit/>
           </a:bodyPr>
           <a:lstStyle/>
@@ -9116,8 +9116,8 @@
         </p:nvSpPr>
         <p:spPr>
           <a:xfrm>
-            <a:off x="365760" y="2057400"/>
-            <a:ext cx="11457432" cy="1298448"/>
+            <a:off x="365760" y="2029968"/>
+            <a:ext cx="11457432" cy="1353312"/>
           </a:xfrm>
           <a:prstGeom prst="roundRect">
             <a:avLst>
@@ -9163,8 +9163,8 @@
         </p:nvSpPr>
         <p:spPr>
           <a:xfrm>
-            <a:off x="502920" y="2148840"/>
-            <a:ext cx="2606040" cy="256032"/>
+            <a:off x="502920" y="2139696"/>
+            <a:ext cx="2468880" cy="256032"/>
           </a:xfrm>
           <a:prstGeom prst="roundRect">
             <a:avLst>
@@ -9208,8 +9208,8 @@
         </p:nvSpPr>
         <p:spPr>
           <a:xfrm>
-            <a:off x="502920" y="2167128"/>
-            <a:ext cx="2606040" cy="219456"/>
+            <a:off x="502920" y="2148840"/>
+            <a:ext cx="2468880" cy="237744"/>
           </a:xfrm>
           <a:prstGeom prst="rect">
             <a:avLst/>
@@ -9217,7 +9217,7 @@
           <a:noFill/>
         </p:spPr>
         <p:txBody>
-          <a:bodyPr wrap="square" lIns="0" rIns="0" tIns="0" bIns="0">
+          <a:bodyPr wrap="square" lIns="25400" rIns="25400" tIns="12700" bIns="12700">
             <a:spAutoFit/>
           </a:bodyPr>
           <a:lstStyle/>
@@ -9251,7 +9251,7 @@
         </p:blipFill>
         <p:spPr>
           <a:xfrm>
-            <a:off x="3200400" y="2148840"/>
+            <a:off x="3108960" y="2139696"/>
             <a:ext cx="256032" cy="256032"/>
           </a:xfrm>
           <a:prstGeom prst="rect">
@@ -9267,8 +9267,8 @@
         </p:nvSpPr>
         <p:spPr>
           <a:xfrm>
-            <a:off x="3520440" y="2148840"/>
-            <a:ext cx="7772400" cy="256032"/>
+            <a:off x="3456432" y="2139696"/>
+            <a:ext cx="7955279" cy="256032"/>
           </a:xfrm>
           <a:prstGeom prst="rect">
             <a:avLst/>
@@ -9276,7 +9276,7 @@
           <a:noFill/>
         </p:spPr>
         <p:txBody>
-          <a:bodyPr wrap="square" lIns="0" rIns="0" tIns="0" bIns="0">
+          <a:bodyPr wrap="square" lIns="25400" rIns="25400" tIns="12700" bIns="12700">
             <a:spAutoFit/>
           </a:bodyPr>
           <a:lstStyle/>
@@ -9303,7 +9303,7 @@
         <p:spPr>
           <a:xfrm>
             <a:off x="502920" y="2532888"/>
-            <a:ext cx="3611880" cy="658368"/>
+            <a:ext cx="3611880" cy="685800"/>
           </a:xfrm>
           <a:prstGeom prst="roundRect">
             <a:avLst>
@@ -9357,8 +9357,8 @@
         </p:blipFill>
         <p:spPr>
           <a:xfrm>
-            <a:off x="612648" y="2624328"/>
-            <a:ext cx="329184" cy="329184"/>
+            <a:off x="612648" y="2697480"/>
+            <a:ext cx="347472" cy="347472"/>
           </a:xfrm>
           <a:prstGeom prst="rect">
             <a:avLst/>
@@ -9373,8 +9373,8 @@
         </p:nvSpPr>
         <p:spPr>
           <a:xfrm>
-            <a:off x="1005840" y="2587752"/>
-            <a:ext cx="2971800" cy="256032"/>
+            <a:off x="1033272" y="2642616"/>
+            <a:ext cx="2926080" cy="256032"/>
           </a:xfrm>
           <a:prstGeom prst="rect">
             <a:avLst/>
@@ -9382,7 +9382,7 @@
           <a:noFill/>
         </p:spPr>
         <p:txBody>
-          <a:bodyPr wrap="square" lIns="0" rIns="0" tIns="0" bIns="0">
+          <a:bodyPr wrap="square" lIns="25400" rIns="25400" tIns="12700" bIns="12700">
             <a:spAutoFit/>
           </a:bodyPr>
           <a:lstStyle/>
@@ -9408,8 +9408,8 @@
         </p:nvSpPr>
         <p:spPr>
           <a:xfrm>
-            <a:off x="1005840" y="2862072"/>
-            <a:ext cx="2971800" cy="256032"/>
+            <a:off x="1033272" y="2916936"/>
+            <a:ext cx="2926080" cy="256032"/>
           </a:xfrm>
           <a:prstGeom prst="rect">
             <a:avLst/>
@@ -9417,7 +9417,7 @@
           <a:noFill/>
         </p:spPr>
         <p:txBody>
-          <a:bodyPr wrap="square" lIns="0" rIns="0" tIns="0" bIns="0">
+          <a:bodyPr wrap="square" lIns="25400" rIns="25400" tIns="12700" bIns="12700">
             <a:spAutoFit/>
           </a:bodyPr>
           <a:lstStyle/>
@@ -9444,7 +9444,7 @@
         <p:spPr>
           <a:xfrm>
             <a:off x="4279392" y="2532888"/>
-            <a:ext cx="3611880" cy="658368"/>
+            <a:ext cx="3611880" cy="685800"/>
           </a:xfrm>
           <a:prstGeom prst="roundRect">
             <a:avLst>
@@ -9498,8 +9498,8 @@
         </p:blipFill>
         <p:spPr>
           <a:xfrm>
-            <a:off x="4389120" y="2624328"/>
-            <a:ext cx="329184" cy="329184"/>
+            <a:off x="4389120" y="2697480"/>
+            <a:ext cx="347472" cy="347472"/>
           </a:xfrm>
           <a:prstGeom prst="rect">
             <a:avLst/>
@@ -9514,8 +9514,8 @@
         </p:nvSpPr>
         <p:spPr>
           <a:xfrm>
-            <a:off x="4782312" y="2587752"/>
-            <a:ext cx="2971800" cy="256032"/>
+            <a:off x="4809744" y="2642616"/>
+            <a:ext cx="2926080" cy="256032"/>
           </a:xfrm>
           <a:prstGeom prst="rect">
             <a:avLst/>
@@ -9523,7 +9523,7 @@
           <a:noFill/>
         </p:spPr>
         <p:txBody>
-          <a:bodyPr wrap="square" lIns="0" rIns="0" tIns="0" bIns="0">
+          <a:bodyPr wrap="square" lIns="25400" rIns="25400" tIns="12700" bIns="12700">
             <a:spAutoFit/>
           </a:bodyPr>
           <a:lstStyle/>
@@ -9549,8 +9549,8 @@
         </p:nvSpPr>
         <p:spPr>
           <a:xfrm>
-            <a:off x="4782312" y="2862072"/>
-            <a:ext cx="2971800" cy="256032"/>
+            <a:off x="4809744" y="2916936"/>
+            <a:ext cx="2926080" cy="256032"/>
           </a:xfrm>
           <a:prstGeom prst="rect">
             <a:avLst/>
@@ -9558,7 +9558,7 @@
           <a:noFill/>
         </p:spPr>
         <p:txBody>
-          <a:bodyPr wrap="square" lIns="0" rIns="0" tIns="0" bIns="0">
+          <a:bodyPr wrap="square" lIns="25400" rIns="25400" tIns="12700" bIns="12700">
             <a:spAutoFit/>
           </a:bodyPr>
           <a:lstStyle/>
@@ -9585,7 +9585,7 @@
         <p:spPr>
           <a:xfrm>
             <a:off x="8055864" y="2532888"/>
-            <a:ext cx="3611880" cy="658368"/>
+            <a:ext cx="3611880" cy="685800"/>
           </a:xfrm>
           <a:prstGeom prst="roundRect">
             <a:avLst>
@@ -9639,8 +9639,8 @@
         </p:blipFill>
         <p:spPr>
           <a:xfrm>
-            <a:off x="8165592" y="2624328"/>
-            <a:ext cx="329184" cy="329184"/>
+            <a:off x="8165592" y="2697480"/>
+            <a:ext cx="347472" cy="347472"/>
           </a:xfrm>
           <a:prstGeom prst="rect">
             <a:avLst/>
@@ -9655,8 +9655,8 @@
         </p:nvSpPr>
         <p:spPr>
           <a:xfrm>
-            <a:off x="8558784" y="2587752"/>
-            <a:ext cx="2971800" cy="256032"/>
+            <a:off x="8586216" y="2642616"/>
+            <a:ext cx="2926080" cy="256032"/>
           </a:xfrm>
           <a:prstGeom prst="rect">
             <a:avLst/>
@@ -9664,7 +9664,7 @@
           <a:noFill/>
         </p:spPr>
         <p:txBody>
-          <a:bodyPr wrap="square" lIns="0" rIns="0" tIns="0" bIns="0">
+          <a:bodyPr wrap="square" lIns="25400" rIns="25400" tIns="12700" bIns="12700">
             <a:spAutoFit/>
           </a:bodyPr>
           <a:lstStyle/>
@@ -9690,8 +9690,8 @@
         </p:nvSpPr>
         <p:spPr>
           <a:xfrm>
-            <a:off x="8558784" y="2862072"/>
-            <a:ext cx="2971800" cy="256032"/>
+            <a:off x="8586216" y="2916936"/>
+            <a:ext cx="2926080" cy="256032"/>
           </a:xfrm>
           <a:prstGeom prst="rect">
             <a:avLst/>
@@ -9699,7 +9699,7 @@
           <a:noFill/>
         </p:spPr>
         <p:txBody>
-          <a:bodyPr wrap="square" lIns="0" rIns="0" tIns="0" bIns="0">
+          <a:bodyPr wrap="square" lIns="25400" rIns="25400" tIns="12700" bIns="12700">
             <a:spAutoFit/>
           </a:bodyPr>
           <a:lstStyle/>
@@ -9725,8 +9725,8 @@
         </p:nvSpPr>
         <p:spPr>
           <a:xfrm>
-            <a:off x="1600200" y="3474720"/>
-            <a:ext cx="146304" cy="146304"/>
+            <a:off x="1645920" y="3493008"/>
+            <a:ext cx="137160" cy="137160"/>
           </a:xfrm>
           <a:prstGeom prst="downArrow">
             <a:avLst/>
@@ -9768,8 +9768,8 @@
         </p:nvSpPr>
         <p:spPr>
           <a:xfrm>
-            <a:off x="4251960" y="3474720"/>
-            <a:ext cx="146304" cy="146304"/>
+            <a:off x="4297680" y="3493008"/>
+            <a:ext cx="137160" cy="137160"/>
           </a:xfrm>
           <a:prstGeom prst="downArrow">
             <a:avLst/>
@@ -9811,8 +9811,8 @@
         </p:nvSpPr>
         <p:spPr>
           <a:xfrm>
-            <a:off x="6903720" y="3474720"/>
-            <a:ext cx="146304" cy="146304"/>
+            <a:off x="6949440" y="3493008"/>
+            <a:ext cx="137160" cy="137160"/>
           </a:xfrm>
           <a:prstGeom prst="downArrow">
             <a:avLst/>
@@ -9854,8 +9854,8 @@
         </p:nvSpPr>
         <p:spPr>
           <a:xfrm>
-            <a:off x="9555480" y="3474720"/>
-            <a:ext cx="146304" cy="146304"/>
+            <a:off x="9601200" y="3493008"/>
+            <a:ext cx="137160" cy="137160"/>
           </a:xfrm>
           <a:prstGeom prst="downArrow">
             <a:avLst/>
@@ -9906,7 +9906,7 @@
           <a:noFill/>
         </p:spPr>
         <p:txBody>
-          <a:bodyPr wrap="square" lIns="0" rIns="0" tIns="0" bIns="0">
+          <a:bodyPr wrap="square" lIns="25400" rIns="25400" tIns="12700" bIns="12700">
             <a:spAutoFit/>
           </a:bodyPr>
           <a:lstStyle/>
@@ -9932,8 +9932,8 @@
         </p:nvSpPr>
         <p:spPr>
           <a:xfrm>
-            <a:off x="365760" y="3931920"/>
-            <a:ext cx="2697480" cy="1280160"/>
+            <a:off x="365760" y="3950208"/>
+            <a:ext cx="2740914" cy="1234440"/>
           </a:xfrm>
           <a:prstGeom prst="roundRect">
             <a:avLst>
@@ -9979,8 +9979,8 @@
         </p:nvSpPr>
         <p:spPr>
           <a:xfrm>
-            <a:off x="475488" y="4023360"/>
-            <a:ext cx="1371600" cy="219456"/>
+            <a:off x="475488" y="4041648"/>
+            <a:ext cx="1325880" cy="219456"/>
           </a:xfrm>
           <a:prstGeom prst="roundRect">
             <a:avLst>
@@ -10024,8 +10024,8 @@
         </p:nvSpPr>
         <p:spPr>
           <a:xfrm>
-            <a:off x="475488" y="4041648"/>
-            <a:ext cx="1371600" cy="182880"/>
+            <a:off x="475488" y="4050792"/>
+            <a:ext cx="1325880" cy="201168"/>
           </a:xfrm>
           <a:prstGeom prst="rect">
             <a:avLst/>
@@ -10033,7 +10033,7 @@
           <a:noFill/>
         </p:spPr>
         <p:txBody>
-          <a:bodyPr wrap="square" lIns="0" rIns="0" tIns="0" bIns="0">
+          <a:bodyPr wrap="square" lIns="25400" rIns="25400" tIns="12700" bIns="12700">
             <a:spAutoFit/>
           </a:bodyPr>
           <a:lstStyle/>
@@ -10059,8 +10059,8 @@
         </p:nvSpPr>
         <p:spPr>
           <a:xfrm>
-            <a:off x="493776" y="4315968"/>
-            <a:ext cx="2441448" cy="256032"/>
+            <a:off x="493776" y="4334256"/>
+            <a:ext cx="2484882" cy="256032"/>
           </a:xfrm>
           <a:prstGeom prst="rect">
             <a:avLst/>
@@ -10068,7 +10068,7 @@
           <a:noFill/>
         </p:spPr>
         <p:txBody>
-          <a:bodyPr wrap="square" lIns="0" rIns="0" tIns="0" bIns="0">
+          <a:bodyPr wrap="square" lIns="25400" rIns="25400" tIns="12700" bIns="12700">
             <a:spAutoFit/>
           </a:bodyPr>
           <a:lstStyle/>
@@ -10094,8 +10094,8 @@
         </p:nvSpPr>
         <p:spPr>
           <a:xfrm>
-            <a:off x="493776" y="4636008"/>
-            <a:ext cx="2441448" cy="411480"/>
+            <a:off x="493776" y="4626864"/>
+            <a:ext cx="2484882" cy="457200"/>
           </a:xfrm>
           <a:prstGeom prst="rect">
             <a:avLst/>
@@ -10103,7 +10103,7 @@
           <a:noFill/>
         </p:spPr>
         <p:txBody>
-          <a:bodyPr wrap="square" lIns="0" rIns="0" tIns="0" bIns="0">
+          <a:bodyPr wrap="square" lIns="25400" rIns="25400" tIns="12700" bIns="12700">
             <a:spAutoFit/>
           </a:bodyPr>
           <a:lstStyle/>
@@ -10116,7 +10116,8 @@
                 </a:solidFill>
                 <a:latin typeface="Calibri"/>
               </a:rPr>
-              <a:t>Central coupon platform  ·  inventory · issue / redeem · track</a:t>
+              <a:t>Central coupon platform
+inventory · issue / redeem · track</a:t>
             </a:r>
           </a:p>
         </p:txBody>
@@ -10129,8 +10130,8 @@
         </p:nvSpPr>
         <p:spPr>
           <a:xfrm>
-            <a:off x="493776" y="5093208"/>
-            <a:ext cx="2441448" cy="201168"/>
+            <a:off x="493776" y="4892040"/>
+            <a:ext cx="2484882" cy="219456"/>
           </a:xfrm>
           <a:prstGeom prst="rect">
             <a:avLst/>
@@ -10138,7 +10139,7 @@
           <a:noFill/>
         </p:spPr>
         <p:txBody>
-          <a:bodyPr wrap="square" lIns="0" rIns="0" tIns="0" bIns="0">
+          <a:bodyPr wrap="square" lIns="25400" rIns="25400" tIns="12700" bIns="12700">
             <a:spAutoFit/>
           </a:bodyPr>
           <a:lstStyle/>
@@ -10164,8 +10165,8 @@
         </p:nvSpPr>
         <p:spPr>
           <a:xfrm>
-            <a:off x="3227832" y="3931920"/>
-            <a:ext cx="2697480" cy="1280160"/>
+            <a:off x="3271266" y="3950208"/>
+            <a:ext cx="2740914" cy="1234440"/>
           </a:xfrm>
           <a:prstGeom prst="roundRect">
             <a:avLst>
@@ -10175,7 +10176,7 @@
           <a:solidFill>
             <a:srgbClr val="0C2340"/>
           </a:solidFill>
-          <a:ln w="15240">
+          <a:ln w="15875">
             <a:solidFill>
               <a:srgbClr val="C4B5FD"/>
             </a:solidFill>
@@ -10211,8 +10212,8 @@
         </p:nvSpPr>
         <p:spPr>
           <a:xfrm>
-            <a:off x="3355848" y="4078224"/>
-            <a:ext cx="2441448" cy="256032"/>
+            <a:off x="3399282" y="4078224"/>
+            <a:ext cx="2484882" cy="256032"/>
           </a:xfrm>
           <a:prstGeom prst="rect">
             <a:avLst/>
@@ -10220,7 +10221,7 @@
           <a:noFill/>
         </p:spPr>
         <p:txBody>
-          <a:bodyPr wrap="square" lIns="0" rIns="0" tIns="0" bIns="0">
+          <a:bodyPr wrap="square" lIns="25400" rIns="25400" tIns="12700" bIns="12700">
             <a:spAutoFit/>
           </a:bodyPr>
           <a:lstStyle/>
@@ -10246,8 +10247,8 @@
         </p:nvSpPr>
         <p:spPr>
           <a:xfrm>
-            <a:off x="3355848" y="4398264"/>
-            <a:ext cx="2441448" cy="411480"/>
+            <a:off x="3399282" y="4370832"/>
+            <a:ext cx="2484882" cy="457200"/>
           </a:xfrm>
           <a:prstGeom prst="rect">
             <a:avLst/>
@@ -10255,7 +10256,7 @@
           <a:noFill/>
         </p:spPr>
         <p:txBody>
-          <a:bodyPr wrap="square" lIns="0" rIns="0" tIns="0" bIns="0">
+          <a:bodyPr wrap="square" lIns="25400" rIns="25400" tIns="12700" bIns="12700">
             <a:spAutoFit/>
           </a:bodyPr>
           <a:lstStyle/>
@@ -10268,7 +10269,8 @@
                 </a:solidFill>
                 <a:latin typeface="Calibri"/>
               </a:rPr>
-              <a:t>Fulfillment  ·  triggered after routing</a:t>
+              <a:t>Fulfillment
+triggered after routing</a:t>
             </a:r>
           </a:p>
         </p:txBody>
@@ -10281,8 +10283,8 @@
         </p:nvSpPr>
         <p:spPr>
           <a:xfrm>
-            <a:off x="3355848" y="4855464"/>
-            <a:ext cx="2441448" cy="201168"/>
+            <a:off x="3399282" y="4892040"/>
+            <a:ext cx="2484882" cy="219456"/>
           </a:xfrm>
           <a:prstGeom prst="rect">
             <a:avLst/>
@@ -10290,7 +10292,7 @@
           <a:noFill/>
         </p:spPr>
         <p:txBody>
-          <a:bodyPr wrap="square" lIns="0" rIns="0" tIns="0" bIns="0">
+          <a:bodyPr wrap="square" lIns="25400" rIns="25400" tIns="12700" bIns="12700">
             <a:spAutoFit/>
           </a:bodyPr>
           <a:lstStyle/>
@@ -10316,8 +10318,8 @@
         </p:nvSpPr>
         <p:spPr>
           <a:xfrm>
-            <a:off x="6089904" y="3931920"/>
-            <a:ext cx="2697480" cy="1280160"/>
+            <a:off x="6176772" y="3950208"/>
+            <a:ext cx="2740914" cy="1234440"/>
           </a:xfrm>
           <a:prstGeom prst="roundRect">
             <a:avLst>
@@ -10327,7 +10329,7 @@
           <a:solidFill>
             <a:srgbClr val="0C2340"/>
           </a:solidFill>
-          <a:ln w="15240">
+          <a:ln w="15875">
             <a:solidFill>
               <a:srgbClr val="38BDF8"/>
             </a:solidFill>
@@ -10363,8 +10365,8 @@
         </p:nvSpPr>
         <p:spPr>
           <a:xfrm>
-            <a:off x="6217920" y="4078224"/>
-            <a:ext cx="2441448" cy="256032"/>
+            <a:off x="6304788" y="4078224"/>
+            <a:ext cx="2484882" cy="256032"/>
           </a:xfrm>
           <a:prstGeom prst="rect">
             <a:avLst/>
@@ -10372,7 +10374,7 @@
           <a:noFill/>
         </p:spPr>
         <p:txBody>
-          <a:bodyPr wrap="square" lIns="0" rIns="0" tIns="0" bIns="0">
+          <a:bodyPr wrap="square" lIns="25400" rIns="25400" tIns="12700" bIns="12700">
             <a:spAutoFit/>
           </a:bodyPr>
           <a:lstStyle/>
@@ -10398,8 +10400,8 @@
         </p:nvSpPr>
         <p:spPr>
           <a:xfrm>
-            <a:off x="6217920" y="4398264"/>
-            <a:ext cx="2441448" cy="411480"/>
+            <a:off x="6304788" y="4370832"/>
+            <a:ext cx="2484882" cy="457200"/>
           </a:xfrm>
           <a:prstGeom prst="rect">
             <a:avLst/>
@@ -10407,7 +10409,7 @@
           <a:noFill/>
         </p:spPr>
         <p:txBody>
-          <a:bodyPr wrap="square" lIns="0" rIns="0" tIns="0" bIns="0">
+          <a:bodyPr wrap="square" lIns="25400" rIns="25400" tIns="12700" bIns="12700">
             <a:spAutoFit/>
           </a:bodyPr>
           <a:lstStyle/>
@@ -10433,8 +10435,8 @@
         </p:nvSpPr>
         <p:spPr>
           <a:xfrm>
-            <a:off x="6217920" y="4855464"/>
-            <a:ext cx="2441448" cy="201168"/>
+            <a:off x="6304788" y="4892040"/>
+            <a:ext cx="2484882" cy="219456"/>
           </a:xfrm>
           <a:prstGeom prst="rect">
             <a:avLst/>
@@ -10442,7 +10444,7 @@
           <a:noFill/>
         </p:spPr>
         <p:txBody>
-          <a:bodyPr wrap="square" lIns="0" rIns="0" tIns="0" bIns="0">
+          <a:bodyPr wrap="square" lIns="25400" rIns="25400" tIns="12700" bIns="12700">
             <a:spAutoFit/>
           </a:bodyPr>
           <a:lstStyle/>
@@ -10468,8 +10470,8 @@
         </p:nvSpPr>
         <p:spPr>
           <a:xfrm>
-            <a:off x="8951976" y="3931920"/>
-            <a:ext cx="2697480" cy="1280160"/>
+            <a:off x="9082278" y="3950208"/>
+            <a:ext cx="2740914" cy="1234440"/>
           </a:xfrm>
           <a:prstGeom prst="roundRect">
             <a:avLst>
@@ -10479,7 +10481,7 @@
           <a:solidFill>
             <a:srgbClr val="0C2340"/>
           </a:solidFill>
-          <a:ln w="15240">
+          <a:ln w="15875">
             <a:solidFill>
               <a:srgbClr val="FB923C"/>
             </a:solidFill>
@@ -10523,7 +10525,7 @@
         </p:blipFill>
         <p:spPr>
           <a:xfrm>
-            <a:off x="9079992" y="4078224"/>
+            <a:off x="9210294" y="4078224"/>
             <a:ext cx="237744" cy="237744"/>
           </a:xfrm>
           <a:prstGeom prst="rect">
@@ -10547,7 +10549,7 @@
         </p:blipFill>
         <p:spPr>
           <a:xfrm>
-            <a:off x="9354312" y="4078224"/>
+            <a:off x="9484614" y="4078224"/>
             <a:ext cx="237744" cy="237744"/>
           </a:xfrm>
           <a:prstGeom prst="rect">
@@ -10563,8 +10565,8 @@
         </p:nvSpPr>
         <p:spPr>
           <a:xfrm>
-            <a:off x="9665208" y="4078224"/>
-            <a:ext cx="1828800" cy="256032"/>
+            <a:off x="9795510" y="4078224"/>
+            <a:ext cx="1872234" cy="237744"/>
           </a:xfrm>
           <a:prstGeom prst="rect">
             <a:avLst/>
@@ -10572,7 +10574,7 @@
           <a:noFill/>
         </p:spPr>
         <p:txBody>
-          <a:bodyPr wrap="square" lIns="0" rIns="0" tIns="0" bIns="0">
+          <a:bodyPr wrap="square" lIns="25400" rIns="25400" tIns="12700" bIns="12700">
             <a:spAutoFit/>
           </a:bodyPr>
           <a:lstStyle/>
@@ -10585,7 +10587,7 @@
                 </a:solidFill>
                 <a:latin typeface="Calibri"/>
               </a:rPr>
-              <a:t>xapi / CRM</a:t>
+              <a:t>XAPI / CRM</a:t>
             </a:r>
           </a:p>
         </p:txBody>
@@ -10598,8 +10600,8 @@
         </p:nvSpPr>
         <p:spPr>
           <a:xfrm>
-            <a:off x="9079992" y="4425696"/>
-            <a:ext cx="2441448" cy="411480"/>
+            <a:off x="9210294" y="4425696"/>
+            <a:ext cx="2484882" cy="457200"/>
           </a:xfrm>
           <a:prstGeom prst="rect">
             <a:avLst/>
@@ -10607,7 +10609,7 @@
           <a:noFill/>
         </p:spPr>
         <p:txBody>
-          <a:bodyPr wrap="square" lIns="0" rIns="0" tIns="0" bIns="0">
+          <a:bodyPr wrap="square" lIns="25400" rIns="25400" tIns="12700" bIns="12700">
             <a:spAutoFit/>
           </a:bodyPr>
           <a:lstStyle/>
@@ -10620,7 +10622,8 @@
                 </a:solidFill>
                 <a:latin typeface="Calibri"/>
               </a:rPr>
-              <a:t>Balances · apps (Yes UA · sim)</a:t>
+              <a:t>Balances · apps
+(Yes UA · sim)</a:t>
             </a:r>
           </a:p>
         </p:txBody>
@@ -10633,8 +10636,8 @@
         </p:nvSpPr>
         <p:spPr>
           <a:xfrm>
-            <a:off x="9079992" y="4855464"/>
-            <a:ext cx="2441448" cy="201168"/>
+            <a:off x="9210294" y="4892040"/>
+            <a:ext cx="2484882" cy="219456"/>
           </a:xfrm>
           <a:prstGeom prst="rect">
             <a:avLst/>
@@ -10642,7 +10645,7 @@
           <a:noFill/>
         </p:spPr>
         <p:txBody>
-          <a:bodyPr wrap="square" lIns="0" rIns="0" tIns="0" bIns="0">
+          <a:bodyPr wrap="square" lIns="25400" rIns="25400" tIns="12700" bIns="12700">
             <a:spAutoFit/>
           </a:bodyPr>
           <a:lstStyle/>
@@ -10668,8 +10671,8 @@
         </p:nvSpPr>
         <p:spPr>
           <a:xfrm>
-            <a:off x="365760" y="5349240"/>
-            <a:ext cx="2697480" cy="329184"/>
+            <a:off x="365760" y="5321808"/>
+            <a:ext cx="2740914" cy="365760"/>
           </a:xfrm>
           <a:prstGeom prst="roundRect">
             <a:avLst>
@@ -10715,8 +10718,8 @@
         </p:nvSpPr>
         <p:spPr>
           <a:xfrm>
-            <a:off x="475488" y="5413248"/>
-            <a:ext cx="2478024" cy="219456"/>
+            <a:off x="475488" y="5394960"/>
+            <a:ext cx="2521458" cy="237744"/>
           </a:xfrm>
           <a:prstGeom prst="rect">
             <a:avLst/>
@@ -10724,7 +10727,7 @@
           <a:noFill/>
         </p:spPr>
         <p:txBody>
-          <a:bodyPr wrap="square" lIns="0" rIns="0" tIns="0" bIns="0">
+          <a:bodyPr wrap="square" lIns="25400" rIns="25400" tIns="12700" bIns="12700">
             <a:spAutoFit/>
           </a:bodyPr>
           <a:lstStyle/>
@@ -10750,8 +10753,8 @@
         </p:nvSpPr>
         <p:spPr>
           <a:xfrm>
-            <a:off x="3227832" y="5349240"/>
-            <a:ext cx="8503920" cy="329184"/>
+            <a:off x="3271266" y="5321808"/>
+            <a:ext cx="8551926" cy="365760"/>
           </a:xfrm>
           <a:prstGeom prst="roundRect">
             <a:avLst>
@@ -10797,8 +10800,8 @@
         </p:nvSpPr>
         <p:spPr>
           <a:xfrm>
-            <a:off x="3364992" y="5413248"/>
-            <a:ext cx="8229600" cy="219456"/>
+            <a:off x="3408426" y="5394960"/>
+            <a:ext cx="8412480" cy="237744"/>
           </a:xfrm>
           <a:prstGeom prst="rect">
             <a:avLst/>
@@ -10806,7 +10809,7 @@
           <a:noFill/>
         </p:spPr>
         <p:txBody>
-          <a:bodyPr wrap="square" lIns="0" rIns="0" tIns="0" bIns="0">
+          <a:bodyPr wrap="square" lIns="25400" rIns="25400" tIns="12700" bIns="12700">
             <a:spAutoFit/>
           </a:bodyPr>
           <a:lstStyle/>
@@ -10833,7 +10836,7 @@
         <p:spPr>
           <a:xfrm>
             <a:off x="365760" y="5852160"/>
-            <a:ext cx="11460175" cy="640080"/>
+            <a:ext cx="11457432" cy="640080"/>
           </a:xfrm>
           <a:prstGeom prst="roundRect">
             <a:avLst>
@@ -10887,8 +10890,8 @@
         </p:blipFill>
         <p:spPr>
           <a:xfrm>
-            <a:off x="502920" y="5961888"/>
-            <a:ext cx="292608" cy="292608"/>
+            <a:off x="502920" y="5980176"/>
+            <a:ext cx="274320" cy="274320"/>
           </a:xfrm>
           <a:prstGeom prst="rect">
             <a:avLst/>
@@ -10911,8 +10914,8 @@
         </p:blipFill>
         <p:spPr>
           <a:xfrm>
-            <a:off x="868680" y="5961888"/>
-            <a:ext cx="292608" cy="292608"/>
+            <a:off x="868680" y="5980176"/>
+            <a:ext cx="274320" cy="274320"/>
           </a:xfrm>
           <a:prstGeom prst="rect">
             <a:avLst/>
@@ -10935,8 +10938,8 @@
         </p:blipFill>
         <p:spPr>
           <a:xfrm>
-            <a:off x="1234440" y="5961888"/>
-            <a:ext cx="292608" cy="292608"/>
+            <a:off x="1234440" y="5980176"/>
+            <a:ext cx="274320" cy="274320"/>
           </a:xfrm>
           <a:prstGeom prst="rect">
             <a:avLst/>
@@ -10959,8 +10962,8 @@
         </p:blipFill>
         <p:spPr>
           <a:xfrm>
-            <a:off x="1691640" y="5961888"/>
-            <a:ext cx="292608" cy="292608"/>
+            <a:off x="1691640" y="5980176"/>
+            <a:ext cx="274320" cy="274320"/>
           </a:xfrm>
           <a:prstGeom prst="rect">
             <a:avLst/>
@@ -10983,8 +10986,8 @@
         </p:blipFill>
         <p:spPr>
           <a:xfrm>
-            <a:off x="2057400" y="5961888"/>
-            <a:ext cx="292608" cy="292608"/>
+            <a:off x="2057400" y="5980176"/>
+            <a:ext cx="274320" cy="274320"/>
           </a:xfrm>
           <a:prstGeom prst="rect">
             <a:avLst/>
@@ -10999,8 +11002,8 @@
         </p:nvSpPr>
         <p:spPr>
           <a:xfrm>
-            <a:off x="2514600" y="5989320"/>
-            <a:ext cx="9144000" cy="320040"/>
+            <a:off x="2468880" y="5961888"/>
+            <a:ext cx="9144000" cy="411480"/>
           </a:xfrm>
           <a:prstGeom prst="rect">
             <a:avLst/>
@@ -11008,20 +11011,21 @@
           <a:noFill/>
         </p:spPr>
         <p:txBody>
-          <a:bodyPr wrap="square" lIns="0" rIns="0" tIns="0" bIns="0">
+          <a:bodyPr wrap="square" lIns="25400" rIns="25400" tIns="12700" bIns="12700">
             <a:spAutoFit/>
           </a:bodyPr>
           <a:lstStyle/>
           <a:p>
             <a:pPr algn="l"/>
             <a:r>
-              <a:rPr sz="1200" b="0">
+              <a:rPr sz="1100" b="0">
                 <a:solidFill>
                   <a:srgbClr val="CBD5E1"/>
                 </a:solidFill>
                 <a:latin typeface="Calibri"/>
               </a:rPr>
-              <a:t>SDK · REST · Kafka     ·     LedgeRX ↔ one UAF interface     ·     hub logic then fan-out     ·     Yes UA · sim behind xapi</a:t>
+              <a:t>SDK · REST · Kafka     ·     LedgeRX ↔ one UAF interface only     ·     hub runs UAF logic then fan-out
+Yes UA · sim sit behind XAPI / CRM  —  not direct LedgeRX connectors</a:t>
             </a:r>
           </a:p>
         </p:txBody>

</xml_diff>

<commit_message>
docs(decks): official UAF wordmark + sim/Yes UA app icons (CTO-approved)
</commit_message>
<xml_diff>
--- a/docs/decks/LedgeRX-System-Architecture-CTO.pptx
+++ b/docs/decks/LedgeRX-System-Architecture-CTO.pptx
@@ -3184,7 +3184,7 @@
         <p:spPr>
           <a:xfrm>
             <a:off x="365760" y="146304"/>
-            <a:ext cx="6583680" cy="274320"/>
+            <a:ext cx="5943600" cy="274320"/>
           </a:xfrm>
           <a:prstGeom prst="rect">
             <a:avLst/>
@@ -3212,7 +3212,7 @@
       </p:sp>
       <p:pic>
         <p:nvPicPr>
-          <p:cNvPr id="5" name="Picture 4" descr="uaf.png"/>
+          <p:cNvPr id="5" name="Picture 4" descr="uaf_badge_48.png"/>
           <p:cNvPicPr>
             <a:picLocks noChangeAspect="1"/>
           </p:cNvPicPr>
@@ -3226,52 +3226,17 @@
         </p:blipFill>
         <p:spPr>
           <a:xfrm>
-            <a:off x="7772400" y="128016"/>
-            <a:ext cx="329184" cy="329184"/>
+            <a:off x="7178040" y="128016"/>
+            <a:ext cx="1234440" cy="384048"/>
           </a:xfrm>
           <a:prstGeom prst="rect">
             <a:avLst/>
           </a:prstGeom>
         </p:spPr>
       </p:pic>
-      <p:sp>
-        <p:nvSpPr>
-          <p:cNvPr id="6" name="TextBox 5"/>
-          <p:cNvSpPr txBox="1"/>
-          <p:nvPr/>
-        </p:nvSpPr>
-        <p:spPr>
-          <a:xfrm>
-            <a:off x="8156448" y="164592"/>
-            <a:ext cx="502920" cy="256032"/>
-          </a:xfrm>
-          <a:prstGeom prst="rect">
-            <a:avLst/>
-          </a:prstGeom>
-          <a:noFill/>
-        </p:spPr>
-        <p:txBody>
-          <a:bodyPr wrap="square" lIns="25400" rIns="25400" tIns="12700" bIns="12700">
-            <a:spAutoFit/>
-          </a:bodyPr>
-          <a:lstStyle/>
-          <a:p>
-            <a:pPr algn="l"/>
-            <a:r>
-              <a:rPr sz="1100" b="1">
-                <a:solidFill>
-                  <a:srgbClr val="2DD4BF"/>
-                </a:solidFill>
-                <a:latin typeface="Calibri"/>
-              </a:rPr>
-              <a:t>UAF</a:t>
-            </a:r>
-          </a:p>
-        </p:txBody>
-      </p:sp>
       <p:pic>
         <p:nvPicPr>
-          <p:cNvPr id="7" name="Picture 6" descr="sim.png"/>
+          <p:cNvPr id="6" name="Picture 5" descr="sim_mark_48.png"/>
           <p:cNvPicPr>
             <a:picLocks noChangeAspect="1"/>
           </p:cNvPicPr>
@@ -3285,8 +3250,8 @@
         </p:blipFill>
         <p:spPr>
           <a:xfrm>
-            <a:off x="8732520" y="128016"/>
-            <a:ext cx="329184" cy="329184"/>
+            <a:off x="8549640" y="128016"/>
+            <a:ext cx="384048" cy="384048"/>
           </a:xfrm>
           <a:prstGeom prst="rect">
             <a:avLst/>
@@ -3295,14 +3260,14 @@
       </p:pic>
       <p:sp>
         <p:nvSpPr>
-          <p:cNvPr id="8" name="TextBox 7"/>
+          <p:cNvPr id="7" name="TextBox 6"/>
           <p:cNvSpPr txBox="1"/>
           <p:nvPr/>
         </p:nvSpPr>
         <p:spPr>
           <a:xfrm>
-            <a:off x="9116568" y="164592"/>
-            <a:ext cx="457200" cy="256032"/>
+            <a:off x="8979408" y="182880"/>
+            <a:ext cx="411480" cy="274320"/>
           </a:xfrm>
           <a:prstGeom prst="rect">
             <a:avLst/>
@@ -3317,7 +3282,7 @@
           <a:p>
             <a:pPr algn="l"/>
             <a:r>
-              <a:rPr sz="1100" b="1">
+              <a:rPr sz="1200" b="1">
                 <a:solidFill>
                   <a:srgbClr val="38BDF8"/>
                 </a:solidFill>
@@ -3330,14 +3295,14 @@
       </p:sp>
       <p:sp>
         <p:nvSpPr>
-          <p:cNvPr id="9" name="Rounded Rectangle 8"/>
+          <p:cNvPr id="8" name="Rounded Rectangle 7"/>
           <p:cNvSpPr/>
           <p:nvPr/>
         </p:nvSpPr>
         <p:spPr>
           <a:xfrm>
             <a:off x="10195560" y="128016"/>
-            <a:ext cx="1600200" cy="329184"/>
+            <a:ext cx="1600200" cy="384048"/>
           </a:xfrm>
           <a:prstGeom prst="roundRect">
             <a:avLst>
@@ -3377,14 +3342,14 @@
       </p:sp>
       <p:sp>
         <p:nvSpPr>
-          <p:cNvPr id="10" name="TextBox 9"/>
+          <p:cNvPr id="9" name="TextBox 8"/>
           <p:cNvSpPr txBox="1"/>
           <p:nvPr/>
         </p:nvSpPr>
         <p:spPr>
           <a:xfrm>
-            <a:off x="10195560" y="164592"/>
-            <a:ext cx="1600200" cy="256032"/>
+            <a:off x="10195560" y="182880"/>
+            <a:ext cx="1600200" cy="274320"/>
           </a:xfrm>
           <a:prstGeom prst="rect">
             <a:avLst/>
@@ -3412,13 +3377,13 @@
       </p:sp>
       <p:sp>
         <p:nvSpPr>
-          <p:cNvPr id="11" name="TextBox 10"/>
+          <p:cNvPr id="10" name="TextBox 9"/>
           <p:cNvSpPr txBox="1"/>
           <p:nvPr/>
         </p:nvSpPr>
         <p:spPr>
           <a:xfrm>
-            <a:off x="365760" y="475488"/>
+            <a:off x="365760" y="512064"/>
             <a:ext cx="9144000" cy="219456"/>
           </a:xfrm>
           <a:prstGeom prst="rect">
@@ -3447,14 +3412,14 @@
       </p:sp>
       <p:sp>
         <p:nvSpPr>
-          <p:cNvPr id="12" name="Rounded Rectangle 11"/>
+          <p:cNvPr id="11" name="Rounded Rectangle 10"/>
           <p:cNvSpPr/>
           <p:nvPr/>
         </p:nvSpPr>
         <p:spPr>
           <a:xfrm>
-            <a:off x="365760" y="804672"/>
-            <a:ext cx="1761082" cy="5074920"/>
+            <a:off x="365760" y="841248"/>
+            <a:ext cx="1761082" cy="5029200"/>
           </a:xfrm>
           <a:prstGeom prst="roundRect">
             <a:avLst>
@@ -3494,13 +3459,13 @@
       </p:sp>
       <p:sp>
         <p:nvSpPr>
-          <p:cNvPr id="13" name="Oval 12"/>
+          <p:cNvPr id="12" name="Oval 11"/>
           <p:cNvSpPr/>
           <p:nvPr/>
         </p:nvSpPr>
         <p:spPr>
           <a:xfrm>
-            <a:off x="475488" y="914400"/>
+            <a:off x="475488" y="950976"/>
             <a:ext cx="237744" cy="237744"/>
           </a:xfrm>
           <a:prstGeom prst="ellipse">
@@ -3537,13 +3502,13 @@
       </p:sp>
       <p:sp>
         <p:nvSpPr>
-          <p:cNvPr id="14" name="TextBox 13"/>
+          <p:cNvPr id="13" name="TextBox 12"/>
           <p:cNvSpPr txBox="1"/>
           <p:nvPr/>
         </p:nvSpPr>
         <p:spPr>
           <a:xfrm>
-            <a:off x="475488" y="932688"/>
+            <a:off x="475488" y="969264"/>
             <a:ext cx="237744" cy="201168"/>
           </a:xfrm>
           <a:prstGeom prst="rect">
@@ -3572,13 +3537,13 @@
       </p:sp>
       <p:sp>
         <p:nvSpPr>
-          <p:cNvPr id="15" name="TextBox 14"/>
+          <p:cNvPr id="14" name="TextBox 13"/>
           <p:cNvSpPr txBox="1"/>
           <p:nvPr/>
         </p:nvSpPr>
         <p:spPr>
           <a:xfrm>
-            <a:off x="768096" y="932688"/>
+            <a:off x="768096" y="969264"/>
             <a:ext cx="1249018" cy="201168"/>
           </a:xfrm>
           <a:prstGeom prst="rect">
@@ -3607,14 +3572,14 @@
       </p:sp>
       <p:sp>
         <p:nvSpPr>
-          <p:cNvPr id="16" name="TextBox 15"/>
+          <p:cNvPr id="15" name="TextBox 14"/>
           <p:cNvSpPr txBox="1"/>
           <p:nvPr/>
         </p:nvSpPr>
         <p:spPr>
           <a:xfrm>
-            <a:off x="475488" y="1225296"/>
-            <a:ext cx="1541626" cy="237744"/>
+            <a:off x="475488" y="1261872"/>
+            <a:ext cx="1541626" cy="219456"/>
           </a:xfrm>
           <a:prstGeom prst="rect">
             <a:avLst/>
@@ -3642,14 +3607,14 @@
       </p:sp>
       <p:sp>
         <p:nvSpPr>
-          <p:cNvPr id="17" name="Rounded Rectangle 16"/>
+          <p:cNvPr id="16" name="Rounded Rectangle 15"/>
           <p:cNvSpPr/>
           <p:nvPr/>
         </p:nvSpPr>
         <p:spPr>
           <a:xfrm>
             <a:off x="475488" y="1517904"/>
-            <a:ext cx="1541626" cy="365760"/>
+            <a:ext cx="1541626" cy="438912"/>
           </a:xfrm>
           <a:prstGeom prst="roundRect">
             <a:avLst>
@@ -3689,7 +3654,7 @@
       </p:sp>
       <p:pic>
         <p:nvPicPr>
-          <p:cNvPr id="18" name="Picture 17" descr="uaf.png"/>
+          <p:cNvPr id="17" name="Picture 16" descr="uaf_badge_48.png"/>
           <p:cNvPicPr>
             <a:picLocks noChangeAspect="1"/>
           </p:cNvPicPr>
@@ -3703,8 +3668,8 @@
         </p:blipFill>
         <p:spPr>
           <a:xfrm>
-            <a:off x="548640" y="1563624"/>
-            <a:ext cx="256032" cy="256032"/>
+            <a:off x="530352" y="1572768"/>
+            <a:ext cx="1051560" cy="329184"/>
           </a:xfrm>
           <a:prstGeom prst="rect">
             <a:avLst/>
@@ -3713,14 +3678,14 @@
       </p:pic>
       <p:sp>
         <p:nvSpPr>
-          <p:cNvPr id="19" name="TextBox 18"/>
+          <p:cNvPr id="18" name="TextBox 17"/>
           <p:cNvSpPr txBox="1"/>
           <p:nvPr/>
         </p:nvSpPr>
         <p:spPr>
           <a:xfrm>
-            <a:off x="859536" y="1581912"/>
-            <a:ext cx="1188720" cy="237744"/>
+            <a:off x="1645920" y="1627632"/>
+            <a:ext cx="457200" cy="256032"/>
           </a:xfrm>
           <a:prstGeom prst="rect">
             <a:avLst/>
@@ -3741,21 +3706,21 @@
                 </a:solidFill>
                 <a:latin typeface="Calibri"/>
               </a:rPr>
-              <a:t>UAF channels</a:t>
-            </a:r>
-          </a:p>
-        </p:txBody>
-      </p:sp>
-      <p:sp>
-        <p:nvSpPr>
-          <p:cNvPr id="20" name="Rounded Rectangle 19"/>
+              <a:t>UAF</a:t>
+            </a:r>
+          </a:p>
+        </p:txBody>
+      </p:sp>
+      <p:sp>
+        <p:nvSpPr>
+          <p:cNvPr id="19" name="Rounded Rectangle 18"/>
           <p:cNvSpPr/>
           <p:nvPr/>
         </p:nvSpPr>
         <p:spPr>
           <a:xfrm>
-            <a:off x="475488" y="2039112"/>
-            <a:ext cx="1541626" cy="868680"/>
+            <a:off x="475488" y="2103120"/>
+            <a:ext cx="1541626" cy="841248"/>
           </a:xfrm>
           <a:prstGeom prst="roundRect">
             <a:avLst>
@@ -3795,14 +3760,14 @@
       </p:sp>
       <p:sp>
         <p:nvSpPr>
-          <p:cNvPr id="21" name="Rectangle 20"/>
+          <p:cNvPr id="20" name="Rectangle 19"/>
           <p:cNvSpPr/>
           <p:nvPr/>
         </p:nvSpPr>
         <p:spPr>
           <a:xfrm>
-            <a:off x="475488" y="2130552"/>
-            <a:ext cx="45720" cy="685800"/>
+            <a:off x="475488" y="2194560"/>
+            <a:ext cx="45720" cy="658368"/>
           </a:xfrm>
           <a:prstGeom prst="rect">
             <a:avLst/>
@@ -3838,14 +3803,14 @@
       </p:sp>
       <p:sp>
         <p:nvSpPr>
-          <p:cNvPr id="22" name="TextBox 21"/>
+          <p:cNvPr id="21" name="TextBox 20"/>
           <p:cNvSpPr txBox="1"/>
           <p:nvPr/>
         </p:nvSpPr>
         <p:spPr>
           <a:xfrm>
-            <a:off x="603504" y="2130552"/>
-            <a:ext cx="1340458" cy="722376"/>
+            <a:off x="603504" y="2194560"/>
+            <a:ext cx="1340458" cy="694944"/>
           </a:xfrm>
           <a:prstGeom prst="rect">
             <a:avLst/>
@@ -3899,14 +3864,14 @@
       </p:sp>
       <p:sp>
         <p:nvSpPr>
-          <p:cNvPr id="23" name="Rounded Rectangle 22"/>
+          <p:cNvPr id="22" name="Rounded Rectangle 21"/>
           <p:cNvSpPr/>
           <p:nvPr/>
         </p:nvSpPr>
         <p:spPr>
           <a:xfrm>
-            <a:off x="475488" y="2999232"/>
-            <a:ext cx="1541626" cy="868680"/>
+            <a:off x="475488" y="3035808"/>
+            <a:ext cx="1541626" cy="841248"/>
           </a:xfrm>
           <a:prstGeom prst="roundRect">
             <a:avLst>
@@ -3946,14 +3911,14 @@
       </p:sp>
       <p:sp>
         <p:nvSpPr>
-          <p:cNvPr id="24" name="Rectangle 23"/>
+          <p:cNvPr id="23" name="Rectangle 22"/>
           <p:cNvSpPr/>
           <p:nvPr/>
         </p:nvSpPr>
         <p:spPr>
           <a:xfrm>
-            <a:off x="475488" y="3090672"/>
-            <a:ext cx="45720" cy="685800"/>
+            <a:off x="475488" y="3127248"/>
+            <a:ext cx="45720" cy="658368"/>
           </a:xfrm>
           <a:prstGeom prst="rect">
             <a:avLst/>
@@ -3989,14 +3954,14 @@
       </p:sp>
       <p:sp>
         <p:nvSpPr>
-          <p:cNvPr id="25" name="TextBox 24"/>
+          <p:cNvPr id="24" name="TextBox 23"/>
           <p:cNvSpPr txBox="1"/>
           <p:nvPr/>
         </p:nvSpPr>
         <p:spPr>
           <a:xfrm>
-            <a:off x="603504" y="3090672"/>
-            <a:ext cx="1340458" cy="722376"/>
+            <a:off x="603504" y="3127248"/>
+            <a:ext cx="1340458" cy="694944"/>
           </a:xfrm>
           <a:prstGeom prst="rect">
             <a:avLst/>
@@ -4050,14 +4015,14 @@
       </p:sp>
       <p:sp>
         <p:nvSpPr>
-          <p:cNvPr id="26" name="Rounded Rectangle 25"/>
+          <p:cNvPr id="25" name="Rounded Rectangle 24"/>
           <p:cNvSpPr/>
           <p:nvPr/>
         </p:nvSpPr>
         <p:spPr>
           <a:xfrm>
-            <a:off x="475488" y="3959352"/>
-            <a:ext cx="1541626" cy="868680"/>
+            <a:off x="475488" y="3968496"/>
+            <a:ext cx="1541626" cy="841248"/>
           </a:xfrm>
           <a:prstGeom prst="roundRect">
             <a:avLst>
@@ -4097,14 +4062,14 @@
       </p:sp>
       <p:sp>
         <p:nvSpPr>
-          <p:cNvPr id="27" name="Rectangle 26"/>
+          <p:cNvPr id="26" name="Rectangle 25"/>
           <p:cNvSpPr/>
           <p:nvPr/>
         </p:nvSpPr>
         <p:spPr>
           <a:xfrm>
-            <a:off x="475488" y="4050792"/>
-            <a:ext cx="45720" cy="685800"/>
+            <a:off x="475488" y="4059936"/>
+            <a:ext cx="45720" cy="658368"/>
           </a:xfrm>
           <a:prstGeom prst="rect">
             <a:avLst/>
@@ -4138,6 +4103,30 @@
           </a:p>
         </p:txBody>
       </p:sp>
+      <p:pic>
+        <p:nvPicPr>
+          <p:cNvPr id="27" name="Picture 26" descr="sim_mark_48.png"/>
+          <p:cNvPicPr>
+            <a:picLocks noChangeAspect="1"/>
+          </p:cNvPicPr>
+          <p:nvPr/>
+        </p:nvPicPr>
+        <p:blipFill>
+          <a:blip r:embed="rId3"/>
+          <a:stretch>
+            <a:fillRect/>
+          </a:stretch>
+        </p:blipFill>
+        <p:spPr>
+          <a:xfrm>
+            <a:off x="585216" y="4224528"/>
+            <a:ext cx="329184" cy="329184"/>
+          </a:xfrm>
+          <a:prstGeom prst="rect">
+            <a:avLst/>
+          </a:prstGeom>
+        </p:spPr>
+      </p:pic>
       <p:sp>
         <p:nvSpPr>
           <p:cNvPr id="28" name="TextBox 27"/>
@@ -4146,8 +4135,8 @@
         </p:nvSpPr>
         <p:spPr>
           <a:xfrm>
-            <a:off x="603504" y="4050792"/>
-            <a:ext cx="1340458" cy="722376"/>
+            <a:off x="987552" y="4059936"/>
+            <a:ext cx="956410" cy="694944"/>
           </a:xfrm>
           <a:prstGeom prst="rect">
             <a:avLst/>
@@ -4207,7 +4196,7 @@
         </p:nvSpPr>
         <p:spPr>
           <a:xfrm>
-            <a:off x="475488" y="5102352"/>
+            <a:off x="475488" y="5093208"/>
             <a:ext cx="1541626" cy="502920"/>
           </a:xfrm>
           <a:prstGeom prst="rect">
@@ -4243,8 +4232,8 @@
         </p:nvSpPr>
         <p:spPr>
           <a:xfrm>
-            <a:off x="2382874" y="804672"/>
-            <a:ext cx="1761082" cy="5074920"/>
+            <a:off x="2382874" y="841248"/>
+            <a:ext cx="1761082" cy="5029200"/>
           </a:xfrm>
           <a:prstGeom prst="roundRect">
             <a:avLst>
@@ -4290,7 +4279,7 @@
         </p:nvSpPr>
         <p:spPr>
           <a:xfrm>
-            <a:off x="2492602" y="914400"/>
+            <a:off x="2492602" y="950976"/>
             <a:ext cx="237744" cy="237744"/>
           </a:xfrm>
           <a:prstGeom prst="ellipse">
@@ -4333,7 +4322,7 @@
         </p:nvSpPr>
         <p:spPr>
           <a:xfrm>
-            <a:off x="2492602" y="932688"/>
+            <a:off x="2492602" y="969264"/>
             <a:ext cx="237744" cy="201168"/>
           </a:xfrm>
           <a:prstGeom prst="rect">
@@ -4368,7 +4357,7 @@
         </p:nvSpPr>
         <p:spPr>
           <a:xfrm>
-            <a:off x="2785210" y="932688"/>
+            <a:off x="2785210" y="969264"/>
             <a:ext cx="1249018" cy="201168"/>
           </a:xfrm>
           <a:prstGeom prst="rect">
@@ -4411,7 +4400,7 @@
         </p:blipFill>
         <p:spPr>
           <a:xfrm>
-            <a:off x="2510890" y="1243584"/>
+            <a:off x="2510890" y="1280160"/>
             <a:ext cx="292608" cy="292608"/>
           </a:xfrm>
           <a:prstGeom prst="rect">
@@ -4427,7 +4416,7 @@
         </p:nvSpPr>
         <p:spPr>
           <a:xfrm>
-            <a:off x="2858362" y="1261872"/>
+            <a:off x="2858362" y="1298448"/>
             <a:ext cx="1121002" cy="256032"/>
           </a:xfrm>
           <a:prstGeom prst="rect">
@@ -4462,7 +4451,7 @@
         </p:nvSpPr>
         <p:spPr>
           <a:xfrm>
-            <a:off x="2510890" y="1609344"/>
+            <a:off x="2510890" y="1627632"/>
             <a:ext cx="1505050" cy="237744"/>
           </a:xfrm>
           <a:prstGeom prst="rect">
@@ -4497,8 +4486,8 @@
         </p:nvSpPr>
         <p:spPr>
           <a:xfrm>
-            <a:off x="2492602" y="1993392"/>
-            <a:ext cx="1541626" cy="868680"/>
+            <a:off x="2492602" y="1984248"/>
+            <a:ext cx="1541626" cy="841248"/>
           </a:xfrm>
           <a:prstGeom prst="roundRect">
             <a:avLst>
@@ -4544,8 +4533,8 @@
         </p:nvSpPr>
         <p:spPr>
           <a:xfrm>
-            <a:off x="2492602" y="2084832"/>
-            <a:ext cx="45720" cy="685800"/>
+            <a:off x="2492602" y="2075688"/>
+            <a:ext cx="45720" cy="658368"/>
           </a:xfrm>
           <a:prstGeom prst="rect">
             <a:avLst/>
@@ -4595,8 +4584,8 @@
         </p:blipFill>
         <p:spPr>
           <a:xfrm>
-            <a:off x="2602330" y="2281428"/>
-            <a:ext cx="292608" cy="292608"/>
+            <a:off x="2602330" y="2240280"/>
+            <a:ext cx="329184" cy="329184"/>
           </a:xfrm>
           <a:prstGeom prst="rect">
             <a:avLst/>
@@ -4611,8 +4600,8 @@
         </p:nvSpPr>
         <p:spPr>
           <a:xfrm>
-            <a:off x="2968090" y="2084832"/>
-            <a:ext cx="992986" cy="722376"/>
+            <a:off x="3004666" y="2075688"/>
+            <a:ext cx="956410" cy="694944"/>
           </a:xfrm>
           <a:prstGeom prst="rect">
             <a:avLst/>
@@ -4672,8 +4661,8 @@
         </p:nvSpPr>
         <p:spPr>
           <a:xfrm>
-            <a:off x="2492602" y="2953512"/>
-            <a:ext cx="1541626" cy="868680"/>
+            <a:off x="2492602" y="2916936"/>
+            <a:ext cx="1541626" cy="841248"/>
           </a:xfrm>
           <a:prstGeom prst="roundRect">
             <a:avLst>
@@ -4719,8 +4708,8 @@
         </p:nvSpPr>
         <p:spPr>
           <a:xfrm>
-            <a:off x="2492602" y="3044952"/>
-            <a:ext cx="45720" cy="685800"/>
+            <a:off x="2492602" y="3008376"/>
+            <a:ext cx="45720" cy="658368"/>
           </a:xfrm>
           <a:prstGeom prst="rect">
             <a:avLst/>
@@ -4770,8 +4759,8 @@
         </p:blipFill>
         <p:spPr>
           <a:xfrm>
-            <a:off x="2602330" y="3241548"/>
-            <a:ext cx="292608" cy="292608"/>
+            <a:off x="2602330" y="3172968"/>
+            <a:ext cx="329184" cy="329184"/>
           </a:xfrm>
           <a:prstGeom prst="rect">
             <a:avLst/>
@@ -4786,8 +4775,8 @@
         </p:nvSpPr>
         <p:spPr>
           <a:xfrm>
-            <a:off x="2968090" y="3044952"/>
-            <a:ext cx="992986" cy="722376"/>
+            <a:off x="3004666" y="3008376"/>
+            <a:ext cx="956410" cy="694944"/>
           </a:xfrm>
           <a:prstGeom prst="rect">
             <a:avLst/>
@@ -4847,8 +4836,8 @@
         </p:nvSpPr>
         <p:spPr>
           <a:xfrm>
-            <a:off x="2492602" y="3913632"/>
-            <a:ext cx="1541626" cy="868680"/>
+            <a:off x="2492602" y="3849624"/>
+            <a:ext cx="1541626" cy="841248"/>
           </a:xfrm>
           <a:prstGeom prst="roundRect">
             <a:avLst>
@@ -4894,8 +4883,8 @@
         </p:nvSpPr>
         <p:spPr>
           <a:xfrm>
-            <a:off x="2492602" y="4005072"/>
-            <a:ext cx="45720" cy="685800"/>
+            <a:off x="2492602" y="3941064"/>
+            <a:ext cx="45720" cy="658368"/>
           </a:xfrm>
           <a:prstGeom prst="rect">
             <a:avLst/>
@@ -4945,8 +4934,8 @@
         </p:blipFill>
         <p:spPr>
           <a:xfrm>
-            <a:off x="2602330" y="4201668"/>
-            <a:ext cx="292608" cy="292608"/>
+            <a:off x="2602330" y="4105656"/>
+            <a:ext cx="329184" cy="329184"/>
           </a:xfrm>
           <a:prstGeom prst="rect">
             <a:avLst/>
@@ -4961,8 +4950,8 @@
         </p:nvSpPr>
         <p:spPr>
           <a:xfrm>
-            <a:off x="2968090" y="4005072"/>
-            <a:ext cx="992986" cy="722376"/>
+            <a:off x="3004666" y="3941064"/>
+            <a:ext cx="956410" cy="694944"/>
           </a:xfrm>
           <a:prstGeom prst="rect">
             <a:avLst/>
@@ -5022,7 +5011,7 @@
         </p:nvSpPr>
         <p:spPr>
           <a:xfrm>
-            <a:off x="2492602" y="5056632"/>
+            <a:off x="2492602" y="5001768"/>
             <a:ext cx="1541626" cy="640080"/>
           </a:xfrm>
           <a:prstGeom prst="rect">
@@ -5058,7 +5047,7 @@
         </p:nvSpPr>
         <p:spPr>
           <a:xfrm>
-            <a:off x="2163418" y="2679191"/>
+            <a:off x="2163418" y="2670048"/>
             <a:ext cx="182880" cy="137160"/>
           </a:xfrm>
           <a:prstGeom prst="rightArrow">
@@ -5101,7 +5090,7 @@
         </p:nvSpPr>
         <p:spPr>
           <a:xfrm>
-            <a:off x="4180532" y="2679191"/>
+            <a:off x="4180532" y="2670048"/>
             <a:ext cx="182880" cy="137160"/>
           </a:xfrm>
           <a:prstGeom prst="rightArrow">
@@ -5144,7 +5133,7 @@
         </p:nvSpPr>
         <p:spPr>
           <a:xfrm>
-            <a:off x="2163418" y="3959352"/>
+            <a:off x="2163418" y="3950208"/>
             <a:ext cx="182880" cy="137160"/>
           </a:xfrm>
           <a:prstGeom prst="rightArrow">
@@ -5187,7 +5176,7 @@
         </p:nvSpPr>
         <p:spPr>
           <a:xfrm>
-            <a:off x="4180532" y="3959352"/>
+            <a:off x="4180532" y="3950208"/>
             <a:ext cx="182880" cy="137160"/>
           </a:xfrm>
           <a:prstGeom prst="rightArrow">
@@ -5230,8 +5219,8 @@
         </p:nvSpPr>
         <p:spPr>
           <a:xfrm>
-            <a:off x="4399988" y="804672"/>
-            <a:ext cx="3913517" cy="5074920"/>
+            <a:off x="4399988" y="841248"/>
+            <a:ext cx="3913517" cy="5029200"/>
           </a:xfrm>
           <a:prstGeom prst="roundRect">
             <a:avLst>
@@ -5277,7 +5266,7 @@
         </p:nvSpPr>
         <p:spPr>
           <a:xfrm>
-            <a:off x="4528004" y="896112"/>
+            <a:off x="4528004" y="932688"/>
             <a:ext cx="3657485" cy="365760"/>
           </a:xfrm>
           <a:prstGeom prst="roundRect">
@@ -5324,7 +5313,7 @@
         </p:nvSpPr>
         <p:spPr>
           <a:xfrm>
-            <a:off x="4601156" y="950976"/>
+            <a:off x="4601156" y="987552"/>
             <a:ext cx="3511181" cy="274320"/>
           </a:xfrm>
           <a:prstGeom prst="rect">
@@ -5359,7 +5348,7 @@
         </p:nvSpPr>
         <p:spPr>
           <a:xfrm>
-            <a:off x="4564580" y="1316736"/>
+            <a:off x="4564580" y="1353312"/>
             <a:ext cx="3584333" cy="237744"/>
           </a:xfrm>
           <a:prstGeom prst="rect">
@@ -5394,8 +5383,8 @@
         </p:nvSpPr>
         <p:spPr>
           <a:xfrm>
-            <a:off x="4546292" y="1673352"/>
-            <a:ext cx="1755590" cy="822960"/>
+            <a:off x="4546292" y="1709928"/>
+            <a:ext cx="1755590" cy="804672"/>
           </a:xfrm>
           <a:prstGeom prst="roundRect">
             <a:avLst>
@@ -5441,8 +5430,8 @@
         </p:nvSpPr>
         <p:spPr>
           <a:xfrm>
-            <a:off x="4546292" y="1764792"/>
-            <a:ext cx="45720" cy="640080"/>
+            <a:off x="4546292" y="1801368"/>
+            <a:ext cx="45720" cy="621792"/>
           </a:xfrm>
           <a:prstGeom prst="rect">
             <a:avLst/>
@@ -5484,8 +5473,8 @@
         </p:nvSpPr>
         <p:spPr>
           <a:xfrm>
-            <a:off x="4674308" y="1764792"/>
-            <a:ext cx="1554422" cy="676656"/>
+            <a:off x="4674308" y="1801368"/>
+            <a:ext cx="1554422" cy="658368"/>
           </a:xfrm>
           <a:prstGeom prst="rect">
             <a:avLst/>
@@ -5545,8 +5534,8 @@
         </p:nvSpPr>
         <p:spPr>
           <a:xfrm>
-            <a:off x="6411610" y="1673352"/>
-            <a:ext cx="1755590" cy="822960"/>
+            <a:off x="6411610" y="1709928"/>
+            <a:ext cx="1755590" cy="804672"/>
           </a:xfrm>
           <a:prstGeom prst="roundRect">
             <a:avLst>
@@ -5592,8 +5581,8 @@
         </p:nvSpPr>
         <p:spPr>
           <a:xfrm>
-            <a:off x="6411610" y="1764792"/>
-            <a:ext cx="45720" cy="640080"/>
+            <a:off x="6411610" y="1801368"/>
+            <a:ext cx="45720" cy="621792"/>
           </a:xfrm>
           <a:prstGeom prst="rect">
             <a:avLst/>
@@ -5635,8 +5624,8 @@
         </p:nvSpPr>
         <p:spPr>
           <a:xfrm>
-            <a:off x="6539626" y="1764792"/>
-            <a:ext cx="1554422" cy="676656"/>
+            <a:off x="6539626" y="1801368"/>
+            <a:ext cx="1554422" cy="658368"/>
           </a:xfrm>
           <a:prstGeom prst="rect">
             <a:avLst/>
@@ -5696,8 +5685,8 @@
         </p:nvSpPr>
         <p:spPr>
           <a:xfrm>
-            <a:off x="4546292" y="2587752"/>
-            <a:ext cx="1755590" cy="822960"/>
+            <a:off x="4546292" y="2606040"/>
+            <a:ext cx="1755590" cy="804672"/>
           </a:xfrm>
           <a:prstGeom prst="roundRect">
             <a:avLst>
@@ -5743,8 +5732,8 @@
         </p:nvSpPr>
         <p:spPr>
           <a:xfrm>
-            <a:off x="4546292" y="2679192"/>
-            <a:ext cx="45720" cy="640080"/>
+            <a:off x="4546292" y="2697480"/>
+            <a:ext cx="45720" cy="621792"/>
           </a:xfrm>
           <a:prstGeom prst="rect">
             <a:avLst/>
@@ -5786,8 +5775,8 @@
         </p:nvSpPr>
         <p:spPr>
           <a:xfrm>
-            <a:off x="4674308" y="2679192"/>
-            <a:ext cx="1554422" cy="676656"/>
+            <a:off x="4674308" y="2697480"/>
+            <a:ext cx="1554422" cy="658368"/>
           </a:xfrm>
           <a:prstGeom prst="rect">
             <a:avLst/>
@@ -5847,8 +5836,8 @@
         </p:nvSpPr>
         <p:spPr>
           <a:xfrm>
-            <a:off x="6411610" y="2587752"/>
-            <a:ext cx="1755590" cy="822960"/>
+            <a:off x="6411610" y="2606040"/>
+            <a:ext cx="1755590" cy="804672"/>
           </a:xfrm>
           <a:prstGeom prst="roundRect">
             <a:avLst>
@@ -5894,8 +5883,8 @@
         </p:nvSpPr>
         <p:spPr>
           <a:xfrm>
-            <a:off x="6411610" y="2679192"/>
-            <a:ext cx="45720" cy="640080"/>
+            <a:off x="6411610" y="2697480"/>
+            <a:ext cx="45720" cy="621792"/>
           </a:xfrm>
           <a:prstGeom prst="rect">
             <a:avLst/>
@@ -5937,8 +5926,8 @@
         </p:nvSpPr>
         <p:spPr>
           <a:xfrm>
-            <a:off x="6539626" y="2679192"/>
-            <a:ext cx="1554422" cy="676656"/>
+            <a:off x="6539626" y="2697480"/>
+            <a:ext cx="1554422" cy="658368"/>
           </a:xfrm>
           <a:prstGeom prst="rect">
             <a:avLst/>
@@ -5999,7 +5988,7 @@
         <p:spPr>
           <a:xfrm>
             <a:off x="4546292" y="3502152"/>
-            <a:ext cx="1755590" cy="822960"/>
+            <a:ext cx="1755590" cy="804672"/>
           </a:xfrm>
           <a:prstGeom prst="roundRect">
             <a:avLst>
@@ -6046,7 +6035,7 @@
         <p:spPr>
           <a:xfrm>
             <a:off x="4546292" y="3593592"/>
-            <a:ext cx="45720" cy="640080"/>
+            <a:ext cx="45720" cy="621792"/>
           </a:xfrm>
           <a:prstGeom prst="rect">
             <a:avLst/>
@@ -6089,7 +6078,7 @@
         <p:spPr>
           <a:xfrm>
             <a:off x="4674308" y="3593592"/>
-            <a:ext cx="1554422" cy="676656"/>
+            <a:ext cx="1554422" cy="658368"/>
           </a:xfrm>
           <a:prstGeom prst="rect">
             <a:avLst/>
@@ -6150,7 +6139,7 @@
         <p:spPr>
           <a:xfrm>
             <a:off x="6411610" y="3502152"/>
-            <a:ext cx="1755590" cy="822960"/>
+            <a:ext cx="1755590" cy="804672"/>
           </a:xfrm>
           <a:prstGeom prst="roundRect">
             <a:avLst>
@@ -6197,7 +6186,7 @@
         <p:spPr>
           <a:xfrm>
             <a:off x="6411610" y="3593592"/>
-            <a:ext cx="45720" cy="640080"/>
+            <a:ext cx="45720" cy="621792"/>
           </a:xfrm>
           <a:prstGeom prst="rect">
             <a:avLst/>
@@ -6240,7 +6229,7 @@
         <p:spPr>
           <a:xfrm>
             <a:off x="6539626" y="3593592"/>
-            <a:ext cx="1554422" cy="676656"/>
+            <a:ext cx="1554422" cy="658368"/>
           </a:xfrm>
           <a:prstGeom prst="rect">
             <a:avLst/>
@@ -6300,7 +6289,7 @@
         </p:nvSpPr>
         <p:spPr>
           <a:xfrm>
-            <a:off x="4546292" y="4507992"/>
+            <a:off x="4546292" y="4498848"/>
             <a:ext cx="3620909" cy="438912"/>
           </a:xfrm>
           <a:prstGeom prst="roundRect">
@@ -6382,7 +6371,7 @@
         </p:nvSpPr>
         <p:spPr>
           <a:xfrm>
-            <a:off x="4546292" y="5056632"/>
+            <a:off x="4546292" y="5047488"/>
             <a:ext cx="3620909" cy="548640"/>
           </a:xfrm>
           <a:prstGeom prst="rect">
@@ -6418,7 +6407,7 @@
         </p:nvSpPr>
         <p:spPr>
           <a:xfrm>
-            <a:off x="8350081" y="2679191"/>
+            <a:off x="8350081" y="2670048"/>
             <a:ext cx="182880" cy="137160"/>
           </a:xfrm>
           <a:prstGeom prst="rightArrow">
@@ -6461,7 +6450,7 @@
         </p:nvSpPr>
         <p:spPr>
           <a:xfrm>
-            <a:off x="8350081" y="3959352"/>
+            <a:off x="8350081" y="3950208"/>
             <a:ext cx="182880" cy="137160"/>
           </a:xfrm>
           <a:prstGeom prst="rightArrow">
@@ -6504,8 +6493,8 @@
         </p:nvSpPr>
         <p:spPr>
           <a:xfrm>
-            <a:off x="8569537" y="804672"/>
-            <a:ext cx="1434956" cy="5074920"/>
+            <a:off x="8569537" y="841248"/>
+            <a:ext cx="1434956" cy="5029200"/>
           </a:xfrm>
           <a:prstGeom prst="roundRect">
             <a:avLst>
@@ -6551,7 +6540,7 @@
         </p:nvSpPr>
         <p:spPr>
           <a:xfrm>
-            <a:off x="8642689" y="914400"/>
+            <a:off x="8642689" y="950976"/>
             <a:ext cx="237744" cy="237744"/>
           </a:xfrm>
           <a:prstGeom prst="ellipse">
@@ -6594,7 +6583,7 @@
         </p:nvSpPr>
         <p:spPr>
           <a:xfrm>
-            <a:off x="8642689" y="932688"/>
+            <a:off x="8642689" y="969264"/>
             <a:ext cx="237744" cy="201168"/>
           </a:xfrm>
           <a:prstGeom prst="rect">
@@ -6629,7 +6618,7 @@
         </p:nvSpPr>
         <p:spPr>
           <a:xfrm>
-            <a:off x="8935297" y="932688"/>
+            <a:off x="8935297" y="969264"/>
             <a:ext cx="1014332" cy="201168"/>
           </a:xfrm>
           <a:prstGeom prst="rect">
@@ -6664,7 +6653,7 @@
         </p:nvSpPr>
         <p:spPr>
           <a:xfrm>
-            <a:off x="8660977" y="1243584"/>
+            <a:off x="8660977" y="1280160"/>
             <a:ext cx="1270364" cy="438912"/>
           </a:xfrm>
           <a:prstGeom prst="rect">
@@ -6700,7 +6689,7 @@
         </p:nvSpPr>
         <p:spPr>
           <a:xfrm>
-            <a:off x="8660977" y="1856232"/>
+            <a:off x="8660977" y="1892808"/>
             <a:ext cx="1252076" cy="914400"/>
           </a:xfrm>
           <a:prstGeom prst="roundRect">
@@ -6747,7 +6736,7 @@
         </p:nvSpPr>
         <p:spPr>
           <a:xfrm>
-            <a:off x="8660977" y="1947672"/>
+            <a:off x="8660977" y="1984248"/>
             <a:ext cx="45720" cy="731520"/>
           </a:xfrm>
           <a:prstGeom prst="rect">
@@ -6790,7 +6779,7 @@
         </p:nvSpPr>
         <p:spPr>
           <a:xfrm>
-            <a:off x="8788993" y="1947672"/>
+            <a:off x="8788993" y="1984248"/>
             <a:ext cx="1050908" cy="768096"/>
           </a:xfrm>
           <a:prstGeom prst="rect">
@@ -6851,7 +6840,7 @@
         </p:nvSpPr>
         <p:spPr>
           <a:xfrm>
-            <a:off x="8660977" y="2907792"/>
+            <a:off x="8660977" y="2944368"/>
             <a:ext cx="1252076" cy="914400"/>
           </a:xfrm>
           <a:prstGeom prst="roundRect">
@@ -6898,7 +6887,7 @@
         </p:nvSpPr>
         <p:spPr>
           <a:xfrm>
-            <a:off x="8660977" y="2999232"/>
+            <a:off x="8660977" y="3035808"/>
             <a:ext cx="45720" cy="731520"/>
           </a:xfrm>
           <a:prstGeom prst="rect">
@@ -6941,7 +6930,7 @@
         </p:nvSpPr>
         <p:spPr>
           <a:xfrm>
-            <a:off x="8788993" y="2999232"/>
+            <a:off x="8788993" y="3035808"/>
             <a:ext cx="1050908" cy="768096"/>
           </a:xfrm>
           <a:prstGeom prst="rect">
@@ -7002,7 +6991,7 @@
         </p:nvSpPr>
         <p:spPr>
           <a:xfrm>
-            <a:off x="8660977" y="3959352"/>
+            <a:off x="8660977" y="3995928"/>
             <a:ext cx="1252076" cy="914400"/>
           </a:xfrm>
           <a:prstGeom prst="roundRect">
@@ -7049,7 +7038,7 @@
         </p:nvSpPr>
         <p:spPr>
           <a:xfrm>
-            <a:off x="8660977" y="4050792"/>
+            <a:off x="8660977" y="4087368"/>
             <a:ext cx="45720" cy="731520"/>
           </a:xfrm>
           <a:prstGeom prst="rect">
@@ -7092,7 +7081,7 @@
         </p:nvSpPr>
         <p:spPr>
           <a:xfrm>
-            <a:off x="8788993" y="4050792"/>
+            <a:off x="8788993" y="4087368"/>
             <a:ext cx="1050908" cy="768096"/>
           </a:xfrm>
           <a:prstGeom prst="rect">
@@ -7153,7 +7142,7 @@
         </p:nvSpPr>
         <p:spPr>
           <a:xfrm>
-            <a:off x="10041069" y="2679191"/>
+            <a:off x="10041069" y="2670048"/>
             <a:ext cx="182880" cy="137160"/>
           </a:xfrm>
           <a:prstGeom prst="rightArrow">
@@ -7196,7 +7185,7 @@
         </p:nvSpPr>
         <p:spPr>
           <a:xfrm>
-            <a:off x="10041069" y="3959352"/>
+            <a:off x="10041069" y="3950208"/>
             <a:ext cx="182880" cy="137160"/>
           </a:xfrm>
           <a:prstGeom prst="rightArrow">
@@ -7239,8 +7228,8 @@
         </p:nvSpPr>
         <p:spPr>
           <a:xfrm>
-            <a:off x="10260525" y="804672"/>
-            <a:ext cx="1565407" cy="5074920"/>
+            <a:off x="10260525" y="841248"/>
+            <a:ext cx="1565407" cy="5029200"/>
           </a:xfrm>
           <a:prstGeom prst="roundRect">
             <a:avLst>
@@ -7286,7 +7275,7 @@
         </p:nvSpPr>
         <p:spPr>
           <a:xfrm>
-            <a:off x="10333677" y="914400"/>
+            <a:off x="10333677" y="950976"/>
             <a:ext cx="237744" cy="237744"/>
           </a:xfrm>
           <a:prstGeom prst="ellipse">
@@ -7329,7 +7318,7 @@
         </p:nvSpPr>
         <p:spPr>
           <a:xfrm>
-            <a:off x="10333677" y="932688"/>
+            <a:off x="10333677" y="969264"/>
             <a:ext cx="237744" cy="201168"/>
           </a:xfrm>
           <a:prstGeom prst="rect">
@@ -7364,7 +7353,7 @@
         </p:nvSpPr>
         <p:spPr>
           <a:xfrm>
-            <a:off x="10626285" y="932688"/>
+            <a:off x="10626285" y="969264"/>
             <a:ext cx="1144783" cy="201168"/>
           </a:xfrm>
           <a:prstGeom prst="rect">
@@ -7399,7 +7388,7 @@
         </p:nvSpPr>
         <p:spPr>
           <a:xfrm>
-            <a:off x="10351965" y="1225296"/>
+            <a:off x="10351965" y="1261872"/>
             <a:ext cx="1400815" cy="457200"/>
           </a:xfrm>
           <a:prstGeom prst="rect">
@@ -7435,7 +7424,7 @@
         </p:nvSpPr>
         <p:spPr>
           <a:xfrm>
-            <a:off x="10351965" y="1856232"/>
+            <a:off x="10351965" y="1892808"/>
             <a:ext cx="1382527" cy="777240"/>
           </a:xfrm>
           <a:prstGeom prst="roundRect">
@@ -7482,7 +7471,7 @@
         </p:nvSpPr>
         <p:spPr>
           <a:xfrm>
-            <a:off x="10351965" y="1947672"/>
+            <a:off x="10351965" y="1984248"/>
             <a:ext cx="45720" cy="594360"/>
           </a:xfrm>
           <a:prstGeom prst="rect">
@@ -7525,7 +7514,7 @@
         </p:nvSpPr>
         <p:spPr>
           <a:xfrm>
-            <a:off x="10479981" y="1947672"/>
+            <a:off x="10479981" y="1984248"/>
             <a:ext cx="1181359" cy="630936"/>
           </a:xfrm>
           <a:prstGeom prst="rect">
@@ -7586,7 +7575,7 @@
         </p:nvSpPr>
         <p:spPr>
           <a:xfrm>
-            <a:off x="10351965" y="2724912"/>
+            <a:off x="10351965" y="2761488"/>
             <a:ext cx="1382527" cy="777240"/>
           </a:xfrm>
           <a:prstGeom prst="roundRect">
@@ -7633,7 +7622,7 @@
         </p:nvSpPr>
         <p:spPr>
           <a:xfrm>
-            <a:off x="10351965" y="2816352"/>
+            <a:off x="10351965" y="2852928"/>
             <a:ext cx="45720" cy="594360"/>
           </a:xfrm>
           <a:prstGeom prst="rect">
@@ -7676,7 +7665,7 @@
         </p:nvSpPr>
         <p:spPr>
           <a:xfrm>
-            <a:off x="10479981" y="2816352"/>
+            <a:off x="10479981" y="2852928"/>
             <a:ext cx="1181359" cy="630936"/>
           </a:xfrm>
           <a:prstGeom prst="rect">
@@ -7737,7 +7726,7 @@
         </p:nvSpPr>
         <p:spPr>
           <a:xfrm>
-            <a:off x="10351965" y="3593592"/>
+            <a:off x="10351965" y="3630168"/>
             <a:ext cx="1382527" cy="777240"/>
           </a:xfrm>
           <a:prstGeom prst="roundRect">
@@ -7784,7 +7773,7 @@
         </p:nvSpPr>
         <p:spPr>
           <a:xfrm>
-            <a:off x="10351965" y="3685032"/>
+            <a:off x="10351965" y="3721608"/>
             <a:ext cx="45720" cy="594360"/>
           </a:xfrm>
           <a:prstGeom prst="rect">
@@ -7827,7 +7816,7 @@
         </p:nvSpPr>
         <p:spPr>
           <a:xfrm>
-            <a:off x="10479981" y="3685032"/>
+            <a:off x="10479981" y="3721608"/>
             <a:ext cx="1181359" cy="630936"/>
           </a:xfrm>
           <a:prstGeom prst="rect">
@@ -7888,7 +7877,7 @@
         </p:nvSpPr>
         <p:spPr>
           <a:xfrm>
-            <a:off x="10351965" y="4462271"/>
+            <a:off x="10351965" y="4498847"/>
             <a:ext cx="1382527" cy="777240"/>
           </a:xfrm>
           <a:prstGeom prst="roundRect">
@@ -7935,7 +7924,7 @@
         </p:nvSpPr>
         <p:spPr>
           <a:xfrm>
-            <a:off x="10351965" y="4553711"/>
+            <a:off x="10351965" y="4590287"/>
             <a:ext cx="45720" cy="594360"/>
           </a:xfrm>
           <a:prstGeom prst="rect">
@@ -7978,7 +7967,7 @@
         </p:nvSpPr>
         <p:spPr>
           <a:xfrm>
-            <a:off x="10479981" y="4553711"/>
+            <a:off x="10479981" y="4590287"/>
             <a:ext cx="1181359" cy="630936"/>
           </a:xfrm>
           <a:prstGeom prst="rect">
@@ -8078,224 +8067,57 @@
           </a:p>
         </p:txBody>
       </p:sp>
-      <p:sp>
-        <p:nvSpPr>
-          <p:cNvPr id="115" name="Oval 114"/>
-          <p:cNvSpPr/>
-          <p:nvPr/>
-        </p:nvSpPr>
-        <p:spPr>
-          <a:xfrm>
-            <a:off x="502920" y="6236208"/>
-            <a:ext cx="128016" cy="128016"/>
-          </a:xfrm>
-          <a:prstGeom prst="ellipse">
-            <a:avLst/>
-          </a:prstGeom>
-          <a:solidFill>
-            <a:srgbClr val="38BDF8"/>
-          </a:solidFill>
-          <a:ln>
-            <a:noFill/>
-          </a:ln>
-        </p:spPr>
-        <p:style>
-          <a:lnRef idx="1">
-            <a:schemeClr val="accent1"/>
-          </a:lnRef>
-          <a:fillRef idx="3">
-            <a:schemeClr val="accent1"/>
-          </a:fillRef>
-          <a:effectRef idx="2">
-            <a:schemeClr val="accent1"/>
-          </a:effectRef>
-          <a:fontRef idx="minor">
-            <a:schemeClr val="lt1"/>
-          </a:fontRef>
-        </p:style>
-        <p:txBody>
-          <a:bodyPr rtlCol="0" anchor="ctr"/>
-          <a:lstStyle/>
-          <a:p>
-            <a:pPr algn="ctr"/>
-          </a:p>
-        </p:txBody>
-      </p:sp>
-      <p:sp>
-        <p:nvSpPr>
-          <p:cNvPr id="116" name="Oval 115"/>
-          <p:cNvSpPr/>
-          <p:nvPr/>
-        </p:nvSpPr>
-        <p:spPr>
-          <a:xfrm>
-            <a:off x="740664" y="6236208"/>
-            <a:ext cx="128016" cy="128016"/>
-          </a:xfrm>
-          <a:prstGeom prst="ellipse">
-            <a:avLst/>
-          </a:prstGeom>
-          <a:solidFill>
-            <a:srgbClr val="FB923C"/>
-          </a:solidFill>
-          <a:ln>
-            <a:noFill/>
-          </a:ln>
-        </p:spPr>
-        <p:style>
-          <a:lnRef idx="1">
-            <a:schemeClr val="accent1"/>
-          </a:lnRef>
-          <a:fillRef idx="3">
-            <a:schemeClr val="accent1"/>
-          </a:fillRef>
-          <a:effectRef idx="2">
-            <a:schemeClr val="accent1"/>
-          </a:effectRef>
-          <a:fontRef idx="minor">
-            <a:schemeClr val="lt1"/>
-          </a:fontRef>
-        </p:style>
-        <p:txBody>
-          <a:bodyPr rtlCol="0" anchor="ctr"/>
-          <a:lstStyle/>
-          <a:p>
-            <a:pPr algn="ctr"/>
-          </a:p>
-        </p:txBody>
-      </p:sp>
-      <p:sp>
-        <p:nvSpPr>
-          <p:cNvPr id="117" name="Oval 116"/>
-          <p:cNvSpPr/>
-          <p:nvPr/>
-        </p:nvSpPr>
-        <p:spPr>
-          <a:xfrm>
-            <a:off x="978408" y="6236208"/>
-            <a:ext cx="128016" cy="128016"/>
-          </a:xfrm>
-          <a:prstGeom prst="ellipse">
-            <a:avLst/>
-          </a:prstGeom>
-          <a:solidFill>
-            <a:srgbClr val="2DD4BF"/>
-          </a:solidFill>
-          <a:ln>
-            <a:noFill/>
-          </a:ln>
-        </p:spPr>
-        <p:style>
-          <a:lnRef idx="1">
-            <a:schemeClr val="accent1"/>
-          </a:lnRef>
-          <a:fillRef idx="3">
-            <a:schemeClr val="accent1"/>
-          </a:fillRef>
-          <a:effectRef idx="2">
-            <a:schemeClr val="accent1"/>
-          </a:effectRef>
-          <a:fontRef idx="minor">
-            <a:schemeClr val="lt1"/>
-          </a:fontRef>
-        </p:style>
-        <p:txBody>
-          <a:bodyPr rtlCol="0" anchor="ctr"/>
-          <a:lstStyle/>
-          <a:p>
-            <a:pPr algn="ctr"/>
-          </a:p>
-        </p:txBody>
-      </p:sp>
-      <p:sp>
-        <p:nvSpPr>
-          <p:cNvPr id="118" name="Oval 117"/>
-          <p:cNvSpPr/>
-          <p:nvPr/>
-        </p:nvSpPr>
-        <p:spPr>
-          <a:xfrm>
-            <a:off x="1216152" y="6236208"/>
-            <a:ext cx="128016" cy="128016"/>
-          </a:xfrm>
-          <a:prstGeom prst="ellipse">
-            <a:avLst/>
-          </a:prstGeom>
-          <a:solidFill>
-            <a:srgbClr val="FCD34D"/>
-          </a:solidFill>
-          <a:ln>
-            <a:noFill/>
-          </a:ln>
-        </p:spPr>
-        <p:style>
-          <a:lnRef idx="1">
-            <a:schemeClr val="accent1"/>
-          </a:lnRef>
-          <a:fillRef idx="3">
-            <a:schemeClr val="accent1"/>
-          </a:fillRef>
-          <a:effectRef idx="2">
-            <a:schemeClr val="accent1"/>
-          </a:effectRef>
-          <a:fontRef idx="minor">
-            <a:schemeClr val="lt1"/>
-          </a:fontRef>
-        </p:style>
-        <p:txBody>
-          <a:bodyPr rtlCol="0" anchor="ctr"/>
-          <a:lstStyle/>
-          <a:p>
-            <a:pPr algn="ctr"/>
-          </a:p>
-        </p:txBody>
-      </p:sp>
-      <p:sp>
-        <p:nvSpPr>
-          <p:cNvPr id="119" name="Oval 118"/>
-          <p:cNvSpPr/>
-          <p:nvPr/>
-        </p:nvSpPr>
-        <p:spPr>
-          <a:xfrm>
-            <a:off x="1453896" y="6236208"/>
-            <a:ext cx="128016" cy="128016"/>
-          </a:xfrm>
-          <a:prstGeom prst="ellipse">
-            <a:avLst/>
-          </a:prstGeom>
-          <a:solidFill>
-            <a:srgbClr val="C4B5FD"/>
-          </a:solidFill>
-          <a:ln>
-            <a:noFill/>
-          </a:ln>
-        </p:spPr>
-        <p:style>
-          <a:lnRef idx="1">
-            <a:schemeClr val="accent1"/>
-          </a:lnRef>
-          <a:fillRef idx="3">
-            <a:schemeClr val="accent1"/>
-          </a:fillRef>
-          <a:effectRef idx="2">
-            <a:schemeClr val="accent1"/>
-          </a:effectRef>
-          <a:fontRef idx="minor">
-            <a:schemeClr val="lt1"/>
-          </a:fontRef>
-        </p:style>
-        <p:txBody>
-          <a:bodyPr rtlCol="0" anchor="ctr"/>
-          <a:lstStyle/>
-          <a:p>
-            <a:pPr algn="ctr"/>
-          </a:p>
-        </p:txBody>
-      </p:sp>
       <p:pic>
         <p:nvPicPr>
-          <p:cNvPr id="120" name="Picture 119" descr="sdk.png"/>
+          <p:cNvPr id="115" name="Picture 114" descr="uaf_mark_40.png"/>
+          <p:cNvPicPr>
+            <a:picLocks noChangeAspect="1"/>
+          </p:cNvPicPr>
+          <p:nvPr/>
+        </p:nvPicPr>
+        <p:blipFill>
+          <a:blip r:embed="rId8"/>
+          <a:stretch>
+            <a:fillRect/>
+          </a:stretch>
+        </p:blipFill>
+        <p:spPr>
+          <a:xfrm>
+            <a:off x="502920" y="6181344"/>
+            <a:ext cx="292608" cy="292608"/>
+          </a:xfrm>
+          <a:prstGeom prst="rect">
+            <a:avLst/>
+          </a:prstGeom>
+        </p:spPr>
+      </p:pic>
+      <p:pic>
+        <p:nvPicPr>
+          <p:cNvPr id="116" name="Picture 115" descr="sim_mark_48.png"/>
+          <p:cNvPicPr>
+            <a:picLocks noChangeAspect="1"/>
+          </p:cNvPicPr>
+          <p:nvPr/>
+        </p:nvPicPr>
+        <p:blipFill>
+          <a:blip r:embed="rId3"/>
+          <a:stretch>
+            <a:fillRect/>
+          </a:stretch>
+        </p:blipFill>
+        <p:spPr>
+          <a:xfrm>
+            <a:off x="868680" y="6181344"/>
+            <a:ext cx="292608" cy="292608"/>
+          </a:xfrm>
+          <a:prstGeom prst="rect">
+            <a:avLst/>
+          </a:prstGeom>
+        </p:spPr>
+      </p:pic>
+      <p:pic>
+        <p:nvPicPr>
+          <p:cNvPr id="117" name="Picture 116" descr="sdk.png"/>
           <p:cNvPicPr>
             <a:picLocks noChangeAspect="1"/>
           </p:cNvPicPr>
@@ -8309,8 +8131,8 @@
         </p:blipFill>
         <p:spPr>
           <a:xfrm>
-            <a:off x="1828800" y="6181344"/>
-            <a:ext cx="237744" cy="237744"/>
+            <a:off x="1280160" y="6181344"/>
+            <a:ext cx="256032" cy="256032"/>
           </a:xfrm>
           <a:prstGeom prst="rect">
             <a:avLst/>
@@ -8319,7 +8141,7 @@
       </p:pic>
       <p:pic>
         <p:nvPicPr>
-          <p:cNvPr id="121" name="Picture 120" descr="rest.png"/>
+          <p:cNvPr id="118" name="Picture 117" descr="rest.png"/>
           <p:cNvPicPr>
             <a:picLocks noChangeAspect="1"/>
           </p:cNvPicPr>
@@ -8333,8 +8155,8 @@
         </p:blipFill>
         <p:spPr>
           <a:xfrm>
-            <a:off x="2121408" y="6181344"/>
-            <a:ext cx="237744" cy="237744"/>
+            <a:off x="1600200" y="6181344"/>
+            <a:ext cx="256032" cy="256032"/>
           </a:xfrm>
           <a:prstGeom prst="rect">
             <a:avLst/>
@@ -8343,7 +8165,7 @@
       </p:pic>
       <p:pic>
         <p:nvPicPr>
-          <p:cNvPr id="122" name="Picture 121" descr="kafka.png"/>
+          <p:cNvPr id="119" name="Picture 118" descr="kafka.png"/>
           <p:cNvPicPr>
             <a:picLocks noChangeAspect="1"/>
           </p:cNvPicPr>
@@ -8357,8 +8179,8 @@
         </p:blipFill>
         <p:spPr>
           <a:xfrm>
-            <a:off x="2414016" y="6181344"/>
-            <a:ext cx="237744" cy="237744"/>
+            <a:off x="1920240" y="6181344"/>
+            <a:ext cx="256032" cy="256032"/>
           </a:xfrm>
           <a:prstGeom prst="rect">
             <a:avLst/>
@@ -8367,14 +8189,14 @@
       </p:pic>
       <p:sp>
         <p:nvSpPr>
-          <p:cNvPr id="123" name="TextBox 122"/>
+          <p:cNvPr id="120" name="TextBox 119"/>
           <p:cNvSpPr txBox="1"/>
           <p:nvPr/>
         </p:nvSpPr>
         <p:spPr>
           <a:xfrm>
-            <a:off x="2788920" y="6199632"/>
-            <a:ext cx="7315200" cy="292608"/>
+            <a:off x="2331720" y="6199632"/>
+            <a:ext cx="7772400" cy="292608"/>
           </a:xfrm>
           <a:prstGeom prst="rect">
             <a:avLst/>
@@ -8395,14 +8217,14 @@
                 </a:solidFill>
                 <a:latin typeface="Calibri"/>
               </a:rPr>
-              <a:t>SDK · REST · Kafka     ·     one Landing interface     ·     UAF fan-out behind the hub</a:t>
-            </a:r>
-          </a:p>
-        </p:txBody>
-      </p:sp>
-      <p:sp>
-        <p:nvSpPr>
-          <p:cNvPr id="124" name="TextBox 123"/>
+              <a:t>UAF · sim  ·  SDK · REST · Kafka     ·     one Landing interface     ·     UAF fan-out behind hub</a:t>
+            </a:r>
+          </a:p>
+        </p:txBody>
+      </p:sp>
+      <p:sp>
+        <p:nvSpPr>
+          <p:cNvPr id="121" name="TextBox 120"/>
           <p:cNvSpPr txBox="1"/>
           <p:nvPr/>
         </p:nvSpPr>
@@ -8547,8 +8369,8 @@
         </p:nvSpPr>
         <p:spPr>
           <a:xfrm>
-            <a:off x="365760" y="146304"/>
-            <a:ext cx="7315200" cy="292608"/>
+            <a:off x="365760" y="128016"/>
+            <a:ext cx="6583680" cy="274320"/>
           </a:xfrm>
           <a:prstGeom prst="rect">
             <a:avLst/>
@@ -8576,7 +8398,7 @@
       </p:sp>
       <p:pic>
         <p:nvPicPr>
-          <p:cNvPr id="5" name="Picture 4" descr="uaf.png"/>
+          <p:cNvPr id="5" name="Picture 4" descr="uaf_badge_48.png"/>
           <p:cNvPicPr>
             <a:picLocks noChangeAspect="1"/>
           </p:cNvPicPr>
@@ -8590,52 +8412,17 @@
         </p:blipFill>
         <p:spPr>
           <a:xfrm>
-            <a:off x="8229600" y="146304"/>
-            <a:ext cx="292608" cy="292608"/>
+            <a:off x="7635240" y="109728"/>
+            <a:ext cx="1143000" cy="365760"/>
           </a:xfrm>
           <a:prstGeom prst="rect">
             <a:avLst/>
           </a:prstGeom>
         </p:spPr>
       </p:pic>
-      <p:sp>
-        <p:nvSpPr>
-          <p:cNvPr id="6" name="TextBox 5"/>
-          <p:cNvSpPr txBox="1"/>
-          <p:nvPr/>
-        </p:nvSpPr>
-        <p:spPr>
-          <a:xfrm>
-            <a:off x="8558784" y="164592"/>
-            <a:ext cx="457200" cy="256032"/>
-          </a:xfrm>
-          <a:prstGeom prst="rect">
-            <a:avLst/>
-          </a:prstGeom>
-          <a:noFill/>
-        </p:spPr>
-        <p:txBody>
-          <a:bodyPr wrap="square" lIns="25400" rIns="25400" tIns="12700" bIns="12700">
-            <a:spAutoFit/>
-          </a:bodyPr>
-          <a:lstStyle/>
-          <a:p>
-            <a:pPr algn="l"/>
-            <a:r>
-              <a:rPr sz="1100" b="1">
-                <a:solidFill>
-                  <a:srgbClr val="2DD4BF"/>
-                </a:solidFill>
-                <a:latin typeface="Calibri"/>
-              </a:rPr>
-              <a:t>UAF</a:t>
-            </a:r>
-          </a:p>
-        </p:txBody>
-      </p:sp>
       <p:pic>
         <p:nvPicPr>
-          <p:cNvPr id="7" name="Picture 6" descr="sim.png"/>
+          <p:cNvPr id="6" name="Picture 5" descr="sim_mark_48.png"/>
           <p:cNvPicPr>
             <a:picLocks noChangeAspect="1"/>
           </p:cNvPicPr>
@@ -8649,8 +8436,8 @@
         </p:blipFill>
         <p:spPr>
           <a:xfrm>
-            <a:off x="9098280" y="146304"/>
-            <a:ext cx="292608" cy="292608"/>
+            <a:off x="8915400" y="109728"/>
+            <a:ext cx="365760" cy="365760"/>
           </a:xfrm>
           <a:prstGeom prst="rect">
             <a:avLst/>
@@ -8659,13 +8446,13 @@
       </p:pic>
       <p:sp>
         <p:nvSpPr>
-          <p:cNvPr id="8" name="TextBox 7"/>
+          <p:cNvPr id="7" name="TextBox 6"/>
           <p:cNvSpPr txBox="1"/>
           <p:nvPr/>
         </p:nvSpPr>
         <p:spPr>
           <a:xfrm>
-            <a:off x="9436608" y="164592"/>
+            <a:off x="9345168" y="164592"/>
             <a:ext cx="411480" cy="256032"/>
           </a:xfrm>
           <a:prstGeom prst="rect">
@@ -8694,14 +8481,14 @@
       </p:sp>
       <p:sp>
         <p:nvSpPr>
-          <p:cNvPr id="9" name="Rounded Rectangle 8"/>
+          <p:cNvPr id="8" name="Rounded Rectangle 7"/>
           <p:cNvSpPr/>
           <p:nvPr/>
         </p:nvSpPr>
         <p:spPr>
           <a:xfrm>
-            <a:off x="10058400" y="128016"/>
-            <a:ext cx="1737360" cy="329184"/>
+            <a:off x="10058400" y="109728"/>
+            <a:ext cx="1737360" cy="365760"/>
           </a:xfrm>
           <a:prstGeom prst="roundRect">
             <a:avLst>
@@ -8741,14 +8528,14 @@
       </p:sp>
       <p:sp>
         <p:nvSpPr>
-          <p:cNvPr id="10" name="TextBox 9"/>
+          <p:cNvPr id="9" name="TextBox 8"/>
           <p:cNvSpPr txBox="1"/>
           <p:nvPr/>
         </p:nvSpPr>
         <p:spPr>
           <a:xfrm>
-            <a:off x="10058400" y="164592"/>
-            <a:ext cx="1737360" cy="256032"/>
+            <a:off x="10058400" y="146304"/>
+            <a:ext cx="1737360" cy="292608"/>
           </a:xfrm>
           <a:prstGeom prst="rect">
             <a:avLst/>
@@ -8776,13 +8563,13 @@
       </p:sp>
       <p:sp>
         <p:nvSpPr>
-          <p:cNvPr id="11" name="TextBox 10"/>
+          <p:cNvPr id="10" name="TextBox 9"/>
           <p:cNvSpPr txBox="1"/>
           <p:nvPr/>
         </p:nvSpPr>
         <p:spPr>
           <a:xfrm>
-            <a:off x="365760" y="475488"/>
+            <a:off x="365760" y="530352"/>
             <a:ext cx="11430000" cy="219456"/>
           </a:xfrm>
           <a:prstGeom prst="rect">
@@ -8811,14 +8598,14 @@
       </p:sp>
       <p:sp>
         <p:nvSpPr>
-          <p:cNvPr id="12" name="Rounded Rectangle 11"/>
+          <p:cNvPr id="11" name="Rounded Rectangle 10"/>
           <p:cNvSpPr/>
           <p:nvPr/>
         </p:nvSpPr>
         <p:spPr>
           <a:xfrm>
-            <a:off x="365760" y="804672"/>
-            <a:ext cx="11457432" cy="868680"/>
+            <a:off x="365760" y="841248"/>
+            <a:ext cx="11457432" cy="841248"/>
           </a:xfrm>
           <a:prstGeom prst="roundRect">
             <a:avLst>
@@ -8858,13 +8645,13 @@
       </p:sp>
       <p:sp>
         <p:nvSpPr>
-          <p:cNvPr id="13" name="Rounded Rectangle 12"/>
+          <p:cNvPr id="12" name="Rounded Rectangle 11"/>
           <p:cNvSpPr/>
           <p:nvPr/>
         </p:nvSpPr>
         <p:spPr>
           <a:xfrm>
-            <a:off x="502920" y="932688"/>
+            <a:off x="502920" y="950976"/>
             <a:ext cx="1691640" cy="256032"/>
           </a:xfrm>
           <a:prstGeom prst="roundRect">
@@ -8903,13 +8690,13 @@
       </p:sp>
       <p:sp>
         <p:nvSpPr>
-          <p:cNvPr id="14" name="TextBox 13"/>
+          <p:cNvPr id="13" name="TextBox 12"/>
           <p:cNvSpPr txBox="1"/>
           <p:nvPr/>
         </p:nvSpPr>
         <p:spPr>
           <a:xfrm>
-            <a:off x="502920" y="941832"/>
+            <a:off x="502920" y="960120"/>
             <a:ext cx="1691640" cy="237744"/>
           </a:xfrm>
           <a:prstGeom prst="rect">
@@ -8938,13 +8725,13 @@
       </p:sp>
       <p:sp>
         <p:nvSpPr>
-          <p:cNvPr id="15" name="TextBox 14"/>
+          <p:cNvPr id="14" name="TextBox 13"/>
           <p:cNvSpPr txBox="1"/>
           <p:nvPr/>
         </p:nvSpPr>
         <p:spPr>
           <a:xfrm>
-            <a:off x="2377440" y="914400"/>
+            <a:off x="2377440" y="932688"/>
             <a:ext cx="8961120" cy="256032"/>
           </a:xfrm>
           <a:prstGeom prst="rect">
@@ -8973,7 +8760,7 @@
       </p:sp>
       <p:pic>
         <p:nvPicPr>
-          <p:cNvPr id="16" name="Picture 15" descr="kafka.png"/>
+          <p:cNvPr id="15" name="Picture 14" descr="kafka.png"/>
           <p:cNvPicPr>
             <a:picLocks noChangeAspect="1"/>
           </p:cNvPicPr>
@@ -8987,7 +8774,7 @@
         </p:blipFill>
         <p:spPr>
           <a:xfrm>
-            <a:off x="2377440" y="1261872"/>
+            <a:off x="2377440" y="1280160"/>
             <a:ext cx="237744" cy="237744"/>
           </a:xfrm>
           <a:prstGeom prst="rect">
@@ -8997,13 +8784,13 @@
       </p:pic>
       <p:sp>
         <p:nvSpPr>
-          <p:cNvPr id="17" name="TextBox 16"/>
+          <p:cNvPr id="16" name="TextBox 15"/>
           <p:cNvSpPr txBox="1"/>
           <p:nvPr/>
         </p:nvSpPr>
         <p:spPr>
           <a:xfrm>
-            <a:off x="2697480" y="1261872"/>
+            <a:off x="2697480" y="1280160"/>
             <a:ext cx="8686800" cy="256032"/>
           </a:xfrm>
           <a:prstGeom prst="rect">
@@ -9032,7 +8819,7 @@
       </p:sp>
       <p:sp>
         <p:nvSpPr>
-          <p:cNvPr id="18" name="Down Arrow 17"/>
+          <p:cNvPr id="17" name="Down Arrow 16"/>
           <p:cNvSpPr/>
           <p:nvPr/>
         </p:nvSpPr>
@@ -9075,7 +8862,7 @@
       </p:sp>
       <p:sp>
         <p:nvSpPr>
-          <p:cNvPr id="19" name="TextBox 18"/>
+          <p:cNvPr id="18" name="TextBox 17"/>
           <p:cNvSpPr txBox="1"/>
           <p:nvPr/>
         </p:nvSpPr>
@@ -9110,7 +8897,7 @@
       </p:sp>
       <p:sp>
         <p:nvSpPr>
-          <p:cNvPr id="20" name="Rounded Rectangle 19"/>
+          <p:cNvPr id="19" name="Rounded Rectangle 18"/>
           <p:cNvSpPr/>
           <p:nvPr/>
         </p:nvSpPr>
@@ -9157,14 +8944,14 @@
       </p:sp>
       <p:sp>
         <p:nvSpPr>
-          <p:cNvPr id="21" name="Rounded Rectangle 20"/>
+          <p:cNvPr id="20" name="Rounded Rectangle 19"/>
           <p:cNvSpPr/>
           <p:nvPr/>
         </p:nvSpPr>
         <p:spPr>
           <a:xfrm>
-            <a:off x="502920" y="2139696"/>
-            <a:ext cx="2468880" cy="256032"/>
+            <a:off x="502920" y="2121408"/>
+            <a:ext cx="2286000" cy="256032"/>
           </a:xfrm>
           <a:prstGeom prst="roundRect">
             <a:avLst>
@@ -9202,14 +8989,14 @@
       </p:sp>
       <p:sp>
         <p:nvSpPr>
-          <p:cNvPr id="22" name="TextBox 21"/>
+          <p:cNvPr id="21" name="TextBox 20"/>
           <p:cNvSpPr txBox="1"/>
           <p:nvPr/>
         </p:nvSpPr>
         <p:spPr>
           <a:xfrm>
-            <a:off x="502920" y="2148840"/>
-            <a:ext cx="2468880" cy="237744"/>
+            <a:off x="502920" y="2130552"/>
+            <a:ext cx="2286000" cy="237744"/>
           </a:xfrm>
           <a:prstGeom prst="rect">
             <a:avLst/>
@@ -9237,7 +9024,7 @@
       </p:sp>
       <p:pic>
         <p:nvPicPr>
-          <p:cNvPr id="23" name="Picture 22" descr="uaf.png"/>
+          <p:cNvPr id="22" name="Picture 21" descr="uaf_badge_48.png"/>
           <p:cNvPicPr>
             <a:picLocks noChangeAspect="1"/>
           </p:cNvPicPr>
@@ -9251,8 +9038,8 @@
         </p:blipFill>
         <p:spPr>
           <a:xfrm>
-            <a:off x="3108960" y="2139696"/>
-            <a:ext cx="256032" cy="256032"/>
+            <a:off x="2926080" y="2103120"/>
+            <a:ext cx="1097280" cy="329184"/>
           </a:xfrm>
           <a:prstGeom prst="rect">
             <a:avLst/>
@@ -9261,14 +9048,14 @@
       </p:pic>
       <p:sp>
         <p:nvSpPr>
-          <p:cNvPr id="24" name="TextBox 23"/>
+          <p:cNvPr id="23" name="TextBox 22"/>
           <p:cNvSpPr txBox="1"/>
           <p:nvPr/>
         </p:nvSpPr>
         <p:spPr>
           <a:xfrm>
-            <a:off x="3456432" y="2139696"/>
-            <a:ext cx="7955279" cy="256032"/>
+            <a:off x="4160520" y="2121408"/>
+            <a:ext cx="7132320" cy="256032"/>
           </a:xfrm>
           <a:prstGeom prst="rect">
             <a:avLst/>
@@ -9296,7 +9083,7 @@
       </p:sp>
       <p:sp>
         <p:nvSpPr>
-          <p:cNvPr id="25" name="Rounded Rectangle 24"/>
+          <p:cNvPr id="24" name="Rounded Rectangle 23"/>
           <p:cNvSpPr/>
           <p:nvPr/>
         </p:nvSpPr>
@@ -9343,7 +9130,7 @@
       </p:sp>
       <p:pic>
         <p:nvPicPr>
-          <p:cNvPr id="26" name="Picture 25" descr="kafka.png"/>
+          <p:cNvPr id="25" name="Picture 24" descr="kafka.png"/>
           <p:cNvPicPr>
             <a:picLocks noChangeAspect="1"/>
           </p:cNvPicPr>
@@ -9367,7 +9154,7 @@
       </p:pic>
       <p:sp>
         <p:nvSpPr>
-          <p:cNvPr id="27" name="TextBox 26"/>
+          <p:cNvPr id="26" name="TextBox 25"/>
           <p:cNvSpPr txBox="1"/>
           <p:nvPr/>
         </p:nvSpPr>
@@ -9402,7 +9189,7 @@
       </p:sp>
       <p:sp>
         <p:nvSpPr>
-          <p:cNvPr id="28" name="TextBox 27"/>
+          <p:cNvPr id="27" name="TextBox 26"/>
           <p:cNvSpPr txBox="1"/>
           <p:nvPr/>
         </p:nvSpPr>
@@ -9437,7 +9224,7 @@
       </p:sp>
       <p:sp>
         <p:nvSpPr>
-          <p:cNvPr id="29" name="Rounded Rectangle 28"/>
+          <p:cNvPr id="28" name="Rounded Rectangle 27"/>
           <p:cNvSpPr/>
           <p:nvPr/>
         </p:nvSpPr>
@@ -9484,7 +9271,7 @@
       </p:sp>
       <p:pic>
         <p:nvPicPr>
-          <p:cNvPr id="30" name="Picture 29" descr="sdk.png"/>
+          <p:cNvPr id="29" name="Picture 28" descr="sdk.png"/>
           <p:cNvPicPr>
             <a:picLocks noChangeAspect="1"/>
           </p:cNvPicPr>
@@ -9508,7 +9295,7 @@
       </p:pic>
       <p:sp>
         <p:nvSpPr>
-          <p:cNvPr id="31" name="TextBox 30"/>
+          <p:cNvPr id="30" name="TextBox 29"/>
           <p:cNvSpPr txBox="1"/>
           <p:nvPr/>
         </p:nvSpPr>
@@ -9543,7 +9330,7 @@
       </p:sp>
       <p:sp>
         <p:nvSpPr>
-          <p:cNvPr id="32" name="TextBox 31"/>
+          <p:cNvPr id="31" name="TextBox 30"/>
           <p:cNvSpPr txBox="1"/>
           <p:nvPr/>
         </p:nvSpPr>
@@ -9578,7 +9365,7 @@
       </p:sp>
       <p:sp>
         <p:nvSpPr>
-          <p:cNvPr id="33" name="Rounded Rectangle 32"/>
+          <p:cNvPr id="32" name="Rounded Rectangle 31"/>
           <p:cNvSpPr/>
           <p:nvPr/>
         </p:nvSpPr>
@@ -9625,7 +9412,7 @@
       </p:sp>
       <p:pic>
         <p:nvPicPr>
-          <p:cNvPr id="34" name="Picture 33" descr="rest.png"/>
+          <p:cNvPr id="33" name="Picture 32" descr="rest.png"/>
           <p:cNvPicPr>
             <a:picLocks noChangeAspect="1"/>
           </p:cNvPicPr>
@@ -9649,7 +9436,7 @@
       </p:pic>
       <p:sp>
         <p:nvSpPr>
-          <p:cNvPr id="35" name="TextBox 34"/>
+          <p:cNvPr id="34" name="TextBox 33"/>
           <p:cNvSpPr txBox="1"/>
           <p:nvPr/>
         </p:nvSpPr>
@@ -9684,7 +9471,7 @@
       </p:sp>
       <p:sp>
         <p:nvSpPr>
-          <p:cNvPr id="36" name="TextBox 35"/>
+          <p:cNvPr id="35" name="TextBox 34"/>
           <p:cNvSpPr txBox="1"/>
           <p:nvPr/>
         </p:nvSpPr>
@@ -9719,7 +9506,7 @@
       </p:sp>
       <p:sp>
         <p:nvSpPr>
-          <p:cNvPr id="37" name="Down Arrow 36"/>
+          <p:cNvPr id="36" name="Down Arrow 35"/>
           <p:cNvSpPr/>
           <p:nvPr/>
         </p:nvSpPr>
@@ -9762,7 +9549,7 @@
       </p:sp>
       <p:sp>
         <p:nvSpPr>
-          <p:cNvPr id="38" name="Down Arrow 37"/>
+          <p:cNvPr id="37" name="Down Arrow 36"/>
           <p:cNvSpPr/>
           <p:nvPr/>
         </p:nvSpPr>
@@ -9805,7 +9592,7 @@
       </p:sp>
       <p:sp>
         <p:nvSpPr>
-          <p:cNvPr id="39" name="Down Arrow 38"/>
+          <p:cNvPr id="38" name="Down Arrow 37"/>
           <p:cNvSpPr/>
           <p:nvPr/>
         </p:nvSpPr>
@@ -9848,7 +9635,7 @@
       </p:sp>
       <p:sp>
         <p:nvSpPr>
-          <p:cNvPr id="40" name="Down Arrow 39"/>
+          <p:cNvPr id="39" name="Down Arrow 38"/>
           <p:cNvSpPr/>
           <p:nvPr/>
         </p:nvSpPr>
@@ -9891,7 +9678,7 @@
       </p:sp>
       <p:sp>
         <p:nvSpPr>
-          <p:cNvPr id="41" name="TextBox 40"/>
+          <p:cNvPr id="40" name="TextBox 39"/>
           <p:cNvSpPr txBox="1"/>
           <p:nvPr/>
         </p:nvSpPr>
@@ -9926,7 +9713,7 @@
       </p:sp>
       <p:sp>
         <p:nvSpPr>
-          <p:cNvPr id="42" name="Rounded Rectangle 41"/>
+          <p:cNvPr id="41" name="Rounded Rectangle 40"/>
           <p:cNvSpPr/>
           <p:nvPr/>
         </p:nvSpPr>
@@ -9973,7 +9760,7 @@
       </p:sp>
       <p:sp>
         <p:nvSpPr>
-          <p:cNvPr id="43" name="Rounded Rectangle 42"/>
+          <p:cNvPr id="42" name="Rounded Rectangle 41"/>
           <p:cNvSpPr/>
           <p:nvPr/>
         </p:nvSpPr>
@@ -10018,7 +9805,7 @@
       </p:sp>
       <p:sp>
         <p:nvSpPr>
-          <p:cNvPr id="44" name="TextBox 43"/>
+          <p:cNvPr id="43" name="TextBox 42"/>
           <p:cNvSpPr txBox="1"/>
           <p:nvPr/>
         </p:nvSpPr>
@@ -10053,7 +9840,7 @@
       </p:sp>
       <p:sp>
         <p:nvSpPr>
-          <p:cNvPr id="45" name="TextBox 44"/>
+          <p:cNvPr id="44" name="TextBox 43"/>
           <p:cNvSpPr txBox="1"/>
           <p:nvPr/>
         </p:nvSpPr>
@@ -10088,7 +9875,7 @@
       </p:sp>
       <p:sp>
         <p:nvSpPr>
-          <p:cNvPr id="46" name="TextBox 45"/>
+          <p:cNvPr id="45" name="TextBox 44"/>
           <p:cNvSpPr txBox="1"/>
           <p:nvPr/>
         </p:nvSpPr>
@@ -10124,7 +9911,7 @@
       </p:sp>
       <p:sp>
         <p:nvSpPr>
-          <p:cNvPr id="47" name="TextBox 46"/>
+          <p:cNvPr id="46" name="TextBox 45"/>
           <p:cNvSpPr txBox="1"/>
           <p:nvPr/>
         </p:nvSpPr>
@@ -10159,7 +9946,7 @@
       </p:sp>
       <p:sp>
         <p:nvSpPr>
-          <p:cNvPr id="48" name="Rounded Rectangle 47"/>
+          <p:cNvPr id="47" name="Rounded Rectangle 46"/>
           <p:cNvSpPr/>
           <p:nvPr/>
         </p:nvSpPr>
@@ -10206,7 +9993,7 @@
       </p:sp>
       <p:sp>
         <p:nvSpPr>
-          <p:cNvPr id="49" name="TextBox 48"/>
+          <p:cNvPr id="48" name="TextBox 47"/>
           <p:cNvSpPr txBox="1"/>
           <p:nvPr/>
         </p:nvSpPr>
@@ -10241,7 +10028,7 @@
       </p:sp>
       <p:sp>
         <p:nvSpPr>
-          <p:cNvPr id="50" name="TextBox 49"/>
+          <p:cNvPr id="49" name="TextBox 48"/>
           <p:cNvSpPr txBox="1"/>
           <p:nvPr/>
         </p:nvSpPr>
@@ -10277,7 +10064,7 @@
       </p:sp>
       <p:sp>
         <p:nvSpPr>
-          <p:cNvPr id="51" name="TextBox 50"/>
+          <p:cNvPr id="50" name="TextBox 49"/>
           <p:cNvSpPr txBox="1"/>
           <p:nvPr/>
         </p:nvSpPr>
@@ -10312,7 +10099,7 @@
       </p:sp>
       <p:sp>
         <p:nvSpPr>
-          <p:cNvPr id="52" name="Rounded Rectangle 51"/>
+          <p:cNvPr id="51" name="Rounded Rectangle 50"/>
           <p:cNvSpPr/>
           <p:nvPr/>
         </p:nvSpPr>
@@ -10359,7 +10146,7 @@
       </p:sp>
       <p:sp>
         <p:nvSpPr>
-          <p:cNvPr id="53" name="TextBox 52"/>
+          <p:cNvPr id="52" name="TextBox 51"/>
           <p:cNvSpPr txBox="1"/>
           <p:nvPr/>
         </p:nvSpPr>
@@ -10394,7 +10181,7 @@
       </p:sp>
       <p:sp>
         <p:nvSpPr>
-          <p:cNvPr id="54" name="TextBox 53"/>
+          <p:cNvPr id="53" name="TextBox 52"/>
           <p:cNvSpPr txBox="1"/>
           <p:nvPr/>
         </p:nvSpPr>
@@ -10429,7 +10216,7 @@
       </p:sp>
       <p:sp>
         <p:nvSpPr>
-          <p:cNvPr id="55" name="TextBox 54"/>
+          <p:cNvPr id="54" name="TextBox 53"/>
           <p:cNvSpPr txBox="1"/>
           <p:nvPr/>
         </p:nvSpPr>
@@ -10464,7 +10251,7 @@
       </p:sp>
       <p:sp>
         <p:nvSpPr>
-          <p:cNvPr id="56" name="Rounded Rectangle 55"/>
+          <p:cNvPr id="55" name="Rounded Rectangle 54"/>
           <p:cNvSpPr/>
           <p:nvPr/>
         </p:nvSpPr>
@@ -10511,14 +10298,14 @@
       </p:sp>
       <p:pic>
         <p:nvPicPr>
-          <p:cNvPr id="57" name="Picture 56" descr="uaf.png"/>
+          <p:cNvPr id="56" name="Picture 55" descr="uaf_mark_40.png"/>
           <p:cNvPicPr>
             <a:picLocks noChangeAspect="1"/>
           </p:cNvPicPr>
           <p:nvPr/>
         </p:nvPicPr>
         <p:blipFill>
-          <a:blip r:embed="rId2"/>
+          <a:blip r:embed="rId7"/>
           <a:stretch>
             <a:fillRect/>
           </a:stretch>
@@ -10526,7 +10313,7 @@
         <p:spPr>
           <a:xfrm>
             <a:off x="9210294" y="4078224"/>
-            <a:ext cx="237744" cy="237744"/>
+            <a:ext cx="256032" cy="256032"/>
           </a:xfrm>
           <a:prstGeom prst="rect">
             <a:avLst/>
@@ -10535,7 +10322,7 @@
       </p:pic>
       <p:pic>
         <p:nvPicPr>
-          <p:cNvPr id="58" name="Picture 57" descr="sim.png"/>
+          <p:cNvPr id="57" name="Picture 56" descr="sim_mark_48.png"/>
           <p:cNvPicPr>
             <a:picLocks noChangeAspect="1"/>
           </p:cNvPicPr>
@@ -10549,8 +10336,32 @@
         </p:blipFill>
         <p:spPr>
           <a:xfrm>
-            <a:off x="9484614" y="4078224"/>
-            <a:ext cx="237744" cy="237744"/>
+            <a:off x="9521190" y="4078224"/>
+            <a:ext cx="256032" cy="256032"/>
+          </a:xfrm>
+          <a:prstGeom prst="rect">
+            <a:avLst/>
+          </a:prstGeom>
+        </p:spPr>
+      </p:pic>
+      <p:pic>
+        <p:nvPicPr>
+          <p:cNvPr id="58" name="Picture 57" descr="yesua_mark_48.png"/>
+          <p:cNvPicPr>
+            <a:picLocks noChangeAspect="1"/>
+          </p:cNvPicPr>
+          <p:nvPr/>
+        </p:nvPicPr>
+        <p:blipFill>
+          <a:blip r:embed="rId8"/>
+          <a:stretch>
+            <a:fillRect/>
+          </a:stretch>
+        </p:blipFill>
+        <p:spPr>
+          <a:xfrm>
+            <a:off x="9832086" y="4078224"/>
+            <a:ext cx="256032" cy="256032"/>
           </a:xfrm>
           <a:prstGeom prst="rect">
             <a:avLst/>
@@ -10565,8 +10376,8 @@
         </p:nvSpPr>
         <p:spPr>
           <a:xfrm>
-            <a:off x="9795510" y="4078224"/>
-            <a:ext cx="1872234" cy="237744"/>
+            <a:off x="10161270" y="4078224"/>
+            <a:ext cx="1506474" cy="256032"/>
           </a:xfrm>
           <a:prstGeom prst="rect">
             <a:avLst/>
@@ -10581,7 +10392,7 @@
           <a:p>
             <a:pPr algn="l"/>
             <a:r>
-              <a:rPr sz="1300" b="1">
+              <a:rPr sz="1200" b="1">
                 <a:solidFill>
                   <a:srgbClr val="F8FAFC"/>
                 </a:solidFill>
@@ -10600,8 +10411,8 @@
         </p:nvSpPr>
         <p:spPr>
           <a:xfrm>
-            <a:off x="9210294" y="4425696"/>
-            <a:ext cx="2484882" cy="457200"/>
+            <a:off x="9210294" y="4443984"/>
+            <a:ext cx="2484882" cy="411480"/>
           </a:xfrm>
           <a:prstGeom prst="rect">
             <a:avLst/>
@@ -10876,7 +10687,79 @@
       </p:sp>
       <p:pic>
         <p:nvPicPr>
-          <p:cNvPr id="67" name="Picture 66" descr="sdk.png"/>
+          <p:cNvPr id="67" name="Picture 66" descr="uaf_badge_48.png"/>
+          <p:cNvPicPr>
+            <a:picLocks noChangeAspect="1"/>
+          </p:cNvPicPr>
+          <p:nvPr/>
+        </p:nvPicPr>
+        <p:blipFill>
+          <a:blip r:embed="rId2"/>
+          <a:stretch>
+            <a:fillRect/>
+          </a:stretch>
+        </p:blipFill>
+        <p:spPr>
+          <a:xfrm>
+            <a:off x="502920" y="5961888"/>
+            <a:ext cx="1051560" cy="329184"/>
+          </a:xfrm>
+          <a:prstGeom prst="rect">
+            <a:avLst/>
+          </a:prstGeom>
+        </p:spPr>
+      </p:pic>
+      <p:pic>
+        <p:nvPicPr>
+          <p:cNvPr id="68" name="Picture 67" descr="sim_mark_48.png"/>
+          <p:cNvPicPr>
+            <a:picLocks noChangeAspect="1"/>
+          </p:cNvPicPr>
+          <p:nvPr/>
+        </p:nvPicPr>
+        <p:blipFill>
+          <a:blip r:embed="rId3"/>
+          <a:stretch>
+            <a:fillRect/>
+          </a:stretch>
+        </p:blipFill>
+        <p:spPr>
+          <a:xfrm>
+            <a:off x="1691640" y="5961888"/>
+            <a:ext cx="310896" cy="310896"/>
+          </a:xfrm>
+          <a:prstGeom prst="rect">
+            <a:avLst/>
+          </a:prstGeom>
+        </p:spPr>
+      </p:pic>
+      <p:pic>
+        <p:nvPicPr>
+          <p:cNvPr id="69" name="Picture 68" descr="yesua_mark_48.png"/>
+          <p:cNvPicPr>
+            <a:picLocks noChangeAspect="1"/>
+          </p:cNvPicPr>
+          <p:nvPr/>
+        </p:nvPicPr>
+        <p:blipFill>
+          <a:blip r:embed="rId8"/>
+          <a:stretch>
+            <a:fillRect/>
+          </a:stretch>
+        </p:blipFill>
+        <p:spPr>
+          <a:xfrm>
+            <a:off x="2084831" y="5961888"/>
+            <a:ext cx="310896" cy="310896"/>
+          </a:xfrm>
+          <a:prstGeom prst="rect">
+            <a:avLst/>
+          </a:prstGeom>
+        </p:spPr>
+      </p:pic>
+      <p:pic>
+        <p:nvPicPr>
+          <p:cNvPr id="70" name="Picture 69" descr="sdk.png"/>
           <p:cNvPicPr>
             <a:picLocks noChangeAspect="1"/>
           </p:cNvPicPr>
@@ -10890,8 +10773,8 @@
         </p:blipFill>
         <p:spPr>
           <a:xfrm>
-            <a:off x="502920" y="5980176"/>
-            <a:ext cx="274320" cy="274320"/>
+            <a:off x="2560320" y="5980176"/>
+            <a:ext cx="256032" cy="256032"/>
           </a:xfrm>
           <a:prstGeom prst="rect">
             <a:avLst/>
@@ -10900,7 +10783,7 @@
       </p:pic>
       <p:pic>
         <p:nvPicPr>
-          <p:cNvPr id="68" name="Picture 67" descr="rest.png"/>
+          <p:cNvPr id="71" name="Picture 70" descr="rest.png"/>
           <p:cNvPicPr>
             <a:picLocks noChangeAspect="1"/>
           </p:cNvPicPr>
@@ -10914,8 +10797,8 @@
         </p:blipFill>
         <p:spPr>
           <a:xfrm>
-            <a:off x="868680" y="5980176"/>
-            <a:ext cx="274320" cy="274320"/>
+            <a:off x="2880360" y="5980176"/>
+            <a:ext cx="256032" cy="256032"/>
           </a:xfrm>
           <a:prstGeom prst="rect">
             <a:avLst/>
@@ -10924,7 +10807,7 @@
       </p:pic>
       <p:pic>
         <p:nvPicPr>
-          <p:cNvPr id="69" name="Picture 68" descr="kafka.png"/>
+          <p:cNvPr id="72" name="Picture 71" descr="kafka.png"/>
           <p:cNvPicPr>
             <a:picLocks noChangeAspect="1"/>
           </p:cNvPicPr>
@@ -10938,72 +10821,24 @@
         </p:blipFill>
         <p:spPr>
           <a:xfrm>
-            <a:off x="1234440" y="5980176"/>
-            <a:ext cx="274320" cy="274320"/>
+            <a:off x="3200400" y="5980176"/>
+            <a:ext cx="256032" cy="256032"/>
           </a:xfrm>
           <a:prstGeom prst="rect">
             <a:avLst/>
           </a:prstGeom>
         </p:spPr>
       </p:pic>
-      <p:pic>
-        <p:nvPicPr>
-          <p:cNvPr id="70" name="Picture 69" descr="uaf.png"/>
-          <p:cNvPicPr>
-            <a:picLocks noChangeAspect="1"/>
-          </p:cNvPicPr>
-          <p:nvPr/>
-        </p:nvPicPr>
-        <p:blipFill>
-          <a:blip r:embed="rId2"/>
-          <a:stretch>
-            <a:fillRect/>
-          </a:stretch>
-        </p:blipFill>
-        <p:spPr>
-          <a:xfrm>
-            <a:off x="1691640" y="5980176"/>
-            <a:ext cx="274320" cy="274320"/>
-          </a:xfrm>
-          <a:prstGeom prst="rect">
-            <a:avLst/>
-          </a:prstGeom>
-        </p:spPr>
-      </p:pic>
-      <p:pic>
-        <p:nvPicPr>
-          <p:cNvPr id="71" name="Picture 70" descr="sim.png"/>
-          <p:cNvPicPr>
-            <a:picLocks noChangeAspect="1"/>
-          </p:cNvPicPr>
-          <p:nvPr/>
-        </p:nvPicPr>
-        <p:blipFill>
-          <a:blip r:embed="rId3"/>
-          <a:stretch>
-            <a:fillRect/>
-          </a:stretch>
-        </p:blipFill>
-        <p:spPr>
-          <a:xfrm>
-            <a:off x="2057400" y="5980176"/>
-            <a:ext cx="274320" cy="274320"/>
-          </a:xfrm>
-          <a:prstGeom prst="rect">
-            <a:avLst/>
-          </a:prstGeom>
-        </p:spPr>
-      </p:pic>
-      <p:sp>
-        <p:nvSpPr>
-          <p:cNvPr id="72" name="TextBox 71"/>
+      <p:sp>
+        <p:nvSpPr>
+          <p:cNvPr id="73" name="TextBox 72"/>
           <p:cNvSpPr txBox="1"/>
           <p:nvPr/>
         </p:nvSpPr>
         <p:spPr>
           <a:xfrm>
-            <a:off x="2468880" y="5961888"/>
-            <a:ext cx="9144000" cy="411480"/>
+            <a:off x="3611880" y="5943600"/>
+            <a:ext cx="7955279" cy="457200"/>
           </a:xfrm>
           <a:prstGeom prst="rect">
             <a:avLst/>
@@ -11024,8 +10859,8 @@
                 </a:solidFill>
                 <a:latin typeface="Calibri"/>
               </a:rPr>
-              <a:t>SDK · REST · Kafka     ·     LedgeRX ↔ one UAF interface only     ·     hub runs UAF logic then fan-out
-Yes UA · sim sit behind XAPI / CRM  —  not direct LedgeRX connectors</a:t>
+              <a:t>Official UAF · sim · Yes UA logos (CTO-approved)     ·     LedgeRX ↔ one UAF interface
+Hub runs UAF logic then fan-out  ·  apps sit behind XAPI / CRM</a:t>
             </a:r>
           </a:p>
         </p:txBody>

</xml_diff>